<commit_message>
assets: Update WIP presentation for python_1
</commit_message>
<xml_diff>
--- a/python_1/presentation_python_1.pptx
+++ b/python_1/presentation_python_1.pptx
@@ -5,7 +5,7 @@
     <p:sldMasterId id="2147483648" r:id="rId1"/>
   </p:sldMasterIdLst>
   <p:notesMasterIdLst>
-    <p:notesMasterId r:id="rId15"/>
+    <p:notesMasterId r:id="rId16"/>
   </p:notesMasterIdLst>
   <p:sldIdLst>
     <p:sldId id="256" r:id="rId2"/>
@@ -19,8 +19,9 @@
     <p:sldId id="266" r:id="rId10"/>
     <p:sldId id="268" r:id="rId11"/>
     <p:sldId id="269" r:id="rId12"/>
-    <p:sldId id="267" r:id="rId13"/>
-    <p:sldId id="262" r:id="rId14"/>
+    <p:sldId id="270" r:id="rId13"/>
+    <p:sldId id="267" r:id="rId14"/>
+    <p:sldId id="262" r:id="rId15"/>
   </p:sldIdLst>
   <p:sldSz cx="12192000" cy="6858000"/>
   <p:notesSz cx="6858000" cy="9144000"/>
@@ -3851,9 +3852,9 @@
         <p:spPr>
           <a:xfrm>
             <a:off x="2869660" y="2716450"/>
-            <a:ext cx="6452681" cy="3081695"/>
+            <a:ext cx="6452681" cy="2785378"/>
           </a:xfrm>
-          <a:prstGeom prst="roundRect">
+          <a:prstGeom prst="rect">
             <a:avLst/>
           </a:prstGeom>
           <a:solidFill>
@@ -4000,9 +4001,9 @@
         <p:spPr>
           <a:xfrm>
             <a:off x="2869659" y="383636"/>
-            <a:ext cx="6452681" cy="2162294"/>
+            <a:ext cx="6452681" cy="1954381"/>
           </a:xfrm>
-          <a:prstGeom prst="roundRect">
+          <a:prstGeom prst="rect">
             <a:avLst/>
           </a:prstGeom>
           <a:solidFill>
@@ -4192,6 +4193,16 @@
 <file path=ppt/slides/slide11.xml><?xml version="1.0" encoding="utf-8"?>
 <p:sld xmlns:a="http://schemas.openxmlformats.org/drawingml/2006/main" xmlns:r="http://schemas.openxmlformats.org/officeDocument/2006/relationships" xmlns:p="http://schemas.openxmlformats.org/presentationml/2006/main">
   <p:cSld>
+    <p:bg>
+      <p:bgPr>
+        <a:solidFill>
+          <a:schemeClr val="bg1">
+            <a:lumMod val="95000"/>
+          </a:schemeClr>
+        </a:solidFill>
+        <a:effectLst/>
+      </p:bgPr>
+    </p:bg>
     <p:spTree>
       <p:nvGrpSpPr>
         <p:cNvPr id="1" name="">
@@ -4259,6 +4270,9 @@
             </a:r>
             <a:r>
               <a:rPr lang="en-US" i="1" dirty="0">
+                <a:solidFill>
+                  <a:srgbClr val="C00000"/>
+                </a:solidFill>
                 <a:latin typeface="Arial Rounded MT Bold" panose="020F0704030504030204" pitchFamily="34" charset="0"/>
               </a:rPr>
               <a:t>docstring</a:t>
@@ -4271,35 +4285,6 @@
             </a:r>
             <a:endParaRPr lang="fr-CA" dirty="0">
               <a:latin typeface="Arial Rounded MT Bold" panose="020F0704030504030204" pitchFamily="34" charset="0"/>
-            </a:endParaRPr>
-          </a:p>
-        </p:txBody>
-      </p:sp>
-      <p:sp>
-        <p:nvSpPr>
-          <p:cNvPr id="3" name="Content Placeholder 2">
-            <a:extLst>
-              <a:ext uri="{FF2B5EF4-FFF2-40B4-BE49-F238E27FC236}">
-                <a16:creationId xmlns:a16="http://schemas.microsoft.com/office/drawing/2014/main" id="{26403653-D11E-D30D-C57E-D58F52129CFC}"/>
-              </a:ext>
-            </a:extLst>
-          </p:cNvPr>
-          <p:cNvSpPr>
-            <a:spLocks noGrp="1"/>
-          </p:cNvSpPr>
-          <p:nvPr>
-            <p:ph idx="1"/>
-          </p:nvPr>
-        </p:nvSpPr>
-        <p:spPr/>
-        <p:txBody>
-          <a:bodyPr>
-            <a:normAutofit/>
-          </a:bodyPr>
-          <a:lstStyle/>
-          <a:p>
-            <a:endParaRPr lang="pt-BR" sz="2600" dirty="0">
-              <a:latin typeface="Consolas" panose="020B0609020204030204" pitchFamily="49" charset="0"/>
             </a:endParaRPr>
           </a:p>
         </p:txBody>
@@ -4333,6 +4318,564 @@
           </a:p>
         </p:txBody>
       </p:sp>
+      <p:sp>
+        <p:nvSpPr>
+          <p:cNvPr id="5" name="TextBox 4">
+            <a:extLst>
+              <a:ext uri="{FF2B5EF4-FFF2-40B4-BE49-F238E27FC236}">
+                <a16:creationId xmlns:a16="http://schemas.microsoft.com/office/drawing/2014/main" id="{0FF5A086-00CE-0086-99AB-93E60322E322}"/>
+              </a:ext>
+            </a:extLst>
+          </p:cNvPr>
+          <p:cNvSpPr txBox="1"/>
+          <p:nvPr/>
+        </p:nvSpPr>
+        <p:spPr>
+          <a:xfrm>
+            <a:off x="1999032" y="1690688"/>
+            <a:ext cx="4829785" cy="3693319"/>
+          </a:xfrm>
+          <a:prstGeom prst="rect">
+            <a:avLst/>
+          </a:prstGeom>
+          <a:solidFill>
+            <a:schemeClr val="bg1"/>
+          </a:solidFill>
+          <a:ln w="12700">
+            <a:solidFill>
+              <a:schemeClr val="tx1"/>
+            </a:solidFill>
+          </a:ln>
+        </p:spPr>
+        <p:txBody>
+          <a:bodyPr wrap="square">
+            <a:spAutoFit/>
+          </a:bodyPr>
+          <a:lstStyle/>
+          <a:p>
+            <a:br>
+              <a:rPr lang="pt-BR" sz="500" b="1" dirty="0">
+                <a:latin typeface="Consolas" panose="020B0609020204030204" pitchFamily="49" charset="0"/>
+              </a:rPr>
+            </a:br>
+            <a:r>
+              <a:rPr lang="pt-BR" sz="1600" b="1" dirty="0">
+                <a:latin typeface="Consolas" panose="020B0609020204030204" pitchFamily="49" charset="0"/>
+              </a:rPr>
+              <a:t>def calculer_afficher_racines(a, b, c):</a:t>
+            </a:r>
+          </a:p>
+          <a:p>
+            <a:endParaRPr lang="pt-BR" sz="500" b="1" dirty="0">
+              <a:latin typeface="Consolas" panose="020B0609020204030204" pitchFamily="49" charset="0"/>
+            </a:endParaRPr>
+          </a:p>
+          <a:p>
+            <a:r>
+              <a:rPr lang="pt-BR" sz="1600" b="1" dirty="0">
+                <a:latin typeface="Consolas" panose="020B0609020204030204" pitchFamily="49" charset="0"/>
+              </a:rPr>
+              <a:t>  </a:t>
+            </a:r>
+            <a:r>
+              <a:rPr lang="pt-BR" sz="1600" b="1" dirty="0">
+                <a:solidFill>
+                  <a:srgbClr val="C00000"/>
+                </a:solidFill>
+                <a:latin typeface="Consolas" panose="020B0609020204030204" pitchFamily="49" charset="0"/>
+              </a:rPr>
+              <a:t>"""</a:t>
+            </a:r>
+          </a:p>
+          <a:p>
+            <a:r>
+              <a:rPr lang="pt-BR" sz="1600" b="1" dirty="0">
+                <a:solidFill>
+                  <a:srgbClr val="C00000"/>
+                </a:solidFill>
+                <a:latin typeface="Consolas" panose="020B0609020204030204" pitchFamily="49" charset="0"/>
+              </a:rPr>
+              <a:t>  Calcule et affiche les racines d'une </a:t>
+            </a:r>
+            <a:br>
+              <a:rPr lang="pt-BR" sz="1600" b="1" dirty="0">
+                <a:solidFill>
+                  <a:srgbClr val="C00000"/>
+                </a:solidFill>
+                <a:latin typeface="Consolas" panose="020B0609020204030204" pitchFamily="49" charset="0"/>
+              </a:rPr>
+            </a:br>
+            <a:r>
+              <a:rPr lang="pt-BR" sz="1600" b="1" dirty="0">
+                <a:solidFill>
+                  <a:srgbClr val="C00000"/>
+                </a:solidFill>
+                <a:latin typeface="Consolas" panose="020B0609020204030204" pitchFamily="49" charset="0"/>
+              </a:rPr>
+              <a:t>  quadratique.</a:t>
+            </a:r>
+          </a:p>
+          <a:p>
+            <a:endParaRPr lang="pt-BR" sz="1600" b="1" dirty="0">
+              <a:solidFill>
+                <a:srgbClr val="C00000"/>
+              </a:solidFill>
+              <a:latin typeface="Consolas" panose="020B0609020204030204" pitchFamily="49" charset="0"/>
+            </a:endParaRPr>
+          </a:p>
+          <a:p>
+            <a:r>
+              <a:rPr lang="pt-BR" sz="1600" b="1" dirty="0">
+                <a:solidFill>
+                  <a:srgbClr val="C00000"/>
+                </a:solidFill>
+                <a:latin typeface="Consolas" panose="020B0609020204030204" pitchFamily="49" charset="0"/>
+              </a:rPr>
+              <a:t>  Arguments:</a:t>
+            </a:r>
+          </a:p>
+          <a:p>
+            <a:r>
+              <a:rPr lang="pt-BR" sz="1600" b="1" dirty="0">
+                <a:solidFill>
+                  <a:srgbClr val="C00000"/>
+                </a:solidFill>
+                <a:latin typeface="Consolas" panose="020B0609020204030204" pitchFamily="49" charset="0"/>
+              </a:rPr>
+              <a:t>    a (int): Coefficient du terme x^2.</a:t>
+            </a:r>
+          </a:p>
+          <a:p>
+            <a:r>
+              <a:rPr lang="pt-BR" sz="1600" b="1" dirty="0">
+                <a:solidFill>
+                  <a:srgbClr val="C00000"/>
+                </a:solidFill>
+                <a:latin typeface="Consolas" panose="020B0609020204030204" pitchFamily="49" charset="0"/>
+              </a:rPr>
+              <a:t>    b (int): Coefficient du terme x^1.</a:t>
+            </a:r>
+          </a:p>
+          <a:p>
+            <a:r>
+              <a:rPr lang="pt-BR" sz="1600" b="1" dirty="0">
+                <a:solidFill>
+                  <a:srgbClr val="C00000"/>
+                </a:solidFill>
+                <a:latin typeface="Consolas" panose="020B0609020204030204" pitchFamily="49" charset="0"/>
+              </a:rPr>
+              <a:t>    c (int): Coefficient du terme x^0.</a:t>
+            </a:r>
+          </a:p>
+          <a:p>
+            <a:endParaRPr lang="pt-BR" sz="1600" b="1" dirty="0">
+              <a:solidFill>
+                <a:srgbClr val="C00000"/>
+              </a:solidFill>
+              <a:latin typeface="Consolas" panose="020B0609020204030204" pitchFamily="49" charset="0"/>
+            </a:endParaRPr>
+          </a:p>
+          <a:p>
+            <a:r>
+              <a:rPr lang="pt-BR" sz="1600" b="1" dirty="0">
+                <a:solidFill>
+                  <a:srgbClr val="C00000"/>
+                </a:solidFill>
+                <a:latin typeface="Consolas" panose="020B0609020204030204" pitchFamily="49" charset="0"/>
+              </a:rPr>
+              <a:t>  Retourne:</a:t>
+            </a:r>
+          </a:p>
+          <a:p>
+            <a:r>
+              <a:rPr lang="pt-BR" sz="1600" b="1" dirty="0">
+                <a:solidFill>
+                  <a:srgbClr val="C00000"/>
+                </a:solidFill>
+                <a:latin typeface="Consolas" panose="020B0609020204030204" pitchFamily="49" charset="0"/>
+              </a:rPr>
+              <a:t>    Rien.</a:t>
+            </a:r>
+          </a:p>
+          <a:p>
+            <a:r>
+              <a:rPr lang="pt-BR" sz="1600" b="1" dirty="0">
+                <a:solidFill>
+                  <a:srgbClr val="C00000"/>
+                </a:solidFill>
+                <a:latin typeface="Consolas" panose="020B0609020204030204" pitchFamily="49" charset="0"/>
+              </a:rPr>
+              <a:t>  """</a:t>
+            </a:r>
+            <a:br>
+              <a:rPr lang="pt-BR" sz="1600" b="1" dirty="0">
+                <a:latin typeface="Consolas" panose="020B0609020204030204" pitchFamily="49" charset="0"/>
+              </a:rPr>
+            </a:br>
+            <a:r>
+              <a:rPr lang="pt-BR" sz="1600" b="1" dirty="0">
+                <a:latin typeface="Consolas" panose="020B0609020204030204" pitchFamily="49" charset="0"/>
+              </a:rPr>
+              <a:t>  ...</a:t>
+            </a:r>
+            <a:endParaRPr lang="fr-CA" sz="1600" dirty="0"/>
+          </a:p>
+        </p:txBody>
+      </p:sp>
+      <p:grpSp>
+        <p:nvGrpSpPr>
+          <p:cNvPr id="22" name="Group 21">
+            <a:extLst>
+              <a:ext uri="{FF2B5EF4-FFF2-40B4-BE49-F238E27FC236}">
+                <a16:creationId xmlns:a16="http://schemas.microsoft.com/office/drawing/2014/main" id="{8C6B12FC-9E65-03DE-B090-3B50F4029508}"/>
+              </a:ext>
+            </a:extLst>
+          </p:cNvPr>
+          <p:cNvGrpSpPr/>
+          <p:nvPr/>
+        </p:nvGrpSpPr>
+        <p:grpSpPr>
+          <a:xfrm>
+            <a:off x="6476100" y="3529022"/>
+            <a:ext cx="3084203" cy="369332"/>
+            <a:chOff x="6485106" y="3914378"/>
+            <a:chExt cx="3084203" cy="369332"/>
+          </a:xfrm>
+        </p:grpSpPr>
+        <p:sp>
+          <p:nvSpPr>
+            <p:cNvPr id="7" name="TextBox 6">
+              <a:extLst>
+                <a:ext uri="{FF2B5EF4-FFF2-40B4-BE49-F238E27FC236}">
+                  <a16:creationId xmlns:a16="http://schemas.microsoft.com/office/drawing/2014/main" id="{89B73522-44D2-9EB2-AE5F-62447DA5B08C}"/>
+                </a:ext>
+              </a:extLst>
+            </p:cNvPr>
+            <p:cNvSpPr txBox="1"/>
+            <p:nvPr/>
+          </p:nvSpPr>
+          <p:spPr>
+            <a:xfrm>
+              <a:off x="7309395" y="3914378"/>
+              <a:ext cx="2259914" cy="369332"/>
+            </a:xfrm>
+            <a:prstGeom prst="rect">
+              <a:avLst/>
+            </a:prstGeom>
+            <a:noFill/>
+          </p:spPr>
+          <p:txBody>
+            <a:bodyPr wrap="none" rtlCol="0">
+              <a:spAutoFit/>
+            </a:bodyPr>
+            <a:lstStyle/>
+            <a:p>
+              <a:r>
+                <a:rPr lang="en-US" b="1" dirty="0" err="1"/>
+                <a:t>Paramètres</a:t>
+              </a:r>
+              <a:r>
+                <a:rPr lang="en-US" dirty="0"/>
+                <a:t> et </a:t>
+              </a:r>
+              <a:r>
+                <a:rPr lang="en-US" b="1" dirty="0"/>
+                <a:t>types</a:t>
+              </a:r>
+              <a:endParaRPr lang="fr-CA" b="1" dirty="0"/>
+            </a:p>
+          </p:txBody>
+        </p:sp>
+        <p:cxnSp>
+          <p:nvCxnSpPr>
+            <p:cNvPr id="13" name="Straight Arrow Connector 12">
+              <a:extLst>
+                <a:ext uri="{FF2B5EF4-FFF2-40B4-BE49-F238E27FC236}">
+                  <a16:creationId xmlns:a16="http://schemas.microsoft.com/office/drawing/2014/main" id="{D95E8B3E-21D2-FA77-DFFE-D9AD598B9DDF}"/>
+                </a:ext>
+              </a:extLst>
+            </p:cNvPr>
+            <p:cNvCxnSpPr>
+              <a:cxnSpLocks/>
+            </p:cNvCxnSpPr>
+            <p:nvPr/>
+          </p:nvCxnSpPr>
+          <p:spPr>
+            <a:xfrm flipH="1">
+              <a:off x="6485106" y="4099044"/>
+              <a:ext cx="810000" cy="0"/>
+            </a:xfrm>
+            <a:prstGeom prst="straightConnector1">
+              <a:avLst/>
+            </a:prstGeom>
+            <a:ln>
+              <a:tailEnd type="triangle"/>
+            </a:ln>
+          </p:spPr>
+          <p:style>
+            <a:lnRef idx="2">
+              <a:schemeClr val="dk1"/>
+            </a:lnRef>
+            <a:fillRef idx="0">
+              <a:schemeClr val="dk1"/>
+            </a:fillRef>
+            <a:effectRef idx="1">
+              <a:schemeClr val="dk1"/>
+            </a:effectRef>
+            <a:fontRef idx="minor">
+              <a:schemeClr val="tx1"/>
+            </a:fontRef>
+          </p:style>
+        </p:cxnSp>
+      </p:grpSp>
+      <p:grpSp>
+        <p:nvGrpSpPr>
+          <p:cNvPr id="21" name="Group 20">
+            <a:extLst>
+              <a:ext uri="{FF2B5EF4-FFF2-40B4-BE49-F238E27FC236}">
+                <a16:creationId xmlns:a16="http://schemas.microsoft.com/office/drawing/2014/main" id="{4B567321-DF6A-F325-765B-9AD2C691237D}"/>
+              </a:ext>
+            </a:extLst>
+          </p:cNvPr>
+          <p:cNvGrpSpPr/>
+          <p:nvPr/>
+        </p:nvGrpSpPr>
+        <p:grpSpPr>
+          <a:xfrm>
+            <a:off x="6477056" y="2333014"/>
+            <a:ext cx="2584200" cy="369332"/>
+            <a:chOff x="6486062" y="2692430"/>
+            <a:chExt cx="2584200" cy="369332"/>
+          </a:xfrm>
+        </p:grpSpPr>
+        <p:sp>
+          <p:nvSpPr>
+            <p:cNvPr id="6" name="TextBox 5">
+              <a:extLst>
+                <a:ext uri="{FF2B5EF4-FFF2-40B4-BE49-F238E27FC236}">
+                  <a16:creationId xmlns:a16="http://schemas.microsoft.com/office/drawing/2014/main" id="{EE54A686-9704-982A-49AA-E24F61E31421}"/>
+                </a:ext>
+              </a:extLst>
+            </p:cNvPr>
+            <p:cNvSpPr txBox="1"/>
+            <p:nvPr/>
+          </p:nvSpPr>
+          <p:spPr>
+            <a:xfrm>
+              <a:off x="7309395" y="2692430"/>
+              <a:ext cx="1760867" cy="369332"/>
+            </a:xfrm>
+            <a:prstGeom prst="rect">
+              <a:avLst/>
+            </a:prstGeom>
+            <a:noFill/>
+          </p:spPr>
+          <p:txBody>
+            <a:bodyPr wrap="none" rtlCol="0">
+              <a:spAutoFit/>
+            </a:bodyPr>
+            <a:lstStyle/>
+            <a:p>
+              <a:r>
+                <a:rPr lang="en-US" b="1" dirty="0" err="1"/>
+                <a:t>Responsabilité</a:t>
+              </a:r>
+              <a:endParaRPr lang="fr-CA" dirty="0"/>
+            </a:p>
+          </p:txBody>
+        </p:sp>
+        <p:cxnSp>
+          <p:nvCxnSpPr>
+            <p:cNvPr id="16" name="Straight Arrow Connector 15">
+              <a:extLst>
+                <a:ext uri="{FF2B5EF4-FFF2-40B4-BE49-F238E27FC236}">
+                  <a16:creationId xmlns:a16="http://schemas.microsoft.com/office/drawing/2014/main" id="{2DE447F2-251C-0AF9-C60E-1AD9C25512B4}"/>
+                </a:ext>
+              </a:extLst>
+            </p:cNvPr>
+            <p:cNvCxnSpPr>
+              <a:cxnSpLocks/>
+            </p:cNvCxnSpPr>
+            <p:nvPr/>
+          </p:nvCxnSpPr>
+          <p:spPr>
+            <a:xfrm flipH="1" flipV="1">
+              <a:off x="6486062" y="2876748"/>
+              <a:ext cx="810000" cy="0"/>
+            </a:xfrm>
+            <a:prstGeom prst="straightConnector1">
+              <a:avLst/>
+            </a:prstGeom>
+            <a:ln>
+              <a:tailEnd type="triangle"/>
+            </a:ln>
+          </p:spPr>
+          <p:style>
+            <a:lnRef idx="2">
+              <a:schemeClr val="dk1"/>
+            </a:lnRef>
+            <a:fillRef idx="0">
+              <a:schemeClr val="dk1"/>
+            </a:fillRef>
+            <a:effectRef idx="1">
+              <a:schemeClr val="dk1"/>
+            </a:effectRef>
+            <a:fontRef idx="minor">
+              <a:schemeClr val="tx1"/>
+            </a:fontRef>
+          </p:style>
+        </p:cxnSp>
+      </p:grpSp>
+      <p:grpSp>
+        <p:nvGrpSpPr>
+          <p:cNvPr id="23" name="Group 22">
+            <a:extLst>
+              <a:ext uri="{FF2B5EF4-FFF2-40B4-BE49-F238E27FC236}">
+                <a16:creationId xmlns:a16="http://schemas.microsoft.com/office/drawing/2014/main" id="{B1CC6EB7-1F47-EDE2-B762-220670DA8FE2}"/>
+              </a:ext>
+            </a:extLst>
+          </p:cNvPr>
+          <p:cNvGrpSpPr/>
+          <p:nvPr/>
+        </p:nvGrpSpPr>
+        <p:grpSpPr>
+          <a:xfrm>
+            <a:off x="6476100" y="4489297"/>
+            <a:ext cx="3003860" cy="369332"/>
+            <a:chOff x="6485106" y="4913563"/>
+            <a:chExt cx="3003860" cy="369332"/>
+          </a:xfrm>
+        </p:grpSpPr>
+        <p:sp>
+          <p:nvSpPr>
+            <p:cNvPr id="8" name="TextBox 7">
+              <a:extLst>
+                <a:ext uri="{FF2B5EF4-FFF2-40B4-BE49-F238E27FC236}">
+                  <a16:creationId xmlns:a16="http://schemas.microsoft.com/office/drawing/2014/main" id="{E1C8391D-7588-CBCA-18B5-D77A6EF56D6D}"/>
+                </a:ext>
+              </a:extLst>
+            </p:cNvPr>
+            <p:cNvSpPr txBox="1"/>
+            <p:nvPr/>
+          </p:nvSpPr>
+          <p:spPr>
+            <a:xfrm>
+              <a:off x="7309395" y="4913563"/>
+              <a:ext cx="2179571" cy="369332"/>
+            </a:xfrm>
+            <a:prstGeom prst="rect">
+              <a:avLst/>
+            </a:prstGeom>
+            <a:noFill/>
+          </p:spPr>
+          <p:txBody>
+            <a:bodyPr wrap="none" rtlCol="0">
+              <a:spAutoFit/>
+            </a:bodyPr>
+            <a:lstStyle/>
+            <a:p>
+              <a:r>
+                <a:rPr lang="en-US" b="1" dirty="0"/>
+                <a:t>Ce qui est </a:t>
+              </a:r>
+              <a:r>
+                <a:rPr lang="en-US" b="1" dirty="0" err="1"/>
+                <a:t>retourné</a:t>
+              </a:r>
+              <a:endParaRPr lang="fr-CA" b="1" dirty="0"/>
+            </a:p>
+          </p:txBody>
+        </p:sp>
+        <p:cxnSp>
+          <p:nvCxnSpPr>
+            <p:cNvPr id="17" name="Straight Arrow Connector 16">
+              <a:extLst>
+                <a:ext uri="{FF2B5EF4-FFF2-40B4-BE49-F238E27FC236}">
+                  <a16:creationId xmlns:a16="http://schemas.microsoft.com/office/drawing/2014/main" id="{7B19C0E5-42A8-78CD-8BC5-AA800ED6DF06}"/>
+                </a:ext>
+              </a:extLst>
+            </p:cNvPr>
+            <p:cNvCxnSpPr>
+              <a:cxnSpLocks/>
+            </p:cNvCxnSpPr>
+            <p:nvPr/>
+          </p:nvCxnSpPr>
+          <p:spPr>
+            <a:xfrm flipH="1">
+              <a:off x="6485106" y="5098230"/>
+              <a:ext cx="810000" cy="0"/>
+            </a:xfrm>
+            <a:prstGeom prst="straightConnector1">
+              <a:avLst/>
+            </a:prstGeom>
+            <a:ln>
+              <a:tailEnd type="triangle"/>
+            </a:ln>
+          </p:spPr>
+          <p:style>
+            <a:lnRef idx="2">
+              <a:schemeClr val="dk1"/>
+            </a:lnRef>
+            <a:fillRef idx="0">
+              <a:schemeClr val="dk1"/>
+            </a:fillRef>
+            <a:effectRef idx="1">
+              <a:schemeClr val="dk1"/>
+            </a:effectRef>
+            <a:fontRef idx="minor">
+              <a:schemeClr val="tx1"/>
+            </a:fontRef>
+          </p:style>
+        </p:cxnSp>
+      </p:grpSp>
+      <p:sp>
+        <p:nvSpPr>
+          <p:cNvPr id="24" name="TextBox 23">
+            <a:extLst>
+              <a:ext uri="{FF2B5EF4-FFF2-40B4-BE49-F238E27FC236}">
+                <a16:creationId xmlns:a16="http://schemas.microsoft.com/office/drawing/2014/main" id="{F6459D09-2D7D-E4F4-3612-99F8BBECAEE4}"/>
+              </a:ext>
+            </a:extLst>
+          </p:cNvPr>
+          <p:cNvSpPr txBox="1"/>
+          <p:nvPr/>
+        </p:nvSpPr>
+        <p:spPr>
+          <a:xfrm>
+            <a:off x="838199" y="6176963"/>
+            <a:ext cx="10515599" cy="369332"/>
+          </a:xfrm>
+          <a:prstGeom prst="rect">
+            <a:avLst/>
+          </a:prstGeom>
+          <a:noFill/>
+        </p:spPr>
+        <p:txBody>
+          <a:bodyPr wrap="square">
+            <a:spAutoFit/>
+          </a:bodyPr>
+          <a:lstStyle/>
+          <a:p>
+            <a:pPr algn="ctr"/>
+            <a:r>
+              <a:rPr lang="fr-CA" sz="1800" b="1" dirty="0">
+                <a:latin typeface="Consolas" panose="020B0609020204030204" pitchFamily="49" charset="0"/>
+              </a:rPr>
+              <a:t>SOURCE: </a:t>
+            </a:r>
+            <a:r>
+              <a:rPr lang="fr-CA" b="1" dirty="0">
+                <a:latin typeface="Consolas" panose="020B0609020204030204" pitchFamily="49" charset="0"/>
+                <a:hlinkClick r:id="rId2"/>
+              </a:rPr>
+              <a:t>https://google.github.io/styleguide/pyguide.html</a:t>
+            </a:r>
+            <a:endParaRPr lang="fr-CA" sz="1800" b="1" dirty="0">
+              <a:latin typeface="Consolas" panose="020B0609020204030204" pitchFamily="49" charset="0"/>
+            </a:endParaRPr>
+          </a:p>
+        </p:txBody>
+      </p:sp>
     </p:spTree>
     <p:extLst>
       <p:ext uri="{BB962C8B-B14F-4D97-AF65-F5344CB8AC3E}">
@@ -4343,10 +4886,371 @@
   <p:clrMapOvr>
     <a:masterClrMapping/>
   </p:clrMapOvr>
+  <p:timing>
+    <p:tnLst>
+      <p:par>
+        <p:cTn id="1" dur="indefinite" restart="never" nodeType="tmRoot">
+          <p:childTnLst>
+            <p:seq concurrent="1" nextAc="seek">
+              <p:cTn id="2" dur="indefinite" nodeType="mainSeq">
+                <p:childTnLst>
+                  <p:par>
+                    <p:cTn id="3" fill="hold">
+                      <p:stCondLst>
+                        <p:cond delay="indefinite"/>
+                      </p:stCondLst>
+                      <p:childTnLst>
+                        <p:par>
+                          <p:cTn id="4" fill="hold">
+                            <p:stCondLst>
+                              <p:cond delay="0"/>
+                            </p:stCondLst>
+                            <p:childTnLst>
+                              <p:par>
+                                <p:cTn id="5" presetID="10" presetClass="entr" presetSubtype="0" fill="hold" nodeType="clickEffect">
+                                  <p:stCondLst>
+                                    <p:cond delay="0"/>
+                                  </p:stCondLst>
+                                  <p:childTnLst>
+                                    <p:set>
+                                      <p:cBhvr>
+                                        <p:cTn id="6" dur="1" fill="hold">
+                                          <p:stCondLst>
+                                            <p:cond delay="0"/>
+                                          </p:stCondLst>
+                                        </p:cTn>
+                                        <p:tgtEl>
+                                          <p:spTgt spid="21"/>
+                                        </p:tgtEl>
+                                        <p:attrNameLst>
+                                          <p:attrName>style.visibility</p:attrName>
+                                        </p:attrNameLst>
+                                      </p:cBhvr>
+                                      <p:to>
+                                        <p:strVal val="visible"/>
+                                      </p:to>
+                                    </p:set>
+                                    <p:animEffect transition="in" filter="fade">
+                                      <p:cBhvr>
+                                        <p:cTn id="7" dur="500"/>
+                                        <p:tgtEl>
+                                          <p:spTgt spid="21"/>
+                                        </p:tgtEl>
+                                      </p:cBhvr>
+                                    </p:animEffect>
+                                  </p:childTnLst>
+                                </p:cTn>
+                              </p:par>
+                            </p:childTnLst>
+                          </p:cTn>
+                        </p:par>
+                      </p:childTnLst>
+                    </p:cTn>
+                  </p:par>
+                  <p:par>
+                    <p:cTn id="8" fill="hold">
+                      <p:stCondLst>
+                        <p:cond delay="indefinite"/>
+                      </p:stCondLst>
+                      <p:childTnLst>
+                        <p:par>
+                          <p:cTn id="9" fill="hold">
+                            <p:stCondLst>
+                              <p:cond delay="0"/>
+                            </p:stCondLst>
+                            <p:childTnLst>
+                              <p:par>
+                                <p:cTn id="10" presetID="10" presetClass="entr" presetSubtype="0" fill="hold" nodeType="clickEffect">
+                                  <p:stCondLst>
+                                    <p:cond delay="0"/>
+                                  </p:stCondLst>
+                                  <p:childTnLst>
+                                    <p:set>
+                                      <p:cBhvr>
+                                        <p:cTn id="11" dur="1" fill="hold">
+                                          <p:stCondLst>
+                                            <p:cond delay="0"/>
+                                          </p:stCondLst>
+                                        </p:cTn>
+                                        <p:tgtEl>
+                                          <p:spTgt spid="22"/>
+                                        </p:tgtEl>
+                                        <p:attrNameLst>
+                                          <p:attrName>style.visibility</p:attrName>
+                                        </p:attrNameLst>
+                                      </p:cBhvr>
+                                      <p:to>
+                                        <p:strVal val="visible"/>
+                                      </p:to>
+                                    </p:set>
+                                    <p:animEffect transition="in" filter="fade">
+                                      <p:cBhvr>
+                                        <p:cTn id="12" dur="500"/>
+                                        <p:tgtEl>
+                                          <p:spTgt spid="22"/>
+                                        </p:tgtEl>
+                                      </p:cBhvr>
+                                    </p:animEffect>
+                                  </p:childTnLst>
+                                </p:cTn>
+                              </p:par>
+                            </p:childTnLst>
+                          </p:cTn>
+                        </p:par>
+                      </p:childTnLst>
+                    </p:cTn>
+                  </p:par>
+                  <p:par>
+                    <p:cTn id="13" fill="hold">
+                      <p:stCondLst>
+                        <p:cond delay="indefinite"/>
+                      </p:stCondLst>
+                      <p:childTnLst>
+                        <p:par>
+                          <p:cTn id="14" fill="hold">
+                            <p:stCondLst>
+                              <p:cond delay="0"/>
+                            </p:stCondLst>
+                            <p:childTnLst>
+                              <p:par>
+                                <p:cTn id="15" presetID="10" presetClass="entr" presetSubtype="0" fill="hold" nodeType="clickEffect">
+                                  <p:stCondLst>
+                                    <p:cond delay="0"/>
+                                  </p:stCondLst>
+                                  <p:childTnLst>
+                                    <p:set>
+                                      <p:cBhvr>
+                                        <p:cTn id="16" dur="1" fill="hold">
+                                          <p:stCondLst>
+                                            <p:cond delay="0"/>
+                                          </p:stCondLst>
+                                        </p:cTn>
+                                        <p:tgtEl>
+                                          <p:spTgt spid="23"/>
+                                        </p:tgtEl>
+                                        <p:attrNameLst>
+                                          <p:attrName>style.visibility</p:attrName>
+                                        </p:attrNameLst>
+                                      </p:cBhvr>
+                                      <p:to>
+                                        <p:strVal val="visible"/>
+                                      </p:to>
+                                    </p:set>
+                                    <p:animEffect transition="in" filter="fade">
+                                      <p:cBhvr>
+                                        <p:cTn id="17" dur="500"/>
+                                        <p:tgtEl>
+                                          <p:spTgt spid="23"/>
+                                        </p:tgtEl>
+                                      </p:cBhvr>
+                                    </p:animEffect>
+                                  </p:childTnLst>
+                                </p:cTn>
+                              </p:par>
+                            </p:childTnLst>
+                          </p:cTn>
+                        </p:par>
+                      </p:childTnLst>
+                    </p:cTn>
+                  </p:par>
+                </p:childTnLst>
+              </p:cTn>
+              <p:prevCondLst>
+                <p:cond evt="onPrev" delay="0">
+                  <p:tgtEl>
+                    <p:sldTgt/>
+                  </p:tgtEl>
+                </p:cond>
+              </p:prevCondLst>
+              <p:nextCondLst>
+                <p:cond evt="onNext" delay="0">
+                  <p:tgtEl>
+                    <p:sldTgt/>
+                  </p:tgtEl>
+                </p:cond>
+              </p:nextCondLst>
+            </p:seq>
+          </p:childTnLst>
+        </p:cTn>
+      </p:par>
+    </p:tnLst>
+  </p:timing>
 </p:sld>
 </file>
 
 <file path=ppt/slides/slide12.xml><?xml version="1.0" encoding="utf-8"?>
+<p:sld xmlns:a="http://schemas.openxmlformats.org/drawingml/2006/main" xmlns:r="http://schemas.openxmlformats.org/officeDocument/2006/relationships" xmlns:p="http://schemas.openxmlformats.org/presentationml/2006/main">
+  <p:cSld>
+    <p:bg>
+      <p:bgPr>
+        <a:solidFill>
+          <a:schemeClr val="bg1">
+            <a:lumMod val="95000"/>
+          </a:schemeClr>
+        </a:solidFill>
+        <a:effectLst/>
+      </p:bgPr>
+    </p:bg>
+    <p:spTree>
+      <p:nvGrpSpPr>
+        <p:cNvPr id="1" name="">
+          <a:extLst>
+            <a:ext uri="{FF2B5EF4-FFF2-40B4-BE49-F238E27FC236}">
+              <a16:creationId xmlns:a16="http://schemas.microsoft.com/office/drawing/2014/main" id="{75DA6A40-BCE7-A8AF-2F09-CCBF86A73F57}"/>
+            </a:ext>
+          </a:extLst>
+        </p:cNvPr>
+        <p:cNvGrpSpPr/>
+        <p:nvPr/>
+      </p:nvGrpSpPr>
+      <p:grpSpPr>
+        <a:xfrm>
+          <a:off x="0" y="0"/>
+          <a:ext cx="0" cy="0"/>
+          <a:chOff x="0" y="0"/>
+          <a:chExt cx="0" cy="0"/>
+        </a:xfrm>
+      </p:grpSpPr>
+      <p:sp>
+        <p:nvSpPr>
+          <p:cNvPr id="2" name="Title 1">
+            <a:extLst>
+              <a:ext uri="{FF2B5EF4-FFF2-40B4-BE49-F238E27FC236}">
+                <a16:creationId xmlns:a16="http://schemas.microsoft.com/office/drawing/2014/main" id="{5AD71FA1-6AD3-129C-8A3A-20D41092F1F1}"/>
+              </a:ext>
+            </a:extLst>
+          </p:cNvPr>
+          <p:cNvSpPr>
+            <a:spLocks noGrp="1"/>
+          </p:cNvSpPr>
+          <p:nvPr>
+            <p:ph type="title"/>
+          </p:nvPr>
+        </p:nvSpPr>
+        <p:spPr/>
+        <p:txBody>
+          <a:bodyPr/>
+          <a:lstStyle/>
+          <a:p>
+            <a:r>
+              <a:rPr lang="en-US" dirty="0">
+                <a:latin typeface="Arial Rounded MT Bold" panose="020F0704030504030204" pitchFamily="34" charset="0"/>
+              </a:rPr>
+              <a:t>ANNEXE I</a:t>
+            </a:r>
+            <a:endParaRPr lang="fr-CA" dirty="0">
+              <a:latin typeface="Arial Rounded MT Bold" panose="020F0704030504030204" pitchFamily="34" charset="0"/>
+            </a:endParaRPr>
+          </a:p>
+        </p:txBody>
+      </p:sp>
+      <p:sp>
+        <p:nvSpPr>
+          <p:cNvPr id="11" name="Slide Number Placeholder 10">
+            <a:extLst>
+              <a:ext uri="{FF2B5EF4-FFF2-40B4-BE49-F238E27FC236}">
+                <a16:creationId xmlns:a16="http://schemas.microsoft.com/office/drawing/2014/main" id="{6B59C14A-02F3-20F2-19A6-212B35B47AC1}"/>
+              </a:ext>
+            </a:extLst>
+          </p:cNvPr>
+          <p:cNvSpPr>
+            <a:spLocks noGrp="1"/>
+          </p:cNvSpPr>
+          <p:nvPr>
+            <p:ph type="sldNum" sz="quarter" idx="12"/>
+          </p:nvPr>
+        </p:nvSpPr>
+        <p:spPr/>
+        <p:txBody>
+          <a:bodyPr/>
+          <a:lstStyle/>
+          <a:p>
+            <a:fld id="{846B06B1-1179-491F-A487-8E0C403F7C13}" type="slidenum">
+              <a:rPr lang="fr-CA" smtClean="0"/>
+              <a:t>12</a:t>
+            </a:fld>
+            <a:endParaRPr lang="fr-CA"/>
+          </a:p>
+        </p:txBody>
+      </p:sp>
+      <p:sp>
+        <p:nvSpPr>
+          <p:cNvPr id="9" name="Content Placeholder 2">
+            <a:extLst>
+              <a:ext uri="{FF2B5EF4-FFF2-40B4-BE49-F238E27FC236}">
+                <a16:creationId xmlns:a16="http://schemas.microsoft.com/office/drawing/2014/main" id="{431F6E27-257B-2553-4FF3-7C114074BCBC}"/>
+              </a:ext>
+            </a:extLst>
+          </p:cNvPr>
+          <p:cNvSpPr/>
+          <p:nvPr>
+            <p:ph idx="1"/>
+          </p:nvPr>
+        </p:nvSpPr>
+        <p:spPr>
+          <a:xfrm>
+            <a:off x="838200" y="1825625"/>
+            <a:ext cx="10515600" cy="4351338"/>
+          </a:xfrm>
+        </p:spPr>
+        <p:txBody>
+          <a:bodyPr>
+            <a:normAutofit/>
+          </a:bodyPr>
+          <a:lstStyle/>
+          <a:p>
+            <a:pPr marL="514350" indent="-514350" algn="just">
+              <a:buFont typeface="+mj-lt"/>
+              <a:buAutoNum type="arabicPeriod"/>
+            </a:pPr>
+            <a:r>
+              <a:rPr lang="en-US" dirty="0"/>
+              <a:t>Butler, Simon; </a:t>
+            </a:r>
+            <a:r>
+              <a:rPr lang="en-US" dirty="0" err="1"/>
+              <a:t>Wermelinger</a:t>
+            </a:r>
+            <a:r>
+              <a:rPr lang="en-US" dirty="0"/>
+              <a:t>, Michel; Yu, Yijun and Sharp, Helen (2010). Exploring the Influence of </a:t>
+            </a:r>
+            <a:r>
+              <a:rPr lang="en-US" dirty="0" err="1"/>
+              <a:t>IdentifierNames</a:t>
+            </a:r>
+            <a:r>
+              <a:rPr lang="en-US" dirty="0"/>
+              <a:t> on Code Quality: An empirical study. In: 14th European Conference on Software Maintenance </a:t>
+            </a:r>
+            <a:r>
+              <a:rPr lang="en-US" dirty="0" err="1"/>
+              <a:t>andReengineering</a:t>
+            </a:r>
+            <a:r>
+              <a:rPr lang="en-US" dirty="0"/>
+              <a:t>, 15-18 Mar 2010, Madrid, Spain, pp. 156–165.</a:t>
+            </a:r>
+            <a:endParaRPr lang="pt-BR" sz="2600" dirty="0">
+              <a:latin typeface="Consolas" panose="020B0609020204030204" pitchFamily="49" charset="0"/>
+            </a:endParaRPr>
+          </a:p>
+        </p:txBody>
+      </p:sp>
+    </p:spTree>
+    <p:extLst>
+      <p:ext uri="{BB962C8B-B14F-4D97-AF65-F5344CB8AC3E}">
+        <p14:creationId xmlns:p14="http://schemas.microsoft.com/office/powerpoint/2010/main" val="4215596461"/>
+      </p:ext>
+    </p:extLst>
+  </p:cSld>
+  <p:clrMapOvr>
+    <a:masterClrMapping/>
+  </p:clrMapOvr>
+</p:sld>
+</file>
+
+<file path=ppt/slides/slide13.xml><?xml version="1.0" encoding="utf-8"?>
 <p:sld xmlns:a="http://schemas.openxmlformats.org/drawingml/2006/main" xmlns:r="http://schemas.openxmlformats.org/officeDocument/2006/relationships" xmlns:p="http://schemas.openxmlformats.org/presentationml/2006/main">
   <p:cSld>
     <p:bg>
@@ -4465,7 +5369,7 @@
           <a:p>
             <a:fld id="{846B06B1-1179-491F-A487-8E0C403F7C13}" type="slidenum">
               <a:rPr lang="fr-CA" smtClean="0"/>
-              <a:t>12</a:t>
+              <a:t>13</a:t>
             </a:fld>
             <a:endParaRPr lang="fr-CA"/>
           </a:p>
@@ -4484,7 +5388,7 @@
 </p:sld>
 </file>
 
-<file path=ppt/slides/slide13.xml><?xml version="1.0" encoding="utf-8"?>
+<file path=ppt/slides/slide14.xml><?xml version="1.0" encoding="utf-8"?>
 <p:sld xmlns:a="http://schemas.openxmlformats.org/drawingml/2006/main" xmlns:r="http://schemas.openxmlformats.org/officeDocument/2006/relationships" xmlns:p="http://schemas.openxmlformats.org/presentationml/2006/main">
   <p:cSld>
     <p:spTree>
@@ -4653,7 +5557,7 @@
           <a:p>
             <a:fld id="{846B06B1-1179-491F-A487-8E0C403F7C13}" type="slidenum">
               <a:rPr lang="fr-CA" smtClean="0"/>
-              <a:t>13</a:t>
+              <a:t>14</a:t>
             </a:fld>
             <a:endParaRPr lang="fr-CA"/>
           </a:p>
@@ -4730,8 +5634,8 @@
           </a:p>
         </p:txBody>
       </p:sp>
-      <mc:AlternateContent xmlns:mc="http://schemas.openxmlformats.org/markup-compatibility/2006">
-        <mc:Choice xmlns:a14="http://schemas.microsoft.com/office/drawing/2010/main" Requires="a14">
+      <mc:AlternateContent xmlns:mc="http://schemas.openxmlformats.org/markup-compatibility/2006" xmlns:a14="http://schemas.microsoft.com/office/drawing/2010/main">
+        <mc:Choice Requires="a14">
           <p:sp>
             <p:nvSpPr>
               <p:cNvPr id="3" name="Content Placeholder 2">
@@ -5201,7 +6105,7 @@
             </p:txBody>
           </p:sp>
         </mc:Choice>
-        <mc:Fallback>
+        <mc:Fallback xmlns="">
           <p:sp>
             <p:nvSpPr>
               <p:cNvPr id="3" name="Content Placeholder 2">
@@ -5877,8 +6781,8 @@
           </a:p>
         </p:txBody>
       </p:sp>
-      <mc:AlternateContent xmlns:mc="http://schemas.openxmlformats.org/markup-compatibility/2006">
-        <mc:Choice xmlns:a14="http://schemas.microsoft.com/office/drawing/2010/main" Requires="a14">
+      <mc:AlternateContent xmlns:mc="http://schemas.openxmlformats.org/markup-compatibility/2006" xmlns:a14="http://schemas.microsoft.com/office/drawing/2010/main">
+        <mc:Choice Requires="a14">
           <p:sp>
             <p:nvSpPr>
               <p:cNvPr id="3" name="Content Placeholder 2">
@@ -6192,7 +7096,7 @@
             </p:txBody>
           </p:sp>
         </mc:Choice>
-        <mc:Fallback>
+        <mc:Fallback xmlns="">
           <p:sp>
             <p:nvSpPr>
               <p:cNvPr id="3" name="Content Placeholder 2">
@@ -8654,8 +9558,8 @@
           <a:chExt cx="0" cy="0"/>
         </a:xfrm>
       </p:grpSpPr>
-      <mc:AlternateContent xmlns:mc="http://schemas.openxmlformats.org/markup-compatibility/2006">
-        <mc:Choice xmlns:a14="http://schemas.microsoft.com/office/drawing/2010/main" Requires="a14">
+      <mc:AlternateContent xmlns:mc="http://schemas.openxmlformats.org/markup-compatibility/2006" xmlns:a14="http://schemas.microsoft.com/office/drawing/2010/main">
+        <mc:Choice Requires="a14">
           <p:sp>
             <p:nvSpPr>
               <p:cNvPr id="2" name="Title 1">
@@ -8749,7 +9653,7 @@
             </p:txBody>
           </p:sp>
         </mc:Choice>
-        <mc:Fallback>
+        <mc:Fallback xmlns="">
           <p:sp>
             <p:nvSpPr>
               <p:cNvPr id="2" name="Title 1">
@@ -8789,8 +9693,8 @@
           </p:sp>
         </mc:Fallback>
       </mc:AlternateContent>
-      <mc:AlternateContent xmlns:mc="http://schemas.openxmlformats.org/markup-compatibility/2006">
-        <mc:Choice xmlns:a14="http://schemas.microsoft.com/office/drawing/2010/main" Requires="a14">
+      <mc:AlternateContent xmlns:mc="http://schemas.openxmlformats.org/markup-compatibility/2006" xmlns:a14="http://schemas.microsoft.com/office/drawing/2010/main">
+        <mc:Choice Requires="a14">
           <p:sp>
             <p:nvSpPr>
               <p:cNvPr id="3" name="Content Placeholder 2">
@@ -9292,7 +10196,7 @@
             </p:txBody>
           </p:sp>
         </mc:Choice>
-        <mc:Fallback>
+        <mc:Fallback xmlns="">
           <p:sp>
             <p:nvSpPr>
               <p:cNvPr id="3" name="Content Placeholder 2">
@@ -9743,8 +10647,8 @@
           </a:p>
         </p:txBody>
       </p:sp>
-      <mc:AlternateContent xmlns:mc="http://schemas.openxmlformats.org/markup-compatibility/2006">
-        <mc:Choice xmlns:a14="http://schemas.microsoft.com/office/drawing/2010/main" Requires="a14">
+      <mc:AlternateContent xmlns:mc="http://schemas.openxmlformats.org/markup-compatibility/2006" xmlns:a14="http://schemas.microsoft.com/office/drawing/2010/main">
+        <mc:Choice Requires="a14">
           <p:sp>
             <p:nvSpPr>
               <p:cNvPr id="3" name="Content Placeholder 2">
@@ -9827,7 +10731,7 @@
             </p:txBody>
           </p:sp>
         </mc:Choice>
-        <mc:Fallback>
+        <mc:Fallback xmlns="">
           <p:sp>
             <p:nvSpPr>
               <p:cNvPr id="3" name="Content Placeholder 2">
@@ -9911,9 +10815,9 @@
         <p:spPr>
           <a:xfrm>
             <a:off x="2869659" y="3104135"/>
-            <a:ext cx="6452681" cy="2162294"/>
+            <a:ext cx="6452681" cy="1954381"/>
           </a:xfrm>
-          <a:prstGeom prst="roundRect">
+          <a:prstGeom prst="rect">
             <a:avLst/>
           </a:prstGeom>
           <a:solidFill>
@@ -10114,7 +11018,7 @@
             </a:extLst>
           </p:cNvPr>
           <p:cNvSpPr>
-            <a:spLocks noGrp="1"/>
+            <a:spLocks noGrp="1" noRot="1" noMove="1" noResize="1" noEditPoints="1" noAdjustHandles="1" noChangeArrowheads="1" noChangeShapeType="1"/>
           </p:cNvSpPr>
           <p:nvPr>
             <p:ph idx="1"/>
@@ -10229,7 +11133,7 @@
               <a:rPr lang="pt-BR" sz="2600" b="1" dirty="0">
                 <a:latin typeface="Consolas" panose="020B0609020204030204" pitchFamily="49" charset="0"/>
               </a:rPr>
-              <a:t>Verbes d'action</a:t>
+              <a:t>Verbe d'action</a:t>
             </a:r>
             <a:r>
               <a:rPr lang="pt-BR" sz="2600" dirty="0">
@@ -10249,7 +11153,20 @@
               <a:rPr lang="pt-BR" sz="2600" b="1" dirty="0">
                 <a:latin typeface="Consolas" panose="020B0609020204030204" pitchFamily="49" charset="0"/>
               </a:rPr>
-              <a:t>mots-clés réservés</a:t>
+              <a:t>mots-clés réservés (</a:t>
+            </a:r>
+            <a:r>
+              <a:rPr lang="pt-BR" sz="2600" b="1" dirty="0">
+                <a:latin typeface="Consolas" panose="020B0609020204030204" pitchFamily="49" charset="0"/>
+                <a:hlinkClick r:id="rId2"/>
+              </a:rPr>
+              <a:t>lien</a:t>
+            </a:r>
+            <a:r>
+              <a:rPr lang="pt-BR" sz="2600" b="1" dirty="0">
+                <a:latin typeface="Consolas" panose="020B0609020204030204" pitchFamily="49" charset="0"/>
+              </a:rPr>
+              <a:t>)</a:t>
             </a:r>
           </a:p>
           <a:p>
@@ -10294,6 +11211,55 @@
               <a:t>9</a:t>
             </a:fld>
             <a:endParaRPr lang="fr-CA"/>
+          </a:p>
+        </p:txBody>
+      </p:sp>
+      <p:sp>
+        <p:nvSpPr>
+          <p:cNvPr id="4" name="TextBox 3">
+            <a:extLst>
+              <a:ext uri="{FF2B5EF4-FFF2-40B4-BE49-F238E27FC236}">
+                <a16:creationId xmlns:a16="http://schemas.microsoft.com/office/drawing/2014/main" id="{195BC26F-4260-FBE0-009F-7E08B9978BC4}"/>
+              </a:ext>
+            </a:extLst>
+          </p:cNvPr>
+          <p:cNvSpPr txBox="1"/>
+          <p:nvPr/>
+        </p:nvSpPr>
+        <p:spPr>
+          <a:xfrm>
+            <a:off x="838199" y="6176963"/>
+            <a:ext cx="10515599" cy="369332"/>
+          </a:xfrm>
+          <a:prstGeom prst="rect">
+            <a:avLst/>
+          </a:prstGeom>
+          <a:noFill/>
+        </p:spPr>
+        <p:txBody>
+          <a:bodyPr wrap="square">
+            <a:spAutoFit/>
+          </a:bodyPr>
+          <a:lstStyle/>
+          <a:p>
+            <a:pPr marL="0" indent="0" algn="ctr">
+              <a:buNone/>
+            </a:pPr>
+            <a:r>
+              <a:rPr lang="en-US" b="1" dirty="0">
+                <a:latin typeface="Consolas" panose="020B0609020204030204" pitchFamily="49" charset="0"/>
+              </a:rPr>
+              <a:t>V</a:t>
+            </a:r>
+            <a:r>
+              <a:rPr lang="fr-CA" b="1" dirty="0">
+                <a:latin typeface="Consolas" panose="020B0609020204030204" pitchFamily="49" charset="0"/>
+              </a:rPr>
+              <a:t>OIR L'ANNEXE I</a:t>
+            </a:r>
+            <a:endParaRPr lang="fr-CA" sz="1800" b="1" dirty="0">
+              <a:latin typeface="Consolas" panose="020B0609020204030204" pitchFamily="49" charset="0"/>
+            </a:endParaRPr>
           </a:p>
         </p:txBody>
       </p:sp>

</xml_diff>

<commit_message>
feat: Expand python_1 presentation to slide no.11
</commit_message>
<xml_diff>
--- a/python_1/presentation_python_1.pptx
+++ b/python_1/presentation_python_1.pptx
@@ -210,7 +210,7 @@
           <a:p>
             <a:fld id="{17426931-AE65-4D08-8B32-62FCBDE55937}" type="datetimeFigureOut">
               <a:rPr lang="fr-CA" smtClean="0"/>
-              <a:t>2026-04-07</a:t>
+              <a:t>2026-04-08</a:t>
             </a:fld>
             <a:endParaRPr lang="fr-CA"/>
           </a:p>
@@ -627,7 +627,7 @@
           <a:p>
             <a:fld id="{73720E39-F9E6-45F4-9AF3-0670893E0E05}" type="datetime1">
               <a:rPr lang="fr-CA" smtClean="0"/>
-              <a:t>2026-04-07</a:t>
+              <a:t>2026-04-08</a:t>
             </a:fld>
             <a:endParaRPr lang="fr-CA"/>
           </a:p>
@@ -827,7 +827,7 @@
           <a:p>
             <a:fld id="{2A86A87F-FCE1-414B-898E-E056954DFB53}" type="datetime1">
               <a:rPr lang="fr-CA" smtClean="0"/>
-              <a:t>2026-04-07</a:t>
+              <a:t>2026-04-08</a:t>
             </a:fld>
             <a:endParaRPr lang="fr-CA"/>
           </a:p>
@@ -1037,7 +1037,7 @@
           <a:p>
             <a:fld id="{86217A25-A768-4FB5-8838-4C76F4A4D771}" type="datetime1">
               <a:rPr lang="fr-CA" smtClean="0"/>
-              <a:t>2026-04-07</a:t>
+              <a:t>2026-04-08</a:t>
             </a:fld>
             <a:endParaRPr lang="fr-CA"/>
           </a:p>
@@ -1237,7 +1237,7 @@
           <a:p>
             <a:fld id="{6DF5E9B1-F4B4-44A9-8978-A50A0AD8373C}" type="datetime1">
               <a:rPr lang="fr-CA" smtClean="0"/>
-              <a:t>2026-04-07</a:t>
+              <a:t>2026-04-08</a:t>
             </a:fld>
             <a:endParaRPr lang="fr-CA"/>
           </a:p>
@@ -1513,7 +1513,7 @@
           <a:p>
             <a:fld id="{5DE8FE0D-E91C-47AE-8B70-2B0ABA5D1B1E}" type="datetime1">
               <a:rPr lang="fr-CA" smtClean="0"/>
-              <a:t>2026-04-07</a:t>
+              <a:t>2026-04-08</a:t>
             </a:fld>
             <a:endParaRPr lang="fr-CA"/>
           </a:p>
@@ -1781,7 +1781,7 @@
           <a:p>
             <a:fld id="{F3AB8F30-8420-4011-A9ED-ED2F47883C93}" type="datetime1">
               <a:rPr lang="fr-CA" smtClean="0"/>
-              <a:t>2026-04-07</a:t>
+              <a:t>2026-04-08</a:t>
             </a:fld>
             <a:endParaRPr lang="fr-CA"/>
           </a:p>
@@ -2196,7 +2196,7 @@
           <a:p>
             <a:fld id="{852876F1-672F-46E4-BC46-E9D4C880BFEF}" type="datetime1">
               <a:rPr lang="fr-CA" smtClean="0"/>
-              <a:t>2026-04-07</a:t>
+              <a:t>2026-04-08</a:t>
             </a:fld>
             <a:endParaRPr lang="fr-CA"/>
           </a:p>
@@ -2338,7 +2338,7 @@
           <a:p>
             <a:fld id="{05494588-57AE-4A88-AA7D-14590C8ABB1D}" type="datetime1">
               <a:rPr lang="fr-CA" smtClean="0"/>
-              <a:t>2026-04-07</a:t>
+              <a:t>2026-04-08</a:t>
             </a:fld>
             <a:endParaRPr lang="fr-CA"/>
           </a:p>
@@ -2451,7 +2451,7 @@
           <a:p>
             <a:fld id="{70596107-F84A-4D89-B7EE-30826EF0EE70}" type="datetime1">
               <a:rPr lang="fr-CA" smtClean="0"/>
-              <a:t>2026-04-07</a:t>
+              <a:t>2026-04-08</a:t>
             </a:fld>
             <a:endParaRPr lang="fr-CA"/>
           </a:p>
@@ -2764,7 +2764,7 @@
           <a:p>
             <a:fld id="{12C269CA-6797-4965-A975-3F40F12DAD06}" type="datetime1">
               <a:rPr lang="fr-CA" smtClean="0"/>
-              <a:t>2026-04-07</a:t>
+              <a:t>2026-04-08</a:t>
             </a:fld>
             <a:endParaRPr lang="fr-CA"/>
           </a:p>
@@ -3053,7 +3053,7 @@
           <a:p>
             <a:fld id="{3F5AE234-69D2-4522-AB7A-F911A65753A0}" type="datetime1">
               <a:rPr lang="fr-CA" smtClean="0"/>
-              <a:t>2026-04-07</a:t>
+              <a:t>2026-04-08</a:t>
             </a:fld>
             <a:endParaRPr lang="fr-CA"/>
           </a:p>
@@ -3296,7 +3296,7 @@
           <a:p>
             <a:fld id="{30546B8D-50B2-4CF7-ACAA-221A68F8C882}" type="datetime1">
               <a:rPr lang="fr-CA" smtClean="0"/>
-              <a:t>2026-04-07</a:t>
+              <a:t>2026-04-08</a:t>
             </a:fld>
             <a:endParaRPr lang="fr-CA"/>
           </a:p>
@@ -3851,8 +3851,8 @@
         </p:nvSpPr>
         <p:spPr>
           <a:xfrm>
-            <a:off x="2869660" y="2716450"/>
-            <a:ext cx="6452681" cy="2785378"/>
+            <a:off x="2698481" y="2716450"/>
+            <a:ext cx="6795040" cy="2785378"/>
           </a:xfrm>
           <a:prstGeom prst="rect">
             <a:avLst/>
@@ -3922,7 +3922,7 @@
               <a:rPr lang="pt-BR" b="1" dirty="0">
                 <a:latin typeface="Consolas" panose="020B0609020204030204" pitchFamily="49" charset="0"/>
               </a:rPr>
-              <a:t>  DISCRIMINANT = (b ** 2 - 4 * a * c) ** 0.5</a:t>
+              <a:t>  RACINE_DISCRIMINANT = (b ** 2 - 4 * a * c) ** 0.5</a:t>
             </a:r>
           </a:p>
           <a:p>
@@ -3930,7 +3930,7 @@
               <a:rPr lang="pt-BR" b="1" dirty="0">
                 <a:latin typeface="Consolas" panose="020B0609020204030204" pitchFamily="49" charset="0"/>
               </a:rPr>
-              <a:t>  racine_1 = (-b - DISCRIMINANT) / (2 * a)</a:t>
+              <a:t>  racine_1 = (-b - RACINE_DISCRIMINANT ) / (2 * a)</a:t>
             </a:r>
           </a:p>
           <a:p>
@@ -3938,7 +3938,7 @@
               <a:rPr lang="pt-BR" b="1" dirty="0">
                 <a:latin typeface="Consolas" panose="020B0609020204030204" pitchFamily="49" charset="0"/>
               </a:rPr>
-              <a:t>  racine_2 = (-b + DISCRIMINANT) / (2 * a)</a:t>
+              <a:t>  racine_2 = (-b + RACINE_DISCRIMINANT ) / (2 * a)</a:t>
             </a:r>
           </a:p>
           <a:p>
@@ -4000,8 +4000,8 @@
         </p:nvSpPr>
         <p:spPr>
           <a:xfrm>
-            <a:off x="2869659" y="383636"/>
-            <a:ext cx="6452681" cy="1954381"/>
+            <a:off x="2698480" y="383636"/>
+            <a:ext cx="6795040" cy="1954381"/>
           </a:xfrm>
           <a:prstGeom prst="rect">
             <a:avLst/>
@@ -5182,7 +5182,9 @@
               </a:ext>
             </a:extLst>
           </p:cNvPr>
-          <p:cNvSpPr/>
+          <p:cNvSpPr>
+            <a:spLocks noGrp="1"/>
+          </p:cNvSpPr>
           <p:nvPr>
             <p:ph idx="1"/>
           </p:nvPr>
@@ -9693,8 +9695,8 @@
           </p:sp>
         </mc:Fallback>
       </mc:AlternateContent>
-      <mc:AlternateContent xmlns:mc="http://schemas.openxmlformats.org/markup-compatibility/2006" xmlns:a14="http://schemas.microsoft.com/office/drawing/2010/main">
-        <mc:Choice Requires="a14">
+      <mc:AlternateContent xmlns:mc="http://schemas.openxmlformats.org/markup-compatibility/2006">
+        <mc:Choice xmlns:a14="http://schemas.microsoft.com/office/drawing/2010/main" Requires="a14">
           <p:sp>
             <p:nvSpPr>
               <p:cNvPr id="3" name="Content Placeholder 2">
@@ -10193,10 +10195,102 @@
                   <a:latin typeface="Consolas" panose="020B0609020204030204" pitchFamily="49" charset="0"/>
                 </a:endParaRPr>
               </a:p>
+              <a:p>
+                <a:pPr marL="0" indent="0" algn="just">
+                  <a:buNone/>
+                </a:pPr>
+                <a:r>
+                  <a:rPr lang="en-CA" b="1" dirty="0">
+                    <a:latin typeface="Consolas" panose="020B0609020204030204" pitchFamily="49" charset="0"/>
+                  </a:rPr>
+                  <a:t>Pour </a:t>
+                </a:r>
+                <a14:m>
+                  <m:oMath xmlns:m="http://schemas.openxmlformats.org/officeDocument/2006/math">
+                    <m:r>
+                      <a:rPr lang="en-CA" b="1" i="1" smtClean="0">
+                        <a:latin typeface="Cambria Math" panose="02040503050406030204" pitchFamily="18" charset="0"/>
+                      </a:rPr>
+                      <m:t>𝒙</m:t>
+                    </m:r>
+                    <m:r>
+                      <a:rPr lang="en-CA" b="1" i="1" smtClean="0">
+                        <a:latin typeface="Cambria Math" panose="02040503050406030204" pitchFamily="18" charset="0"/>
+                      </a:rPr>
+                      <m:t>=</m:t>
+                    </m:r>
+                    <m:r>
+                      <a:rPr lang="en-CA" b="1" i="1" smtClean="0">
+                        <a:latin typeface="Cambria Math" panose="02040503050406030204" pitchFamily="18" charset="0"/>
+                      </a:rPr>
+                      <m:t>𝟏</m:t>
+                    </m:r>
+                  </m:oMath>
+                </a14:m>
+                <a:r>
+                  <a:rPr lang="en-CA" b="1" dirty="0">
+                    <a:latin typeface="Consolas" panose="020B0609020204030204" pitchFamily="49" charset="0"/>
+                  </a:rPr>
+                  <a:t>, </a:t>
+                </a:r>
+                <a14:m>
+                  <m:oMath xmlns:m="http://schemas.openxmlformats.org/officeDocument/2006/math">
+                    <m:r>
+                      <a:rPr lang="en-CA" b="1" i="1" smtClean="0">
+                        <a:latin typeface="Cambria Math" panose="02040503050406030204" pitchFamily="18" charset="0"/>
+                      </a:rPr>
+                      <m:t>𝒚</m:t>
+                    </m:r>
+                    <m:r>
+                      <a:rPr lang="en-CA" b="1" i="1" smtClean="0">
+                        <a:latin typeface="Cambria Math" panose="02040503050406030204" pitchFamily="18" charset="0"/>
+                      </a:rPr>
+                      <m:t>=</m:t>
+                    </m:r>
+                    <m:r>
+                      <a:rPr lang="en-CA" b="1" i="1" smtClean="0">
+                        <a:latin typeface="Cambria Math" panose="02040503050406030204" pitchFamily="18" charset="0"/>
+                      </a:rPr>
+                      <m:t>𝟐</m:t>
+                    </m:r>
+                  </m:oMath>
+                </a14:m>
+                <a:r>
+                  <a:rPr lang="en-CA" b="1" dirty="0">
+                    <a:latin typeface="Consolas" panose="020B0609020204030204" pitchFamily="49" charset="0"/>
+                  </a:rPr>
+                  <a:t>, </a:t>
+                </a:r>
+                <a14:m>
+                  <m:oMath xmlns:m="http://schemas.openxmlformats.org/officeDocument/2006/math">
+                    <m:r>
+                      <a:rPr lang="en-CA" b="1" i="1" smtClean="0">
+                        <a:latin typeface="Cambria Math" panose="02040503050406030204" pitchFamily="18" charset="0"/>
+                      </a:rPr>
+                      <m:t>𝒛</m:t>
+                    </m:r>
+                    <m:r>
+                      <a:rPr lang="en-CA" b="1" i="1" smtClean="0">
+                        <a:latin typeface="Cambria Math" panose="02040503050406030204" pitchFamily="18" charset="0"/>
+                      </a:rPr>
+                      <m:t>=−</m:t>
+                    </m:r>
+                    <m:r>
+                      <a:rPr lang="en-CA" b="1" i="1" smtClean="0">
+                        <a:latin typeface="Cambria Math" panose="02040503050406030204" pitchFamily="18" charset="0"/>
+                      </a:rPr>
+                      <m:t>𝟏</m:t>
+                    </m:r>
+                  </m:oMath>
+                </a14:m>
+                <a:endParaRPr lang="en-CA" b="1" dirty="0">
+                  <a:latin typeface="Consolas" panose="020B0609020204030204" pitchFamily="49" charset="0"/>
+                </a:endParaRPr>
+              </a:p>
             </p:txBody>
           </p:sp>
         </mc:Choice>
-        <mc:Fallback xmlns="">
+        <mc:Fallback>
           <p:sp>
             <p:nvSpPr>
               <p:cNvPr id="3" name="Content Placeholder 2">
@@ -10815,7 +10909,7 @@
         <p:spPr>
           <a:xfrm>
             <a:off x="2869659" y="3104135"/>
-            <a:ext cx="6452681" cy="1954381"/>
+            <a:ext cx="5100537" cy="1954381"/>
           </a:xfrm>
           <a:prstGeom prst="rect">
             <a:avLst/>
@@ -10928,6 +11022,210 @@
           </a:p>
         </p:txBody>
       </p:sp>
+      <p:grpSp>
+        <p:nvGrpSpPr>
+          <p:cNvPr id="4" name="Group 3">
+            <a:extLst>
+              <a:ext uri="{FF2B5EF4-FFF2-40B4-BE49-F238E27FC236}">
+                <a16:creationId xmlns:a16="http://schemas.microsoft.com/office/drawing/2014/main" id="{2BEF6B35-24ED-F88F-D31B-E5C7962AC412}"/>
+              </a:ext>
+            </a:extLst>
+          </p:cNvPr>
+          <p:cNvGrpSpPr/>
+          <p:nvPr/>
+        </p:nvGrpSpPr>
+        <p:grpSpPr>
+          <a:xfrm>
+            <a:off x="7723773" y="3205424"/>
+            <a:ext cx="1771280" cy="369332"/>
+            <a:chOff x="6485106" y="3914378"/>
+            <a:chExt cx="1771280" cy="369332"/>
+          </a:xfrm>
+        </p:grpSpPr>
+        <p:sp>
+          <p:nvSpPr>
+            <p:cNvPr id="5" name="TextBox 4">
+              <a:extLst>
+                <a:ext uri="{FF2B5EF4-FFF2-40B4-BE49-F238E27FC236}">
+                  <a16:creationId xmlns:a16="http://schemas.microsoft.com/office/drawing/2014/main" id="{888E60CA-339A-6B53-D288-F704F97D5634}"/>
+                </a:ext>
+              </a:extLst>
+            </p:cNvPr>
+            <p:cNvSpPr txBox="1"/>
+            <p:nvPr/>
+          </p:nvSpPr>
+          <p:spPr>
+            <a:xfrm>
+              <a:off x="7309395" y="3914378"/>
+              <a:ext cx="946991" cy="369332"/>
+            </a:xfrm>
+            <a:prstGeom prst="rect">
+              <a:avLst/>
+            </a:prstGeom>
+            <a:noFill/>
+          </p:spPr>
+          <p:txBody>
+            <a:bodyPr wrap="none" rtlCol="0">
+              <a:spAutoFit/>
+            </a:bodyPr>
+            <a:lstStyle/>
+            <a:p>
+              <a:r>
+                <a:rPr lang="en-US" b="1" dirty="0"/>
+                <a:t>En-tête</a:t>
+              </a:r>
+              <a:endParaRPr lang="fr-CA" b="1" dirty="0"/>
+            </a:p>
+          </p:txBody>
+        </p:sp>
+        <p:cxnSp>
+          <p:nvCxnSpPr>
+            <p:cNvPr id="6" name="Straight Arrow Connector 5">
+              <a:extLst>
+                <a:ext uri="{FF2B5EF4-FFF2-40B4-BE49-F238E27FC236}">
+                  <a16:creationId xmlns:a16="http://schemas.microsoft.com/office/drawing/2014/main" id="{889B386E-B4D3-ECBF-0F45-058DB147A597}"/>
+                </a:ext>
+              </a:extLst>
+            </p:cNvPr>
+            <p:cNvCxnSpPr>
+              <a:cxnSpLocks/>
+            </p:cNvCxnSpPr>
+            <p:nvPr/>
+          </p:nvCxnSpPr>
+          <p:spPr>
+            <a:xfrm flipH="1">
+              <a:off x="6485106" y="4099044"/>
+              <a:ext cx="810000" cy="0"/>
+            </a:xfrm>
+            <a:prstGeom prst="straightConnector1">
+              <a:avLst/>
+            </a:prstGeom>
+            <a:ln>
+              <a:tailEnd type="triangle"/>
+            </a:ln>
+          </p:spPr>
+          <p:style>
+            <a:lnRef idx="2">
+              <a:schemeClr val="dk1"/>
+            </a:lnRef>
+            <a:fillRef idx="0">
+              <a:schemeClr val="dk1"/>
+            </a:fillRef>
+            <a:effectRef idx="1">
+              <a:schemeClr val="dk1"/>
+            </a:effectRef>
+            <a:fontRef idx="minor">
+              <a:schemeClr val="tx1"/>
+            </a:fontRef>
+          </p:style>
+        </p:cxnSp>
+      </p:grpSp>
+      <p:grpSp>
+        <p:nvGrpSpPr>
+          <p:cNvPr id="8" name="Group 7">
+            <a:extLst>
+              <a:ext uri="{FF2B5EF4-FFF2-40B4-BE49-F238E27FC236}">
+                <a16:creationId xmlns:a16="http://schemas.microsoft.com/office/drawing/2014/main" id="{587AC407-806A-9844-A3C2-326252B29AE4}"/>
+              </a:ext>
+            </a:extLst>
+          </p:cNvPr>
+          <p:cNvGrpSpPr/>
+          <p:nvPr/>
+        </p:nvGrpSpPr>
+        <p:grpSpPr>
+          <a:xfrm>
+            <a:off x="7723773" y="4165699"/>
+            <a:ext cx="4082040" cy="369332"/>
+            <a:chOff x="6485106" y="4913563"/>
+            <a:chExt cx="4082040" cy="369332"/>
+          </a:xfrm>
+        </p:grpSpPr>
+        <p:sp>
+          <p:nvSpPr>
+            <p:cNvPr id="9" name="TextBox 8">
+              <a:extLst>
+                <a:ext uri="{FF2B5EF4-FFF2-40B4-BE49-F238E27FC236}">
+                  <a16:creationId xmlns:a16="http://schemas.microsoft.com/office/drawing/2014/main" id="{A1F76033-B16F-AEF2-C255-EAF6D517CF04}"/>
+                </a:ext>
+              </a:extLst>
+            </p:cNvPr>
+            <p:cNvSpPr txBox="1"/>
+            <p:nvPr/>
+          </p:nvSpPr>
+          <p:spPr>
+            <a:xfrm>
+              <a:off x="7309395" y="4913563"/>
+              <a:ext cx="3257751" cy="369332"/>
+            </a:xfrm>
+            <a:prstGeom prst="rect">
+              <a:avLst/>
+            </a:prstGeom>
+            <a:noFill/>
+          </p:spPr>
+          <p:txBody>
+            <a:bodyPr wrap="none" rtlCol="0">
+              <a:spAutoFit/>
+            </a:bodyPr>
+            <a:lstStyle/>
+            <a:p>
+              <a:r>
+                <a:rPr lang="en-US" b="1" dirty="0"/>
+                <a:t>Corps </a:t>
+              </a:r>
+              <a:r>
+                <a:rPr lang="en-US" b="1" dirty="0" err="1"/>
+                <a:t>contenant</a:t>
+              </a:r>
+              <a:r>
+                <a:rPr lang="en-US" b="1" dirty="0"/>
+                <a:t> instructions</a:t>
+              </a:r>
+              <a:endParaRPr lang="fr-CA" b="1" dirty="0"/>
+            </a:p>
+          </p:txBody>
+        </p:sp>
+        <p:cxnSp>
+          <p:nvCxnSpPr>
+            <p:cNvPr id="10" name="Straight Arrow Connector 9">
+              <a:extLst>
+                <a:ext uri="{FF2B5EF4-FFF2-40B4-BE49-F238E27FC236}">
+                  <a16:creationId xmlns:a16="http://schemas.microsoft.com/office/drawing/2014/main" id="{62C5D3A4-140A-B882-1BC3-CAFFAC2E21B4}"/>
+                </a:ext>
+              </a:extLst>
+            </p:cNvPr>
+            <p:cNvCxnSpPr>
+              <a:cxnSpLocks/>
+            </p:cNvCxnSpPr>
+            <p:nvPr/>
+          </p:nvCxnSpPr>
+          <p:spPr>
+            <a:xfrm flipH="1">
+              <a:off x="6485106" y="5098230"/>
+              <a:ext cx="810000" cy="0"/>
+            </a:xfrm>
+            <a:prstGeom prst="straightConnector1">
+              <a:avLst/>
+            </a:prstGeom>
+            <a:ln>
+              <a:tailEnd type="triangle"/>
+            </a:ln>
+          </p:spPr>
+          <p:style>
+            <a:lnRef idx="2">
+              <a:schemeClr val="dk1"/>
+            </a:lnRef>
+            <a:fillRef idx="0">
+              <a:schemeClr val="dk1"/>
+            </a:fillRef>
+            <a:effectRef idx="1">
+              <a:schemeClr val="dk1"/>
+            </a:effectRef>
+            <a:fontRef idx="minor">
+              <a:schemeClr val="tx1"/>
+            </a:fontRef>
+          </p:style>
+        </p:cxnSp>
+      </p:grpSp>
     </p:spTree>
     <p:extLst>
       <p:ext uri="{BB962C8B-B14F-4D97-AF65-F5344CB8AC3E}">
@@ -10938,6 +11236,142 @@
   <p:clrMapOvr>
     <a:masterClrMapping/>
   </p:clrMapOvr>
+  <p:timing>
+    <p:tnLst>
+      <p:par>
+        <p:cTn id="1" dur="indefinite" restart="never" nodeType="tmRoot">
+          <p:childTnLst>
+            <p:seq concurrent="1" nextAc="seek">
+              <p:cTn id="2" dur="indefinite" nodeType="mainSeq">
+                <p:childTnLst>
+                  <p:par>
+                    <p:cTn id="3" fill="hold">
+                      <p:stCondLst>
+                        <p:cond delay="indefinite"/>
+                      </p:stCondLst>
+                      <p:childTnLst>
+                        <p:par>
+                          <p:cTn id="4" fill="hold">
+                            <p:stCondLst>
+                              <p:cond delay="0"/>
+                            </p:stCondLst>
+                            <p:childTnLst>
+                              <p:par>
+                                <p:cTn id="5" presetID="10" presetClass="entr" presetSubtype="0" fill="hold" nodeType="clickEffect">
+                                  <p:stCondLst>
+                                    <p:cond delay="0"/>
+                                  </p:stCondLst>
+                                  <p:childTnLst>
+                                    <p:set>
+                                      <p:cBhvr>
+                                        <p:cTn id="6" dur="1" fill="hold">
+                                          <p:stCondLst>
+                                            <p:cond delay="0"/>
+                                          </p:stCondLst>
+                                        </p:cTn>
+                                        <p:tgtEl>
+                                          <p:spTgt spid="4"/>
+                                        </p:tgtEl>
+                                        <p:attrNameLst>
+                                          <p:attrName>style.visibility</p:attrName>
+                                        </p:attrNameLst>
+                                      </p:cBhvr>
+                                      <p:to>
+                                        <p:strVal val="visible"/>
+                                      </p:to>
+                                    </p:set>
+                                    <p:animEffect transition="in" filter="fade">
+                                      <p:cBhvr>
+                                        <p:cTn id="7" dur="500"/>
+                                        <p:tgtEl>
+                                          <p:spTgt spid="4"/>
+                                        </p:tgtEl>
+                                      </p:cBhvr>
+                                    </p:animEffect>
+                                  </p:childTnLst>
+                                </p:cTn>
+                              </p:par>
+                            </p:childTnLst>
+                          </p:cTn>
+                        </p:par>
+                      </p:childTnLst>
+                    </p:cTn>
+                  </p:par>
+                  <p:par>
+                    <p:cTn id="8" fill="hold">
+                      <p:stCondLst>
+                        <p:cond delay="indefinite"/>
+                      </p:stCondLst>
+                      <p:childTnLst>
+                        <p:par>
+                          <p:cTn id="9" fill="hold">
+                            <p:stCondLst>
+                              <p:cond delay="0"/>
+                            </p:stCondLst>
+                            <p:childTnLst>
+                              <p:par>
+                                <p:cTn id="10" presetID="10" presetClass="entr" presetSubtype="0" fill="hold" nodeType="clickEffect">
+                                  <p:stCondLst>
+                                    <p:cond delay="0"/>
+                                  </p:stCondLst>
+                                  <p:childTnLst>
+                                    <p:set>
+                                      <p:cBhvr>
+                                        <p:cTn id="11" dur="1" fill="hold">
+                                          <p:stCondLst>
+                                            <p:cond delay="0"/>
+                                          </p:stCondLst>
+                                        </p:cTn>
+                                        <p:tgtEl>
+                                          <p:spTgt spid="8"/>
+                                        </p:tgtEl>
+                                        <p:attrNameLst>
+                                          <p:attrName>style.visibility</p:attrName>
+                                        </p:attrNameLst>
+                                      </p:cBhvr>
+                                      <p:to>
+                                        <p:strVal val="visible"/>
+                                      </p:to>
+                                    </p:set>
+                                    <p:animEffect transition="in" filter="fade">
+                                      <p:cBhvr>
+                                        <p:cTn id="12" dur="500"/>
+                                        <p:tgtEl>
+                                          <p:spTgt spid="8"/>
+                                        </p:tgtEl>
+                                      </p:cBhvr>
+                                    </p:animEffect>
+                                  </p:childTnLst>
+                                </p:cTn>
+                              </p:par>
+                            </p:childTnLst>
+                          </p:cTn>
+                        </p:par>
+                      </p:childTnLst>
+                    </p:cTn>
+                  </p:par>
+                </p:childTnLst>
+              </p:cTn>
+              <p:prevCondLst>
+                <p:cond evt="onPrev" delay="0">
+                  <p:tgtEl>
+                    <p:sldTgt/>
+                  </p:tgtEl>
+                </p:cond>
+              </p:prevCondLst>
+              <p:nextCondLst>
+                <p:cond evt="onNext" delay="0">
+                  <p:tgtEl>
+                    <p:sldTgt/>
+                  </p:tgtEl>
+                </p:cond>
+              </p:nextCondLst>
+            </p:seq>
+          </p:childTnLst>
+        </p:cTn>
+      </p:par>
+    </p:tnLst>
+  </p:timing>
 </p:sld>
 </file>
 
@@ -11144,9 +11578,23 @@
           </a:p>
           <a:p>
             <a:r>
+              <a:rPr lang="pt-BR" sz="2600" b="1" dirty="0">
+                <a:latin typeface="Consolas" panose="020B0609020204030204" pitchFamily="49" charset="0"/>
+              </a:rPr>
+              <a:t>Aération</a:t>
+            </a:r>
+            <a:r>
               <a:rPr lang="pt-BR" sz="2600" dirty="0">
                 <a:latin typeface="Consolas" panose="020B0609020204030204" pitchFamily="49" charset="0"/>
               </a:rPr>
+              <a:t> horizontale et verticale</a:t>
+            </a:r>
+          </a:p>
+          <a:p>
+            <a:r>
+              <a:rPr lang="pt-BR" sz="2600" dirty="0">
+                <a:latin typeface="Consolas" panose="020B0609020204030204" pitchFamily="49" charset="0"/>
+              </a:rPr>
               <a:t>Ne pas écraser les </a:t>
             </a:r>
             <a:r>
@@ -11167,20 +11615,6 @@
                 <a:latin typeface="Consolas" panose="020B0609020204030204" pitchFamily="49" charset="0"/>
               </a:rPr>
               <a:t>)</a:t>
-            </a:r>
-          </a:p>
-          <a:p>
-            <a:r>
-              <a:rPr lang="pt-BR" sz="2600" b="1" dirty="0">
-                <a:latin typeface="Consolas" panose="020B0609020204030204" pitchFamily="49" charset="0"/>
-              </a:rPr>
-              <a:t>Aération</a:t>
-            </a:r>
-            <a:r>
-              <a:rPr lang="pt-BR" sz="2600" dirty="0">
-                <a:latin typeface="Consolas" panose="020B0609020204030204" pitchFamily="49" charset="0"/>
-              </a:rPr>
-              <a:t> horizontale et verticale</a:t>
             </a:r>
           </a:p>
         </p:txBody>
@@ -11211,55 +11645,6 @@
               <a:t>9</a:t>
             </a:fld>
             <a:endParaRPr lang="fr-CA"/>
-          </a:p>
-        </p:txBody>
-      </p:sp>
-      <p:sp>
-        <p:nvSpPr>
-          <p:cNvPr id="4" name="TextBox 3">
-            <a:extLst>
-              <a:ext uri="{FF2B5EF4-FFF2-40B4-BE49-F238E27FC236}">
-                <a16:creationId xmlns:a16="http://schemas.microsoft.com/office/drawing/2014/main" id="{195BC26F-4260-FBE0-009F-7E08B9978BC4}"/>
-              </a:ext>
-            </a:extLst>
-          </p:cNvPr>
-          <p:cNvSpPr txBox="1"/>
-          <p:nvPr/>
-        </p:nvSpPr>
-        <p:spPr>
-          <a:xfrm>
-            <a:off x="838199" y="6176963"/>
-            <a:ext cx="10515599" cy="369332"/>
-          </a:xfrm>
-          <a:prstGeom prst="rect">
-            <a:avLst/>
-          </a:prstGeom>
-          <a:noFill/>
-        </p:spPr>
-        <p:txBody>
-          <a:bodyPr wrap="square">
-            <a:spAutoFit/>
-          </a:bodyPr>
-          <a:lstStyle/>
-          <a:p>
-            <a:pPr marL="0" indent="0" algn="ctr">
-              <a:buNone/>
-            </a:pPr>
-            <a:r>
-              <a:rPr lang="en-US" b="1" dirty="0">
-                <a:latin typeface="Consolas" panose="020B0609020204030204" pitchFamily="49" charset="0"/>
-              </a:rPr>
-              <a:t>V</a:t>
-            </a:r>
-            <a:r>
-              <a:rPr lang="fr-CA" b="1" dirty="0">
-                <a:latin typeface="Consolas" panose="020B0609020204030204" pitchFamily="49" charset="0"/>
-              </a:rPr>
-              <a:t>OIR L'ANNEXE I</a:t>
-            </a:r>
-            <a:endParaRPr lang="fr-CA" sz="1800" b="1" dirty="0">
-              <a:latin typeface="Consolas" panose="020B0609020204030204" pitchFamily="49" charset="0"/>
-            </a:endParaRPr>
           </a:p>
         </p:txBody>
       </p:sp>

</xml_diff>

<commit_message>
feat: Expand python_1 presentation to slide no.12
</commit_message>
<xml_diff>
--- a/python_1/presentation_python_1.pptx
+++ b/python_1/presentation_python_1.pptx
@@ -5,7 +5,7 @@
     <p:sldMasterId id="2147483648" r:id="rId1"/>
   </p:sldMasterIdLst>
   <p:notesMasterIdLst>
-    <p:notesMasterId r:id="rId16"/>
+    <p:notesMasterId r:id="rId17"/>
   </p:notesMasterIdLst>
   <p:sldIdLst>
     <p:sldId id="256" r:id="rId2"/>
@@ -19,9 +19,10 @@
     <p:sldId id="266" r:id="rId10"/>
     <p:sldId id="268" r:id="rId11"/>
     <p:sldId id="269" r:id="rId12"/>
-    <p:sldId id="270" r:id="rId13"/>
-    <p:sldId id="267" r:id="rId14"/>
-    <p:sldId id="262" r:id="rId15"/>
+    <p:sldId id="271" r:id="rId13"/>
+    <p:sldId id="270" r:id="rId14"/>
+    <p:sldId id="267" r:id="rId15"/>
+    <p:sldId id="262" r:id="rId16"/>
   </p:sldIdLst>
   <p:sldSz cx="12192000" cy="6858000"/>
   <p:notesSz cx="6858000" cy="9144000"/>
@@ -5096,6 +5097,723 @@
         <p:cNvPr id="1" name="">
           <a:extLst>
             <a:ext uri="{FF2B5EF4-FFF2-40B4-BE49-F238E27FC236}">
+              <a16:creationId xmlns:a16="http://schemas.microsoft.com/office/drawing/2014/main" id="{FC4CFB3D-5C36-FB16-D869-DE8DB5E09B90}"/>
+            </a:ext>
+          </a:extLst>
+        </p:cNvPr>
+        <p:cNvGrpSpPr/>
+        <p:nvPr/>
+      </p:nvGrpSpPr>
+      <p:grpSpPr>
+        <a:xfrm>
+          <a:off x="0" y="0"/>
+          <a:ext cx="0" cy="0"/>
+          <a:chOff x="0" y="0"/>
+          <a:chExt cx="0" cy="0"/>
+        </a:xfrm>
+      </p:grpSpPr>
+      <p:sp>
+        <p:nvSpPr>
+          <p:cNvPr id="2" name="Title 1">
+            <a:extLst>
+              <a:ext uri="{FF2B5EF4-FFF2-40B4-BE49-F238E27FC236}">
+                <a16:creationId xmlns:a16="http://schemas.microsoft.com/office/drawing/2014/main" id="{A96336D6-3AF5-00AC-D152-B752CDA1B5DA}"/>
+              </a:ext>
+            </a:extLst>
+          </p:cNvPr>
+          <p:cNvSpPr>
+            <a:spLocks noGrp="1"/>
+          </p:cNvSpPr>
+          <p:nvPr>
+            <p:ph type="title"/>
+          </p:nvPr>
+        </p:nvSpPr>
+        <p:spPr/>
+        <p:txBody>
+          <a:bodyPr/>
+          <a:lstStyle/>
+          <a:p>
+            <a:r>
+              <a:rPr lang="en-US" dirty="0">
+                <a:latin typeface="Arial Rounded MT Bold" panose="020F0704030504030204" pitchFamily="34" charset="0"/>
+              </a:rPr>
+              <a:t>Retours et tuples (</a:t>
+            </a:r>
+            <a:r>
+              <a:rPr lang="en-US" dirty="0">
+                <a:latin typeface="Consolas" panose="020B0609020204030204" pitchFamily="49" charset="0"/>
+              </a:rPr>
+              <a:t>return</a:t>
+            </a:r>
+            <a:r>
+              <a:rPr lang="en-US" dirty="0">
+                <a:latin typeface="Arial Rounded MT Bold" panose="020F0704030504030204" pitchFamily="34" charset="0"/>
+              </a:rPr>
+              <a:t>)</a:t>
+            </a:r>
+            <a:endParaRPr lang="fr-CA" dirty="0">
+              <a:latin typeface="Arial Rounded MT Bold" panose="020F0704030504030204" pitchFamily="34" charset="0"/>
+            </a:endParaRPr>
+          </a:p>
+        </p:txBody>
+      </p:sp>
+      <p:sp>
+        <p:nvSpPr>
+          <p:cNvPr id="11" name="Slide Number Placeholder 10">
+            <a:extLst>
+              <a:ext uri="{FF2B5EF4-FFF2-40B4-BE49-F238E27FC236}">
+                <a16:creationId xmlns:a16="http://schemas.microsoft.com/office/drawing/2014/main" id="{E082D1A2-B90E-D1A5-80B5-93841D35DFC4}"/>
+              </a:ext>
+            </a:extLst>
+          </p:cNvPr>
+          <p:cNvSpPr>
+            <a:spLocks noGrp="1"/>
+          </p:cNvSpPr>
+          <p:nvPr>
+            <p:ph type="sldNum" sz="quarter" idx="12"/>
+          </p:nvPr>
+        </p:nvSpPr>
+        <p:spPr/>
+        <p:txBody>
+          <a:bodyPr/>
+          <a:lstStyle/>
+          <a:p>
+            <a:fld id="{846B06B1-1179-491F-A487-8E0C403F7C13}" type="slidenum">
+              <a:rPr lang="fr-CA" smtClean="0"/>
+              <a:t>12</a:t>
+            </a:fld>
+            <a:endParaRPr lang="fr-CA"/>
+          </a:p>
+        </p:txBody>
+      </p:sp>
+      <p:sp>
+        <p:nvSpPr>
+          <p:cNvPr id="5" name="TextBox 4">
+            <a:extLst>
+              <a:ext uri="{FF2B5EF4-FFF2-40B4-BE49-F238E27FC236}">
+                <a16:creationId xmlns:a16="http://schemas.microsoft.com/office/drawing/2014/main" id="{A342FFEE-95AA-6D2E-7D00-6B6B9F720626}"/>
+              </a:ext>
+            </a:extLst>
+          </p:cNvPr>
+          <p:cNvSpPr txBox="1"/>
+          <p:nvPr/>
+        </p:nvSpPr>
+        <p:spPr>
+          <a:xfrm>
+            <a:off x="817930" y="2523966"/>
+            <a:ext cx="5278070" cy="2954655"/>
+          </a:xfrm>
+          <a:prstGeom prst="rect">
+            <a:avLst/>
+          </a:prstGeom>
+          <a:solidFill>
+            <a:schemeClr val="bg1"/>
+          </a:solidFill>
+          <a:ln w="12700">
+            <a:solidFill>
+              <a:schemeClr val="tx1"/>
+            </a:solidFill>
+          </a:ln>
+        </p:spPr>
+        <p:txBody>
+          <a:bodyPr wrap="square">
+            <a:spAutoFit/>
+          </a:bodyPr>
+          <a:lstStyle/>
+          <a:p>
+            <a:br>
+              <a:rPr lang="pt-BR" sz="300" b="1" dirty="0">
+                <a:latin typeface="Consolas" panose="020B0609020204030204" pitchFamily="49" charset="0"/>
+              </a:rPr>
+            </a:br>
+            <a:r>
+              <a:rPr lang="pt-BR" sz="1200" b="1" dirty="0">
+                <a:latin typeface="Consolas" panose="020B0609020204030204" pitchFamily="49" charset="0"/>
+              </a:rPr>
+              <a:t>def calculer_quotient_reste(dividende, diviseur):</a:t>
+            </a:r>
+          </a:p>
+          <a:p>
+            <a:endParaRPr lang="pt-BR" sz="300" b="1" dirty="0">
+              <a:latin typeface="Consolas" panose="020B0609020204030204" pitchFamily="49" charset="0"/>
+            </a:endParaRPr>
+          </a:p>
+          <a:p>
+            <a:r>
+              <a:rPr lang="pt-BR" sz="1200" b="1" dirty="0">
+                <a:latin typeface="Consolas" panose="020B0609020204030204" pitchFamily="49" charset="0"/>
+              </a:rPr>
+              <a:t>  </a:t>
+            </a:r>
+            <a:r>
+              <a:rPr lang="pt-BR" sz="1200" b="1" dirty="0">
+                <a:solidFill>
+                  <a:srgbClr val="C00000"/>
+                </a:solidFill>
+                <a:latin typeface="Consolas" panose="020B0609020204030204" pitchFamily="49" charset="0"/>
+              </a:rPr>
+              <a:t>"""</a:t>
+            </a:r>
+          </a:p>
+          <a:p>
+            <a:r>
+              <a:rPr lang="pt-BR" sz="1200" b="1" dirty="0">
+                <a:solidFill>
+                  <a:srgbClr val="C00000"/>
+                </a:solidFill>
+                <a:latin typeface="Consolas" panose="020B0609020204030204" pitchFamily="49" charset="0"/>
+              </a:rPr>
+              <a:t>  Effectue la division entière entre dividende et </a:t>
+            </a:r>
+          </a:p>
+          <a:p>
+            <a:r>
+              <a:rPr lang="pt-BR" sz="1200" b="1" dirty="0">
+                <a:solidFill>
+                  <a:srgbClr val="C00000"/>
+                </a:solidFill>
+                <a:latin typeface="Consolas" panose="020B0609020204030204" pitchFamily="49" charset="0"/>
+              </a:rPr>
+              <a:t>  diviseur.</a:t>
+            </a:r>
+          </a:p>
+          <a:p>
+            <a:endParaRPr lang="pt-BR" sz="1200" b="1" dirty="0">
+              <a:solidFill>
+                <a:srgbClr val="C00000"/>
+              </a:solidFill>
+              <a:latin typeface="Consolas" panose="020B0609020204030204" pitchFamily="49" charset="0"/>
+            </a:endParaRPr>
+          </a:p>
+          <a:p>
+            <a:r>
+              <a:rPr lang="pt-BR" sz="1200" b="1" dirty="0">
+                <a:solidFill>
+                  <a:srgbClr val="C00000"/>
+                </a:solidFill>
+                <a:latin typeface="Consolas" panose="020B0609020204030204" pitchFamily="49" charset="0"/>
+              </a:rPr>
+              <a:t>  Arguments:</a:t>
+            </a:r>
+          </a:p>
+          <a:p>
+            <a:r>
+              <a:rPr lang="pt-BR" sz="1200" b="1" dirty="0">
+                <a:solidFill>
+                  <a:srgbClr val="C00000"/>
+                </a:solidFill>
+                <a:latin typeface="Consolas" panose="020B0609020204030204" pitchFamily="49" charset="0"/>
+              </a:rPr>
+              <a:t>    dividende (int): Le dividende.</a:t>
+            </a:r>
+          </a:p>
+          <a:p>
+            <a:r>
+              <a:rPr lang="pt-BR" sz="1200" b="1" dirty="0">
+                <a:solidFill>
+                  <a:srgbClr val="C00000"/>
+                </a:solidFill>
+                <a:latin typeface="Consolas" panose="020B0609020204030204" pitchFamily="49" charset="0"/>
+              </a:rPr>
+              <a:t>    diviseur (int): Le diviseur.</a:t>
+            </a:r>
+          </a:p>
+          <a:p>
+            <a:endParaRPr lang="pt-BR" sz="1200" b="1" dirty="0">
+              <a:solidFill>
+                <a:srgbClr val="C00000"/>
+              </a:solidFill>
+              <a:latin typeface="Consolas" panose="020B0609020204030204" pitchFamily="49" charset="0"/>
+            </a:endParaRPr>
+          </a:p>
+          <a:p>
+            <a:r>
+              <a:rPr lang="pt-BR" sz="1200" b="1" dirty="0">
+                <a:solidFill>
+                  <a:srgbClr val="C00000"/>
+                </a:solidFill>
+                <a:latin typeface="Consolas" panose="020B0609020204030204" pitchFamily="49" charset="0"/>
+              </a:rPr>
+              <a:t>  Retourne:</a:t>
+            </a:r>
+          </a:p>
+          <a:p>
+            <a:r>
+              <a:rPr lang="pt-BR" sz="1200" b="1" dirty="0">
+                <a:solidFill>
+                  <a:srgbClr val="C00000"/>
+                </a:solidFill>
+                <a:latin typeface="Consolas" panose="020B0609020204030204" pitchFamily="49" charset="0"/>
+              </a:rPr>
+              <a:t>    Un tuple contenant:</a:t>
+            </a:r>
+          </a:p>
+          <a:p>
+            <a:r>
+              <a:rPr lang="pt-BR" sz="1200" b="1" dirty="0">
+                <a:solidFill>
+                  <a:srgbClr val="C00000"/>
+                </a:solidFill>
+                <a:latin typeface="Consolas" panose="020B0609020204030204" pitchFamily="49" charset="0"/>
+              </a:rPr>
+              <a:t>      - int: Le quotient de la division entière (//).</a:t>
+            </a:r>
+          </a:p>
+          <a:p>
+            <a:r>
+              <a:rPr lang="pt-BR" sz="1200" b="1" dirty="0">
+                <a:solidFill>
+                  <a:srgbClr val="C00000"/>
+                </a:solidFill>
+                <a:latin typeface="Consolas" panose="020B0609020204030204" pitchFamily="49" charset="0"/>
+              </a:rPr>
+              <a:t>      - int: Le reste de la division entière (%).</a:t>
+            </a:r>
+          </a:p>
+          <a:p>
+            <a:r>
+              <a:rPr lang="pt-BR" sz="1200" b="1" dirty="0">
+                <a:solidFill>
+                  <a:srgbClr val="C00000"/>
+                </a:solidFill>
+                <a:latin typeface="Consolas" panose="020B0609020204030204" pitchFamily="49" charset="0"/>
+              </a:rPr>
+              <a:t>  """</a:t>
+            </a:r>
+            <a:br>
+              <a:rPr lang="pt-BR" sz="1200" b="1" dirty="0">
+                <a:latin typeface="Consolas" panose="020B0609020204030204" pitchFamily="49" charset="0"/>
+              </a:rPr>
+            </a:br>
+            <a:r>
+              <a:rPr lang="pt-BR" sz="1200" b="1" dirty="0">
+                <a:latin typeface="Consolas" panose="020B0609020204030204" pitchFamily="49" charset="0"/>
+              </a:rPr>
+              <a:t>  return dividende // diviseur, dividende % diviseur</a:t>
+            </a:r>
+            <a:endParaRPr lang="fr-CA" sz="1200" dirty="0"/>
+          </a:p>
+        </p:txBody>
+      </p:sp>
+      <p:sp>
+        <p:nvSpPr>
+          <p:cNvPr id="9" name="Content Placeholder 2">
+            <a:extLst>
+              <a:ext uri="{FF2B5EF4-FFF2-40B4-BE49-F238E27FC236}">
+                <a16:creationId xmlns:a16="http://schemas.microsoft.com/office/drawing/2014/main" id="{1E3E3737-BA5C-C36B-8231-6E54F041C408}"/>
+              </a:ext>
+            </a:extLst>
+          </p:cNvPr>
+          <p:cNvSpPr/>
+          <p:nvPr>
+            <p:ph idx="1"/>
+          </p:nvPr>
+        </p:nvSpPr>
+        <p:spPr>
+          <a:xfrm>
+            <a:off x="6096000" y="1825625"/>
+            <a:ext cx="5257800" cy="4351338"/>
+          </a:xfrm>
+        </p:spPr>
+        <p:txBody>
+          <a:bodyPr anchor="ctr">
+            <a:normAutofit/>
+          </a:bodyPr>
+          <a:lstStyle/>
+          <a:p>
+            <a:pPr marL="0" indent="0">
+              <a:buNone/>
+            </a:pPr>
+            <a:r>
+              <a:rPr lang="en-CA" sz="1200" b="1" dirty="0">
+                <a:latin typeface="Consolas" panose="020B0609020204030204" pitchFamily="49" charset="0"/>
+              </a:rPr>
+              <a:t>  &gt;&gt;&gt; </a:t>
+            </a:r>
+            <a:r>
+              <a:rPr lang="en-CA" sz="1200" b="1" dirty="0" err="1">
+                <a:latin typeface="Consolas" panose="020B0609020204030204" pitchFamily="49" charset="0"/>
+              </a:rPr>
+              <a:t>resultat</a:t>
+            </a:r>
+            <a:r>
+              <a:rPr lang="en-CA" sz="1200" b="1" dirty="0">
+                <a:latin typeface="Consolas" panose="020B0609020204030204" pitchFamily="49" charset="0"/>
+              </a:rPr>
+              <a:t> = </a:t>
+            </a:r>
+            <a:r>
+              <a:rPr lang="en-CA" sz="1200" b="1" dirty="0" err="1">
+                <a:latin typeface="Consolas" panose="020B0609020204030204" pitchFamily="49" charset="0"/>
+              </a:rPr>
+              <a:t>calculer_quotient_reste</a:t>
+            </a:r>
+            <a:r>
+              <a:rPr lang="en-CA" sz="1200" b="1" dirty="0">
+                <a:latin typeface="Consolas" panose="020B0609020204030204" pitchFamily="49" charset="0"/>
+              </a:rPr>
+              <a:t>(7, 3)</a:t>
+            </a:r>
+          </a:p>
+          <a:p>
+            <a:pPr marL="0" indent="0">
+              <a:buNone/>
+            </a:pPr>
+            <a:r>
+              <a:rPr lang="en-CA" sz="1200" b="1" dirty="0">
+                <a:latin typeface="Consolas" panose="020B0609020204030204" pitchFamily="49" charset="0"/>
+              </a:rPr>
+              <a:t>  &gt;&gt;&gt; print(</a:t>
+            </a:r>
+            <a:r>
+              <a:rPr lang="en-CA" sz="1200" b="1" dirty="0" err="1">
+                <a:latin typeface="Consolas" panose="020B0609020204030204" pitchFamily="49" charset="0"/>
+              </a:rPr>
+              <a:t>resultat</a:t>
+            </a:r>
+            <a:r>
+              <a:rPr lang="en-CA" sz="1200" b="1" dirty="0">
+                <a:latin typeface="Consolas" panose="020B0609020204030204" pitchFamily="49" charset="0"/>
+              </a:rPr>
+              <a:t>, type(</a:t>
+            </a:r>
+            <a:r>
+              <a:rPr lang="en-CA" sz="1200" b="1" dirty="0" err="1">
+                <a:latin typeface="Consolas" panose="020B0609020204030204" pitchFamily="49" charset="0"/>
+              </a:rPr>
+              <a:t>resultat</a:t>
+            </a:r>
+            <a:r>
+              <a:rPr lang="en-CA" sz="1200" b="1" dirty="0">
+                <a:latin typeface="Consolas" panose="020B0609020204030204" pitchFamily="49" charset="0"/>
+              </a:rPr>
+              <a:t>))</a:t>
+            </a:r>
+          </a:p>
+          <a:p>
+            <a:pPr marL="0" indent="0" algn="just">
+              <a:buNone/>
+            </a:pPr>
+            <a:r>
+              <a:rPr lang="en-CA" sz="1200" dirty="0">
+                <a:solidFill>
+                  <a:schemeClr val="bg1">
+                    <a:lumMod val="50000"/>
+                  </a:schemeClr>
+                </a:solidFill>
+                <a:latin typeface="Consolas" panose="020B0609020204030204" pitchFamily="49" charset="0"/>
+              </a:rPr>
+              <a:t>  (2, 1) &lt;class 'tuple'&gt;</a:t>
+            </a:r>
+          </a:p>
+          <a:p>
+            <a:pPr marL="0" indent="0">
+              <a:buNone/>
+            </a:pPr>
+            <a:r>
+              <a:rPr lang="en-CA" sz="1200" b="1" dirty="0">
+                <a:latin typeface="Consolas" panose="020B0609020204030204" pitchFamily="49" charset="0"/>
+              </a:rPr>
+              <a:t>  &gt;&gt;&gt; quotient, </a:t>
+            </a:r>
+            <a:r>
+              <a:rPr lang="en-CA" sz="1200" b="1" dirty="0" err="1">
+                <a:latin typeface="Consolas" panose="020B0609020204030204" pitchFamily="49" charset="0"/>
+              </a:rPr>
+              <a:t>reste</a:t>
+            </a:r>
+            <a:r>
+              <a:rPr lang="en-CA" sz="1200" b="1" dirty="0">
+                <a:latin typeface="Consolas" panose="020B0609020204030204" pitchFamily="49" charset="0"/>
+              </a:rPr>
+              <a:t> = </a:t>
+            </a:r>
+            <a:r>
+              <a:rPr lang="en-CA" sz="1200" b="1" dirty="0" err="1">
+                <a:latin typeface="Consolas" panose="020B0609020204030204" pitchFamily="49" charset="0"/>
+              </a:rPr>
+              <a:t>calculer_quotient_reste</a:t>
+            </a:r>
+            <a:r>
+              <a:rPr lang="en-CA" sz="1200" b="1" dirty="0">
+                <a:latin typeface="Consolas" panose="020B0609020204030204" pitchFamily="49" charset="0"/>
+              </a:rPr>
+              <a:t>(7, 3)</a:t>
+            </a:r>
+          </a:p>
+          <a:p>
+            <a:pPr marL="0" indent="0">
+              <a:buNone/>
+            </a:pPr>
+            <a:r>
+              <a:rPr lang="en-CA" sz="1200" b="1" dirty="0">
+                <a:latin typeface="Consolas" panose="020B0609020204030204" pitchFamily="49" charset="0"/>
+              </a:rPr>
+              <a:t>  &gt;&gt;&gt; print(quotient, type(quotient), </a:t>
+            </a:r>
+            <a:r>
+              <a:rPr lang="en-CA" sz="1200" b="1" dirty="0" err="1">
+                <a:latin typeface="Consolas" panose="020B0609020204030204" pitchFamily="49" charset="0"/>
+              </a:rPr>
+              <a:t>reste</a:t>
+            </a:r>
+            <a:r>
+              <a:rPr lang="en-CA" sz="1200" b="1" dirty="0">
+                <a:latin typeface="Consolas" panose="020B0609020204030204" pitchFamily="49" charset="0"/>
+              </a:rPr>
+              <a:t>, type(</a:t>
+            </a:r>
+            <a:r>
+              <a:rPr lang="en-CA" sz="1200" b="1" dirty="0" err="1">
+                <a:latin typeface="Consolas" panose="020B0609020204030204" pitchFamily="49" charset="0"/>
+              </a:rPr>
+              <a:t>reste</a:t>
+            </a:r>
+            <a:r>
+              <a:rPr lang="en-CA" sz="1200" b="1" dirty="0">
+                <a:latin typeface="Consolas" panose="020B0609020204030204" pitchFamily="49" charset="0"/>
+              </a:rPr>
+              <a:t>))</a:t>
+            </a:r>
+          </a:p>
+          <a:p>
+            <a:pPr marL="0" indent="0" algn="just">
+              <a:buNone/>
+            </a:pPr>
+            <a:r>
+              <a:rPr lang="en-CA" sz="1200" dirty="0">
+                <a:solidFill>
+                  <a:schemeClr val="bg1">
+                    <a:lumMod val="50000"/>
+                  </a:schemeClr>
+                </a:solidFill>
+                <a:latin typeface="Consolas" panose="020B0609020204030204" pitchFamily="49" charset="0"/>
+              </a:rPr>
+              <a:t>  2 &lt;class 'int'&gt; 1 &lt;class 'int'&gt;</a:t>
+            </a:r>
+          </a:p>
+        </p:txBody>
+      </p:sp>
+      <p:grpSp>
+        <p:nvGrpSpPr>
+          <p:cNvPr id="12" name="Group 11">
+            <a:extLst>
+              <a:ext uri="{FF2B5EF4-FFF2-40B4-BE49-F238E27FC236}">
+                <a16:creationId xmlns:a16="http://schemas.microsoft.com/office/drawing/2014/main" id="{8A7160CB-47C7-C18B-6CDA-6B4D4AAFD7EF}"/>
+              </a:ext>
+            </a:extLst>
+          </p:cNvPr>
+          <p:cNvGrpSpPr/>
+          <p:nvPr/>
+        </p:nvGrpSpPr>
+        <p:grpSpPr>
+          <a:xfrm>
+            <a:off x="1677896" y="5546350"/>
+            <a:ext cx="3795334" cy="729332"/>
+            <a:chOff x="6323753" y="4467617"/>
+            <a:chExt cx="3795334" cy="729332"/>
+          </a:xfrm>
+        </p:grpSpPr>
+        <p:sp>
+          <p:nvSpPr>
+            <p:cNvPr id="14" name="TextBox 13">
+              <a:extLst>
+                <a:ext uri="{FF2B5EF4-FFF2-40B4-BE49-F238E27FC236}">
+                  <a16:creationId xmlns:a16="http://schemas.microsoft.com/office/drawing/2014/main" id="{C3129542-1092-AC98-47BF-8CFBE30FC125}"/>
+                </a:ext>
+              </a:extLst>
+            </p:cNvPr>
+            <p:cNvSpPr txBox="1"/>
+            <p:nvPr/>
+          </p:nvSpPr>
+          <p:spPr>
+            <a:xfrm>
+              <a:off x="6323753" y="4827617"/>
+              <a:ext cx="3795334" cy="369332"/>
+            </a:xfrm>
+            <a:prstGeom prst="rect">
+              <a:avLst/>
+            </a:prstGeom>
+            <a:noFill/>
+          </p:spPr>
+          <p:txBody>
+            <a:bodyPr wrap="none" rtlCol="0">
+              <a:spAutoFit/>
+            </a:bodyPr>
+            <a:lstStyle/>
+            <a:p>
+              <a:r>
+                <a:rPr lang="en-US" b="1" dirty="0"/>
+                <a:t>Valeurs </a:t>
+              </a:r>
+              <a:r>
+                <a:rPr lang="en-US" b="1" dirty="0" err="1"/>
+                <a:t>séparées</a:t>
+              </a:r>
+              <a:r>
+                <a:rPr lang="en-US" b="1" dirty="0"/>
+                <a:t> par des virgules</a:t>
+              </a:r>
+              <a:endParaRPr lang="fr-CA" b="1" dirty="0"/>
+            </a:p>
+          </p:txBody>
+        </p:sp>
+        <p:cxnSp>
+          <p:nvCxnSpPr>
+            <p:cNvPr id="15" name="Straight Arrow Connector 14">
+              <a:extLst>
+                <a:ext uri="{FF2B5EF4-FFF2-40B4-BE49-F238E27FC236}">
+                  <a16:creationId xmlns:a16="http://schemas.microsoft.com/office/drawing/2014/main" id="{A2BC393B-408D-5C24-6933-DD664CEF7BEE}"/>
+                </a:ext>
+              </a:extLst>
+            </p:cNvPr>
+            <p:cNvCxnSpPr>
+              <a:cxnSpLocks/>
+            </p:cNvCxnSpPr>
+            <p:nvPr/>
+          </p:nvCxnSpPr>
+          <p:spPr>
+            <a:xfrm flipV="1">
+              <a:off x="8119118" y="4467617"/>
+              <a:ext cx="0" cy="360000"/>
+            </a:xfrm>
+            <a:prstGeom prst="straightConnector1">
+              <a:avLst/>
+            </a:prstGeom>
+            <a:ln>
+              <a:tailEnd type="triangle"/>
+            </a:ln>
+          </p:spPr>
+          <p:style>
+            <a:lnRef idx="2">
+              <a:schemeClr val="dk1"/>
+            </a:lnRef>
+            <a:fillRef idx="0">
+              <a:schemeClr val="dk1"/>
+            </a:fillRef>
+            <a:effectRef idx="1">
+              <a:schemeClr val="dk1"/>
+            </a:effectRef>
+            <a:fontRef idx="minor">
+              <a:schemeClr val="tx1"/>
+            </a:fontRef>
+          </p:style>
+        </p:cxnSp>
+      </p:grpSp>
+    </p:spTree>
+    <p:extLst>
+      <p:ext uri="{BB962C8B-B14F-4D97-AF65-F5344CB8AC3E}">
+        <p14:creationId xmlns:p14="http://schemas.microsoft.com/office/powerpoint/2010/main" val="619911894"/>
+      </p:ext>
+    </p:extLst>
+  </p:cSld>
+  <p:clrMapOvr>
+    <a:masterClrMapping/>
+  </p:clrMapOvr>
+  <p:timing>
+    <p:tnLst>
+      <p:par>
+        <p:cTn id="1" dur="indefinite" restart="never" nodeType="tmRoot">
+          <p:childTnLst>
+            <p:seq concurrent="1" nextAc="seek">
+              <p:cTn id="2" dur="indefinite" nodeType="mainSeq">
+                <p:childTnLst>
+                  <p:par>
+                    <p:cTn id="3" fill="hold">
+                      <p:stCondLst>
+                        <p:cond delay="indefinite"/>
+                      </p:stCondLst>
+                      <p:childTnLst>
+                        <p:par>
+                          <p:cTn id="4" fill="hold">
+                            <p:stCondLst>
+                              <p:cond delay="0"/>
+                            </p:stCondLst>
+                            <p:childTnLst>
+                              <p:par>
+                                <p:cTn id="5" presetID="10" presetClass="entr" presetSubtype="0" fill="hold" nodeType="clickEffect">
+                                  <p:stCondLst>
+                                    <p:cond delay="0"/>
+                                  </p:stCondLst>
+                                  <p:childTnLst>
+                                    <p:set>
+                                      <p:cBhvr>
+                                        <p:cTn id="6" dur="1" fill="hold">
+                                          <p:stCondLst>
+                                            <p:cond delay="0"/>
+                                          </p:stCondLst>
+                                        </p:cTn>
+                                        <p:tgtEl>
+                                          <p:spTgt spid="12"/>
+                                        </p:tgtEl>
+                                        <p:attrNameLst>
+                                          <p:attrName>style.visibility</p:attrName>
+                                        </p:attrNameLst>
+                                      </p:cBhvr>
+                                      <p:to>
+                                        <p:strVal val="visible"/>
+                                      </p:to>
+                                    </p:set>
+                                    <p:animEffect transition="in" filter="fade">
+                                      <p:cBhvr>
+                                        <p:cTn id="7" dur="500"/>
+                                        <p:tgtEl>
+                                          <p:spTgt spid="12"/>
+                                        </p:tgtEl>
+                                      </p:cBhvr>
+                                    </p:animEffect>
+                                  </p:childTnLst>
+                                </p:cTn>
+                              </p:par>
+                            </p:childTnLst>
+                          </p:cTn>
+                        </p:par>
+                      </p:childTnLst>
+                    </p:cTn>
+                  </p:par>
+                </p:childTnLst>
+              </p:cTn>
+              <p:prevCondLst>
+                <p:cond evt="onPrev" delay="0">
+                  <p:tgtEl>
+                    <p:sldTgt/>
+                  </p:tgtEl>
+                </p:cond>
+              </p:prevCondLst>
+              <p:nextCondLst>
+                <p:cond evt="onNext" delay="0">
+                  <p:tgtEl>
+                    <p:sldTgt/>
+                  </p:tgtEl>
+                </p:cond>
+              </p:nextCondLst>
+            </p:seq>
+          </p:childTnLst>
+        </p:cTn>
+      </p:par>
+    </p:tnLst>
+  </p:timing>
+</p:sld>
+</file>
+
+<file path=ppt/slides/slide13.xml><?xml version="1.0" encoding="utf-8"?>
+<p:sld xmlns:a="http://schemas.openxmlformats.org/drawingml/2006/main" xmlns:r="http://schemas.openxmlformats.org/officeDocument/2006/relationships" xmlns:p="http://schemas.openxmlformats.org/presentationml/2006/main">
+  <p:cSld>
+    <p:bg>
+      <p:bgPr>
+        <a:solidFill>
+          <a:schemeClr val="bg1">
+            <a:lumMod val="95000"/>
+          </a:schemeClr>
+        </a:solidFill>
+        <a:effectLst/>
+      </p:bgPr>
+    </p:bg>
+    <p:spTree>
+      <p:nvGrpSpPr>
+        <p:cNvPr id="1" name="">
+          <a:extLst>
+            <a:ext uri="{FF2B5EF4-FFF2-40B4-BE49-F238E27FC236}">
               <a16:creationId xmlns:a16="http://schemas.microsoft.com/office/drawing/2014/main" id="{75DA6A40-BCE7-A8AF-2F09-CCBF86A73F57}"/>
             </a:ext>
           </a:extLst>
@@ -5167,7 +5885,7 @@
           <a:p>
             <a:fld id="{846B06B1-1179-491F-A487-8E0C403F7C13}" type="slidenum">
               <a:rPr lang="fr-CA" smtClean="0"/>
-              <a:t>12</a:t>
+              <a:t>13</a:t>
             </a:fld>
             <a:endParaRPr lang="fr-CA"/>
           </a:p>
@@ -5252,7 +5970,7 @@
 </p:sld>
 </file>
 
-<file path=ppt/slides/slide13.xml><?xml version="1.0" encoding="utf-8"?>
+<file path=ppt/slides/slide14.xml><?xml version="1.0" encoding="utf-8"?>
 <p:sld xmlns:a="http://schemas.openxmlformats.org/drawingml/2006/main" xmlns:r="http://schemas.openxmlformats.org/officeDocument/2006/relationships" xmlns:p="http://schemas.openxmlformats.org/presentationml/2006/main">
   <p:cSld>
     <p:bg>
@@ -5371,7 +6089,7 @@
           <a:p>
             <a:fld id="{846B06B1-1179-491F-A487-8E0C403F7C13}" type="slidenum">
               <a:rPr lang="fr-CA" smtClean="0"/>
-              <a:t>13</a:t>
+              <a:t>14</a:t>
             </a:fld>
             <a:endParaRPr lang="fr-CA"/>
           </a:p>
@@ -5390,7 +6108,7 @@
 </p:sld>
 </file>
 
-<file path=ppt/slides/slide14.xml><?xml version="1.0" encoding="utf-8"?>
+<file path=ppt/slides/slide15.xml><?xml version="1.0" encoding="utf-8"?>
 <p:sld xmlns:a="http://schemas.openxmlformats.org/drawingml/2006/main" xmlns:r="http://schemas.openxmlformats.org/officeDocument/2006/relationships" xmlns:p="http://schemas.openxmlformats.org/presentationml/2006/main">
   <p:cSld>
     <p:spTree>
@@ -5559,7 +6277,7 @@
           <a:p>
             <a:fld id="{846B06B1-1179-491F-A487-8E0C403F7C13}" type="slidenum">
               <a:rPr lang="fr-CA" smtClean="0"/>
-              <a:t>14</a:t>
+              <a:t>15</a:t>
             </a:fld>
             <a:endParaRPr lang="fr-CA"/>
           </a:p>
@@ -9695,8 +10413,8 @@
           </p:sp>
         </mc:Fallback>
       </mc:AlternateContent>
-      <mc:AlternateContent xmlns:mc="http://schemas.openxmlformats.org/markup-compatibility/2006">
-        <mc:Choice xmlns:a14="http://schemas.microsoft.com/office/drawing/2010/main" Requires="a14">
+      <mc:AlternateContent xmlns:mc="http://schemas.openxmlformats.org/markup-compatibility/2006" xmlns:a14="http://schemas.microsoft.com/office/drawing/2010/main">
+        <mc:Choice Requires="a14">
           <p:sp>
             <p:nvSpPr>
               <p:cNvPr id="3" name="Content Placeholder 2">
@@ -10290,7 +11008,7 @@
             </p:txBody>
           </p:sp>
         </mc:Choice>
-        <mc:Fallback>
+        <mc:Fallback xmlns="">
           <p:sp>
             <p:nvSpPr>
               <p:cNvPr id="3" name="Content Placeholder 2">

</xml_diff>

<commit_message>
chore: Extend python_1 slide deck to slide no.13
</commit_message>
<xml_diff>
--- a/python_1/presentation_python_1.pptx
+++ b/python_1/presentation_python_1.pptx
@@ -5,7 +5,7 @@
     <p:sldMasterId id="2147483648" r:id="rId1"/>
   </p:sldMasterIdLst>
   <p:notesMasterIdLst>
-    <p:notesMasterId r:id="rId17"/>
+    <p:notesMasterId r:id="rId18"/>
   </p:notesMasterIdLst>
   <p:sldIdLst>
     <p:sldId id="256" r:id="rId2"/>
@@ -20,9 +20,10 @@
     <p:sldId id="268" r:id="rId11"/>
     <p:sldId id="269" r:id="rId12"/>
     <p:sldId id="271" r:id="rId13"/>
-    <p:sldId id="270" r:id="rId14"/>
-    <p:sldId id="267" r:id="rId15"/>
-    <p:sldId id="262" r:id="rId16"/>
+    <p:sldId id="272" r:id="rId14"/>
+    <p:sldId id="270" r:id="rId15"/>
+    <p:sldId id="267" r:id="rId16"/>
+    <p:sldId id="262" r:id="rId17"/>
   </p:sldIdLst>
   <p:sldSz cx="12192000" cy="6858000"/>
   <p:notesSz cx="6858000" cy="9144000"/>
@@ -211,7 +212,7 @@
           <a:p>
             <a:fld id="{17426931-AE65-4D08-8B32-62FCBDE55937}" type="datetimeFigureOut">
               <a:rPr lang="fr-CA" smtClean="0"/>
-              <a:t>2026-04-08</a:t>
+              <a:t>2026-04-09</a:t>
             </a:fld>
             <a:endParaRPr lang="fr-CA"/>
           </a:p>
@@ -628,7 +629,7 @@
           <a:p>
             <a:fld id="{73720E39-F9E6-45F4-9AF3-0670893E0E05}" type="datetime1">
               <a:rPr lang="fr-CA" smtClean="0"/>
-              <a:t>2026-04-08</a:t>
+              <a:t>2026-04-09</a:t>
             </a:fld>
             <a:endParaRPr lang="fr-CA"/>
           </a:p>
@@ -828,7 +829,7 @@
           <a:p>
             <a:fld id="{2A86A87F-FCE1-414B-898E-E056954DFB53}" type="datetime1">
               <a:rPr lang="fr-CA" smtClean="0"/>
-              <a:t>2026-04-08</a:t>
+              <a:t>2026-04-09</a:t>
             </a:fld>
             <a:endParaRPr lang="fr-CA"/>
           </a:p>
@@ -1038,7 +1039,7 @@
           <a:p>
             <a:fld id="{86217A25-A768-4FB5-8838-4C76F4A4D771}" type="datetime1">
               <a:rPr lang="fr-CA" smtClean="0"/>
-              <a:t>2026-04-08</a:t>
+              <a:t>2026-04-09</a:t>
             </a:fld>
             <a:endParaRPr lang="fr-CA"/>
           </a:p>
@@ -1238,7 +1239,7 @@
           <a:p>
             <a:fld id="{6DF5E9B1-F4B4-44A9-8978-A50A0AD8373C}" type="datetime1">
               <a:rPr lang="fr-CA" smtClean="0"/>
-              <a:t>2026-04-08</a:t>
+              <a:t>2026-04-09</a:t>
             </a:fld>
             <a:endParaRPr lang="fr-CA"/>
           </a:p>
@@ -1514,7 +1515,7 @@
           <a:p>
             <a:fld id="{5DE8FE0D-E91C-47AE-8B70-2B0ABA5D1B1E}" type="datetime1">
               <a:rPr lang="fr-CA" smtClean="0"/>
-              <a:t>2026-04-08</a:t>
+              <a:t>2026-04-09</a:t>
             </a:fld>
             <a:endParaRPr lang="fr-CA"/>
           </a:p>
@@ -1782,7 +1783,7 @@
           <a:p>
             <a:fld id="{F3AB8F30-8420-4011-A9ED-ED2F47883C93}" type="datetime1">
               <a:rPr lang="fr-CA" smtClean="0"/>
-              <a:t>2026-04-08</a:t>
+              <a:t>2026-04-09</a:t>
             </a:fld>
             <a:endParaRPr lang="fr-CA"/>
           </a:p>
@@ -2197,7 +2198,7 @@
           <a:p>
             <a:fld id="{852876F1-672F-46E4-BC46-E9D4C880BFEF}" type="datetime1">
               <a:rPr lang="fr-CA" smtClean="0"/>
-              <a:t>2026-04-08</a:t>
+              <a:t>2026-04-09</a:t>
             </a:fld>
             <a:endParaRPr lang="fr-CA"/>
           </a:p>
@@ -2339,7 +2340,7 @@
           <a:p>
             <a:fld id="{05494588-57AE-4A88-AA7D-14590C8ABB1D}" type="datetime1">
               <a:rPr lang="fr-CA" smtClean="0"/>
-              <a:t>2026-04-08</a:t>
+              <a:t>2026-04-09</a:t>
             </a:fld>
             <a:endParaRPr lang="fr-CA"/>
           </a:p>
@@ -2452,7 +2453,7 @@
           <a:p>
             <a:fld id="{70596107-F84A-4D89-B7EE-30826EF0EE70}" type="datetime1">
               <a:rPr lang="fr-CA" smtClean="0"/>
-              <a:t>2026-04-08</a:t>
+              <a:t>2026-04-09</a:t>
             </a:fld>
             <a:endParaRPr lang="fr-CA"/>
           </a:p>
@@ -2765,7 +2766,7 @@
           <a:p>
             <a:fld id="{12C269CA-6797-4965-A975-3F40F12DAD06}" type="datetime1">
               <a:rPr lang="fr-CA" smtClean="0"/>
-              <a:t>2026-04-08</a:t>
+              <a:t>2026-04-09</a:t>
             </a:fld>
             <a:endParaRPr lang="fr-CA"/>
           </a:p>
@@ -3054,7 +3055,7 @@
           <a:p>
             <a:fld id="{3F5AE234-69D2-4522-AB7A-F911A65753A0}" type="datetime1">
               <a:rPr lang="fr-CA" smtClean="0"/>
-              <a:t>2026-04-08</a:t>
+              <a:t>2026-04-09</a:t>
             </a:fld>
             <a:endParaRPr lang="fr-CA"/>
           </a:p>
@@ -3297,7 +3298,7 @@
           <a:p>
             <a:fld id="{30546B8D-50B2-4CF7-ACAA-221A68F8C882}" type="datetime1">
               <a:rPr lang="fr-CA" smtClean="0"/>
-              <a:t>2026-04-08</a:t>
+              <a:t>2026-04-09</a:t>
             </a:fld>
             <a:endParaRPr lang="fr-CA"/>
           </a:p>
@@ -3976,7 +3977,7 @@
               <a:rPr lang="pt-BR" b="1" dirty="0">
                 <a:latin typeface="Consolas" panose="020B0609020204030204" pitchFamily="49" charset="0"/>
               </a:rPr>
-              <a:t>  print(racine_1, racine_2)</a:t>
+              <a:t>  print('r1 = ', racine_1, 'r2 = ', racine_2)</a:t>
             </a:r>
             <a:br>
               <a:rPr lang="pt-BR" b="1" dirty="0">
@@ -5201,7 +5202,7 @@
         <p:spPr>
           <a:xfrm>
             <a:off x="817930" y="2523966"/>
-            <a:ext cx="5278070" cy="2954655"/>
+            <a:ext cx="5278070" cy="2769989"/>
           </a:xfrm>
           <a:prstGeom prst="rect">
             <a:avLst/>
@@ -5263,18 +5264,7 @@
                 </a:solidFill>
                 <a:latin typeface="Consolas" panose="020B0609020204030204" pitchFamily="49" charset="0"/>
               </a:rPr>
-              <a:t>  Effectue la division entière entre dividende et </a:t>
-            </a:r>
-          </a:p>
-          <a:p>
-            <a:r>
-              <a:rPr lang="pt-BR" sz="1200" b="1" dirty="0">
-                <a:solidFill>
-                  <a:srgbClr val="C00000"/>
-                </a:solidFill>
-                <a:latin typeface="Consolas" panose="020B0609020204030204" pitchFamily="49" charset="0"/>
-              </a:rPr>
-              <a:t>  diviseur.</a:t>
+              <a:t>  Effectue la division entière entre deux entiers.</a:t>
             </a:r>
           </a:p>
           <a:p>
@@ -5356,7 +5346,7 @@
                 </a:solidFill>
                 <a:latin typeface="Consolas" panose="020B0609020204030204" pitchFamily="49" charset="0"/>
               </a:rPr>
-              <a:t>      - int: Le quotient de la division entière (//).</a:t>
+              <a:t>      - int: Le quotient de la division entière.</a:t>
             </a:r>
           </a:p>
           <a:p>
@@ -5367,7 +5357,7 @@
                 </a:solidFill>
                 <a:latin typeface="Consolas" panose="020B0609020204030204" pitchFamily="49" charset="0"/>
               </a:rPr>
-              <a:t>      - int: Le reste de la division entière (%).</a:t>
+              <a:t>      - int: Le reste de la division entière.</a:t>
             </a:r>
           </a:p>
           <a:p>
@@ -5404,7 +5394,9 @@
               </a:ext>
             </a:extLst>
           </p:cNvPr>
-          <p:cNvSpPr/>
+          <p:cNvSpPr>
+            <a:spLocks noGrp="1"/>
+          </p:cNvSpPr>
           <p:nvPr>
             <p:ph idx="1"/>
           </p:nvPr>
@@ -5802,6 +5794,536 @@
     <p:bg>
       <p:bgPr>
         <a:solidFill>
+          <a:schemeClr val="accent6">
+            <a:lumMod val="20000"/>
+            <a:lumOff val="80000"/>
+          </a:schemeClr>
+        </a:solidFill>
+        <a:effectLst/>
+      </p:bgPr>
+    </p:bg>
+    <p:spTree>
+      <p:nvGrpSpPr>
+        <p:cNvPr id="1" name="">
+          <a:extLst>
+            <a:ext uri="{FF2B5EF4-FFF2-40B4-BE49-F238E27FC236}">
+              <a16:creationId xmlns:a16="http://schemas.microsoft.com/office/drawing/2014/main" id="{091DC5C5-96B0-DFC0-C149-A1B2ED086C89}"/>
+            </a:ext>
+          </a:extLst>
+        </p:cNvPr>
+        <p:cNvGrpSpPr/>
+        <p:nvPr/>
+      </p:nvGrpSpPr>
+      <p:grpSpPr>
+        <a:xfrm>
+          <a:off x="0" y="0"/>
+          <a:ext cx="0" cy="0"/>
+          <a:chOff x="0" y="0"/>
+          <a:chExt cx="0" cy="0"/>
+        </a:xfrm>
+      </p:grpSpPr>
+      <p:sp>
+        <p:nvSpPr>
+          <p:cNvPr id="2" name="Title 1">
+            <a:extLst>
+              <a:ext uri="{FF2B5EF4-FFF2-40B4-BE49-F238E27FC236}">
+                <a16:creationId xmlns:a16="http://schemas.microsoft.com/office/drawing/2014/main" id="{F50A9400-3A0A-6097-5B0F-57FC5124E7D4}"/>
+              </a:ext>
+            </a:extLst>
+          </p:cNvPr>
+          <p:cNvSpPr>
+            <a:spLocks noGrp="1"/>
+          </p:cNvSpPr>
+          <p:nvPr>
+            <p:ph type="title"/>
+          </p:nvPr>
+        </p:nvSpPr>
+        <p:spPr/>
+        <p:txBody>
+          <a:bodyPr/>
+          <a:lstStyle/>
+          <a:p>
+            <a:r>
+              <a:rPr lang="en-US" dirty="0">
+                <a:latin typeface="Arial Rounded MT Bold" panose="020F0704030504030204" pitchFamily="34" charset="0"/>
+              </a:rPr>
+              <a:t>XR6 – Minimum et maximum</a:t>
+            </a:r>
+            <a:endParaRPr lang="fr-CA" dirty="0">
+              <a:latin typeface="Arial Rounded MT Bold" panose="020F0704030504030204" pitchFamily="34" charset="0"/>
+            </a:endParaRPr>
+          </a:p>
+        </p:txBody>
+      </p:sp>
+      <p:sp>
+        <p:nvSpPr>
+          <p:cNvPr id="3" name="Content Placeholder 2">
+            <a:extLst>
+              <a:ext uri="{FF2B5EF4-FFF2-40B4-BE49-F238E27FC236}">
+                <a16:creationId xmlns:a16="http://schemas.microsoft.com/office/drawing/2014/main" id="{55B708E1-836A-CDCA-0056-6EDA9E9CFD0C}"/>
+              </a:ext>
+            </a:extLst>
+          </p:cNvPr>
+          <p:cNvSpPr>
+            <a:spLocks noGrp="1"/>
+          </p:cNvSpPr>
+          <p:nvPr>
+            <p:ph idx="1"/>
+          </p:nvPr>
+        </p:nvSpPr>
+        <p:spPr/>
+        <p:txBody>
+          <a:bodyPr>
+            <a:normAutofit/>
+          </a:bodyPr>
+          <a:lstStyle/>
+          <a:p>
+            <a:pPr marL="0" indent="0" algn="just">
+              <a:lnSpc>
+                <a:spcPct val="114000"/>
+              </a:lnSpc>
+              <a:buNone/>
+            </a:pPr>
+            <a:r>
+              <a:rPr lang="en-US" sz="2000" dirty="0" err="1">
+                <a:latin typeface="Consolas" panose="020B0609020204030204" pitchFamily="49" charset="0"/>
+              </a:rPr>
+              <a:t>Implémentez</a:t>
+            </a:r>
+            <a:r>
+              <a:rPr lang="en-US" sz="2000" dirty="0">
+                <a:latin typeface="Consolas" panose="020B0609020204030204" pitchFamily="49" charset="0"/>
+              </a:rPr>
+              <a:t> </a:t>
+            </a:r>
+            <a:r>
+              <a:rPr lang="en-US" sz="2000" dirty="0" err="1">
+                <a:latin typeface="Consolas" panose="020B0609020204030204" pitchFamily="49" charset="0"/>
+              </a:rPr>
+              <a:t>une</a:t>
+            </a:r>
+            <a:r>
+              <a:rPr lang="en-US" sz="2000" dirty="0">
+                <a:latin typeface="Consolas" panose="020B0609020204030204" pitchFamily="49" charset="0"/>
+              </a:rPr>
+              <a:t> </a:t>
+            </a:r>
+            <a:r>
+              <a:rPr lang="en-US" sz="2000" dirty="0" err="1">
+                <a:latin typeface="Consolas" panose="020B0609020204030204" pitchFamily="49" charset="0"/>
+              </a:rPr>
+              <a:t>fonction</a:t>
+            </a:r>
+            <a:r>
+              <a:rPr lang="en-US" sz="2000" dirty="0">
+                <a:latin typeface="Consolas" panose="020B0609020204030204" pitchFamily="49" charset="0"/>
+              </a:rPr>
+              <a:t> </a:t>
+            </a:r>
+            <a:r>
+              <a:rPr lang="en-US" sz="2000" dirty="0" err="1">
+                <a:latin typeface="Consolas" panose="020B0609020204030204" pitchFamily="49" charset="0"/>
+              </a:rPr>
+              <a:t>nommée</a:t>
+            </a:r>
+            <a:r>
+              <a:rPr lang="en-US" sz="2000" dirty="0">
+                <a:latin typeface="Consolas" panose="020B0609020204030204" pitchFamily="49" charset="0"/>
+              </a:rPr>
+              <a:t> </a:t>
+            </a:r>
+            <a:r>
+              <a:rPr lang="en-US" sz="2000" b="1" dirty="0" err="1">
+                <a:latin typeface="Consolas" panose="020B0609020204030204" pitchFamily="49" charset="0"/>
+              </a:rPr>
+              <a:t>obtenir_min_max</a:t>
+            </a:r>
+            <a:r>
+              <a:rPr lang="en-US" sz="2000" dirty="0">
+                <a:latin typeface="Consolas" panose="020B0609020204030204" pitchFamily="49" charset="0"/>
+              </a:rPr>
+              <a:t> qui est </a:t>
+            </a:r>
+            <a:r>
+              <a:rPr lang="en-US" sz="2000" dirty="0" err="1">
+                <a:latin typeface="Consolas" panose="020B0609020204030204" pitchFamily="49" charset="0"/>
+              </a:rPr>
+              <a:t>appelée</a:t>
+            </a:r>
+            <a:r>
+              <a:rPr lang="en-US" sz="2000" dirty="0">
+                <a:latin typeface="Consolas" panose="020B0609020204030204" pitchFamily="49" charset="0"/>
+              </a:rPr>
+              <a:t> </a:t>
+            </a:r>
+            <a:r>
+              <a:rPr lang="en-CA" sz="2000" dirty="0">
+                <a:latin typeface="Consolas" panose="020B0609020204030204" pitchFamily="49" charset="0"/>
+              </a:rPr>
+              <a:t>à </a:t>
+            </a:r>
+            <a:r>
+              <a:rPr lang="en-CA" sz="2000" dirty="0" err="1">
+                <a:latin typeface="Consolas" panose="020B0609020204030204" pitchFamily="49" charset="0"/>
+              </a:rPr>
+              <a:t>l'intérieur</a:t>
+            </a:r>
+            <a:r>
+              <a:rPr lang="en-CA" sz="2000" dirty="0">
+                <a:latin typeface="Consolas" panose="020B0609020204030204" pitchFamily="49" charset="0"/>
+              </a:rPr>
+              <a:t> </a:t>
+            </a:r>
+            <a:r>
+              <a:rPr lang="en-CA" sz="2000" dirty="0" err="1">
+                <a:latin typeface="Consolas" panose="020B0609020204030204" pitchFamily="49" charset="0"/>
+              </a:rPr>
+              <a:t>d'une</a:t>
+            </a:r>
+            <a:r>
+              <a:rPr lang="en-CA" sz="2000" dirty="0">
+                <a:latin typeface="Consolas" panose="020B0609020204030204" pitchFamily="49" charset="0"/>
+              </a:rPr>
+              <a:t> </a:t>
+            </a:r>
+            <a:r>
+              <a:rPr lang="en-CA" sz="2000" dirty="0" err="1">
+                <a:latin typeface="Consolas" panose="020B0609020204030204" pitchFamily="49" charset="0"/>
+              </a:rPr>
+              <a:t>fonction</a:t>
+            </a:r>
+            <a:r>
+              <a:rPr lang="en-CA" sz="2000" dirty="0">
+                <a:latin typeface="Consolas" panose="020B0609020204030204" pitchFamily="49" charset="0"/>
+              </a:rPr>
+              <a:t> </a:t>
+            </a:r>
+            <a:r>
+              <a:rPr lang="en-CA" sz="2000" dirty="0" err="1">
+                <a:latin typeface="Consolas" panose="020B0609020204030204" pitchFamily="49" charset="0"/>
+              </a:rPr>
+              <a:t>nommée</a:t>
+            </a:r>
+            <a:r>
+              <a:rPr lang="en-CA" sz="2000" dirty="0">
+                <a:latin typeface="Consolas" panose="020B0609020204030204" pitchFamily="49" charset="0"/>
+              </a:rPr>
+              <a:t> </a:t>
+            </a:r>
+            <a:r>
+              <a:rPr lang="en-CA" sz="2000" b="1" dirty="0" err="1">
+                <a:latin typeface="Consolas" panose="020B0609020204030204" pitchFamily="49" charset="0"/>
+              </a:rPr>
+              <a:t>afficher_min_max</a:t>
+            </a:r>
+            <a:r>
+              <a:rPr lang="en-CA" sz="2000" dirty="0">
+                <a:latin typeface="Consolas" panose="020B0609020204030204" pitchFamily="49" charset="0"/>
+              </a:rPr>
+              <a:t> </a:t>
+            </a:r>
+            <a:r>
+              <a:rPr lang="en-CA" sz="2000" dirty="0" err="1">
+                <a:latin typeface="Consolas" panose="020B0609020204030204" pitchFamily="49" charset="0"/>
+              </a:rPr>
+              <a:t>dont</a:t>
+            </a:r>
+            <a:r>
+              <a:rPr lang="en-CA" sz="2000" dirty="0">
+                <a:latin typeface="Consolas" panose="020B0609020204030204" pitchFamily="49" charset="0"/>
+              </a:rPr>
+              <a:t> le </a:t>
+            </a:r>
+            <a:r>
+              <a:rPr lang="en-CA" sz="2000" dirty="0" err="1">
+                <a:latin typeface="Consolas" panose="020B0609020204030204" pitchFamily="49" charset="0"/>
+              </a:rPr>
+              <a:t>comportement</a:t>
+            </a:r>
+            <a:r>
+              <a:rPr lang="en-CA" sz="2000" dirty="0">
+                <a:latin typeface="Consolas" panose="020B0609020204030204" pitchFamily="49" charset="0"/>
+              </a:rPr>
+              <a:t> est le </a:t>
+            </a:r>
+            <a:r>
+              <a:rPr lang="en-CA" sz="2000" dirty="0" err="1">
+                <a:latin typeface="Consolas" panose="020B0609020204030204" pitchFamily="49" charset="0"/>
+              </a:rPr>
+              <a:t>suivant</a:t>
+            </a:r>
+            <a:r>
+              <a:rPr lang="en-CA" sz="2000" dirty="0">
+                <a:latin typeface="Consolas" panose="020B0609020204030204" pitchFamily="49" charset="0"/>
+              </a:rPr>
+              <a:t> :</a:t>
+            </a:r>
+            <a:endParaRPr lang="en-US" sz="2000" dirty="0">
+              <a:latin typeface="Consolas" panose="020B0609020204030204" pitchFamily="49" charset="0"/>
+            </a:endParaRPr>
+          </a:p>
+          <a:p>
+            <a:pPr marL="0" indent="0" algn="just">
+              <a:buNone/>
+            </a:pPr>
+            <a:endParaRPr lang="en-US" sz="100" b="1" dirty="0">
+              <a:latin typeface="Consolas" panose="020B0609020204030204" pitchFamily="49" charset="0"/>
+            </a:endParaRPr>
+          </a:p>
+          <a:p>
+            <a:pPr marL="457200" lvl="1" indent="0" algn="just">
+              <a:buNone/>
+            </a:pPr>
+            <a:r>
+              <a:rPr lang="en-CA" sz="2000" b="1" dirty="0">
+                <a:latin typeface="Consolas" panose="020B0609020204030204" pitchFamily="49" charset="0"/>
+              </a:rPr>
+              <a:t>&gt;&gt;&gt; </a:t>
+            </a:r>
+            <a:r>
+              <a:rPr lang="en-CA" sz="2000" b="1" dirty="0" err="1">
+                <a:latin typeface="Consolas" panose="020B0609020204030204" pitchFamily="49" charset="0"/>
+              </a:rPr>
+              <a:t>afficher_min_max</a:t>
+            </a:r>
+            <a:r>
+              <a:rPr lang="en-CA" sz="2000" b="1" dirty="0">
+                <a:latin typeface="Consolas" panose="020B0609020204030204" pitchFamily="49" charset="0"/>
+              </a:rPr>
+              <a:t>(10, 1)</a:t>
+            </a:r>
+          </a:p>
+          <a:p>
+            <a:pPr marL="457200" lvl="1" indent="0" algn="just">
+              <a:lnSpc>
+                <a:spcPct val="100000"/>
+              </a:lnSpc>
+              <a:buNone/>
+            </a:pPr>
+            <a:r>
+              <a:rPr lang="en-CA" sz="2000" dirty="0">
+                <a:solidFill>
+                  <a:schemeClr val="bg1">
+                    <a:lumMod val="50000"/>
+                  </a:schemeClr>
+                </a:solidFill>
+                <a:latin typeface="Consolas" panose="020B0609020204030204" pitchFamily="49" charset="0"/>
+              </a:rPr>
+              <a:t>Le minimum </a:t>
+            </a:r>
+            <a:r>
+              <a:rPr lang="en-CA" sz="2000" dirty="0" err="1">
+                <a:solidFill>
+                  <a:schemeClr val="bg1">
+                    <a:lumMod val="50000"/>
+                  </a:schemeClr>
+                </a:solidFill>
+                <a:latin typeface="Consolas" panose="020B0609020204030204" pitchFamily="49" charset="0"/>
+              </a:rPr>
+              <a:t>vaut</a:t>
+            </a:r>
+            <a:r>
+              <a:rPr lang="en-CA" sz="2000" dirty="0">
+                <a:solidFill>
+                  <a:schemeClr val="bg1">
+                    <a:lumMod val="50000"/>
+                  </a:schemeClr>
+                </a:solidFill>
+                <a:latin typeface="Consolas" panose="020B0609020204030204" pitchFamily="49" charset="0"/>
+              </a:rPr>
+              <a:t> 1</a:t>
+            </a:r>
+          </a:p>
+          <a:p>
+            <a:pPr marL="457200" lvl="1" indent="0" algn="just">
+              <a:lnSpc>
+                <a:spcPct val="100000"/>
+              </a:lnSpc>
+              <a:buNone/>
+            </a:pPr>
+            <a:r>
+              <a:rPr lang="en-CA" sz="2000" dirty="0">
+                <a:solidFill>
+                  <a:schemeClr val="bg1">
+                    <a:lumMod val="50000"/>
+                  </a:schemeClr>
+                </a:solidFill>
+                <a:latin typeface="Consolas" panose="020B0609020204030204" pitchFamily="49" charset="0"/>
+              </a:rPr>
+              <a:t>Le maximum </a:t>
+            </a:r>
+            <a:r>
+              <a:rPr lang="en-CA" sz="2000" dirty="0" err="1">
+                <a:solidFill>
+                  <a:schemeClr val="bg1">
+                    <a:lumMod val="50000"/>
+                  </a:schemeClr>
+                </a:solidFill>
+                <a:latin typeface="Consolas" panose="020B0609020204030204" pitchFamily="49" charset="0"/>
+              </a:rPr>
+              <a:t>vaut</a:t>
+            </a:r>
+            <a:r>
+              <a:rPr lang="en-CA" sz="2000" dirty="0">
+                <a:solidFill>
+                  <a:schemeClr val="bg1">
+                    <a:lumMod val="50000"/>
+                  </a:schemeClr>
+                </a:solidFill>
+                <a:latin typeface="Consolas" panose="020B0609020204030204" pitchFamily="49" charset="0"/>
+              </a:rPr>
+              <a:t> 10</a:t>
+            </a:r>
+            <a:endParaRPr lang="en-US" sz="2000" dirty="0">
+              <a:solidFill>
+                <a:schemeClr val="bg1">
+                  <a:lumMod val="50000"/>
+                </a:schemeClr>
+              </a:solidFill>
+              <a:latin typeface="Consolas" panose="020B0609020204030204" pitchFamily="49" charset="0"/>
+            </a:endParaRPr>
+          </a:p>
+          <a:p>
+            <a:pPr marL="0" indent="0" algn="just">
+              <a:buNone/>
+            </a:pPr>
+            <a:endParaRPr lang="en-US" sz="100" b="1" dirty="0">
+              <a:latin typeface="Consolas" panose="020B0609020204030204" pitchFamily="49" charset="0"/>
+            </a:endParaRPr>
+          </a:p>
+          <a:p>
+            <a:pPr marL="0" indent="0" algn="just">
+              <a:buNone/>
+            </a:pPr>
+            <a:r>
+              <a:rPr lang="en-US" sz="2000" b="1" dirty="0">
+                <a:latin typeface="Consolas" panose="020B0609020204030204" pitchFamily="49" charset="0"/>
+              </a:rPr>
+              <a:t>Remarque: </a:t>
+            </a:r>
+            <a:r>
+              <a:rPr lang="en-US" sz="2000" dirty="0" err="1">
+                <a:latin typeface="Consolas" panose="020B0609020204030204" pitchFamily="49" charset="0"/>
+              </a:rPr>
+              <a:t>Assumez</a:t>
+            </a:r>
+            <a:r>
+              <a:rPr lang="en-US" sz="2000" dirty="0">
+                <a:latin typeface="Consolas" panose="020B0609020204030204" pitchFamily="49" charset="0"/>
+              </a:rPr>
+              <a:t> </a:t>
+            </a:r>
+            <a:r>
+              <a:rPr lang="en-US" sz="2000" dirty="0" err="1">
+                <a:latin typeface="Consolas" panose="020B0609020204030204" pitchFamily="49" charset="0"/>
+              </a:rPr>
+              <a:t>que</a:t>
+            </a:r>
+            <a:r>
+              <a:rPr lang="en-US" sz="2000" dirty="0">
+                <a:latin typeface="Consolas" panose="020B0609020204030204" pitchFamily="49" charset="0"/>
+              </a:rPr>
+              <a:t> les </a:t>
+            </a:r>
+            <a:r>
+              <a:rPr lang="en-US" sz="2000" dirty="0" err="1">
+                <a:latin typeface="Consolas" panose="020B0609020204030204" pitchFamily="49" charset="0"/>
+              </a:rPr>
+              <a:t>valeurs</a:t>
+            </a:r>
+            <a:r>
+              <a:rPr lang="en-US" sz="2000" dirty="0">
+                <a:latin typeface="Consolas" panose="020B0609020204030204" pitchFamily="49" charset="0"/>
+              </a:rPr>
+              <a:t> </a:t>
+            </a:r>
+            <a:r>
+              <a:rPr lang="en-US" sz="2000" dirty="0" err="1">
+                <a:latin typeface="Consolas" panose="020B0609020204030204" pitchFamily="49" charset="0"/>
+              </a:rPr>
+              <a:t>fournies</a:t>
+            </a:r>
+            <a:r>
+              <a:rPr lang="en-US" sz="2000" dirty="0">
+                <a:latin typeface="Consolas" panose="020B0609020204030204" pitchFamily="49" charset="0"/>
+              </a:rPr>
+              <a:t> </a:t>
+            </a:r>
+            <a:r>
+              <a:rPr lang="en-US" sz="2000" dirty="0" err="1">
+                <a:latin typeface="Consolas" panose="020B0609020204030204" pitchFamily="49" charset="0"/>
+              </a:rPr>
+              <a:t>sont</a:t>
+            </a:r>
+            <a:r>
+              <a:rPr lang="en-US" sz="2000" dirty="0">
+                <a:latin typeface="Consolas" panose="020B0609020204030204" pitchFamily="49" charset="0"/>
+              </a:rPr>
+              <a:t> des </a:t>
+            </a:r>
+            <a:r>
+              <a:rPr lang="en-US" sz="2000" b="1" dirty="0" err="1">
+                <a:latin typeface="Consolas" panose="020B0609020204030204" pitchFamily="49" charset="0"/>
+              </a:rPr>
+              <a:t>entiers</a:t>
+            </a:r>
+            <a:r>
+              <a:rPr lang="en-US" sz="2000" dirty="0">
+                <a:latin typeface="Consolas" panose="020B0609020204030204" pitchFamily="49" charset="0"/>
+              </a:rPr>
+              <a:t>.</a:t>
+            </a:r>
+          </a:p>
+        </p:txBody>
+      </p:sp>
+      <p:sp>
+        <p:nvSpPr>
+          <p:cNvPr id="4" name="Slide Number Placeholder 3">
+            <a:extLst>
+              <a:ext uri="{FF2B5EF4-FFF2-40B4-BE49-F238E27FC236}">
+                <a16:creationId xmlns:a16="http://schemas.microsoft.com/office/drawing/2014/main" id="{21182E0C-4536-B899-7CAC-305374930944}"/>
+              </a:ext>
+            </a:extLst>
+          </p:cNvPr>
+          <p:cNvSpPr>
+            <a:spLocks noGrp="1"/>
+          </p:cNvSpPr>
+          <p:nvPr>
+            <p:ph type="sldNum" sz="quarter" idx="12"/>
+          </p:nvPr>
+        </p:nvSpPr>
+        <p:spPr/>
+        <p:txBody>
+          <a:bodyPr/>
+          <a:lstStyle/>
+          <a:p>
+            <a:fld id="{846B06B1-1179-491F-A487-8E0C403F7C13}" type="slidenum">
+              <a:rPr lang="fr-CA" smtClean="0"/>
+              <a:t>13</a:t>
+            </a:fld>
+            <a:endParaRPr lang="fr-CA"/>
+          </a:p>
+        </p:txBody>
+      </p:sp>
+    </p:spTree>
+    <p:extLst>
+      <p:ext uri="{BB962C8B-B14F-4D97-AF65-F5344CB8AC3E}">
+        <p14:creationId xmlns:p14="http://schemas.microsoft.com/office/powerpoint/2010/main" val="3428146133"/>
+      </p:ext>
+    </p:extLst>
+  </p:cSld>
+  <p:clrMapOvr>
+    <a:masterClrMapping/>
+  </p:clrMapOvr>
+</p:sld>
+</file>
+
+<file path=ppt/slides/slide14.xml><?xml version="1.0" encoding="utf-8"?>
+<p:sld xmlns:a="http://schemas.openxmlformats.org/drawingml/2006/main" xmlns:r="http://schemas.openxmlformats.org/officeDocument/2006/relationships" xmlns:p="http://schemas.openxmlformats.org/presentationml/2006/main">
+  <p:cSld>
+    <p:bg>
+      <p:bgPr>
+        <a:solidFill>
           <a:schemeClr val="bg1">
             <a:lumMod val="95000"/>
           </a:schemeClr>
@@ -5885,7 +6407,7 @@
           <a:p>
             <a:fld id="{846B06B1-1179-491F-A487-8E0C403F7C13}" type="slidenum">
               <a:rPr lang="fr-CA" smtClean="0"/>
-              <a:t>13</a:t>
+              <a:t>14</a:t>
             </a:fld>
             <a:endParaRPr lang="fr-CA"/>
           </a:p>
@@ -5970,7 +6492,7 @@
 </p:sld>
 </file>
 
-<file path=ppt/slides/slide14.xml><?xml version="1.0" encoding="utf-8"?>
+<file path=ppt/slides/slide15.xml><?xml version="1.0" encoding="utf-8"?>
 <p:sld xmlns:a="http://schemas.openxmlformats.org/drawingml/2006/main" xmlns:r="http://schemas.openxmlformats.org/officeDocument/2006/relationships" xmlns:p="http://schemas.openxmlformats.org/presentationml/2006/main">
   <p:cSld>
     <p:bg>
@@ -6089,7 +6611,7 @@
           <a:p>
             <a:fld id="{846B06B1-1179-491F-A487-8E0C403F7C13}" type="slidenum">
               <a:rPr lang="fr-CA" smtClean="0"/>
-              <a:t>14</a:t>
+              <a:t>15</a:t>
             </a:fld>
             <a:endParaRPr lang="fr-CA"/>
           </a:p>
@@ -6108,7 +6630,7 @@
 </p:sld>
 </file>
 
-<file path=ppt/slides/slide15.xml><?xml version="1.0" encoding="utf-8"?>
+<file path=ppt/slides/slide16.xml><?xml version="1.0" encoding="utf-8"?>
 <p:sld xmlns:a="http://schemas.openxmlformats.org/drawingml/2006/main" xmlns:r="http://schemas.openxmlformats.org/officeDocument/2006/relationships" xmlns:p="http://schemas.openxmlformats.org/presentationml/2006/main">
   <p:cSld>
     <p:spTree>
@@ -6277,7 +6799,7 @@
           <a:p>
             <a:fld id="{846B06B1-1179-491F-A487-8E0C403F7C13}" type="slidenum">
               <a:rPr lang="fr-CA" smtClean="0"/>
-              <a:t>15</a:t>
+              <a:t>16</a:t>
             </a:fld>
             <a:endParaRPr lang="fr-CA"/>
           </a:p>
@@ -11333,7 +11855,7 @@
               <a:rPr lang="pt-BR" sz="2600" b="1" dirty="0">
                 <a:latin typeface="Consolas" panose="020B0609020204030204" pitchFamily="49" charset="0"/>
               </a:rPr>
-              <a:t>print(r1, r2)</a:t>
+              <a:t>print('r1 = ', r1, 'r2 = ', r2)</a:t>
             </a:r>
             <a:endParaRPr lang="en-US" sz="2600" b="1" dirty="0">
               <a:latin typeface="Consolas" panose="020B0609020204030204" pitchFamily="49" charset="0"/>
@@ -11729,7 +12251,7 @@
               <a:rPr lang="pt-BR" b="1" dirty="0">
                 <a:latin typeface="Consolas" panose="020B0609020204030204" pitchFamily="49" charset="0"/>
               </a:rPr>
-              <a:t>  print(r1,r2)</a:t>
+              <a:t>  print('r1 = ', r1, 'r2 = ', r2)</a:t>
             </a:r>
             <a:br>
               <a:rPr lang="pt-BR" b="1" dirty="0">

</xml_diff>

<commit_message>
chore: Extend python_1 slide deck to slide no.14
</commit_message>
<xml_diff>
--- a/python_1/presentation_python_1.pptx
+++ b/python_1/presentation_python_1.pptx
@@ -5,7 +5,7 @@
     <p:sldMasterId id="2147483648" r:id="rId1"/>
   </p:sldMasterIdLst>
   <p:notesMasterIdLst>
-    <p:notesMasterId r:id="rId18"/>
+    <p:notesMasterId r:id="rId19"/>
   </p:notesMasterIdLst>
   <p:sldIdLst>
     <p:sldId id="256" r:id="rId2"/>
@@ -21,9 +21,10 @@
     <p:sldId id="269" r:id="rId12"/>
     <p:sldId id="271" r:id="rId13"/>
     <p:sldId id="272" r:id="rId14"/>
-    <p:sldId id="270" r:id="rId15"/>
-    <p:sldId id="267" r:id="rId16"/>
-    <p:sldId id="262" r:id="rId17"/>
+    <p:sldId id="273" r:id="rId15"/>
+    <p:sldId id="270" r:id="rId16"/>
+    <p:sldId id="267" r:id="rId17"/>
+    <p:sldId id="262" r:id="rId18"/>
   </p:sldIdLst>
   <p:sldSz cx="12192000" cy="6858000"/>
   <p:notesSz cx="6858000" cy="9144000"/>
@@ -5138,7 +5139,7 @@
               <a:rPr lang="en-US" dirty="0">
                 <a:latin typeface="Arial Rounded MT Bold" panose="020F0704030504030204" pitchFamily="34" charset="0"/>
               </a:rPr>
-              <a:t>Retours et tuples (</a:t>
+              <a:t>Retours et intro aux tuples (</a:t>
             </a:r>
             <a:r>
               <a:rPr lang="en-US" dirty="0">
@@ -6324,6 +6325,1732 @@
     <p:bg>
       <p:bgPr>
         <a:solidFill>
+          <a:srgbClr val="F5F5F5"/>
+        </a:solidFill>
+        <a:effectLst/>
+      </p:bgPr>
+    </p:bg>
+    <p:spTree>
+      <p:nvGrpSpPr>
+        <p:cNvPr id="1" name="">
+          <a:extLst>
+            <a:ext uri="{FF2B5EF4-FFF2-40B4-BE49-F238E27FC236}">
+              <a16:creationId xmlns:a16="http://schemas.microsoft.com/office/drawing/2014/main" id="{B1ECE0A8-C69A-F91E-D5FF-DF3E0F38ED81}"/>
+            </a:ext>
+          </a:extLst>
+        </p:cNvPr>
+        <p:cNvGrpSpPr/>
+        <p:nvPr/>
+      </p:nvGrpSpPr>
+      <p:grpSpPr>
+        <a:xfrm>
+          <a:off x="0" y="0"/>
+          <a:ext cx="0" cy="0"/>
+          <a:chOff x="0" y="0"/>
+          <a:chExt cx="0" cy="0"/>
+        </a:xfrm>
+      </p:grpSpPr>
+      <p:sp>
+        <p:nvSpPr>
+          <p:cNvPr id="2" name="Title 1">
+            <a:extLst>
+              <a:ext uri="{FF2B5EF4-FFF2-40B4-BE49-F238E27FC236}">
+                <a16:creationId xmlns:a16="http://schemas.microsoft.com/office/drawing/2014/main" id="{9D895B25-CFFF-163A-8DBB-80844E06534F}"/>
+              </a:ext>
+            </a:extLst>
+          </p:cNvPr>
+          <p:cNvSpPr>
+            <a:spLocks noGrp="1"/>
+          </p:cNvSpPr>
+          <p:nvPr>
+            <p:ph type="title"/>
+          </p:nvPr>
+        </p:nvSpPr>
+        <p:spPr/>
+        <p:txBody>
+          <a:bodyPr/>
+          <a:lstStyle/>
+          <a:p>
+            <a:r>
+              <a:rPr lang="en-US" dirty="0">
+                <a:latin typeface="Arial Rounded MT Bold" panose="020F0704030504030204" pitchFamily="34" charset="0"/>
+              </a:rPr>
+              <a:t>Les tuples (pour de </a:t>
+            </a:r>
+            <a:r>
+              <a:rPr lang="en-US" dirty="0" err="1">
+                <a:latin typeface="Arial Rounded MT Bold" panose="020F0704030504030204" pitchFamily="34" charset="0"/>
+              </a:rPr>
+              <a:t>vrai</a:t>
+            </a:r>
+            <a:r>
+              <a:rPr lang="en-US" dirty="0">
+                <a:latin typeface="Arial Rounded MT Bold" panose="020F0704030504030204" pitchFamily="34" charset="0"/>
+              </a:rPr>
+              <a:t>)</a:t>
+            </a:r>
+            <a:endParaRPr lang="fr-CA" dirty="0">
+              <a:latin typeface="Arial Rounded MT Bold" panose="020F0704030504030204" pitchFamily="34" charset="0"/>
+            </a:endParaRPr>
+          </a:p>
+        </p:txBody>
+      </p:sp>
+      <p:sp>
+        <p:nvSpPr>
+          <p:cNvPr id="3" name="Content Placeholder 2">
+            <a:extLst>
+              <a:ext uri="{FF2B5EF4-FFF2-40B4-BE49-F238E27FC236}">
+                <a16:creationId xmlns:a16="http://schemas.microsoft.com/office/drawing/2014/main" id="{C262F9B2-DD40-4C1F-D52B-F48B4CC87ECD}"/>
+              </a:ext>
+            </a:extLst>
+          </p:cNvPr>
+          <p:cNvSpPr>
+            <a:spLocks noGrp="1"/>
+          </p:cNvSpPr>
+          <p:nvPr>
+            <p:ph idx="1"/>
+          </p:nvPr>
+        </p:nvSpPr>
+        <p:spPr/>
+        <p:txBody>
+          <a:bodyPr>
+            <a:normAutofit fontScale="92500" lnSpcReduction="20000"/>
+          </a:bodyPr>
+          <a:lstStyle/>
+          <a:p>
+            <a:pPr algn="just"/>
+            <a:r>
+              <a:rPr lang="fr-CA" sz="2000" dirty="0">
+                <a:latin typeface="Consolas" panose="020B0609020204030204" pitchFamily="49" charset="0"/>
+              </a:rPr>
+              <a:t>Regroupement </a:t>
+            </a:r>
+            <a:r>
+              <a:rPr lang="fr-CA" sz="2000" b="1" dirty="0">
+                <a:latin typeface="Consolas" panose="020B0609020204030204" pitchFamily="49" charset="0"/>
+              </a:rPr>
+              <a:t>immuable</a:t>
+            </a:r>
+            <a:r>
+              <a:rPr lang="fr-CA" sz="2000" dirty="0">
+                <a:latin typeface="Consolas" panose="020B0609020204030204" pitchFamily="49" charset="0"/>
+              </a:rPr>
+              <a:t> de </a:t>
+            </a:r>
+            <a:r>
+              <a:rPr lang="fr-CA" sz="2000" b="1" dirty="0">
+                <a:latin typeface="Consolas" panose="020B0609020204030204" pitchFamily="49" charset="0"/>
+              </a:rPr>
+              <a:t>valeurs quelconques séparées par des virgules</a:t>
+            </a:r>
+          </a:p>
+          <a:p>
+            <a:pPr marL="0" indent="0" algn="just">
+              <a:buNone/>
+            </a:pPr>
+            <a:endParaRPr lang="fr-CA" sz="100" b="1" dirty="0">
+              <a:latin typeface="Consolas" panose="020B0609020204030204" pitchFamily="49" charset="0"/>
+            </a:endParaRPr>
+          </a:p>
+          <a:p>
+            <a:pPr marL="457200" lvl="1" indent="0" algn="just">
+              <a:lnSpc>
+                <a:spcPct val="100000"/>
+              </a:lnSpc>
+              <a:buNone/>
+            </a:pPr>
+            <a:r>
+              <a:rPr lang="fr-CA" sz="1800" b="1" dirty="0">
+                <a:latin typeface="Consolas" panose="020B0609020204030204" pitchFamily="49" charset="0"/>
+              </a:rPr>
+              <a:t>&gt;&gt;&gt; </a:t>
+            </a:r>
+            <a:r>
+              <a:rPr lang="fr-CA" sz="1800" b="1" dirty="0" err="1">
+                <a:latin typeface="Consolas" panose="020B0609020204030204" pitchFamily="49" charset="0"/>
+              </a:rPr>
+              <a:t>un_tuple</a:t>
+            </a:r>
+            <a:r>
+              <a:rPr lang="fr-CA" sz="1800" b="1" dirty="0">
+                <a:latin typeface="Consolas" panose="020B0609020204030204" pitchFamily="49" charset="0"/>
+              </a:rPr>
+              <a:t> = 17, 0, 5, </a:t>
+            </a:r>
+            <a:r>
+              <a:rPr lang="fr-CA" sz="1800" b="1" dirty="0" err="1">
+                <a:latin typeface="Consolas" panose="020B0609020204030204" pitchFamily="49" charset="0"/>
+              </a:rPr>
+              <a:t>True</a:t>
+            </a:r>
+            <a:endParaRPr lang="fr-CA" sz="1800" b="1" dirty="0">
+              <a:latin typeface="Consolas" panose="020B0609020204030204" pitchFamily="49" charset="0"/>
+            </a:endParaRPr>
+          </a:p>
+          <a:p>
+            <a:pPr marL="457200" lvl="1" indent="0" algn="just">
+              <a:lnSpc>
+                <a:spcPct val="100000"/>
+              </a:lnSpc>
+              <a:buNone/>
+            </a:pPr>
+            <a:r>
+              <a:rPr lang="fr-CA" sz="1800" b="1" dirty="0">
+                <a:latin typeface="Consolas" panose="020B0609020204030204" pitchFamily="49" charset="0"/>
+              </a:rPr>
+              <a:t>&gt;&gt;&gt; </a:t>
+            </a:r>
+            <a:r>
+              <a:rPr lang="fr-CA" sz="1800" b="1" dirty="0" err="1">
+                <a:latin typeface="Consolas" panose="020B0609020204030204" pitchFamily="49" charset="0"/>
+              </a:rPr>
+              <a:t>print</a:t>
+            </a:r>
+            <a:r>
+              <a:rPr lang="fr-CA" sz="1800" b="1" dirty="0">
+                <a:latin typeface="Consolas" panose="020B0609020204030204" pitchFamily="49" charset="0"/>
+              </a:rPr>
+              <a:t>(type(</a:t>
+            </a:r>
+            <a:r>
+              <a:rPr lang="fr-CA" sz="1800" b="1" dirty="0" err="1">
+                <a:latin typeface="Consolas" panose="020B0609020204030204" pitchFamily="49" charset="0"/>
+              </a:rPr>
+              <a:t>un_tuple</a:t>
+            </a:r>
+            <a:r>
+              <a:rPr lang="fr-CA" sz="1800" b="1" dirty="0">
+                <a:latin typeface="Consolas" panose="020B0609020204030204" pitchFamily="49" charset="0"/>
+              </a:rPr>
+              <a:t>))</a:t>
+            </a:r>
+          </a:p>
+          <a:p>
+            <a:pPr marL="457200" lvl="1" indent="0" algn="just">
+              <a:lnSpc>
+                <a:spcPct val="100000"/>
+              </a:lnSpc>
+              <a:buNone/>
+            </a:pPr>
+            <a:r>
+              <a:rPr lang="en-US" sz="1800" dirty="0">
+                <a:solidFill>
+                  <a:schemeClr val="bg1">
+                    <a:lumMod val="50000"/>
+                  </a:schemeClr>
+                </a:solidFill>
+                <a:latin typeface="Consolas" panose="020B0609020204030204" pitchFamily="49" charset="0"/>
+              </a:rPr>
+              <a:t>&lt;class 'tuple'&gt;</a:t>
+            </a:r>
+          </a:p>
+          <a:p>
+            <a:pPr marL="457200" lvl="1" indent="0" algn="just">
+              <a:lnSpc>
+                <a:spcPct val="100000"/>
+              </a:lnSpc>
+              <a:buNone/>
+            </a:pPr>
+            <a:endParaRPr lang="fr-CA" sz="1800" dirty="0">
+              <a:latin typeface="Consolas" panose="020B0609020204030204" pitchFamily="49" charset="0"/>
+            </a:endParaRPr>
+          </a:p>
+          <a:p>
+            <a:pPr marL="457200" lvl="1" indent="0" algn="just">
+              <a:lnSpc>
+                <a:spcPct val="100000"/>
+              </a:lnSpc>
+              <a:buNone/>
+            </a:pPr>
+            <a:r>
+              <a:rPr lang="fr-CA" sz="1800" b="1" dirty="0">
+                <a:latin typeface="Consolas" panose="020B0609020204030204" pitchFamily="49" charset="0"/>
+              </a:rPr>
+              <a:t>&gt;&gt;&gt; </a:t>
+            </a:r>
+            <a:r>
+              <a:rPr lang="fr-CA" sz="1800" b="1" dirty="0" err="1">
+                <a:latin typeface="Consolas" panose="020B0609020204030204" pitchFamily="49" charset="0"/>
+              </a:rPr>
+              <a:t>un_autre_tuple</a:t>
+            </a:r>
+            <a:r>
+              <a:rPr lang="fr-CA" sz="1800" b="1" dirty="0">
+                <a:latin typeface="Consolas" panose="020B0609020204030204" pitchFamily="49" charset="0"/>
+              </a:rPr>
+              <a:t> = (17, 0, 5, </a:t>
+            </a:r>
+            <a:r>
+              <a:rPr lang="fr-CA" sz="1800" b="1" dirty="0" err="1">
+                <a:latin typeface="Consolas" panose="020B0609020204030204" pitchFamily="49" charset="0"/>
+              </a:rPr>
+              <a:t>True</a:t>
+            </a:r>
+            <a:r>
+              <a:rPr lang="fr-CA" sz="1800" b="1" dirty="0">
+                <a:latin typeface="Consolas" panose="020B0609020204030204" pitchFamily="49" charset="0"/>
+              </a:rPr>
+              <a:t>)</a:t>
+            </a:r>
+            <a:endParaRPr lang="fr-CA" sz="1800" b="1" i="1" dirty="0">
+              <a:solidFill>
+                <a:schemeClr val="accent6"/>
+              </a:solidFill>
+              <a:latin typeface="Consolas" panose="020B0609020204030204" pitchFamily="49" charset="0"/>
+            </a:endParaRPr>
+          </a:p>
+          <a:p>
+            <a:pPr marL="457200" lvl="1" indent="0" algn="just">
+              <a:lnSpc>
+                <a:spcPct val="100000"/>
+              </a:lnSpc>
+              <a:buNone/>
+            </a:pPr>
+            <a:r>
+              <a:rPr lang="fr-CA" sz="1800" b="1" dirty="0">
+                <a:latin typeface="Consolas" panose="020B0609020204030204" pitchFamily="49" charset="0"/>
+              </a:rPr>
+              <a:t>&gt;&gt;&gt; </a:t>
+            </a:r>
+            <a:r>
+              <a:rPr lang="fr-CA" sz="1800" b="1" dirty="0" err="1">
+                <a:latin typeface="Consolas" panose="020B0609020204030204" pitchFamily="49" charset="0"/>
+              </a:rPr>
+              <a:t>print</a:t>
+            </a:r>
+            <a:r>
+              <a:rPr lang="fr-CA" sz="1800" b="1" dirty="0">
+                <a:latin typeface="Consolas" panose="020B0609020204030204" pitchFamily="49" charset="0"/>
+              </a:rPr>
+              <a:t>(type(</a:t>
+            </a:r>
+            <a:r>
+              <a:rPr lang="fr-CA" sz="1800" b="1" dirty="0" err="1">
+                <a:latin typeface="Consolas" panose="020B0609020204030204" pitchFamily="49" charset="0"/>
+              </a:rPr>
+              <a:t>un_autre_tuple</a:t>
+            </a:r>
+            <a:r>
+              <a:rPr lang="fr-CA" sz="1800" b="1" dirty="0">
+                <a:latin typeface="Consolas" panose="020B0609020204030204" pitchFamily="49" charset="0"/>
+              </a:rPr>
+              <a:t>))</a:t>
+            </a:r>
+          </a:p>
+          <a:p>
+            <a:pPr marL="457200" lvl="1" indent="0" algn="just">
+              <a:lnSpc>
+                <a:spcPct val="100000"/>
+              </a:lnSpc>
+              <a:buNone/>
+            </a:pPr>
+            <a:r>
+              <a:rPr lang="en-US" sz="1800" dirty="0">
+                <a:solidFill>
+                  <a:schemeClr val="bg1">
+                    <a:lumMod val="50000"/>
+                  </a:schemeClr>
+                </a:solidFill>
+                <a:latin typeface="Consolas" panose="020B0609020204030204" pitchFamily="49" charset="0"/>
+              </a:rPr>
+              <a:t>&lt;class 'tuple'&gt;</a:t>
+            </a:r>
+          </a:p>
+          <a:p>
+            <a:pPr marL="457200" lvl="1" indent="0" algn="just">
+              <a:lnSpc>
+                <a:spcPct val="100000"/>
+              </a:lnSpc>
+              <a:buNone/>
+            </a:pPr>
+            <a:endParaRPr lang="en-US" sz="1800" dirty="0">
+              <a:solidFill>
+                <a:schemeClr val="bg1">
+                  <a:lumMod val="50000"/>
+                </a:schemeClr>
+              </a:solidFill>
+              <a:latin typeface="Consolas" panose="020B0609020204030204" pitchFamily="49" charset="0"/>
+            </a:endParaRPr>
+          </a:p>
+          <a:p>
+            <a:pPr marL="457200" lvl="1" indent="0" algn="just">
+              <a:lnSpc>
+                <a:spcPct val="100000"/>
+              </a:lnSpc>
+              <a:buNone/>
+            </a:pPr>
+            <a:r>
+              <a:rPr lang="fr-CA" sz="1800" b="1" dirty="0">
+                <a:latin typeface="Consolas" panose="020B0609020204030204" pitchFamily="49" charset="0"/>
+              </a:rPr>
+              <a:t>&gt;&gt;&gt; </a:t>
+            </a:r>
+            <a:r>
+              <a:rPr lang="fr-CA" sz="1800" b="1" dirty="0" err="1">
+                <a:latin typeface="Consolas" panose="020B0609020204030204" pitchFamily="49" charset="0"/>
+              </a:rPr>
+              <a:t>un_tuple</a:t>
+            </a:r>
+            <a:r>
+              <a:rPr lang="fr-CA" sz="1800" b="1" dirty="0">
+                <a:latin typeface="Consolas" panose="020B0609020204030204" pitchFamily="49" charset="0"/>
+              </a:rPr>
+              <a:t> == </a:t>
+            </a:r>
+            <a:r>
+              <a:rPr lang="fr-CA" sz="1800" b="1" dirty="0" err="1">
+                <a:latin typeface="Consolas" panose="020B0609020204030204" pitchFamily="49" charset="0"/>
+              </a:rPr>
+              <a:t>un_autre_tuple</a:t>
+            </a:r>
+            <a:endParaRPr lang="fr-CA" sz="1800" b="1" dirty="0">
+              <a:latin typeface="Consolas" panose="020B0609020204030204" pitchFamily="49" charset="0"/>
+            </a:endParaRPr>
+          </a:p>
+          <a:p>
+            <a:pPr marL="457200" lvl="1" indent="0" algn="just">
+              <a:lnSpc>
+                <a:spcPct val="100000"/>
+              </a:lnSpc>
+              <a:buNone/>
+            </a:pPr>
+            <a:r>
+              <a:rPr lang="fr-CA" sz="1800" dirty="0" err="1">
+                <a:solidFill>
+                  <a:schemeClr val="bg1">
+                    <a:lumMod val="50000"/>
+                  </a:schemeClr>
+                </a:solidFill>
+                <a:latin typeface="Consolas" panose="020B0609020204030204" pitchFamily="49" charset="0"/>
+              </a:rPr>
+              <a:t>True</a:t>
+            </a:r>
+            <a:endParaRPr lang="en-US" sz="1800" dirty="0">
+              <a:solidFill>
+                <a:schemeClr val="bg1">
+                  <a:lumMod val="50000"/>
+                </a:schemeClr>
+              </a:solidFill>
+              <a:latin typeface="Consolas" panose="020B0609020204030204" pitchFamily="49" charset="0"/>
+            </a:endParaRPr>
+          </a:p>
+          <a:p>
+            <a:pPr marL="457200" lvl="1" indent="0" algn="just">
+              <a:buNone/>
+            </a:pPr>
+            <a:endParaRPr lang="en-US" sz="100" b="1" dirty="0">
+              <a:latin typeface="Consolas" panose="020B0609020204030204" pitchFamily="49" charset="0"/>
+            </a:endParaRPr>
+          </a:p>
+          <a:p>
+            <a:pPr algn="just"/>
+            <a:r>
+              <a:rPr lang="fr-CA" sz="2000" dirty="0">
+                <a:latin typeface="Consolas" panose="020B0609020204030204" pitchFamily="49" charset="0"/>
+              </a:rPr>
+              <a:t>Positions d</a:t>
+            </a:r>
+            <a:r>
+              <a:rPr lang="en-US" sz="2000" dirty="0" err="1">
+                <a:latin typeface="Consolas" panose="020B0609020204030204" pitchFamily="49" charset="0"/>
+              </a:rPr>
+              <a:t>ésignées</a:t>
+            </a:r>
+            <a:r>
+              <a:rPr lang="fr-CA" sz="2000" dirty="0">
+                <a:latin typeface="Consolas" panose="020B0609020204030204" pitchFamily="49" charset="0"/>
+              </a:rPr>
+              <a:t> par des </a:t>
+            </a:r>
+            <a:r>
+              <a:rPr lang="fr-CA" sz="2000" b="1" dirty="0">
+                <a:latin typeface="Consolas" panose="020B0609020204030204" pitchFamily="49" charset="0"/>
+              </a:rPr>
+              <a:t>entiers consécutifs</a:t>
+            </a:r>
+            <a:r>
+              <a:rPr lang="fr-CA" sz="2000" dirty="0">
+                <a:latin typeface="Consolas" panose="020B0609020204030204" pitchFamily="49" charset="0"/>
+              </a:rPr>
+              <a:t> </a:t>
+            </a:r>
+            <a:r>
+              <a:rPr lang="fr-CA" sz="2000" b="1" dirty="0">
+                <a:latin typeface="Consolas" panose="020B0609020204030204" pitchFamily="49" charset="0"/>
+              </a:rPr>
+              <a:t>commençant à zéro:</a:t>
+            </a:r>
+          </a:p>
+          <a:p>
+            <a:pPr marL="457200" lvl="1" indent="0" algn="just">
+              <a:buNone/>
+            </a:pPr>
+            <a:endParaRPr lang="fr-CA" sz="100" b="1" dirty="0">
+              <a:latin typeface="Consolas" panose="020B0609020204030204" pitchFamily="49" charset="0"/>
+            </a:endParaRPr>
+          </a:p>
+          <a:p>
+            <a:pPr marL="457200" lvl="1" indent="0" algn="just">
+              <a:lnSpc>
+                <a:spcPct val="100000"/>
+              </a:lnSpc>
+              <a:buNone/>
+            </a:pPr>
+            <a:r>
+              <a:rPr lang="fr-CA" sz="1800" b="1" dirty="0">
+                <a:latin typeface="Consolas" panose="020B0609020204030204" pitchFamily="49" charset="0"/>
+              </a:rPr>
+              <a:t>&gt;&gt;&gt; </a:t>
+            </a:r>
+            <a:r>
+              <a:rPr lang="fr-CA" sz="1800" b="1" dirty="0" err="1">
+                <a:latin typeface="Consolas" panose="020B0609020204030204" pitchFamily="49" charset="0"/>
+              </a:rPr>
+              <a:t>print</a:t>
+            </a:r>
+            <a:r>
+              <a:rPr lang="fr-CA" sz="1800" b="1" dirty="0">
+                <a:latin typeface="Consolas" panose="020B0609020204030204" pitchFamily="49" charset="0"/>
+              </a:rPr>
+              <a:t>(</a:t>
+            </a:r>
+            <a:r>
+              <a:rPr lang="fr-CA" sz="1800" b="1" dirty="0" err="1">
+                <a:latin typeface="Consolas" panose="020B0609020204030204" pitchFamily="49" charset="0"/>
+              </a:rPr>
+              <a:t>un_tuple</a:t>
+            </a:r>
+            <a:r>
+              <a:rPr lang="fr-CA" sz="1800" b="1" dirty="0">
+                <a:latin typeface="Consolas" panose="020B0609020204030204" pitchFamily="49" charset="0"/>
+              </a:rPr>
+              <a:t>[2])</a:t>
+            </a:r>
+          </a:p>
+          <a:p>
+            <a:pPr marL="457200" lvl="2" indent="0" algn="just">
+              <a:lnSpc>
+                <a:spcPct val="80000"/>
+              </a:lnSpc>
+              <a:spcBef>
+                <a:spcPts val="1000"/>
+              </a:spcBef>
+              <a:buNone/>
+            </a:pPr>
+            <a:r>
+              <a:rPr lang="fr-CA" sz="1800" dirty="0">
+                <a:solidFill>
+                  <a:schemeClr val="bg1">
+                    <a:lumMod val="50000"/>
+                  </a:schemeClr>
+                </a:solidFill>
+                <a:latin typeface="Consolas" panose="020B0609020204030204" pitchFamily="49" charset="0"/>
+              </a:rPr>
+              <a:t>5</a:t>
+            </a:r>
+          </a:p>
+        </p:txBody>
+      </p:sp>
+      <p:sp>
+        <p:nvSpPr>
+          <p:cNvPr id="5" name="Slide Number Placeholder 4">
+            <a:extLst>
+              <a:ext uri="{FF2B5EF4-FFF2-40B4-BE49-F238E27FC236}">
+                <a16:creationId xmlns:a16="http://schemas.microsoft.com/office/drawing/2014/main" id="{31C405A5-9A40-D21D-A95E-4B60717C4380}"/>
+              </a:ext>
+            </a:extLst>
+          </p:cNvPr>
+          <p:cNvSpPr>
+            <a:spLocks noGrp="1"/>
+          </p:cNvSpPr>
+          <p:nvPr>
+            <p:ph type="sldNum" sz="quarter" idx="12"/>
+          </p:nvPr>
+        </p:nvSpPr>
+        <p:spPr/>
+        <p:txBody>
+          <a:bodyPr/>
+          <a:lstStyle/>
+          <a:p>
+            <a:fld id="{846B06B1-1179-491F-A487-8E0C403F7C13}" type="slidenum">
+              <a:rPr lang="fr-CA" smtClean="0"/>
+              <a:t>14</a:t>
+            </a:fld>
+            <a:endParaRPr lang="fr-CA"/>
+          </a:p>
+        </p:txBody>
+      </p:sp>
+      <p:grpSp>
+        <p:nvGrpSpPr>
+          <p:cNvPr id="8" name="Group 7">
+            <a:extLst>
+              <a:ext uri="{FF2B5EF4-FFF2-40B4-BE49-F238E27FC236}">
+                <a16:creationId xmlns:a16="http://schemas.microsoft.com/office/drawing/2014/main" id="{EEC674CA-7C74-7C64-F9CD-34EC7119EB61}"/>
+              </a:ext>
+            </a:extLst>
+          </p:cNvPr>
+          <p:cNvGrpSpPr/>
+          <p:nvPr/>
+        </p:nvGrpSpPr>
+        <p:grpSpPr>
+          <a:xfrm>
+            <a:off x="5172593" y="4353110"/>
+            <a:ext cx="4092107" cy="369332"/>
+            <a:chOff x="6485106" y="4913563"/>
+            <a:chExt cx="4092107" cy="369332"/>
+          </a:xfrm>
+        </p:grpSpPr>
+        <p:sp>
+          <p:nvSpPr>
+            <p:cNvPr id="9" name="TextBox 8">
+              <a:extLst>
+                <a:ext uri="{FF2B5EF4-FFF2-40B4-BE49-F238E27FC236}">
+                  <a16:creationId xmlns:a16="http://schemas.microsoft.com/office/drawing/2014/main" id="{51BBA235-7013-6811-8A0B-42BCB8053F38}"/>
+                </a:ext>
+              </a:extLst>
+            </p:cNvPr>
+            <p:cNvSpPr txBox="1"/>
+            <p:nvPr/>
+          </p:nvSpPr>
+          <p:spPr>
+            <a:xfrm>
+              <a:off x="7309395" y="4913563"/>
+              <a:ext cx="3267818" cy="369332"/>
+            </a:xfrm>
+            <a:prstGeom prst="rect">
+              <a:avLst/>
+            </a:prstGeom>
+            <a:noFill/>
+          </p:spPr>
+          <p:txBody>
+            <a:bodyPr wrap="none" rtlCol="0">
+              <a:spAutoFit/>
+            </a:bodyPr>
+            <a:lstStyle/>
+            <a:p>
+              <a:r>
+                <a:rPr lang="en-US" sz="1700" b="1" dirty="0" err="1">
+                  <a:solidFill>
+                    <a:srgbClr val="FF2500"/>
+                  </a:solidFill>
+                </a:rPr>
+                <a:t>Opérateur</a:t>
+              </a:r>
+              <a:r>
+                <a:rPr lang="en-US" sz="1700" b="1" dirty="0">
+                  <a:solidFill>
+                    <a:srgbClr val="FF2500"/>
+                  </a:solidFill>
+                </a:rPr>
+                <a:t> de </a:t>
+              </a:r>
+              <a:r>
+                <a:rPr lang="en-US" sz="1700" b="1" dirty="0" err="1">
+                  <a:solidFill>
+                    <a:srgbClr val="FF2500"/>
+                  </a:solidFill>
+                </a:rPr>
+                <a:t>comparaison</a:t>
+              </a:r>
+              <a:r>
+                <a:rPr lang="en-US" sz="1700" b="1" dirty="0">
+                  <a:solidFill>
+                    <a:srgbClr val="FF2500"/>
+                  </a:solidFill>
+                </a:rPr>
+                <a:t> </a:t>
+              </a:r>
+              <a:r>
+                <a:rPr lang="en-US" b="1" dirty="0"/>
+                <a:t>(</a:t>
+              </a:r>
+              <a:r>
+                <a:rPr lang="en-US" b="1" dirty="0">
+                  <a:latin typeface="Consolas" panose="020B0609020204030204" pitchFamily="49" charset="0"/>
+                </a:rPr>
+                <a:t>==</a:t>
+              </a:r>
+              <a:r>
+                <a:rPr lang="en-US" b="1" dirty="0"/>
+                <a:t>)</a:t>
+              </a:r>
+              <a:endParaRPr lang="fr-CA" b="1" dirty="0">
+                <a:latin typeface="Consolas" panose="020B0609020204030204" pitchFamily="49" charset="0"/>
+              </a:endParaRPr>
+            </a:p>
+          </p:txBody>
+        </p:sp>
+        <p:cxnSp>
+          <p:nvCxnSpPr>
+            <p:cNvPr id="10" name="Straight Arrow Connector 9">
+              <a:extLst>
+                <a:ext uri="{FF2B5EF4-FFF2-40B4-BE49-F238E27FC236}">
+                  <a16:creationId xmlns:a16="http://schemas.microsoft.com/office/drawing/2014/main" id="{995F480B-256B-6627-3F72-CCB840E347F2}"/>
+                </a:ext>
+              </a:extLst>
+            </p:cNvPr>
+            <p:cNvCxnSpPr>
+              <a:cxnSpLocks/>
+            </p:cNvCxnSpPr>
+            <p:nvPr/>
+          </p:nvCxnSpPr>
+          <p:spPr>
+            <a:xfrm flipH="1">
+              <a:off x="6485106" y="5098230"/>
+              <a:ext cx="810000" cy="0"/>
+            </a:xfrm>
+            <a:prstGeom prst="straightConnector1">
+              <a:avLst/>
+            </a:prstGeom>
+            <a:ln>
+              <a:tailEnd type="triangle"/>
+            </a:ln>
+          </p:spPr>
+          <p:style>
+            <a:lnRef idx="2">
+              <a:schemeClr val="dk1"/>
+            </a:lnRef>
+            <a:fillRef idx="0">
+              <a:schemeClr val="dk1"/>
+            </a:fillRef>
+            <a:effectRef idx="1">
+              <a:schemeClr val="dk1"/>
+            </a:effectRef>
+            <a:fontRef idx="minor">
+              <a:schemeClr val="tx1"/>
+            </a:fontRef>
+          </p:style>
+        </p:cxnSp>
+      </p:grpSp>
+      <p:grpSp>
+        <p:nvGrpSpPr>
+          <p:cNvPr id="11" name="Group 10">
+            <a:extLst>
+              <a:ext uri="{FF2B5EF4-FFF2-40B4-BE49-F238E27FC236}">
+                <a16:creationId xmlns:a16="http://schemas.microsoft.com/office/drawing/2014/main" id="{C8FE2BBC-FBAE-79B5-8470-D8A8F94B9D82}"/>
+              </a:ext>
+            </a:extLst>
+          </p:cNvPr>
+          <p:cNvGrpSpPr/>
+          <p:nvPr/>
+        </p:nvGrpSpPr>
+        <p:grpSpPr>
+          <a:xfrm>
+            <a:off x="1694078" y="5717018"/>
+            <a:ext cx="3985578" cy="639332"/>
+            <a:chOff x="7111661" y="4643563"/>
+            <a:chExt cx="3985578" cy="639332"/>
+          </a:xfrm>
+        </p:grpSpPr>
+        <p:sp>
+          <p:nvSpPr>
+            <p:cNvPr id="12" name="TextBox 11">
+              <a:extLst>
+                <a:ext uri="{FF2B5EF4-FFF2-40B4-BE49-F238E27FC236}">
+                  <a16:creationId xmlns:a16="http://schemas.microsoft.com/office/drawing/2014/main" id="{06F969EB-123E-1EA2-4DF8-6702DD01BCCF}"/>
+                </a:ext>
+              </a:extLst>
+            </p:cNvPr>
+            <p:cNvSpPr txBox="1"/>
+            <p:nvPr/>
+          </p:nvSpPr>
+          <p:spPr>
+            <a:xfrm>
+              <a:off x="7111661" y="4913563"/>
+              <a:ext cx="3985578" cy="369332"/>
+            </a:xfrm>
+            <a:prstGeom prst="rect">
+              <a:avLst/>
+            </a:prstGeom>
+            <a:noFill/>
+          </p:spPr>
+          <p:txBody>
+            <a:bodyPr wrap="none" rtlCol="0">
+              <a:spAutoFit/>
+            </a:bodyPr>
+            <a:lstStyle/>
+            <a:p>
+              <a:r>
+                <a:rPr lang="en-US" sz="1700" b="1" dirty="0" err="1">
+                  <a:solidFill>
+                    <a:srgbClr val="FF2500"/>
+                  </a:solidFill>
+                </a:rPr>
+                <a:t>Opérateur</a:t>
+              </a:r>
+              <a:r>
+                <a:rPr lang="en-US" sz="1700" b="1" dirty="0">
+                  <a:solidFill>
+                    <a:srgbClr val="FF2500"/>
+                  </a:solidFill>
+                </a:rPr>
+                <a:t> </a:t>
+              </a:r>
+              <a:r>
+                <a:rPr lang="en-US" sz="1700" b="1" dirty="0" err="1">
+                  <a:solidFill>
+                    <a:srgbClr val="FF2500"/>
+                  </a:solidFill>
+                </a:rPr>
+                <a:t>d'accès</a:t>
+              </a:r>
+              <a:r>
+                <a:rPr lang="en-US" sz="1700" b="1" dirty="0">
+                  <a:solidFill>
+                    <a:srgbClr val="FF2500"/>
+                  </a:solidFill>
+                </a:rPr>
+                <a:t> </a:t>
+              </a:r>
+              <a:r>
+                <a:rPr lang="en-US" b="1" dirty="0"/>
+                <a:t>par indexation (</a:t>
+              </a:r>
+              <a:r>
+                <a:rPr lang="en-CA" b="1" dirty="0">
+                  <a:latin typeface="Consolas" panose="020B0609020204030204" pitchFamily="49" charset="0"/>
+                </a:rPr>
+                <a:t>[]</a:t>
+              </a:r>
+              <a:r>
+                <a:rPr lang="en-US" b="1" dirty="0"/>
+                <a:t>)</a:t>
+              </a:r>
+              <a:endParaRPr lang="fr-CA" b="1" dirty="0">
+                <a:latin typeface="Consolas" panose="020B0609020204030204" pitchFamily="49" charset="0"/>
+              </a:endParaRPr>
+            </a:p>
+          </p:txBody>
+        </p:sp>
+        <p:cxnSp>
+          <p:nvCxnSpPr>
+            <p:cNvPr id="13" name="Straight Arrow Connector 12">
+              <a:extLst>
+                <a:ext uri="{FF2B5EF4-FFF2-40B4-BE49-F238E27FC236}">
+                  <a16:creationId xmlns:a16="http://schemas.microsoft.com/office/drawing/2014/main" id="{BD64C109-715F-0048-2D2F-4F5DF5D8798C}"/>
+                </a:ext>
+              </a:extLst>
+            </p:cNvPr>
+            <p:cNvCxnSpPr>
+              <a:cxnSpLocks/>
+            </p:cNvCxnSpPr>
+            <p:nvPr/>
+          </p:nvCxnSpPr>
+          <p:spPr>
+            <a:xfrm flipV="1">
+              <a:off x="9104450" y="4643563"/>
+              <a:ext cx="0" cy="270000"/>
+            </a:xfrm>
+            <a:prstGeom prst="straightConnector1">
+              <a:avLst/>
+            </a:prstGeom>
+            <a:ln>
+              <a:tailEnd type="triangle"/>
+            </a:ln>
+          </p:spPr>
+          <p:style>
+            <a:lnRef idx="2">
+              <a:schemeClr val="dk1"/>
+            </a:lnRef>
+            <a:fillRef idx="0">
+              <a:schemeClr val="dk1"/>
+            </a:fillRef>
+            <a:effectRef idx="1">
+              <a:schemeClr val="dk1"/>
+            </a:effectRef>
+            <a:fontRef idx="minor">
+              <a:schemeClr val="tx1"/>
+            </a:fontRef>
+          </p:style>
+        </p:cxnSp>
+      </p:grpSp>
+    </p:spTree>
+    <p:extLst>
+      <p:ext uri="{BB962C8B-B14F-4D97-AF65-F5344CB8AC3E}">
+        <p14:creationId xmlns:p14="http://schemas.microsoft.com/office/powerpoint/2010/main" val="4137054191"/>
+      </p:ext>
+    </p:extLst>
+  </p:cSld>
+  <p:clrMapOvr>
+    <a:masterClrMapping/>
+  </p:clrMapOvr>
+  <p:timing>
+    <p:tnLst>
+      <p:par>
+        <p:cTn id="1" dur="indefinite" restart="never" nodeType="tmRoot">
+          <p:childTnLst>
+            <p:seq concurrent="1" nextAc="seek">
+              <p:cTn id="2" dur="indefinite" nodeType="mainSeq">
+                <p:childTnLst>
+                  <p:par>
+                    <p:cTn id="3" fill="hold">
+                      <p:stCondLst>
+                        <p:cond delay="indefinite"/>
+                      </p:stCondLst>
+                      <p:childTnLst>
+                        <p:par>
+                          <p:cTn id="4" fill="hold">
+                            <p:stCondLst>
+                              <p:cond delay="0"/>
+                            </p:stCondLst>
+                            <p:childTnLst>
+                              <p:par>
+                                <p:cTn id="5" presetID="10" presetClass="entr" presetSubtype="0" fill="hold" nodeType="clickEffect">
+                                  <p:stCondLst>
+                                    <p:cond delay="0"/>
+                                  </p:stCondLst>
+                                  <p:childTnLst>
+                                    <p:set>
+                                      <p:cBhvr>
+                                        <p:cTn id="6" dur="1" fill="hold">
+                                          <p:stCondLst>
+                                            <p:cond delay="0"/>
+                                          </p:stCondLst>
+                                        </p:cTn>
+                                        <p:tgtEl>
+                                          <p:spTgt spid="3">
+                                            <p:txEl>
+                                              <p:pRg st="2" end="2"/>
+                                            </p:txEl>
+                                          </p:spTgt>
+                                        </p:tgtEl>
+                                        <p:attrNameLst>
+                                          <p:attrName>style.visibility</p:attrName>
+                                        </p:attrNameLst>
+                                      </p:cBhvr>
+                                      <p:to>
+                                        <p:strVal val="visible"/>
+                                      </p:to>
+                                    </p:set>
+                                    <p:animEffect transition="in" filter="fade">
+                                      <p:cBhvr>
+                                        <p:cTn id="7" dur="500"/>
+                                        <p:tgtEl>
+                                          <p:spTgt spid="3">
+                                            <p:txEl>
+                                              <p:pRg st="2" end="2"/>
+                                            </p:txEl>
+                                          </p:spTgt>
+                                        </p:tgtEl>
+                                      </p:cBhvr>
+                                    </p:animEffect>
+                                  </p:childTnLst>
+                                </p:cTn>
+                              </p:par>
+                            </p:childTnLst>
+                          </p:cTn>
+                        </p:par>
+                      </p:childTnLst>
+                    </p:cTn>
+                  </p:par>
+                  <p:par>
+                    <p:cTn id="8" fill="hold">
+                      <p:stCondLst>
+                        <p:cond delay="indefinite"/>
+                      </p:stCondLst>
+                      <p:childTnLst>
+                        <p:par>
+                          <p:cTn id="9" fill="hold">
+                            <p:stCondLst>
+                              <p:cond delay="0"/>
+                            </p:stCondLst>
+                            <p:childTnLst>
+                              <p:par>
+                                <p:cTn id="10" presetID="10" presetClass="entr" presetSubtype="0" fill="hold" nodeType="clickEffect">
+                                  <p:stCondLst>
+                                    <p:cond delay="0"/>
+                                  </p:stCondLst>
+                                  <p:childTnLst>
+                                    <p:set>
+                                      <p:cBhvr>
+                                        <p:cTn id="11" dur="1" fill="hold">
+                                          <p:stCondLst>
+                                            <p:cond delay="0"/>
+                                          </p:stCondLst>
+                                        </p:cTn>
+                                        <p:tgtEl>
+                                          <p:spTgt spid="3">
+                                            <p:txEl>
+                                              <p:pRg st="3" end="3"/>
+                                            </p:txEl>
+                                          </p:spTgt>
+                                        </p:tgtEl>
+                                        <p:attrNameLst>
+                                          <p:attrName>style.visibility</p:attrName>
+                                        </p:attrNameLst>
+                                      </p:cBhvr>
+                                      <p:to>
+                                        <p:strVal val="visible"/>
+                                      </p:to>
+                                    </p:set>
+                                    <p:animEffect transition="in" filter="fade">
+                                      <p:cBhvr>
+                                        <p:cTn id="12" dur="500"/>
+                                        <p:tgtEl>
+                                          <p:spTgt spid="3">
+                                            <p:txEl>
+                                              <p:pRg st="3" end="3"/>
+                                            </p:txEl>
+                                          </p:spTgt>
+                                        </p:tgtEl>
+                                      </p:cBhvr>
+                                    </p:animEffect>
+                                  </p:childTnLst>
+                                </p:cTn>
+                              </p:par>
+                            </p:childTnLst>
+                          </p:cTn>
+                        </p:par>
+                      </p:childTnLst>
+                    </p:cTn>
+                  </p:par>
+                  <p:par>
+                    <p:cTn id="13" fill="hold">
+                      <p:stCondLst>
+                        <p:cond delay="indefinite"/>
+                      </p:stCondLst>
+                      <p:childTnLst>
+                        <p:par>
+                          <p:cTn id="14" fill="hold">
+                            <p:stCondLst>
+                              <p:cond delay="0"/>
+                            </p:stCondLst>
+                            <p:childTnLst>
+                              <p:par>
+                                <p:cTn id="15" presetID="10" presetClass="entr" presetSubtype="0" fill="hold" nodeType="clickEffect">
+                                  <p:stCondLst>
+                                    <p:cond delay="0"/>
+                                  </p:stCondLst>
+                                  <p:childTnLst>
+                                    <p:set>
+                                      <p:cBhvr>
+                                        <p:cTn id="16" dur="1" fill="hold">
+                                          <p:stCondLst>
+                                            <p:cond delay="0"/>
+                                          </p:stCondLst>
+                                        </p:cTn>
+                                        <p:tgtEl>
+                                          <p:spTgt spid="3">
+                                            <p:txEl>
+                                              <p:pRg st="4" end="4"/>
+                                            </p:txEl>
+                                          </p:spTgt>
+                                        </p:tgtEl>
+                                        <p:attrNameLst>
+                                          <p:attrName>style.visibility</p:attrName>
+                                        </p:attrNameLst>
+                                      </p:cBhvr>
+                                      <p:to>
+                                        <p:strVal val="visible"/>
+                                      </p:to>
+                                    </p:set>
+                                    <p:animEffect transition="in" filter="fade">
+                                      <p:cBhvr>
+                                        <p:cTn id="17" dur="500"/>
+                                        <p:tgtEl>
+                                          <p:spTgt spid="3">
+                                            <p:txEl>
+                                              <p:pRg st="4" end="4"/>
+                                            </p:txEl>
+                                          </p:spTgt>
+                                        </p:tgtEl>
+                                      </p:cBhvr>
+                                    </p:animEffect>
+                                  </p:childTnLst>
+                                </p:cTn>
+                              </p:par>
+                            </p:childTnLst>
+                          </p:cTn>
+                        </p:par>
+                      </p:childTnLst>
+                    </p:cTn>
+                  </p:par>
+                  <p:par>
+                    <p:cTn id="18" fill="hold">
+                      <p:stCondLst>
+                        <p:cond delay="indefinite"/>
+                      </p:stCondLst>
+                      <p:childTnLst>
+                        <p:par>
+                          <p:cTn id="19" fill="hold">
+                            <p:stCondLst>
+                              <p:cond delay="0"/>
+                            </p:stCondLst>
+                            <p:childTnLst>
+                              <p:par>
+                                <p:cTn id="20" presetID="10" presetClass="entr" presetSubtype="0" fill="hold" nodeType="clickEffect">
+                                  <p:stCondLst>
+                                    <p:cond delay="0"/>
+                                  </p:stCondLst>
+                                  <p:childTnLst>
+                                    <p:set>
+                                      <p:cBhvr>
+                                        <p:cTn id="21" dur="1" fill="hold">
+                                          <p:stCondLst>
+                                            <p:cond delay="0"/>
+                                          </p:stCondLst>
+                                        </p:cTn>
+                                        <p:tgtEl>
+                                          <p:spTgt spid="3">
+                                            <p:txEl>
+                                              <p:pRg st="6" end="6"/>
+                                            </p:txEl>
+                                          </p:spTgt>
+                                        </p:tgtEl>
+                                        <p:attrNameLst>
+                                          <p:attrName>style.visibility</p:attrName>
+                                        </p:attrNameLst>
+                                      </p:cBhvr>
+                                      <p:to>
+                                        <p:strVal val="visible"/>
+                                      </p:to>
+                                    </p:set>
+                                    <p:animEffect transition="in" filter="fade">
+                                      <p:cBhvr>
+                                        <p:cTn id="22" dur="500"/>
+                                        <p:tgtEl>
+                                          <p:spTgt spid="3">
+                                            <p:txEl>
+                                              <p:pRg st="6" end="6"/>
+                                            </p:txEl>
+                                          </p:spTgt>
+                                        </p:tgtEl>
+                                      </p:cBhvr>
+                                    </p:animEffect>
+                                  </p:childTnLst>
+                                </p:cTn>
+                              </p:par>
+                            </p:childTnLst>
+                          </p:cTn>
+                        </p:par>
+                      </p:childTnLst>
+                    </p:cTn>
+                  </p:par>
+                  <p:par>
+                    <p:cTn id="23" fill="hold">
+                      <p:stCondLst>
+                        <p:cond delay="indefinite"/>
+                      </p:stCondLst>
+                      <p:childTnLst>
+                        <p:par>
+                          <p:cTn id="24" fill="hold">
+                            <p:stCondLst>
+                              <p:cond delay="0"/>
+                            </p:stCondLst>
+                            <p:childTnLst>
+                              <p:par>
+                                <p:cTn id="25" presetID="10" presetClass="entr" presetSubtype="0" fill="hold" nodeType="clickEffect">
+                                  <p:stCondLst>
+                                    <p:cond delay="0"/>
+                                  </p:stCondLst>
+                                  <p:childTnLst>
+                                    <p:set>
+                                      <p:cBhvr>
+                                        <p:cTn id="26" dur="1" fill="hold">
+                                          <p:stCondLst>
+                                            <p:cond delay="0"/>
+                                          </p:stCondLst>
+                                        </p:cTn>
+                                        <p:tgtEl>
+                                          <p:spTgt spid="3">
+                                            <p:txEl>
+                                              <p:pRg st="7" end="7"/>
+                                            </p:txEl>
+                                          </p:spTgt>
+                                        </p:tgtEl>
+                                        <p:attrNameLst>
+                                          <p:attrName>style.visibility</p:attrName>
+                                        </p:attrNameLst>
+                                      </p:cBhvr>
+                                      <p:to>
+                                        <p:strVal val="visible"/>
+                                      </p:to>
+                                    </p:set>
+                                    <p:animEffect transition="in" filter="fade">
+                                      <p:cBhvr>
+                                        <p:cTn id="27" dur="500"/>
+                                        <p:tgtEl>
+                                          <p:spTgt spid="3">
+                                            <p:txEl>
+                                              <p:pRg st="7" end="7"/>
+                                            </p:txEl>
+                                          </p:spTgt>
+                                        </p:tgtEl>
+                                      </p:cBhvr>
+                                    </p:animEffect>
+                                  </p:childTnLst>
+                                </p:cTn>
+                              </p:par>
+                            </p:childTnLst>
+                          </p:cTn>
+                        </p:par>
+                      </p:childTnLst>
+                    </p:cTn>
+                  </p:par>
+                  <p:par>
+                    <p:cTn id="28" fill="hold">
+                      <p:stCondLst>
+                        <p:cond delay="indefinite"/>
+                      </p:stCondLst>
+                      <p:childTnLst>
+                        <p:par>
+                          <p:cTn id="29" fill="hold">
+                            <p:stCondLst>
+                              <p:cond delay="0"/>
+                            </p:stCondLst>
+                            <p:childTnLst>
+                              <p:par>
+                                <p:cTn id="30" presetID="10" presetClass="entr" presetSubtype="0" fill="hold" nodeType="clickEffect">
+                                  <p:stCondLst>
+                                    <p:cond delay="0"/>
+                                  </p:stCondLst>
+                                  <p:childTnLst>
+                                    <p:set>
+                                      <p:cBhvr>
+                                        <p:cTn id="31" dur="1" fill="hold">
+                                          <p:stCondLst>
+                                            <p:cond delay="0"/>
+                                          </p:stCondLst>
+                                        </p:cTn>
+                                        <p:tgtEl>
+                                          <p:spTgt spid="3">
+                                            <p:txEl>
+                                              <p:pRg st="8" end="8"/>
+                                            </p:txEl>
+                                          </p:spTgt>
+                                        </p:tgtEl>
+                                        <p:attrNameLst>
+                                          <p:attrName>style.visibility</p:attrName>
+                                        </p:attrNameLst>
+                                      </p:cBhvr>
+                                      <p:to>
+                                        <p:strVal val="visible"/>
+                                      </p:to>
+                                    </p:set>
+                                    <p:animEffect transition="in" filter="fade">
+                                      <p:cBhvr>
+                                        <p:cTn id="32" dur="500"/>
+                                        <p:tgtEl>
+                                          <p:spTgt spid="3">
+                                            <p:txEl>
+                                              <p:pRg st="8" end="8"/>
+                                            </p:txEl>
+                                          </p:spTgt>
+                                        </p:tgtEl>
+                                      </p:cBhvr>
+                                    </p:animEffect>
+                                  </p:childTnLst>
+                                </p:cTn>
+                              </p:par>
+                            </p:childTnLst>
+                          </p:cTn>
+                        </p:par>
+                      </p:childTnLst>
+                    </p:cTn>
+                  </p:par>
+                  <p:par>
+                    <p:cTn id="33" fill="hold">
+                      <p:stCondLst>
+                        <p:cond delay="indefinite"/>
+                      </p:stCondLst>
+                      <p:childTnLst>
+                        <p:par>
+                          <p:cTn id="34" fill="hold">
+                            <p:stCondLst>
+                              <p:cond delay="0"/>
+                            </p:stCondLst>
+                            <p:childTnLst>
+                              <p:par>
+                                <p:cTn id="35" presetID="10" presetClass="entr" presetSubtype="0" fill="hold" nodeType="clickEffect">
+                                  <p:stCondLst>
+                                    <p:cond delay="0"/>
+                                  </p:stCondLst>
+                                  <p:childTnLst>
+                                    <p:set>
+                                      <p:cBhvr>
+                                        <p:cTn id="36" dur="1" fill="hold">
+                                          <p:stCondLst>
+                                            <p:cond delay="0"/>
+                                          </p:stCondLst>
+                                        </p:cTn>
+                                        <p:tgtEl>
+                                          <p:spTgt spid="3">
+                                            <p:txEl>
+                                              <p:pRg st="10" end="10"/>
+                                            </p:txEl>
+                                          </p:spTgt>
+                                        </p:tgtEl>
+                                        <p:attrNameLst>
+                                          <p:attrName>style.visibility</p:attrName>
+                                        </p:attrNameLst>
+                                      </p:cBhvr>
+                                      <p:to>
+                                        <p:strVal val="visible"/>
+                                      </p:to>
+                                    </p:set>
+                                    <p:animEffect transition="in" filter="fade">
+                                      <p:cBhvr>
+                                        <p:cTn id="37" dur="500"/>
+                                        <p:tgtEl>
+                                          <p:spTgt spid="3">
+                                            <p:txEl>
+                                              <p:pRg st="10" end="10"/>
+                                            </p:txEl>
+                                          </p:spTgt>
+                                        </p:tgtEl>
+                                      </p:cBhvr>
+                                    </p:animEffect>
+                                  </p:childTnLst>
+                                </p:cTn>
+                              </p:par>
+                            </p:childTnLst>
+                          </p:cTn>
+                        </p:par>
+                      </p:childTnLst>
+                    </p:cTn>
+                  </p:par>
+                  <p:par>
+                    <p:cTn id="38" fill="hold">
+                      <p:stCondLst>
+                        <p:cond delay="indefinite"/>
+                      </p:stCondLst>
+                      <p:childTnLst>
+                        <p:par>
+                          <p:cTn id="39" fill="hold">
+                            <p:stCondLst>
+                              <p:cond delay="0"/>
+                            </p:stCondLst>
+                            <p:childTnLst>
+                              <p:par>
+                                <p:cTn id="40" presetID="10" presetClass="entr" presetSubtype="0" fill="hold" nodeType="clickEffect">
+                                  <p:stCondLst>
+                                    <p:cond delay="0"/>
+                                  </p:stCondLst>
+                                  <p:childTnLst>
+                                    <p:set>
+                                      <p:cBhvr>
+                                        <p:cTn id="41" dur="1" fill="hold">
+                                          <p:stCondLst>
+                                            <p:cond delay="0"/>
+                                          </p:stCondLst>
+                                        </p:cTn>
+                                        <p:tgtEl>
+                                          <p:spTgt spid="3">
+                                            <p:txEl>
+                                              <p:pRg st="11" end="11"/>
+                                            </p:txEl>
+                                          </p:spTgt>
+                                        </p:tgtEl>
+                                        <p:attrNameLst>
+                                          <p:attrName>style.visibility</p:attrName>
+                                        </p:attrNameLst>
+                                      </p:cBhvr>
+                                      <p:to>
+                                        <p:strVal val="visible"/>
+                                      </p:to>
+                                    </p:set>
+                                    <p:animEffect transition="in" filter="fade">
+                                      <p:cBhvr>
+                                        <p:cTn id="42" dur="500"/>
+                                        <p:tgtEl>
+                                          <p:spTgt spid="3">
+                                            <p:txEl>
+                                              <p:pRg st="11" end="11"/>
+                                            </p:txEl>
+                                          </p:spTgt>
+                                        </p:tgtEl>
+                                      </p:cBhvr>
+                                    </p:animEffect>
+                                  </p:childTnLst>
+                                </p:cTn>
+                              </p:par>
+                            </p:childTnLst>
+                          </p:cTn>
+                        </p:par>
+                      </p:childTnLst>
+                    </p:cTn>
+                  </p:par>
+                  <p:par>
+                    <p:cTn id="43" fill="hold">
+                      <p:stCondLst>
+                        <p:cond delay="indefinite"/>
+                      </p:stCondLst>
+                      <p:childTnLst>
+                        <p:par>
+                          <p:cTn id="44" fill="hold">
+                            <p:stCondLst>
+                              <p:cond delay="0"/>
+                            </p:stCondLst>
+                            <p:childTnLst>
+                              <p:par>
+                                <p:cTn id="45" presetID="10" presetClass="entr" presetSubtype="0" fill="hold" nodeType="clickEffect">
+                                  <p:stCondLst>
+                                    <p:cond delay="0"/>
+                                  </p:stCondLst>
+                                  <p:childTnLst>
+                                    <p:set>
+                                      <p:cBhvr>
+                                        <p:cTn id="46" dur="1" fill="hold">
+                                          <p:stCondLst>
+                                            <p:cond delay="0"/>
+                                          </p:stCondLst>
+                                        </p:cTn>
+                                        <p:tgtEl>
+                                          <p:spTgt spid="3">
+                                            <p:txEl>
+                                              <p:pRg st="13" end="13"/>
+                                            </p:txEl>
+                                          </p:spTgt>
+                                        </p:tgtEl>
+                                        <p:attrNameLst>
+                                          <p:attrName>style.visibility</p:attrName>
+                                        </p:attrNameLst>
+                                      </p:cBhvr>
+                                      <p:to>
+                                        <p:strVal val="visible"/>
+                                      </p:to>
+                                    </p:set>
+                                    <p:animEffect transition="in" filter="fade">
+                                      <p:cBhvr>
+                                        <p:cTn id="47" dur="500"/>
+                                        <p:tgtEl>
+                                          <p:spTgt spid="3">
+                                            <p:txEl>
+                                              <p:pRg st="13" end="13"/>
+                                            </p:txEl>
+                                          </p:spTgt>
+                                        </p:tgtEl>
+                                      </p:cBhvr>
+                                    </p:animEffect>
+                                  </p:childTnLst>
+                                </p:cTn>
+                              </p:par>
+                            </p:childTnLst>
+                          </p:cTn>
+                        </p:par>
+                      </p:childTnLst>
+                    </p:cTn>
+                  </p:par>
+                  <p:par>
+                    <p:cTn id="48" fill="hold">
+                      <p:stCondLst>
+                        <p:cond delay="indefinite"/>
+                      </p:stCondLst>
+                      <p:childTnLst>
+                        <p:par>
+                          <p:cTn id="49" fill="hold">
+                            <p:stCondLst>
+                              <p:cond delay="0"/>
+                            </p:stCondLst>
+                            <p:childTnLst>
+                              <p:par>
+                                <p:cTn id="50" presetID="10" presetClass="entr" presetSubtype="0" fill="hold" nodeType="clickEffect">
+                                  <p:stCondLst>
+                                    <p:cond delay="0"/>
+                                  </p:stCondLst>
+                                  <p:childTnLst>
+                                    <p:set>
+                                      <p:cBhvr>
+                                        <p:cTn id="51" dur="1" fill="hold">
+                                          <p:stCondLst>
+                                            <p:cond delay="0"/>
+                                          </p:stCondLst>
+                                        </p:cTn>
+                                        <p:tgtEl>
+                                          <p:spTgt spid="3">
+                                            <p:txEl>
+                                              <p:pRg st="15" end="15"/>
+                                            </p:txEl>
+                                          </p:spTgt>
+                                        </p:tgtEl>
+                                        <p:attrNameLst>
+                                          <p:attrName>style.visibility</p:attrName>
+                                        </p:attrNameLst>
+                                      </p:cBhvr>
+                                      <p:to>
+                                        <p:strVal val="visible"/>
+                                      </p:to>
+                                    </p:set>
+                                    <p:animEffect transition="in" filter="fade">
+                                      <p:cBhvr>
+                                        <p:cTn id="52" dur="500"/>
+                                        <p:tgtEl>
+                                          <p:spTgt spid="3">
+                                            <p:txEl>
+                                              <p:pRg st="15" end="15"/>
+                                            </p:txEl>
+                                          </p:spTgt>
+                                        </p:tgtEl>
+                                      </p:cBhvr>
+                                    </p:animEffect>
+                                  </p:childTnLst>
+                                </p:cTn>
+                              </p:par>
+                            </p:childTnLst>
+                          </p:cTn>
+                        </p:par>
+                      </p:childTnLst>
+                    </p:cTn>
+                  </p:par>
+                  <p:par>
+                    <p:cTn id="53" fill="hold">
+                      <p:stCondLst>
+                        <p:cond delay="indefinite"/>
+                      </p:stCondLst>
+                      <p:childTnLst>
+                        <p:par>
+                          <p:cTn id="54" fill="hold">
+                            <p:stCondLst>
+                              <p:cond delay="0"/>
+                            </p:stCondLst>
+                            <p:childTnLst>
+                              <p:par>
+                                <p:cTn id="55" presetID="10" presetClass="entr" presetSubtype="0" fill="hold" nodeType="clickEffect">
+                                  <p:stCondLst>
+                                    <p:cond delay="0"/>
+                                  </p:stCondLst>
+                                  <p:childTnLst>
+                                    <p:set>
+                                      <p:cBhvr>
+                                        <p:cTn id="56" dur="1" fill="hold">
+                                          <p:stCondLst>
+                                            <p:cond delay="0"/>
+                                          </p:stCondLst>
+                                        </p:cTn>
+                                        <p:tgtEl>
+                                          <p:spTgt spid="3">
+                                            <p:txEl>
+                                              <p:pRg st="16" end="16"/>
+                                            </p:txEl>
+                                          </p:spTgt>
+                                        </p:tgtEl>
+                                        <p:attrNameLst>
+                                          <p:attrName>style.visibility</p:attrName>
+                                        </p:attrNameLst>
+                                      </p:cBhvr>
+                                      <p:to>
+                                        <p:strVal val="visible"/>
+                                      </p:to>
+                                    </p:set>
+                                    <p:animEffect transition="in" filter="fade">
+                                      <p:cBhvr>
+                                        <p:cTn id="57" dur="500"/>
+                                        <p:tgtEl>
+                                          <p:spTgt spid="3">
+                                            <p:txEl>
+                                              <p:pRg st="16" end="16"/>
+                                            </p:txEl>
+                                          </p:spTgt>
+                                        </p:tgtEl>
+                                      </p:cBhvr>
+                                    </p:animEffect>
+                                  </p:childTnLst>
+                                </p:cTn>
+                              </p:par>
+                            </p:childTnLst>
+                          </p:cTn>
+                        </p:par>
+                      </p:childTnLst>
+                    </p:cTn>
+                  </p:par>
+                  <p:par>
+                    <p:cTn id="58" fill="hold">
+                      <p:stCondLst>
+                        <p:cond delay="indefinite"/>
+                      </p:stCondLst>
+                      <p:childTnLst>
+                        <p:par>
+                          <p:cTn id="59" fill="hold">
+                            <p:stCondLst>
+                              <p:cond delay="0"/>
+                            </p:stCondLst>
+                            <p:childTnLst>
+                              <p:par>
+                                <p:cTn id="60" presetID="10" presetClass="entr" presetSubtype="0" fill="hold" nodeType="clickEffect">
+                                  <p:stCondLst>
+                                    <p:cond delay="0"/>
+                                  </p:stCondLst>
+                                  <p:childTnLst>
+                                    <p:set>
+                                      <p:cBhvr>
+                                        <p:cTn id="61" dur="1" fill="hold">
+                                          <p:stCondLst>
+                                            <p:cond delay="0"/>
+                                          </p:stCondLst>
+                                        </p:cTn>
+                                        <p:tgtEl>
+                                          <p:spTgt spid="3">
+                                            <p:txEl>
+                                              <p:pRg st="0" end="0"/>
+                                            </p:txEl>
+                                          </p:spTgt>
+                                        </p:tgtEl>
+                                        <p:attrNameLst>
+                                          <p:attrName>style.visibility</p:attrName>
+                                        </p:attrNameLst>
+                                      </p:cBhvr>
+                                      <p:to>
+                                        <p:strVal val="visible"/>
+                                      </p:to>
+                                    </p:set>
+                                    <p:animEffect transition="in" filter="fade">
+                                      <p:cBhvr>
+                                        <p:cTn id="62" dur="500"/>
+                                        <p:tgtEl>
+                                          <p:spTgt spid="3">
+                                            <p:txEl>
+                                              <p:pRg st="0" end="0"/>
+                                            </p:txEl>
+                                          </p:spTgt>
+                                        </p:tgtEl>
+                                      </p:cBhvr>
+                                    </p:animEffect>
+                                  </p:childTnLst>
+                                </p:cTn>
+                              </p:par>
+                            </p:childTnLst>
+                          </p:cTn>
+                        </p:par>
+                      </p:childTnLst>
+                    </p:cTn>
+                  </p:par>
+                  <p:par>
+                    <p:cTn id="63" fill="hold">
+                      <p:stCondLst>
+                        <p:cond delay="indefinite"/>
+                      </p:stCondLst>
+                      <p:childTnLst>
+                        <p:par>
+                          <p:cTn id="64" fill="hold">
+                            <p:stCondLst>
+                              <p:cond delay="0"/>
+                            </p:stCondLst>
+                            <p:childTnLst>
+                              <p:par>
+                                <p:cTn id="65" presetID="10" presetClass="entr" presetSubtype="0" fill="hold" nodeType="clickEffect">
+                                  <p:stCondLst>
+                                    <p:cond delay="0"/>
+                                  </p:stCondLst>
+                                  <p:childTnLst>
+                                    <p:set>
+                                      <p:cBhvr>
+                                        <p:cTn id="66" dur="1" fill="hold">
+                                          <p:stCondLst>
+                                            <p:cond delay="0"/>
+                                          </p:stCondLst>
+                                        </p:cTn>
+                                        <p:tgtEl>
+                                          <p:spTgt spid="8"/>
+                                        </p:tgtEl>
+                                        <p:attrNameLst>
+                                          <p:attrName>style.visibility</p:attrName>
+                                        </p:attrNameLst>
+                                      </p:cBhvr>
+                                      <p:to>
+                                        <p:strVal val="visible"/>
+                                      </p:to>
+                                    </p:set>
+                                    <p:animEffect transition="in" filter="fade">
+                                      <p:cBhvr>
+                                        <p:cTn id="67" dur="500"/>
+                                        <p:tgtEl>
+                                          <p:spTgt spid="8"/>
+                                        </p:tgtEl>
+                                      </p:cBhvr>
+                                    </p:animEffect>
+                                  </p:childTnLst>
+                                </p:cTn>
+                              </p:par>
+                            </p:childTnLst>
+                          </p:cTn>
+                        </p:par>
+                      </p:childTnLst>
+                    </p:cTn>
+                  </p:par>
+                  <p:par>
+                    <p:cTn id="68" fill="hold">
+                      <p:stCondLst>
+                        <p:cond delay="indefinite"/>
+                      </p:stCondLst>
+                      <p:childTnLst>
+                        <p:par>
+                          <p:cTn id="69" fill="hold">
+                            <p:stCondLst>
+                              <p:cond delay="0"/>
+                            </p:stCondLst>
+                            <p:childTnLst>
+                              <p:par>
+                                <p:cTn id="70" presetID="10" presetClass="entr" presetSubtype="0" fill="hold" nodeType="clickEffect">
+                                  <p:stCondLst>
+                                    <p:cond delay="0"/>
+                                  </p:stCondLst>
+                                  <p:childTnLst>
+                                    <p:set>
+                                      <p:cBhvr>
+                                        <p:cTn id="71" dur="1" fill="hold">
+                                          <p:stCondLst>
+                                            <p:cond delay="0"/>
+                                          </p:stCondLst>
+                                        </p:cTn>
+                                        <p:tgtEl>
+                                          <p:spTgt spid="11"/>
+                                        </p:tgtEl>
+                                        <p:attrNameLst>
+                                          <p:attrName>style.visibility</p:attrName>
+                                        </p:attrNameLst>
+                                      </p:cBhvr>
+                                      <p:to>
+                                        <p:strVal val="visible"/>
+                                      </p:to>
+                                    </p:set>
+                                    <p:animEffect transition="in" filter="fade">
+                                      <p:cBhvr>
+                                        <p:cTn id="72" dur="500"/>
+                                        <p:tgtEl>
+                                          <p:spTgt spid="11"/>
+                                        </p:tgtEl>
+                                      </p:cBhvr>
+                                    </p:animEffect>
+                                  </p:childTnLst>
+                                </p:cTn>
+                              </p:par>
+                            </p:childTnLst>
+                          </p:cTn>
+                        </p:par>
+                      </p:childTnLst>
+                    </p:cTn>
+                  </p:par>
+                </p:childTnLst>
+              </p:cTn>
+              <p:prevCondLst>
+                <p:cond evt="onPrev" delay="0">
+                  <p:tgtEl>
+                    <p:sldTgt/>
+                  </p:tgtEl>
+                </p:cond>
+              </p:prevCondLst>
+              <p:nextCondLst>
+                <p:cond evt="onNext" delay="0">
+                  <p:tgtEl>
+                    <p:sldTgt/>
+                  </p:tgtEl>
+                </p:cond>
+              </p:nextCondLst>
+            </p:seq>
+          </p:childTnLst>
+        </p:cTn>
+      </p:par>
+    </p:tnLst>
+  </p:timing>
+</p:sld>
+</file>
+
+<file path=ppt/slides/slide15.xml><?xml version="1.0" encoding="utf-8"?>
+<p:sld xmlns:a="http://schemas.openxmlformats.org/drawingml/2006/main" xmlns:r="http://schemas.openxmlformats.org/officeDocument/2006/relationships" xmlns:p="http://schemas.openxmlformats.org/presentationml/2006/main">
+  <p:cSld>
+    <p:bg>
+      <p:bgPr>
+        <a:solidFill>
           <a:schemeClr val="bg1">
             <a:lumMod val="95000"/>
           </a:schemeClr>
@@ -6407,7 +8134,7 @@
           <a:p>
             <a:fld id="{846B06B1-1179-491F-A487-8E0C403F7C13}" type="slidenum">
               <a:rPr lang="fr-CA" smtClean="0"/>
-              <a:t>14</a:t>
+              <a:t>15</a:t>
             </a:fld>
             <a:endParaRPr lang="fr-CA"/>
           </a:p>
@@ -6492,7 +8219,7 @@
 </p:sld>
 </file>
 
-<file path=ppt/slides/slide15.xml><?xml version="1.0" encoding="utf-8"?>
+<file path=ppt/slides/slide16.xml><?xml version="1.0" encoding="utf-8"?>
 <p:sld xmlns:a="http://schemas.openxmlformats.org/drawingml/2006/main" xmlns:r="http://schemas.openxmlformats.org/officeDocument/2006/relationships" xmlns:p="http://schemas.openxmlformats.org/presentationml/2006/main">
   <p:cSld>
     <p:bg>
@@ -6611,7 +8338,7 @@
           <a:p>
             <a:fld id="{846B06B1-1179-491F-A487-8E0C403F7C13}" type="slidenum">
               <a:rPr lang="fr-CA" smtClean="0"/>
-              <a:t>15</a:t>
+              <a:t>16</a:t>
             </a:fld>
             <a:endParaRPr lang="fr-CA"/>
           </a:p>
@@ -6630,7 +8357,7 @@
 </p:sld>
 </file>
 
-<file path=ppt/slides/slide16.xml><?xml version="1.0" encoding="utf-8"?>
+<file path=ppt/slides/slide17.xml><?xml version="1.0" encoding="utf-8"?>
 <p:sld xmlns:a="http://schemas.openxmlformats.org/drawingml/2006/main" xmlns:r="http://schemas.openxmlformats.org/officeDocument/2006/relationships" xmlns:p="http://schemas.openxmlformats.org/presentationml/2006/main">
   <p:cSld>
     <p:spTree>
@@ -6799,7 +8526,7 @@
           <a:p>
             <a:fld id="{846B06B1-1179-491F-A487-8E0C403F7C13}" type="slidenum">
               <a:rPr lang="fr-CA" smtClean="0"/>
-              <a:t>16</a:t>
+              <a:t>17</a:t>
             </a:fld>
             <a:endParaRPr lang="fr-CA"/>
           </a:p>
@@ -11724,7 +13451,7 @@
               <a:buNone/>
             </a:pPr>
             <a:r>
-              <a:rPr lang="en-US" b="1" i="1" dirty="0">
+              <a:rPr lang="en-US" i="1" dirty="0">
                 <a:solidFill>
                   <a:schemeClr val="accent6"/>
                 </a:solidFill>
@@ -11733,7 +13460,7 @@
               <a:t># </a:t>
             </a:r>
             <a:r>
-              <a:rPr lang="en-US" b="1" i="1" dirty="0" err="1">
+              <a:rPr lang="en-US" i="1" dirty="0" err="1">
                 <a:solidFill>
                   <a:schemeClr val="accent6"/>
                 </a:solidFill>
@@ -11741,7 +13468,7 @@
               </a:rPr>
               <a:t>Paramètres</a:t>
             </a:r>
-            <a:endParaRPr lang="en-US" b="1" i="1" dirty="0">
+            <a:endParaRPr lang="en-US" i="1" dirty="0">
               <a:solidFill>
                 <a:schemeClr val="accent6"/>
               </a:solidFill>
@@ -11753,7 +13480,7 @@
               <a:buNone/>
             </a:pPr>
             <a:r>
-              <a:rPr lang="pt-BR" sz="2600" b="1" dirty="0">
+              <a:rPr lang="pt-BR" sz="2600" dirty="0">
                 <a:latin typeface="Consolas" panose="020B0609020204030204" pitchFamily="49" charset="0"/>
               </a:rPr>
               <a:t>a = 1</a:t>
@@ -11764,7 +13491,7 @@
               <a:buNone/>
             </a:pPr>
             <a:r>
-              <a:rPr lang="pt-BR" sz="2600" b="1" dirty="0">
+              <a:rPr lang="pt-BR" sz="2600" dirty="0">
                 <a:latin typeface="Consolas" panose="020B0609020204030204" pitchFamily="49" charset="0"/>
               </a:rPr>
               <a:t>b = 2</a:t>
@@ -11775,7 +13502,7 @@
               <a:buNone/>
             </a:pPr>
             <a:r>
-              <a:rPr lang="pt-BR" sz="2600" b="1" dirty="0">
+              <a:rPr lang="pt-BR" sz="2600" dirty="0">
                 <a:latin typeface="Consolas" panose="020B0609020204030204" pitchFamily="49" charset="0"/>
               </a:rPr>
               <a:t>c = -1</a:t>
@@ -11785,7 +13512,7 @@
             <a:pPr marL="0" indent="0">
               <a:buNone/>
             </a:pPr>
-            <a:endParaRPr lang="pt-BR" sz="2600" b="1" dirty="0">
+            <a:endParaRPr lang="pt-BR" sz="2600" dirty="0">
               <a:latin typeface="Consolas" panose="020B0609020204030204" pitchFamily="49" charset="0"/>
             </a:endParaRPr>
           </a:p>
@@ -11794,7 +13521,7 @@
               <a:buNone/>
             </a:pPr>
             <a:r>
-              <a:rPr lang="pt-BR" sz="2600" b="1" i="1" dirty="0">
+              <a:rPr lang="pt-BR" sz="2600" i="1" dirty="0">
                 <a:solidFill>
                   <a:schemeClr val="accent6"/>
                 </a:solidFill>
@@ -11808,7 +13535,7 @@
               <a:buNone/>
             </a:pPr>
             <a:r>
-              <a:rPr lang="pt-BR" sz="2600" b="1" dirty="0">
+              <a:rPr lang="pt-BR" sz="2600" dirty="0">
                 <a:latin typeface="Consolas" panose="020B0609020204030204" pitchFamily="49" charset="0"/>
               </a:rPr>
               <a:t>r1 = (-b - (b**2 - 4 * a * c)**0.5) / (2 * a)</a:t>
@@ -11819,7 +13546,7 @@
               <a:buNone/>
             </a:pPr>
             <a:r>
-              <a:rPr lang="pt-BR" sz="2600" b="1" dirty="0">
+              <a:rPr lang="pt-BR" sz="2600" dirty="0">
                 <a:latin typeface="Consolas" panose="020B0609020204030204" pitchFamily="49" charset="0"/>
               </a:rPr>
               <a:t>r2 = (-b + (b**2 - 4 * a * c)**0.5) / (2 * a)</a:t>
@@ -11829,7 +13556,7 @@
             <a:pPr marL="0" indent="0">
               <a:buNone/>
             </a:pPr>
-            <a:endParaRPr lang="pt-BR" sz="2600" b="1" dirty="0">
+            <a:endParaRPr lang="pt-BR" sz="2600" dirty="0">
               <a:latin typeface="Consolas" panose="020B0609020204030204" pitchFamily="49" charset="0"/>
             </a:endParaRPr>
           </a:p>
@@ -11838,7 +13565,7 @@
               <a:buNone/>
             </a:pPr>
             <a:r>
-              <a:rPr lang="pt-BR" sz="2600" b="1" i="1" dirty="0">
+              <a:rPr lang="pt-BR" sz="2600" i="1" dirty="0">
                 <a:solidFill>
                   <a:schemeClr val="accent6"/>
                 </a:solidFill>
@@ -11852,12 +13579,12 @@
               <a:buNone/>
             </a:pPr>
             <a:r>
-              <a:rPr lang="pt-BR" sz="2600" b="1" dirty="0">
+              <a:rPr lang="pt-BR" sz="2600" dirty="0">
                 <a:latin typeface="Consolas" panose="020B0609020204030204" pitchFamily="49" charset="0"/>
               </a:rPr>
               <a:t>print('r1 = ', r1, 'r2 = ', r2)</a:t>
             </a:r>
-            <a:endParaRPr lang="en-US" sz="2600" b="1" dirty="0">
+            <a:endParaRPr lang="en-US" sz="2600" dirty="0">
               <a:latin typeface="Consolas" panose="020B0609020204030204" pitchFamily="49" charset="0"/>
             </a:endParaRPr>
           </a:p>

</xml_diff>

<commit_message>
feat: Update python_1 presentation up to slide no.16
</commit_message>
<xml_diff>
--- a/python_1/presentation_python_1.pptx
+++ b/python_1/presentation_python_1.pptx
@@ -5,7 +5,7 @@
     <p:sldMasterId id="2147483648" r:id="rId1"/>
   </p:sldMasterIdLst>
   <p:notesMasterIdLst>
-    <p:notesMasterId r:id="rId19"/>
+    <p:notesMasterId r:id="rId21"/>
   </p:notesMasterIdLst>
   <p:sldIdLst>
     <p:sldId id="256" r:id="rId2"/>
@@ -22,9 +22,11 @@
     <p:sldId id="271" r:id="rId13"/>
     <p:sldId id="272" r:id="rId14"/>
     <p:sldId id="273" r:id="rId15"/>
-    <p:sldId id="270" r:id="rId16"/>
-    <p:sldId id="267" r:id="rId17"/>
-    <p:sldId id="262" r:id="rId18"/>
+    <p:sldId id="274" r:id="rId16"/>
+    <p:sldId id="275" r:id="rId17"/>
+    <p:sldId id="270" r:id="rId18"/>
+    <p:sldId id="267" r:id="rId19"/>
+    <p:sldId id="262" r:id="rId20"/>
   </p:sldIdLst>
   <p:sldSz cx="12192000" cy="6858000"/>
   <p:notesSz cx="6858000" cy="9144000"/>
@@ -213,7 +215,7 @@
           <a:p>
             <a:fld id="{17426931-AE65-4D08-8B32-62FCBDE55937}" type="datetimeFigureOut">
               <a:rPr lang="fr-CA" smtClean="0"/>
-              <a:t>2026-04-09</a:t>
+              <a:t>2026-04-10</a:t>
             </a:fld>
             <a:endParaRPr lang="fr-CA"/>
           </a:p>
@@ -630,7 +632,7 @@
           <a:p>
             <a:fld id="{73720E39-F9E6-45F4-9AF3-0670893E0E05}" type="datetime1">
               <a:rPr lang="fr-CA" smtClean="0"/>
-              <a:t>2026-04-09</a:t>
+              <a:t>2026-04-10</a:t>
             </a:fld>
             <a:endParaRPr lang="fr-CA"/>
           </a:p>
@@ -830,7 +832,7 @@
           <a:p>
             <a:fld id="{2A86A87F-FCE1-414B-898E-E056954DFB53}" type="datetime1">
               <a:rPr lang="fr-CA" smtClean="0"/>
-              <a:t>2026-04-09</a:t>
+              <a:t>2026-04-10</a:t>
             </a:fld>
             <a:endParaRPr lang="fr-CA"/>
           </a:p>
@@ -1040,7 +1042,7 @@
           <a:p>
             <a:fld id="{86217A25-A768-4FB5-8838-4C76F4A4D771}" type="datetime1">
               <a:rPr lang="fr-CA" smtClean="0"/>
-              <a:t>2026-04-09</a:t>
+              <a:t>2026-04-10</a:t>
             </a:fld>
             <a:endParaRPr lang="fr-CA"/>
           </a:p>
@@ -1240,7 +1242,7 @@
           <a:p>
             <a:fld id="{6DF5E9B1-F4B4-44A9-8978-A50A0AD8373C}" type="datetime1">
               <a:rPr lang="fr-CA" smtClean="0"/>
-              <a:t>2026-04-09</a:t>
+              <a:t>2026-04-10</a:t>
             </a:fld>
             <a:endParaRPr lang="fr-CA"/>
           </a:p>
@@ -1516,7 +1518,7 @@
           <a:p>
             <a:fld id="{5DE8FE0D-E91C-47AE-8B70-2B0ABA5D1B1E}" type="datetime1">
               <a:rPr lang="fr-CA" smtClean="0"/>
-              <a:t>2026-04-09</a:t>
+              <a:t>2026-04-10</a:t>
             </a:fld>
             <a:endParaRPr lang="fr-CA"/>
           </a:p>
@@ -1784,7 +1786,7 @@
           <a:p>
             <a:fld id="{F3AB8F30-8420-4011-A9ED-ED2F47883C93}" type="datetime1">
               <a:rPr lang="fr-CA" smtClean="0"/>
-              <a:t>2026-04-09</a:t>
+              <a:t>2026-04-10</a:t>
             </a:fld>
             <a:endParaRPr lang="fr-CA"/>
           </a:p>
@@ -2199,7 +2201,7 @@
           <a:p>
             <a:fld id="{852876F1-672F-46E4-BC46-E9D4C880BFEF}" type="datetime1">
               <a:rPr lang="fr-CA" smtClean="0"/>
-              <a:t>2026-04-09</a:t>
+              <a:t>2026-04-10</a:t>
             </a:fld>
             <a:endParaRPr lang="fr-CA"/>
           </a:p>
@@ -2341,7 +2343,7 @@
           <a:p>
             <a:fld id="{05494588-57AE-4A88-AA7D-14590C8ABB1D}" type="datetime1">
               <a:rPr lang="fr-CA" smtClean="0"/>
-              <a:t>2026-04-09</a:t>
+              <a:t>2026-04-10</a:t>
             </a:fld>
             <a:endParaRPr lang="fr-CA"/>
           </a:p>
@@ -2454,7 +2456,7 @@
           <a:p>
             <a:fld id="{70596107-F84A-4D89-B7EE-30826EF0EE70}" type="datetime1">
               <a:rPr lang="fr-CA" smtClean="0"/>
-              <a:t>2026-04-09</a:t>
+              <a:t>2026-04-10</a:t>
             </a:fld>
             <a:endParaRPr lang="fr-CA"/>
           </a:p>
@@ -2767,7 +2769,7 @@
           <a:p>
             <a:fld id="{12C269CA-6797-4965-A975-3F40F12DAD06}" type="datetime1">
               <a:rPr lang="fr-CA" smtClean="0"/>
-              <a:t>2026-04-09</a:t>
+              <a:t>2026-04-10</a:t>
             </a:fld>
             <a:endParaRPr lang="fr-CA"/>
           </a:p>
@@ -3056,7 +3058,7 @@
           <a:p>
             <a:fld id="{3F5AE234-69D2-4522-AB7A-F911A65753A0}" type="datetime1">
               <a:rPr lang="fr-CA" smtClean="0"/>
-              <a:t>2026-04-09</a:t>
+              <a:t>2026-04-10</a:t>
             </a:fld>
             <a:endParaRPr lang="fr-CA"/>
           </a:p>
@@ -3299,7 +3301,7 @@
           <a:p>
             <a:fld id="{30546B8D-50B2-4CF7-ACAA-221A68F8C882}" type="datetime1">
               <a:rPr lang="fr-CA" smtClean="0"/>
-              <a:t>2026-04-09</a:t>
+              <a:t>2026-04-10</a:t>
             </a:fld>
             <a:endParaRPr lang="fr-CA"/>
           </a:p>
@@ -6375,19 +6377,7 @@
               <a:rPr lang="en-US" dirty="0">
                 <a:latin typeface="Arial Rounded MT Bold" panose="020F0704030504030204" pitchFamily="34" charset="0"/>
               </a:rPr>
-              <a:t>Les tuples (pour de </a:t>
-            </a:r>
-            <a:r>
-              <a:rPr lang="en-US" dirty="0" err="1">
-                <a:latin typeface="Arial Rounded MT Bold" panose="020F0704030504030204" pitchFamily="34" charset="0"/>
-              </a:rPr>
-              <a:t>vrai</a:t>
-            </a:r>
-            <a:r>
-              <a:rPr lang="en-US" dirty="0">
-                <a:latin typeface="Arial Rounded MT Bold" panose="020F0704030504030204" pitchFamily="34" charset="0"/>
-              </a:rPr>
-              <a:t>)</a:t>
+              <a:t>Les tuples</a:t>
             </a:r>
             <a:endParaRPr lang="fr-CA" dirty="0">
               <a:latin typeface="Arial Rounded MT Bold" panose="020F0704030504030204" pitchFamily="34" charset="0"/>
@@ -7140,6 +7130,110 @@
             <a:xfrm flipV="1">
               <a:off x="9104450" y="4643563"/>
               <a:ext cx="0" cy="270000"/>
+            </a:xfrm>
+            <a:prstGeom prst="straightConnector1">
+              <a:avLst/>
+            </a:prstGeom>
+            <a:ln>
+              <a:tailEnd type="triangle"/>
+            </a:ln>
+          </p:spPr>
+          <p:style>
+            <a:lnRef idx="2">
+              <a:schemeClr val="dk1"/>
+            </a:lnRef>
+            <a:fillRef idx="0">
+              <a:schemeClr val="dk1"/>
+            </a:fillRef>
+            <a:effectRef idx="1">
+              <a:schemeClr val="dk1"/>
+            </a:effectRef>
+            <a:fontRef idx="minor">
+              <a:schemeClr val="tx1"/>
+            </a:fontRef>
+          </p:style>
+        </p:cxnSp>
+      </p:grpSp>
+      <p:grpSp>
+        <p:nvGrpSpPr>
+          <p:cNvPr id="4" name="Group 3">
+            <a:extLst>
+              <a:ext uri="{FF2B5EF4-FFF2-40B4-BE49-F238E27FC236}">
+                <a16:creationId xmlns:a16="http://schemas.microsoft.com/office/drawing/2014/main" id="{6474BA31-B4C5-F171-224E-FD74DAEFC792}"/>
+              </a:ext>
+            </a:extLst>
+          </p:cNvPr>
+          <p:cNvGrpSpPr/>
+          <p:nvPr/>
+        </p:nvGrpSpPr>
+        <p:grpSpPr>
+          <a:xfrm>
+            <a:off x="5059102" y="2193923"/>
+            <a:ext cx="2295397" cy="353943"/>
+            <a:chOff x="6485106" y="4913563"/>
+            <a:chExt cx="2295397" cy="353943"/>
+          </a:xfrm>
+        </p:grpSpPr>
+        <p:sp>
+          <p:nvSpPr>
+            <p:cNvPr id="6" name="TextBox 5">
+              <a:extLst>
+                <a:ext uri="{FF2B5EF4-FFF2-40B4-BE49-F238E27FC236}">
+                  <a16:creationId xmlns:a16="http://schemas.microsoft.com/office/drawing/2014/main" id="{601CF530-34EA-5EAD-2ECF-3E4F33DB1A6A}"/>
+                </a:ext>
+              </a:extLst>
+            </p:cNvPr>
+            <p:cNvSpPr txBox="1"/>
+            <p:nvPr/>
+          </p:nvSpPr>
+          <p:spPr>
+            <a:xfrm>
+              <a:off x="7309395" y="4913563"/>
+              <a:ext cx="1471108" cy="353943"/>
+            </a:xfrm>
+            <a:prstGeom prst="rect">
+              <a:avLst/>
+            </a:prstGeom>
+            <a:noFill/>
+          </p:spPr>
+          <p:txBody>
+            <a:bodyPr wrap="none" rtlCol="0">
+              <a:spAutoFit/>
+            </a:bodyPr>
+            <a:lstStyle/>
+            <a:p>
+              <a:r>
+                <a:rPr lang="en-US" sz="1700" b="1" dirty="0">
+                  <a:solidFill>
+                    <a:srgbClr val="FF2500"/>
+                  </a:solidFill>
+                </a:rPr>
+                <a:t>Types mixtes</a:t>
+              </a:r>
+              <a:endParaRPr lang="fr-CA" b="1" dirty="0">
+                <a:latin typeface="Consolas" panose="020B0609020204030204" pitchFamily="49" charset="0"/>
+              </a:endParaRPr>
+            </a:p>
+          </p:txBody>
+        </p:sp>
+        <p:cxnSp>
+          <p:nvCxnSpPr>
+            <p:cNvPr id="7" name="Straight Arrow Connector 6">
+              <a:extLst>
+                <a:ext uri="{FF2B5EF4-FFF2-40B4-BE49-F238E27FC236}">
+                  <a16:creationId xmlns:a16="http://schemas.microsoft.com/office/drawing/2014/main" id="{0C29FA7A-D0D1-1BD3-7B72-EAEED2095DCD}"/>
+                </a:ext>
+              </a:extLst>
+            </p:cNvPr>
+            <p:cNvCxnSpPr>
+              <a:cxnSpLocks/>
+            </p:cNvCxnSpPr>
+            <p:nvPr/>
+          </p:nvCxnSpPr>
+          <p:spPr>
+            <a:xfrm flipH="1">
+              <a:off x="6485106" y="5098230"/>
+              <a:ext cx="810000" cy="0"/>
             </a:xfrm>
             <a:prstGeom prst="straightConnector1">
               <a:avLst/>
@@ -8020,6 +8114,59 @@
                       </p:childTnLst>
                     </p:cTn>
                   </p:par>
+                  <p:par>
+                    <p:cTn id="73" fill="hold">
+                      <p:stCondLst>
+                        <p:cond delay="indefinite"/>
+                      </p:stCondLst>
+                      <p:childTnLst>
+                        <p:par>
+                          <p:cTn id="74" fill="hold">
+                            <p:stCondLst>
+                              <p:cond delay="0"/>
+                            </p:stCondLst>
+                            <p:childTnLst>
+                              <p:par>
+                                <p:cTn id="75" presetID="10" presetClass="entr" presetSubtype="0" fill="hold" nodeType="clickEffect">
+                                  <p:stCondLst>
+                                    <p:cond delay="0"/>
+                                  </p:stCondLst>
+                                  <p:childTnLst>
+                                    <p:set>
+                                      <p:cBhvr>
+                                        <p:cTn id="76" dur="1" fill="hold">
+                                          <p:stCondLst>
+                                            <p:cond delay="0"/>
+                                          </p:stCondLst>
+                                        </p:cTn>
+                                        <p:tgtEl>
+                                          <p:spTgt spid="4"/>
+                                        </p:tgtEl>
+                                        <p:attrNameLst>
+                                          <p:attrName>style.visibility</p:attrName>
+                                        </p:attrNameLst>
+                                      </p:cBhvr>
+                                      <p:to>
+                                        <p:strVal val="visible"/>
+                                      </p:to>
+                                    </p:set>
+                                    <p:animEffect transition="in" filter="fade">
+                                      <p:cBhvr>
+                                        <p:cTn id="77" dur="500"/>
+                                        <p:tgtEl>
+                                          <p:spTgt spid="4"/>
+                                        </p:tgtEl>
+                                      </p:cBhvr>
+                                    </p:animEffect>
+                                  </p:childTnLst>
+                                </p:cTn>
+                              </p:par>
+                            </p:childTnLst>
+                          </p:cTn>
+                        </p:par>
+                      </p:childTnLst>
+                    </p:cTn>
+                  </p:par>
                 </p:childTnLst>
               </p:cTn>
               <p:prevCondLst>
@@ -8046,6 +8193,1659 @@
 </file>
 
 <file path=ppt/slides/slide15.xml><?xml version="1.0" encoding="utf-8"?>
+<p:sld xmlns:a="http://schemas.openxmlformats.org/drawingml/2006/main" xmlns:r="http://schemas.openxmlformats.org/officeDocument/2006/relationships" xmlns:p="http://schemas.openxmlformats.org/presentationml/2006/main">
+  <p:cSld>
+    <p:bg>
+      <p:bgPr>
+        <a:solidFill>
+          <a:srgbClr val="F5F5F5"/>
+        </a:solidFill>
+        <a:effectLst/>
+      </p:bgPr>
+    </p:bg>
+    <p:spTree>
+      <p:nvGrpSpPr>
+        <p:cNvPr id="1" name="">
+          <a:extLst>
+            <a:ext uri="{FF2B5EF4-FFF2-40B4-BE49-F238E27FC236}">
+              <a16:creationId xmlns:a16="http://schemas.microsoft.com/office/drawing/2014/main" id="{78438212-5310-2749-2206-42D2B2131423}"/>
+            </a:ext>
+          </a:extLst>
+        </p:cNvPr>
+        <p:cNvGrpSpPr/>
+        <p:nvPr/>
+      </p:nvGrpSpPr>
+      <p:grpSpPr>
+        <a:xfrm>
+          <a:off x="0" y="0"/>
+          <a:ext cx="0" cy="0"/>
+          <a:chOff x="0" y="0"/>
+          <a:chExt cx="0" cy="0"/>
+        </a:xfrm>
+      </p:grpSpPr>
+      <p:sp>
+        <p:nvSpPr>
+          <p:cNvPr id="2" name="Title 1">
+            <a:extLst>
+              <a:ext uri="{FF2B5EF4-FFF2-40B4-BE49-F238E27FC236}">
+                <a16:creationId xmlns:a16="http://schemas.microsoft.com/office/drawing/2014/main" id="{57D0FA24-9B43-CE1E-2E4E-B59484B61796}"/>
+              </a:ext>
+            </a:extLst>
+          </p:cNvPr>
+          <p:cNvSpPr>
+            <a:spLocks noGrp="1"/>
+          </p:cNvSpPr>
+          <p:nvPr>
+            <p:ph type="title"/>
+          </p:nvPr>
+        </p:nvSpPr>
+        <p:spPr/>
+        <p:txBody>
+          <a:bodyPr/>
+          <a:lstStyle/>
+          <a:p>
+            <a:r>
+              <a:rPr lang="en-US" dirty="0">
+                <a:latin typeface="Arial Rounded MT Bold" panose="020F0704030504030204" pitchFamily="34" charset="0"/>
+              </a:rPr>
+              <a:t>Les </a:t>
+            </a:r>
+            <a:r>
+              <a:rPr lang="en-US" dirty="0" err="1">
+                <a:latin typeface="Arial Rounded MT Bold" panose="020F0704030504030204" pitchFamily="34" charset="0"/>
+              </a:rPr>
+              <a:t>listes</a:t>
+            </a:r>
+            <a:endParaRPr lang="fr-CA" dirty="0">
+              <a:latin typeface="Arial Rounded MT Bold" panose="020F0704030504030204" pitchFamily="34" charset="0"/>
+            </a:endParaRPr>
+          </a:p>
+        </p:txBody>
+      </p:sp>
+      <p:sp>
+        <p:nvSpPr>
+          <p:cNvPr id="3" name="Content Placeholder 2">
+            <a:extLst>
+              <a:ext uri="{FF2B5EF4-FFF2-40B4-BE49-F238E27FC236}">
+                <a16:creationId xmlns:a16="http://schemas.microsoft.com/office/drawing/2014/main" id="{75EE0030-DC38-6FE1-80CF-22E6F47E8DC8}"/>
+              </a:ext>
+            </a:extLst>
+          </p:cNvPr>
+          <p:cNvSpPr>
+            <a:spLocks noGrp="1"/>
+          </p:cNvSpPr>
+          <p:nvPr>
+            <p:ph idx="1"/>
+          </p:nvPr>
+        </p:nvSpPr>
+        <p:spPr/>
+        <p:txBody>
+          <a:bodyPr>
+            <a:normAutofit/>
+          </a:bodyPr>
+          <a:lstStyle/>
+          <a:p>
+            <a:pPr algn="just">
+              <a:lnSpc>
+                <a:spcPct val="100000"/>
+              </a:lnSpc>
+            </a:pPr>
+            <a:r>
+              <a:rPr lang="fr-CA" sz="1900" dirty="0">
+                <a:latin typeface="Consolas" panose="020B0609020204030204" pitchFamily="49" charset="0"/>
+              </a:rPr>
+              <a:t>En gros</a:t>
+            </a:r>
+            <a:r>
+              <a:rPr lang="fr-CA" sz="2000" dirty="0">
+                <a:latin typeface="Consolas" panose="020B0609020204030204" pitchFamily="49" charset="0"/>
+              </a:rPr>
+              <a:t>, ce sont des "</a:t>
+            </a:r>
+            <a:r>
+              <a:rPr lang="fr-CA" sz="2000" b="1" dirty="0">
+                <a:latin typeface="Consolas" panose="020B0609020204030204" pitchFamily="49" charset="0"/>
+              </a:rPr>
+              <a:t>tuples modifiables</a:t>
+            </a:r>
+            <a:r>
+              <a:rPr lang="fr-CA" sz="2000" dirty="0">
+                <a:latin typeface="Consolas" panose="020B0609020204030204" pitchFamily="49" charset="0"/>
+              </a:rPr>
+              <a:t>"</a:t>
+            </a:r>
+          </a:p>
+          <a:p>
+            <a:pPr marL="0" indent="0" algn="just">
+              <a:lnSpc>
+                <a:spcPct val="120000"/>
+              </a:lnSpc>
+              <a:buNone/>
+            </a:pPr>
+            <a:endParaRPr lang="fr-CA" sz="100" dirty="0">
+              <a:latin typeface="Consolas" panose="020B0609020204030204" pitchFamily="49" charset="0"/>
+            </a:endParaRPr>
+          </a:p>
+          <a:p>
+            <a:pPr marL="457200" lvl="1" indent="0" algn="just">
+              <a:lnSpc>
+                <a:spcPct val="100000"/>
+              </a:lnSpc>
+              <a:buNone/>
+            </a:pPr>
+            <a:r>
+              <a:rPr lang="en-CA" sz="2000" b="1" dirty="0">
+                <a:latin typeface="Consolas" panose="020B0609020204030204" pitchFamily="49" charset="0"/>
+              </a:rPr>
+              <a:t>&gt;&gt;&gt; </a:t>
+            </a:r>
+            <a:r>
+              <a:rPr lang="en-CA" sz="2000" b="1" dirty="0" err="1">
+                <a:latin typeface="Consolas" panose="020B0609020204030204" pitchFamily="49" charset="0"/>
+              </a:rPr>
+              <a:t>une_liste</a:t>
+            </a:r>
+            <a:r>
+              <a:rPr lang="en-CA" sz="2000" b="1" dirty="0">
+                <a:latin typeface="Consolas" panose="020B0609020204030204" pitchFamily="49" charset="0"/>
+              </a:rPr>
+              <a:t> = [1, 2, 3, 4]</a:t>
+            </a:r>
+            <a:endParaRPr lang="fr-CA" sz="2000" b="1" dirty="0">
+              <a:latin typeface="Consolas" panose="020B0609020204030204" pitchFamily="49" charset="0"/>
+            </a:endParaRPr>
+          </a:p>
+          <a:p>
+            <a:pPr marL="457200" lvl="1" indent="0" algn="just">
+              <a:lnSpc>
+                <a:spcPct val="100000"/>
+              </a:lnSpc>
+              <a:buNone/>
+            </a:pPr>
+            <a:r>
+              <a:rPr lang="fr-CA" sz="2000" b="1" dirty="0">
+                <a:latin typeface="Consolas" panose="020B0609020204030204" pitchFamily="49" charset="0"/>
+              </a:rPr>
+              <a:t>&gt;&gt;&gt; </a:t>
+            </a:r>
+            <a:r>
+              <a:rPr lang="fr-CA" sz="2000" b="1" dirty="0" err="1">
+                <a:latin typeface="Consolas" panose="020B0609020204030204" pitchFamily="49" charset="0"/>
+              </a:rPr>
+              <a:t>une_liste</a:t>
+            </a:r>
+            <a:r>
+              <a:rPr lang="fr-CA" sz="2000" b="1" dirty="0">
+                <a:latin typeface="Consolas" panose="020B0609020204030204" pitchFamily="49" charset="0"/>
+              </a:rPr>
+              <a:t>[0] = None</a:t>
+            </a:r>
+          </a:p>
+          <a:p>
+            <a:pPr marL="457200" lvl="1" indent="0" algn="just">
+              <a:lnSpc>
+                <a:spcPct val="100000"/>
+              </a:lnSpc>
+              <a:buNone/>
+            </a:pPr>
+            <a:r>
+              <a:rPr lang="fr-CA" sz="2000" b="1" dirty="0">
+                <a:latin typeface="Consolas" panose="020B0609020204030204" pitchFamily="49" charset="0"/>
+              </a:rPr>
+              <a:t>&gt;&gt;&gt; </a:t>
+            </a:r>
+            <a:r>
+              <a:rPr lang="fr-CA" sz="2000" b="1" dirty="0" err="1">
+                <a:latin typeface="Consolas" panose="020B0609020204030204" pitchFamily="49" charset="0"/>
+              </a:rPr>
+              <a:t>print</a:t>
+            </a:r>
+            <a:r>
+              <a:rPr lang="fr-CA" sz="2000" b="1" dirty="0">
+                <a:latin typeface="Consolas" panose="020B0609020204030204" pitchFamily="49" charset="0"/>
+              </a:rPr>
+              <a:t>(</a:t>
+            </a:r>
+            <a:r>
+              <a:rPr lang="fr-CA" sz="2000" b="1" dirty="0" err="1">
+                <a:latin typeface="Consolas" panose="020B0609020204030204" pitchFamily="49" charset="0"/>
+              </a:rPr>
+              <a:t>une_liste</a:t>
+            </a:r>
+            <a:r>
+              <a:rPr lang="fr-CA" sz="2000" b="1" dirty="0">
+                <a:latin typeface="Consolas" panose="020B0609020204030204" pitchFamily="49" charset="0"/>
+              </a:rPr>
+              <a:t>)</a:t>
+            </a:r>
+          </a:p>
+          <a:p>
+            <a:pPr marL="457200" lvl="1" indent="0" algn="just">
+              <a:lnSpc>
+                <a:spcPct val="100000"/>
+              </a:lnSpc>
+              <a:buNone/>
+            </a:pPr>
+            <a:r>
+              <a:rPr lang="fr-CA" sz="2000" dirty="0">
+                <a:solidFill>
+                  <a:schemeClr val="bg1">
+                    <a:lumMod val="50000"/>
+                  </a:schemeClr>
+                </a:solidFill>
+                <a:latin typeface="Consolas" panose="020B0609020204030204" pitchFamily="49" charset="0"/>
+              </a:rPr>
+              <a:t>[None, 2, 3, 4]</a:t>
+            </a:r>
+          </a:p>
+          <a:p>
+            <a:pPr marL="457200" lvl="1" indent="0" algn="just">
+              <a:lnSpc>
+                <a:spcPct val="80000"/>
+              </a:lnSpc>
+              <a:buNone/>
+            </a:pPr>
+            <a:endParaRPr lang="fr-CA" sz="2000" dirty="0">
+              <a:solidFill>
+                <a:schemeClr val="bg1">
+                  <a:lumMod val="50000"/>
+                </a:schemeClr>
+              </a:solidFill>
+              <a:latin typeface="Consolas" panose="020B0609020204030204" pitchFamily="49" charset="0"/>
+            </a:endParaRPr>
+          </a:p>
+          <a:p>
+            <a:pPr marL="457200" lvl="1" indent="0" algn="just">
+              <a:lnSpc>
+                <a:spcPct val="100000"/>
+              </a:lnSpc>
+              <a:buNone/>
+            </a:pPr>
+            <a:r>
+              <a:rPr lang="en-CA" sz="2000" b="1" dirty="0">
+                <a:latin typeface="Consolas" panose="020B0609020204030204" pitchFamily="49" charset="0"/>
+              </a:rPr>
+              <a:t>&gt;&gt;&gt; </a:t>
+            </a:r>
+            <a:r>
+              <a:rPr lang="en-CA" sz="2000" b="1" dirty="0" err="1">
+                <a:latin typeface="Consolas" panose="020B0609020204030204" pitchFamily="49" charset="0"/>
+              </a:rPr>
+              <a:t>un_tuple</a:t>
+            </a:r>
+            <a:r>
+              <a:rPr lang="en-CA" sz="2000" b="1" dirty="0">
+                <a:latin typeface="Consolas" panose="020B0609020204030204" pitchFamily="49" charset="0"/>
+              </a:rPr>
+              <a:t> = (1, 2, 3, 4)</a:t>
+            </a:r>
+            <a:endParaRPr lang="fr-CA" sz="2000" b="1" dirty="0">
+              <a:latin typeface="Consolas" panose="020B0609020204030204" pitchFamily="49" charset="0"/>
+            </a:endParaRPr>
+          </a:p>
+          <a:p>
+            <a:pPr marL="457200" lvl="1" indent="0" algn="just">
+              <a:lnSpc>
+                <a:spcPct val="100000"/>
+              </a:lnSpc>
+              <a:buNone/>
+            </a:pPr>
+            <a:r>
+              <a:rPr lang="fr-CA" sz="2000" b="1" dirty="0">
+                <a:latin typeface="Consolas" panose="020B0609020204030204" pitchFamily="49" charset="0"/>
+              </a:rPr>
+              <a:t>&gt;&gt;&gt; </a:t>
+            </a:r>
+            <a:r>
+              <a:rPr lang="fr-CA" sz="2000" b="1" dirty="0" err="1">
+                <a:latin typeface="Consolas" panose="020B0609020204030204" pitchFamily="49" charset="0"/>
+              </a:rPr>
+              <a:t>un_tuple</a:t>
+            </a:r>
+            <a:r>
+              <a:rPr lang="fr-CA" sz="2000" b="1" dirty="0">
+                <a:latin typeface="Consolas" panose="020B0609020204030204" pitchFamily="49" charset="0"/>
+              </a:rPr>
+              <a:t>[0] = None</a:t>
+            </a:r>
+          </a:p>
+          <a:p>
+            <a:pPr marL="457200" lvl="1" indent="0" algn="just">
+              <a:lnSpc>
+                <a:spcPct val="100000"/>
+              </a:lnSpc>
+              <a:buNone/>
+            </a:pPr>
+            <a:r>
+              <a:rPr lang="en-US" sz="2000" dirty="0" err="1">
+                <a:solidFill>
+                  <a:schemeClr val="bg1">
+                    <a:lumMod val="50000"/>
+                  </a:schemeClr>
+                </a:solidFill>
+                <a:latin typeface="Consolas" panose="020B0609020204030204" pitchFamily="49" charset="0"/>
+              </a:rPr>
+              <a:t>TypeError</a:t>
+            </a:r>
+            <a:r>
+              <a:rPr lang="en-US" sz="2000" dirty="0">
+                <a:solidFill>
+                  <a:schemeClr val="bg1">
+                    <a:lumMod val="50000"/>
+                  </a:schemeClr>
+                </a:solidFill>
+                <a:latin typeface="Consolas" panose="020B0609020204030204" pitchFamily="49" charset="0"/>
+              </a:rPr>
+              <a:t>: 'tuple' object </a:t>
+            </a:r>
+            <a:r>
+              <a:rPr lang="en-US" sz="2000" dirty="0">
+                <a:solidFill>
+                  <a:srgbClr val="FF2500"/>
+                </a:solidFill>
+                <a:latin typeface="Consolas" panose="020B0609020204030204" pitchFamily="49" charset="0"/>
+              </a:rPr>
+              <a:t>does not support item assignment</a:t>
+            </a:r>
+            <a:endParaRPr lang="fr-CA" sz="2000" dirty="0">
+              <a:solidFill>
+                <a:srgbClr val="FF2500"/>
+              </a:solidFill>
+              <a:latin typeface="Consolas" panose="020B0609020204030204" pitchFamily="49" charset="0"/>
+            </a:endParaRPr>
+          </a:p>
+        </p:txBody>
+      </p:sp>
+      <p:sp>
+        <p:nvSpPr>
+          <p:cNvPr id="5" name="Slide Number Placeholder 4">
+            <a:extLst>
+              <a:ext uri="{FF2B5EF4-FFF2-40B4-BE49-F238E27FC236}">
+                <a16:creationId xmlns:a16="http://schemas.microsoft.com/office/drawing/2014/main" id="{B9EA5889-0719-DE66-F837-22CFBC5A60E9}"/>
+              </a:ext>
+            </a:extLst>
+          </p:cNvPr>
+          <p:cNvSpPr>
+            <a:spLocks noGrp="1"/>
+          </p:cNvSpPr>
+          <p:nvPr>
+            <p:ph type="sldNum" sz="quarter" idx="12"/>
+          </p:nvPr>
+        </p:nvSpPr>
+        <p:spPr/>
+        <p:txBody>
+          <a:bodyPr/>
+          <a:lstStyle/>
+          <a:p>
+            <a:fld id="{846B06B1-1179-491F-A487-8E0C403F7C13}" type="slidenum">
+              <a:rPr lang="fr-CA" smtClean="0"/>
+              <a:t>15</a:t>
+            </a:fld>
+            <a:endParaRPr lang="fr-CA"/>
+          </a:p>
+        </p:txBody>
+      </p:sp>
+    </p:spTree>
+    <p:extLst>
+      <p:ext uri="{BB962C8B-B14F-4D97-AF65-F5344CB8AC3E}">
+        <p14:creationId xmlns:p14="http://schemas.microsoft.com/office/powerpoint/2010/main" val="1332705739"/>
+      </p:ext>
+    </p:extLst>
+  </p:cSld>
+  <p:clrMapOvr>
+    <a:masterClrMapping/>
+  </p:clrMapOvr>
+  <p:timing>
+    <p:tnLst>
+      <p:par>
+        <p:cTn id="1" dur="indefinite" restart="never" nodeType="tmRoot">
+          <p:childTnLst>
+            <p:seq concurrent="1" nextAc="seek">
+              <p:cTn id="2" dur="indefinite" nodeType="mainSeq">
+                <p:childTnLst>
+                  <p:par>
+                    <p:cTn id="3" fill="hold">
+                      <p:stCondLst>
+                        <p:cond delay="indefinite"/>
+                      </p:stCondLst>
+                      <p:childTnLst>
+                        <p:par>
+                          <p:cTn id="4" fill="hold">
+                            <p:stCondLst>
+                              <p:cond delay="0"/>
+                            </p:stCondLst>
+                            <p:childTnLst>
+                              <p:par>
+                                <p:cTn id="5" presetID="10" presetClass="entr" presetSubtype="0" fill="hold" nodeType="clickEffect">
+                                  <p:stCondLst>
+                                    <p:cond delay="0"/>
+                                  </p:stCondLst>
+                                  <p:childTnLst>
+                                    <p:set>
+                                      <p:cBhvr>
+                                        <p:cTn id="6" dur="1" fill="hold">
+                                          <p:stCondLst>
+                                            <p:cond delay="0"/>
+                                          </p:stCondLst>
+                                        </p:cTn>
+                                        <p:tgtEl>
+                                          <p:spTgt spid="3">
+                                            <p:txEl>
+                                              <p:pRg st="0" end="0"/>
+                                            </p:txEl>
+                                          </p:spTgt>
+                                        </p:tgtEl>
+                                        <p:attrNameLst>
+                                          <p:attrName>style.visibility</p:attrName>
+                                        </p:attrNameLst>
+                                      </p:cBhvr>
+                                      <p:to>
+                                        <p:strVal val="visible"/>
+                                      </p:to>
+                                    </p:set>
+                                    <p:animEffect transition="in" filter="fade">
+                                      <p:cBhvr>
+                                        <p:cTn id="7" dur="500"/>
+                                        <p:tgtEl>
+                                          <p:spTgt spid="3">
+                                            <p:txEl>
+                                              <p:pRg st="0" end="0"/>
+                                            </p:txEl>
+                                          </p:spTgt>
+                                        </p:tgtEl>
+                                      </p:cBhvr>
+                                    </p:animEffect>
+                                  </p:childTnLst>
+                                </p:cTn>
+                              </p:par>
+                            </p:childTnLst>
+                          </p:cTn>
+                        </p:par>
+                      </p:childTnLst>
+                    </p:cTn>
+                  </p:par>
+                  <p:par>
+                    <p:cTn id="8" fill="hold">
+                      <p:stCondLst>
+                        <p:cond delay="indefinite"/>
+                      </p:stCondLst>
+                      <p:childTnLst>
+                        <p:par>
+                          <p:cTn id="9" fill="hold">
+                            <p:stCondLst>
+                              <p:cond delay="0"/>
+                            </p:stCondLst>
+                            <p:childTnLst>
+                              <p:par>
+                                <p:cTn id="10" presetID="10" presetClass="entr" presetSubtype="0" fill="hold" nodeType="clickEffect">
+                                  <p:stCondLst>
+                                    <p:cond delay="0"/>
+                                  </p:stCondLst>
+                                  <p:childTnLst>
+                                    <p:set>
+                                      <p:cBhvr>
+                                        <p:cTn id="11" dur="1" fill="hold">
+                                          <p:stCondLst>
+                                            <p:cond delay="0"/>
+                                          </p:stCondLst>
+                                        </p:cTn>
+                                        <p:tgtEl>
+                                          <p:spTgt spid="3">
+                                            <p:txEl>
+                                              <p:pRg st="2" end="2"/>
+                                            </p:txEl>
+                                          </p:spTgt>
+                                        </p:tgtEl>
+                                        <p:attrNameLst>
+                                          <p:attrName>style.visibility</p:attrName>
+                                        </p:attrNameLst>
+                                      </p:cBhvr>
+                                      <p:to>
+                                        <p:strVal val="visible"/>
+                                      </p:to>
+                                    </p:set>
+                                    <p:animEffect transition="in" filter="fade">
+                                      <p:cBhvr>
+                                        <p:cTn id="12" dur="500"/>
+                                        <p:tgtEl>
+                                          <p:spTgt spid="3">
+                                            <p:txEl>
+                                              <p:pRg st="2" end="2"/>
+                                            </p:txEl>
+                                          </p:spTgt>
+                                        </p:tgtEl>
+                                      </p:cBhvr>
+                                    </p:animEffect>
+                                  </p:childTnLst>
+                                </p:cTn>
+                              </p:par>
+                            </p:childTnLst>
+                          </p:cTn>
+                        </p:par>
+                      </p:childTnLst>
+                    </p:cTn>
+                  </p:par>
+                  <p:par>
+                    <p:cTn id="13" fill="hold">
+                      <p:stCondLst>
+                        <p:cond delay="indefinite"/>
+                      </p:stCondLst>
+                      <p:childTnLst>
+                        <p:par>
+                          <p:cTn id="14" fill="hold">
+                            <p:stCondLst>
+                              <p:cond delay="0"/>
+                            </p:stCondLst>
+                            <p:childTnLst>
+                              <p:par>
+                                <p:cTn id="15" presetID="10" presetClass="entr" presetSubtype="0" fill="hold" nodeType="clickEffect">
+                                  <p:stCondLst>
+                                    <p:cond delay="0"/>
+                                  </p:stCondLst>
+                                  <p:childTnLst>
+                                    <p:set>
+                                      <p:cBhvr>
+                                        <p:cTn id="16" dur="1" fill="hold">
+                                          <p:stCondLst>
+                                            <p:cond delay="0"/>
+                                          </p:stCondLst>
+                                        </p:cTn>
+                                        <p:tgtEl>
+                                          <p:spTgt spid="3">
+                                            <p:txEl>
+                                              <p:pRg st="3" end="3"/>
+                                            </p:txEl>
+                                          </p:spTgt>
+                                        </p:tgtEl>
+                                        <p:attrNameLst>
+                                          <p:attrName>style.visibility</p:attrName>
+                                        </p:attrNameLst>
+                                      </p:cBhvr>
+                                      <p:to>
+                                        <p:strVal val="visible"/>
+                                      </p:to>
+                                    </p:set>
+                                    <p:animEffect transition="in" filter="fade">
+                                      <p:cBhvr>
+                                        <p:cTn id="17" dur="500"/>
+                                        <p:tgtEl>
+                                          <p:spTgt spid="3">
+                                            <p:txEl>
+                                              <p:pRg st="3" end="3"/>
+                                            </p:txEl>
+                                          </p:spTgt>
+                                        </p:tgtEl>
+                                      </p:cBhvr>
+                                    </p:animEffect>
+                                  </p:childTnLst>
+                                </p:cTn>
+                              </p:par>
+                            </p:childTnLst>
+                          </p:cTn>
+                        </p:par>
+                      </p:childTnLst>
+                    </p:cTn>
+                  </p:par>
+                  <p:par>
+                    <p:cTn id="18" fill="hold">
+                      <p:stCondLst>
+                        <p:cond delay="indefinite"/>
+                      </p:stCondLst>
+                      <p:childTnLst>
+                        <p:par>
+                          <p:cTn id="19" fill="hold">
+                            <p:stCondLst>
+                              <p:cond delay="0"/>
+                            </p:stCondLst>
+                            <p:childTnLst>
+                              <p:par>
+                                <p:cTn id="20" presetID="10" presetClass="entr" presetSubtype="0" fill="hold" nodeType="clickEffect">
+                                  <p:stCondLst>
+                                    <p:cond delay="0"/>
+                                  </p:stCondLst>
+                                  <p:childTnLst>
+                                    <p:set>
+                                      <p:cBhvr>
+                                        <p:cTn id="21" dur="1" fill="hold">
+                                          <p:stCondLst>
+                                            <p:cond delay="0"/>
+                                          </p:stCondLst>
+                                        </p:cTn>
+                                        <p:tgtEl>
+                                          <p:spTgt spid="3">
+                                            <p:txEl>
+                                              <p:pRg st="4" end="4"/>
+                                            </p:txEl>
+                                          </p:spTgt>
+                                        </p:tgtEl>
+                                        <p:attrNameLst>
+                                          <p:attrName>style.visibility</p:attrName>
+                                        </p:attrNameLst>
+                                      </p:cBhvr>
+                                      <p:to>
+                                        <p:strVal val="visible"/>
+                                      </p:to>
+                                    </p:set>
+                                    <p:animEffect transition="in" filter="fade">
+                                      <p:cBhvr>
+                                        <p:cTn id="22" dur="500"/>
+                                        <p:tgtEl>
+                                          <p:spTgt spid="3">
+                                            <p:txEl>
+                                              <p:pRg st="4" end="4"/>
+                                            </p:txEl>
+                                          </p:spTgt>
+                                        </p:tgtEl>
+                                      </p:cBhvr>
+                                    </p:animEffect>
+                                  </p:childTnLst>
+                                </p:cTn>
+                              </p:par>
+                            </p:childTnLst>
+                          </p:cTn>
+                        </p:par>
+                      </p:childTnLst>
+                    </p:cTn>
+                  </p:par>
+                  <p:par>
+                    <p:cTn id="23" fill="hold">
+                      <p:stCondLst>
+                        <p:cond delay="indefinite"/>
+                      </p:stCondLst>
+                      <p:childTnLst>
+                        <p:par>
+                          <p:cTn id="24" fill="hold">
+                            <p:stCondLst>
+                              <p:cond delay="0"/>
+                            </p:stCondLst>
+                            <p:childTnLst>
+                              <p:par>
+                                <p:cTn id="25" presetID="10" presetClass="entr" presetSubtype="0" fill="hold" nodeType="clickEffect">
+                                  <p:stCondLst>
+                                    <p:cond delay="0"/>
+                                  </p:stCondLst>
+                                  <p:childTnLst>
+                                    <p:set>
+                                      <p:cBhvr>
+                                        <p:cTn id="26" dur="1" fill="hold">
+                                          <p:stCondLst>
+                                            <p:cond delay="0"/>
+                                          </p:stCondLst>
+                                        </p:cTn>
+                                        <p:tgtEl>
+                                          <p:spTgt spid="3">
+                                            <p:txEl>
+                                              <p:pRg st="5" end="5"/>
+                                            </p:txEl>
+                                          </p:spTgt>
+                                        </p:tgtEl>
+                                        <p:attrNameLst>
+                                          <p:attrName>style.visibility</p:attrName>
+                                        </p:attrNameLst>
+                                      </p:cBhvr>
+                                      <p:to>
+                                        <p:strVal val="visible"/>
+                                      </p:to>
+                                    </p:set>
+                                    <p:animEffect transition="in" filter="fade">
+                                      <p:cBhvr>
+                                        <p:cTn id="27" dur="500"/>
+                                        <p:tgtEl>
+                                          <p:spTgt spid="3">
+                                            <p:txEl>
+                                              <p:pRg st="5" end="5"/>
+                                            </p:txEl>
+                                          </p:spTgt>
+                                        </p:tgtEl>
+                                      </p:cBhvr>
+                                    </p:animEffect>
+                                  </p:childTnLst>
+                                </p:cTn>
+                              </p:par>
+                            </p:childTnLst>
+                          </p:cTn>
+                        </p:par>
+                      </p:childTnLst>
+                    </p:cTn>
+                  </p:par>
+                </p:childTnLst>
+              </p:cTn>
+              <p:prevCondLst>
+                <p:cond evt="onPrev" delay="0">
+                  <p:tgtEl>
+                    <p:sldTgt/>
+                  </p:tgtEl>
+                </p:cond>
+              </p:prevCondLst>
+              <p:nextCondLst>
+                <p:cond evt="onNext" delay="0">
+                  <p:tgtEl>
+                    <p:sldTgt/>
+                  </p:tgtEl>
+                </p:cond>
+              </p:nextCondLst>
+            </p:seq>
+          </p:childTnLst>
+        </p:cTn>
+      </p:par>
+    </p:tnLst>
+  </p:timing>
+</p:sld>
+</file>
+
+<file path=ppt/slides/slide16.xml><?xml version="1.0" encoding="utf-8"?>
+<p:sld xmlns:a="http://schemas.openxmlformats.org/drawingml/2006/main" xmlns:r="http://schemas.openxmlformats.org/officeDocument/2006/relationships" xmlns:p="http://schemas.openxmlformats.org/presentationml/2006/main">
+  <p:cSld>
+    <p:bg>
+      <p:bgPr>
+        <a:solidFill>
+          <a:srgbClr val="F5F5F5"/>
+        </a:solidFill>
+        <a:effectLst/>
+      </p:bgPr>
+    </p:bg>
+    <p:spTree>
+      <p:nvGrpSpPr>
+        <p:cNvPr id="1" name="">
+          <a:extLst>
+            <a:ext uri="{FF2B5EF4-FFF2-40B4-BE49-F238E27FC236}">
+              <a16:creationId xmlns:a16="http://schemas.microsoft.com/office/drawing/2014/main" id="{0182197A-1E9B-21F5-CB57-176B776DF794}"/>
+            </a:ext>
+          </a:extLst>
+        </p:cNvPr>
+        <p:cNvGrpSpPr/>
+        <p:nvPr/>
+      </p:nvGrpSpPr>
+      <p:grpSpPr>
+        <a:xfrm>
+          <a:off x="0" y="0"/>
+          <a:ext cx="0" cy="0"/>
+          <a:chOff x="0" y="0"/>
+          <a:chExt cx="0" cy="0"/>
+        </a:xfrm>
+      </p:grpSpPr>
+      <p:sp>
+        <p:nvSpPr>
+          <p:cNvPr id="2" name="Title 1">
+            <a:extLst>
+              <a:ext uri="{FF2B5EF4-FFF2-40B4-BE49-F238E27FC236}">
+                <a16:creationId xmlns:a16="http://schemas.microsoft.com/office/drawing/2014/main" id="{17B189F4-6E75-E6B6-49F8-8589F45CA874}"/>
+              </a:ext>
+            </a:extLst>
+          </p:cNvPr>
+          <p:cNvSpPr>
+            <a:spLocks noGrp="1"/>
+          </p:cNvSpPr>
+          <p:nvPr>
+            <p:ph type="title"/>
+          </p:nvPr>
+        </p:nvSpPr>
+        <p:spPr/>
+        <p:txBody>
+          <a:bodyPr/>
+          <a:lstStyle/>
+          <a:p>
+            <a:r>
+              <a:rPr lang="en-US" dirty="0">
+                <a:latin typeface="Arial Rounded MT Bold" panose="020F0704030504030204" pitchFamily="34" charset="0"/>
+              </a:rPr>
+              <a:t>Tuple </a:t>
+            </a:r>
+            <a:r>
+              <a:rPr lang="en-US" dirty="0" err="1">
+                <a:latin typeface="Arial Rounded MT Bold" panose="020F0704030504030204" pitchFamily="34" charset="0"/>
+              </a:rPr>
+              <a:t>ou</a:t>
+            </a:r>
+            <a:r>
+              <a:rPr lang="en-US" dirty="0">
+                <a:latin typeface="Arial Rounded MT Bold" panose="020F0704030504030204" pitchFamily="34" charset="0"/>
+              </a:rPr>
+              <a:t> </a:t>
+            </a:r>
+            <a:r>
+              <a:rPr lang="en-US" dirty="0" err="1">
+                <a:latin typeface="Arial Rounded MT Bold" panose="020F0704030504030204" pitchFamily="34" charset="0"/>
+              </a:rPr>
+              <a:t>liste</a:t>
+            </a:r>
+            <a:r>
+              <a:rPr lang="en-US" dirty="0">
+                <a:latin typeface="Arial Rounded MT Bold" panose="020F0704030504030204" pitchFamily="34" charset="0"/>
+              </a:rPr>
+              <a:t>?</a:t>
+            </a:r>
+            <a:endParaRPr lang="fr-CA" dirty="0">
+              <a:latin typeface="Arial Rounded MT Bold" panose="020F0704030504030204" pitchFamily="34" charset="0"/>
+            </a:endParaRPr>
+          </a:p>
+        </p:txBody>
+      </p:sp>
+      <p:sp>
+        <p:nvSpPr>
+          <p:cNvPr id="3" name="Content Placeholder 2">
+            <a:extLst>
+              <a:ext uri="{FF2B5EF4-FFF2-40B4-BE49-F238E27FC236}">
+                <a16:creationId xmlns:a16="http://schemas.microsoft.com/office/drawing/2014/main" id="{3750EA3B-2CD3-F651-1AD6-B37B7FBCD3EC}"/>
+              </a:ext>
+            </a:extLst>
+          </p:cNvPr>
+          <p:cNvSpPr>
+            <a:spLocks noGrp="1"/>
+          </p:cNvSpPr>
+          <p:nvPr>
+            <p:ph idx="1"/>
+          </p:nvPr>
+        </p:nvSpPr>
+        <p:spPr/>
+        <p:txBody>
+          <a:bodyPr>
+            <a:normAutofit/>
+          </a:bodyPr>
+          <a:lstStyle/>
+          <a:p>
+            <a:pPr marL="0" indent="0" algn="just">
+              <a:lnSpc>
+                <a:spcPct val="150000"/>
+              </a:lnSpc>
+              <a:buNone/>
+            </a:pPr>
+            <a:r>
+              <a:rPr lang="en-US" sz="1900" dirty="0">
+                <a:latin typeface="Consolas" panose="020B0609020204030204" pitchFamily="49" charset="0"/>
+              </a:rPr>
+              <a:t>Une question de ...</a:t>
+            </a:r>
+          </a:p>
+          <a:p>
+            <a:pPr lvl="1" algn="just">
+              <a:lnSpc>
+                <a:spcPct val="150000"/>
+              </a:lnSpc>
+            </a:pPr>
+            <a:r>
+              <a:rPr lang="en-US" sz="1800" b="1" dirty="0" err="1">
+                <a:latin typeface="Consolas" panose="020B0609020204030204" pitchFamily="49" charset="0"/>
+              </a:rPr>
+              <a:t>Clarté</a:t>
+            </a:r>
+            <a:r>
+              <a:rPr lang="en-US" sz="1800" b="1" dirty="0">
+                <a:latin typeface="Consolas" panose="020B0609020204030204" pitchFamily="49" charset="0"/>
+              </a:rPr>
+              <a:t> </a:t>
+            </a:r>
+            <a:r>
+              <a:rPr lang="en-US" sz="1800" b="1" dirty="0" err="1">
+                <a:latin typeface="Consolas" panose="020B0609020204030204" pitchFamily="49" charset="0"/>
+              </a:rPr>
+              <a:t>sémantique</a:t>
+            </a:r>
+            <a:r>
+              <a:rPr lang="en-US" sz="1800" dirty="0">
+                <a:latin typeface="Consolas" panose="020B0609020204030204" pitchFamily="49" charset="0"/>
+              </a:rPr>
+              <a:t>: </a:t>
+            </a:r>
+            <a:r>
+              <a:rPr lang="en-US" sz="1800" dirty="0" err="1">
+                <a:latin typeface="Consolas" panose="020B0609020204030204" pitchFamily="49" charset="0"/>
+              </a:rPr>
+              <a:t>Signale</a:t>
+            </a:r>
+            <a:r>
+              <a:rPr lang="en-US" sz="1800" dirty="0">
+                <a:latin typeface="Consolas" panose="020B0609020204030204" pitchFamily="49" charset="0"/>
+              </a:rPr>
+              <a:t> </a:t>
+            </a:r>
+            <a:r>
+              <a:rPr lang="en-US" sz="1800" dirty="0" err="1">
+                <a:latin typeface="Consolas" panose="020B0609020204030204" pitchFamily="49" charset="0"/>
+              </a:rPr>
+              <a:t>une</a:t>
+            </a:r>
+            <a:r>
+              <a:rPr lang="en-US" sz="1800" dirty="0">
+                <a:latin typeface="Consolas" panose="020B0609020204030204" pitchFamily="49" charset="0"/>
+              </a:rPr>
+              <a:t> </a:t>
+            </a:r>
+            <a:r>
+              <a:rPr lang="en-US" sz="1800" dirty="0" err="1">
+                <a:latin typeface="Consolas" panose="020B0609020204030204" pitchFamily="49" charset="0"/>
+              </a:rPr>
+              <a:t>hypothèse</a:t>
+            </a:r>
+            <a:r>
+              <a:rPr lang="en-US" sz="1800" dirty="0">
+                <a:latin typeface="Consolas" panose="020B0609020204030204" pitchFamily="49" charset="0"/>
+              </a:rPr>
+              <a:t> </a:t>
+            </a:r>
+            <a:r>
+              <a:rPr lang="en-US" sz="1800" dirty="0" err="1">
+                <a:latin typeface="Consolas" panose="020B0609020204030204" pitchFamily="49" charset="0"/>
+              </a:rPr>
+              <a:t>importante</a:t>
+            </a:r>
+            <a:r>
+              <a:rPr lang="en-US" sz="1800" dirty="0">
+                <a:latin typeface="Consolas" panose="020B0609020204030204" pitchFamily="49" charset="0"/>
+              </a:rPr>
+              <a:t> (c.-à-d. </a:t>
+            </a:r>
+            <a:r>
+              <a:rPr lang="en-US" sz="1800" b="1" i="1" dirty="0" err="1">
+                <a:latin typeface="Consolas" panose="020B0609020204030204" pitchFamily="49" charset="0"/>
+              </a:rPr>
+              <a:t>cette</a:t>
+            </a:r>
+            <a:r>
+              <a:rPr lang="en-US" sz="1800" b="1" i="1" dirty="0">
+                <a:latin typeface="Consolas" panose="020B0609020204030204" pitchFamily="49" charset="0"/>
+              </a:rPr>
+              <a:t> </a:t>
+            </a:r>
+            <a:r>
+              <a:rPr lang="en-US" sz="1800" b="1" i="1" dirty="0" err="1">
+                <a:latin typeface="Consolas" panose="020B0609020204030204" pitchFamily="49" charset="0"/>
+              </a:rPr>
+              <a:t>valeur</a:t>
+            </a:r>
+            <a:r>
+              <a:rPr lang="en-US" sz="1800" b="1" i="1" dirty="0">
+                <a:latin typeface="Consolas" panose="020B0609020204030204" pitchFamily="49" charset="0"/>
+              </a:rPr>
+              <a:t> ne change pas</a:t>
+            </a:r>
+            <a:r>
+              <a:rPr lang="en-US" sz="1800" dirty="0">
+                <a:latin typeface="Consolas" panose="020B0609020204030204" pitchFamily="49" charset="0"/>
+              </a:rPr>
+              <a:t>)</a:t>
+            </a:r>
+            <a:endParaRPr lang="en-US" sz="1800" b="1" dirty="0">
+              <a:latin typeface="Consolas" panose="020B0609020204030204" pitchFamily="49" charset="0"/>
+            </a:endParaRPr>
+          </a:p>
+          <a:p>
+            <a:pPr lvl="1" algn="just">
+              <a:lnSpc>
+                <a:spcPct val="150000"/>
+              </a:lnSpc>
+            </a:pPr>
+            <a:r>
+              <a:rPr lang="en-US" sz="1800" b="1" dirty="0" err="1">
+                <a:latin typeface="Consolas" panose="020B0609020204030204" pitchFamily="49" charset="0"/>
+              </a:rPr>
+              <a:t>Intégrité</a:t>
+            </a:r>
+            <a:r>
+              <a:rPr lang="en-US" sz="1800" b="1" dirty="0">
+                <a:latin typeface="Consolas" panose="020B0609020204030204" pitchFamily="49" charset="0"/>
+              </a:rPr>
+              <a:t>: </a:t>
+            </a:r>
+            <a:r>
+              <a:rPr lang="en-US" sz="1800" dirty="0">
+                <a:latin typeface="Consolas" panose="020B0609020204030204" pitchFamily="49" charset="0"/>
+              </a:rPr>
+              <a:t>Plus difficile </a:t>
+            </a:r>
+            <a:r>
+              <a:rPr lang="en-US" sz="1800" dirty="0" err="1">
+                <a:latin typeface="Consolas" panose="020B0609020204030204" pitchFamily="49" charset="0"/>
+              </a:rPr>
+              <a:t>d'altérer</a:t>
+            </a:r>
+            <a:r>
+              <a:rPr lang="en-US" sz="1800" dirty="0">
+                <a:latin typeface="Consolas" panose="020B0609020204030204" pitchFamily="49" charset="0"/>
+              </a:rPr>
+              <a:t> le </a:t>
+            </a:r>
+            <a:r>
+              <a:rPr lang="en-US" sz="1800" dirty="0" err="1">
+                <a:latin typeface="Consolas" panose="020B0609020204030204" pitchFamily="49" charset="0"/>
+              </a:rPr>
+              <a:t>contenu</a:t>
+            </a:r>
+            <a:r>
+              <a:rPr lang="en-US" sz="1800" dirty="0">
+                <a:latin typeface="Consolas" panose="020B0609020204030204" pitchFamily="49" charset="0"/>
+              </a:rPr>
+              <a:t> par accident</a:t>
+            </a:r>
+            <a:endParaRPr lang="en-US" sz="1800" b="1" dirty="0">
+              <a:latin typeface="Consolas" panose="020B0609020204030204" pitchFamily="49" charset="0"/>
+            </a:endParaRPr>
+          </a:p>
+          <a:p>
+            <a:pPr lvl="1" algn="just">
+              <a:lnSpc>
+                <a:spcPct val="150000"/>
+              </a:lnSpc>
+            </a:pPr>
+            <a:r>
+              <a:rPr lang="en-US" sz="1800" b="1" dirty="0" err="1">
+                <a:latin typeface="Consolas" panose="020B0609020204030204" pitchFamily="49" charset="0"/>
+              </a:rPr>
+              <a:t>Stabilité</a:t>
+            </a:r>
+            <a:r>
+              <a:rPr lang="en-US" sz="1800" dirty="0">
+                <a:latin typeface="Consolas" panose="020B0609020204030204" pitchFamily="49" charset="0"/>
+              </a:rPr>
+              <a:t>: Plus difficile </a:t>
+            </a:r>
+            <a:r>
+              <a:rPr lang="en-US" sz="1800" dirty="0" err="1">
+                <a:latin typeface="Consolas" panose="020B0609020204030204" pitchFamily="49" charset="0"/>
+              </a:rPr>
+              <a:t>d'insérer</a:t>
+            </a:r>
+            <a:r>
+              <a:rPr lang="en-US" sz="1800" dirty="0">
+                <a:latin typeface="Consolas" panose="020B0609020204030204" pitchFamily="49" charset="0"/>
+              </a:rPr>
+              <a:t> du </a:t>
+            </a:r>
+            <a:r>
+              <a:rPr lang="en-US" sz="1800" dirty="0" err="1">
+                <a:latin typeface="Consolas" panose="020B0609020204030204" pitchFamily="49" charset="0"/>
+              </a:rPr>
+              <a:t>contenu</a:t>
+            </a:r>
+            <a:r>
+              <a:rPr lang="en-US" sz="1800" dirty="0">
+                <a:latin typeface="Consolas" panose="020B0609020204030204" pitchFamily="49" charset="0"/>
+              </a:rPr>
+              <a:t> </a:t>
+            </a:r>
+            <a:r>
+              <a:rPr lang="en-US" sz="1800" dirty="0" err="1">
+                <a:latin typeface="Consolas" panose="020B0609020204030204" pitchFamily="49" charset="0"/>
+              </a:rPr>
+              <a:t>invalide</a:t>
+            </a:r>
+            <a:endParaRPr lang="en-US" sz="1800" dirty="0">
+              <a:latin typeface="Consolas" panose="020B0609020204030204" pitchFamily="49" charset="0"/>
+            </a:endParaRPr>
+          </a:p>
+          <a:p>
+            <a:pPr lvl="1" algn="just">
+              <a:lnSpc>
+                <a:spcPct val="150000"/>
+              </a:lnSpc>
+            </a:pPr>
+            <a:r>
+              <a:rPr lang="en-US" sz="1800" b="1" dirty="0">
+                <a:latin typeface="Consolas" panose="020B0609020204030204" pitchFamily="49" charset="0"/>
+              </a:rPr>
+              <a:t>Sécurité</a:t>
+            </a:r>
+            <a:r>
+              <a:rPr lang="en-US" sz="1800" dirty="0">
+                <a:latin typeface="Consolas" panose="020B0609020204030204" pitchFamily="49" charset="0"/>
+              </a:rPr>
+              <a:t>: </a:t>
+            </a:r>
+            <a:r>
+              <a:rPr lang="en-US" sz="1800" dirty="0" err="1">
+                <a:latin typeface="Consolas" panose="020B0609020204030204" pitchFamily="49" charset="0"/>
+              </a:rPr>
+              <a:t>Moins</a:t>
+            </a:r>
+            <a:r>
+              <a:rPr lang="en-US" sz="1800" dirty="0">
+                <a:latin typeface="Consolas" panose="020B0609020204030204" pitchFamily="49" charset="0"/>
+              </a:rPr>
+              <a:t> facile </a:t>
+            </a:r>
+            <a:r>
+              <a:rPr lang="en-US" sz="1800" dirty="0" err="1">
+                <a:latin typeface="Consolas" panose="020B0609020204030204" pitchFamily="49" charset="0"/>
+              </a:rPr>
+              <a:t>d'insérer</a:t>
+            </a:r>
+            <a:r>
+              <a:rPr lang="en-US" sz="1800" dirty="0">
+                <a:latin typeface="Consolas" panose="020B0609020204030204" pitchFamily="49" charset="0"/>
+              </a:rPr>
+              <a:t> du </a:t>
+            </a:r>
+            <a:r>
+              <a:rPr lang="en-US" sz="1800" dirty="0" err="1">
+                <a:latin typeface="Consolas" panose="020B0609020204030204" pitchFamily="49" charset="0"/>
+              </a:rPr>
+              <a:t>contenu</a:t>
+            </a:r>
+            <a:r>
+              <a:rPr lang="en-US" sz="1800" dirty="0">
+                <a:latin typeface="Consolas" panose="020B0609020204030204" pitchFamily="49" charset="0"/>
+              </a:rPr>
+              <a:t> </a:t>
+            </a:r>
+            <a:r>
+              <a:rPr lang="en-US" sz="1800" dirty="0" err="1">
+                <a:latin typeface="Consolas" panose="020B0609020204030204" pitchFamily="49" charset="0"/>
+              </a:rPr>
+              <a:t>malicieux</a:t>
+            </a:r>
+            <a:endParaRPr lang="en-US" sz="1800" b="1" dirty="0">
+              <a:latin typeface="Consolas" panose="020B0609020204030204" pitchFamily="49" charset="0"/>
+            </a:endParaRPr>
+          </a:p>
+          <a:p>
+            <a:pPr lvl="1" algn="just">
+              <a:lnSpc>
+                <a:spcPct val="150000"/>
+              </a:lnSpc>
+            </a:pPr>
+            <a:r>
+              <a:rPr lang="en-US" sz="1800" b="1" dirty="0">
+                <a:latin typeface="Consolas" panose="020B0609020204030204" pitchFamily="49" charset="0"/>
+              </a:rPr>
+              <a:t>Performance</a:t>
+            </a:r>
+            <a:r>
+              <a:rPr lang="en-US" sz="1800" dirty="0">
+                <a:latin typeface="Consolas" panose="020B0609020204030204" pitchFamily="49" charset="0"/>
+              </a:rPr>
+              <a:t>: </a:t>
+            </a:r>
+            <a:r>
+              <a:rPr lang="en-US" sz="1800" dirty="0" err="1">
+                <a:latin typeface="Consolas" panose="020B0609020204030204" pitchFamily="49" charset="0"/>
+              </a:rPr>
+              <a:t>Moins</a:t>
+            </a:r>
+            <a:r>
+              <a:rPr lang="en-US" sz="1800" dirty="0">
+                <a:latin typeface="Consolas" panose="020B0609020204030204" pitchFamily="49" charset="0"/>
+              </a:rPr>
+              <a:t> de </a:t>
+            </a:r>
+            <a:r>
+              <a:rPr lang="en-US" sz="1800" dirty="0" err="1">
+                <a:latin typeface="Consolas" panose="020B0609020204030204" pitchFamily="49" charset="0"/>
+              </a:rPr>
+              <a:t>mémoire</a:t>
+            </a:r>
+            <a:r>
+              <a:rPr lang="en-US" sz="1800" dirty="0">
+                <a:latin typeface="Consolas" panose="020B0609020204030204" pitchFamily="49" charset="0"/>
+              </a:rPr>
+              <a:t>; </a:t>
+            </a:r>
+            <a:r>
+              <a:rPr lang="en-US" sz="1800" dirty="0" err="1">
+                <a:latin typeface="Consolas" panose="020B0609020204030204" pitchFamily="49" charset="0"/>
+              </a:rPr>
+              <a:t>Optimisations</a:t>
+            </a:r>
+            <a:r>
+              <a:rPr lang="en-US" sz="1800" dirty="0">
+                <a:latin typeface="Consolas" panose="020B0609020204030204" pitchFamily="49" charset="0"/>
+              </a:rPr>
+              <a:t> possibles (ex: caching)</a:t>
+            </a:r>
+            <a:endParaRPr lang="en-US" sz="1900" dirty="0">
+              <a:latin typeface="Consolas" panose="020B0609020204030204" pitchFamily="49" charset="0"/>
+            </a:endParaRPr>
+          </a:p>
+          <a:p>
+            <a:pPr lvl="1" algn="just">
+              <a:lnSpc>
+                <a:spcPct val="150000"/>
+              </a:lnSpc>
+            </a:pPr>
+            <a:endParaRPr lang="en-US" sz="1800" b="1" dirty="0">
+              <a:latin typeface="Consolas" panose="020B0609020204030204" pitchFamily="49" charset="0"/>
+            </a:endParaRPr>
+          </a:p>
+        </p:txBody>
+      </p:sp>
+      <p:sp>
+        <p:nvSpPr>
+          <p:cNvPr id="5" name="Slide Number Placeholder 4">
+            <a:extLst>
+              <a:ext uri="{FF2B5EF4-FFF2-40B4-BE49-F238E27FC236}">
+                <a16:creationId xmlns:a16="http://schemas.microsoft.com/office/drawing/2014/main" id="{28DB07B7-180C-DD61-1C60-78EB93DF862C}"/>
+              </a:ext>
+            </a:extLst>
+          </p:cNvPr>
+          <p:cNvSpPr>
+            <a:spLocks noGrp="1"/>
+          </p:cNvSpPr>
+          <p:nvPr>
+            <p:ph type="sldNum" sz="quarter" idx="12"/>
+          </p:nvPr>
+        </p:nvSpPr>
+        <p:spPr/>
+        <p:txBody>
+          <a:bodyPr/>
+          <a:lstStyle/>
+          <a:p>
+            <a:fld id="{846B06B1-1179-491F-A487-8E0C403F7C13}" type="slidenum">
+              <a:rPr lang="fr-CA" smtClean="0"/>
+              <a:t>16</a:t>
+            </a:fld>
+            <a:endParaRPr lang="fr-CA"/>
+          </a:p>
+        </p:txBody>
+      </p:sp>
+    </p:spTree>
+    <p:extLst>
+      <p:ext uri="{BB962C8B-B14F-4D97-AF65-F5344CB8AC3E}">
+        <p14:creationId xmlns:p14="http://schemas.microsoft.com/office/powerpoint/2010/main" val="1201031976"/>
+      </p:ext>
+    </p:extLst>
+  </p:cSld>
+  <p:clrMapOvr>
+    <a:masterClrMapping/>
+  </p:clrMapOvr>
+  <p:timing>
+    <p:tnLst>
+      <p:par>
+        <p:cTn id="1" dur="indefinite" restart="never" nodeType="tmRoot">
+          <p:childTnLst>
+            <p:seq concurrent="1" nextAc="seek">
+              <p:cTn id="2" dur="indefinite" nodeType="mainSeq">
+                <p:childTnLst>
+                  <p:par>
+                    <p:cTn id="3" fill="hold">
+                      <p:stCondLst>
+                        <p:cond delay="indefinite"/>
+                      </p:stCondLst>
+                      <p:childTnLst>
+                        <p:par>
+                          <p:cTn id="4" fill="hold">
+                            <p:stCondLst>
+                              <p:cond delay="0"/>
+                            </p:stCondLst>
+                            <p:childTnLst>
+                              <p:par>
+                                <p:cTn id="5" presetID="10" presetClass="entr" presetSubtype="0" fill="hold" nodeType="clickEffect">
+                                  <p:stCondLst>
+                                    <p:cond delay="0"/>
+                                  </p:stCondLst>
+                                  <p:childTnLst>
+                                    <p:set>
+                                      <p:cBhvr>
+                                        <p:cTn id="6" dur="1" fill="hold">
+                                          <p:stCondLst>
+                                            <p:cond delay="0"/>
+                                          </p:stCondLst>
+                                        </p:cTn>
+                                        <p:tgtEl>
+                                          <p:spTgt spid="3">
+                                            <p:txEl>
+                                              <p:pRg st="0" end="0"/>
+                                            </p:txEl>
+                                          </p:spTgt>
+                                        </p:tgtEl>
+                                        <p:attrNameLst>
+                                          <p:attrName>style.visibility</p:attrName>
+                                        </p:attrNameLst>
+                                      </p:cBhvr>
+                                      <p:to>
+                                        <p:strVal val="visible"/>
+                                      </p:to>
+                                    </p:set>
+                                    <p:animEffect transition="in" filter="fade">
+                                      <p:cBhvr>
+                                        <p:cTn id="7" dur="500"/>
+                                        <p:tgtEl>
+                                          <p:spTgt spid="3">
+                                            <p:txEl>
+                                              <p:pRg st="0" end="0"/>
+                                            </p:txEl>
+                                          </p:spTgt>
+                                        </p:tgtEl>
+                                      </p:cBhvr>
+                                    </p:animEffect>
+                                  </p:childTnLst>
+                                </p:cTn>
+                              </p:par>
+                            </p:childTnLst>
+                          </p:cTn>
+                        </p:par>
+                      </p:childTnLst>
+                    </p:cTn>
+                  </p:par>
+                  <p:par>
+                    <p:cTn id="8" fill="hold">
+                      <p:stCondLst>
+                        <p:cond delay="indefinite"/>
+                      </p:stCondLst>
+                      <p:childTnLst>
+                        <p:par>
+                          <p:cTn id="9" fill="hold">
+                            <p:stCondLst>
+                              <p:cond delay="0"/>
+                            </p:stCondLst>
+                            <p:childTnLst>
+                              <p:par>
+                                <p:cTn id="10" presetID="10" presetClass="entr" presetSubtype="0" fill="hold" nodeType="clickEffect">
+                                  <p:stCondLst>
+                                    <p:cond delay="0"/>
+                                  </p:stCondLst>
+                                  <p:childTnLst>
+                                    <p:set>
+                                      <p:cBhvr>
+                                        <p:cTn id="11" dur="1" fill="hold">
+                                          <p:stCondLst>
+                                            <p:cond delay="0"/>
+                                          </p:stCondLst>
+                                        </p:cTn>
+                                        <p:tgtEl>
+                                          <p:spTgt spid="3">
+                                            <p:txEl>
+                                              <p:pRg st="1" end="1"/>
+                                            </p:txEl>
+                                          </p:spTgt>
+                                        </p:tgtEl>
+                                        <p:attrNameLst>
+                                          <p:attrName>style.visibility</p:attrName>
+                                        </p:attrNameLst>
+                                      </p:cBhvr>
+                                      <p:to>
+                                        <p:strVal val="visible"/>
+                                      </p:to>
+                                    </p:set>
+                                    <p:animEffect transition="in" filter="fade">
+                                      <p:cBhvr>
+                                        <p:cTn id="12" dur="500"/>
+                                        <p:tgtEl>
+                                          <p:spTgt spid="3">
+                                            <p:txEl>
+                                              <p:pRg st="1" end="1"/>
+                                            </p:txEl>
+                                          </p:spTgt>
+                                        </p:tgtEl>
+                                      </p:cBhvr>
+                                    </p:animEffect>
+                                  </p:childTnLst>
+                                </p:cTn>
+                              </p:par>
+                            </p:childTnLst>
+                          </p:cTn>
+                        </p:par>
+                      </p:childTnLst>
+                    </p:cTn>
+                  </p:par>
+                  <p:par>
+                    <p:cTn id="13" fill="hold">
+                      <p:stCondLst>
+                        <p:cond delay="indefinite"/>
+                      </p:stCondLst>
+                      <p:childTnLst>
+                        <p:par>
+                          <p:cTn id="14" fill="hold">
+                            <p:stCondLst>
+                              <p:cond delay="0"/>
+                            </p:stCondLst>
+                            <p:childTnLst>
+                              <p:par>
+                                <p:cTn id="15" presetID="10" presetClass="entr" presetSubtype="0" fill="hold" nodeType="clickEffect">
+                                  <p:stCondLst>
+                                    <p:cond delay="0"/>
+                                  </p:stCondLst>
+                                  <p:childTnLst>
+                                    <p:set>
+                                      <p:cBhvr>
+                                        <p:cTn id="16" dur="1" fill="hold">
+                                          <p:stCondLst>
+                                            <p:cond delay="0"/>
+                                          </p:stCondLst>
+                                        </p:cTn>
+                                        <p:tgtEl>
+                                          <p:spTgt spid="3">
+                                            <p:txEl>
+                                              <p:pRg st="2" end="2"/>
+                                            </p:txEl>
+                                          </p:spTgt>
+                                        </p:tgtEl>
+                                        <p:attrNameLst>
+                                          <p:attrName>style.visibility</p:attrName>
+                                        </p:attrNameLst>
+                                      </p:cBhvr>
+                                      <p:to>
+                                        <p:strVal val="visible"/>
+                                      </p:to>
+                                    </p:set>
+                                    <p:animEffect transition="in" filter="fade">
+                                      <p:cBhvr>
+                                        <p:cTn id="17" dur="500"/>
+                                        <p:tgtEl>
+                                          <p:spTgt spid="3">
+                                            <p:txEl>
+                                              <p:pRg st="2" end="2"/>
+                                            </p:txEl>
+                                          </p:spTgt>
+                                        </p:tgtEl>
+                                      </p:cBhvr>
+                                    </p:animEffect>
+                                  </p:childTnLst>
+                                </p:cTn>
+                              </p:par>
+                            </p:childTnLst>
+                          </p:cTn>
+                        </p:par>
+                      </p:childTnLst>
+                    </p:cTn>
+                  </p:par>
+                  <p:par>
+                    <p:cTn id="18" fill="hold">
+                      <p:stCondLst>
+                        <p:cond delay="indefinite"/>
+                      </p:stCondLst>
+                      <p:childTnLst>
+                        <p:par>
+                          <p:cTn id="19" fill="hold">
+                            <p:stCondLst>
+                              <p:cond delay="0"/>
+                            </p:stCondLst>
+                            <p:childTnLst>
+                              <p:par>
+                                <p:cTn id="20" presetID="10" presetClass="entr" presetSubtype="0" fill="hold" nodeType="clickEffect">
+                                  <p:stCondLst>
+                                    <p:cond delay="0"/>
+                                  </p:stCondLst>
+                                  <p:childTnLst>
+                                    <p:set>
+                                      <p:cBhvr>
+                                        <p:cTn id="21" dur="1" fill="hold">
+                                          <p:stCondLst>
+                                            <p:cond delay="0"/>
+                                          </p:stCondLst>
+                                        </p:cTn>
+                                        <p:tgtEl>
+                                          <p:spTgt spid="3">
+                                            <p:txEl>
+                                              <p:pRg st="3" end="3"/>
+                                            </p:txEl>
+                                          </p:spTgt>
+                                        </p:tgtEl>
+                                        <p:attrNameLst>
+                                          <p:attrName>style.visibility</p:attrName>
+                                        </p:attrNameLst>
+                                      </p:cBhvr>
+                                      <p:to>
+                                        <p:strVal val="visible"/>
+                                      </p:to>
+                                    </p:set>
+                                    <p:animEffect transition="in" filter="fade">
+                                      <p:cBhvr>
+                                        <p:cTn id="22" dur="500"/>
+                                        <p:tgtEl>
+                                          <p:spTgt spid="3">
+                                            <p:txEl>
+                                              <p:pRg st="3" end="3"/>
+                                            </p:txEl>
+                                          </p:spTgt>
+                                        </p:tgtEl>
+                                      </p:cBhvr>
+                                    </p:animEffect>
+                                  </p:childTnLst>
+                                </p:cTn>
+                              </p:par>
+                            </p:childTnLst>
+                          </p:cTn>
+                        </p:par>
+                      </p:childTnLst>
+                    </p:cTn>
+                  </p:par>
+                  <p:par>
+                    <p:cTn id="23" fill="hold">
+                      <p:stCondLst>
+                        <p:cond delay="indefinite"/>
+                      </p:stCondLst>
+                      <p:childTnLst>
+                        <p:par>
+                          <p:cTn id="24" fill="hold">
+                            <p:stCondLst>
+                              <p:cond delay="0"/>
+                            </p:stCondLst>
+                            <p:childTnLst>
+                              <p:par>
+                                <p:cTn id="25" presetID="10" presetClass="entr" presetSubtype="0" fill="hold" nodeType="clickEffect">
+                                  <p:stCondLst>
+                                    <p:cond delay="0"/>
+                                  </p:stCondLst>
+                                  <p:childTnLst>
+                                    <p:set>
+                                      <p:cBhvr>
+                                        <p:cTn id="26" dur="1" fill="hold">
+                                          <p:stCondLst>
+                                            <p:cond delay="0"/>
+                                          </p:stCondLst>
+                                        </p:cTn>
+                                        <p:tgtEl>
+                                          <p:spTgt spid="3">
+                                            <p:txEl>
+                                              <p:pRg st="4" end="4"/>
+                                            </p:txEl>
+                                          </p:spTgt>
+                                        </p:tgtEl>
+                                        <p:attrNameLst>
+                                          <p:attrName>style.visibility</p:attrName>
+                                        </p:attrNameLst>
+                                      </p:cBhvr>
+                                      <p:to>
+                                        <p:strVal val="visible"/>
+                                      </p:to>
+                                    </p:set>
+                                    <p:animEffect transition="in" filter="fade">
+                                      <p:cBhvr>
+                                        <p:cTn id="27" dur="500"/>
+                                        <p:tgtEl>
+                                          <p:spTgt spid="3">
+                                            <p:txEl>
+                                              <p:pRg st="4" end="4"/>
+                                            </p:txEl>
+                                          </p:spTgt>
+                                        </p:tgtEl>
+                                      </p:cBhvr>
+                                    </p:animEffect>
+                                  </p:childTnLst>
+                                </p:cTn>
+                              </p:par>
+                            </p:childTnLst>
+                          </p:cTn>
+                        </p:par>
+                      </p:childTnLst>
+                    </p:cTn>
+                  </p:par>
+                  <p:par>
+                    <p:cTn id="28" fill="hold">
+                      <p:stCondLst>
+                        <p:cond delay="indefinite"/>
+                      </p:stCondLst>
+                      <p:childTnLst>
+                        <p:par>
+                          <p:cTn id="29" fill="hold">
+                            <p:stCondLst>
+                              <p:cond delay="0"/>
+                            </p:stCondLst>
+                            <p:childTnLst>
+                              <p:par>
+                                <p:cTn id="30" presetID="10" presetClass="entr" presetSubtype="0" fill="hold" nodeType="clickEffect">
+                                  <p:stCondLst>
+                                    <p:cond delay="0"/>
+                                  </p:stCondLst>
+                                  <p:childTnLst>
+                                    <p:set>
+                                      <p:cBhvr>
+                                        <p:cTn id="31" dur="1" fill="hold">
+                                          <p:stCondLst>
+                                            <p:cond delay="0"/>
+                                          </p:stCondLst>
+                                        </p:cTn>
+                                        <p:tgtEl>
+                                          <p:spTgt spid="3">
+                                            <p:txEl>
+                                              <p:pRg st="5" end="5"/>
+                                            </p:txEl>
+                                          </p:spTgt>
+                                        </p:tgtEl>
+                                        <p:attrNameLst>
+                                          <p:attrName>style.visibility</p:attrName>
+                                        </p:attrNameLst>
+                                      </p:cBhvr>
+                                      <p:to>
+                                        <p:strVal val="visible"/>
+                                      </p:to>
+                                    </p:set>
+                                    <p:animEffect transition="in" filter="fade">
+                                      <p:cBhvr>
+                                        <p:cTn id="32" dur="500"/>
+                                        <p:tgtEl>
+                                          <p:spTgt spid="3">
+                                            <p:txEl>
+                                              <p:pRg st="5" end="5"/>
+                                            </p:txEl>
+                                          </p:spTgt>
+                                        </p:tgtEl>
+                                      </p:cBhvr>
+                                    </p:animEffect>
+                                  </p:childTnLst>
+                                </p:cTn>
+                              </p:par>
+                            </p:childTnLst>
+                          </p:cTn>
+                        </p:par>
+                      </p:childTnLst>
+                    </p:cTn>
+                  </p:par>
+                </p:childTnLst>
+              </p:cTn>
+              <p:prevCondLst>
+                <p:cond evt="onPrev" delay="0">
+                  <p:tgtEl>
+                    <p:sldTgt/>
+                  </p:tgtEl>
+                </p:cond>
+              </p:prevCondLst>
+              <p:nextCondLst>
+                <p:cond evt="onNext" delay="0">
+                  <p:tgtEl>
+                    <p:sldTgt/>
+                  </p:tgtEl>
+                </p:cond>
+              </p:nextCondLst>
+            </p:seq>
+          </p:childTnLst>
+        </p:cTn>
+      </p:par>
+    </p:tnLst>
+  </p:timing>
+</p:sld>
+</file>
+
+<file path=ppt/slides/slide17.xml><?xml version="1.0" encoding="utf-8"?>
 <p:sld xmlns:a="http://schemas.openxmlformats.org/drawingml/2006/main" xmlns:r="http://schemas.openxmlformats.org/officeDocument/2006/relationships" xmlns:p="http://schemas.openxmlformats.org/presentationml/2006/main">
   <p:cSld>
     <p:bg>
@@ -8134,7 +9934,7 @@
           <a:p>
             <a:fld id="{846B06B1-1179-491F-A487-8E0C403F7C13}" type="slidenum">
               <a:rPr lang="fr-CA" smtClean="0"/>
-              <a:t>15</a:t>
+              <a:t>17</a:t>
             </a:fld>
             <a:endParaRPr lang="fr-CA"/>
           </a:p>
@@ -8219,7 +10019,7 @@
 </p:sld>
 </file>
 
-<file path=ppt/slides/slide16.xml><?xml version="1.0" encoding="utf-8"?>
+<file path=ppt/slides/slide18.xml><?xml version="1.0" encoding="utf-8"?>
 <p:sld xmlns:a="http://schemas.openxmlformats.org/drawingml/2006/main" xmlns:r="http://schemas.openxmlformats.org/officeDocument/2006/relationships" xmlns:p="http://schemas.openxmlformats.org/presentationml/2006/main">
   <p:cSld>
     <p:bg>
@@ -8338,7 +10138,7 @@
           <a:p>
             <a:fld id="{846B06B1-1179-491F-A487-8E0C403F7C13}" type="slidenum">
               <a:rPr lang="fr-CA" smtClean="0"/>
-              <a:t>16</a:t>
+              <a:t>18</a:t>
             </a:fld>
             <a:endParaRPr lang="fr-CA"/>
           </a:p>
@@ -8357,7 +10157,7 @@
 </p:sld>
 </file>
 
-<file path=ppt/slides/slide17.xml><?xml version="1.0" encoding="utf-8"?>
+<file path=ppt/slides/slide19.xml><?xml version="1.0" encoding="utf-8"?>
 <p:sld xmlns:a="http://schemas.openxmlformats.org/drawingml/2006/main" xmlns:r="http://schemas.openxmlformats.org/officeDocument/2006/relationships" xmlns:p="http://schemas.openxmlformats.org/presentationml/2006/main">
   <p:cSld>
     <p:spTree>
@@ -8526,7 +10326,7 @@
           <a:p>
             <a:fld id="{846B06B1-1179-491F-A487-8E0C403F7C13}" type="slidenum">
               <a:rPr lang="fr-CA" smtClean="0"/>
-              <a:t>17</a:t>
+              <a:t>19</a:t>
             </a:fld>
             <a:endParaRPr lang="fr-CA"/>
           </a:p>

</xml_diff>

<commit_message>
feat: Extend python_1 notebook cells up to slide no.17
</commit_message>
<xml_diff>
--- a/python_1/presentation_python_1.pptx
+++ b/python_1/presentation_python_1.pptx
@@ -5,7 +5,7 @@
     <p:sldMasterId id="2147483648" r:id="rId1"/>
   </p:sldMasterIdLst>
   <p:notesMasterIdLst>
-    <p:notesMasterId r:id="rId21"/>
+    <p:notesMasterId r:id="rId22"/>
   </p:notesMasterIdLst>
   <p:sldIdLst>
     <p:sldId id="256" r:id="rId2"/>
@@ -24,9 +24,10 @@
     <p:sldId id="273" r:id="rId15"/>
     <p:sldId id="274" r:id="rId16"/>
     <p:sldId id="275" r:id="rId17"/>
-    <p:sldId id="270" r:id="rId18"/>
-    <p:sldId id="267" r:id="rId19"/>
-    <p:sldId id="262" r:id="rId20"/>
+    <p:sldId id="276" r:id="rId18"/>
+    <p:sldId id="270" r:id="rId19"/>
+    <p:sldId id="267" r:id="rId20"/>
+    <p:sldId id="262" r:id="rId21"/>
   </p:sldIdLst>
   <p:sldSz cx="12192000" cy="6858000"/>
   <p:notesSz cx="6858000" cy="9144000"/>
@@ -215,7 +216,7 @@
           <a:p>
             <a:fld id="{17426931-AE65-4D08-8B32-62FCBDE55937}" type="datetimeFigureOut">
               <a:rPr lang="fr-CA" smtClean="0"/>
-              <a:t>2026-04-10</a:t>
+              <a:t>2026-04-11</a:t>
             </a:fld>
             <a:endParaRPr lang="fr-CA"/>
           </a:p>
@@ -632,7 +633,7 @@
           <a:p>
             <a:fld id="{73720E39-F9E6-45F4-9AF3-0670893E0E05}" type="datetime1">
               <a:rPr lang="fr-CA" smtClean="0"/>
-              <a:t>2026-04-10</a:t>
+              <a:t>2026-04-11</a:t>
             </a:fld>
             <a:endParaRPr lang="fr-CA"/>
           </a:p>
@@ -832,7 +833,7 @@
           <a:p>
             <a:fld id="{2A86A87F-FCE1-414B-898E-E056954DFB53}" type="datetime1">
               <a:rPr lang="fr-CA" smtClean="0"/>
-              <a:t>2026-04-10</a:t>
+              <a:t>2026-04-11</a:t>
             </a:fld>
             <a:endParaRPr lang="fr-CA"/>
           </a:p>
@@ -1042,7 +1043,7 @@
           <a:p>
             <a:fld id="{86217A25-A768-4FB5-8838-4C76F4A4D771}" type="datetime1">
               <a:rPr lang="fr-CA" smtClean="0"/>
-              <a:t>2026-04-10</a:t>
+              <a:t>2026-04-11</a:t>
             </a:fld>
             <a:endParaRPr lang="fr-CA"/>
           </a:p>
@@ -1242,7 +1243,7 @@
           <a:p>
             <a:fld id="{6DF5E9B1-F4B4-44A9-8978-A50A0AD8373C}" type="datetime1">
               <a:rPr lang="fr-CA" smtClean="0"/>
-              <a:t>2026-04-10</a:t>
+              <a:t>2026-04-11</a:t>
             </a:fld>
             <a:endParaRPr lang="fr-CA"/>
           </a:p>
@@ -1518,7 +1519,7 @@
           <a:p>
             <a:fld id="{5DE8FE0D-E91C-47AE-8B70-2B0ABA5D1B1E}" type="datetime1">
               <a:rPr lang="fr-CA" smtClean="0"/>
-              <a:t>2026-04-10</a:t>
+              <a:t>2026-04-11</a:t>
             </a:fld>
             <a:endParaRPr lang="fr-CA"/>
           </a:p>
@@ -1786,7 +1787,7 @@
           <a:p>
             <a:fld id="{F3AB8F30-8420-4011-A9ED-ED2F47883C93}" type="datetime1">
               <a:rPr lang="fr-CA" smtClean="0"/>
-              <a:t>2026-04-10</a:t>
+              <a:t>2026-04-11</a:t>
             </a:fld>
             <a:endParaRPr lang="fr-CA"/>
           </a:p>
@@ -2201,7 +2202,7 @@
           <a:p>
             <a:fld id="{852876F1-672F-46E4-BC46-E9D4C880BFEF}" type="datetime1">
               <a:rPr lang="fr-CA" smtClean="0"/>
-              <a:t>2026-04-10</a:t>
+              <a:t>2026-04-11</a:t>
             </a:fld>
             <a:endParaRPr lang="fr-CA"/>
           </a:p>
@@ -2343,7 +2344,7 @@
           <a:p>
             <a:fld id="{05494588-57AE-4A88-AA7D-14590C8ABB1D}" type="datetime1">
               <a:rPr lang="fr-CA" smtClean="0"/>
-              <a:t>2026-04-10</a:t>
+              <a:t>2026-04-11</a:t>
             </a:fld>
             <a:endParaRPr lang="fr-CA"/>
           </a:p>
@@ -2456,7 +2457,7 @@
           <a:p>
             <a:fld id="{70596107-F84A-4D89-B7EE-30826EF0EE70}" type="datetime1">
               <a:rPr lang="fr-CA" smtClean="0"/>
-              <a:t>2026-04-10</a:t>
+              <a:t>2026-04-11</a:t>
             </a:fld>
             <a:endParaRPr lang="fr-CA"/>
           </a:p>
@@ -2769,7 +2770,7 @@
           <a:p>
             <a:fld id="{12C269CA-6797-4965-A975-3F40F12DAD06}" type="datetime1">
               <a:rPr lang="fr-CA" smtClean="0"/>
-              <a:t>2026-04-10</a:t>
+              <a:t>2026-04-11</a:t>
             </a:fld>
             <a:endParaRPr lang="fr-CA"/>
           </a:p>
@@ -3058,7 +3059,7 @@
           <a:p>
             <a:fld id="{3F5AE234-69D2-4522-AB7A-F911A65753A0}" type="datetime1">
               <a:rPr lang="fr-CA" smtClean="0"/>
-              <a:t>2026-04-10</a:t>
+              <a:t>2026-04-11</a:t>
             </a:fld>
             <a:endParaRPr lang="fr-CA"/>
           </a:p>
@@ -3301,7 +3302,7 @@
           <a:p>
             <a:fld id="{30546B8D-50B2-4CF7-ACAA-221A68F8C882}" type="datetime1">
               <a:rPr lang="fr-CA" smtClean="0"/>
-              <a:t>2026-04-10</a:t>
+              <a:t>2026-04-11</a:t>
             </a:fld>
             <a:endParaRPr lang="fr-CA"/>
           </a:p>
@@ -6377,7 +6378,19 @@
               <a:rPr lang="en-US" dirty="0">
                 <a:latin typeface="Arial Rounded MT Bold" panose="020F0704030504030204" pitchFamily="34" charset="0"/>
               </a:rPr>
-              <a:t>Les tuples</a:t>
+              <a:t>Les tuples (</a:t>
+            </a:r>
+            <a:r>
+              <a:rPr lang="en-US" dirty="0">
+                <a:latin typeface="Consolas" panose="020B0609020204030204" pitchFamily="49" charset="0"/>
+              </a:rPr>
+              <a:t>tuple</a:t>
+            </a:r>
+            <a:r>
+              <a:rPr lang="en-US" dirty="0">
+                <a:latin typeface="Arial Rounded MT Bold" panose="020F0704030504030204" pitchFamily="34" charset="0"/>
+              </a:rPr>
+              <a:t>)</a:t>
             </a:r>
             <a:endParaRPr lang="fr-CA" dirty="0">
               <a:latin typeface="Arial Rounded MT Bold" panose="020F0704030504030204" pitchFamily="34" charset="0"/>
@@ -6404,7 +6417,7 @@
         <p:spPr/>
         <p:txBody>
           <a:bodyPr>
-            <a:normAutofit fontScale="92500" lnSpcReduction="20000"/>
+            <a:normAutofit fontScale="85000" lnSpcReduction="10000"/>
           </a:bodyPr>
           <a:lstStyle/>
           <a:p>
@@ -6414,6 +6427,18 @@
                 <a:latin typeface="Consolas" panose="020B0609020204030204" pitchFamily="49" charset="0"/>
               </a:rPr>
               <a:t>Regroupement </a:t>
+            </a:r>
+            <a:r>
+              <a:rPr lang="fr-CA" sz="2000" b="1" dirty="0">
+                <a:latin typeface="Consolas" panose="020B0609020204030204" pitchFamily="49" charset="0"/>
+              </a:rPr>
+              <a:t>ordonné</a:t>
+            </a:r>
+            <a:r>
+              <a:rPr lang="fr-CA" sz="2000" dirty="0">
+                <a:latin typeface="Consolas" panose="020B0609020204030204" pitchFamily="49" charset="0"/>
+              </a:rPr>
+              <a:t> et </a:t>
             </a:r>
             <a:r>
               <a:rPr lang="fr-CA" sz="2000" b="1" dirty="0">
@@ -7026,7 +7051,7 @@
         </p:nvGrpSpPr>
         <p:grpSpPr>
           <a:xfrm>
-            <a:off x="1694078" y="5717018"/>
+            <a:off x="1465478" y="5717018"/>
             <a:ext cx="3985578" cy="639332"/>
             <a:chOff x="7111661" y="4643563"/>
             <a:chExt cx="3985578" cy="639332"/>
@@ -8256,6 +8281,24 @@
               </a:rPr>
               <a:t>listes</a:t>
             </a:r>
+            <a:r>
+              <a:rPr lang="en-US" dirty="0">
+                <a:latin typeface="Arial Rounded MT Bold" panose="020F0704030504030204" pitchFamily="34" charset="0"/>
+              </a:rPr>
+              <a:t> (</a:t>
+            </a:r>
+            <a:r>
+              <a:rPr lang="en-US" dirty="0">
+                <a:latin typeface="Consolas" panose="020B0609020204030204" pitchFamily="49" charset="0"/>
+              </a:rPr>
+              <a:t>list</a:t>
+            </a:r>
+            <a:r>
+              <a:rPr lang="en-US" dirty="0">
+                <a:latin typeface="Arial Rounded MT Bold" panose="020F0704030504030204" pitchFamily="34" charset="0"/>
+              </a:rPr>
+              <a:t>)</a:t>
+            </a:r>
             <a:endParaRPr lang="fr-CA" dirty="0">
               <a:latin typeface="Arial Rounded MT Bold" panose="020F0704030504030204" pitchFamily="34" charset="0"/>
             </a:endParaRPr>
@@ -9851,6 +9894,1104 @@
     <p:bg>
       <p:bgPr>
         <a:solidFill>
+          <a:srgbClr val="F5F5F5"/>
+        </a:solidFill>
+        <a:effectLst/>
+      </p:bgPr>
+    </p:bg>
+    <p:spTree>
+      <p:nvGrpSpPr>
+        <p:cNvPr id="1" name="">
+          <a:extLst>
+            <a:ext uri="{FF2B5EF4-FFF2-40B4-BE49-F238E27FC236}">
+              <a16:creationId xmlns:a16="http://schemas.microsoft.com/office/drawing/2014/main" id="{C87C6FE8-EFD5-F7C3-9849-D1CE5F28A8E2}"/>
+            </a:ext>
+          </a:extLst>
+        </p:cNvPr>
+        <p:cNvGrpSpPr/>
+        <p:nvPr/>
+      </p:nvGrpSpPr>
+      <p:grpSpPr>
+        <a:xfrm>
+          <a:off x="0" y="0"/>
+          <a:ext cx="0" cy="0"/>
+          <a:chOff x="0" y="0"/>
+          <a:chExt cx="0" cy="0"/>
+        </a:xfrm>
+      </p:grpSpPr>
+      <p:sp>
+        <p:nvSpPr>
+          <p:cNvPr id="2" name="Title 1">
+            <a:extLst>
+              <a:ext uri="{FF2B5EF4-FFF2-40B4-BE49-F238E27FC236}">
+                <a16:creationId xmlns:a16="http://schemas.microsoft.com/office/drawing/2014/main" id="{0B5FE197-84B1-5571-7598-3F283FC46014}"/>
+              </a:ext>
+            </a:extLst>
+          </p:cNvPr>
+          <p:cNvSpPr>
+            <a:spLocks noGrp="1"/>
+          </p:cNvSpPr>
+          <p:nvPr>
+            <p:ph type="title"/>
+          </p:nvPr>
+        </p:nvSpPr>
+        <p:spPr/>
+        <p:txBody>
+          <a:bodyPr/>
+          <a:lstStyle/>
+          <a:p>
+            <a:r>
+              <a:rPr lang="en-US" dirty="0">
+                <a:latin typeface="Arial Rounded MT Bold" panose="020F0704030504030204" pitchFamily="34" charset="0"/>
+              </a:rPr>
+              <a:t>Les </a:t>
+            </a:r>
+            <a:r>
+              <a:rPr lang="en-US" dirty="0" err="1">
+                <a:latin typeface="Arial Rounded MT Bold" panose="020F0704030504030204" pitchFamily="34" charset="0"/>
+              </a:rPr>
+              <a:t>dictionnaires</a:t>
+            </a:r>
+            <a:r>
+              <a:rPr lang="en-US" dirty="0">
+                <a:latin typeface="Arial Rounded MT Bold" panose="020F0704030504030204" pitchFamily="34" charset="0"/>
+              </a:rPr>
+              <a:t> (</a:t>
+            </a:r>
+            <a:r>
+              <a:rPr lang="en-US" dirty="0" err="1">
+                <a:latin typeface="Consolas" panose="020B0609020204030204" pitchFamily="49" charset="0"/>
+              </a:rPr>
+              <a:t>dict</a:t>
+            </a:r>
+            <a:r>
+              <a:rPr lang="en-US" dirty="0">
+                <a:latin typeface="Arial Rounded MT Bold" panose="020F0704030504030204" pitchFamily="34" charset="0"/>
+              </a:rPr>
+              <a:t>)</a:t>
+            </a:r>
+            <a:endParaRPr lang="fr-CA" dirty="0">
+              <a:latin typeface="Arial Rounded MT Bold" panose="020F0704030504030204" pitchFamily="34" charset="0"/>
+            </a:endParaRPr>
+          </a:p>
+        </p:txBody>
+      </p:sp>
+      <p:sp>
+        <p:nvSpPr>
+          <p:cNvPr id="3" name="Content Placeholder 2">
+            <a:extLst>
+              <a:ext uri="{FF2B5EF4-FFF2-40B4-BE49-F238E27FC236}">
+                <a16:creationId xmlns:a16="http://schemas.microsoft.com/office/drawing/2014/main" id="{4C2F62CF-9424-A63D-5F0C-DFC44F7EF931}"/>
+              </a:ext>
+            </a:extLst>
+          </p:cNvPr>
+          <p:cNvSpPr>
+            <a:spLocks noGrp="1"/>
+          </p:cNvSpPr>
+          <p:nvPr>
+            <p:ph idx="1"/>
+          </p:nvPr>
+        </p:nvSpPr>
+        <p:spPr/>
+        <p:txBody>
+          <a:bodyPr>
+            <a:normAutofit/>
+          </a:bodyPr>
+          <a:lstStyle/>
+          <a:p>
+            <a:pPr algn="just">
+              <a:lnSpc>
+                <a:spcPct val="100000"/>
+              </a:lnSpc>
+            </a:pPr>
+            <a:r>
+              <a:rPr lang="en-CA" sz="1900" dirty="0" err="1">
+                <a:latin typeface="Consolas" panose="020B0609020204030204" pitchFamily="49" charset="0"/>
+              </a:rPr>
+              <a:t>Regroupement</a:t>
+            </a:r>
+            <a:r>
+              <a:rPr lang="en-CA" sz="1900" dirty="0">
+                <a:latin typeface="Consolas" panose="020B0609020204030204" pitchFamily="49" charset="0"/>
+              </a:rPr>
+              <a:t> </a:t>
+            </a:r>
+            <a:r>
+              <a:rPr lang="en-CA" sz="1900" b="1" dirty="0" err="1">
+                <a:latin typeface="Consolas" panose="020B0609020204030204" pitchFamily="49" charset="0"/>
+              </a:rPr>
+              <a:t>ordonné</a:t>
+            </a:r>
+            <a:r>
+              <a:rPr lang="en-CA" sz="1900" dirty="0">
+                <a:latin typeface="Consolas" panose="020B0609020204030204" pitchFamily="49" charset="0"/>
+              </a:rPr>
+              <a:t> de </a:t>
+            </a:r>
+            <a:r>
+              <a:rPr lang="en-CA" sz="1900" dirty="0" err="1">
+                <a:latin typeface="Consolas" panose="020B0609020204030204" pitchFamily="49" charset="0"/>
+              </a:rPr>
+              <a:t>paires</a:t>
+            </a:r>
+            <a:r>
+              <a:rPr lang="en-CA" sz="1900" dirty="0">
+                <a:latin typeface="Consolas" panose="020B0609020204030204" pitchFamily="49" charset="0"/>
+              </a:rPr>
+              <a:t> </a:t>
+            </a:r>
+            <a:r>
+              <a:rPr lang="en-CA" sz="1900" b="1" dirty="0">
+                <a:latin typeface="Consolas" panose="020B0609020204030204" pitchFamily="49" charset="0"/>
+              </a:rPr>
+              <a:t>cl</a:t>
+            </a:r>
+            <a:r>
+              <a:rPr lang="en-US" sz="1900" b="1" dirty="0">
+                <a:latin typeface="Consolas" panose="020B0609020204030204" pitchFamily="49" charset="0"/>
+              </a:rPr>
+              <a:t>é:valeur </a:t>
+            </a:r>
+            <a:r>
+              <a:rPr lang="en-US" sz="1900" dirty="0">
+                <a:latin typeface="Consolas" panose="020B0609020204030204" pitchFamily="49" charset="0"/>
+              </a:rPr>
+              <a:t>entre </a:t>
+            </a:r>
+            <a:r>
+              <a:rPr lang="en-US" sz="1900" b="1" dirty="0">
+                <a:latin typeface="Consolas" panose="020B0609020204030204" pitchFamily="49" charset="0"/>
+              </a:rPr>
+              <a:t>accolades</a:t>
+            </a:r>
+          </a:p>
+          <a:p>
+            <a:pPr algn="just">
+              <a:lnSpc>
+                <a:spcPct val="100000"/>
+              </a:lnSpc>
+            </a:pPr>
+            <a:endParaRPr lang="fr-CA" sz="100" b="1" dirty="0">
+              <a:solidFill>
+                <a:srgbClr val="FF2500"/>
+              </a:solidFill>
+              <a:latin typeface="Consolas" panose="020B0609020204030204" pitchFamily="49" charset="0"/>
+            </a:endParaRPr>
+          </a:p>
+          <a:p>
+            <a:pPr marL="457200" lvl="1" indent="0" algn="just">
+              <a:lnSpc>
+                <a:spcPct val="100000"/>
+              </a:lnSpc>
+              <a:buNone/>
+            </a:pPr>
+            <a:r>
+              <a:rPr lang="en-CA" sz="2000" b="1" dirty="0">
+                <a:latin typeface="Consolas" panose="020B0609020204030204" pitchFamily="49" charset="0"/>
+              </a:rPr>
+              <a:t>&gt;&gt;&gt; point = {'x': 0, 'y': 10}</a:t>
+            </a:r>
+            <a:endParaRPr lang="fr-CA" sz="2000" b="1" dirty="0">
+              <a:latin typeface="Consolas" panose="020B0609020204030204" pitchFamily="49" charset="0"/>
+            </a:endParaRPr>
+          </a:p>
+          <a:p>
+            <a:pPr marL="457200" lvl="1" indent="0" algn="just">
+              <a:lnSpc>
+                <a:spcPct val="100000"/>
+              </a:lnSpc>
+              <a:buNone/>
+            </a:pPr>
+            <a:r>
+              <a:rPr lang="fr-CA" sz="2000" b="1" dirty="0">
+                <a:latin typeface="Consolas" panose="020B0609020204030204" pitchFamily="49" charset="0"/>
+              </a:rPr>
+              <a:t>&gt;&gt;&gt; </a:t>
+            </a:r>
+            <a:r>
+              <a:rPr lang="fr-CA" sz="2000" b="1" dirty="0" err="1">
+                <a:latin typeface="Consolas" panose="020B0609020204030204" pitchFamily="49" charset="0"/>
+              </a:rPr>
+              <a:t>print</a:t>
+            </a:r>
+            <a:r>
+              <a:rPr lang="fr-CA" sz="2000" b="1" dirty="0">
+                <a:latin typeface="Consolas" panose="020B0609020204030204" pitchFamily="49" charset="0"/>
+              </a:rPr>
+              <a:t>("x =", </a:t>
+            </a:r>
+            <a:r>
+              <a:rPr lang="en-CA" sz="2000" b="1" dirty="0">
+                <a:latin typeface="Consolas" panose="020B0609020204030204" pitchFamily="49" charset="0"/>
+              </a:rPr>
+              <a:t>point</a:t>
+            </a:r>
+            <a:r>
+              <a:rPr lang="fr-CA" sz="2000" b="1" dirty="0">
+                <a:latin typeface="Consolas" panose="020B0609020204030204" pitchFamily="49" charset="0"/>
+              </a:rPr>
+              <a:t>['x'], "et y =", </a:t>
+            </a:r>
+            <a:r>
+              <a:rPr lang="en-CA" sz="2000" b="1" dirty="0">
+                <a:latin typeface="Consolas" panose="020B0609020204030204" pitchFamily="49" charset="0"/>
+              </a:rPr>
+              <a:t>point["y"]</a:t>
+            </a:r>
+            <a:r>
+              <a:rPr lang="fr-CA" sz="2000" b="1" dirty="0">
+                <a:latin typeface="Consolas" panose="020B0609020204030204" pitchFamily="49" charset="0"/>
+              </a:rPr>
+              <a:t>)</a:t>
+            </a:r>
+          </a:p>
+          <a:p>
+            <a:pPr marL="457200" lvl="1" indent="0" algn="just">
+              <a:lnSpc>
+                <a:spcPct val="100000"/>
+              </a:lnSpc>
+              <a:buNone/>
+            </a:pPr>
+            <a:r>
+              <a:rPr lang="fr-CA" sz="2000" dirty="0">
+                <a:solidFill>
+                  <a:schemeClr val="bg1">
+                    <a:lumMod val="50000"/>
+                  </a:schemeClr>
+                </a:solidFill>
+                <a:latin typeface="Consolas" panose="020B0609020204030204" pitchFamily="49" charset="0"/>
+              </a:rPr>
+              <a:t>x = 0 et y = 10</a:t>
+            </a:r>
+          </a:p>
+          <a:p>
+            <a:pPr algn="just">
+              <a:lnSpc>
+                <a:spcPct val="100000"/>
+              </a:lnSpc>
+            </a:pPr>
+            <a:r>
+              <a:rPr lang="en-CA" sz="1900" dirty="0" err="1">
+                <a:latin typeface="Consolas" panose="020B0609020204030204" pitchFamily="49" charset="0"/>
+              </a:rPr>
+              <a:t>Peut</a:t>
+            </a:r>
+            <a:r>
+              <a:rPr lang="en-CA" sz="1900" dirty="0">
+                <a:latin typeface="Consolas" panose="020B0609020204030204" pitchFamily="49" charset="0"/>
+              </a:rPr>
+              <a:t> </a:t>
+            </a:r>
+            <a:r>
+              <a:rPr lang="en-CA" sz="1900" dirty="0" err="1">
+                <a:latin typeface="Consolas" panose="020B0609020204030204" pitchFamily="49" charset="0"/>
+              </a:rPr>
+              <a:t>repr</a:t>
+            </a:r>
+            <a:r>
+              <a:rPr lang="fr-CA" sz="1900" dirty="0" err="1">
+                <a:latin typeface="Consolas" panose="020B0609020204030204" pitchFamily="49" charset="0"/>
+              </a:rPr>
+              <a:t>ésenter</a:t>
+            </a:r>
+            <a:r>
+              <a:rPr lang="fr-CA" sz="1900" dirty="0">
+                <a:latin typeface="Consolas" panose="020B0609020204030204" pitchFamily="49" charset="0"/>
+              </a:rPr>
+              <a:t> des concepts plus élaborés</a:t>
+            </a:r>
+          </a:p>
+          <a:p>
+            <a:pPr algn="just">
+              <a:lnSpc>
+                <a:spcPct val="100000"/>
+              </a:lnSpc>
+            </a:pPr>
+            <a:endParaRPr lang="en-US" sz="100" dirty="0">
+              <a:latin typeface="Consolas" panose="020B0609020204030204" pitchFamily="49" charset="0"/>
+            </a:endParaRPr>
+          </a:p>
+          <a:p>
+            <a:pPr marL="457200" lvl="1" indent="0" algn="just">
+              <a:lnSpc>
+                <a:spcPct val="100000"/>
+              </a:lnSpc>
+              <a:buNone/>
+            </a:pPr>
+            <a:r>
+              <a:rPr lang="en-CA" sz="2000" b="1" dirty="0">
+                <a:latin typeface="Consolas" panose="020B0609020204030204" pitchFamily="49" charset="0"/>
+              </a:rPr>
+              <a:t>&gt;&gt;&gt; coefficients = {</a:t>
+            </a:r>
+            <a:r>
+              <a:rPr lang="fr-CA" sz="2000" b="1" dirty="0">
+                <a:latin typeface="Consolas" panose="020B0609020204030204" pitchFamily="49" charset="0"/>
+              </a:rPr>
+              <a:t>"a": 1, "b": 2, "c": -1</a:t>
+            </a:r>
+            <a:r>
+              <a:rPr lang="en-CA" sz="2000" b="1" dirty="0">
+                <a:latin typeface="Consolas" panose="020B0609020204030204" pitchFamily="49" charset="0"/>
+              </a:rPr>
+              <a:t>}</a:t>
+            </a:r>
+          </a:p>
+          <a:p>
+            <a:pPr marL="457200" lvl="1" indent="0" algn="just">
+              <a:lnSpc>
+                <a:spcPct val="100000"/>
+              </a:lnSpc>
+              <a:buNone/>
+            </a:pPr>
+            <a:r>
+              <a:rPr lang="en-CA" sz="2000" b="1" dirty="0">
+                <a:latin typeface="Consolas" panose="020B0609020204030204" pitchFamily="49" charset="0"/>
+              </a:rPr>
+              <a:t>&gt;&gt;&gt; print(', '.join(f"{k} = {v}" for k, v in </a:t>
+            </a:r>
+            <a:r>
+              <a:rPr lang="en-CA" sz="2000" b="1" dirty="0" err="1">
+                <a:latin typeface="Consolas" panose="020B0609020204030204" pitchFamily="49" charset="0"/>
+              </a:rPr>
+              <a:t>coefficients.items</a:t>
+            </a:r>
+            <a:r>
+              <a:rPr lang="en-CA" sz="2000" b="1" dirty="0">
+                <a:latin typeface="Consolas" panose="020B0609020204030204" pitchFamily="49" charset="0"/>
+              </a:rPr>
+              <a:t>())</a:t>
+            </a:r>
+          </a:p>
+          <a:p>
+            <a:pPr marL="457200" lvl="1" indent="0" algn="just">
+              <a:lnSpc>
+                <a:spcPct val="100000"/>
+              </a:lnSpc>
+              <a:buNone/>
+            </a:pPr>
+            <a:r>
+              <a:rPr lang="fr-CA" sz="2000" dirty="0">
+                <a:solidFill>
+                  <a:schemeClr val="bg1">
+                    <a:lumMod val="50000"/>
+                  </a:schemeClr>
+                </a:solidFill>
+                <a:latin typeface="Consolas" panose="020B0609020204030204" pitchFamily="49" charset="0"/>
+              </a:rPr>
+              <a:t>a = 1, b = 2, c = -1</a:t>
+            </a:r>
+          </a:p>
+          <a:p>
+            <a:pPr marL="457200" lvl="1" indent="0" algn="just">
+              <a:lnSpc>
+                <a:spcPct val="100000"/>
+              </a:lnSpc>
+              <a:buNone/>
+            </a:pPr>
+            <a:endParaRPr lang="fr-CA" sz="100" b="1" dirty="0">
+              <a:latin typeface="Consolas" panose="020B0609020204030204" pitchFamily="49" charset="0"/>
+            </a:endParaRPr>
+          </a:p>
+          <a:p>
+            <a:pPr marL="457200" lvl="1" indent="0" algn="just">
+              <a:lnSpc>
+                <a:spcPct val="100000"/>
+              </a:lnSpc>
+              <a:buNone/>
+            </a:pPr>
+            <a:r>
+              <a:rPr lang="en-CA" sz="2000" b="1" dirty="0">
+                <a:latin typeface="Consolas" panose="020B0609020204030204" pitchFamily="49" charset="0"/>
+              </a:rPr>
+              <a:t>Remarque: </a:t>
+            </a:r>
+            <a:r>
+              <a:rPr lang="en-CA" sz="2000" dirty="0">
+                <a:latin typeface="Consolas" panose="020B0609020204030204" pitchFamily="49" charset="0"/>
+              </a:rPr>
+              <a:t>Pas id</a:t>
+            </a:r>
+            <a:r>
+              <a:rPr lang="en-US" sz="2000" dirty="0" err="1">
+                <a:latin typeface="Consolas" panose="020B0609020204030204" pitchFamily="49" charset="0"/>
+              </a:rPr>
+              <a:t>éal</a:t>
+            </a:r>
+            <a:r>
+              <a:rPr lang="en-US" sz="2000" dirty="0">
+                <a:latin typeface="Consolas" panose="020B0609020204030204" pitchFamily="49" charset="0"/>
+              </a:rPr>
+              <a:t>, </a:t>
+            </a:r>
+            <a:r>
+              <a:rPr lang="en-US" sz="2000" dirty="0" err="1">
+                <a:latin typeface="Consolas" panose="020B0609020204030204" pitchFamily="49" charset="0"/>
+              </a:rPr>
+              <a:t>mais</a:t>
+            </a:r>
+            <a:r>
+              <a:rPr lang="en-US" sz="2000" dirty="0">
+                <a:latin typeface="Consolas" panose="020B0609020204030204" pitchFamily="49" charset="0"/>
+              </a:rPr>
+              <a:t> le monde est </a:t>
+            </a:r>
+            <a:r>
+              <a:rPr lang="en-US" sz="2000" dirty="0" err="1">
+                <a:latin typeface="Consolas" panose="020B0609020204030204" pitchFamily="49" charset="0"/>
+              </a:rPr>
+              <a:t>imparfait</a:t>
+            </a:r>
+            <a:r>
+              <a:rPr lang="en-US" sz="2000" dirty="0">
+                <a:latin typeface="Consolas" panose="020B0609020204030204" pitchFamily="49" charset="0"/>
+              </a:rPr>
+              <a:t> ...</a:t>
+            </a:r>
+            <a:endParaRPr lang="fr-CA" sz="2000" dirty="0">
+              <a:latin typeface="Consolas" panose="020B0609020204030204" pitchFamily="49" charset="0"/>
+            </a:endParaRPr>
+          </a:p>
+          <a:p>
+            <a:pPr marL="457200" lvl="1" indent="0" algn="just">
+              <a:lnSpc>
+                <a:spcPct val="100000"/>
+              </a:lnSpc>
+              <a:buNone/>
+            </a:pPr>
+            <a:endParaRPr lang="fr-CA" sz="2000" b="1" dirty="0">
+              <a:latin typeface="Consolas" panose="020B0609020204030204" pitchFamily="49" charset="0"/>
+            </a:endParaRPr>
+          </a:p>
+        </p:txBody>
+      </p:sp>
+      <p:sp>
+        <p:nvSpPr>
+          <p:cNvPr id="5" name="Slide Number Placeholder 4">
+            <a:extLst>
+              <a:ext uri="{FF2B5EF4-FFF2-40B4-BE49-F238E27FC236}">
+                <a16:creationId xmlns:a16="http://schemas.microsoft.com/office/drawing/2014/main" id="{81BBD4C7-C1F1-E0CC-6C43-7275FA78437E}"/>
+              </a:ext>
+            </a:extLst>
+          </p:cNvPr>
+          <p:cNvSpPr>
+            <a:spLocks noGrp="1"/>
+          </p:cNvSpPr>
+          <p:nvPr>
+            <p:ph type="sldNum" sz="quarter" idx="12"/>
+          </p:nvPr>
+        </p:nvSpPr>
+        <p:spPr/>
+        <p:txBody>
+          <a:bodyPr/>
+          <a:lstStyle/>
+          <a:p>
+            <a:fld id="{846B06B1-1179-491F-A487-8E0C403F7C13}" type="slidenum">
+              <a:rPr lang="fr-CA" smtClean="0"/>
+              <a:t>17</a:t>
+            </a:fld>
+            <a:endParaRPr lang="fr-CA"/>
+          </a:p>
+        </p:txBody>
+      </p:sp>
+    </p:spTree>
+    <p:extLst>
+      <p:ext uri="{BB962C8B-B14F-4D97-AF65-F5344CB8AC3E}">
+        <p14:creationId xmlns:p14="http://schemas.microsoft.com/office/powerpoint/2010/main" val="596938014"/>
+      </p:ext>
+    </p:extLst>
+  </p:cSld>
+  <p:clrMapOvr>
+    <a:masterClrMapping/>
+  </p:clrMapOvr>
+  <p:timing>
+    <p:tnLst>
+      <p:par>
+        <p:cTn id="1" dur="indefinite" restart="never" nodeType="tmRoot">
+          <p:childTnLst>
+            <p:seq concurrent="1" nextAc="seek">
+              <p:cTn id="2" dur="indefinite" nodeType="mainSeq">
+                <p:childTnLst>
+                  <p:par>
+                    <p:cTn id="3" fill="hold">
+                      <p:stCondLst>
+                        <p:cond delay="indefinite"/>
+                      </p:stCondLst>
+                      <p:childTnLst>
+                        <p:par>
+                          <p:cTn id="4" fill="hold">
+                            <p:stCondLst>
+                              <p:cond delay="0"/>
+                            </p:stCondLst>
+                            <p:childTnLst>
+                              <p:par>
+                                <p:cTn id="5" presetID="10" presetClass="entr" presetSubtype="0" fill="hold" nodeType="clickEffect">
+                                  <p:stCondLst>
+                                    <p:cond delay="0"/>
+                                  </p:stCondLst>
+                                  <p:childTnLst>
+                                    <p:set>
+                                      <p:cBhvr>
+                                        <p:cTn id="6" dur="1" fill="hold">
+                                          <p:stCondLst>
+                                            <p:cond delay="0"/>
+                                          </p:stCondLst>
+                                        </p:cTn>
+                                        <p:tgtEl>
+                                          <p:spTgt spid="3">
+                                            <p:txEl>
+                                              <p:pRg st="0" end="0"/>
+                                            </p:txEl>
+                                          </p:spTgt>
+                                        </p:tgtEl>
+                                        <p:attrNameLst>
+                                          <p:attrName>style.visibility</p:attrName>
+                                        </p:attrNameLst>
+                                      </p:cBhvr>
+                                      <p:to>
+                                        <p:strVal val="visible"/>
+                                      </p:to>
+                                    </p:set>
+                                    <p:animEffect transition="in" filter="fade">
+                                      <p:cBhvr>
+                                        <p:cTn id="7" dur="500"/>
+                                        <p:tgtEl>
+                                          <p:spTgt spid="3">
+                                            <p:txEl>
+                                              <p:pRg st="0" end="0"/>
+                                            </p:txEl>
+                                          </p:spTgt>
+                                        </p:tgtEl>
+                                      </p:cBhvr>
+                                    </p:animEffect>
+                                  </p:childTnLst>
+                                </p:cTn>
+                              </p:par>
+                            </p:childTnLst>
+                          </p:cTn>
+                        </p:par>
+                      </p:childTnLst>
+                    </p:cTn>
+                  </p:par>
+                  <p:par>
+                    <p:cTn id="8" fill="hold">
+                      <p:stCondLst>
+                        <p:cond delay="indefinite"/>
+                      </p:stCondLst>
+                      <p:childTnLst>
+                        <p:par>
+                          <p:cTn id="9" fill="hold">
+                            <p:stCondLst>
+                              <p:cond delay="0"/>
+                            </p:stCondLst>
+                            <p:childTnLst>
+                              <p:par>
+                                <p:cTn id="10" presetID="10" presetClass="entr" presetSubtype="0" fill="hold" nodeType="clickEffect">
+                                  <p:stCondLst>
+                                    <p:cond delay="0"/>
+                                  </p:stCondLst>
+                                  <p:childTnLst>
+                                    <p:set>
+                                      <p:cBhvr>
+                                        <p:cTn id="11" dur="1" fill="hold">
+                                          <p:stCondLst>
+                                            <p:cond delay="0"/>
+                                          </p:stCondLst>
+                                        </p:cTn>
+                                        <p:tgtEl>
+                                          <p:spTgt spid="3">
+                                            <p:txEl>
+                                              <p:pRg st="2" end="2"/>
+                                            </p:txEl>
+                                          </p:spTgt>
+                                        </p:tgtEl>
+                                        <p:attrNameLst>
+                                          <p:attrName>style.visibility</p:attrName>
+                                        </p:attrNameLst>
+                                      </p:cBhvr>
+                                      <p:to>
+                                        <p:strVal val="visible"/>
+                                      </p:to>
+                                    </p:set>
+                                    <p:animEffect transition="in" filter="fade">
+                                      <p:cBhvr>
+                                        <p:cTn id="12" dur="500"/>
+                                        <p:tgtEl>
+                                          <p:spTgt spid="3">
+                                            <p:txEl>
+                                              <p:pRg st="2" end="2"/>
+                                            </p:txEl>
+                                          </p:spTgt>
+                                        </p:tgtEl>
+                                      </p:cBhvr>
+                                    </p:animEffect>
+                                  </p:childTnLst>
+                                </p:cTn>
+                              </p:par>
+                            </p:childTnLst>
+                          </p:cTn>
+                        </p:par>
+                      </p:childTnLst>
+                    </p:cTn>
+                  </p:par>
+                  <p:par>
+                    <p:cTn id="13" fill="hold">
+                      <p:stCondLst>
+                        <p:cond delay="indefinite"/>
+                      </p:stCondLst>
+                      <p:childTnLst>
+                        <p:par>
+                          <p:cTn id="14" fill="hold">
+                            <p:stCondLst>
+                              <p:cond delay="0"/>
+                            </p:stCondLst>
+                            <p:childTnLst>
+                              <p:par>
+                                <p:cTn id="15" presetID="10" presetClass="entr" presetSubtype="0" fill="hold" nodeType="clickEffect">
+                                  <p:stCondLst>
+                                    <p:cond delay="0"/>
+                                  </p:stCondLst>
+                                  <p:childTnLst>
+                                    <p:set>
+                                      <p:cBhvr>
+                                        <p:cTn id="16" dur="1" fill="hold">
+                                          <p:stCondLst>
+                                            <p:cond delay="0"/>
+                                          </p:stCondLst>
+                                        </p:cTn>
+                                        <p:tgtEl>
+                                          <p:spTgt spid="3">
+                                            <p:txEl>
+                                              <p:pRg st="3" end="3"/>
+                                            </p:txEl>
+                                          </p:spTgt>
+                                        </p:tgtEl>
+                                        <p:attrNameLst>
+                                          <p:attrName>style.visibility</p:attrName>
+                                        </p:attrNameLst>
+                                      </p:cBhvr>
+                                      <p:to>
+                                        <p:strVal val="visible"/>
+                                      </p:to>
+                                    </p:set>
+                                    <p:animEffect transition="in" filter="fade">
+                                      <p:cBhvr>
+                                        <p:cTn id="17" dur="500"/>
+                                        <p:tgtEl>
+                                          <p:spTgt spid="3">
+                                            <p:txEl>
+                                              <p:pRg st="3" end="3"/>
+                                            </p:txEl>
+                                          </p:spTgt>
+                                        </p:tgtEl>
+                                      </p:cBhvr>
+                                    </p:animEffect>
+                                  </p:childTnLst>
+                                </p:cTn>
+                              </p:par>
+                            </p:childTnLst>
+                          </p:cTn>
+                        </p:par>
+                      </p:childTnLst>
+                    </p:cTn>
+                  </p:par>
+                  <p:par>
+                    <p:cTn id="18" fill="hold">
+                      <p:stCondLst>
+                        <p:cond delay="indefinite"/>
+                      </p:stCondLst>
+                      <p:childTnLst>
+                        <p:par>
+                          <p:cTn id="19" fill="hold">
+                            <p:stCondLst>
+                              <p:cond delay="0"/>
+                            </p:stCondLst>
+                            <p:childTnLst>
+                              <p:par>
+                                <p:cTn id="20" presetID="10" presetClass="entr" presetSubtype="0" fill="hold" nodeType="clickEffect">
+                                  <p:stCondLst>
+                                    <p:cond delay="0"/>
+                                  </p:stCondLst>
+                                  <p:childTnLst>
+                                    <p:set>
+                                      <p:cBhvr>
+                                        <p:cTn id="21" dur="1" fill="hold">
+                                          <p:stCondLst>
+                                            <p:cond delay="0"/>
+                                          </p:stCondLst>
+                                        </p:cTn>
+                                        <p:tgtEl>
+                                          <p:spTgt spid="3">
+                                            <p:txEl>
+                                              <p:pRg st="4" end="4"/>
+                                            </p:txEl>
+                                          </p:spTgt>
+                                        </p:tgtEl>
+                                        <p:attrNameLst>
+                                          <p:attrName>style.visibility</p:attrName>
+                                        </p:attrNameLst>
+                                      </p:cBhvr>
+                                      <p:to>
+                                        <p:strVal val="visible"/>
+                                      </p:to>
+                                    </p:set>
+                                    <p:animEffect transition="in" filter="fade">
+                                      <p:cBhvr>
+                                        <p:cTn id="22" dur="500"/>
+                                        <p:tgtEl>
+                                          <p:spTgt spid="3">
+                                            <p:txEl>
+                                              <p:pRg st="4" end="4"/>
+                                            </p:txEl>
+                                          </p:spTgt>
+                                        </p:tgtEl>
+                                      </p:cBhvr>
+                                    </p:animEffect>
+                                  </p:childTnLst>
+                                </p:cTn>
+                              </p:par>
+                            </p:childTnLst>
+                          </p:cTn>
+                        </p:par>
+                      </p:childTnLst>
+                    </p:cTn>
+                  </p:par>
+                  <p:par>
+                    <p:cTn id="23" fill="hold">
+                      <p:stCondLst>
+                        <p:cond delay="indefinite"/>
+                      </p:stCondLst>
+                      <p:childTnLst>
+                        <p:par>
+                          <p:cTn id="24" fill="hold">
+                            <p:stCondLst>
+                              <p:cond delay="0"/>
+                            </p:stCondLst>
+                            <p:childTnLst>
+                              <p:par>
+                                <p:cTn id="25" presetID="10" presetClass="entr" presetSubtype="0" fill="hold" nodeType="clickEffect">
+                                  <p:stCondLst>
+                                    <p:cond delay="0"/>
+                                  </p:stCondLst>
+                                  <p:childTnLst>
+                                    <p:set>
+                                      <p:cBhvr>
+                                        <p:cTn id="26" dur="1" fill="hold">
+                                          <p:stCondLst>
+                                            <p:cond delay="0"/>
+                                          </p:stCondLst>
+                                        </p:cTn>
+                                        <p:tgtEl>
+                                          <p:spTgt spid="3">
+                                            <p:txEl>
+                                              <p:pRg st="5" end="5"/>
+                                            </p:txEl>
+                                          </p:spTgt>
+                                        </p:tgtEl>
+                                        <p:attrNameLst>
+                                          <p:attrName>style.visibility</p:attrName>
+                                        </p:attrNameLst>
+                                      </p:cBhvr>
+                                      <p:to>
+                                        <p:strVal val="visible"/>
+                                      </p:to>
+                                    </p:set>
+                                    <p:animEffect transition="in" filter="fade">
+                                      <p:cBhvr>
+                                        <p:cTn id="27" dur="500"/>
+                                        <p:tgtEl>
+                                          <p:spTgt spid="3">
+                                            <p:txEl>
+                                              <p:pRg st="5" end="5"/>
+                                            </p:txEl>
+                                          </p:spTgt>
+                                        </p:tgtEl>
+                                      </p:cBhvr>
+                                    </p:animEffect>
+                                  </p:childTnLst>
+                                </p:cTn>
+                              </p:par>
+                            </p:childTnLst>
+                          </p:cTn>
+                        </p:par>
+                      </p:childTnLst>
+                    </p:cTn>
+                  </p:par>
+                  <p:par>
+                    <p:cTn id="28" fill="hold">
+                      <p:stCondLst>
+                        <p:cond delay="indefinite"/>
+                      </p:stCondLst>
+                      <p:childTnLst>
+                        <p:par>
+                          <p:cTn id="29" fill="hold">
+                            <p:stCondLst>
+                              <p:cond delay="0"/>
+                            </p:stCondLst>
+                            <p:childTnLst>
+                              <p:par>
+                                <p:cTn id="30" presetID="10" presetClass="entr" presetSubtype="0" fill="hold" nodeType="clickEffect">
+                                  <p:stCondLst>
+                                    <p:cond delay="0"/>
+                                  </p:stCondLst>
+                                  <p:childTnLst>
+                                    <p:set>
+                                      <p:cBhvr>
+                                        <p:cTn id="31" dur="1" fill="hold">
+                                          <p:stCondLst>
+                                            <p:cond delay="0"/>
+                                          </p:stCondLst>
+                                        </p:cTn>
+                                        <p:tgtEl>
+                                          <p:spTgt spid="3">
+                                            <p:txEl>
+                                              <p:pRg st="7" end="7"/>
+                                            </p:txEl>
+                                          </p:spTgt>
+                                        </p:tgtEl>
+                                        <p:attrNameLst>
+                                          <p:attrName>style.visibility</p:attrName>
+                                        </p:attrNameLst>
+                                      </p:cBhvr>
+                                      <p:to>
+                                        <p:strVal val="visible"/>
+                                      </p:to>
+                                    </p:set>
+                                    <p:animEffect transition="in" filter="fade">
+                                      <p:cBhvr>
+                                        <p:cTn id="32" dur="500"/>
+                                        <p:tgtEl>
+                                          <p:spTgt spid="3">
+                                            <p:txEl>
+                                              <p:pRg st="7" end="7"/>
+                                            </p:txEl>
+                                          </p:spTgt>
+                                        </p:tgtEl>
+                                      </p:cBhvr>
+                                    </p:animEffect>
+                                  </p:childTnLst>
+                                </p:cTn>
+                              </p:par>
+                            </p:childTnLst>
+                          </p:cTn>
+                        </p:par>
+                      </p:childTnLst>
+                    </p:cTn>
+                  </p:par>
+                  <p:par>
+                    <p:cTn id="33" fill="hold">
+                      <p:stCondLst>
+                        <p:cond delay="indefinite"/>
+                      </p:stCondLst>
+                      <p:childTnLst>
+                        <p:par>
+                          <p:cTn id="34" fill="hold">
+                            <p:stCondLst>
+                              <p:cond delay="0"/>
+                            </p:stCondLst>
+                            <p:childTnLst>
+                              <p:par>
+                                <p:cTn id="35" presetID="10" presetClass="entr" presetSubtype="0" fill="hold" nodeType="clickEffect">
+                                  <p:stCondLst>
+                                    <p:cond delay="0"/>
+                                  </p:stCondLst>
+                                  <p:childTnLst>
+                                    <p:set>
+                                      <p:cBhvr>
+                                        <p:cTn id="36" dur="1" fill="hold">
+                                          <p:stCondLst>
+                                            <p:cond delay="0"/>
+                                          </p:stCondLst>
+                                        </p:cTn>
+                                        <p:tgtEl>
+                                          <p:spTgt spid="3">
+                                            <p:txEl>
+                                              <p:pRg st="8" end="8"/>
+                                            </p:txEl>
+                                          </p:spTgt>
+                                        </p:tgtEl>
+                                        <p:attrNameLst>
+                                          <p:attrName>style.visibility</p:attrName>
+                                        </p:attrNameLst>
+                                      </p:cBhvr>
+                                      <p:to>
+                                        <p:strVal val="visible"/>
+                                      </p:to>
+                                    </p:set>
+                                    <p:animEffect transition="in" filter="fade">
+                                      <p:cBhvr>
+                                        <p:cTn id="37" dur="500"/>
+                                        <p:tgtEl>
+                                          <p:spTgt spid="3">
+                                            <p:txEl>
+                                              <p:pRg st="8" end="8"/>
+                                            </p:txEl>
+                                          </p:spTgt>
+                                        </p:tgtEl>
+                                      </p:cBhvr>
+                                    </p:animEffect>
+                                  </p:childTnLst>
+                                </p:cTn>
+                              </p:par>
+                            </p:childTnLst>
+                          </p:cTn>
+                        </p:par>
+                      </p:childTnLst>
+                    </p:cTn>
+                  </p:par>
+                  <p:par>
+                    <p:cTn id="38" fill="hold">
+                      <p:stCondLst>
+                        <p:cond delay="indefinite"/>
+                      </p:stCondLst>
+                      <p:childTnLst>
+                        <p:par>
+                          <p:cTn id="39" fill="hold">
+                            <p:stCondLst>
+                              <p:cond delay="0"/>
+                            </p:stCondLst>
+                            <p:childTnLst>
+                              <p:par>
+                                <p:cTn id="40" presetID="10" presetClass="entr" presetSubtype="0" fill="hold" nodeType="clickEffect">
+                                  <p:stCondLst>
+                                    <p:cond delay="0"/>
+                                  </p:stCondLst>
+                                  <p:childTnLst>
+                                    <p:set>
+                                      <p:cBhvr>
+                                        <p:cTn id="41" dur="1" fill="hold">
+                                          <p:stCondLst>
+                                            <p:cond delay="0"/>
+                                          </p:stCondLst>
+                                        </p:cTn>
+                                        <p:tgtEl>
+                                          <p:spTgt spid="3">
+                                            <p:txEl>
+                                              <p:pRg st="9" end="9"/>
+                                            </p:txEl>
+                                          </p:spTgt>
+                                        </p:tgtEl>
+                                        <p:attrNameLst>
+                                          <p:attrName>style.visibility</p:attrName>
+                                        </p:attrNameLst>
+                                      </p:cBhvr>
+                                      <p:to>
+                                        <p:strVal val="visible"/>
+                                      </p:to>
+                                    </p:set>
+                                    <p:animEffect transition="in" filter="fade">
+                                      <p:cBhvr>
+                                        <p:cTn id="42" dur="500"/>
+                                        <p:tgtEl>
+                                          <p:spTgt spid="3">
+                                            <p:txEl>
+                                              <p:pRg st="9" end="9"/>
+                                            </p:txEl>
+                                          </p:spTgt>
+                                        </p:tgtEl>
+                                      </p:cBhvr>
+                                    </p:animEffect>
+                                  </p:childTnLst>
+                                </p:cTn>
+                              </p:par>
+                            </p:childTnLst>
+                          </p:cTn>
+                        </p:par>
+                      </p:childTnLst>
+                    </p:cTn>
+                  </p:par>
+                  <p:par>
+                    <p:cTn id="43" fill="hold">
+                      <p:stCondLst>
+                        <p:cond delay="indefinite"/>
+                      </p:stCondLst>
+                      <p:childTnLst>
+                        <p:par>
+                          <p:cTn id="44" fill="hold">
+                            <p:stCondLst>
+                              <p:cond delay="0"/>
+                            </p:stCondLst>
+                            <p:childTnLst>
+                              <p:par>
+                                <p:cTn id="45" presetID="10" presetClass="entr" presetSubtype="0" fill="hold" nodeType="clickEffect">
+                                  <p:stCondLst>
+                                    <p:cond delay="0"/>
+                                  </p:stCondLst>
+                                  <p:childTnLst>
+                                    <p:set>
+                                      <p:cBhvr>
+                                        <p:cTn id="46" dur="1" fill="hold">
+                                          <p:stCondLst>
+                                            <p:cond delay="0"/>
+                                          </p:stCondLst>
+                                        </p:cTn>
+                                        <p:tgtEl>
+                                          <p:spTgt spid="3">
+                                            <p:txEl>
+                                              <p:pRg st="11" end="11"/>
+                                            </p:txEl>
+                                          </p:spTgt>
+                                        </p:tgtEl>
+                                        <p:attrNameLst>
+                                          <p:attrName>style.visibility</p:attrName>
+                                        </p:attrNameLst>
+                                      </p:cBhvr>
+                                      <p:to>
+                                        <p:strVal val="visible"/>
+                                      </p:to>
+                                    </p:set>
+                                    <p:animEffect transition="in" filter="fade">
+                                      <p:cBhvr>
+                                        <p:cTn id="47" dur="500"/>
+                                        <p:tgtEl>
+                                          <p:spTgt spid="3">
+                                            <p:txEl>
+                                              <p:pRg st="11" end="11"/>
+                                            </p:txEl>
+                                          </p:spTgt>
+                                        </p:tgtEl>
+                                      </p:cBhvr>
+                                    </p:animEffect>
+                                  </p:childTnLst>
+                                </p:cTn>
+                              </p:par>
+                            </p:childTnLst>
+                          </p:cTn>
+                        </p:par>
+                      </p:childTnLst>
+                    </p:cTn>
+                  </p:par>
+                </p:childTnLst>
+              </p:cTn>
+              <p:prevCondLst>
+                <p:cond evt="onPrev" delay="0">
+                  <p:tgtEl>
+                    <p:sldTgt/>
+                  </p:tgtEl>
+                </p:cond>
+              </p:prevCondLst>
+              <p:nextCondLst>
+                <p:cond evt="onNext" delay="0">
+                  <p:tgtEl>
+                    <p:sldTgt/>
+                  </p:tgtEl>
+                </p:cond>
+              </p:nextCondLst>
+            </p:seq>
+          </p:childTnLst>
+        </p:cTn>
+      </p:par>
+    </p:tnLst>
+  </p:timing>
+</p:sld>
+</file>
+
+<file path=ppt/slides/slide18.xml><?xml version="1.0" encoding="utf-8"?>
+<p:sld xmlns:a="http://schemas.openxmlformats.org/drawingml/2006/main" xmlns:r="http://schemas.openxmlformats.org/officeDocument/2006/relationships" xmlns:p="http://schemas.openxmlformats.org/presentationml/2006/main">
+  <p:cSld>
+    <p:bg>
+      <p:bgPr>
+        <a:solidFill>
           <a:schemeClr val="bg1">
             <a:lumMod val="95000"/>
           </a:schemeClr>
@@ -9934,7 +11075,7 @@
           <a:p>
             <a:fld id="{846B06B1-1179-491F-A487-8E0C403F7C13}" type="slidenum">
               <a:rPr lang="fr-CA" smtClean="0"/>
-              <a:t>17</a:t>
+              <a:t>18</a:t>
             </a:fld>
             <a:endParaRPr lang="fr-CA"/>
           </a:p>
@@ -10019,7 +11160,7 @@
 </p:sld>
 </file>
 
-<file path=ppt/slides/slide18.xml><?xml version="1.0" encoding="utf-8"?>
+<file path=ppt/slides/slide19.xml><?xml version="1.0" encoding="utf-8"?>
 <p:sld xmlns:a="http://schemas.openxmlformats.org/drawingml/2006/main" xmlns:r="http://schemas.openxmlformats.org/officeDocument/2006/relationships" xmlns:p="http://schemas.openxmlformats.org/presentationml/2006/main">
   <p:cSld>
     <p:bg>
@@ -10138,7 +11279,7 @@
           <a:p>
             <a:fld id="{846B06B1-1179-491F-A487-8E0C403F7C13}" type="slidenum">
               <a:rPr lang="fr-CA" smtClean="0"/>
-              <a:t>18</a:t>
+              <a:t>19</a:t>
             </a:fld>
             <a:endParaRPr lang="fr-CA"/>
           </a:p>
@@ -10148,194 +11289,6 @@
     <p:extLst>
       <p:ext uri="{BB962C8B-B14F-4D97-AF65-F5344CB8AC3E}">
         <p14:creationId xmlns:p14="http://schemas.microsoft.com/office/powerpoint/2010/main" val="2334800325"/>
-      </p:ext>
-    </p:extLst>
-  </p:cSld>
-  <p:clrMapOvr>
-    <a:masterClrMapping/>
-  </p:clrMapOvr>
-</p:sld>
-</file>
-
-<file path=ppt/slides/slide19.xml><?xml version="1.0" encoding="utf-8"?>
-<p:sld xmlns:a="http://schemas.openxmlformats.org/drawingml/2006/main" xmlns:r="http://schemas.openxmlformats.org/officeDocument/2006/relationships" xmlns:p="http://schemas.openxmlformats.org/presentationml/2006/main">
-  <p:cSld>
-    <p:spTree>
-      <p:nvGrpSpPr>
-        <p:cNvPr id="1" name="">
-          <a:extLst>
-            <a:ext uri="{FF2B5EF4-FFF2-40B4-BE49-F238E27FC236}">
-              <a16:creationId xmlns:a16="http://schemas.microsoft.com/office/drawing/2014/main" id="{C4FE5AC6-E16E-CBF3-7DF3-37169D45026B}"/>
-            </a:ext>
-          </a:extLst>
-        </p:cNvPr>
-        <p:cNvGrpSpPr/>
-        <p:nvPr/>
-      </p:nvGrpSpPr>
-      <p:grpSpPr>
-        <a:xfrm>
-          <a:off x="0" y="0"/>
-          <a:ext cx="0" cy="0"/>
-          <a:chOff x="0" y="0"/>
-          <a:chExt cx="0" cy="0"/>
-        </a:xfrm>
-      </p:grpSpPr>
-      <p:sp>
-        <p:nvSpPr>
-          <p:cNvPr id="2" name="Title 1">
-            <a:extLst>
-              <a:ext uri="{FF2B5EF4-FFF2-40B4-BE49-F238E27FC236}">
-                <a16:creationId xmlns:a16="http://schemas.microsoft.com/office/drawing/2014/main" id="{5750A927-3AF3-1105-1BE2-D370C7DAEA96}"/>
-              </a:ext>
-            </a:extLst>
-          </p:cNvPr>
-          <p:cNvSpPr>
-            <a:spLocks noGrp="1"/>
-          </p:cNvSpPr>
-          <p:nvPr>
-            <p:ph type="title"/>
-          </p:nvPr>
-        </p:nvSpPr>
-        <p:spPr/>
-        <p:txBody>
-          <a:bodyPr/>
-          <a:lstStyle/>
-          <a:p>
-            <a:r>
-              <a:rPr lang="en-US" dirty="0" err="1">
-                <a:latin typeface="Arial Rounded MT Bold" panose="020F0704030504030204" pitchFamily="34" charset="0"/>
-              </a:rPr>
-              <a:t>Boîte</a:t>
-            </a:r>
-            <a:r>
-              <a:rPr lang="en-US" dirty="0">
-                <a:latin typeface="Arial Rounded MT Bold" panose="020F0704030504030204" pitchFamily="34" charset="0"/>
-              </a:rPr>
-              <a:t> à </a:t>
-            </a:r>
-            <a:r>
-              <a:rPr lang="en-US" dirty="0" err="1">
-                <a:latin typeface="Arial Rounded MT Bold" panose="020F0704030504030204" pitchFamily="34" charset="0"/>
-              </a:rPr>
-              <a:t>savon</a:t>
-            </a:r>
-            <a:endParaRPr lang="fr-CA" dirty="0">
-              <a:latin typeface="Arial Rounded MT Bold" panose="020F0704030504030204" pitchFamily="34" charset="0"/>
-            </a:endParaRPr>
-          </a:p>
-        </p:txBody>
-      </p:sp>
-      <p:sp>
-        <p:nvSpPr>
-          <p:cNvPr id="3" name="Content Placeholder 2">
-            <a:extLst>
-              <a:ext uri="{FF2B5EF4-FFF2-40B4-BE49-F238E27FC236}">
-                <a16:creationId xmlns:a16="http://schemas.microsoft.com/office/drawing/2014/main" id="{238F9EF2-9A1B-D8F8-3653-B2333F4464C3}"/>
-              </a:ext>
-            </a:extLst>
-          </p:cNvPr>
-          <p:cNvSpPr>
-            <a:spLocks noGrp="1"/>
-          </p:cNvSpPr>
-          <p:nvPr>
-            <p:ph idx="1"/>
-          </p:nvPr>
-        </p:nvSpPr>
-        <p:spPr/>
-        <p:txBody>
-          <a:bodyPr>
-            <a:normAutofit/>
-          </a:bodyPr>
-          <a:lstStyle/>
-          <a:p>
-            <a:pPr marL="0" indent="0" algn="just">
-              <a:buNone/>
-            </a:pPr>
-            <a:r>
-              <a:rPr lang="en-US" b="1" i="1" dirty="0" err="1">
-                <a:latin typeface="Consolas" panose="020B0609020204030204" pitchFamily="49" charset="0"/>
-              </a:rPr>
-              <a:t>Entiers</a:t>
-            </a:r>
-            <a:r>
-              <a:rPr lang="en-US" b="1" i="1" dirty="0">
-                <a:latin typeface="Consolas" panose="020B0609020204030204" pitchFamily="49" charset="0"/>
-              </a:rPr>
-              <a:t> à precision "infinite"</a:t>
-            </a:r>
-          </a:p>
-          <a:p>
-            <a:pPr marL="0" indent="0" algn="just">
-              <a:buNone/>
-            </a:pPr>
-            <a:r>
-              <a:rPr lang="en-US" b="1" i="1" dirty="0">
-                <a:latin typeface="Consolas" panose="020B0609020204030204" pitchFamily="49" charset="0"/>
-              </a:rPr>
-              <a:t>Truthiness</a:t>
-            </a:r>
-          </a:p>
-          <a:p>
-            <a:pPr marL="0" indent="0" algn="just">
-              <a:buNone/>
-            </a:pPr>
-            <a:r>
-              <a:rPr lang="en-CA" b="1" i="1" dirty="0" err="1">
-                <a:latin typeface="Consolas" panose="020B0609020204030204" pitchFamily="49" charset="0"/>
-              </a:rPr>
-              <a:t>Nombres</a:t>
-            </a:r>
-            <a:r>
-              <a:rPr lang="en-CA" b="1" i="1" dirty="0">
-                <a:latin typeface="Consolas" panose="020B0609020204030204" pitchFamily="49" charset="0"/>
-              </a:rPr>
-              <a:t> </a:t>
-            </a:r>
-            <a:r>
-              <a:rPr lang="en-CA" b="1" i="1" dirty="0" err="1">
-                <a:latin typeface="Consolas" panose="020B0609020204030204" pitchFamily="49" charset="0"/>
-              </a:rPr>
-              <a:t>imaginaires</a:t>
-            </a:r>
-            <a:endParaRPr lang="en-CA" b="1" i="1" dirty="0">
-              <a:latin typeface="Consolas" panose="020B0609020204030204" pitchFamily="49" charset="0"/>
-            </a:endParaRPr>
-          </a:p>
-        </p:txBody>
-      </p:sp>
-      <p:sp>
-        <p:nvSpPr>
-          <p:cNvPr id="4" name="Slide Number Placeholder 3">
-            <a:extLst>
-              <a:ext uri="{FF2B5EF4-FFF2-40B4-BE49-F238E27FC236}">
-                <a16:creationId xmlns:a16="http://schemas.microsoft.com/office/drawing/2014/main" id="{8EDFF14A-781E-B2B6-B1C5-9B936FB0C6A8}"/>
-              </a:ext>
-            </a:extLst>
-          </p:cNvPr>
-          <p:cNvSpPr>
-            <a:spLocks noGrp="1"/>
-          </p:cNvSpPr>
-          <p:nvPr>
-            <p:ph type="sldNum" sz="quarter" idx="12"/>
-          </p:nvPr>
-        </p:nvSpPr>
-        <p:spPr/>
-        <p:txBody>
-          <a:bodyPr/>
-          <a:lstStyle/>
-          <a:p>
-            <a:fld id="{846B06B1-1179-491F-A487-8E0C403F7C13}" type="slidenum">
-              <a:rPr lang="fr-CA" smtClean="0"/>
-              <a:t>19</a:t>
-            </a:fld>
-            <a:endParaRPr lang="fr-CA"/>
-          </a:p>
-        </p:txBody>
-      </p:sp>
-    </p:spTree>
-    <p:extLst>
-      <p:ext uri="{BB962C8B-B14F-4D97-AF65-F5344CB8AC3E}">
-        <p14:creationId xmlns:p14="http://schemas.microsoft.com/office/powerpoint/2010/main" val="1511279349"/>
       </p:ext>
     </p:extLst>
   </p:cSld>
@@ -11483,6 +12436,194 @@
       </p:par>
     </p:tnLst>
   </p:timing>
+</p:sld>
+</file>
+
+<file path=ppt/slides/slide20.xml><?xml version="1.0" encoding="utf-8"?>
+<p:sld xmlns:a="http://schemas.openxmlformats.org/drawingml/2006/main" xmlns:r="http://schemas.openxmlformats.org/officeDocument/2006/relationships" xmlns:p="http://schemas.openxmlformats.org/presentationml/2006/main">
+  <p:cSld>
+    <p:spTree>
+      <p:nvGrpSpPr>
+        <p:cNvPr id="1" name="">
+          <a:extLst>
+            <a:ext uri="{FF2B5EF4-FFF2-40B4-BE49-F238E27FC236}">
+              <a16:creationId xmlns:a16="http://schemas.microsoft.com/office/drawing/2014/main" id="{C4FE5AC6-E16E-CBF3-7DF3-37169D45026B}"/>
+            </a:ext>
+          </a:extLst>
+        </p:cNvPr>
+        <p:cNvGrpSpPr/>
+        <p:nvPr/>
+      </p:nvGrpSpPr>
+      <p:grpSpPr>
+        <a:xfrm>
+          <a:off x="0" y="0"/>
+          <a:ext cx="0" cy="0"/>
+          <a:chOff x="0" y="0"/>
+          <a:chExt cx="0" cy="0"/>
+        </a:xfrm>
+      </p:grpSpPr>
+      <p:sp>
+        <p:nvSpPr>
+          <p:cNvPr id="2" name="Title 1">
+            <a:extLst>
+              <a:ext uri="{FF2B5EF4-FFF2-40B4-BE49-F238E27FC236}">
+                <a16:creationId xmlns:a16="http://schemas.microsoft.com/office/drawing/2014/main" id="{5750A927-3AF3-1105-1BE2-D370C7DAEA96}"/>
+              </a:ext>
+            </a:extLst>
+          </p:cNvPr>
+          <p:cNvSpPr>
+            <a:spLocks noGrp="1"/>
+          </p:cNvSpPr>
+          <p:nvPr>
+            <p:ph type="title"/>
+          </p:nvPr>
+        </p:nvSpPr>
+        <p:spPr/>
+        <p:txBody>
+          <a:bodyPr/>
+          <a:lstStyle/>
+          <a:p>
+            <a:r>
+              <a:rPr lang="en-US" dirty="0" err="1">
+                <a:latin typeface="Arial Rounded MT Bold" panose="020F0704030504030204" pitchFamily="34" charset="0"/>
+              </a:rPr>
+              <a:t>Boîte</a:t>
+            </a:r>
+            <a:r>
+              <a:rPr lang="en-US" dirty="0">
+                <a:latin typeface="Arial Rounded MT Bold" panose="020F0704030504030204" pitchFamily="34" charset="0"/>
+              </a:rPr>
+              <a:t> à </a:t>
+            </a:r>
+            <a:r>
+              <a:rPr lang="en-US" dirty="0" err="1">
+                <a:latin typeface="Arial Rounded MT Bold" panose="020F0704030504030204" pitchFamily="34" charset="0"/>
+              </a:rPr>
+              <a:t>savon</a:t>
+            </a:r>
+            <a:endParaRPr lang="fr-CA" dirty="0">
+              <a:latin typeface="Arial Rounded MT Bold" panose="020F0704030504030204" pitchFamily="34" charset="0"/>
+            </a:endParaRPr>
+          </a:p>
+        </p:txBody>
+      </p:sp>
+      <p:sp>
+        <p:nvSpPr>
+          <p:cNvPr id="3" name="Content Placeholder 2">
+            <a:extLst>
+              <a:ext uri="{FF2B5EF4-FFF2-40B4-BE49-F238E27FC236}">
+                <a16:creationId xmlns:a16="http://schemas.microsoft.com/office/drawing/2014/main" id="{238F9EF2-9A1B-D8F8-3653-B2333F4464C3}"/>
+              </a:ext>
+            </a:extLst>
+          </p:cNvPr>
+          <p:cNvSpPr>
+            <a:spLocks noGrp="1"/>
+          </p:cNvSpPr>
+          <p:nvPr>
+            <p:ph idx="1"/>
+          </p:nvPr>
+        </p:nvSpPr>
+        <p:spPr/>
+        <p:txBody>
+          <a:bodyPr>
+            <a:normAutofit/>
+          </a:bodyPr>
+          <a:lstStyle/>
+          <a:p>
+            <a:pPr marL="0" indent="0" algn="just">
+              <a:buNone/>
+            </a:pPr>
+            <a:r>
+              <a:rPr lang="en-US" b="1" i="1" dirty="0" err="1">
+                <a:latin typeface="Consolas" panose="020B0609020204030204" pitchFamily="49" charset="0"/>
+              </a:rPr>
+              <a:t>Entiers</a:t>
+            </a:r>
+            <a:r>
+              <a:rPr lang="en-US" b="1" i="1" dirty="0">
+                <a:latin typeface="Consolas" panose="020B0609020204030204" pitchFamily="49" charset="0"/>
+              </a:rPr>
+              <a:t> à precision "infinite"</a:t>
+            </a:r>
+          </a:p>
+          <a:p>
+            <a:pPr marL="0" indent="0" algn="just">
+              <a:buNone/>
+            </a:pPr>
+            <a:r>
+              <a:rPr lang="en-US" b="1" i="1" dirty="0">
+                <a:latin typeface="Consolas" panose="020B0609020204030204" pitchFamily="49" charset="0"/>
+              </a:rPr>
+              <a:t>Truthiness</a:t>
+            </a:r>
+          </a:p>
+          <a:p>
+            <a:pPr marL="0" indent="0" algn="just">
+              <a:buNone/>
+            </a:pPr>
+            <a:r>
+              <a:rPr lang="en-CA" b="1" i="1" dirty="0" err="1">
+                <a:latin typeface="Consolas" panose="020B0609020204030204" pitchFamily="49" charset="0"/>
+              </a:rPr>
+              <a:t>Nombres</a:t>
+            </a:r>
+            <a:r>
+              <a:rPr lang="en-CA" b="1" i="1" dirty="0">
+                <a:latin typeface="Consolas" panose="020B0609020204030204" pitchFamily="49" charset="0"/>
+              </a:rPr>
+              <a:t> </a:t>
+            </a:r>
+            <a:r>
+              <a:rPr lang="en-CA" b="1" i="1" dirty="0" err="1">
+                <a:latin typeface="Consolas" panose="020B0609020204030204" pitchFamily="49" charset="0"/>
+              </a:rPr>
+              <a:t>imaginaires</a:t>
+            </a:r>
+            <a:endParaRPr lang="en-CA" b="1" i="1" dirty="0">
+              <a:latin typeface="Consolas" panose="020B0609020204030204" pitchFamily="49" charset="0"/>
+            </a:endParaRPr>
+          </a:p>
+        </p:txBody>
+      </p:sp>
+      <p:sp>
+        <p:nvSpPr>
+          <p:cNvPr id="4" name="Slide Number Placeholder 3">
+            <a:extLst>
+              <a:ext uri="{FF2B5EF4-FFF2-40B4-BE49-F238E27FC236}">
+                <a16:creationId xmlns:a16="http://schemas.microsoft.com/office/drawing/2014/main" id="{8EDFF14A-781E-B2B6-B1C5-9B936FB0C6A8}"/>
+              </a:ext>
+            </a:extLst>
+          </p:cNvPr>
+          <p:cNvSpPr>
+            <a:spLocks noGrp="1"/>
+          </p:cNvSpPr>
+          <p:nvPr>
+            <p:ph type="sldNum" sz="quarter" idx="12"/>
+          </p:nvPr>
+        </p:nvSpPr>
+        <p:spPr/>
+        <p:txBody>
+          <a:bodyPr/>
+          <a:lstStyle/>
+          <a:p>
+            <a:fld id="{846B06B1-1179-491F-A487-8E0C403F7C13}" type="slidenum">
+              <a:rPr lang="fr-CA" smtClean="0"/>
+              <a:t>20</a:t>
+            </a:fld>
+            <a:endParaRPr lang="fr-CA"/>
+          </a:p>
+        </p:txBody>
+      </p:sp>
+    </p:spTree>
+    <p:extLst>
+      <p:ext uri="{BB962C8B-B14F-4D97-AF65-F5344CB8AC3E}">
+        <p14:creationId xmlns:p14="http://schemas.microsoft.com/office/powerpoint/2010/main" val="1511279349"/>
+      </p:ext>
+    </p:extLst>
+  </p:cSld>
+  <p:clrMapOvr>
+    <a:masterClrMapping/>
+  </p:clrMapOvr>
 </p:sld>
 </file>
 

</xml_diff>

<commit_message>
feat: Extend python_1 notebook cells up to slide no.23 (WIP)
</commit_message>
<xml_diff>
--- a/python_1/presentation_python_1.pptx
+++ b/python_1/presentation_python_1.pptx
@@ -5,7 +5,7 @@
     <p:sldMasterId id="2147483648" r:id="rId1"/>
   </p:sldMasterIdLst>
   <p:notesMasterIdLst>
-    <p:notesMasterId r:id="rId22"/>
+    <p:notesMasterId r:id="rId26"/>
   </p:notesMasterIdLst>
   <p:sldIdLst>
     <p:sldId id="256" r:id="rId2"/>
@@ -25,9 +25,13 @@
     <p:sldId id="274" r:id="rId16"/>
     <p:sldId id="275" r:id="rId17"/>
     <p:sldId id="276" r:id="rId18"/>
-    <p:sldId id="270" r:id="rId19"/>
-    <p:sldId id="267" r:id="rId20"/>
-    <p:sldId id="262" r:id="rId21"/>
+    <p:sldId id="277" r:id="rId19"/>
+    <p:sldId id="278" r:id="rId20"/>
+    <p:sldId id="282" r:id="rId21"/>
+    <p:sldId id="280" r:id="rId22"/>
+    <p:sldId id="279" r:id="rId23"/>
+    <p:sldId id="281" r:id="rId24"/>
+    <p:sldId id="270" r:id="rId25"/>
   </p:sldIdLst>
   <p:sldSz cx="12192000" cy="6858000"/>
   <p:notesSz cx="6858000" cy="9144000"/>
@@ -6278,6 +6282,28 @@
               <a:t>.</a:t>
             </a:r>
           </a:p>
+          <a:p>
+            <a:pPr marL="0" indent="0" algn="just">
+              <a:buNone/>
+            </a:pPr>
+            <a:endParaRPr lang="en-US" sz="2000" dirty="0">
+              <a:latin typeface="Consolas" panose="020B0609020204030204" pitchFamily="49" charset="0"/>
+            </a:endParaRPr>
+          </a:p>
+          <a:p>
+            <a:pPr marL="0" indent="0" algn="just">
+              <a:buNone/>
+            </a:pPr>
+            <a:r>
+              <a:rPr lang="en-US" sz="2000" dirty="0">
+                <a:highlight>
+                  <a:srgbClr val="FF0000"/>
+                </a:highlight>
+                <a:latin typeface="Consolas" panose="020B0609020204030204" pitchFamily="49" charset="0"/>
+              </a:rPr>
+              <a:t>...</a:t>
+            </a:r>
+          </a:p>
         </p:txBody>
       </p:sp>
       <p:sp>
@@ -6417,43 +6443,47 @@
         <p:spPr/>
         <p:txBody>
           <a:bodyPr>
-            <a:normAutofit fontScale="85000" lnSpcReduction="10000"/>
+            <a:normAutofit fontScale="85000" lnSpcReduction="20000"/>
           </a:bodyPr>
           <a:lstStyle/>
           <a:p>
-            <a:pPr algn="just"/>
-            <a:r>
-              <a:rPr lang="fr-CA" sz="2000" dirty="0">
+            <a:pPr algn="just">
+              <a:lnSpc>
+                <a:spcPct val="120000"/>
+              </a:lnSpc>
+            </a:pPr>
+            <a:r>
+              <a:rPr lang="fr-CA" sz="2100" dirty="0">
                 <a:latin typeface="Consolas" panose="020B0609020204030204" pitchFamily="49" charset="0"/>
               </a:rPr>
               <a:t>Regroupement </a:t>
             </a:r>
             <a:r>
-              <a:rPr lang="fr-CA" sz="2000" b="1" dirty="0">
+              <a:rPr lang="fr-CA" sz="2100" b="1" dirty="0">
                 <a:latin typeface="Consolas" panose="020B0609020204030204" pitchFamily="49" charset="0"/>
               </a:rPr>
               <a:t>ordonné</a:t>
             </a:r>
             <a:r>
-              <a:rPr lang="fr-CA" sz="2000" dirty="0">
+              <a:rPr lang="fr-CA" sz="2100" dirty="0">
                 <a:latin typeface="Consolas" panose="020B0609020204030204" pitchFamily="49" charset="0"/>
               </a:rPr>
               <a:t> et </a:t>
             </a:r>
             <a:r>
-              <a:rPr lang="fr-CA" sz="2000" b="1" dirty="0">
+              <a:rPr lang="fr-CA" sz="2100" b="1" dirty="0">
                 <a:latin typeface="Consolas" panose="020B0609020204030204" pitchFamily="49" charset="0"/>
               </a:rPr>
               <a:t>immuable</a:t>
             </a:r>
             <a:r>
-              <a:rPr lang="fr-CA" sz="2000" dirty="0">
+              <a:rPr lang="fr-CA" sz="2100" dirty="0">
                 <a:latin typeface="Consolas" panose="020B0609020204030204" pitchFamily="49" charset="0"/>
               </a:rPr>
               <a:t> de </a:t>
             </a:r>
             <a:r>
-              <a:rPr lang="fr-CA" sz="2000" b="1" dirty="0">
+              <a:rPr lang="fr-CA" sz="2100" b="1" dirty="0">
                 <a:latin typeface="Consolas" panose="020B0609020204030204" pitchFamily="49" charset="0"/>
               </a:rPr>
               <a:t>valeurs quelconques séparées par des virgules</a:t>
@@ -6909,7 +6939,7 @@
         </p:nvGrpSpPr>
         <p:grpSpPr>
           <a:xfrm>
-            <a:off x="5172593" y="4353110"/>
+            <a:off x="5059102" y="4480110"/>
             <a:ext cx="4092107" cy="369332"/>
             <a:chOff x="6485106" y="4913563"/>
             <a:chExt cx="4092107" cy="369332"/>
@@ -7051,7 +7081,7 @@
         </p:nvGrpSpPr>
         <p:grpSpPr>
           <a:xfrm>
-            <a:off x="1465478" y="5717018"/>
+            <a:off x="1440078" y="5907518"/>
             <a:ext cx="3985578" cy="639332"/>
             <a:chOff x="7111661" y="4643563"/>
             <a:chExt cx="3985578" cy="639332"/>
@@ -7193,7 +7223,7 @@
         </p:nvGrpSpPr>
         <p:grpSpPr>
           <a:xfrm>
-            <a:off x="5059102" y="2193923"/>
+            <a:off x="5059102" y="2727323"/>
             <a:ext cx="2295397" cy="353943"/>
             <a:chOff x="6485106" y="4913563"/>
             <a:chExt cx="2295397" cy="353943"/>
@@ -8361,7 +8391,7 @@
           <a:p>
             <a:pPr marL="0" indent="0" algn="just">
               <a:lnSpc>
-                <a:spcPct val="120000"/>
+                <a:spcPct val="100000"/>
               </a:lnSpc>
               <a:buNone/>
             </a:pPr>
@@ -8484,7 +8514,7 @@
           <a:p>
             <a:pPr marL="457200" lvl="1" indent="0" algn="just">
               <a:lnSpc>
-                <a:spcPct val="80000"/>
+                <a:spcPct val="100000"/>
               </a:lnSpc>
               <a:buNone/>
             </a:pPr>
@@ -10335,6 +10365,18 @@
                 <a:latin typeface="Consolas" panose="020B0609020204030204" pitchFamily="49" charset="0"/>
               </a:rPr>
               <a:t> le monde est </a:t>
+            </a:r>
+            <a:r>
+              <a:rPr lang="en-US" sz="2000" dirty="0" err="1">
+                <a:latin typeface="Consolas" panose="020B0609020204030204" pitchFamily="49" charset="0"/>
+              </a:rPr>
+              <a:t>souvent</a:t>
+            </a:r>
+            <a:r>
+              <a:rPr lang="en-US" sz="2000" dirty="0">
+                <a:latin typeface="Consolas" panose="020B0609020204030204" pitchFamily="49" charset="0"/>
+              </a:rPr>
+              <a:t> </a:t>
             </a:r>
             <a:r>
               <a:rPr lang="en-US" sz="2000" dirty="0" err="1">
@@ -10992,9 +11034,7 @@
     <p:bg>
       <p:bgPr>
         <a:solidFill>
-          <a:schemeClr val="bg1">
-            <a:lumMod val="95000"/>
-          </a:schemeClr>
+          <a:srgbClr val="F5F5F5"/>
         </a:solidFill>
         <a:effectLst/>
       </p:bgPr>
@@ -11004,7 +11044,7 @@
         <p:cNvPr id="1" name="">
           <a:extLst>
             <a:ext uri="{FF2B5EF4-FFF2-40B4-BE49-F238E27FC236}">
-              <a16:creationId xmlns:a16="http://schemas.microsoft.com/office/drawing/2014/main" id="{75DA6A40-BCE7-A8AF-2F09-CCBF86A73F57}"/>
+              <a16:creationId xmlns:a16="http://schemas.microsoft.com/office/drawing/2014/main" id="{CA0F5DB1-E175-BEA3-3FFD-9BC39E635E0C}"/>
             </a:ext>
           </a:extLst>
         </p:cNvPr>
@@ -11024,7 +11064,7 @@
           <p:cNvPr id="2" name="Title 1">
             <a:extLst>
               <a:ext uri="{FF2B5EF4-FFF2-40B4-BE49-F238E27FC236}">
-                <a16:creationId xmlns:a16="http://schemas.microsoft.com/office/drawing/2014/main" id="{5AD71FA1-6AD3-129C-8A3A-20D41092F1F1}"/>
+                <a16:creationId xmlns:a16="http://schemas.microsoft.com/office/drawing/2014/main" id="{1CA2C8C3-FEBE-7FDD-D07F-C81ABC745672}"/>
               </a:ext>
             </a:extLst>
           </p:cNvPr>
@@ -11041,10 +11081,22 @@
           <a:lstStyle/>
           <a:p>
             <a:r>
+              <a:rPr lang="en-US" dirty="0" err="1">
+                <a:latin typeface="Arial Rounded MT Bold" panose="020F0704030504030204" pitchFamily="34" charset="0"/>
+              </a:rPr>
+              <a:t>Saveurs</a:t>
+            </a:r>
+            <a:r>
               <a:rPr lang="en-US" dirty="0">
                 <a:latin typeface="Arial Rounded MT Bold" panose="020F0704030504030204" pitchFamily="34" charset="0"/>
               </a:rPr>
-              <a:t>ANNEXE I</a:t>
+              <a:t> </a:t>
+            </a:r>
+            <a:r>
+              <a:rPr lang="en-US" dirty="0" err="1">
+                <a:latin typeface="Arial Rounded MT Bold" panose="020F0704030504030204" pitchFamily="34" charset="0"/>
+              </a:rPr>
+              <a:t>d'arguments</a:t>
             </a:r>
             <a:endParaRPr lang="fr-CA" dirty="0">
               <a:latin typeface="Arial Rounded MT Bold" panose="020F0704030504030204" pitchFamily="34" charset="0"/>
@@ -11054,10 +11106,345 @@
       </p:sp>
       <p:sp>
         <p:nvSpPr>
-          <p:cNvPr id="11" name="Slide Number Placeholder 10">
+          <p:cNvPr id="3" name="Content Placeholder 2">
             <a:extLst>
               <a:ext uri="{FF2B5EF4-FFF2-40B4-BE49-F238E27FC236}">
-                <a16:creationId xmlns:a16="http://schemas.microsoft.com/office/drawing/2014/main" id="{6B59C14A-02F3-20F2-19A6-212B35B47AC1}"/>
+                <a16:creationId xmlns:a16="http://schemas.microsoft.com/office/drawing/2014/main" id="{298C5D9F-BDB5-5951-AD08-DC1EAADFD282}"/>
+              </a:ext>
+            </a:extLst>
+          </p:cNvPr>
+          <p:cNvSpPr>
+            <a:spLocks noGrp="1"/>
+          </p:cNvSpPr>
+          <p:nvPr>
+            <p:ph idx="1"/>
+          </p:nvPr>
+        </p:nvSpPr>
+        <p:spPr/>
+        <p:txBody>
+          <a:bodyPr>
+            <a:normAutofit/>
+          </a:bodyPr>
+          <a:lstStyle/>
+          <a:p>
+            <a:pPr marL="457200" lvl="1" indent="0" algn="just">
+              <a:lnSpc>
+                <a:spcPct val="100000"/>
+              </a:lnSpc>
+              <a:buNone/>
+            </a:pPr>
+            <a:endParaRPr lang="en-CA" sz="1800" dirty="0">
+              <a:latin typeface="Consolas" panose="020B0609020204030204" pitchFamily="49" charset="0"/>
+            </a:endParaRPr>
+          </a:p>
+          <a:p>
+            <a:pPr marL="457200" lvl="1" indent="0" algn="just">
+              <a:lnSpc>
+                <a:spcPct val="100000"/>
+              </a:lnSpc>
+              <a:buNone/>
+            </a:pPr>
+            <a:endParaRPr lang="en-CA" sz="1800" dirty="0">
+              <a:latin typeface="Consolas" panose="020B0609020204030204" pitchFamily="49" charset="0"/>
+            </a:endParaRPr>
+          </a:p>
+          <a:p>
+            <a:pPr marL="457200" lvl="1" indent="0" algn="just">
+              <a:lnSpc>
+                <a:spcPct val="100000"/>
+              </a:lnSpc>
+              <a:buNone/>
+            </a:pPr>
+            <a:endParaRPr lang="en-CA" sz="1800" dirty="0">
+              <a:latin typeface="Consolas" panose="020B0609020204030204" pitchFamily="49" charset="0"/>
+            </a:endParaRPr>
+          </a:p>
+          <a:p>
+            <a:pPr algn="just">
+              <a:lnSpc>
+                <a:spcPct val="100000"/>
+              </a:lnSpc>
+            </a:pPr>
+            <a:r>
+              <a:rPr lang="en-CA" sz="1800" dirty="0">
+                <a:latin typeface="Consolas" panose="020B0609020204030204" pitchFamily="49" charset="0"/>
+              </a:rPr>
+              <a:t>Param</a:t>
+            </a:r>
+            <a:r>
+              <a:rPr lang="en-US" sz="1800" dirty="0" err="1">
+                <a:latin typeface="Consolas" panose="020B0609020204030204" pitchFamily="49" charset="0"/>
+              </a:rPr>
+              <a:t>ètres</a:t>
+            </a:r>
+            <a:r>
+              <a:rPr lang="en-US" sz="1800" dirty="0">
+                <a:latin typeface="Consolas" panose="020B0609020204030204" pitchFamily="49" charset="0"/>
+              </a:rPr>
+              <a:t> </a:t>
+            </a:r>
+            <a:r>
+              <a:rPr lang="en-US" sz="1800" dirty="0" err="1">
+                <a:latin typeface="Consolas" panose="020B0609020204030204" pitchFamily="49" charset="0"/>
+              </a:rPr>
+              <a:t>positionnels</a:t>
+            </a:r>
+            <a:r>
+              <a:rPr lang="en-US" sz="1800" dirty="0">
+                <a:latin typeface="Consolas" panose="020B0609020204030204" pitchFamily="49" charset="0"/>
+              </a:rPr>
+              <a:t> ...</a:t>
+            </a:r>
+          </a:p>
+          <a:p>
+            <a:pPr lvl="1" algn="just">
+              <a:lnSpc>
+                <a:spcPct val="100000"/>
+              </a:lnSpc>
+            </a:pPr>
+            <a:r>
+              <a:rPr lang="en-US" sz="1400" dirty="0" err="1">
+                <a:latin typeface="Consolas" panose="020B0609020204030204" pitchFamily="49" charset="0"/>
+              </a:rPr>
+              <a:t>explicites</a:t>
+            </a:r>
+            <a:r>
+              <a:rPr lang="en-US" sz="1400" dirty="0">
+                <a:latin typeface="Consolas" panose="020B0609020204030204" pitchFamily="49" charset="0"/>
+              </a:rPr>
+              <a:t>: </a:t>
+            </a:r>
+            <a:r>
+              <a:rPr lang="pt-BR" sz="1400" b="1" dirty="0">
+                <a:solidFill>
+                  <a:srgbClr val="00B0F0"/>
+                </a:solidFill>
+                <a:latin typeface="Consolas" panose="020B0609020204030204" pitchFamily="49" charset="0"/>
+              </a:rPr>
+              <a:t>p1</a:t>
+            </a:r>
+            <a:r>
+              <a:rPr lang="pt-BR" sz="1400" b="1" dirty="0">
+                <a:latin typeface="Consolas" panose="020B0609020204030204" pitchFamily="49" charset="0"/>
+              </a:rPr>
+              <a:t>, </a:t>
+            </a:r>
+            <a:r>
+              <a:rPr lang="pt-BR" sz="1400" b="1" dirty="0">
+                <a:solidFill>
+                  <a:srgbClr val="00B0F0"/>
+                </a:solidFill>
+                <a:latin typeface="Consolas" panose="020B0609020204030204" pitchFamily="49" charset="0"/>
+              </a:rPr>
+              <a:t>p2</a:t>
+            </a:r>
+            <a:r>
+              <a:rPr lang="pt-BR" sz="1400" b="1" dirty="0">
+                <a:latin typeface="Consolas" panose="020B0609020204030204" pitchFamily="49" charset="0"/>
+              </a:rPr>
+              <a:t>, </a:t>
+            </a:r>
+            <a:r>
+              <a:rPr lang="pt-BR" sz="1400" b="1" dirty="0">
+                <a:solidFill>
+                  <a:srgbClr val="00B0F0"/>
+                </a:solidFill>
+                <a:latin typeface="Consolas" panose="020B0609020204030204" pitchFamily="49" charset="0"/>
+              </a:rPr>
+              <a:t>...</a:t>
+            </a:r>
+          </a:p>
+          <a:p>
+            <a:pPr lvl="1" algn="just">
+              <a:lnSpc>
+                <a:spcPct val="100000"/>
+              </a:lnSpc>
+            </a:pPr>
+            <a:r>
+              <a:rPr lang="en-US" sz="1400" dirty="0" err="1">
+                <a:latin typeface="Consolas" panose="020B0609020204030204" pitchFamily="49" charset="0"/>
+              </a:rPr>
+              <a:t>supplémentaires</a:t>
+            </a:r>
+            <a:r>
+              <a:rPr lang="en-US" sz="1400" dirty="0">
+                <a:latin typeface="Consolas" panose="020B0609020204030204" pitchFamily="49" charset="0"/>
+              </a:rPr>
+              <a:t>: </a:t>
+            </a:r>
+            <a:r>
+              <a:rPr lang="pt-BR" sz="1400" b="1" dirty="0">
+                <a:solidFill>
+                  <a:srgbClr val="7030A0"/>
+                </a:solidFill>
+                <a:latin typeface="Consolas" panose="020B0609020204030204" pitchFamily="49" charset="0"/>
+              </a:rPr>
+              <a:t>*args</a:t>
+            </a:r>
+            <a:r>
+              <a:rPr lang="en-US" sz="1400" dirty="0">
+                <a:latin typeface="Consolas" panose="020B0609020204030204" pitchFamily="49" charset="0"/>
+              </a:rPr>
+              <a:t> (tuple)</a:t>
+            </a:r>
+            <a:endParaRPr lang="en-US" sz="1400" dirty="0">
+              <a:solidFill>
+                <a:srgbClr val="00B0F0"/>
+              </a:solidFill>
+              <a:latin typeface="Consolas" panose="020B0609020204030204" pitchFamily="49" charset="0"/>
+            </a:endParaRPr>
+          </a:p>
+          <a:p>
+            <a:pPr algn="just">
+              <a:lnSpc>
+                <a:spcPct val="100000"/>
+              </a:lnSpc>
+            </a:pPr>
+            <a:r>
+              <a:rPr lang="en-US" sz="1800" dirty="0" err="1">
+                <a:latin typeface="Consolas" panose="020B0609020204030204" pitchFamily="49" charset="0"/>
+              </a:rPr>
+              <a:t>Paramètres</a:t>
+            </a:r>
+            <a:r>
+              <a:rPr lang="en-US" sz="1800" dirty="0">
+                <a:latin typeface="Consolas" panose="020B0609020204030204" pitchFamily="49" charset="0"/>
+              </a:rPr>
+              <a:t> </a:t>
+            </a:r>
+            <a:r>
+              <a:rPr lang="en-US" sz="1800" dirty="0" err="1">
+                <a:latin typeface="Consolas" panose="020B0609020204030204" pitchFamily="49" charset="0"/>
+              </a:rPr>
+              <a:t>nommés</a:t>
+            </a:r>
+            <a:r>
+              <a:rPr lang="en-US" sz="1800" dirty="0">
+                <a:latin typeface="Consolas" panose="020B0609020204030204" pitchFamily="49" charset="0"/>
+              </a:rPr>
+              <a:t> ... </a:t>
+            </a:r>
+          </a:p>
+          <a:p>
+            <a:pPr lvl="1" algn="just">
+              <a:lnSpc>
+                <a:spcPct val="100000"/>
+              </a:lnSpc>
+            </a:pPr>
+            <a:r>
+              <a:rPr lang="en-US" sz="1400" dirty="0" err="1">
+                <a:latin typeface="Consolas" panose="020B0609020204030204" pitchFamily="49" charset="0"/>
+              </a:rPr>
+              <a:t>explicites</a:t>
+            </a:r>
+            <a:r>
+              <a:rPr lang="en-US" sz="1400" dirty="0">
+                <a:latin typeface="Consolas" panose="020B0609020204030204" pitchFamily="49" charset="0"/>
+              </a:rPr>
+              <a:t>: </a:t>
+            </a:r>
+            <a:r>
+              <a:rPr lang="pt-BR" sz="1400" b="1" dirty="0">
+                <a:solidFill>
+                  <a:schemeClr val="accent6"/>
+                </a:solidFill>
+                <a:latin typeface="Consolas" panose="020B0609020204030204" pitchFamily="49" charset="0"/>
+              </a:rPr>
+              <a:t>n1=v1</a:t>
+            </a:r>
+            <a:r>
+              <a:rPr lang="en-US" sz="1400" dirty="0">
+                <a:latin typeface="Consolas" panose="020B0609020204030204" pitchFamily="49" charset="0"/>
+              </a:rPr>
+              <a:t>, </a:t>
+            </a:r>
+            <a:r>
+              <a:rPr lang="pt-BR" sz="1400" b="1" dirty="0">
+                <a:solidFill>
+                  <a:schemeClr val="accent6"/>
+                </a:solidFill>
+                <a:latin typeface="Consolas" panose="020B0609020204030204" pitchFamily="49" charset="0"/>
+              </a:rPr>
+              <a:t>n2=v2</a:t>
+            </a:r>
+            <a:r>
+              <a:rPr lang="en-US" sz="1400" dirty="0">
+                <a:latin typeface="Consolas" panose="020B0609020204030204" pitchFamily="49" charset="0"/>
+              </a:rPr>
+              <a:t>, </a:t>
+            </a:r>
+            <a:r>
+              <a:rPr lang="pt-BR" sz="1400" b="1" dirty="0">
+                <a:solidFill>
+                  <a:schemeClr val="accent6"/>
+                </a:solidFill>
+                <a:latin typeface="Consolas" panose="020B0609020204030204" pitchFamily="49" charset="0"/>
+              </a:rPr>
+              <a:t>...</a:t>
+            </a:r>
+          </a:p>
+          <a:p>
+            <a:pPr lvl="1" algn="just">
+              <a:lnSpc>
+                <a:spcPct val="100000"/>
+              </a:lnSpc>
+            </a:pPr>
+            <a:r>
+              <a:rPr lang="en-US" sz="1400" dirty="0" err="1">
+                <a:latin typeface="Consolas" panose="020B0609020204030204" pitchFamily="49" charset="0"/>
+              </a:rPr>
+              <a:t>supplémentaires</a:t>
+            </a:r>
+            <a:r>
+              <a:rPr lang="en-US" sz="1400" dirty="0">
+                <a:latin typeface="Consolas" panose="020B0609020204030204" pitchFamily="49" charset="0"/>
+              </a:rPr>
+              <a:t>: </a:t>
+            </a:r>
+            <a:r>
+              <a:rPr lang="pt-BR" sz="1400" b="1" dirty="0">
+                <a:solidFill>
+                  <a:schemeClr val="accent2"/>
+                </a:solidFill>
+                <a:latin typeface="Consolas" panose="020B0609020204030204" pitchFamily="49" charset="0"/>
+              </a:rPr>
+              <a:t>**kwargs</a:t>
+            </a:r>
+            <a:r>
+              <a:rPr lang="en-US" sz="1400" dirty="0">
+                <a:latin typeface="Consolas" panose="020B0609020204030204" pitchFamily="49" charset="0"/>
+              </a:rPr>
+              <a:t> (</a:t>
+            </a:r>
+            <a:r>
+              <a:rPr lang="en-US" sz="1400" dirty="0" err="1">
+                <a:latin typeface="Consolas" panose="020B0609020204030204" pitchFamily="49" charset="0"/>
+              </a:rPr>
+              <a:t>dict</a:t>
+            </a:r>
+            <a:endParaRPr lang="fr-CA" sz="1800" dirty="0">
+              <a:latin typeface="Consolas" panose="020B0609020204030204" pitchFamily="49" charset="0"/>
+            </a:endParaRPr>
+          </a:p>
+          <a:p>
+            <a:pPr marL="457200" lvl="1" indent="0" algn="just">
+              <a:lnSpc>
+                <a:spcPct val="100000"/>
+              </a:lnSpc>
+              <a:buNone/>
+            </a:pPr>
+            <a:endParaRPr lang="fr-CA" sz="1800" dirty="0">
+              <a:latin typeface="Consolas" panose="020B0609020204030204" pitchFamily="49" charset="0"/>
+            </a:endParaRPr>
+          </a:p>
+        </p:txBody>
+      </p:sp>
+      <p:sp>
+        <p:nvSpPr>
+          <p:cNvPr id="5" name="Slide Number Placeholder 4">
+            <a:extLst>
+              <a:ext uri="{FF2B5EF4-FFF2-40B4-BE49-F238E27FC236}">
+                <a16:creationId xmlns:a16="http://schemas.microsoft.com/office/drawing/2014/main" id="{4FCC6D4E-9044-2CAD-117A-ED6DD8B58C37}"/>
               </a:ext>
             </a:extLst>
           </p:cNvPr>
@@ -11083,65 +11470,388 @@
       </p:sp>
       <p:sp>
         <p:nvSpPr>
+          <p:cNvPr id="4" name="TextBox 3">
+            <a:extLst>
+              <a:ext uri="{FF2B5EF4-FFF2-40B4-BE49-F238E27FC236}">
+                <a16:creationId xmlns:a16="http://schemas.microsoft.com/office/drawing/2014/main" id="{0B9F7036-758E-E421-FFF7-216D86E9AE44}"/>
+              </a:ext>
+            </a:extLst>
+          </p:cNvPr>
+          <p:cNvSpPr txBox="1"/>
+          <p:nvPr/>
+        </p:nvSpPr>
+        <p:spPr>
+          <a:xfrm>
+            <a:off x="1927865" y="1825625"/>
+            <a:ext cx="8336269" cy="754053"/>
+          </a:xfrm>
+          <a:prstGeom prst="rect">
+            <a:avLst/>
+          </a:prstGeom>
+          <a:solidFill>
+            <a:schemeClr val="bg1"/>
+          </a:solidFill>
+          <a:ln w="19050">
+            <a:solidFill>
+              <a:schemeClr val="tx1"/>
+            </a:solidFill>
+          </a:ln>
+        </p:spPr>
+        <p:txBody>
+          <a:bodyPr wrap="square">
+            <a:spAutoFit/>
+          </a:bodyPr>
+          <a:lstStyle/>
+          <a:p>
+            <a:br>
+              <a:rPr lang="pt-BR" sz="100" b="1" dirty="0">
+                <a:latin typeface="Consolas" panose="020B0609020204030204" pitchFamily="49" charset="0"/>
+              </a:rPr>
+            </a:br>
+            <a:r>
+              <a:rPr lang="pt-BR" sz="2000" b="1" dirty="0">
+                <a:latin typeface="Consolas" panose="020B0609020204030204" pitchFamily="49" charset="0"/>
+              </a:rPr>
+              <a:t>def foo(</a:t>
+            </a:r>
+            <a:r>
+              <a:rPr lang="pt-BR" sz="2000" b="1" dirty="0">
+                <a:solidFill>
+                  <a:srgbClr val="00B0F0"/>
+                </a:solidFill>
+                <a:latin typeface="Consolas" panose="020B0609020204030204" pitchFamily="49" charset="0"/>
+              </a:rPr>
+              <a:t>p1</a:t>
+            </a:r>
+            <a:r>
+              <a:rPr lang="pt-BR" sz="2000" b="1" dirty="0">
+                <a:latin typeface="Consolas" panose="020B0609020204030204" pitchFamily="49" charset="0"/>
+              </a:rPr>
+              <a:t>, </a:t>
+            </a:r>
+            <a:r>
+              <a:rPr lang="pt-BR" sz="2000" b="1" dirty="0">
+                <a:solidFill>
+                  <a:srgbClr val="00B0F0"/>
+                </a:solidFill>
+                <a:latin typeface="Consolas" panose="020B0609020204030204" pitchFamily="49" charset="0"/>
+              </a:rPr>
+              <a:t>p2</a:t>
+            </a:r>
+            <a:r>
+              <a:rPr lang="pt-BR" sz="2000" b="1" dirty="0">
+                <a:latin typeface="Consolas" panose="020B0609020204030204" pitchFamily="49" charset="0"/>
+              </a:rPr>
+              <a:t>, </a:t>
+            </a:r>
+            <a:r>
+              <a:rPr lang="pt-BR" sz="2000" b="1" dirty="0">
+                <a:solidFill>
+                  <a:srgbClr val="00B0F0"/>
+                </a:solidFill>
+                <a:latin typeface="Consolas" panose="020B0609020204030204" pitchFamily="49" charset="0"/>
+              </a:rPr>
+              <a:t>...</a:t>
+            </a:r>
+            <a:r>
+              <a:rPr lang="pt-BR" sz="2000" b="1" dirty="0">
+                <a:latin typeface="Consolas" panose="020B0609020204030204" pitchFamily="49" charset="0"/>
+              </a:rPr>
+              <a:t>, </a:t>
+            </a:r>
+            <a:r>
+              <a:rPr lang="pt-BR" sz="2000" b="1" dirty="0">
+                <a:solidFill>
+                  <a:srgbClr val="7030A0"/>
+                </a:solidFill>
+                <a:latin typeface="Consolas" panose="020B0609020204030204" pitchFamily="49" charset="0"/>
+              </a:rPr>
+              <a:t>*args</a:t>
+            </a:r>
+            <a:r>
+              <a:rPr lang="pt-BR" sz="2000" b="1" dirty="0">
+                <a:latin typeface="Consolas" panose="020B0609020204030204" pitchFamily="49" charset="0"/>
+              </a:rPr>
+              <a:t>, </a:t>
+            </a:r>
+            <a:r>
+              <a:rPr lang="pt-BR" sz="2000" b="1" dirty="0">
+                <a:solidFill>
+                  <a:schemeClr val="accent6"/>
+                </a:solidFill>
+                <a:latin typeface="Consolas" panose="020B0609020204030204" pitchFamily="49" charset="0"/>
+              </a:rPr>
+              <a:t>n1=v1</a:t>
+            </a:r>
+            <a:r>
+              <a:rPr lang="pt-BR" sz="2000" b="1" dirty="0">
+                <a:latin typeface="Consolas" panose="020B0609020204030204" pitchFamily="49" charset="0"/>
+              </a:rPr>
+              <a:t>, </a:t>
+            </a:r>
+            <a:r>
+              <a:rPr lang="pt-BR" sz="2000" b="1" dirty="0">
+                <a:solidFill>
+                  <a:schemeClr val="accent6"/>
+                </a:solidFill>
+                <a:latin typeface="Consolas" panose="020B0609020204030204" pitchFamily="49" charset="0"/>
+              </a:rPr>
+              <a:t>n2=v2</a:t>
+            </a:r>
+            <a:r>
+              <a:rPr lang="pt-BR" sz="2000" b="1" dirty="0">
+                <a:latin typeface="Consolas" panose="020B0609020204030204" pitchFamily="49" charset="0"/>
+              </a:rPr>
+              <a:t>, </a:t>
+            </a:r>
+            <a:r>
+              <a:rPr lang="pt-BR" sz="2000" b="1" dirty="0">
+                <a:solidFill>
+                  <a:schemeClr val="accent6"/>
+                </a:solidFill>
+                <a:latin typeface="Consolas" panose="020B0609020204030204" pitchFamily="49" charset="0"/>
+              </a:rPr>
+              <a:t>...</a:t>
+            </a:r>
+            <a:r>
+              <a:rPr lang="pt-BR" sz="2000" b="1" dirty="0">
+                <a:latin typeface="Consolas" panose="020B0609020204030204" pitchFamily="49" charset="0"/>
+              </a:rPr>
+              <a:t>, </a:t>
+            </a:r>
+            <a:r>
+              <a:rPr lang="pt-BR" sz="2000" b="1" dirty="0">
+                <a:solidFill>
+                  <a:schemeClr val="accent2"/>
+                </a:solidFill>
+                <a:latin typeface="Consolas" panose="020B0609020204030204" pitchFamily="49" charset="0"/>
+              </a:rPr>
+              <a:t>**kwargs</a:t>
+            </a:r>
+            <a:r>
+              <a:rPr lang="pt-BR" sz="2000" b="1" dirty="0">
+                <a:latin typeface="Consolas" panose="020B0609020204030204" pitchFamily="49" charset="0"/>
+              </a:rPr>
+              <a:t>):</a:t>
+            </a:r>
+          </a:p>
+          <a:p>
+            <a:endParaRPr lang="pt-BR" sz="100" b="1" dirty="0">
+              <a:latin typeface="Consolas" panose="020B0609020204030204" pitchFamily="49" charset="0"/>
+            </a:endParaRPr>
+          </a:p>
+          <a:p>
+            <a:r>
+              <a:rPr lang="pt-BR" sz="2000" b="1" dirty="0">
+                <a:latin typeface="Consolas" panose="020B0609020204030204" pitchFamily="49" charset="0"/>
+              </a:rPr>
+              <a:t>  ...</a:t>
+            </a:r>
+          </a:p>
+          <a:p>
+            <a:endParaRPr lang="fr-CA" sz="100" dirty="0"/>
+          </a:p>
+        </p:txBody>
+      </p:sp>
+      <p:sp>
+        <p:nvSpPr>
           <p:cNvPr id="9" name="Content Placeholder 2">
             <a:extLst>
               <a:ext uri="{FF2B5EF4-FFF2-40B4-BE49-F238E27FC236}">
-                <a16:creationId xmlns:a16="http://schemas.microsoft.com/office/drawing/2014/main" id="{431F6E27-257B-2553-4FF3-7C114074BCBC}"/>
+                <a16:creationId xmlns:a16="http://schemas.microsoft.com/office/drawing/2014/main" id="{1AA0F8DA-6A48-C0B3-BC29-66738FE64C26}"/>
               </a:ext>
             </a:extLst>
           </p:cNvPr>
-          <p:cNvSpPr>
-            <a:spLocks noGrp="1"/>
+          <p:cNvSpPr txBox="1">
+            <a:spLocks/>
           </p:cNvSpPr>
-          <p:nvPr>
-            <p:ph idx="1"/>
-          </p:nvPr>
+          <p:nvPr/>
         </p:nvSpPr>
         <p:spPr>
           <a:xfrm>
-            <a:off x="838200" y="1825625"/>
+            <a:off x="990600" y="1978025"/>
             <a:ext cx="10515600" cy="4351338"/>
           </a:xfrm>
+          <a:prstGeom prst="rect">
+            <a:avLst/>
+          </a:prstGeom>
         </p:spPr>
         <p:txBody>
-          <a:bodyPr>
+          <a:bodyPr vert="horz" lIns="91440" tIns="45720" rIns="91440" bIns="45720" rtlCol="0">
             <a:normAutofit/>
           </a:bodyPr>
-          <a:lstStyle/>
-          <a:p>
-            <a:pPr marL="514350" indent="-514350" algn="just">
-              <a:buFont typeface="+mj-lt"/>
-              <a:buAutoNum type="arabicPeriod"/>
+          <a:lstStyle>
+            <a:lvl1pPr marL="228600" indent="-228600" algn="l" defTabSz="914400" rtl="0" eaLnBrk="1" latinLnBrk="0" hangingPunct="1">
+              <a:lnSpc>
+                <a:spcPct val="90000"/>
+              </a:lnSpc>
+              <a:spcBef>
+                <a:spcPts val="1000"/>
+              </a:spcBef>
+              <a:buFont typeface="Arial" panose="020B0604020202020204" pitchFamily="34" charset="0"/>
+              <a:buChar char="•"/>
+              <a:defRPr sz="2800" kern="1200">
+                <a:solidFill>
+                  <a:schemeClr val="tx1"/>
+                </a:solidFill>
+                <a:latin typeface="+mn-lt"/>
+                <a:ea typeface="+mn-ea"/>
+                <a:cs typeface="+mn-cs"/>
+              </a:defRPr>
+            </a:lvl1pPr>
+            <a:lvl2pPr marL="685800" indent="-228600" algn="l" defTabSz="914400" rtl="0" eaLnBrk="1" latinLnBrk="0" hangingPunct="1">
+              <a:lnSpc>
+                <a:spcPct val="90000"/>
+              </a:lnSpc>
+              <a:spcBef>
+                <a:spcPts val="500"/>
+              </a:spcBef>
+              <a:buFont typeface="Arial" panose="020B0604020202020204" pitchFamily="34" charset="0"/>
+              <a:buChar char="•"/>
+              <a:defRPr sz="2400" kern="1200">
+                <a:solidFill>
+                  <a:schemeClr val="tx1"/>
+                </a:solidFill>
+                <a:latin typeface="+mn-lt"/>
+                <a:ea typeface="+mn-ea"/>
+                <a:cs typeface="+mn-cs"/>
+              </a:defRPr>
+            </a:lvl2pPr>
+            <a:lvl3pPr marL="1143000" indent="-228600" algn="l" defTabSz="914400" rtl="0" eaLnBrk="1" latinLnBrk="0" hangingPunct="1">
+              <a:lnSpc>
+                <a:spcPct val="90000"/>
+              </a:lnSpc>
+              <a:spcBef>
+                <a:spcPts val="500"/>
+              </a:spcBef>
+              <a:buFont typeface="Arial" panose="020B0604020202020204" pitchFamily="34" charset="0"/>
+              <a:buChar char="•"/>
+              <a:defRPr sz="2000" kern="1200">
+                <a:solidFill>
+                  <a:schemeClr val="tx1"/>
+                </a:solidFill>
+                <a:latin typeface="+mn-lt"/>
+                <a:ea typeface="+mn-ea"/>
+                <a:cs typeface="+mn-cs"/>
+              </a:defRPr>
+            </a:lvl3pPr>
+            <a:lvl4pPr marL="1600200" indent="-228600" algn="l" defTabSz="914400" rtl="0" eaLnBrk="1" latinLnBrk="0" hangingPunct="1">
+              <a:lnSpc>
+                <a:spcPct val="90000"/>
+              </a:lnSpc>
+              <a:spcBef>
+                <a:spcPts val="500"/>
+              </a:spcBef>
+              <a:buFont typeface="Arial" panose="020B0604020202020204" pitchFamily="34" charset="0"/>
+              <a:buChar char="•"/>
+              <a:defRPr sz="1800" kern="1200">
+                <a:solidFill>
+                  <a:schemeClr val="tx1"/>
+                </a:solidFill>
+                <a:latin typeface="+mn-lt"/>
+                <a:ea typeface="+mn-ea"/>
+                <a:cs typeface="+mn-cs"/>
+              </a:defRPr>
+            </a:lvl4pPr>
+            <a:lvl5pPr marL="2057400" indent="-228600" algn="l" defTabSz="914400" rtl="0" eaLnBrk="1" latinLnBrk="0" hangingPunct="1">
+              <a:lnSpc>
+                <a:spcPct val="90000"/>
+              </a:lnSpc>
+              <a:spcBef>
+                <a:spcPts val="500"/>
+              </a:spcBef>
+              <a:buFont typeface="Arial" panose="020B0604020202020204" pitchFamily="34" charset="0"/>
+              <a:buChar char="•"/>
+              <a:defRPr sz="1800" kern="1200">
+                <a:solidFill>
+                  <a:schemeClr val="tx1"/>
+                </a:solidFill>
+                <a:latin typeface="+mn-lt"/>
+                <a:ea typeface="+mn-ea"/>
+                <a:cs typeface="+mn-cs"/>
+              </a:defRPr>
+            </a:lvl5pPr>
+            <a:lvl6pPr marL="2514600" indent="-228600" algn="l" defTabSz="914400" rtl="0" eaLnBrk="1" latinLnBrk="0" hangingPunct="1">
+              <a:lnSpc>
+                <a:spcPct val="90000"/>
+              </a:lnSpc>
+              <a:spcBef>
+                <a:spcPts val="500"/>
+              </a:spcBef>
+              <a:buFont typeface="Arial" panose="020B0604020202020204" pitchFamily="34" charset="0"/>
+              <a:buChar char="•"/>
+              <a:defRPr sz="1800" kern="1200">
+                <a:solidFill>
+                  <a:schemeClr val="tx1"/>
+                </a:solidFill>
+                <a:latin typeface="+mn-lt"/>
+                <a:ea typeface="+mn-ea"/>
+                <a:cs typeface="+mn-cs"/>
+              </a:defRPr>
+            </a:lvl6pPr>
+            <a:lvl7pPr marL="2971800" indent="-228600" algn="l" defTabSz="914400" rtl="0" eaLnBrk="1" latinLnBrk="0" hangingPunct="1">
+              <a:lnSpc>
+                <a:spcPct val="90000"/>
+              </a:lnSpc>
+              <a:spcBef>
+                <a:spcPts val="500"/>
+              </a:spcBef>
+              <a:buFont typeface="Arial" panose="020B0604020202020204" pitchFamily="34" charset="0"/>
+              <a:buChar char="•"/>
+              <a:defRPr sz="1800" kern="1200">
+                <a:solidFill>
+                  <a:schemeClr val="tx1"/>
+                </a:solidFill>
+                <a:latin typeface="+mn-lt"/>
+                <a:ea typeface="+mn-ea"/>
+                <a:cs typeface="+mn-cs"/>
+              </a:defRPr>
+            </a:lvl7pPr>
+            <a:lvl8pPr marL="3429000" indent="-228600" algn="l" defTabSz="914400" rtl="0" eaLnBrk="1" latinLnBrk="0" hangingPunct="1">
+              <a:lnSpc>
+                <a:spcPct val="90000"/>
+              </a:lnSpc>
+              <a:spcBef>
+                <a:spcPts val="500"/>
+              </a:spcBef>
+              <a:buFont typeface="Arial" panose="020B0604020202020204" pitchFamily="34" charset="0"/>
+              <a:buChar char="•"/>
+              <a:defRPr sz="1800" kern="1200">
+                <a:solidFill>
+                  <a:schemeClr val="tx1"/>
+                </a:solidFill>
+                <a:latin typeface="+mn-lt"/>
+                <a:ea typeface="+mn-ea"/>
+                <a:cs typeface="+mn-cs"/>
+              </a:defRPr>
+            </a:lvl8pPr>
+            <a:lvl9pPr marL="3886200" indent="-228600" algn="l" defTabSz="914400" rtl="0" eaLnBrk="1" latinLnBrk="0" hangingPunct="1">
+              <a:lnSpc>
+                <a:spcPct val="90000"/>
+              </a:lnSpc>
+              <a:spcBef>
+                <a:spcPts val="500"/>
+              </a:spcBef>
+              <a:buFont typeface="Arial" panose="020B0604020202020204" pitchFamily="34" charset="0"/>
+              <a:buChar char="•"/>
+              <a:defRPr sz="1800" kern="1200">
+                <a:solidFill>
+                  <a:schemeClr val="tx1"/>
+                </a:solidFill>
+                <a:latin typeface="+mn-lt"/>
+                <a:ea typeface="+mn-ea"/>
+                <a:cs typeface="+mn-cs"/>
+              </a:defRPr>
+            </a:lvl9pPr>
+          </a:lstStyle>
+          <a:p>
+            <a:pPr marL="457200" lvl="1" indent="0" algn="just">
+              <a:lnSpc>
+                <a:spcPct val="150000"/>
+              </a:lnSpc>
+              <a:buNone/>
             </a:pPr>
-            <a:r>
-              <a:rPr lang="en-US" dirty="0"/>
-              <a:t>Butler, Simon; </a:t>
-            </a:r>
-            <a:r>
-              <a:rPr lang="en-US" dirty="0" err="1"/>
-              <a:t>Wermelinger</a:t>
-            </a:r>
-            <a:r>
-              <a:rPr lang="en-US" dirty="0"/>
-              <a:t>, Michel; Yu, Yijun and Sharp, Helen (2010). Exploring the Influence of </a:t>
-            </a:r>
-            <a:r>
-              <a:rPr lang="en-US" dirty="0" err="1"/>
-              <a:t>IdentifierNames</a:t>
-            </a:r>
-            <a:r>
-              <a:rPr lang="en-US" dirty="0"/>
-              <a:t> on Code Quality: An empirical study. In: 14th European Conference on Software Maintenance </a:t>
-            </a:r>
-            <a:r>
-              <a:rPr lang="en-US" dirty="0" err="1"/>
-              <a:t>andReengineering</a:t>
-            </a:r>
-            <a:r>
-              <a:rPr lang="en-US" dirty="0"/>
-              <a:t>, 15-18 Mar 2010, Madrid, Spain, pp. 156–165.</a:t>
-            </a:r>
-            <a:endParaRPr lang="pt-BR" sz="2600" dirty="0">
+            <a:endParaRPr lang="en-US" sz="1800" b="1" dirty="0">
               <a:latin typeface="Consolas" panose="020B0609020204030204" pitchFamily="49" charset="0"/>
             </a:endParaRPr>
           </a:p>
@@ -11150,13 +11860,109 @@
     </p:spTree>
     <p:extLst>
       <p:ext uri="{BB962C8B-B14F-4D97-AF65-F5344CB8AC3E}">
-        <p14:creationId xmlns:p14="http://schemas.microsoft.com/office/powerpoint/2010/main" val="4215596461"/>
+        <p14:creationId xmlns:p14="http://schemas.microsoft.com/office/powerpoint/2010/main" val="1419331967"/>
       </p:ext>
     </p:extLst>
   </p:cSld>
   <p:clrMapOvr>
     <a:masterClrMapping/>
   </p:clrMapOvr>
+  <p:timing>
+    <p:tnLst>
+      <p:par>
+        <p:cTn id="1" dur="indefinite" restart="never" nodeType="tmRoot">
+          <p:childTnLst>
+            <p:seq concurrent="1" nextAc="seek">
+              <p:cTn id="2" dur="indefinite" nodeType="mainSeq">
+                <p:childTnLst>
+                  <p:par>
+                    <p:cTn id="3" fill="hold">
+                      <p:stCondLst>
+                        <p:cond delay="indefinite"/>
+                      </p:stCondLst>
+                      <p:childTnLst>
+                        <p:par>
+                          <p:cTn id="4" fill="hold">
+                            <p:stCondLst>
+                              <p:cond delay="0"/>
+                            </p:stCondLst>
+                            <p:childTnLst>
+                              <p:par>
+                                <p:cTn id="5" presetID="10" presetClass="entr" presetSubtype="0" fill="hold" nodeType="clickEffect" nodePh="1">
+                                  <p:stCondLst>
+                                    <p:cond delay="0"/>
+                                  </p:stCondLst>
+                                  <p:endCondLst>
+                                    <p:cond evt="begin" delay="0">
+                                      <p:tn val="5"/>
+                                    </p:cond>
+                                  </p:endCondLst>
+                                  <p:childTnLst>
+                                    <p:set>
+                                      <p:cBhvr>
+                                        <p:cTn id="6" dur="1" fill="hold">
+                                          <p:stCondLst>
+                                            <p:cond delay="0"/>
+                                          </p:stCondLst>
+                                        </p:cTn>
+                                        <p:tgtEl>
+                                          <p:spTgt spid="9">
+                                            <p:txEl>
+                                              <p:pRg st="0" end="0"/>
+                                            </p:txEl>
+                                          </p:spTgt>
+                                        </p:tgtEl>
+                                        <p:attrNameLst>
+                                          <p:attrName>style.visibility</p:attrName>
+                                        </p:attrNameLst>
+                                      </p:cBhvr>
+                                      <p:to>
+                                        <p:strVal val="visible"/>
+                                      </p:to>
+                                    </p:set>
+                                    <p:animEffect transition="in" filter="fade">
+                                      <p:cBhvr>
+                                        <p:cTn id="7" dur="500"/>
+                                        <p:tgtEl>
+                                          <p:spTgt spid="9">
+                                            <p:txEl>
+                                              <p:pRg st="0" end="0"/>
+                                            </p:txEl>
+                                          </p:spTgt>
+                                        </p:tgtEl>
+                                      </p:cBhvr>
+                                    </p:animEffect>
+                                  </p:childTnLst>
+                                </p:cTn>
+                              </p:par>
+                            </p:childTnLst>
+                          </p:cTn>
+                        </p:par>
+                      </p:childTnLst>
+                    </p:cTn>
+                  </p:par>
+                </p:childTnLst>
+              </p:cTn>
+              <p:prevCondLst>
+                <p:cond evt="onPrev" delay="0">
+                  <p:tgtEl>
+                    <p:sldTgt/>
+                  </p:tgtEl>
+                </p:cond>
+              </p:prevCondLst>
+              <p:nextCondLst>
+                <p:cond evt="onNext" delay="0">
+                  <p:tgtEl>
+                    <p:sldTgt/>
+                  </p:tgtEl>
+                </p:cond>
+              </p:nextCondLst>
+            </p:seq>
+          </p:childTnLst>
+        </p:cTn>
+      </p:par>
+    </p:tnLst>
+  </p:timing>
 </p:sld>
 </file>
 
@@ -11166,7 +11972,10 @@
     <p:bg>
       <p:bgPr>
         <a:solidFill>
-          <a:srgbClr val="F5F5F5"/>
+          <a:schemeClr val="accent6">
+            <a:lumMod val="20000"/>
+            <a:lumOff val="80000"/>
+          </a:schemeClr>
         </a:solidFill>
         <a:effectLst/>
       </p:bgPr>
@@ -11176,7 +11985,7 @@
         <p:cNvPr id="1" name="">
           <a:extLst>
             <a:ext uri="{FF2B5EF4-FFF2-40B4-BE49-F238E27FC236}">
-              <a16:creationId xmlns:a16="http://schemas.microsoft.com/office/drawing/2014/main" id="{F4FE6B38-1704-6F06-89FE-FA013387C16F}"/>
+              <a16:creationId xmlns:a16="http://schemas.microsoft.com/office/drawing/2014/main" id="{12B613ED-4C20-B810-736E-08E5068F9C51}"/>
             </a:ext>
           </a:extLst>
         </p:cNvPr>
@@ -11196,7 +12005,7 @@
           <p:cNvPr id="2" name="Title 1">
             <a:extLst>
               <a:ext uri="{FF2B5EF4-FFF2-40B4-BE49-F238E27FC236}">
-                <a16:creationId xmlns:a16="http://schemas.microsoft.com/office/drawing/2014/main" id="{52A402DF-FA1B-9ED3-5AC6-0C835AF415CA}"/>
+                <a16:creationId xmlns:a16="http://schemas.microsoft.com/office/drawing/2014/main" id="{01CEAD93-2D28-3BC9-2E9D-896F6B4181BB}"/>
               </a:ext>
             </a:extLst>
           </p:cNvPr>
@@ -11216,7 +12025,13 @@
               <a:rPr lang="en-US" dirty="0">
                 <a:latin typeface="Arial Rounded MT Bold" panose="020F0704030504030204" pitchFamily="34" charset="0"/>
               </a:rPr>
-              <a:t>Bilan</a:t>
+              <a:t>XR6 – Lecture </a:t>
+            </a:r>
+            <a:r>
+              <a:rPr lang="en-US" dirty="0" err="1">
+                <a:latin typeface="Arial Rounded MT Bold" panose="020F0704030504030204" pitchFamily="34" charset="0"/>
+              </a:rPr>
+              <a:t>dirigée</a:t>
             </a:r>
             <a:endParaRPr lang="fr-CA" dirty="0">
               <a:latin typeface="Arial Rounded MT Bold" panose="020F0704030504030204" pitchFamily="34" charset="0"/>
@@ -11229,7 +12044,7 @@
           <p:cNvPr id="3" name="Content Placeholder 2">
             <a:extLst>
               <a:ext uri="{FF2B5EF4-FFF2-40B4-BE49-F238E27FC236}">
-                <a16:creationId xmlns:a16="http://schemas.microsoft.com/office/drawing/2014/main" id="{D21CBD71-C056-4558-D771-2E0CD665AD0A}"/>
+                <a16:creationId xmlns:a16="http://schemas.microsoft.com/office/drawing/2014/main" id="{209ABF4A-28F0-C642-B07B-85B4C439D074}"/>
               </a:ext>
             </a:extLst>
           </p:cNvPr>
@@ -11247,21 +12062,199 @@
           </a:bodyPr>
           <a:lstStyle/>
           <a:p>
-            <a:r>
-              <a:rPr lang="pt-BR" sz="2600" b="1" dirty="0">
-                <a:latin typeface="Consolas" panose="020B0609020204030204" pitchFamily="49" charset="0"/>
-              </a:rPr>
-              <a:t>...</a:t>
-            </a:r>
+            <a:pPr marL="0" indent="0" algn="just">
+              <a:lnSpc>
+                <a:spcPct val="100000"/>
+              </a:lnSpc>
+              <a:buNone/>
+            </a:pPr>
+            <a:r>
+              <a:rPr lang="en-US" sz="2000" dirty="0" err="1">
+                <a:latin typeface="Consolas" panose="020B0609020204030204" pitchFamily="49" charset="0"/>
+              </a:rPr>
+              <a:t>Décrivez</a:t>
+            </a:r>
+            <a:r>
+              <a:rPr lang="en-US" sz="2000" dirty="0">
+                <a:latin typeface="Consolas" panose="020B0609020204030204" pitchFamily="49" charset="0"/>
+              </a:rPr>
+              <a:t> la </a:t>
+            </a:r>
+            <a:r>
+              <a:rPr lang="en-US" sz="2000" dirty="0" err="1">
+                <a:latin typeface="Consolas" panose="020B0609020204030204" pitchFamily="49" charset="0"/>
+              </a:rPr>
+              <a:t>fonction</a:t>
+            </a:r>
+            <a:r>
+              <a:rPr lang="en-US" sz="2000" dirty="0">
+                <a:latin typeface="Consolas" panose="020B0609020204030204" pitchFamily="49" charset="0"/>
+              </a:rPr>
+              <a:t> </a:t>
+            </a:r>
+            <a:r>
+              <a:rPr lang="en-US" sz="2000" dirty="0" err="1">
+                <a:latin typeface="Consolas" panose="020B0609020204030204" pitchFamily="49" charset="0"/>
+              </a:rPr>
+              <a:t>suivante</a:t>
+            </a:r>
+            <a:r>
+              <a:rPr lang="en-US" sz="2000" dirty="0">
+                <a:latin typeface="Consolas" panose="020B0609020204030204" pitchFamily="49" charset="0"/>
+              </a:rPr>
+              <a:t> à </a:t>
+            </a:r>
+            <a:r>
+              <a:rPr lang="en-US" sz="2000" dirty="0" err="1">
+                <a:latin typeface="Consolas" panose="020B0609020204030204" pitchFamily="49" charset="0"/>
+              </a:rPr>
+              <a:t>partir</a:t>
+            </a:r>
+            <a:r>
+              <a:rPr lang="en-US" sz="2000" dirty="0">
+                <a:latin typeface="Consolas" panose="020B0609020204030204" pitchFamily="49" charset="0"/>
+              </a:rPr>
+              <a:t> de </a:t>
+            </a:r>
+            <a:r>
+              <a:rPr lang="en-US" sz="2000" dirty="0" err="1">
+                <a:latin typeface="Consolas" panose="020B0609020204030204" pitchFamily="49" charset="0"/>
+              </a:rPr>
+              <a:t>sa</a:t>
+            </a:r>
+            <a:r>
+              <a:rPr lang="en-US" sz="2000" dirty="0">
+                <a:latin typeface="Consolas" panose="020B0609020204030204" pitchFamily="49" charset="0"/>
+              </a:rPr>
+              <a:t> signature et de la documentation </a:t>
+            </a:r>
+            <a:r>
+              <a:rPr lang="en-US" sz="2000" dirty="0" err="1">
+                <a:latin typeface="Consolas" panose="020B0609020204030204" pitchFamily="49" charset="0"/>
+              </a:rPr>
+              <a:t>suivante</a:t>
+            </a:r>
+            <a:r>
+              <a:rPr lang="en-US" sz="2000" dirty="0">
+                <a:latin typeface="Consolas" panose="020B0609020204030204" pitchFamily="49" charset="0"/>
+              </a:rPr>
+              <a:t>: </a:t>
+            </a:r>
+          </a:p>
+          <a:p>
+            <a:pPr marL="0" indent="0" algn="just">
+              <a:lnSpc>
+                <a:spcPct val="100000"/>
+              </a:lnSpc>
+              <a:buNone/>
+            </a:pPr>
+            <a:endParaRPr lang="en-US" sz="100" dirty="0">
+              <a:latin typeface="Consolas" panose="020B0609020204030204" pitchFamily="49" charset="0"/>
+            </a:endParaRPr>
+          </a:p>
+          <a:p>
+            <a:pPr lvl="1" algn="just">
+              <a:lnSpc>
+                <a:spcPct val="150000"/>
+              </a:lnSpc>
+            </a:pPr>
+            <a:r>
+              <a:rPr lang="en-US" sz="1400" dirty="0">
+                <a:latin typeface="Consolas" panose="020B0609020204030204" pitchFamily="49" charset="0"/>
+                <a:hlinkClick r:id="rId2"/>
+              </a:rPr>
+              <a:t>https://docs.python.org/fr/3.14/reference/compound_stmts.html#the-for-statement</a:t>
+            </a:r>
+            <a:endParaRPr lang="en-US" sz="1400" dirty="0">
+              <a:latin typeface="Consolas" panose="020B0609020204030204" pitchFamily="49" charset="0"/>
+            </a:endParaRPr>
+          </a:p>
+          <a:p>
+            <a:pPr lvl="1" algn="just">
+              <a:lnSpc>
+                <a:spcPct val="150000"/>
+              </a:lnSpc>
+            </a:pPr>
+            <a:r>
+              <a:rPr lang="en-US" sz="1400" dirty="0">
+                <a:latin typeface="Consolas" panose="020B0609020204030204" pitchFamily="49" charset="0"/>
+                <a:hlinkClick r:id="rId3"/>
+              </a:rPr>
+              <a:t>https://docs.python.org/fr/3.14/reference/expressions.html#slicings</a:t>
+            </a:r>
+          </a:p>
+          <a:p>
+            <a:pPr lvl="1" algn="just">
+              <a:lnSpc>
+                <a:spcPct val="150000"/>
+              </a:lnSpc>
+            </a:pPr>
+            <a:r>
+              <a:rPr lang="en-US" sz="1400" dirty="0">
+                <a:latin typeface="Consolas" panose="020B0609020204030204" pitchFamily="49" charset="0"/>
+                <a:hlinkClick r:id="rId3"/>
+              </a:rPr>
+              <a:t>https://docs.python.org/fr/3.14/reference/simple_stmts.html#augmented-assignment-statements</a:t>
+            </a:r>
+            <a:endParaRPr lang="en-US" sz="1400" dirty="0">
+              <a:latin typeface="Consolas" panose="020B0609020204030204" pitchFamily="49" charset="0"/>
+            </a:endParaRPr>
+          </a:p>
+          <a:p>
+            <a:pPr lvl="1" algn="just">
+              <a:lnSpc>
+                <a:spcPct val="150000"/>
+              </a:lnSpc>
+            </a:pPr>
+            <a:r>
+              <a:rPr lang="en-US" sz="1400" dirty="0">
+                <a:latin typeface="Consolas" panose="020B0609020204030204" pitchFamily="49" charset="0"/>
+                <a:hlinkClick r:id="rId4"/>
+              </a:rPr>
+              <a:t>https://docs.python.org/fr/3.14/library/stdtypes.html#str</a:t>
+            </a:r>
+            <a:endParaRPr lang="en-US" sz="1400" dirty="0">
+              <a:latin typeface="Consolas" panose="020B0609020204030204" pitchFamily="49" charset="0"/>
+            </a:endParaRPr>
+          </a:p>
+          <a:p>
+            <a:pPr algn="just"/>
+            <a:endParaRPr lang="en-US" sz="2000" dirty="0">
+              <a:latin typeface="Consolas" panose="020B0609020204030204" pitchFamily="49" charset="0"/>
+            </a:endParaRPr>
+          </a:p>
+          <a:p>
+            <a:pPr marL="0" indent="0" algn="just">
+              <a:buNone/>
+            </a:pPr>
+            <a:endParaRPr lang="en-US" sz="2000" dirty="0">
+              <a:latin typeface="Consolas" panose="020B0609020204030204" pitchFamily="49" charset="0"/>
+            </a:endParaRPr>
+          </a:p>
+          <a:p>
+            <a:pPr marL="0" indent="0" algn="just">
+              <a:buNone/>
+            </a:pPr>
+            <a:endParaRPr lang="en-US" sz="2000" dirty="0">
+              <a:latin typeface="Consolas" panose="020B0609020204030204" pitchFamily="49" charset="0"/>
+            </a:endParaRPr>
+          </a:p>
+          <a:p>
+            <a:pPr marL="0" indent="0" algn="just">
+              <a:buNone/>
+            </a:pPr>
+            <a:endParaRPr lang="en-US" sz="2000" dirty="0">
+              <a:latin typeface="Consolas" panose="020B0609020204030204" pitchFamily="49" charset="0"/>
+            </a:endParaRPr>
           </a:p>
         </p:txBody>
       </p:sp>
       <p:sp>
         <p:nvSpPr>
-          <p:cNvPr id="11" name="Slide Number Placeholder 10">
+          <p:cNvPr id="4" name="Slide Number Placeholder 3">
             <a:extLst>
               <a:ext uri="{FF2B5EF4-FFF2-40B4-BE49-F238E27FC236}">
-                <a16:creationId xmlns:a16="http://schemas.microsoft.com/office/drawing/2014/main" id="{214D04C3-CF8C-FC10-8DAA-B190C95D3746}"/>
+                <a16:creationId xmlns:a16="http://schemas.microsoft.com/office/drawing/2014/main" id="{06432649-ACCF-C494-8C4D-BD60A1909A70}"/>
               </a:ext>
             </a:extLst>
           </p:cNvPr>
@@ -11285,10 +12278,181 @@
           </a:p>
         </p:txBody>
       </p:sp>
+      <p:sp>
+        <p:nvSpPr>
+          <p:cNvPr id="6" name="TextBox 5">
+            <a:extLst>
+              <a:ext uri="{FF2B5EF4-FFF2-40B4-BE49-F238E27FC236}">
+                <a16:creationId xmlns:a16="http://schemas.microsoft.com/office/drawing/2014/main" id="{101C41D6-9989-63BC-E338-ED604AF40B76}"/>
+              </a:ext>
+            </a:extLst>
+          </p:cNvPr>
+          <p:cNvSpPr txBox="1"/>
+          <p:nvPr/>
+        </p:nvSpPr>
+        <p:spPr>
+          <a:xfrm>
+            <a:off x="3538857" y="4422637"/>
+            <a:ext cx="5114285" cy="1754326"/>
+          </a:xfrm>
+          <a:prstGeom prst="rect">
+            <a:avLst/>
+          </a:prstGeom>
+          <a:solidFill>
+            <a:schemeClr val="bg1"/>
+          </a:solidFill>
+          <a:ln w="19050">
+            <a:solidFill>
+              <a:schemeClr val="tx1"/>
+            </a:solidFill>
+          </a:ln>
+        </p:spPr>
+        <p:txBody>
+          <a:bodyPr wrap="square" anchor="ctr">
+            <a:spAutoFit/>
+          </a:bodyPr>
+          <a:lstStyle/>
+          <a:p>
+            <a:pPr marL="0" indent="0">
+              <a:buNone/>
+            </a:pPr>
+            <a:r>
+              <a:rPr lang="en-US" b="1" dirty="0">
+                <a:latin typeface="Consolas" panose="020B0609020204030204" pitchFamily="49" charset="0"/>
+              </a:rPr>
+              <a:t>def </a:t>
+            </a:r>
+            <a:r>
+              <a:rPr lang="en-US" b="1" dirty="0" err="1">
+                <a:latin typeface="Consolas" panose="020B0609020204030204" pitchFamily="49" charset="0"/>
+              </a:rPr>
+              <a:t>souder</a:t>
+            </a:r>
+            <a:r>
+              <a:rPr lang="en-US" b="1" dirty="0">
+                <a:latin typeface="Consolas" panose="020B0609020204030204" pitchFamily="49" charset="0"/>
+              </a:rPr>
+              <a:t>(*</a:t>
+            </a:r>
+            <a:r>
+              <a:rPr lang="en-US" b="1" dirty="0" err="1">
+                <a:latin typeface="Consolas" panose="020B0609020204030204" pitchFamily="49" charset="0"/>
+              </a:rPr>
+              <a:t>objets</a:t>
+            </a:r>
+            <a:r>
+              <a:rPr lang="en-US" b="1" dirty="0">
+                <a:latin typeface="Consolas" panose="020B0609020204030204" pitchFamily="49" charset="0"/>
+              </a:rPr>
+              <a:t>, </a:t>
+            </a:r>
+            <a:r>
+              <a:rPr lang="en-US" b="1" dirty="0" err="1">
+                <a:latin typeface="Consolas" panose="020B0609020204030204" pitchFamily="49" charset="0"/>
+              </a:rPr>
+              <a:t>sep</a:t>
+            </a:r>
+            <a:r>
+              <a:rPr lang="en-US" b="1" dirty="0">
+                <a:latin typeface="Consolas" panose="020B0609020204030204" pitchFamily="49" charset="0"/>
+              </a:rPr>
+              <a:t>=' ', end='\n'):</a:t>
+            </a:r>
+          </a:p>
+          <a:p>
+            <a:pPr marL="0" indent="0">
+              <a:buNone/>
+            </a:pPr>
+            <a:r>
+              <a:rPr lang="en-US" b="1" dirty="0">
+                <a:latin typeface="Consolas" panose="020B0609020204030204" pitchFamily="49" charset="0"/>
+              </a:rPr>
+              <a:t>  buffer = ''</a:t>
+            </a:r>
+          </a:p>
+          <a:p>
+            <a:pPr marL="0" indent="0">
+              <a:buNone/>
+            </a:pPr>
+            <a:r>
+              <a:rPr lang="en-US" b="1" dirty="0">
+                <a:latin typeface="Consolas" panose="020B0609020204030204" pitchFamily="49" charset="0"/>
+              </a:rPr>
+              <a:t>  for obj in </a:t>
+            </a:r>
+            <a:r>
+              <a:rPr lang="en-US" b="1" dirty="0" err="1">
+                <a:latin typeface="Consolas" panose="020B0609020204030204" pitchFamily="49" charset="0"/>
+              </a:rPr>
+              <a:t>objets</a:t>
+            </a:r>
+            <a:r>
+              <a:rPr lang="en-US" b="1" dirty="0">
+                <a:latin typeface="Consolas" panose="020B0609020204030204" pitchFamily="49" charset="0"/>
+              </a:rPr>
+              <a:t>[:-1]:</a:t>
+            </a:r>
+          </a:p>
+          <a:p>
+            <a:pPr marL="0" indent="0">
+              <a:buNone/>
+            </a:pPr>
+            <a:r>
+              <a:rPr lang="en-US" b="1" dirty="0">
+                <a:latin typeface="Consolas" panose="020B0609020204030204" pitchFamily="49" charset="0"/>
+              </a:rPr>
+              <a:t>    buffer += str(obj) + </a:t>
+            </a:r>
+            <a:r>
+              <a:rPr lang="en-US" b="1" dirty="0" err="1">
+                <a:latin typeface="Consolas" panose="020B0609020204030204" pitchFamily="49" charset="0"/>
+              </a:rPr>
+              <a:t>sep</a:t>
+            </a:r>
+            <a:endParaRPr lang="en-US" b="1" dirty="0">
+              <a:latin typeface="Consolas" panose="020B0609020204030204" pitchFamily="49" charset="0"/>
+            </a:endParaRPr>
+          </a:p>
+          <a:p>
+            <a:pPr marL="0" indent="0">
+              <a:buNone/>
+            </a:pPr>
+            <a:r>
+              <a:rPr lang="en-US" b="1" dirty="0">
+                <a:latin typeface="Consolas" panose="020B0609020204030204" pitchFamily="49" charset="0"/>
+              </a:rPr>
+              <a:t>  buffer += str(</a:t>
+            </a:r>
+            <a:r>
+              <a:rPr lang="en-US" b="1" dirty="0" err="1">
+                <a:latin typeface="Consolas" panose="020B0609020204030204" pitchFamily="49" charset="0"/>
+              </a:rPr>
+              <a:t>objets</a:t>
+            </a:r>
+            <a:r>
+              <a:rPr lang="en-US" b="1" dirty="0">
+                <a:latin typeface="Consolas" panose="020B0609020204030204" pitchFamily="49" charset="0"/>
+              </a:rPr>
+              <a:t>[-1]) + end</a:t>
+            </a:r>
+          </a:p>
+          <a:p>
+            <a:pPr marL="0" indent="0">
+              <a:buNone/>
+            </a:pPr>
+            <a:r>
+              <a:rPr lang="en-US" b="1" dirty="0">
+                <a:latin typeface="Consolas" panose="020B0609020204030204" pitchFamily="49" charset="0"/>
+              </a:rPr>
+              <a:t>  return buffer</a:t>
+            </a:r>
+          </a:p>
+        </p:txBody>
+      </p:sp>
     </p:spTree>
     <p:extLst>
       <p:ext uri="{BB962C8B-B14F-4D97-AF65-F5344CB8AC3E}">
-        <p14:creationId xmlns:p14="http://schemas.microsoft.com/office/powerpoint/2010/main" val="2334800325"/>
+        <p14:creationId xmlns:p14="http://schemas.microsoft.com/office/powerpoint/2010/main" val="2824829369"/>
       </p:ext>
     </p:extLst>
   </p:cSld>
@@ -12442,12 +13606,20 @@
 <file path=ppt/slides/slide20.xml><?xml version="1.0" encoding="utf-8"?>
 <p:sld xmlns:a="http://schemas.openxmlformats.org/drawingml/2006/main" xmlns:r="http://schemas.openxmlformats.org/officeDocument/2006/relationships" xmlns:p="http://schemas.openxmlformats.org/presentationml/2006/main">
   <p:cSld>
+    <p:bg>
+      <p:bgPr>
+        <a:solidFill>
+          <a:srgbClr val="F5F5F5"/>
+        </a:solidFill>
+        <a:effectLst/>
+      </p:bgPr>
+    </p:bg>
     <p:spTree>
       <p:nvGrpSpPr>
         <p:cNvPr id="1" name="">
           <a:extLst>
             <a:ext uri="{FF2B5EF4-FFF2-40B4-BE49-F238E27FC236}">
-              <a16:creationId xmlns:a16="http://schemas.microsoft.com/office/drawing/2014/main" id="{C4FE5AC6-E16E-CBF3-7DF3-37169D45026B}"/>
+              <a16:creationId xmlns:a16="http://schemas.microsoft.com/office/drawing/2014/main" id="{55DD9394-0F20-9ED4-27FF-70846487BACA}"/>
             </a:ext>
           </a:extLst>
         </p:cNvPr>
@@ -12467,7 +13639,7 @@
           <p:cNvPr id="2" name="Title 1">
             <a:extLst>
               <a:ext uri="{FF2B5EF4-FFF2-40B4-BE49-F238E27FC236}">
-                <a16:creationId xmlns:a16="http://schemas.microsoft.com/office/drawing/2014/main" id="{5750A927-3AF3-1105-1BE2-D370C7DAEA96}"/>
+                <a16:creationId xmlns:a16="http://schemas.microsoft.com/office/drawing/2014/main" id="{5EFB5F6B-CCFE-30D9-7E6E-1C38C711F3C0}"/>
               </a:ext>
             </a:extLst>
           </p:cNvPr>
@@ -12487,19 +13659,31 @@
               <a:rPr lang="en-US" dirty="0" err="1">
                 <a:latin typeface="Arial Rounded MT Bold" panose="020F0704030504030204" pitchFamily="34" charset="0"/>
               </a:rPr>
-              <a:t>Boîte</a:t>
+              <a:t>Opérateurs</a:t>
             </a:r>
             <a:r>
               <a:rPr lang="en-US" dirty="0">
                 <a:latin typeface="Arial Rounded MT Bold" panose="020F0704030504030204" pitchFamily="34" charset="0"/>
               </a:rPr>
-              <a:t> à </a:t>
+              <a:t> </a:t>
             </a:r>
             <a:r>
               <a:rPr lang="en-US" dirty="0" err="1">
                 <a:latin typeface="Arial Rounded MT Bold" panose="020F0704030504030204" pitchFamily="34" charset="0"/>
               </a:rPr>
-              <a:t>savon</a:t>
+              <a:t>retournant</a:t>
+            </a:r>
+            <a:r>
+              <a:rPr lang="en-US" dirty="0">
+                <a:latin typeface="Arial Rounded MT Bold" panose="020F0704030504030204" pitchFamily="34" charset="0"/>
+              </a:rPr>
+              <a:t> </a:t>
+            </a:r>
+            <a:r>
+              <a:rPr lang="en-US" dirty="0" err="1">
+                <a:latin typeface="Arial Rounded MT Bold" panose="020F0704030504030204" pitchFamily="34" charset="0"/>
+              </a:rPr>
+              <a:t>booléens</a:t>
             </a:r>
             <a:endParaRPr lang="fr-CA" dirty="0">
               <a:latin typeface="Arial Rounded MT Bold" panose="020F0704030504030204" pitchFamily="34" charset="0"/>
@@ -12512,7 +13696,7 @@
           <p:cNvPr id="3" name="Content Placeholder 2">
             <a:extLst>
               <a:ext uri="{FF2B5EF4-FFF2-40B4-BE49-F238E27FC236}">
-                <a16:creationId xmlns:a16="http://schemas.microsoft.com/office/drawing/2014/main" id="{238F9EF2-9A1B-D8F8-3653-B2333F4464C3}"/>
+                <a16:creationId xmlns:a16="http://schemas.microsoft.com/office/drawing/2014/main" id="{C266EEB5-5DF4-1772-722C-9295423EFC10}"/>
               </a:ext>
             </a:extLst>
           </p:cNvPr>
@@ -12530,56 +13714,40 @@
           </a:bodyPr>
           <a:lstStyle/>
           <a:p>
-            <a:pPr marL="0" indent="0" algn="just">
+            <a:pPr marL="457200" lvl="1" indent="0" algn="just">
+              <a:lnSpc>
+                <a:spcPct val="100000"/>
+              </a:lnSpc>
               <a:buNone/>
             </a:pPr>
-            <a:r>
-              <a:rPr lang="en-US" b="1" i="1" dirty="0" err="1">
-                <a:latin typeface="Consolas" panose="020B0609020204030204" pitchFamily="49" charset="0"/>
-              </a:rPr>
-              <a:t>Entiers</a:t>
-            </a:r>
-            <a:r>
-              <a:rPr lang="en-US" b="1" i="1" dirty="0">
-                <a:latin typeface="Consolas" panose="020B0609020204030204" pitchFamily="49" charset="0"/>
-              </a:rPr>
-              <a:t> à precision "infinite"</a:t>
-            </a:r>
-          </a:p>
-          <a:p>
-            <a:pPr marL="0" indent="0" algn="just">
+            <a:endParaRPr lang="en-CA" sz="1800" dirty="0">
+              <a:latin typeface="Consolas" panose="020B0609020204030204" pitchFamily="49" charset="0"/>
+            </a:endParaRPr>
+          </a:p>
+          <a:p>
+            <a:pPr algn="just">
+              <a:lnSpc>
+                <a:spcPct val="100000"/>
+              </a:lnSpc>
+            </a:pPr>
+            <a:r>
+              <a:rPr lang="en-US" sz="1800" dirty="0">
+                <a:latin typeface="Consolas" panose="020B0609020204030204" pitchFamily="49" charset="0"/>
+              </a:rPr>
+              <a:t>...</a:t>
+            </a:r>
+            <a:endParaRPr lang="fr-CA" sz="1800" dirty="0">
+              <a:latin typeface="Consolas" panose="020B0609020204030204" pitchFamily="49" charset="0"/>
+            </a:endParaRPr>
+          </a:p>
+          <a:p>
+            <a:pPr marL="457200" lvl="1" indent="0" algn="just">
+              <a:lnSpc>
+                <a:spcPct val="100000"/>
+              </a:lnSpc>
               <a:buNone/>
             </a:pPr>
-            <a:r>
-              <a:rPr lang="en-US" b="1" i="1" dirty="0">
-                <a:latin typeface="Consolas" panose="020B0609020204030204" pitchFamily="49" charset="0"/>
-              </a:rPr>
-              <a:t>Truthiness</a:t>
-            </a:r>
-          </a:p>
-          <a:p>
-            <a:pPr marL="0" indent="0" algn="just">
-              <a:buNone/>
-            </a:pPr>
-            <a:r>
-              <a:rPr lang="en-CA" b="1" i="1" dirty="0" err="1">
-                <a:latin typeface="Consolas" panose="020B0609020204030204" pitchFamily="49" charset="0"/>
-              </a:rPr>
-              <a:t>Nombres</a:t>
-            </a:r>
-            <a:r>
-              <a:rPr lang="en-CA" b="1" i="1" dirty="0">
-                <a:latin typeface="Consolas" panose="020B0609020204030204" pitchFamily="49" charset="0"/>
-              </a:rPr>
-              <a:t> </a:t>
-            </a:r>
-            <a:r>
-              <a:rPr lang="en-CA" b="1" i="1" dirty="0" err="1">
-                <a:latin typeface="Consolas" panose="020B0609020204030204" pitchFamily="49" charset="0"/>
-              </a:rPr>
-              <a:t>imaginaires</a:t>
-            </a:r>
-            <a:endParaRPr lang="en-CA" b="1" i="1" dirty="0">
+            <a:endParaRPr lang="fr-CA" sz="1800" dirty="0">
               <a:latin typeface="Consolas" panose="020B0609020204030204" pitchFamily="49" charset="0"/>
             </a:endParaRPr>
           </a:p>
@@ -12587,10 +13755,10 @@
       </p:sp>
       <p:sp>
         <p:nvSpPr>
-          <p:cNvPr id="4" name="Slide Number Placeholder 3">
+          <p:cNvPr id="5" name="Slide Number Placeholder 4">
             <a:extLst>
               <a:ext uri="{FF2B5EF4-FFF2-40B4-BE49-F238E27FC236}">
-                <a16:creationId xmlns:a16="http://schemas.microsoft.com/office/drawing/2014/main" id="{8EDFF14A-781E-B2B6-B1C5-9B936FB0C6A8}"/>
+                <a16:creationId xmlns:a16="http://schemas.microsoft.com/office/drawing/2014/main" id="{1D56E47F-EF32-D003-0325-404D98F49AB3}"/>
               </a:ext>
             </a:extLst>
           </p:cNvPr>
@@ -12614,10 +13782,1900 @@
           </a:p>
         </p:txBody>
       </p:sp>
+      <p:sp>
+        <p:nvSpPr>
+          <p:cNvPr id="9" name="Content Placeholder 2">
+            <a:extLst>
+              <a:ext uri="{FF2B5EF4-FFF2-40B4-BE49-F238E27FC236}">
+                <a16:creationId xmlns:a16="http://schemas.microsoft.com/office/drawing/2014/main" id="{6E92DEC4-CDDE-6297-79CC-B928881C6EEF}"/>
+              </a:ext>
+            </a:extLst>
+          </p:cNvPr>
+          <p:cNvSpPr txBox="1">
+            <a:spLocks/>
+          </p:cNvSpPr>
+          <p:nvPr/>
+        </p:nvSpPr>
+        <p:spPr>
+          <a:xfrm>
+            <a:off x="990600" y="1978025"/>
+            <a:ext cx="10515600" cy="4351338"/>
+          </a:xfrm>
+          <a:prstGeom prst="rect">
+            <a:avLst/>
+          </a:prstGeom>
+        </p:spPr>
+        <p:txBody>
+          <a:bodyPr vert="horz" lIns="91440" tIns="45720" rIns="91440" bIns="45720" rtlCol="0">
+            <a:normAutofit/>
+          </a:bodyPr>
+          <a:lstStyle>
+            <a:lvl1pPr marL="228600" indent="-228600" algn="l" defTabSz="914400" rtl="0" eaLnBrk="1" latinLnBrk="0" hangingPunct="1">
+              <a:lnSpc>
+                <a:spcPct val="90000"/>
+              </a:lnSpc>
+              <a:spcBef>
+                <a:spcPts val="1000"/>
+              </a:spcBef>
+              <a:buFont typeface="Arial" panose="020B0604020202020204" pitchFamily="34" charset="0"/>
+              <a:buChar char="•"/>
+              <a:defRPr sz="2800" kern="1200">
+                <a:solidFill>
+                  <a:schemeClr val="tx1"/>
+                </a:solidFill>
+                <a:latin typeface="+mn-lt"/>
+                <a:ea typeface="+mn-ea"/>
+                <a:cs typeface="+mn-cs"/>
+              </a:defRPr>
+            </a:lvl1pPr>
+            <a:lvl2pPr marL="685800" indent="-228600" algn="l" defTabSz="914400" rtl="0" eaLnBrk="1" latinLnBrk="0" hangingPunct="1">
+              <a:lnSpc>
+                <a:spcPct val="90000"/>
+              </a:lnSpc>
+              <a:spcBef>
+                <a:spcPts val="500"/>
+              </a:spcBef>
+              <a:buFont typeface="Arial" panose="020B0604020202020204" pitchFamily="34" charset="0"/>
+              <a:buChar char="•"/>
+              <a:defRPr sz="2400" kern="1200">
+                <a:solidFill>
+                  <a:schemeClr val="tx1"/>
+                </a:solidFill>
+                <a:latin typeface="+mn-lt"/>
+                <a:ea typeface="+mn-ea"/>
+                <a:cs typeface="+mn-cs"/>
+              </a:defRPr>
+            </a:lvl2pPr>
+            <a:lvl3pPr marL="1143000" indent="-228600" algn="l" defTabSz="914400" rtl="0" eaLnBrk="1" latinLnBrk="0" hangingPunct="1">
+              <a:lnSpc>
+                <a:spcPct val="90000"/>
+              </a:lnSpc>
+              <a:spcBef>
+                <a:spcPts val="500"/>
+              </a:spcBef>
+              <a:buFont typeface="Arial" panose="020B0604020202020204" pitchFamily="34" charset="0"/>
+              <a:buChar char="•"/>
+              <a:defRPr sz="2000" kern="1200">
+                <a:solidFill>
+                  <a:schemeClr val="tx1"/>
+                </a:solidFill>
+                <a:latin typeface="+mn-lt"/>
+                <a:ea typeface="+mn-ea"/>
+                <a:cs typeface="+mn-cs"/>
+              </a:defRPr>
+            </a:lvl3pPr>
+            <a:lvl4pPr marL="1600200" indent="-228600" algn="l" defTabSz="914400" rtl="0" eaLnBrk="1" latinLnBrk="0" hangingPunct="1">
+              <a:lnSpc>
+                <a:spcPct val="90000"/>
+              </a:lnSpc>
+              <a:spcBef>
+                <a:spcPts val="500"/>
+              </a:spcBef>
+              <a:buFont typeface="Arial" panose="020B0604020202020204" pitchFamily="34" charset="0"/>
+              <a:buChar char="•"/>
+              <a:defRPr sz="1800" kern="1200">
+                <a:solidFill>
+                  <a:schemeClr val="tx1"/>
+                </a:solidFill>
+                <a:latin typeface="+mn-lt"/>
+                <a:ea typeface="+mn-ea"/>
+                <a:cs typeface="+mn-cs"/>
+              </a:defRPr>
+            </a:lvl4pPr>
+            <a:lvl5pPr marL="2057400" indent="-228600" algn="l" defTabSz="914400" rtl="0" eaLnBrk="1" latinLnBrk="0" hangingPunct="1">
+              <a:lnSpc>
+                <a:spcPct val="90000"/>
+              </a:lnSpc>
+              <a:spcBef>
+                <a:spcPts val="500"/>
+              </a:spcBef>
+              <a:buFont typeface="Arial" panose="020B0604020202020204" pitchFamily="34" charset="0"/>
+              <a:buChar char="•"/>
+              <a:defRPr sz="1800" kern="1200">
+                <a:solidFill>
+                  <a:schemeClr val="tx1"/>
+                </a:solidFill>
+                <a:latin typeface="+mn-lt"/>
+                <a:ea typeface="+mn-ea"/>
+                <a:cs typeface="+mn-cs"/>
+              </a:defRPr>
+            </a:lvl5pPr>
+            <a:lvl6pPr marL="2514600" indent="-228600" algn="l" defTabSz="914400" rtl="0" eaLnBrk="1" latinLnBrk="0" hangingPunct="1">
+              <a:lnSpc>
+                <a:spcPct val="90000"/>
+              </a:lnSpc>
+              <a:spcBef>
+                <a:spcPts val="500"/>
+              </a:spcBef>
+              <a:buFont typeface="Arial" panose="020B0604020202020204" pitchFamily="34" charset="0"/>
+              <a:buChar char="•"/>
+              <a:defRPr sz="1800" kern="1200">
+                <a:solidFill>
+                  <a:schemeClr val="tx1"/>
+                </a:solidFill>
+                <a:latin typeface="+mn-lt"/>
+                <a:ea typeface="+mn-ea"/>
+                <a:cs typeface="+mn-cs"/>
+              </a:defRPr>
+            </a:lvl6pPr>
+            <a:lvl7pPr marL="2971800" indent="-228600" algn="l" defTabSz="914400" rtl="0" eaLnBrk="1" latinLnBrk="0" hangingPunct="1">
+              <a:lnSpc>
+                <a:spcPct val="90000"/>
+              </a:lnSpc>
+              <a:spcBef>
+                <a:spcPts val="500"/>
+              </a:spcBef>
+              <a:buFont typeface="Arial" panose="020B0604020202020204" pitchFamily="34" charset="0"/>
+              <a:buChar char="•"/>
+              <a:defRPr sz="1800" kern="1200">
+                <a:solidFill>
+                  <a:schemeClr val="tx1"/>
+                </a:solidFill>
+                <a:latin typeface="+mn-lt"/>
+                <a:ea typeface="+mn-ea"/>
+                <a:cs typeface="+mn-cs"/>
+              </a:defRPr>
+            </a:lvl7pPr>
+            <a:lvl8pPr marL="3429000" indent="-228600" algn="l" defTabSz="914400" rtl="0" eaLnBrk="1" latinLnBrk="0" hangingPunct="1">
+              <a:lnSpc>
+                <a:spcPct val="90000"/>
+              </a:lnSpc>
+              <a:spcBef>
+                <a:spcPts val="500"/>
+              </a:spcBef>
+              <a:buFont typeface="Arial" panose="020B0604020202020204" pitchFamily="34" charset="0"/>
+              <a:buChar char="•"/>
+              <a:defRPr sz="1800" kern="1200">
+                <a:solidFill>
+                  <a:schemeClr val="tx1"/>
+                </a:solidFill>
+                <a:latin typeface="+mn-lt"/>
+                <a:ea typeface="+mn-ea"/>
+                <a:cs typeface="+mn-cs"/>
+              </a:defRPr>
+            </a:lvl8pPr>
+            <a:lvl9pPr marL="3886200" indent="-228600" algn="l" defTabSz="914400" rtl="0" eaLnBrk="1" latinLnBrk="0" hangingPunct="1">
+              <a:lnSpc>
+                <a:spcPct val="90000"/>
+              </a:lnSpc>
+              <a:spcBef>
+                <a:spcPts val="500"/>
+              </a:spcBef>
+              <a:buFont typeface="Arial" panose="020B0604020202020204" pitchFamily="34" charset="0"/>
+              <a:buChar char="•"/>
+              <a:defRPr sz="1800" kern="1200">
+                <a:solidFill>
+                  <a:schemeClr val="tx1"/>
+                </a:solidFill>
+                <a:latin typeface="+mn-lt"/>
+                <a:ea typeface="+mn-ea"/>
+                <a:cs typeface="+mn-cs"/>
+              </a:defRPr>
+            </a:lvl9pPr>
+          </a:lstStyle>
+          <a:p>
+            <a:pPr marL="457200" lvl="1" indent="0" algn="just">
+              <a:lnSpc>
+                <a:spcPct val="150000"/>
+              </a:lnSpc>
+              <a:buNone/>
+            </a:pPr>
+            <a:endParaRPr lang="en-US" sz="1800" b="1" dirty="0">
+              <a:latin typeface="Consolas" panose="020B0609020204030204" pitchFamily="49" charset="0"/>
+            </a:endParaRPr>
+          </a:p>
+        </p:txBody>
+      </p:sp>
     </p:spTree>
     <p:extLst>
       <p:ext uri="{BB962C8B-B14F-4D97-AF65-F5344CB8AC3E}">
-        <p14:creationId xmlns:p14="http://schemas.microsoft.com/office/powerpoint/2010/main" val="1511279349"/>
+        <p14:creationId xmlns:p14="http://schemas.microsoft.com/office/powerpoint/2010/main" val="1652302043"/>
+      </p:ext>
+    </p:extLst>
+  </p:cSld>
+  <p:clrMapOvr>
+    <a:masterClrMapping/>
+  </p:clrMapOvr>
+  <p:timing>
+    <p:tnLst>
+      <p:par>
+        <p:cTn id="1" dur="indefinite" restart="never" nodeType="tmRoot">
+          <p:childTnLst>
+            <p:seq concurrent="1" nextAc="seek">
+              <p:cTn id="2" dur="indefinite" nodeType="mainSeq">
+                <p:childTnLst>
+                  <p:par>
+                    <p:cTn id="3" fill="hold">
+                      <p:stCondLst>
+                        <p:cond delay="indefinite"/>
+                      </p:stCondLst>
+                      <p:childTnLst>
+                        <p:par>
+                          <p:cTn id="4" fill="hold">
+                            <p:stCondLst>
+                              <p:cond delay="0"/>
+                            </p:stCondLst>
+                            <p:childTnLst>
+                              <p:par>
+                                <p:cTn id="5" presetID="10" presetClass="entr" presetSubtype="0" fill="hold" nodeType="clickEffect" nodePh="1">
+                                  <p:stCondLst>
+                                    <p:cond delay="0"/>
+                                  </p:stCondLst>
+                                  <p:endCondLst>
+                                    <p:cond evt="begin" delay="0">
+                                      <p:tn val="5"/>
+                                    </p:cond>
+                                  </p:endCondLst>
+                                  <p:childTnLst>
+                                    <p:set>
+                                      <p:cBhvr>
+                                        <p:cTn id="6" dur="1" fill="hold">
+                                          <p:stCondLst>
+                                            <p:cond delay="0"/>
+                                          </p:stCondLst>
+                                        </p:cTn>
+                                        <p:tgtEl>
+                                          <p:spTgt spid="9">
+                                            <p:txEl>
+                                              <p:pRg st="0" end="0"/>
+                                            </p:txEl>
+                                          </p:spTgt>
+                                        </p:tgtEl>
+                                        <p:attrNameLst>
+                                          <p:attrName>style.visibility</p:attrName>
+                                        </p:attrNameLst>
+                                      </p:cBhvr>
+                                      <p:to>
+                                        <p:strVal val="visible"/>
+                                      </p:to>
+                                    </p:set>
+                                    <p:animEffect transition="in" filter="fade">
+                                      <p:cBhvr>
+                                        <p:cTn id="7" dur="500"/>
+                                        <p:tgtEl>
+                                          <p:spTgt spid="9">
+                                            <p:txEl>
+                                              <p:pRg st="0" end="0"/>
+                                            </p:txEl>
+                                          </p:spTgt>
+                                        </p:tgtEl>
+                                      </p:cBhvr>
+                                    </p:animEffect>
+                                  </p:childTnLst>
+                                </p:cTn>
+                              </p:par>
+                            </p:childTnLst>
+                          </p:cTn>
+                        </p:par>
+                      </p:childTnLst>
+                    </p:cTn>
+                  </p:par>
+                </p:childTnLst>
+              </p:cTn>
+              <p:prevCondLst>
+                <p:cond evt="onPrev" delay="0">
+                  <p:tgtEl>
+                    <p:sldTgt/>
+                  </p:tgtEl>
+                </p:cond>
+              </p:prevCondLst>
+              <p:nextCondLst>
+                <p:cond evt="onNext" delay="0">
+                  <p:tgtEl>
+                    <p:sldTgt/>
+                  </p:tgtEl>
+                </p:cond>
+              </p:nextCondLst>
+            </p:seq>
+          </p:childTnLst>
+        </p:cTn>
+      </p:par>
+    </p:tnLst>
+  </p:timing>
+</p:sld>
+</file>
+
+<file path=ppt/slides/slide21.xml><?xml version="1.0" encoding="utf-8"?>
+<p:sld xmlns:a="http://schemas.openxmlformats.org/drawingml/2006/main" xmlns:r="http://schemas.openxmlformats.org/officeDocument/2006/relationships" xmlns:p="http://schemas.openxmlformats.org/presentationml/2006/main">
+  <p:cSld>
+    <p:bg>
+      <p:bgPr>
+        <a:solidFill>
+          <a:srgbClr val="F5F5F5"/>
+        </a:solidFill>
+        <a:effectLst/>
+      </p:bgPr>
+    </p:bg>
+    <p:spTree>
+      <p:nvGrpSpPr>
+        <p:cNvPr id="1" name="">
+          <a:extLst>
+            <a:ext uri="{FF2B5EF4-FFF2-40B4-BE49-F238E27FC236}">
+              <a16:creationId xmlns:a16="http://schemas.microsoft.com/office/drawing/2014/main" id="{5CEED507-E097-7B00-F3A4-E611BBC1F638}"/>
+            </a:ext>
+          </a:extLst>
+        </p:cNvPr>
+        <p:cNvGrpSpPr/>
+        <p:nvPr/>
+      </p:nvGrpSpPr>
+      <p:grpSpPr>
+        <a:xfrm>
+          <a:off x="0" y="0"/>
+          <a:ext cx="0" cy="0"/>
+          <a:chOff x="0" y="0"/>
+          <a:chExt cx="0" cy="0"/>
+        </a:xfrm>
+      </p:grpSpPr>
+      <p:sp>
+        <p:nvSpPr>
+          <p:cNvPr id="2" name="Title 1">
+            <a:extLst>
+              <a:ext uri="{FF2B5EF4-FFF2-40B4-BE49-F238E27FC236}">
+                <a16:creationId xmlns:a16="http://schemas.microsoft.com/office/drawing/2014/main" id="{D99048F4-2C75-F498-3CD0-A110F9271C6D}"/>
+              </a:ext>
+            </a:extLst>
+          </p:cNvPr>
+          <p:cNvSpPr>
+            <a:spLocks noGrp="1"/>
+          </p:cNvSpPr>
+          <p:nvPr>
+            <p:ph type="title"/>
+          </p:nvPr>
+        </p:nvSpPr>
+        <p:spPr/>
+        <p:txBody>
+          <a:bodyPr/>
+          <a:lstStyle/>
+          <a:p>
+            <a:r>
+              <a:rPr lang="en-US" dirty="0" err="1">
+                <a:latin typeface="Arial Rounded MT Bold" panose="020F0704030504030204" pitchFamily="34" charset="0"/>
+              </a:rPr>
+              <a:t>Conditionnelles</a:t>
+            </a:r>
+            <a:endParaRPr lang="fr-CA" dirty="0">
+              <a:latin typeface="Arial Rounded MT Bold" panose="020F0704030504030204" pitchFamily="34" charset="0"/>
+            </a:endParaRPr>
+          </a:p>
+        </p:txBody>
+      </p:sp>
+      <p:sp>
+        <p:nvSpPr>
+          <p:cNvPr id="3" name="Content Placeholder 2">
+            <a:extLst>
+              <a:ext uri="{FF2B5EF4-FFF2-40B4-BE49-F238E27FC236}">
+                <a16:creationId xmlns:a16="http://schemas.microsoft.com/office/drawing/2014/main" id="{9F02AA3A-E71B-559F-13C8-1F1127571700}"/>
+              </a:ext>
+            </a:extLst>
+          </p:cNvPr>
+          <p:cNvSpPr>
+            <a:spLocks noGrp="1"/>
+          </p:cNvSpPr>
+          <p:nvPr>
+            <p:ph idx="1"/>
+          </p:nvPr>
+        </p:nvSpPr>
+        <p:spPr/>
+        <p:txBody>
+          <a:bodyPr>
+            <a:normAutofit/>
+          </a:bodyPr>
+          <a:lstStyle/>
+          <a:p>
+            <a:pPr marL="457200" lvl="1" indent="0" algn="just">
+              <a:lnSpc>
+                <a:spcPct val="100000"/>
+              </a:lnSpc>
+              <a:buNone/>
+            </a:pPr>
+            <a:endParaRPr lang="en-CA" sz="1800" dirty="0">
+              <a:latin typeface="Consolas" panose="020B0609020204030204" pitchFamily="49" charset="0"/>
+            </a:endParaRPr>
+          </a:p>
+          <a:p>
+            <a:pPr algn="just">
+              <a:lnSpc>
+                <a:spcPct val="100000"/>
+              </a:lnSpc>
+            </a:pPr>
+            <a:r>
+              <a:rPr lang="en-US" sz="1800" dirty="0">
+                <a:latin typeface="Consolas" panose="020B0609020204030204" pitchFamily="49" charset="0"/>
+              </a:rPr>
+              <a:t>...</a:t>
+            </a:r>
+            <a:endParaRPr lang="fr-CA" sz="1800" dirty="0">
+              <a:latin typeface="Consolas" panose="020B0609020204030204" pitchFamily="49" charset="0"/>
+            </a:endParaRPr>
+          </a:p>
+          <a:p>
+            <a:pPr marL="457200" lvl="1" indent="0" algn="just">
+              <a:lnSpc>
+                <a:spcPct val="100000"/>
+              </a:lnSpc>
+              <a:buNone/>
+            </a:pPr>
+            <a:endParaRPr lang="fr-CA" sz="1800" dirty="0">
+              <a:latin typeface="Consolas" panose="020B0609020204030204" pitchFamily="49" charset="0"/>
+            </a:endParaRPr>
+          </a:p>
+        </p:txBody>
+      </p:sp>
+      <p:sp>
+        <p:nvSpPr>
+          <p:cNvPr id="5" name="Slide Number Placeholder 4">
+            <a:extLst>
+              <a:ext uri="{FF2B5EF4-FFF2-40B4-BE49-F238E27FC236}">
+                <a16:creationId xmlns:a16="http://schemas.microsoft.com/office/drawing/2014/main" id="{BFBB4537-5FEB-352D-F1CE-F0BFF9A61AC0}"/>
+              </a:ext>
+            </a:extLst>
+          </p:cNvPr>
+          <p:cNvSpPr>
+            <a:spLocks noGrp="1"/>
+          </p:cNvSpPr>
+          <p:nvPr>
+            <p:ph type="sldNum" sz="quarter" idx="12"/>
+          </p:nvPr>
+        </p:nvSpPr>
+        <p:spPr/>
+        <p:txBody>
+          <a:bodyPr/>
+          <a:lstStyle/>
+          <a:p>
+            <a:fld id="{846B06B1-1179-491F-A487-8E0C403F7C13}" type="slidenum">
+              <a:rPr lang="fr-CA" smtClean="0"/>
+              <a:t>21</a:t>
+            </a:fld>
+            <a:endParaRPr lang="fr-CA"/>
+          </a:p>
+        </p:txBody>
+      </p:sp>
+      <p:sp>
+        <p:nvSpPr>
+          <p:cNvPr id="9" name="Content Placeholder 2">
+            <a:extLst>
+              <a:ext uri="{FF2B5EF4-FFF2-40B4-BE49-F238E27FC236}">
+                <a16:creationId xmlns:a16="http://schemas.microsoft.com/office/drawing/2014/main" id="{639F647E-8868-AE5B-744B-856F4CFFCE40}"/>
+              </a:ext>
+            </a:extLst>
+          </p:cNvPr>
+          <p:cNvSpPr txBox="1">
+            <a:spLocks/>
+          </p:cNvSpPr>
+          <p:nvPr/>
+        </p:nvSpPr>
+        <p:spPr>
+          <a:xfrm>
+            <a:off x="990600" y="1978025"/>
+            <a:ext cx="10515600" cy="4351338"/>
+          </a:xfrm>
+          <a:prstGeom prst="rect">
+            <a:avLst/>
+          </a:prstGeom>
+        </p:spPr>
+        <p:txBody>
+          <a:bodyPr vert="horz" lIns="91440" tIns="45720" rIns="91440" bIns="45720" rtlCol="0">
+            <a:normAutofit/>
+          </a:bodyPr>
+          <a:lstStyle>
+            <a:lvl1pPr marL="228600" indent="-228600" algn="l" defTabSz="914400" rtl="0" eaLnBrk="1" latinLnBrk="0" hangingPunct="1">
+              <a:lnSpc>
+                <a:spcPct val="90000"/>
+              </a:lnSpc>
+              <a:spcBef>
+                <a:spcPts val="1000"/>
+              </a:spcBef>
+              <a:buFont typeface="Arial" panose="020B0604020202020204" pitchFamily="34" charset="0"/>
+              <a:buChar char="•"/>
+              <a:defRPr sz="2800" kern="1200">
+                <a:solidFill>
+                  <a:schemeClr val="tx1"/>
+                </a:solidFill>
+                <a:latin typeface="+mn-lt"/>
+                <a:ea typeface="+mn-ea"/>
+                <a:cs typeface="+mn-cs"/>
+              </a:defRPr>
+            </a:lvl1pPr>
+            <a:lvl2pPr marL="685800" indent="-228600" algn="l" defTabSz="914400" rtl="0" eaLnBrk="1" latinLnBrk="0" hangingPunct="1">
+              <a:lnSpc>
+                <a:spcPct val="90000"/>
+              </a:lnSpc>
+              <a:spcBef>
+                <a:spcPts val="500"/>
+              </a:spcBef>
+              <a:buFont typeface="Arial" panose="020B0604020202020204" pitchFamily="34" charset="0"/>
+              <a:buChar char="•"/>
+              <a:defRPr sz="2400" kern="1200">
+                <a:solidFill>
+                  <a:schemeClr val="tx1"/>
+                </a:solidFill>
+                <a:latin typeface="+mn-lt"/>
+                <a:ea typeface="+mn-ea"/>
+                <a:cs typeface="+mn-cs"/>
+              </a:defRPr>
+            </a:lvl2pPr>
+            <a:lvl3pPr marL="1143000" indent="-228600" algn="l" defTabSz="914400" rtl="0" eaLnBrk="1" latinLnBrk="0" hangingPunct="1">
+              <a:lnSpc>
+                <a:spcPct val="90000"/>
+              </a:lnSpc>
+              <a:spcBef>
+                <a:spcPts val="500"/>
+              </a:spcBef>
+              <a:buFont typeface="Arial" panose="020B0604020202020204" pitchFamily="34" charset="0"/>
+              <a:buChar char="•"/>
+              <a:defRPr sz="2000" kern="1200">
+                <a:solidFill>
+                  <a:schemeClr val="tx1"/>
+                </a:solidFill>
+                <a:latin typeface="+mn-lt"/>
+                <a:ea typeface="+mn-ea"/>
+                <a:cs typeface="+mn-cs"/>
+              </a:defRPr>
+            </a:lvl3pPr>
+            <a:lvl4pPr marL="1600200" indent="-228600" algn="l" defTabSz="914400" rtl="0" eaLnBrk="1" latinLnBrk="0" hangingPunct="1">
+              <a:lnSpc>
+                <a:spcPct val="90000"/>
+              </a:lnSpc>
+              <a:spcBef>
+                <a:spcPts val="500"/>
+              </a:spcBef>
+              <a:buFont typeface="Arial" panose="020B0604020202020204" pitchFamily="34" charset="0"/>
+              <a:buChar char="•"/>
+              <a:defRPr sz="1800" kern="1200">
+                <a:solidFill>
+                  <a:schemeClr val="tx1"/>
+                </a:solidFill>
+                <a:latin typeface="+mn-lt"/>
+                <a:ea typeface="+mn-ea"/>
+                <a:cs typeface="+mn-cs"/>
+              </a:defRPr>
+            </a:lvl4pPr>
+            <a:lvl5pPr marL="2057400" indent="-228600" algn="l" defTabSz="914400" rtl="0" eaLnBrk="1" latinLnBrk="0" hangingPunct="1">
+              <a:lnSpc>
+                <a:spcPct val="90000"/>
+              </a:lnSpc>
+              <a:spcBef>
+                <a:spcPts val="500"/>
+              </a:spcBef>
+              <a:buFont typeface="Arial" panose="020B0604020202020204" pitchFamily="34" charset="0"/>
+              <a:buChar char="•"/>
+              <a:defRPr sz="1800" kern="1200">
+                <a:solidFill>
+                  <a:schemeClr val="tx1"/>
+                </a:solidFill>
+                <a:latin typeface="+mn-lt"/>
+                <a:ea typeface="+mn-ea"/>
+                <a:cs typeface="+mn-cs"/>
+              </a:defRPr>
+            </a:lvl5pPr>
+            <a:lvl6pPr marL="2514600" indent="-228600" algn="l" defTabSz="914400" rtl="0" eaLnBrk="1" latinLnBrk="0" hangingPunct="1">
+              <a:lnSpc>
+                <a:spcPct val="90000"/>
+              </a:lnSpc>
+              <a:spcBef>
+                <a:spcPts val="500"/>
+              </a:spcBef>
+              <a:buFont typeface="Arial" panose="020B0604020202020204" pitchFamily="34" charset="0"/>
+              <a:buChar char="•"/>
+              <a:defRPr sz="1800" kern="1200">
+                <a:solidFill>
+                  <a:schemeClr val="tx1"/>
+                </a:solidFill>
+                <a:latin typeface="+mn-lt"/>
+                <a:ea typeface="+mn-ea"/>
+                <a:cs typeface="+mn-cs"/>
+              </a:defRPr>
+            </a:lvl6pPr>
+            <a:lvl7pPr marL="2971800" indent="-228600" algn="l" defTabSz="914400" rtl="0" eaLnBrk="1" latinLnBrk="0" hangingPunct="1">
+              <a:lnSpc>
+                <a:spcPct val="90000"/>
+              </a:lnSpc>
+              <a:spcBef>
+                <a:spcPts val="500"/>
+              </a:spcBef>
+              <a:buFont typeface="Arial" panose="020B0604020202020204" pitchFamily="34" charset="0"/>
+              <a:buChar char="•"/>
+              <a:defRPr sz="1800" kern="1200">
+                <a:solidFill>
+                  <a:schemeClr val="tx1"/>
+                </a:solidFill>
+                <a:latin typeface="+mn-lt"/>
+                <a:ea typeface="+mn-ea"/>
+                <a:cs typeface="+mn-cs"/>
+              </a:defRPr>
+            </a:lvl7pPr>
+            <a:lvl8pPr marL="3429000" indent="-228600" algn="l" defTabSz="914400" rtl="0" eaLnBrk="1" latinLnBrk="0" hangingPunct="1">
+              <a:lnSpc>
+                <a:spcPct val="90000"/>
+              </a:lnSpc>
+              <a:spcBef>
+                <a:spcPts val="500"/>
+              </a:spcBef>
+              <a:buFont typeface="Arial" panose="020B0604020202020204" pitchFamily="34" charset="0"/>
+              <a:buChar char="•"/>
+              <a:defRPr sz="1800" kern="1200">
+                <a:solidFill>
+                  <a:schemeClr val="tx1"/>
+                </a:solidFill>
+                <a:latin typeface="+mn-lt"/>
+                <a:ea typeface="+mn-ea"/>
+                <a:cs typeface="+mn-cs"/>
+              </a:defRPr>
+            </a:lvl8pPr>
+            <a:lvl9pPr marL="3886200" indent="-228600" algn="l" defTabSz="914400" rtl="0" eaLnBrk="1" latinLnBrk="0" hangingPunct="1">
+              <a:lnSpc>
+                <a:spcPct val="90000"/>
+              </a:lnSpc>
+              <a:spcBef>
+                <a:spcPts val="500"/>
+              </a:spcBef>
+              <a:buFont typeface="Arial" panose="020B0604020202020204" pitchFamily="34" charset="0"/>
+              <a:buChar char="•"/>
+              <a:defRPr sz="1800" kern="1200">
+                <a:solidFill>
+                  <a:schemeClr val="tx1"/>
+                </a:solidFill>
+                <a:latin typeface="+mn-lt"/>
+                <a:ea typeface="+mn-ea"/>
+                <a:cs typeface="+mn-cs"/>
+              </a:defRPr>
+            </a:lvl9pPr>
+          </a:lstStyle>
+          <a:p>
+            <a:pPr marL="457200" lvl="1" indent="0" algn="just">
+              <a:lnSpc>
+                <a:spcPct val="150000"/>
+              </a:lnSpc>
+              <a:buNone/>
+            </a:pPr>
+            <a:endParaRPr lang="en-US" sz="1800" b="1" dirty="0">
+              <a:latin typeface="Consolas" panose="020B0609020204030204" pitchFamily="49" charset="0"/>
+            </a:endParaRPr>
+          </a:p>
+        </p:txBody>
+      </p:sp>
+    </p:spTree>
+    <p:extLst>
+      <p:ext uri="{BB962C8B-B14F-4D97-AF65-F5344CB8AC3E}">
+        <p14:creationId xmlns:p14="http://schemas.microsoft.com/office/powerpoint/2010/main" val="331786654"/>
+      </p:ext>
+    </p:extLst>
+  </p:cSld>
+  <p:clrMapOvr>
+    <a:masterClrMapping/>
+  </p:clrMapOvr>
+  <p:timing>
+    <p:tnLst>
+      <p:par>
+        <p:cTn id="1" dur="indefinite" restart="never" nodeType="tmRoot">
+          <p:childTnLst>
+            <p:seq concurrent="1" nextAc="seek">
+              <p:cTn id="2" dur="indefinite" nodeType="mainSeq">
+                <p:childTnLst>
+                  <p:par>
+                    <p:cTn id="3" fill="hold">
+                      <p:stCondLst>
+                        <p:cond delay="indefinite"/>
+                      </p:stCondLst>
+                      <p:childTnLst>
+                        <p:par>
+                          <p:cTn id="4" fill="hold">
+                            <p:stCondLst>
+                              <p:cond delay="0"/>
+                            </p:stCondLst>
+                            <p:childTnLst>
+                              <p:par>
+                                <p:cTn id="5" presetID="10" presetClass="entr" presetSubtype="0" fill="hold" nodeType="clickEffect" nodePh="1">
+                                  <p:stCondLst>
+                                    <p:cond delay="0"/>
+                                  </p:stCondLst>
+                                  <p:endCondLst>
+                                    <p:cond evt="begin" delay="0">
+                                      <p:tn val="5"/>
+                                    </p:cond>
+                                  </p:endCondLst>
+                                  <p:childTnLst>
+                                    <p:set>
+                                      <p:cBhvr>
+                                        <p:cTn id="6" dur="1" fill="hold">
+                                          <p:stCondLst>
+                                            <p:cond delay="0"/>
+                                          </p:stCondLst>
+                                        </p:cTn>
+                                        <p:tgtEl>
+                                          <p:spTgt spid="9">
+                                            <p:txEl>
+                                              <p:pRg st="0" end="0"/>
+                                            </p:txEl>
+                                          </p:spTgt>
+                                        </p:tgtEl>
+                                        <p:attrNameLst>
+                                          <p:attrName>style.visibility</p:attrName>
+                                        </p:attrNameLst>
+                                      </p:cBhvr>
+                                      <p:to>
+                                        <p:strVal val="visible"/>
+                                      </p:to>
+                                    </p:set>
+                                    <p:animEffect transition="in" filter="fade">
+                                      <p:cBhvr>
+                                        <p:cTn id="7" dur="500"/>
+                                        <p:tgtEl>
+                                          <p:spTgt spid="9">
+                                            <p:txEl>
+                                              <p:pRg st="0" end="0"/>
+                                            </p:txEl>
+                                          </p:spTgt>
+                                        </p:tgtEl>
+                                      </p:cBhvr>
+                                    </p:animEffect>
+                                  </p:childTnLst>
+                                </p:cTn>
+                              </p:par>
+                            </p:childTnLst>
+                          </p:cTn>
+                        </p:par>
+                      </p:childTnLst>
+                    </p:cTn>
+                  </p:par>
+                </p:childTnLst>
+              </p:cTn>
+              <p:prevCondLst>
+                <p:cond evt="onPrev" delay="0">
+                  <p:tgtEl>
+                    <p:sldTgt/>
+                  </p:tgtEl>
+                </p:cond>
+              </p:prevCondLst>
+              <p:nextCondLst>
+                <p:cond evt="onNext" delay="0">
+                  <p:tgtEl>
+                    <p:sldTgt/>
+                  </p:tgtEl>
+                </p:cond>
+              </p:nextCondLst>
+            </p:seq>
+          </p:childTnLst>
+        </p:cTn>
+      </p:par>
+    </p:tnLst>
+  </p:timing>
+</p:sld>
+</file>
+
+<file path=ppt/slides/slide22.xml><?xml version="1.0" encoding="utf-8"?>
+<p:sld xmlns:a="http://schemas.openxmlformats.org/drawingml/2006/main" xmlns:r="http://schemas.openxmlformats.org/officeDocument/2006/relationships" xmlns:p="http://schemas.openxmlformats.org/presentationml/2006/main">
+  <p:cSld>
+    <p:bg>
+      <p:bgPr>
+        <a:solidFill>
+          <a:srgbClr val="F5F5F5"/>
+        </a:solidFill>
+        <a:effectLst/>
+      </p:bgPr>
+    </p:bg>
+    <p:spTree>
+      <p:nvGrpSpPr>
+        <p:cNvPr id="1" name="">
+          <a:extLst>
+            <a:ext uri="{FF2B5EF4-FFF2-40B4-BE49-F238E27FC236}">
+              <a16:creationId xmlns:a16="http://schemas.microsoft.com/office/drawing/2014/main" id="{B369858B-F974-765F-F62F-85B9F6673B57}"/>
+            </a:ext>
+          </a:extLst>
+        </p:cNvPr>
+        <p:cNvGrpSpPr/>
+        <p:nvPr/>
+      </p:nvGrpSpPr>
+      <p:grpSpPr>
+        <a:xfrm>
+          <a:off x="0" y="0"/>
+          <a:ext cx="0" cy="0"/>
+          <a:chOff x="0" y="0"/>
+          <a:chExt cx="0" cy="0"/>
+        </a:xfrm>
+      </p:grpSpPr>
+      <p:sp>
+        <p:nvSpPr>
+          <p:cNvPr id="2" name="Title 1">
+            <a:extLst>
+              <a:ext uri="{FF2B5EF4-FFF2-40B4-BE49-F238E27FC236}">
+                <a16:creationId xmlns:a16="http://schemas.microsoft.com/office/drawing/2014/main" id="{4DED70CF-A18D-B16A-A769-5344FC586559}"/>
+              </a:ext>
+            </a:extLst>
+          </p:cNvPr>
+          <p:cNvSpPr>
+            <a:spLocks noGrp="1"/>
+          </p:cNvSpPr>
+          <p:nvPr>
+            <p:ph type="title"/>
+          </p:nvPr>
+        </p:nvSpPr>
+        <p:spPr/>
+        <p:txBody>
+          <a:bodyPr/>
+          <a:lstStyle/>
+          <a:p>
+            <a:r>
+              <a:rPr lang="en-US" dirty="0" err="1">
+                <a:latin typeface="Arial Rounded MT Bold" panose="020F0704030504030204" pitchFamily="34" charset="0"/>
+              </a:rPr>
+              <a:t>Boucles</a:t>
+            </a:r>
+            <a:endParaRPr lang="fr-CA" dirty="0">
+              <a:latin typeface="Arial Rounded MT Bold" panose="020F0704030504030204" pitchFamily="34" charset="0"/>
+            </a:endParaRPr>
+          </a:p>
+        </p:txBody>
+      </p:sp>
+      <p:sp>
+        <p:nvSpPr>
+          <p:cNvPr id="3" name="Content Placeholder 2">
+            <a:extLst>
+              <a:ext uri="{FF2B5EF4-FFF2-40B4-BE49-F238E27FC236}">
+                <a16:creationId xmlns:a16="http://schemas.microsoft.com/office/drawing/2014/main" id="{A1DBFB82-A6AD-37FB-F151-DB42D87D364C}"/>
+              </a:ext>
+            </a:extLst>
+          </p:cNvPr>
+          <p:cNvSpPr>
+            <a:spLocks noGrp="1"/>
+          </p:cNvSpPr>
+          <p:nvPr>
+            <p:ph idx="1"/>
+          </p:nvPr>
+        </p:nvSpPr>
+        <p:spPr/>
+        <p:txBody>
+          <a:bodyPr>
+            <a:normAutofit/>
+          </a:bodyPr>
+          <a:lstStyle/>
+          <a:p>
+            <a:pPr marL="457200" lvl="1" indent="0" algn="just">
+              <a:lnSpc>
+                <a:spcPct val="100000"/>
+              </a:lnSpc>
+              <a:buNone/>
+            </a:pPr>
+            <a:endParaRPr lang="en-CA" sz="1800" dirty="0">
+              <a:latin typeface="Consolas" panose="020B0609020204030204" pitchFamily="49" charset="0"/>
+            </a:endParaRPr>
+          </a:p>
+          <a:p>
+            <a:pPr algn="just">
+              <a:lnSpc>
+                <a:spcPct val="100000"/>
+              </a:lnSpc>
+            </a:pPr>
+            <a:r>
+              <a:rPr lang="en-US" sz="1800" dirty="0">
+                <a:latin typeface="Consolas" panose="020B0609020204030204" pitchFamily="49" charset="0"/>
+              </a:rPr>
+              <a:t>...</a:t>
+            </a:r>
+            <a:endParaRPr lang="fr-CA" sz="1800" dirty="0">
+              <a:latin typeface="Consolas" panose="020B0609020204030204" pitchFamily="49" charset="0"/>
+            </a:endParaRPr>
+          </a:p>
+          <a:p>
+            <a:pPr marL="457200" lvl="1" indent="0" algn="just">
+              <a:lnSpc>
+                <a:spcPct val="100000"/>
+              </a:lnSpc>
+              <a:buNone/>
+            </a:pPr>
+            <a:endParaRPr lang="fr-CA" sz="1800" dirty="0">
+              <a:latin typeface="Consolas" panose="020B0609020204030204" pitchFamily="49" charset="0"/>
+            </a:endParaRPr>
+          </a:p>
+        </p:txBody>
+      </p:sp>
+      <p:sp>
+        <p:nvSpPr>
+          <p:cNvPr id="5" name="Slide Number Placeholder 4">
+            <a:extLst>
+              <a:ext uri="{FF2B5EF4-FFF2-40B4-BE49-F238E27FC236}">
+                <a16:creationId xmlns:a16="http://schemas.microsoft.com/office/drawing/2014/main" id="{F9C1D8DD-DAF1-68A1-F11A-BCF4691FD83C}"/>
+              </a:ext>
+            </a:extLst>
+          </p:cNvPr>
+          <p:cNvSpPr>
+            <a:spLocks noGrp="1"/>
+          </p:cNvSpPr>
+          <p:nvPr>
+            <p:ph type="sldNum" sz="quarter" idx="12"/>
+          </p:nvPr>
+        </p:nvSpPr>
+        <p:spPr/>
+        <p:txBody>
+          <a:bodyPr/>
+          <a:lstStyle/>
+          <a:p>
+            <a:fld id="{846B06B1-1179-491F-A487-8E0C403F7C13}" type="slidenum">
+              <a:rPr lang="fr-CA" smtClean="0"/>
+              <a:t>22</a:t>
+            </a:fld>
+            <a:endParaRPr lang="fr-CA"/>
+          </a:p>
+        </p:txBody>
+      </p:sp>
+      <p:sp>
+        <p:nvSpPr>
+          <p:cNvPr id="9" name="Content Placeholder 2">
+            <a:extLst>
+              <a:ext uri="{FF2B5EF4-FFF2-40B4-BE49-F238E27FC236}">
+                <a16:creationId xmlns:a16="http://schemas.microsoft.com/office/drawing/2014/main" id="{6E8363CC-90A4-AFD1-E456-74A77D380F4B}"/>
+              </a:ext>
+            </a:extLst>
+          </p:cNvPr>
+          <p:cNvSpPr txBox="1">
+            <a:spLocks/>
+          </p:cNvSpPr>
+          <p:nvPr/>
+        </p:nvSpPr>
+        <p:spPr>
+          <a:xfrm>
+            <a:off x="990600" y="1978025"/>
+            <a:ext cx="10515600" cy="4351338"/>
+          </a:xfrm>
+          <a:prstGeom prst="rect">
+            <a:avLst/>
+          </a:prstGeom>
+        </p:spPr>
+        <p:txBody>
+          <a:bodyPr vert="horz" lIns="91440" tIns="45720" rIns="91440" bIns="45720" rtlCol="0">
+            <a:normAutofit/>
+          </a:bodyPr>
+          <a:lstStyle>
+            <a:lvl1pPr marL="228600" indent="-228600" algn="l" defTabSz="914400" rtl="0" eaLnBrk="1" latinLnBrk="0" hangingPunct="1">
+              <a:lnSpc>
+                <a:spcPct val="90000"/>
+              </a:lnSpc>
+              <a:spcBef>
+                <a:spcPts val="1000"/>
+              </a:spcBef>
+              <a:buFont typeface="Arial" panose="020B0604020202020204" pitchFamily="34" charset="0"/>
+              <a:buChar char="•"/>
+              <a:defRPr sz="2800" kern="1200">
+                <a:solidFill>
+                  <a:schemeClr val="tx1"/>
+                </a:solidFill>
+                <a:latin typeface="+mn-lt"/>
+                <a:ea typeface="+mn-ea"/>
+                <a:cs typeface="+mn-cs"/>
+              </a:defRPr>
+            </a:lvl1pPr>
+            <a:lvl2pPr marL="685800" indent="-228600" algn="l" defTabSz="914400" rtl="0" eaLnBrk="1" latinLnBrk="0" hangingPunct="1">
+              <a:lnSpc>
+                <a:spcPct val="90000"/>
+              </a:lnSpc>
+              <a:spcBef>
+                <a:spcPts val="500"/>
+              </a:spcBef>
+              <a:buFont typeface="Arial" panose="020B0604020202020204" pitchFamily="34" charset="0"/>
+              <a:buChar char="•"/>
+              <a:defRPr sz="2400" kern="1200">
+                <a:solidFill>
+                  <a:schemeClr val="tx1"/>
+                </a:solidFill>
+                <a:latin typeface="+mn-lt"/>
+                <a:ea typeface="+mn-ea"/>
+                <a:cs typeface="+mn-cs"/>
+              </a:defRPr>
+            </a:lvl2pPr>
+            <a:lvl3pPr marL="1143000" indent="-228600" algn="l" defTabSz="914400" rtl="0" eaLnBrk="1" latinLnBrk="0" hangingPunct="1">
+              <a:lnSpc>
+                <a:spcPct val="90000"/>
+              </a:lnSpc>
+              <a:spcBef>
+                <a:spcPts val="500"/>
+              </a:spcBef>
+              <a:buFont typeface="Arial" panose="020B0604020202020204" pitchFamily="34" charset="0"/>
+              <a:buChar char="•"/>
+              <a:defRPr sz="2000" kern="1200">
+                <a:solidFill>
+                  <a:schemeClr val="tx1"/>
+                </a:solidFill>
+                <a:latin typeface="+mn-lt"/>
+                <a:ea typeface="+mn-ea"/>
+                <a:cs typeface="+mn-cs"/>
+              </a:defRPr>
+            </a:lvl3pPr>
+            <a:lvl4pPr marL="1600200" indent="-228600" algn="l" defTabSz="914400" rtl="0" eaLnBrk="1" latinLnBrk="0" hangingPunct="1">
+              <a:lnSpc>
+                <a:spcPct val="90000"/>
+              </a:lnSpc>
+              <a:spcBef>
+                <a:spcPts val="500"/>
+              </a:spcBef>
+              <a:buFont typeface="Arial" panose="020B0604020202020204" pitchFamily="34" charset="0"/>
+              <a:buChar char="•"/>
+              <a:defRPr sz="1800" kern="1200">
+                <a:solidFill>
+                  <a:schemeClr val="tx1"/>
+                </a:solidFill>
+                <a:latin typeface="+mn-lt"/>
+                <a:ea typeface="+mn-ea"/>
+                <a:cs typeface="+mn-cs"/>
+              </a:defRPr>
+            </a:lvl4pPr>
+            <a:lvl5pPr marL="2057400" indent="-228600" algn="l" defTabSz="914400" rtl="0" eaLnBrk="1" latinLnBrk="0" hangingPunct="1">
+              <a:lnSpc>
+                <a:spcPct val="90000"/>
+              </a:lnSpc>
+              <a:spcBef>
+                <a:spcPts val="500"/>
+              </a:spcBef>
+              <a:buFont typeface="Arial" panose="020B0604020202020204" pitchFamily="34" charset="0"/>
+              <a:buChar char="•"/>
+              <a:defRPr sz="1800" kern="1200">
+                <a:solidFill>
+                  <a:schemeClr val="tx1"/>
+                </a:solidFill>
+                <a:latin typeface="+mn-lt"/>
+                <a:ea typeface="+mn-ea"/>
+                <a:cs typeface="+mn-cs"/>
+              </a:defRPr>
+            </a:lvl5pPr>
+            <a:lvl6pPr marL="2514600" indent="-228600" algn="l" defTabSz="914400" rtl="0" eaLnBrk="1" latinLnBrk="0" hangingPunct="1">
+              <a:lnSpc>
+                <a:spcPct val="90000"/>
+              </a:lnSpc>
+              <a:spcBef>
+                <a:spcPts val="500"/>
+              </a:spcBef>
+              <a:buFont typeface="Arial" panose="020B0604020202020204" pitchFamily="34" charset="0"/>
+              <a:buChar char="•"/>
+              <a:defRPr sz="1800" kern="1200">
+                <a:solidFill>
+                  <a:schemeClr val="tx1"/>
+                </a:solidFill>
+                <a:latin typeface="+mn-lt"/>
+                <a:ea typeface="+mn-ea"/>
+                <a:cs typeface="+mn-cs"/>
+              </a:defRPr>
+            </a:lvl6pPr>
+            <a:lvl7pPr marL="2971800" indent="-228600" algn="l" defTabSz="914400" rtl="0" eaLnBrk="1" latinLnBrk="0" hangingPunct="1">
+              <a:lnSpc>
+                <a:spcPct val="90000"/>
+              </a:lnSpc>
+              <a:spcBef>
+                <a:spcPts val="500"/>
+              </a:spcBef>
+              <a:buFont typeface="Arial" panose="020B0604020202020204" pitchFamily="34" charset="0"/>
+              <a:buChar char="•"/>
+              <a:defRPr sz="1800" kern="1200">
+                <a:solidFill>
+                  <a:schemeClr val="tx1"/>
+                </a:solidFill>
+                <a:latin typeface="+mn-lt"/>
+                <a:ea typeface="+mn-ea"/>
+                <a:cs typeface="+mn-cs"/>
+              </a:defRPr>
+            </a:lvl7pPr>
+            <a:lvl8pPr marL="3429000" indent="-228600" algn="l" defTabSz="914400" rtl="0" eaLnBrk="1" latinLnBrk="0" hangingPunct="1">
+              <a:lnSpc>
+                <a:spcPct val="90000"/>
+              </a:lnSpc>
+              <a:spcBef>
+                <a:spcPts val="500"/>
+              </a:spcBef>
+              <a:buFont typeface="Arial" panose="020B0604020202020204" pitchFamily="34" charset="0"/>
+              <a:buChar char="•"/>
+              <a:defRPr sz="1800" kern="1200">
+                <a:solidFill>
+                  <a:schemeClr val="tx1"/>
+                </a:solidFill>
+                <a:latin typeface="+mn-lt"/>
+                <a:ea typeface="+mn-ea"/>
+                <a:cs typeface="+mn-cs"/>
+              </a:defRPr>
+            </a:lvl8pPr>
+            <a:lvl9pPr marL="3886200" indent="-228600" algn="l" defTabSz="914400" rtl="0" eaLnBrk="1" latinLnBrk="0" hangingPunct="1">
+              <a:lnSpc>
+                <a:spcPct val="90000"/>
+              </a:lnSpc>
+              <a:spcBef>
+                <a:spcPts val="500"/>
+              </a:spcBef>
+              <a:buFont typeface="Arial" panose="020B0604020202020204" pitchFamily="34" charset="0"/>
+              <a:buChar char="•"/>
+              <a:defRPr sz="1800" kern="1200">
+                <a:solidFill>
+                  <a:schemeClr val="tx1"/>
+                </a:solidFill>
+                <a:latin typeface="+mn-lt"/>
+                <a:ea typeface="+mn-ea"/>
+                <a:cs typeface="+mn-cs"/>
+              </a:defRPr>
+            </a:lvl9pPr>
+          </a:lstStyle>
+          <a:p>
+            <a:pPr marL="457200" lvl="1" indent="0" algn="just">
+              <a:lnSpc>
+                <a:spcPct val="150000"/>
+              </a:lnSpc>
+              <a:buNone/>
+            </a:pPr>
+            <a:endParaRPr lang="en-US" sz="1800" b="1" dirty="0">
+              <a:latin typeface="Consolas" panose="020B0609020204030204" pitchFamily="49" charset="0"/>
+            </a:endParaRPr>
+          </a:p>
+        </p:txBody>
+      </p:sp>
+    </p:spTree>
+    <p:extLst>
+      <p:ext uri="{BB962C8B-B14F-4D97-AF65-F5344CB8AC3E}">
+        <p14:creationId xmlns:p14="http://schemas.microsoft.com/office/powerpoint/2010/main" val="1791393998"/>
+      </p:ext>
+    </p:extLst>
+  </p:cSld>
+  <p:clrMapOvr>
+    <a:masterClrMapping/>
+  </p:clrMapOvr>
+  <p:timing>
+    <p:tnLst>
+      <p:par>
+        <p:cTn id="1" dur="indefinite" restart="never" nodeType="tmRoot">
+          <p:childTnLst>
+            <p:seq concurrent="1" nextAc="seek">
+              <p:cTn id="2" dur="indefinite" nodeType="mainSeq">
+                <p:childTnLst>
+                  <p:par>
+                    <p:cTn id="3" fill="hold">
+                      <p:stCondLst>
+                        <p:cond delay="indefinite"/>
+                      </p:stCondLst>
+                      <p:childTnLst>
+                        <p:par>
+                          <p:cTn id="4" fill="hold">
+                            <p:stCondLst>
+                              <p:cond delay="0"/>
+                            </p:stCondLst>
+                            <p:childTnLst>
+                              <p:par>
+                                <p:cTn id="5" presetID="10" presetClass="entr" presetSubtype="0" fill="hold" nodeType="clickEffect" nodePh="1">
+                                  <p:stCondLst>
+                                    <p:cond delay="0"/>
+                                  </p:stCondLst>
+                                  <p:endCondLst>
+                                    <p:cond evt="begin" delay="0">
+                                      <p:tn val="5"/>
+                                    </p:cond>
+                                  </p:endCondLst>
+                                  <p:childTnLst>
+                                    <p:set>
+                                      <p:cBhvr>
+                                        <p:cTn id="6" dur="1" fill="hold">
+                                          <p:stCondLst>
+                                            <p:cond delay="0"/>
+                                          </p:stCondLst>
+                                        </p:cTn>
+                                        <p:tgtEl>
+                                          <p:spTgt spid="9">
+                                            <p:txEl>
+                                              <p:pRg st="0" end="0"/>
+                                            </p:txEl>
+                                          </p:spTgt>
+                                        </p:tgtEl>
+                                        <p:attrNameLst>
+                                          <p:attrName>style.visibility</p:attrName>
+                                        </p:attrNameLst>
+                                      </p:cBhvr>
+                                      <p:to>
+                                        <p:strVal val="visible"/>
+                                      </p:to>
+                                    </p:set>
+                                    <p:animEffect transition="in" filter="fade">
+                                      <p:cBhvr>
+                                        <p:cTn id="7" dur="500"/>
+                                        <p:tgtEl>
+                                          <p:spTgt spid="9">
+                                            <p:txEl>
+                                              <p:pRg st="0" end="0"/>
+                                            </p:txEl>
+                                          </p:spTgt>
+                                        </p:tgtEl>
+                                      </p:cBhvr>
+                                    </p:animEffect>
+                                  </p:childTnLst>
+                                </p:cTn>
+                              </p:par>
+                            </p:childTnLst>
+                          </p:cTn>
+                        </p:par>
+                      </p:childTnLst>
+                    </p:cTn>
+                  </p:par>
+                </p:childTnLst>
+              </p:cTn>
+              <p:prevCondLst>
+                <p:cond evt="onPrev" delay="0">
+                  <p:tgtEl>
+                    <p:sldTgt/>
+                  </p:tgtEl>
+                </p:cond>
+              </p:prevCondLst>
+              <p:nextCondLst>
+                <p:cond evt="onNext" delay="0">
+                  <p:tgtEl>
+                    <p:sldTgt/>
+                  </p:tgtEl>
+                </p:cond>
+              </p:nextCondLst>
+            </p:seq>
+          </p:childTnLst>
+        </p:cTn>
+      </p:par>
+    </p:tnLst>
+  </p:timing>
+</p:sld>
+</file>
+
+<file path=ppt/slides/slide23.xml><?xml version="1.0" encoding="utf-8"?>
+<p:sld xmlns:a="http://schemas.openxmlformats.org/drawingml/2006/main" xmlns:r="http://schemas.openxmlformats.org/officeDocument/2006/relationships" xmlns:p="http://schemas.openxmlformats.org/presentationml/2006/main">
+  <p:cSld>
+    <p:bg>
+      <p:bgPr>
+        <a:solidFill>
+          <a:srgbClr val="F5F5F5"/>
+        </a:solidFill>
+        <a:effectLst/>
+      </p:bgPr>
+    </p:bg>
+    <p:spTree>
+      <p:nvGrpSpPr>
+        <p:cNvPr id="1" name="">
+          <a:extLst>
+            <a:ext uri="{FF2B5EF4-FFF2-40B4-BE49-F238E27FC236}">
+              <a16:creationId xmlns:a16="http://schemas.microsoft.com/office/drawing/2014/main" id="{19DE56A2-CF0B-DCDE-18F0-DF8D05157518}"/>
+            </a:ext>
+          </a:extLst>
+        </p:cNvPr>
+        <p:cNvGrpSpPr/>
+        <p:nvPr/>
+      </p:nvGrpSpPr>
+      <p:grpSpPr>
+        <a:xfrm>
+          <a:off x="0" y="0"/>
+          <a:ext cx="0" cy="0"/>
+          <a:chOff x="0" y="0"/>
+          <a:chExt cx="0" cy="0"/>
+        </a:xfrm>
+      </p:grpSpPr>
+      <p:sp>
+        <p:nvSpPr>
+          <p:cNvPr id="2" name="Title 1">
+            <a:extLst>
+              <a:ext uri="{FF2B5EF4-FFF2-40B4-BE49-F238E27FC236}">
+                <a16:creationId xmlns:a16="http://schemas.microsoft.com/office/drawing/2014/main" id="{E7B2A86D-85D1-03C2-AE7A-9DF4A0AD6A39}"/>
+              </a:ext>
+            </a:extLst>
+          </p:cNvPr>
+          <p:cNvSpPr>
+            <a:spLocks noGrp="1"/>
+          </p:cNvSpPr>
+          <p:nvPr>
+            <p:ph type="title"/>
+          </p:nvPr>
+        </p:nvSpPr>
+        <p:spPr/>
+        <p:txBody>
+          <a:bodyPr/>
+          <a:lstStyle/>
+          <a:p>
+            <a:r>
+              <a:rPr lang="en-US" dirty="0" err="1">
+                <a:latin typeface="Arial Rounded MT Bold" panose="020F0704030504030204" pitchFamily="34" charset="0"/>
+              </a:rPr>
+              <a:t>Objets</a:t>
+            </a:r>
+            <a:r>
+              <a:rPr lang="en-US" dirty="0">
+                <a:latin typeface="Arial Rounded MT Bold" panose="020F0704030504030204" pitchFamily="34" charset="0"/>
+              </a:rPr>
+              <a:t> et </a:t>
+            </a:r>
+            <a:r>
+              <a:rPr lang="en-US" dirty="0" err="1">
+                <a:latin typeface="Arial Rounded MT Bold" panose="020F0704030504030204" pitchFamily="34" charset="0"/>
+              </a:rPr>
+              <a:t>méthodes</a:t>
+            </a:r>
+            <a:endParaRPr lang="fr-CA" dirty="0">
+              <a:latin typeface="Arial Rounded MT Bold" panose="020F0704030504030204" pitchFamily="34" charset="0"/>
+            </a:endParaRPr>
+          </a:p>
+        </p:txBody>
+      </p:sp>
+      <p:sp>
+        <p:nvSpPr>
+          <p:cNvPr id="3" name="Content Placeholder 2">
+            <a:extLst>
+              <a:ext uri="{FF2B5EF4-FFF2-40B4-BE49-F238E27FC236}">
+                <a16:creationId xmlns:a16="http://schemas.microsoft.com/office/drawing/2014/main" id="{668F765D-E029-D26F-4935-E44A7019A184}"/>
+              </a:ext>
+            </a:extLst>
+          </p:cNvPr>
+          <p:cNvSpPr>
+            <a:spLocks noGrp="1"/>
+          </p:cNvSpPr>
+          <p:nvPr>
+            <p:ph idx="1"/>
+          </p:nvPr>
+        </p:nvSpPr>
+        <p:spPr/>
+        <p:txBody>
+          <a:bodyPr>
+            <a:normAutofit/>
+          </a:bodyPr>
+          <a:lstStyle/>
+          <a:p>
+            <a:pPr marL="457200" lvl="1" indent="0" algn="just">
+              <a:lnSpc>
+                <a:spcPct val="100000"/>
+              </a:lnSpc>
+              <a:buNone/>
+            </a:pPr>
+            <a:endParaRPr lang="en-CA" sz="1800" dirty="0">
+              <a:latin typeface="Consolas" panose="020B0609020204030204" pitchFamily="49" charset="0"/>
+            </a:endParaRPr>
+          </a:p>
+          <a:p>
+            <a:pPr algn="just">
+              <a:lnSpc>
+                <a:spcPct val="100000"/>
+              </a:lnSpc>
+            </a:pPr>
+            <a:r>
+              <a:rPr lang="en-US" sz="1800" dirty="0">
+                <a:latin typeface="Consolas" panose="020B0609020204030204" pitchFamily="49" charset="0"/>
+              </a:rPr>
+              <a:t>...</a:t>
+            </a:r>
+            <a:endParaRPr lang="fr-CA" sz="1800" dirty="0">
+              <a:latin typeface="Consolas" panose="020B0609020204030204" pitchFamily="49" charset="0"/>
+            </a:endParaRPr>
+          </a:p>
+          <a:p>
+            <a:pPr marL="457200" lvl="1" indent="0" algn="just">
+              <a:lnSpc>
+                <a:spcPct val="100000"/>
+              </a:lnSpc>
+              <a:buNone/>
+            </a:pPr>
+            <a:endParaRPr lang="fr-CA" sz="1800" dirty="0">
+              <a:latin typeface="Consolas" panose="020B0609020204030204" pitchFamily="49" charset="0"/>
+            </a:endParaRPr>
+          </a:p>
+        </p:txBody>
+      </p:sp>
+      <p:sp>
+        <p:nvSpPr>
+          <p:cNvPr id="5" name="Slide Number Placeholder 4">
+            <a:extLst>
+              <a:ext uri="{FF2B5EF4-FFF2-40B4-BE49-F238E27FC236}">
+                <a16:creationId xmlns:a16="http://schemas.microsoft.com/office/drawing/2014/main" id="{3F111B6A-C575-3556-2AB2-775B93FBBD08}"/>
+              </a:ext>
+            </a:extLst>
+          </p:cNvPr>
+          <p:cNvSpPr>
+            <a:spLocks noGrp="1"/>
+          </p:cNvSpPr>
+          <p:nvPr>
+            <p:ph type="sldNum" sz="quarter" idx="12"/>
+          </p:nvPr>
+        </p:nvSpPr>
+        <p:spPr/>
+        <p:txBody>
+          <a:bodyPr/>
+          <a:lstStyle/>
+          <a:p>
+            <a:fld id="{846B06B1-1179-491F-A487-8E0C403F7C13}" type="slidenum">
+              <a:rPr lang="fr-CA" smtClean="0"/>
+              <a:t>23</a:t>
+            </a:fld>
+            <a:endParaRPr lang="fr-CA"/>
+          </a:p>
+        </p:txBody>
+      </p:sp>
+      <p:sp>
+        <p:nvSpPr>
+          <p:cNvPr id="9" name="Content Placeholder 2">
+            <a:extLst>
+              <a:ext uri="{FF2B5EF4-FFF2-40B4-BE49-F238E27FC236}">
+                <a16:creationId xmlns:a16="http://schemas.microsoft.com/office/drawing/2014/main" id="{1A2F112F-7482-62CD-3247-F489CD4469F8}"/>
+              </a:ext>
+            </a:extLst>
+          </p:cNvPr>
+          <p:cNvSpPr txBox="1">
+            <a:spLocks/>
+          </p:cNvSpPr>
+          <p:nvPr/>
+        </p:nvSpPr>
+        <p:spPr>
+          <a:xfrm>
+            <a:off x="990600" y="1978025"/>
+            <a:ext cx="10515600" cy="4351338"/>
+          </a:xfrm>
+          <a:prstGeom prst="rect">
+            <a:avLst/>
+          </a:prstGeom>
+        </p:spPr>
+        <p:txBody>
+          <a:bodyPr vert="horz" lIns="91440" tIns="45720" rIns="91440" bIns="45720" rtlCol="0">
+            <a:normAutofit/>
+          </a:bodyPr>
+          <a:lstStyle>
+            <a:lvl1pPr marL="228600" indent="-228600" algn="l" defTabSz="914400" rtl="0" eaLnBrk="1" latinLnBrk="0" hangingPunct="1">
+              <a:lnSpc>
+                <a:spcPct val="90000"/>
+              </a:lnSpc>
+              <a:spcBef>
+                <a:spcPts val="1000"/>
+              </a:spcBef>
+              <a:buFont typeface="Arial" panose="020B0604020202020204" pitchFamily="34" charset="0"/>
+              <a:buChar char="•"/>
+              <a:defRPr sz="2800" kern="1200">
+                <a:solidFill>
+                  <a:schemeClr val="tx1"/>
+                </a:solidFill>
+                <a:latin typeface="+mn-lt"/>
+                <a:ea typeface="+mn-ea"/>
+                <a:cs typeface="+mn-cs"/>
+              </a:defRPr>
+            </a:lvl1pPr>
+            <a:lvl2pPr marL="685800" indent="-228600" algn="l" defTabSz="914400" rtl="0" eaLnBrk="1" latinLnBrk="0" hangingPunct="1">
+              <a:lnSpc>
+                <a:spcPct val="90000"/>
+              </a:lnSpc>
+              <a:spcBef>
+                <a:spcPts val="500"/>
+              </a:spcBef>
+              <a:buFont typeface="Arial" panose="020B0604020202020204" pitchFamily="34" charset="0"/>
+              <a:buChar char="•"/>
+              <a:defRPr sz="2400" kern="1200">
+                <a:solidFill>
+                  <a:schemeClr val="tx1"/>
+                </a:solidFill>
+                <a:latin typeface="+mn-lt"/>
+                <a:ea typeface="+mn-ea"/>
+                <a:cs typeface="+mn-cs"/>
+              </a:defRPr>
+            </a:lvl2pPr>
+            <a:lvl3pPr marL="1143000" indent="-228600" algn="l" defTabSz="914400" rtl="0" eaLnBrk="1" latinLnBrk="0" hangingPunct="1">
+              <a:lnSpc>
+                <a:spcPct val="90000"/>
+              </a:lnSpc>
+              <a:spcBef>
+                <a:spcPts val="500"/>
+              </a:spcBef>
+              <a:buFont typeface="Arial" panose="020B0604020202020204" pitchFamily="34" charset="0"/>
+              <a:buChar char="•"/>
+              <a:defRPr sz="2000" kern="1200">
+                <a:solidFill>
+                  <a:schemeClr val="tx1"/>
+                </a:solidFill>
+                <a:latin typeface="+mn-lt"/>
+                <a:ea typeface="+mn-ea"/>
+                <a:cs typeface="+mn-cs"/>
+              </a:defRPr>
+            </a:lvl3pPr>
+            <a:lvl4pPr marL="1600200" indent="-228600" algn="l" defTabSz="914400" rtl="0" eaLnBrk="1" latinLnBrk="0" hangingPunct="1">
+              <a:lnSpc>
+                <a:spcPct val="90000"/>
+              </a:lnSpc>
+              <a:spcBef>
+                <a:spcPts val="500"/>
+              </a:spcBef>
+              <a:buFont typeface="Arial" panose="020B0604020202020204" pitchFamily="34" charset="0"/>
+              <a:buChar char="•"/>
+              <a:defRPr sz="1800" kern="1200">
+                <a:solidFill>
+                  <a:schemeClr val="tx1"/>
+                </a:solidFill>
+                <a:latin typeface="+mn-lt"/>
+                <a:ea typeface="+mn-ea"/>
+                <a:cs typeface="+mn-cs"/>
+              </a:defRPr>
+            </a:lvl4pPr>
+            <a:lvl5pPr marL="2057400" indent="-228600" algn="l" defTabSz="914400" rtl="0" eaLnBrk="1" latinLnBrk="0" hangingPunct="1">
+              <a:lnSpc>
+                <a:spcPct val="90000"/>
+              </a:lnSpc>
+              <a:spcBef>
+                <a:spcPts val="500"/>
+              </a:spcBef>
+              <a:buFont typeface="Arial" panose="020B0604020202020204" pitchFamily="34" charset="0"/>
+              <a:buChar char="•"/>
+              <a:defRPr sz="1800" kern="1200">
+                <a:solidFill>
+                  <a:schemeClr val="tx1"/>
+                </a:solidFill>
+                <a:latin typeface="+mn-lt"/>
+                <a:ea typeface="+mn-ea"/>
+                <a:cs typeface="+mn-cs"/>
+              </a:defRPr>
+            </a:lvl5pPr>
+            <a:lvl6pPr marL="2514600" indent="-228600" algn="l" defTabSz="914400" rtl="0" eaLnBrk="1" latinLnBrk="0" hangingPunct="1">
+              <a:lnSpc>
+                <a:spcPct val="90000"/>
+              </a:lnSpc>
+              <a:spcBef>
+                <a:spcPts val="500"/>
+              </a:spcBef>
+              <a:buFont typeface="Arial" panose="020B0604020202020204" pitchFamily="34" charset="0"/>
+              <a:buChar char="•"/>
+              <a:defRPr sz="1800" kern="1200">
+                <a:solidFill>
+                  <a:schemeClr val="tx1"/>
+                </a:solidFill>
+                <a:latin typeface="+mn-lt"/>
+                <a:ea typeface="+mn-ea"/>
+                <a:cs typeface="+mn-cs"/>
+              </a:defRPr>
+            </a:lvl6pPr>
+            <a:lvl7pPr marL="2971800" indent="-228600" algn="l" defTabSz="914400" rtl="0" eaLnBrk="1" latinLnBrk="0" hangingPunct="1">
+              <a:lnSpc>
+                <a:spcPct val="90000"/>
+              </a:lnSpc>
+              <a:spcBef>
+                <a:spcPts val="500"/>
+              </a:spcBef>
+              <a:buFont typeface="Arial" panose="020B0604020202020204" pitchFamily="34" charset="0"/>
+              <a:buChar char="•"/>
+              <a:defRPr sz="1800" kern="1200">
+                <a:solidFill>
+                  <a:schemeClr val="tx1"/>
+                </a:solidFill>
+                <a:latin typeface="+mn-lt"/>
+                <a:ea typeface="+mn-ea"/>
+                <a:cs typeface="+mn-cs"/>
+              </a:defRPr>
+            </a:lvl7pPr>
+            <a:lvl8pPr marL="3429000" indent="-228600" algn="l" defTabSz="914400" rtl="0" eaLnBrk="1" latinLnBrk="0" hangingPunct="1">
+              <a:lnSpc>
+                <a:spcPct val="90000"/>
+              </a:lnSpc>
+              <a:spcBef>
+                <a:spcPts val="500"/>
+              </a:spcBef>
+              <a:buFont typeface="Arial" panose="020B0604020202020204" pitchFamily="34" charset="0"/>
+              <a:buChar char="•"/>
+              <a:defRPr sz="1800" kern="1200">
+                <a:solidFill>
+                  <a:schemeClr val="tx1"/>
+                </a:solidFill>
+                <a:latin typeface="+mn-lt"/>
+                <a:ea typeface="+mn-ea"/>
+                <a:cs typeface="+mn-cs"/>
+              </a:defRPr>
+            </a:lvl8pPr>
+            <a:lvl9pPr marL="3886200" indent="-228600" algn="l" defTabSz="914400" rtl="0" eaLnBrk="1" latinLnBrk="0" hangingPunct="1">
+              <a:lnSpc>
+                <a:spcPct val="90000"/>
+              </a:lnSpc>
+              <a:spcBef>
+                <a:spcPts val="500"/>
+              </a:spcBef>
+              <a:buFont typeface="Arial" panose="020B0604020202020204" pitchFamily="34" charset="0"/>
+              <a:buChar char="•"/>
+              <a:defRPr sz="1800" kern="1200">
+                <a:solidFill>
+                  <a:schemeClr val="tx1"/>
+                </a:solidFill>
+                <a:latin typeface="+mn-lt"/>
+                <a:ea typeface="+mn-ea"/>
+                <a:cs typeface="+mn-cs"/>
+              </a:defRPr>
+            </a:lvl9pPr>
+          </a:lstStyle>
+          <a:p>
+            <a:pPr marL="457200" lvl="1" indent="0" algn="just">
+              <a:lnSpc>
+                <a:spcPct val="150000"/>
+              </a:lnSpc>
+              <a:buNone/>
+            </a:pPr>
+            <a:endParaRPr lang="en-US" sz="1800" b="1" dirty="0">
+              <a:latin typeface="Consolas" panose="020B0609020204030204" pitchFamily="49" charset="0"/>
+            </a:endParaRPr>
+          </a:p>
+        </p:txBody>
+      </p:sp>
+    </p:spTree>
+    <p:extLst>
+      <p:ext uri="{BB962C8B-B14F-4D97-AF65-F5344CB8AC3E}">
+        <p14:creationId xmlns:p14="http://schemas.microsoft.com/office/powerpoint/2010/main" val="3179990299"/>
+      </p:ext>
+    </p:extLst>
+  </p:cSld>
+  <p:clrMapOvr>
+    <a:masterClrMapping/>
+  </p:clrMapOvr>
+  <p:timing>
+    <p:tnLst>
+      <p:par>
+        <p:cTn id="1" dur="indefinite" restart="never" nodeType="tmRoot">
+          <p:childTnLst>
+            <p:seq concurrent="1" nextAc="seek">
+              <p:cTn id="2" dur="indefinite" nodeType="mainSeq">
+                <p:childTnLst>
+                  <p:par>
+                    <p:cTn id="3" fill="hold">
+                      <p:stCondLst>
+                        <p:cond delay="indefinite"/>
+                      </p:stCondLst>
+                      <p:childTnLst>
+                        <p:par>
+                          <p:cTn id="4" fill="hold">
+                            <p:stCondLst>
+                              <p:cond delay="0"/>
+                            </p:stCondLst>
+                            <p:childTnLst>
+                              <p:par>
+                                <p:cTn id="5" presetID="10" presetClass="entr" presetSubtype="0" fill="hold" nodeType="clickEffect" nodePh="1">
+                                  <p:stCondLst>
+                                    <p:cond delay="0"/>
+                                  </p:stCondLst>
+                                  <p:endCondLst>
+                                    <p:cond evt="begin" delay="0">
+                                      <p:tn val="5"/>
+                                    </p:cond>
+                                  </p:endCondLst>
+                                  <p:childTnLst>
+                                    <p:set>
+                                      <p:cBhvr>
+                                        <p:cTn id="6" dur="1" fill="hold">
+                                          <p:stCondLst>
+                                            <p:cond delay="0"/>
+                                          </p:stCondLst>
+                                        </p:cTn>
+                                        <p:tgtEl>
+                                          <p:spTgt spid="9">
+                                            <p:txEl>
+                                              <p:pRg st="0" end="0"/>
+                                            </p:txEl>
+                                          </p:spTgt>
+                                        </p:tgtEl>
+                                        <p:attrNameLst>
+                                          <p:attrName>style.visibility</p:attrName>
+                                        </p:attrNameLst>
+                                      </p:cBhvr>
+                                      <p:to>
+                                        <p:strVal val="visible"/>
+                                      </p:to>
+                                    </p:set>
+                                    <p:animEffect transition="in" filter="fade">
+                                      <p:cBhvr>
+                                        <p:cTn id="7" dur="500"/>
+                                        <p:tgtEl>
+                                          <p:spTgt spid="9">
+                                            <p:txEl>
+                                              <p:pRg st="0" end="0"/>
+                                            </p:txEl>
+                                          </p:spTgt>
+                                        </p:tgtEl>
+                                      </p:cBhvr>
+                                    </p:animEffect>
+                                  </p:childTnLst>
+                                </p:cTn>
+                              </p:par>
+                            </p:childTnLst>
+                          </p:cTn>
+                        </p:par>
+                      </p:childTnLst>
+                    </p:cTn>
+                  </p:par>
+                </p:childTnLst>
+              </p:cTn>
+              <p:prevCondLst>
+                <p:cond evt="onPrev" delay="0">
+                  <p:tgtEl>
+                    <p:sldTgt/>
+                  </p:tgtEl>
+                </p:cond>
+              </p:prevCondLst>
+              <p:nextCondLst>
+                <p:cond evt="onNext" delay="0">
+                  <p:tgtEl>
+                    <p:sldTgt/>
+                  </p:tgtEl>
+                </p:cond>
+              </p:nextCondLst>
+            </p:seq>
+          </p:childTnLst>
+        </p:cTn>
+      </p:par>
+    </p:tnLst>
+  </p:timing>
+</p:sld>
+</file>
+
+<file path=ppt/slides/slide24.xml><?xml version="1.0" encoding="utf-8"?>
+<p:sld xmlns:a="http://schemas.openxmlformats.org/drawingml/2006/main" xmlns:r="http://schemas.openxmlformats.org/officeDocument/2006/relationships" xmlns:p="http://schemas.openxmlformats.org/presentationml/2006/main">
+  <p:cSld>
+    <p:bg>
+      <p:bgPr>
+        <a:solidFill>
+          <a:schemeClr val="bg1">
+            <a:lumMod val="95000"/>
+          </a:schemeClr>
+        </a:solidFill>
+        <a:effectLst/>
+      </p:bgPr>
+    </p:bg>
+    <p:spTree>
+      <p:nvGrpSpPr>
+        <p:cNvPr id="1" name="">
+          <a:extLst>
+            <a:ext uri="{FF2B5EF4-FFF2-40B4-BE49-F238E27FC236}">
+              <a16:creationId xmlns:a16="http://schemas.microsoft.com/office/drawing/2014/main" id="{75DA6A40-BCE7-A8AF-2F09-CCBF86A73F57}"/>
+            </a:ext>
+          </a:extLst>
+        </p:cNvPr>
+        <p:cNvGrpSpPr/>
+        <p:nvPr/>
+      </p:nvGrpSpPr>
+      <p:grpSpPr>
+        <a:xfrm>
+          <a:off x="0" y="0"/>
+          <a:ext cx="0" cy="0"/>
+          <a:chOff x="0" y="0"/>
+          <a:chExt cx="0" cy="0"/>
+        </a:xfrm>
+      </p:grpSpPr>
+      <p:sp>
+        <p:nvSpPr>
+          <p:cNvPr id="2" name="Title 1">
+            <a:extLst>
+              <a:ext uri="{FF2B5EF4-FFF2-40B4-BE49-F238E27FC236}">
+                <a16:creationId xmlns:a16="http://schemas.microsoft.com/office/drawing/2014/main" id="{5AD71FA1-6AD3-129C-8A3A-20D41092F1F1}"/>
+              </a:ext>
+            </a:extLst>
+          </p:cNvPr>
+          <p:cNvSpPr>
+            <a:spLocks noGrp="1"/>
+          </p:cNvSpPr>
+          <p:nvPr>
+            <p:ph type="title"/>
+          </p:nvPr>
+        </p:nvSpPr>
+        <p:spPr/>
+        <p:txBody>
+          <a:bodyPr/>
+          <a:lstStyle/>
+          <a:p>
+            <a:r>
+              <a:rPr lang="en-US" dirty="0">
+                <a:latin typeface="Arial Rounded MT Bold" panose="020F0704030504030204" pitchFamily="34" charset="0"/>
+              </a:rPr>
+              <a:t>ANNEXE I</a:t>
+            </a:r>
+            <a:endParaRPr lang="fr-CA" dirty="0">
+              <a:latin typeface="Arial Rounded MT Bold" panose="020F0704030504030204" pitchFamily="34" charset="0"/>
+            </a:endParaRPr>
+          </a:p>
+        </p:txBody>
+      </p:sp>
+      <p:sp>
+        <p:nvSpPr>
+          <p:cNvPr id="11" name="Slide Number Placeholder 10">
+            <a:extLst>
+              <a:ext uri="{FF2B5EF4-FFF2-40B4-BE49-F238E27FC236}">
+                <a16:creationId xmlns:a16="http://schemas.microsoft.com/office/drawing/2014/main" id="{6B59C14A-02F3-20F2-19A6-212B35B47AC1}"/>
+              </a:ext>
+            </a:extLst>
+          </p:cNvPr>
+          <p:cNvSpPr>
+            <a:spLocks noGrp="1"/>
+          </p:cNvSpPr>
+          <p:nvPr>
+            <p:ph type="sldNum" sz="quarter" idx="12"/>
+          </p:nvPr>
+        </p:nvSpPr>
+        <p:spPr/>
+        <p:txBody>
+          <a:bodyPr/>
+          <a:lstStyle/>
+          <a:p>
+            <a:fld id="{846B06B1-1179-491F-A487-8E0C403F7C13}" type="slidenum">
+              <a:rPr lang="fr-CA" smtClean="0"/>
+              <a:t>24</a:t>
+            </a:fld>
+            <a:endParaRPr lang="fr-CA"/>
+          </a:p>
+        </p:txBody>
+      </p:sp>
+      <p:sp>
+        <p:nvSpPr>
+          <p:cNvPr id="9" name="Content Placeholder 2">
+            <a:extLst>
+              <a:ext uri="{FF2B5EF4-FFF2-40B4-BE49-F238E27FC236}">
+                <a16:creationId xmlns:a16="http://schemas.microsoft.com/office/drawing/2014/main" id="{431F6E27-257B-2553-4FF3-7C114074BCBC}"/>
+              </a:ext>
+            </a:extLst>
+          </p:cNvPr>
+          <p:cNvSpPr>
+            <a:spLocks noGrp="1"/>
+          </p:cNvSpPr>
+          <p:nvPr>
+            <p:ph idx="1"/>
+          </p:nvPr>
+        </p:nvSpPr>
+        <p:spPr>
+          <a:xfrm>
+            <a:off x="838200" y="1825625"/>
+            <a:ext cx="10515600" cy="4351338"/>
+          </a:xfrm>
+        </p:spPr>
+        <p:txBody>
+          <a:bodyPr>
+            <a:normAutofit/>
+          </a:bodyPr>
+          <a:lstStyle/>
+          <a:p>
+            <a:pPr marL="514350" indent="-514350" algn="just">
+              <a:buFont typeface="+mj-lt"/>
+              <a:buAutoNum type="arabicPeriod"/>
+            </a:pPr>
+            <a:r>
+              <a:rPr lang="en-US" dirty="0"/>
+              <a:t>Butler, Simon; </a:t>
+            </a:r>
+            <a:r>
+              <a:rPr lang="en-US" dirty="0" err="1"/>
+              <a:t>Wermelinger</a:t>
+            </a:r>
+            <a:r>
+              <a:rPr lang="en-US" dirty="0"/>
+              <a:t>, Michel; Yu, Yijun and Sharp, Helen (2010). Exploring the Influence of </a:t>
+            </a:r>
+            <a:r>
+              <a:rPr lang="en-US" dirty="0" err="1"/>
+              <a:t>IdentifierNames</a:t>
+            </a:r>
+            <a:r>
+              <a:rPr lang="en-US" dirty="0"/>
+              <a:t> on Code Quality: An empirical study. In: 14th European Conference on Software Maintenance </a:t>
+            </a:r>
+            <a:r>
+              <a:rPr lang="en-US" dirty="0" err="1"/>
+              <a:t>andReengineering</a:t>
+            </a:r>
+            <a:r>
+              <a:rPr lang="en-US" dirty="0"/>
+              <a:t>, 15-18 Mar 2010, Madrid, Spain, pp. 156–165.</a:t>
+            </a:r>
+            <a:endParaRPr lang="pt-BR" sz="2600" dirty="0">
+              <a:latin typeface="Consolas" panose="020B0609020204030204" pitchFamily="49" charset="0"/>
+            </a:endParaRPr>
+          </a:p>
+        </p:txBody>
+      </p:sp>
+    </p:spTree>
+    <p:extLst>
+      <p:ext uri="{BB962C8B-B14F-4D97-AF65-F5344CB8AC3E}">
+        <p14:creationId xmlns:p14="http://schemas.microsoft.com/office/powerpoint/2010/main" val="4215596461"/>
       </p:ext>
     </p:extLst>
   </p:cSld>

</xml_diff>

<commit_message>
feat: Complete python_1 presentation slide no.21
</commit_message>
<xml_diff>
--- a/python_1/presentation_python_1.pptx
+++ b/python_1/presentation_python_1.pptx
@@ -5,7 +5,7 @@
     <p:sldMasterId id="2147483648" r:id="rId1"/>
   </p:sldMasterIdLst>
   <p:notesMasterIdLst>
-    <p:notesMasterId r:id="rId26"/>
+    <p:notesMasterId r:id="rId27"/>
   </p:notesMasterIdLst>
   <p:sldIdLst>
     <p:sldId id="256" r:id="rId2"/>
@@ -28,10 +28,11 @@
     <p:sldId id="277" r:id="rId19"/>
     <p:sldId id="278" r:id="rId20"/>
     <p:sldId id="282" r:id="rId21"/>
-    <p:sldId id="280" r:id="rId22"/>
-    <p:sldId id="279" r:id="rId23"/>
-    <p:sldId id="281" r:id="rId24"/>
-    <p:sldId id="270" r:id="rId25"/>
+    <p:sldId id="283" r:id="rId22"/>
+    <p:sldId id="280" r:id="rId23"/>
+    <p:sldId id="279" r:id="rId24"/>
+    <p:sldId id="281" r:id="rId25"/>
+    <p:sldId id="270" r:id="rId26"/>
   </p:sldIdLst>
   <p:sldSz cx="12192000" cy="6858000"/>
   <p:notesSz cx="6858000" cy="9144000"/>
@@ -220,7 +221,7 @@
           <a:p>
             <a:fld id="{17426931-AE65-4D08-8B32-62FCBDE55937}" type="datetimeFigureOut">
               <a:rPr lang="fr-CA" smtClean="0"/>
-              <a:t>2026-04-11</a:t>
+              <a:t>2026-04-12</a:t>
             </a:fld>
             <a:endParaRPr lang="fr-CA"/>
           </a:p>
@@ -637,7 +638,7 @@
           <a:p>
             <a:fld id="{73720E39-F9E6-45F4-9AF3-0670893E0E05}" type="datetime1">
               <a:rPr lang="fr-CA" smtClean="0"/>
-              <a:t>2026-04-11</a:t>
+              <a:t>2026-04-12</a:t>
             </a:fld>
             <a:endParaRPr lang="fr-CA"/>
           </a:p>
@@ -837,7 +838,7 @@
           <a:p>
             <a:fld id="{2A86A87F-FCE1-414B-898E-E056954DFB53}" type="datetime1">
               <a:rPr lang="fr-CA" smtClean="0"/>
-              <a:t>2026-04-11</a:t>
+              <a:t>2026-04-12</a:t>
             </a:fld>
             <a:endParaRPr lang="fr-CA"/>
           </a:p>
@@ -1047,7 +1048,7 @@
           <a:p>
             <a:fld id="{86217A25-A768-4FB5-8838-4C76F4A4D771}" type="datetime1">
               <a:rPr lang="fr-CA" smtClean="0"/>
-              <a:t>2026-04-11</a:t>
+              <a:t>2026-04-12</a:t>
             </a:fld>
             <a:endParaRPr lang="fr-CA"/>
           </a:p>
@@ -1247,7 +1248,7 @@
           <a:p>
             <a:fld id="{6DF5E9B1-F4B4-44A9-8978-A50A0AD8373C}" type="datetime1">
               <a:rPr lang="fr-CA" smtClean="0"/>
-              <a:t>2026-04-11</a:t>
+              <a:t>2026-04-12</a:t>
             </a:fld>
             <a:endParaRPr lang="fr-CA"/>
           </a:p>
@@ -1523,7 +1524,7 @@
           <a:p>
             <a:fld id="{5DE8FE0D-E91C-47AE-8B70-2B0ABA5D1B1E}" type="datetime1">
               <a:rPr lang="fr-CA" smtClean="0"/>
-              <a:t>2026-04-11</a:t>
+              <a:t>2026-04-12</a:t>
             </a:fld>
             <a:endParaRPr lang="fr-CA"/>
           </a:p>
@@ -1791,7 +1792,7 @@
           <a:p>
             <a:fld id="{F3AB8F30-8420-4011-A9ED-ED2F47883C93}" type="datetime1">
               <a:rPr lang="fr-CA" smtClean="0"/>
-              <a:t>2026-04-11</a:t>
+              <a:t>2026-04-12</a:t>
             </a:fld>
             <a:endParaRPr lang="fr-CA"/>
           </a:p>
@@ -2206,7 +2207,7 @@
           <a:p>
             <a:fld id="{852876F1-672F-46E4-BC46-E9D4C880BFEF}" type="datetime1">
               <a:rPr lang="fr-CA" smtClean="0"/>
-              <a:t>2026-04-11</a:t>
+              <a:t>2026-04-12</a:t>
             </a:fld>
             <a:endParaRPr lang="fr-CA"/>
           </a:p>
@@ -2348,7 +2349,7 @@
           <a:p>
             <a:fld id="{05494588-57AE-4A88-AA7D-14590C8ABB1D}" type="datetime1">
               <a:rPr lang="fr-CA" smtClean="0"/>
-              <a:t>2026-04-11</a:t>
+              <a:t>2026-04-12</a:t>
             </a:fld>
             <a:endParaRPr lang="fr-CA"/>
           </a:p>
@@ -2461,7 +2462,7 @@
           <a:p>
             <a:fld id="{70596107-F84A-4D89-B7EE-30826EF0EE70}" type="datetime1">
               <a:rPr lang="fr-CA" smtClean="0"/>
-              <a:t>2026-04-11</a:t>
+              <a:t>2026-04-12</a:t>
             </a:fld>
             <a:endParaRPr lang="fr-CA"/>
           </a:p>
@@ -2774,7 +2775,7 @@
           <a:p>
             <a:fld id="{12C269CA-6797-4965-A975-3F40F12DAD06}" type="datetime1">
               <a:rPr lang="fr-CA" smtClean="0"/>
-              <a:t>2026-04-11</a:t>
+              <a:t>2026-04-12</a:t>
             </a:fld>
             <a:endParaRPr lang="fr-CA"/>
           </a:p>
@@ -3063,7 +3064,7 @@
           <a:p>
             <a:fld id="{3F5AE234-69D2-4522-AB7A-F911A65753A0}" type="datetime1">
               <a:rPr lang="fr-CA" smtClean="0"/>
-              <a:t>2026-04-11</a:t>
+              <a:t>2026-04-12</a:t>
             </a:fld>
             <a:endParaRPr lang="fr-CA"/>
           </a:p>
@@ -3306,7 +3307,7 @@
           <a:p>
             <a:fld id="{30546B8D-50B2-4CF7-ACAA-221A68F8C882}" type="datetime1">
               <a:rPr lang="fr-CA" smtClean="0"/>
-              <a:t>2026-04-11</a:t>
+              <a:t>2026-04-12</a:t>
             </a:fld>
             <a:endParaRPr lang="fr-CA"/>
           </a:p>
@@ -13691,68 +13692,495 @@
           </a:p>
         </p:txBody>
       </p:sp>
-      <p:sp>
-        <p:nvSpPr>
-          <p:cNvPr id="3" name="Content Placeholder 2">
-            <a:extLst>
-              <a:ext uri="{FF2B5EF4-FFF2-40B4-BE49-F238E27FC236}">
-                <a16:creationId xmlns:a16="http://schemas.microsoft.com/office/drawing/2014/main" id="{C266EEB5-5DF4-1772-722C-9295423EFC10}"/>
-              </a:ext>
-            </a:extLst>
-          </p:cNvPr>
-          <p:cNvSpPr>
-            <a:spLocks noGrp="1"/>
-          </p:cNvSpPr>
-          <p:nvPr>
-            <p:ph idx="1"/>
-          </p:nvPr>
-        </p:nvSpPr>
-        <p:spPr/>
-        <p:txBody>
-          <a:bodyPr>
-            <a:normAutofit/>
-          </a:bodyPr>
-          <a:lstStyle/>
-          <a:p>
-            <a:pPr marL="457200" lvl="1" indent="0" algn="just">
-              <a:lnSpc>
-                <a:spcPct val="100000"/>
-              </a:lnSpc>
-              <a:buNone/>
-            </a:pPr>
-            <a:endParaRPr lang="en-CA" sz="1800" dirty="0">
-              <a:latin typeface="Consolas" panose="020B0609020204030204" pitchFamily="49" charset="0"/>
-            </a:endParaRPr>
-          </a:p>
-          <a:p>
-            <a:pPr algn="just">
-              <a:lnSpc>
-                <a:spcPct val="100000"/>
-              </a:lnSpc>
-            </a:pPr>
-            <a:r>
-              <a:rPr lang="en-US" sz="1800" dirty="0">
-                <a:latin typeface="Consolas" panose="020B0609020204030204" pitchFamily="49" charset="0"/>
-              </a:rPr>
-              <a:t>...</a:t>
-            </a:r>
-            <a:endParaRPr lang="fr-CA" sz="1800" dirty="0">
-              <a:latin typeface="Consolas" panose="020B0609020204030204" pitchFamily="49" charset="0"/>
-            </a:endParaRPr>
-          </a:p>
-          <a:p>
-            <a:pPr marL="457200" lvl="1" indent="0" algn="just">
-              <a:lnSpc>
-                <a:spcPct val="100000"/>
-              </a:lnSpc>
-              <a:buNone/>
-            </a:pPr>
-            <a:endParaRPr lang="fr-CA" sz="1800" dirty="0">
-              <a:latin typeface="Consolas" panose="020B0609020204030204" pitchFamily="49" charset="0"/>
-            </a:endParaRPr>
-          </a:p>
-        </p:txBody>
-      </p:sp>
+      <mc:AlternateContent xmlns:mc="http://schemas.openxmlformats.org/markup-compatibility/2006" xmlns:a14="http://schemas.microsoft.com/office/drawing/2010/main">
+        <mc:Choice Requires="a14">
+          <p:sp>
+            <p:nvSpPr>
+              <p:cNvPr id="3" name="Content Placeholder 2">
+                <a:extLst>
+                  <a:ext uri="{FF2B5EF4-FFF2-40B4-BE49-F238E27FC236}">
+                    <a16:creationId xmlns:a16="http://schemas.microsoft.com/office/drawing/2014/main" id="{C266EEB5-5DF4-1772-722C-9295423EFC10}"/>
+                  </a:ext>
+                </a:extLst>
+              </p:cNvPr>
+              <p:cNvSpPr>
+                <a:spLocks noGrp="1"/>
+              </p:cNvSpPr>
+              <p:nvPr>
+                <p:ph idx="1"/>
+              </p:nvPr>
+            </p:nvSpPr>
+            <p:spPr/>
+            <p:txBody>
+              <a:bodyPr>
+                <a:normAutofit/>
+              </a:bodyPr>
+              <a:lstStyle/>
+              <a:p>
+                <a:pPr algn="just">
+                  <a:lnSpc>
+                    <a:spcPct val="100000"/>
+                  </a:lnSpc>
+                </a:pPr>
+                <a:r>
+                  <a:rPr lang="en-CA" sz="1800" dirty="0">
+                    <a:latin typeface="Consolas" panose="020B0609020204030204" pitchFamily="49" charset="0"/>
+                  </a:rPr>
+                  <a:t>Op</a:t>
+                </a:r>
+                <a:r>
+                  <a:rPr lang="en-US" sz="1800" dirty="0" err="1">
+                    <a:latin typeface="Consolas" panose="020B0609020204030204" pitchFamily="49" charset="0"/>
+                  </a:rPr>
+                  <a:t>érateurs</a:t>
+                </a:r>
+                <a:r>
+                  <a:rPr lang="en-US" sz="1800" dirty="0">
+                    <a:latin typeface="Consolas" panose="020B0609020204030204" pitchFamily="49" charset="0"/>
+                  </a:rPr>
+                  <a:t> de </a:t>
+                </a:r>
+                <a:r>
+                  <a:rPr lang="en-US" sz="1800" b="1" dirty="0" err="1">
+                    <a:latin typeface="Consolas" panose="020B0609020204030204" pitchFamily="49" charset="0"/>
+                  </a:rPr>
+                  <a:t>comparaison</a:t>
+                </a:r>
+                <a:r>
+                  <a:rPr lang="en-US" sz="1800" dirty="0">
+                    <a:latin typeface="Consolas" panose="020B0609020204030204" pitchFamily="49" charset="0"/>
+                  </a:rPr>
+                  <a:t>: </a:t>
+                </a:r>
+                <a:r>
+                  <a:rPr lang="en-CA" sz="1800" dirty="0">
+                    <a:latin typeface="Consolas" panose="020B0609020204030204" pitchFamily="49" charset="0"/>
+                  </a:rPr>
+                  <a:t>&lt;, &lt;=, &gt;, &gt;=, ==</a:t>
+                </a:r>
+                <a:endParaRPr lang="en-CA" sz="100" dirty="0">
+                  <a:latin typeface="Consolas" panose="020B0609020204030204" pitchFamily="49" charset="0"/>
+                </a:endParaRPr>
+              </a:p>
+              <a:p>
+                <a:pPr lvl="1" algn="just">
+                  <a:lnSpc>
+                    <a:spcPct val="100000"/>
+                  </a:lnSpc>
+                </a:pPr>
+                <a:r>
+                  <a:rPr lang="en-CA" sz="1600" dirty="0" err="1">
+                    <a:latin typeface="Consolas" panose="020B0609020204030204" pitchFamily="49" charset="0"/>
+                  </a:rPr>
+                  <a:t>Devinette</a:t>
+                </a:r>
+                <a:r>
+                  <a:rPr lang="en-CA" sz="1600" dirty="0">
+                    <a:latin typeface="Consolas" panose="020B0609020204030204" pitchFamily="49" charset="0"/>
+                  </a:rPr>
+                  <a:t>: </a:t>
+                </a:r>
+                <a14:m>
+                  <m:oMath xmlns:m="http://schemas.openxmlformats.org/officeDocument/2006/math">
+                    <m:sSup>
+                      <m:sSupPr>
+                        <m:ctrlPr>
+                          <a:rPr lang="en-CA" sz="1600" b="0" i="1" smtClean="0">
+                            <a:latin typeface="Cambria Math" panose="02040503050406030204" pitchFamily="18" charset="0"/>
+                          </a:rPr>
+                        </m:ctrlPr>
+                      </m:sSupPr>
+                      <m:e>
+                        <m:sSup>
+                          <m:sSupPr>
+                            <m:ctrlPr>
+                              <a:rPr lang="en-CA" sz="1600" b="0" i="1" smtClean="0">
+                                <a:latin typeface="Cambria Math" panose="02040503050406030204" pitchFamily="18" charset="0"/>
+                              </a:rPr>
+                            </m:ctrlPr>
+                          </m:sSupPr>
+                          <m:e>
+                            <m:r>
+                              <a:rPr lang="en-CA" sz="1600" b="0" i="1" smtClean="0">
+                                <a:latin typeface="Cambria Math" panose="02040503050406030204" pitchFamily="18" charset="0"/>
+                              </a:rPr>
+                              <m:t>𝜋</m:t>
+                            </m:r>
+                          </m:e>
+                          <m:sup>
+                            <m:r>
+                              <a:rPr lang="en-CA" sz="1600" b="0" i="1" smtClean="0">
+                                <a:latin typeface="Cambria Math" panose="02040503050406030204" pitchFamily="18" charset="0"/>
+                              </a:rPr>
+                              <m:t>𝑒</m:t>
+                            </m:r>
+                          </m:sup>
+                        </m:sSup>
+                        <m:r>
+                          <a:rPr lang="en-CA" sz="1600" b="0" i="1" smtClean="0">
+                            <a:latin typeface="Cambria Math" panose="02040503050406030204" pitchFamily="18" charset="0"/>
+                          </a:rPr>
+                          <m:t>&gt;</m:t>
+                        </m:r>
+                        <m:r>
+                          <a:rPr lang="en-CA" sz="1600" b="0" i="1" smtClean="0">
+                            <a:latin typeface="Cambria Math" panose="02040503050406030204" pitchFamily="18" charset="0"/>
+                          </a:rPr>
+                          <m:t>𝑒</m:t>
+                        </m:r>
+                      </m:e>
+                      <m:sup>
+                        <m:r>
+                          <a:rPr lang="en-CA" sz="1600" b="0" i="1" smtClean="0">
+                            <a:latin typeface="Cambria Math" panose="02040503050406030204" pitchFamily="18" charset="0"/>
+                          </a:rPr>
+                          <m:t>𝜋</m:t>
+                        </m:r>
+                      </m:sup>
+                    </m:sSup>
+                  </m:oMath>
+                </a14:m>
+                <a:r>
+                  <a:rPr lang="fr-CA" sz="1600" dirty="0">
+                    <a:latin typeface="Consolas" panose="020B0609020204030204" pitchFamily="49" charset="0"/>
+                  </a:rPr>
+                  <a:t> ?</a:t>
+                </a:r>
+              </a:p>
+              <a:p>
+                <a:pPr algn="just">
+                  <a:lnSpc>
+                    <a:spcPct val="100000"/>
+                  </a:lnSpc>
+                </a:pPr>
+                <a:endParaRPr lang="fr-CA" sz="100" dirty="0">
+                  <a:latin typeface="Consolas" panose="020B0609020204030204" pitchFamily="49" charset="0"/>
+                </a:endParaRPr>
+              </a:p>
+              <a:p>
+                <a:pPr marL="914400" lvl="2" indent="0" algn="just">
+                  <a:lnSpc>
+                    <a:spcPct val="100000"/>
+                  </a:lnSpc>
+                  <a:buNone/>
+                </a:pPr>
+                <a:r>
+                  <a:rPr lang="en-CA" sz="1400" b="1" dirty="0">
+                    <a:latin typeface="Consolas" panose="020B0609020204030204" pitchFamily="49" charset="0"/>
+                  </a:rPr>
+                  <a:t>&gt;&gt;&gt; from math import pi, exp</a:t>
+                </a:r>
+              </a:p>
+              <a:p>
+                <a:pPr marL="914400" lvl="2" indent="0" algn="just">
+                  <a:lnSpc>
+                    <a:spcPct val="100000"/>
+                  </a:lnSpc>
+                  <a:buNone/>
+                </a:pPr>
+                <a:r>
+                  <a:rPr lang="en-CA" sz="1400" b="1" dirty="0">
+                    <a:latin typeface="Consolas" panose="020B0609020204030204" pitchFamily="49" charset="0"/>
+                  </a:rPr>
+                  <a:t>&gt;&gt;&gt; pi ** exp(1) &gt; exp(1) ** pi</a:t>
+                </a:r>
+              </a:p>
+              <a:p>
+                <a:pPr marL="914400" lvl="2" indent="0" algn="just">
+                  <a:lnSpc>
+                    <a:spcPct val="100000"/>
+                  </a:lnSpc>
+                  <a:buNone/>
+                </a:pPr>
+                <a:r>
+                  <a:rPr lang="en-CA" sz="1400" dirty="0">
+                    <a:solidFill>
+                      <a:schemeClr val="bg1">
+                        <a:lumMod val="50000"/>
+                      </a:schemeClr>
+                    </a:solidFill>
+                    <a:latin typeface="Consolas" panose="020B0609020204030204" pitchFamily="49" charset="0"/>
+                  </a:rPr>
+                  <a:t>False</a:t>
+                </a:r>
+              </a:p>
+              <a:p>
+                <a:pPr algn="just">
+                  <a:lnSpc>
+                    <a:spcPct val="100000"/>
+                  </a:lnSpc>
+                </a:pPr>
+                <a:r>
+                  <a:rPr lang="en-CA" sz="1800" dirty="0">
+                    <a:latin typeface="Consolas" panose="020B0609020204030204" pitchFamily="49" charset="0"/>
+                  </a:rPr>
+                  <a:t>Op</a:t>
+                </a:r>
+                <a:r>
+                  <a:rPr lang="en-US" sz="1800" dirty="0" err="1">
+                    <a:latin typeface="Consolas" panose="020B0609020204030204" pitchFamily="49" charset="0"/>
+                  </a:rPr>
+                  <a:t>érateurs</a:t>
+                </a:r>
+                <a:r>
+                  <a:rPr lang="en-US" sz="1800" dirty="0">
+                    <a:latin typeface="Consolas" panose="020B0609020204030204" pitchFamily="49" charset="0"/>
+                  </a:rPr>
+                  <a:t> </a:t>
+                </a:r>
+                <a:r>
+                  <a:rPr lang="en-US" sz="1800" b="1" dirty="0" err="1">
+                    <a:latin typeface="Consolas" panose="020B0609020204030204" pitchFamily="49" charset="0"/>
+                  </a:rPr>
+                  <a:t>logiques</a:t>
+                </a:r>
+                <a:r>
+                  <a:rPr lang="en-US" sz="1800" dirty="0">
+                    <a:latin typeface="Consolas" panose="020B0609020204030204" pitchFamily="49" charset="0"/>
+                  </a:rPr>
+                  <a:t>:</a:t>
+                </a:r>
+              </a:p>
+              <a:p>
+                <a:pPr lvl="1" algn="just">
+                  <a:lnSpc>
+                    <a:spcPct val="100000"/>
+                  </a:lnSpc>
+                </a:pPr>
+                <a:r>
+                  <a:rPr lang="en-US" sz="1600" dirty="0">
+                    <a:latin typeface="Consolas" panose="020B0609020204030204" pitchFamily="49" charset="0"/>
+                  </a:rPr>
+                  <a:t>ET </a:t>
+                </a:r>
+                <a:r>
+                  <a:rPr lang="en-US" sz="1600" dirty="0" err="1">
+                    <a:latin typeface="Consolas" panose="020B0609020204030204" pitchFamily="49" charset="0"/>
+                  </a:rPr>
+                  <a:t>logique</a:t>
+                </a:r>
+                <a:r>
+                  <a:rPr lang="en-US" sz="1600" dirty="0">
+                    <a:latin typeface="Consolas" panose="020B0609020204030204" pitchFamily="49" charset="0"/>
+                  </a:rPr>
+                  <a:t> (and): Si </a:t>
+                </a:r>
+                <a:r>
+                  <a:rPr lang="en-US" sz="1600" dirty="0" err="1">
+                    <a:latin typeface="Consolas" panose="020B0609020204030204" pitchFamily="49" charset="0"/>
+                  </a:rPr>
+                  <a:t>l'un</a:t>
+                </a:r>
+                <a:r>
+                  <a:rPr lang="en-US" sz="1600" dirty="0">
+                    <a:latin typeface="Consolas" panose="020B0609020204030204" pitchFamily="49" charset="0"/>
+                  </a:rPr>
+                  <a:t> ET </a:t>
+                </a:r>
+                <a:r>
+                  <a:rPr lang="en-US" sz="1600" dirty="0" err="1">
+                    <a:latin typeface="Consolas" panose="020B0609020204030204" pitchFamily="49" charset="0"/>
+                  </a:rPr>
+                  <a:t>l'autre</a:t>
+                </a:r>
+                <a:r>
+                  <a:rPr lang="en-US" sz="1600" dirty="0">
+                    <a:latin typeface="Consolas" panose="020B0609020204030204" pitchFamily="49" charset="0"/>
+                  </a:rPr>
+                  <a:t> est </a:t>
+                </a:r>
+                <a:r>
+                  <a:rPr lang="en-US" sz="1600" dirty="0" err="1">
+                    <a:latin typeface="Consolas" panose="020B0609020204030204" pitchFamily="49" charset="0"/>
+                  </a:rPr>
+                  <a:t>vrai</a:t>
+                </a:r>
+                <a:r>
+                  <a:rPr lang="en-US" sz="1600" dirty="0">
+                    <a:latin typeface="Consolas" panose="020B0609020204030204" pitchFamily="49" charset="0"/>
+                  </a:rPr>
+                  <a:t>, </a:t>
+                </a:r>
+                <a:r>
+                  <a:rPr lang="en-US" sz="1600" dirty="0" err="1">
+                    <a:latin typeface="Consolas" panose="020B0609020204030204" pitchFamily="49" charset="0"/>
+                  </a:rPr>
+                  <a:t>sinon</a:t>
+                </a:r>
+                <a:r>
+                  <a:rPr lang="en-US" sz="1600" dirty="0">
+                    <a:latin typeface="Consolas" panose="020B0609020204030204" pitchFamily="49" charset="0"/>
+                  </a:rPr>
+                  <a:t> faux.</a:t>
+                </a:r>
+              </a:p>
+              <a:p>
+                <a:pPr lvl="1" algn="just">
+                  <a:lnSpc>
+                    <a:spcPct val="100000"/>
+                  </a:lnSpc>
+                </a:pPr>
+                <a:r>
+                  <a:rPr lang="en-US" sz="1600" dirty="0">
+                    <a:latin typeface="Consolas" panose="020B0609020204030204" pitchFamily="49" charset="0"/>
+                  </a:rPr>
+                  <a:t>OU </a:t>
+                </a:r>
+                <a:r>
+                  <a:rPr lang="en-US" sz="1600" dirty="0" err="1">
+                    <a:latin typeface="Consolas" panose="020B0609020204030204" pitchFamily="49" charset="0"/>
+                  </a:rPr>
+                  <a:t>logique</a:t>
+                </a:r>
+                <a:r>
+                  <a:rPr lang="en-US" sz="1600" dirty="0">
+                    <a:latin typeface="Consolas" panose="020B0609020204030204" pitchFamily="49" charset="0"/>
+                  </a:rPr>
+                  <a:t> (or): Si </a:t>
+                </a:r>
+                <a:r>
+                  <a:rPr lang="en-US" sz="1600" dirty="0" err="1">
+                    <a:latin typeface="Consolas" panose="020B0609020204030204" pitchFamily="49" charset="0"/>
+                  </a:rPr>
+                  <a:t>l'un</a:t>
+                </a:r>
+                <a:r>
+                  <a:rPr lang="en-US" sz="1600" dirty="0">
+                    <a:latin typeface="Consolas" panose="020B0609020204030204" pitchFamily="49" charset="0"/>
+                  </a:rPr>
+                  <a:t> OU </a:t>
+                </a:r>
+                <a:r>
+                  <a:rPr lang="en-US" sz="1600" dirty="0" err="1">
+                    <a:latin typeface="Consolas" panose="020B0609020204030204" pitchFamily="49" charset="0"/>
+                  </a:rPr>
+                  <a:t>l'autre</a:t>
+                </a:r>
+                <a:r>
+                  <a:rPr lang="en-US" sz="1600" dirty="0">
+                    <a:latin typeface="Consolas" panose="020B0609020204030204" pitchFamily="49" charset="0"/>
+                  </a:rPr>
+                  <a:t> est </a:t>
+                </a:r>
+                <a:r>
+                  <a:rPr lang="en-US" sz="1600" dirty="0" err="1">
+                    <a:latin typeface="Consolas" panose="020B0609020204030204" pitchFamily="49" charset="0"/>
+                  </a:rPr>
+                  <a:t>vrai</a:t>
+                </a:r>
+                <a:r>
+                  <a:rPr lang="en-US" sz="1600" dirty="0">
+                    <a:latin typeface="Consolas" panose="020B0609020204030204" pitchFamily="49" charset="0"/>
+                  </a:rPr>
+                  <a:t>, </a:t>
+                </a:r>
+                <a:r>
+                  <a:rPr lang="en-US" sz="1600" dirty="0" err="1">
+                    <a:latin typeface="Consolas" panose="020B0609020204030204" pitchFamily="49" charset="0"/>
+                  </a:rPr>
+                  <a:t>sinon</a:t>
+                </a:r>
+                <a:r>
+                  <a:rPr lang="en-US" sz="1600" dirty="0">
+                    <a:latin typeface="Consolas" panose="020B0609020204030204" pitchFamily="49" charset="0"/>
+                  </a:rPr>
+                  <a:t> faux. </a:t>
+                </a:r>
+              </a:p>
+              <a:p>
+                <a:pPr lvl="1" algn="just">
+                  <a:lnSpc>
+                    <a:spcPct val="100000"/>
+                  </a:lnSpc>
+                </a:pPr>
+                <a:r>
+                  <a:rPr lang="en-US" sz="1600" dirty="0">
+                    <a:latin typeface="Consolas" panose="020B0609020204030204" pitchFamily="49" charset="0"/>
+                  </a:rPr>
+                  <a:t>NON </a:t>
+                </a:r>
+                <a:r>
+                  <a:rPr lang="en-US" sz="1600" dirty="0" err="1">
+                    <a:latin typeface="Consolas" panose="020B0609020204030204" pitchFamily="49" charset="0"/>
+                  </a:rPr>
+                  <a:t>logique</a:t>
+                </a:r>
+                <a:r>
+                  <a:rPr lang="en-US" sz="1600" dirty="0">
+                    <a:latin typeface="Consolas" panose="020B0609020204030204" pitchFamily="49" charset="0"/>
+                  </a:rPr>
+                  <a:t> (not): Inversion </a:t>
+                </a:r>
+                <a:r>
+                  <a:rPr lang="en-US" sz="1600" dirty="0" err="1">
+                    <a:latin typeface="Consolas" panose="020B0609020204030204" pitchFamily="49" charset="0"/>
+                  </a:rPr>
+                  <a:t>booléenne</a:t>
+                </a:r>
+                <a:r>
+                  <a:rPr lang="en-US" sz="1600" dirty="0">
+                    <a:latin typeface="Consolas" panose="020B0609020204030204" pitchFamily="49" charset="0"/>
+                  </a:rPr>
+                  <a:t>.</a:t>
+                </a:r>
+                <a:endParaRPr lang="en-CA" sz="2000" dirty="0">
+                  <a:latin typeface="Consolas" panose="020B0609020204030204" pitchFamily="49" charset="0"/>
+                </a:endParaRPr>
+              </a:p>
+              <a:p>
+                <a:pPr marL="457200" lvl="1" indent="0" algn="just">
+                  <a:lnSpc>
+                    <a:spcPct val="100000"/>
+                  </a:lnSpc>
+                  <a:buNone/>
+                </a:pPr>
+                <a:endParaRPr lang="en-US" sz="1600" dirty="0">
+                  <a:latin typeface="Consolas" panose="020B0609020204030204" pitchFamily="49" charset="0"/>
+                </a:endParaRPr>
+              </a:p>
+            </p:txBody>
+          </p:sp>
+        </mc:Choice>
+        <mc:Fallback xmlns="">
+          <p:sp>
+            <p:nvSpPr>
+              <p:cNvPr id="3" name="Content Placeholder 2">
+                <a:extLst>
+                  <a:ext uri="{FF2B5EF4-FFF2-40B4-BE49-F238E27FC236}">
+                    <a16:creationId xmlns:a16="http://schemas.microsoft.com/office/drawing/2014/main" id="{C266EEB5-5DF4-1772-722C-9295423EFC10}"/>
+                  </a:ext>
+                </a:extLst>
+              </p:cNvPr>
+              <p:cNvSpPr>
+                <a:spLocks noGrp="1" noRot="1" noChangeAspect="1" noMove="1" noResize="1" noEditPoints="1" noAdjustHandles="1" noChangeArrowheads="1" noChangeShapeType="1" noTextEdit="1"/>
+              </p:cNvSpPr>
+              <p:nvPr>
+                <p:ph idx="1"/>
+              </p:nvPr>
+            </p:nvSpPr>
+            <p:spPr>
+              <a:blipFill>
+                <a:blip r:embed="rId2"/>
+                <a:stretch>
+                  <a:fillRect l="-406" t="-700"/>
+                </a:stretch>
+              </a:blipFill>
+            </p:spPr>
+            <p:txBody>
+              <a:bodyPr/>
+              <a:lstStyle/>
+              <a:p>
+                <a:r>
+                  <a:rPr lang="fr-CA">
+                    <a:noFill/>
+                  </a:rPr>
+                  <a:t> </a:t>
+                </a:r>
+              </a:p>
+            </p:txBody>
+          </p:sp>
+        </mc:Fallback>
+      </mc:AlternateContent>
       <p:sp>
         <p:nvSpPr>
           <p:cNvPr id="5" name="Slide Number Placeholder 4">
@@ -14101,6 +14529,471 @@
     <p:bg>
       <p:bgPr>
         <a:solidFill>
+          <a:schemeClr val="accent6">
+            <a:lumMod val="20000"/>
+            <a:lumOff val="80000"/>
+          </a:schemeClr>
+        </a:solidFill>
+        <a:effectLst/>
+      </p:bgPr>
+    </p:bg>
+    <p:spTree>
+      <p:nvGrpSpPr>
+        <p:cNvPr id="1" name="">
+          <a:extLst>
+            <a:ext uri="{FF2B5EF4-FFF2-40B4-BE49-F238E27FC236}">
+              <a16:creationId xmlns:a16="http://schemas.microsoft.com/office/drawing/2014/main" id="{2409169B-C89D-BDF5-18C1-65187867AAB2}"/>
+            </a:ext>
+          </a:extLst>
+        </p:cNvPr>
+        <p:cNvGrpSpPr/>
+        <p:nvPr/>
+      </p:nvGrpSpPr>
+      <p:grpSpPr>
+        <a:xfrm>
+          <a:off x="0" y="0"/>
+          <a:ext cx="0" cy="0"/>
+          <a:chOff x="0" y="0"/>
+          <a:chExt cx="0" cy="0"/>
+        </a:xfrm>
+      </p:grpSpPr>
+      <p:sp>
+        <p:nvSpPr>
+          <p:cNvPr id="2" name="Title 1">
+            <a:extLst>
+              <a:ext uri="{FF2B5EF4-FFF2-40B4-BE49-F238E27FC236}">
+                <a16:creationId xmlns:a16="http://schemas.microsoft.com/office/drawing/2014/main" id="{C652CB17-FE13-5B97-C01F-0344ECCCD1B7}"/>
+              </a:ext>
+            </a:extLst>
+          </p:cNvPr>
+          <p:cNvSpPr>
+            <a:spLocks noGrp="1"/>
+          </p:cNvSpPr>
+          <p:nvPr>
+            <p:ph type="title"/>
+          </p:nvPr>
+        </p:nvSpPr>
+        <p:spPr/>
+        <p:txBody>
+          <a:bodyPr/>
+          <a:lstStyle/>
+          <a:p>
+            <a:r>
+              <a:rPr lang="en-US" dirty="0">
+                <a:latin typeface="Arial Rounded MT Bold" panose="020F0704030504030204" pitchFamily="34" charset="0"/>
+              </a:rPr>
+              <a:t>XR6 – Morgane </a:t>
+            </a:r>
+            <a:r>
+              <a:rPr lang="en-US" dirty="0" err="1">
+                <a:latin typeface="Arial Rounded MT Bold" panose="020F0704030504030204" pitchFamily="34" charset="0"/>
+              </a:rPr>
+              <a:t>aimerait</a:t>
+            </a:r>
+            <a:r>
+              <a:rPr lang="en-US" dirty="0">
+                <a:latin typeface="Arial Rounded MT Bold" panose="020F0704030504030204" pitchFamily="34" charset="0"/>
+              </a:rPr>
+              <a:t> savoir ...</a:t>
+            </a:r>
+            <a:endParaRPr lang="fr-CA" dirty="0">
+              <a:latin typeface="Arial Rounded MT Bold" panose="020F0704030504030204" pitchFamily="34" charset="0"/>
+            </a:endParaRPr>
+          </a:p>
+        </p:txBody>
+      </p:sp>
+      <mc:AlternateContent xmlns:mc="http://schemas.openxmlformats.org/markup-compatibility/2006">
+        <mc:Choice xmlns:a14="http://schemas.microsoft.com/office/drawing/2010/main" Requires="a14">
+          <p:sp>
+            <p:nvSpPr>
+              <p:cNvPr id="3" name="Content Placeholder 2">
+                <a:extLst>
+                  <a:ext uri="{FF2B5EF4-FFF2-40B4-BE49-F238E27FC236}">
+                    <a16:creationId xmlns:a16="http://schemas.microsoft.com/office/drawing/2014/main" id="{F3B65A87-4326-B5C4-052F-1B528DFA8034}"/>
+                  </a:ext>
+                </a:extLst>
+              </p:cNvPr>
+              <p:cNvSpPr>
+                <a:spLocks noGrp="1"/>
+              </p:cNvSpPr>
+              <p:nvPr>
+                <p:ph idx="1"/>
+              </p:nvPr>
+            </p:nvSpPr>
+            <p:spPr/>
+            <p:txBody>
+              <a:bodyPr>
+                <a:normAutofit/>
+              </a:bodyPr>
+              <a:lstStyle/>
+              <a:p>
+                <a:pPr marL="0" indent="0">
+                  <a:buNone/>
+                </a:pPr>
+                <a:r>
+                  <a:rPr lang="en-US" sz="2000" dirty="0" err="1">
+                    <a:latin typeface="Consolas" panose="020B0609020204030204" pitchFamily="49" charset="0"/>
+                  </a:rPr>
+                  <a:t>laquelle</a:t>
+                </a:r>
+                <a:r>
+                  <a:rPr lang="en-US" sz="2000" dirty="0">
+                    <a:latin typeface="Consolas" panose="020B0609020204030204" pitchFamily="49" charset="0"/>
+                  </a:rPr>
+                  <a:t> de </a:t>
+                </a:r>
+                <a:r>
+                  <a:rPr lang="en-US" sz="2000" dirty="0" err="1">
+                    <a:latin typeface="Consolas" panose="020B0609020204030204" pitchFamily="49" charset="0"/>
+                  </a:rPr>
+                  <a:t>ces</a:t>
+                </a:r>
+                <a:r>
+                  <a:rPr lang="en-US" sz="2000" dirty="0">
+                    <a:latin typeface="Consolas" panose="020B0609020204030204" pitchFamily="49" charset="0"/>
+                  </a:rPr>
+                  <a:t> deux </a:t>
+                </a:r>
+                <a:r>
+                  <a:rPr lang="en-US" sz="2000" dirty="0" err="1">
+                    <a:latin typeface="Consolas" panose="020B0609020204030204" pitchFamily="49" charset="0"/>
+                  </a:rPr>
+                  <a:t>équations</a:t>
+                </a:r>
+                <a:r>
+                  <a:rPr lang="en-US" sz="2000" dirty="0">
+                    <a:latin typeface="Consolas" panose="020B0609020204030204" pitchFamily="49" charset="0"/>
+                  </a:rPr>
+                  <a:t> est </a:t>
+                </a:r>
+                <a:r>
+                  <a:rPr lang="en-US" sz="2000" dirty="0" err="1">
+                    <a:latin typeface="Consolas" panose="020B0609020204030204" pitchFamily="49" charset="0"/>
+                  </a:rPr>
+                  <a:t>vraie</a:t>
+                </a:r>
+                <a:r>
+                  <a:rPr lang="en-US" sz="2000" dirty="0">
+                    <a:latin typeface="Consolas" panose="020B0609020204030204" pitchFamily="49" charset="0"/>
+                  </a:rPr>
+                  <a:t>?</a:t>
+                </a:r>
+              </a:p>
+              <a:p>
+                <a:pPr marL="0" indent="0" algn="just">
+                  <a:buNone/>
+                </a:pPr>
+                <a:endParaRPr lang="en-CA" sz="2000" b="0" i="1" dirty="0">
+                  <a:latin typeface="Cambria Math" panose="02040503050406030204" pitchFamily="18" charset="0"/>
+                </a:endParaRPr>
+              </a:p>
+              <a:p>
+                <a:pPr marL="0" indent="0" algn="ctr">
+                  <a:buNone/>
+                </a:pPr>
+                <a14:m>
+                  <m:oMath xmlns:m="http://schemas.openxmlformats.org/officeDocument/2006/math">
+                    <m:bar>
+                      <m:barPr>
+                        <m:pos m:val="top"/>
+                        <m:ctrlPr>
+                          <a:rPr lang="en-CA" sz="2500" b="0" i="1" smtClean="0">
+                            <a:latin typeface="Cambria Math" panose="02040503050406030204" pitchFamily="18" charset="0"/>
+                          </a:rPr>
+                        </m:ctrlPr>
+                      </m:barPr>
+                      <m:e>
+                        <m:r>
+                          <a:rPr lang="en-CA" sz="2500" i="1">
+                            <a:latin typeface="Cambria Math" panose="02040503050406030204" pitchFamily="18" charset="0"/>
+                          </a:rPr>
+                          <m:t>𝐴</m:t>
+                        </m:r>
+                        <m:r>
+                          <a:rPr lang="en-CA" sz="2500" i="1">
+                            <a:latin typeface="Cambria Math" panose="02040503050406030204" pitchFamily="18" charset="0"/>
+                            <a:ea typeface="Cambria Math" panose="02040503050406030204" pitchFamily="18" charset="0"/>
+                          </a:rPr>
+                          <m:t>∪</m:t>
+                        </m:r>
+                        <m:r>
+                          <m:rPr>
+                            <m:sty m:val="p"/>
+                          </m:rPr>
+                          <a:rPr lang="en-CA" sz="2500" b="0" i="0" smtClean="0">
+                            <a:latin typeface="Cambria Math" panose="02040503050406030204" pitchFamily="18" charset="0"/>
+                            <a:ea typeface="Cambria Math" panose="02040503050406030204" pitchFamily="18" charset="0"/>
+                          </a:rPr>
+                          <m:t>B</m:t>
+                        </m:r>
+                      </m:e>
+                    </m:bar>
+                    <m:r>
+                      <a:rPr lang="en-CA" sz="2500" i="1">
+                        <a:latin typeface="Cambria Math" panose="02040503050406030204" pitchFamily="18" charset="0"/>
+                        <a:ea typeface="Cambria Math" panose="02040503050406030204" pitchFamily="18" charset="0"/>
+                      </a:rPr>
+                      <m:t>≡</m:t>
+                    </m:r>
+                    <m:bar>
+                      <m:barPr>
+                        <m:pos m:val="top"/>
+                        <m:ctrlPr>
+                          <a:rPr lang="en-CA" sz="2500" i="1">
+                            <a:latin typeface="Cambria Math" panose="02040503050406030204" pitchFamily="18" charset="0"/>
+                          </a:rPr>
+                        </m:ctrlPr>
+                      </m:barPr>
+                      <m:e>
+                        <m:r>
+                          <a:rPr lang="en-CA" sz="2500" i="1">
+                            <a:latin typeface="Cambria Math" panose="02040503050406030204" pitchFamily="18" charset="0"/>
+                          </a:rPr>
+                          <m:t>𝐴</m:t>
+                        </m:r>
+                      </m:e>
+                    </m:bar>
+                    <m:r>
+                      <a:rPr lang="en-CA" sz="2500" b="0" i="1" smtClean="0">
+                        <a:latin typeface="Cambria Math" panose="02040503050406030204" pitchFamily="18" charset="0"/>
+                        <a:ea typeface="Cambria Math" panose="02040503050406030204" pitchFamily="18" charset="0"/>
+                      </a:rPr>
+                      <m:t>∩</m:t>
+                    </m:r>
+                    <m:bar>
+                      <m:barPr>
+                        <m:pos m:val="top"/>
+                        <m:ctrlPr>
+                          <a:rPr lang="en-CA" sz="2500" i="1">
+                            <a:latin typeface="Cambria Math" panose="02040503050406030204" pitchFamily="18" charset="0"/>
+                          </a:rPr>
+                        </m:ctrlPr>
+                      </m:barPr>
+                      <m:e>
+                        <m:r>
+                          <a:rPr lang="en-CA" sz="2500" b="0" i="1" smtClean="0">
+                            <a:latin typeface="Cambria Math" panose="02040503050406030204" pitchFamily="18" charset="0"/>
+                          </a:rPr>
+                          <m:t>𝐵</m:t>
+                        </m:r>
+                      </m:e>
+                    </m:bar>
+                  </m:oMath>
+                </a14:m>
+                <a:r>
+                  <a:rPr lang="en-US" sz="2500" dirty="0">
+                    <a:latin typeface="Consolas" panose="020B0609020204030204" pitchFamily="49" charset="0"/>
+                  </a:rPr>
+                  <a:t> [1]</a:t>
+                </a:r>
+              </a:p>
+              <a:p>
+                <a:pPr marL="0" indent="0" algn="ctr">
+                  <a:buNone/>
+                </a:pPr>
+                <a:endParaRPr lang="en-US" sz="2500" dirty="0">
+                  <a:latin typeface="Consolas" panose="020B0609020204030204" pitchFamily="49" charset="0"/>
+                </a:endParaRPr>
+              </a:p>
+              <a:p>
+                <a:pPr marL="0" indent="0" algn="ctr">
+                  <a:buNone/>
+                </a:pPr>
+                <a14:m>
+                  <m:oMath xmlns:m="http://schemas.openxmlformats.org/officeDocument/2006/math">
+                    <m:bar>
+                      <m:barPr>
+                        <m:pos m:val="top"/>
+                        <m:ctrlPr>
+                          <a:rPr lang="en-CA" sz="2500" i="1">
+                            <a:latin typeface="Cambria Math" panose="02040503050406030204" pitchFamily="18" charset="0"/>
+                          </a:rPr>
+                        </m:ctrlPr>
+                      </m:barPr>
+                      <m:e>
+                        <m:r>
+                          <a:rPr lang="en-CA" sz="2500" i="1">
+                            <a:latin typeface="Cambria Math" panose="02040503050406030204" pitchFamily="18" charset="0"/>
+                          </a:rPr>
+                          <m:t>𝐴</m:t>
+                        </m:r>
+                        <m:r>
+                          <a:rPr lang="en-CA" sz="2500" i="1">
+                            <a:latin typeface="Cambria Math" panose="02040503050406030204" pitchFamily="18" charset="0"/>
+                            <a:ea typeface="Cambria Math" panose="02040503050406030204" pitchFamily="18" charset="0"/>
+                          </a:rPr>
+                          <m:t>∪</m:t>
+                        </m:r>
+                        <m:r>
+                          <m:rPr>
+                            <m:sty m:val="p"/>
+                          </m:rPr>
+                          <a:rPr lang="en-CA" sz="2500">
+                            <a:latin typeface="Cambria Math" panose="02040503050406030204" pitchFamily="18" charset="0"/>
+                            <a:ea typeface="Cambria Math" panose="02040503050406030204" pitchFamily="18" charset="0"/>
+                          </a:rPr>
+                          <m:t>B</m:t>
+                        </m:r>
+                      </m:e>
+                    </m:bar>
+                    <m:r>
+                      <a:rPr lang="en-CA" sz="2500" i="1">
+                        <a:latin typeface="Cambria Math" panose="02040503050406030204" pitchFamily="18" charset="0"/>
+                        <a:ea typeface="Cambria Math" panose="02040503050406030204" pitchFamily="18" charset="0"/>
+                      </a:rPr>
+                      <m:t>≡</m:t>
+                    </m:r>
+                    <m:bar>
+                      <m:barPr>
+                        <m:pos m:val="top"/>
+                        <m:ctrlPr>
+                          <a:rPr lang="en-CA" sz="2500" i="1">
+                            <a:latin typeface="Cambria Math" panose="02040503050406030204" pitchFamily="18" charset="0"/>
+                          </a:rPr>
+                        </m:ctrlPr>
+                      </m:barPr>
+                      <m:e>
+                        <m:r>
+                          <a:rPr lang="en-CA" sz="2500" i="1">
+                            <a:latin typeface="Cambria Math" panose="02040503050406030204" pitchFamily="18" charset="0"/>
+                          </a:rPr>
+                          <m:t>𝐴</m:t>
+                        </m:r>
+                      </m:e>
+                    </m:bar>
+                    <m:r>
+                      <a:rPr lang="en-CA" sz="2500" i="1">
+                        <a:latin typeface="Cambria Math" panose="02040503050406030204" pitchFamily="18" charset="0"/>
+                        <a:ea typeface="Cambria Math" panose="02040503050406030204" pitchFamily="18" charset="0"/>
+                      </a:rPr>
+                      <m:t>∪</m:t>
+                    </m:r>
+                    <m:bar>
+                      <m:barPr>
+                        <m:pos m:val="top"/>
+                        <m:ctrlPr>
+                          <a:rPr lang="en-CA" sz="2500" i="1">
+                            <a:latin typeface="Cambria Math" panose="02040503050406030204" pitchFamily="18" charset="0"/>
+                          </a:rPr>
+                        </m:ctrlPr>
+                      </m:barPr>
+                      <m:e>
+                        <m:r>
+                          <a:rPr lang="en-CA" sz="2500" i="1">
+                            <a:latin typeface="Cambria Math" panose="02040503050406030204" pitchFamily="18" charset="0"/>
+                          </a:rPr>
+                          <m:t>𝐵</m:t>
+                        </m:r>
+                      </m:e>
+                    </m:bar>
+                  </m:oMath>
+                </a14:m>
+                <a:r>
+                  <a:rPr lang="en-US" sz="2500" dirty="0">
+                    <a:latin typeface="Consolas" panose="020B0609020204030204" pitchFamily="49" charset="0"/>
+                  </a:rPr>
+                  <a:t> [2]</a:t>
+                </a:r>
+              </a:p>
+              <a:p>
+                <a:pPr marL="0" indent="0" algn="ctr">
+                  <a:buNone/>
+                </a:pPr>
+                <a:endParaRPr lang="en-US" sz="2500" dirty="0">
+                  <a:latin typeface="Consolas" panose="020B0609020204030204" pitchFamily="49" charset="0"/>
+                </a:endParaRPr>
+              </a:p>
+            </p:txBody>
+          </p:sp>
+        </mc:Choice>
+        <mc:Fallback>
+          <p:sp>
+            <p:nvSpPr>
+              <p:cNvPr id="3" name="Content Placeholder 2">
+                <a:extLst>
+                  <a:ext uri="{FF2B5EF4-FFF2-40B4-BE49-F238E27FC236}">
+                    <a16:creationId xmlns:a16="http://schemas.microsoft.com/office/drawing/2014/main" id="{F3B65A87-4326-B5C4-052F-1B528DFA8034}"/>
+                  </a:ext>
+                </a:extLst>
+              </p:cNvPr>
+              <p:cNvSpPr>
+                <a:spLocks noGrp="1" noRot="1" noChangeAspect="1" noMove="1" noResize="1" noEditPoints="1" noAdjustHandles="1" noChangeArrowheads="1" noChangeShapeType="1" noTextEdit="1"/>
+              </p:cNvSpPr>
+              <p:nvPr>
+                <p:ph idx="1"/>
+              </p:nvPr>
+            </p:nvSpPr>
+            <p:spPr>
+              <a:blipFill>
+                <a:blip r:embed="rId2"/>
+                <a:stretch>
+                  <a:fillRect l="-638" t="-1401"/>
+                </a:stretch>
+              </a:blipFill>
+            </p:spPr>
+            <p:txBody>
+              <a:bodyPr/>
+              <a:lstStyle/>
+              <a:p>
+                <a:r>
+                  <a:rPr lang="fr-CA">
+                    <a:noFill/>
+                  </a:rPr>
+                  <a:t> </a:t>
+                </a:r>
+              </a:p>
+            </p:txBody>
+          </p:sp>
+        </mc:Fallback>
+      </mc:AlternateContent>
+      <p:sp>
+        <p:nvSpPr>
+          <p:cNvPr id="4" name="Slide Number Placeholder 3">
+            <a:extLst>
+              <a:ext uri="{FF2B5EF4-FFF2-40B4-BE49-F238E27FC236}">
+                <a16:creationId xmlns:a16="http://schemas.microsoft.com/office/drawing/2014/main" id="{2035F0E9-A4AF-2B26-AFD2-EBD36B54FEA7}"/>
+              </a:ext>
+            </a:extLst>
+          </p:cNvPr>
+          <p:cNvSpPr>
+            <a:spLocks noGrp="1"/>
+          </p:cNvSpPr>
+          <p:nvPr>
+            <p:ph type="sldNum" sz="quarter" idx="12"/>
+          </p:nvPr>
+        </p:nvSpPr>
+        <p:spPr/>
+        <p:txBody>
+          <a:bodyPr/>
+          <a:lstStyle/>
+          <a:p>
+            <a:fld id="{846B06B1-1179-491F-A487-8E0C403F7C13}" type="slidenum">
+              <a:rPr lang="fr-CA" smtClean="0"/>
+              <a:t>21</a:t>
+            </a:fld>
+            <a:endParaRPr lang="fr-CA"/>
+          </a:p>
+        </p:txBody>
+      </p:sp>
+    </p:spTree>
+    <p:extLst>
+      <p:ext uri="{BB962C8B-B14F-4D97-AF65-F5344CB8AC3E}">
+        <p14:creationId xmlns:p14="http://schemas.microsoft.com/office/powerpoint/2010/main" val="452085315"/>
+      </p:ext>
+    </p:extLst>
+  </p:cSld>
+  <p:clrMapOvr>
+    <a:masterClrMapping/>
+  </p:clrMapOvr>
+</p:sld>
+</file>
+
+<file path=ppt/slides/slide22.xml><?xml version="1.0" encoding="utf-8"?>
+<p:sld xmlns:a="http://schemas.openxmlformats.org/drawingml/2006/main" xmlns:r="http://schemas.openxmlformats.org/officeDocument/2006/relationships" xmlns:p="http://schemas.openxmlformats.org/presentationml/2006/main">
+  <p:cSld>
+    <p:bg>
+      <p:bgPr>
+        <a:solidFill>
           <a:srgbClr val="F5F5F5"/>
         </a:solidFill>
         <a:effectLst/>
@@ -14244,7 +15137,7 @@
           <a:p>
             <a:fld id="{846B06B1-1179-491F-A487-8E0C403F7C13}" type="slidenum">
               <a:rPr lang="fr-CA" smtClean="0"/>
-              <a:t>21</a:t>
+              <a:t>22</a:t>
             </a:fld>
             <a:endParaRPr lang="fr-CA"/>
           </a:p>
@@ -14563,7 +15456,7 @@
 </p:sld>
 </file>
 
-<file path=ppt/slides/slide22.xml><?xml version="1.0" encoding="utf-8"?>
+<file path=ppt/slides/slide23.xml><?xml version="1.0" encoding="utf-8"?>
 <p:sld xmlns:a="http://schemas.openxmlformats.org/drawingml/2006/main" xmlns:r="http://schemas.openxmlformats.org/officeDocument/2006/relationships" xmlns:p="http://schemas.openxmlformats.org/presentationml/2006/main">
   <p:cSld>
     <p:bg>
@@ -14712,7 +15605,7 @@
           <a:p>
             <a:fld id="{846B06B1-1179-491F-A487-8E0C403F7C13}" type="slidenum">
               <a:rPr lang="fr-CA" smtClean="0"/>
-              <a:t>22</a:t>
+              <a:t>23</a:t>
             </a:fld>
             <a:endParaRPr lang="fr-CA"/>
           </a:p>
@@ -15031,7 +15924,7 @@
 </p:sld>
 </file>
 
-<file path=ppt/slides/slide23.xml><?xml version="1.0" encoding="utf-8"?>
+<file path=ppt/slides/slide24.xml><?xml version="1.0" encoding="utf-8"?>
 <p:sld xmlns:a="http://schemas.openxmlformats.org/drawingml/2006/main" xmlns:r="http://schemas.openxmlformats.org/officeDocument/2006/relationships" xmlns:p="http://schemas.openxmlformats.org/presentationml/2006/main">
   <p:cSld>
     <p:bg>
@@ -15192,7 +16085,7 @@
           <a:p>
             <a:fld id="{846B06B1-1179-491F-A487-8E0C403F7C13}" type="slidenum">
               <a:rPr lang="fr-CA" smtClean="0"/>
-              <a:t>23</a:t>
+              <a:t>24</a:t>
             </a:fld>
             <a:endParaRPr lang="fr-CA"/>
           </a:p>
@@ -15511,7 +16404,7 @@
 </p:sld>
 </file>
 
-<file path=ppt/slides/slide24.xml><?xml version="1.0" encoding="utf-8"?>
+<file path=ppt/slides/slide25.xml><?xml version="1.0" encoding="utf-8"?>
 <p:sld xmlns:a="http://schemas.openxmlformats.org/drawingml/2006/main" xmlns:r="http://schemas.openxmlformats.org/officeDocument/2006/relationships" xmlns:p="http://schemas.openxmlformats.org/presentationml/2006/main">
   <p:cSld>
     <p:bg>
@@ -15600,7 +16493,7 @@
           <a:p>
             <a:fld id="{846B06B1-1179-491F-A487-8E0C403F7C13}" type="slidenum">
               <a:rPr lang="fr-CA" smtClean="0"/>
-              <a:t>24</a:t>
+              <a:t>25</a:t>
             </a:fld>
             <a:endParaRPr lang="fr-CA"/>
           </a:p>

</xml_diff>

<commit_message>
feat: Extend python_1 presentation to slide no.26
</commit_message>
<xml_diff>
--- a/python_1/presentation_python_1.pptx
+++ b/python_1/presentation_python_1.pptx
@@ -5,7 +5,7 @@
     <p:sldMasterId id="2147483648" r:id="rId1"/>
   </p:sldMasterIdLst>
   <p:notesMasterIdLst>
-    <p:notesMasterId r:id="rId27"/>
+    <p:notesMasterId r:id="rId29"/>
   </p:notesMasterIdLst>
   <p:sldIdLst>
     <p:sldId id="256" r:id="rId2"/>
@@ -30,9 +30,11 @@
     <p:sldId id="282" r:id="rId21"/>
     <p:sldId id="283" r:id="rId22"/>
     <p:sldId id="280" r:id="rId23"/>
-    <p:sldId id="279" r:id="rId24"/>
-    <p:sldId id="281" r:id="rId25"/>
-    <p:sldId id="270" r:id="rId26"/>
+    <p:sldId id="286" r:id="rId24"/>
+    <p:sldId id="284" r:id="rId25"/>
+    <p:sldId id="279" r:id="rId26"/>
+    <p:sldId id="281" r:id="rId27"/>
+    <p:sldId id="270" r:id="rId28"/>
   </p:sldIdLst>
   <p:sldSz cx="12192000" cy="6858000"/>
   <p:notesSz cx="6858000" cy="9144000"/>
@@ -13692,8 +13694,8 @@
           </a:p>
         </p:txBody>
       </p:sp>
-      <mc:AlternateContent xmlns:mc="http://schemas.openxmlformats.org/markup-compatibility/2006" xmlns:a14="http://schemas.microsoft.com/office/drawing/2010/main">
-        <mc:Choice Requires="a14">
+      <mc:AlternateContent xmlns:mc="http://schemas.openxmlformats.org/markup-compatibility/2006">
+        <mc:Choice xmlns:a14="http://schemas.microsoft.com/office/drawing/2010/main" Requires="a14">
           <p:sp>
             <p:nvSpPr>
               <p:cNvPr id="3" name="Content Placeholder 2">
@@ -13938,7 +13940,7 @@
                   <a:rPr lang="en-US" sz="1800" dirty="0">
                     <a:latin typeface="Consolas" panose="020B0609020204030204" pitchFamily="49" charset="0"/>
                   </a:rPr>
-                  <a:t>:</a:t>
+                  <a:t>: and, or, not</a:t>
                 </a:r>
               </a:p>
               <a:p>
@@ -14141,7 +14143,7 @@
             </p:txBody>
           </p:sp>
         </mc:Choice>
-        <mc:Fallback xmlns="">
+        <mc:Fallback>
           <p:sp>
             <p:nvSpPr>
               <p:cNvPr id="3" name="Content Placeholder 2">
@@ -14683,7 +14685,7 @@
                 <a:pPr marL="0" indent="0" algn="just">
                   <a:buNone/>
                 </a:pPr>
-                <a:endParaRPr lang="en-CA" sz="2000" b="0" i="1" dirty="0">
+                <a:endParaRPr lang="en-CA" sz="100" b="0" i="1" dirty="0">
                   <a:latin typeface="Cambria Math" panose="02040503050406030204" pitchFamily="18" charset="0"/>
                 </a:endParaRPr>
               </a:p>
@@ -14691,6 +14693,12 @@
                 <a:pPr marL="0" indent="0" algn="ctr">
                   <a:buNone/>
                 </a:pPr>
+                <a:r>
+                  <a:rPr lang="en-US" sz="2500" dirty="0">
+                    <a:latin typeface="Consolas" panose="020B0609020204030204" pitchFamily="49" charset="0"/>
+                  </a:rPr>
+                  <a:t>[1] </a:t>
+                </a:r>
                 <a14:m>
                   <m:oMath xmlns:m="http://schemas.openxmlformats.org/officeDocument/2006/math">
                     <m:bar>
@@ -14780,17 +14788,6 @@
                     </m:bar>
                   </m:oMath>
                 </a14:m>
-                <a:r>
-                  <a:rPr lang="en-US" sz="2500" dirty="0">
-                    <a:latin typeface="Consolas" panose="020B0609020204030204" pitchFamily="49" charset="0"/>
-                  </a:rPr>
-                  <a:t> [1]</a:t>
-                </a:r>
-              </a:p>
-              <a:p>
-                <a:pPr marL="0" indent="0" algn="ctr">
-                  <a:buNone/>
-                </a:pPr>
                 <a:endParaRPr lang="en-US" sz="2500" dirty="0">
                   <a:latin typeface="Consolas" panose="020B0609020204030204" pitchFamily="49" charset="0"/>
                 </a:endParaRPr>
@@ -14799,6 +14796,20 @@
                 <a:pPr marL="0" indent="0" algn="ctr">
                   <a:buNone/>
                 </a:pPr>
+                <a:endParaRPr lang="en-US" sz="100" dirty="0">
+                  <a:latin typeface="Consolas" panose="020B0609020204030204" pitchFamily="49" charset="0"/>
+                </a:endParaRPr>
+              </a:p>
+              <a:p>
+                <a:pPr marL="0" indent="0" algn="ctr">
+                  <a:buNone/>
+                </a:pPr>
+                <a:r>
+                  <a:rPr lang="en-US" sz="2500" dirty="0">
+                    <a:latin typeface="Consolas" panose="020B0609020204030204" pitchFamily="49" charset="0"/>
+                  </a:rPr>
+                  <a:t>[2] </a:t>
+                </a:r>
                 <a14:m>
                   <m:oMath xmlns:m="http://schemas.openxmlformats.org/officeDocument/2006/math">
                     <m:bar>
@@ -14888,17 +14899,6 @@
                     </m:bar>
                   </m:oMath>
                 </a14:m>
-                <a:r>
-                  <a:rPr lang="en-US" sz="2500" dirty="0">
-                    <a:latin typeface="Consolas" panose="020B0609020204030204" pitchFamily="49" charset="0"/>
-                  </a:rPr>
-                  <a:t> [2]</a:t>
-                </a:r>
-              </a:p>
-              <a:p>
-                <a:pPr marL="0" indent="0" algn="ctr">
-                  <a:buNone/>
-                </a:pPr>
                 <a:endParaRPr lang="en-US" sz="2500" dirty="0">
                   <a:latin typeface="Consolas" panose="020B0609020204030204" pitchFamily="49" charset="0"/>
                 </a:endParaRPr>
@@ -15041,10 +15041,10 @@
           <a:lstStyle/>
           <a:p>
             <a:r>
-              <a:rPr lang="en-US" dirty="0" err="1">
+              <a:rPr lang="en-US" dirty="0">
                 <a:latin typeface="Arial Rounded MT Bold" panose="020F0704030504030204" pitchFamily="34" charset="0"/>
               </a:rPr>
-              <a:t>Conditionnelles</a:t>
+              <a:t>Choix [1/3]</a:t>
             </a:r>
             <a:endParaRPr lang="fr-CA" dirty="0">
               <a:latin typeface="Arial Rounded MT Bold" panose="020F0704030504030204" pitchFamily="34" charset="0"/>
@@ -15075,6 +15075,368 @@
           </a:bodyPr>
           <a:lstStyle/>
           <a:p>
+            <a:pPr lvl="1" algn="just">
+              <a:lnSpc>
+                <a:spcPct val="100000"/>
+              </a:lnSpc>
+            </a:pPr>
+            <a:r>
+              <a:rPr lang="en-CA" sz="1800" dirty="0">
+                <a:latin typeface="Consolas" panose="020B0609020204030204" pitchFamily="49" charset="0"/>
+              </a:rPr>
+              <a:t>E</a:t>
+            </a:r>
+            <a:r>
+              <a:rPr lang="fr-CA" sz="1800" dirty="0">
+                <a:latin typeface="Consolas" panose="020B0609020204030204" pitchFamily="49" charset="0"/>
+              </a:rPr>
+              <a:t>x</a:t>
+            </a:r>
+            <a:r>
+              <a:rPr lang="en-US" sz="1800" dirty="0" err="1">
+                <a:latin typeface="Consolas" panose="020B0609020204030204" pitchFamily="49" charset="0"/>
+              </a:rPr>
+              <a:t>écuter</a:t>
+            </a:r>
+            <a:r>
+              <a:rPr lang="en-US" sz="1800" dirty="0">
+                <a:latin typeface="Consolas" panose="020B0609020204030204" pitchFamily="49" charset="0"/>
+              </a:rPr>
+              <a:t> du code </a:t>
+            </a:r>
+            <a:r>
+              <a:rPr lang="en-US" sz="1800" dirty="0" err="1">
+                <a:latin typeface="Consolas" panose="020B0609020204030204" pitchFamily="49" charset="0"/>
+              </a:rPr>
+              <a:t>si</a:t>
+            </a:r>
+            <a:r>
+              <a:rPr lang="en-US" sz="1800" dirty="0">
+                <a:latin typeface="Consolas" panose="020B0609020204030204" pitchFamily="49" charset="0"/>
+              </a:rPr>
+              <a:t> </a:t>
+            </a:r>
+            <a:r>
+              <a:rPr lang="en-US" sz="1800" dirty="0" err="1">
+                <a:latin typeface="Consolas" panose="020B0609020204030204" pitchFamily="49" charset="0"/>
+              </a:rPr>
+              <a:t>une</a:t>
+            </a:r>
+            <a:r>
+              <a:rPr lang="en-US" sz="1800" dirty="0">
+                <a:latin typeface="Consolas" panose="020B0609020204030204" pitchFamily="49" charset="0"/>
+              </a:rPr>
+              <a:t> condition est </a:t>
+            </a:r>
+            <a:r>
+              <a:rPr lang="en-US" sz="1800" dirty="0" err="1">
+                <a:latin typeface="Consolas" panose="020B0609020204030204" pitchFamily="49" charset="0"/>
+              </a:rPr>
+              <a:t>vraie</a:t>
+            </a:r>
+            <a:r>
+              <a:rPr lang="en-US" sz="1800" dirty="0">
+                <a:latin typeface="Consolas" panose="020B0609020204030204" pitchFamily="49" charset="0"/>
+              </a:rPr>
+              <a:t> (c.-à-d. </a:t>
+            </a:r>
+            <a:r>
+              <a:rPr lang="en-US" sz="1800" b="1" dirty="0" err="1">
+                <a:latin typeface="Consolas" panose="020B0609020204030204" pitchFamily="49" charset="0"/>
+              </a:rPr>
+              <a:t>égale</a:t>
+            </a:r>
+            <a:r>
+              <a:rPr lang="en-US" sz="1800" b="1" dirty="0">
+                <a:latin typeface="Consolas" panose="020B0609020204030204" pitchFamily="49" charset="0"/>
+              </a:rPr>
+              <a:t> à True</a:t>
+            </a:r>
+            <a:r>
+              <a:rPr lang="en-US" sz="1800" dirty="0">
+                <a:latin typeface="Consolas" panose="020B0609020204030204" pitchFamily="49" charset="0"/>
+              </a:rPr>
+              <a:t>)</a:t>
+            </a:r>
+          </a:p>
+          <a:p>
+            <a:pPr lvl="2" algn="just">
+              <a:lnSpc>
+                <a:spcPct val="100000"/>
+              </a:lnSpc>
+            </a:pPr>
+            <a:r>
+              <a:rPr lang="en-US" sz="1400" dirty="0" err="1">
+                <a:latin typeface="Consolas" panose="020B0609020204030204" pitchFamily="49" charset="0"/>
+              </a:rPr>
+              <a:t>Implique</a:t>
+            </a:r>
+            <a:r>
+              <a:rPr lang="en-US" sz="1400" dirty="0">
+                <a:latin typeface="Consolas" panose="020B0609020204030204" pitchFamily="49" charset="0"/>
+              </a:rPr>
+              <a:t> </a:t>
+            </a:r>
+            <a:r>
+              <a:rPr lang="en-US" sz="1400" dirty="0" err="1">
+                <a:latin typeface="Consolas" panose="020B0609020204030204" pitchFamily="49" charset="0"/>
+              </a:rPr>
+              <a:t>généralement</a:t>
+            </a:r>
+            <a:r>
+              <a:rPr lang="en-US" sz="1400" dirty="0">
+                <a:latin typeface="Consolas" panose="020B0609020204030204" pitchFamily="49" charset="0"/>
+              </a:rPr>
+              <a:t> les </a:t>
+            </a:r>
+            <a:r>
+              <a:rPr lang="en-US" sz="1400" dirty="0" err="1">
+                <a:latin typeface="Consolas" panose="020B0609020204030204" pitchFamily="49" charset="0"/>
+              </a:rPr>
+              <a:t>opérateurs</a:t>
+            </a:r>
+            <a:r>
+              <a:rPr lang="en-US" sz="1400" dirty="0">
+                <a:latin typeface="Consolas" panose="020B0609020204030204" pitchFamily="49" charset="0"/>
+              </a:rPr>
+              <a:t> de </a:t>
+            </a:r>
+            <a:r>
+              <a:rPr lang="en-US" sz="1400" dirty="0" err="1">
+                <a:latin typeface="Consolas" panose="020B0609020204030204" pitchFamily="49" charset="0"/>
+              </a:rPr>
+              <a:t>comparaison</a:t>
+            </a:r>
+            <a:r>
+              <a:rPr lang="en-US" sz="1400" dirty="0">
+                <a:latin typeface="Consolas" panose="020B0609020204030204" pitchFamily="49" charset="0"/>
+              </a:rPr>
+              <a:t> et les </a:t>
+            </a:r>
+            <a:r>
+              <a:rPr lang="en-US" sz="1400" dirty="0" err="1">
+                <a:latin typeface="Consolas" panose="020B0609020204030204" pitchFamily="49" charset="0"/>
+              </a:rPr>
+              <a:t>opérateurs</a:t>
+            </a:r>
+            <a:r>
+              <a:rPr lang="en-US" sz="1400" dirty="0">
+                <a:latin typeface="Consolas" panose="020B0609020204030204" pitchFamily="49" charset="0"/>
+              </a:rPr>
+              <a:t> </a:t>
+            </a:r>
+            <a:r>
+              <a:rPr lang="en-US" sz="1400" dirty="0" err="1">
+                <a:latin typeface="Consolas" panose="020B0609020204030204" pitchFamily="49" charset="0"/>
+              </a:rPr>
+              <a:t>logiques</a:t>
+            </a:r>
+            <a:endParaRPr lang="en-US" sz="1400" dirty="0">
+              <a:latin typeface="Consolas" panose="020B0609020204030204" pitchFamily="49" charset="0"/>
+            </a:endParaRPr>
+          </a:p>
+          <a:p>
+            <a:pPr lvl="2" algn="just">
+              <a:lnSpc>
+                <a:spcPct val="100000"/>
+              </a:lnSpc>
+            </a:pPr>
+            <a:endParaRPr lang="en-US" sz="1400" dirty="0">
+              <a:latin typeface="Consolas" panose="020B0609020204030204" pitchFamily="49" charset="0"/>
+            </a:endParaRPr>
+          </a:p>
+          <a:p>
+            <a:pPr lvl="2" algn="just">
+              <a:lnSpc>
+                <a:spcPct val="100000"/>
+              </a:lnSpc>
+            </a:pPr>
+            <a:endParaRPr lang="en-US" sz="1400" dirty="0">
+              <a:latin typeface="Consolas" panose="020B0609020204030204" pitchFamily="49" charset="0"/>
+            </a:endParaRPr>
+          </a:p>
+          <a:p>
+            <a:pPr lvl="2" algn="just">
+              <a:lnSpc>
+                <a:spcPct val="100000"/>
+              </a:lnSpc>
+            </a:pPr>
+            <a:endParaRPr lang="en-US" sz="1400" dirty="0">
+              <a:latin typeface="Consolas" panose="020B0609020204030204" pitchFamily="49" charset="0"/>
+            </a:endParaRPr>
+          </a:p>
+          <a:p>
+            <a:pPr lvl="2" algn="just">
+              <a:lnSpc>
+                <a:spcPct val="100000"/>
+              </a:lnSpc>
+            </a:pPr>
+            <a:endParaRPr lang="en-US" sz="1400" dirty="0">
+              <a:latin typeface="Consolas" panose="020B0609020204030204" pitchFamily="49" charset="0"/>
+            </a:endParaRPr>
+          </a:p>
+          <a:p>
+            <a:pPr lvl="2" algn="just">
+              <a:lnSpc>
+                <a:spcPct val="100000"/>
+              </a:lnSpc>
+            </a:pPr>
+            <a:endParaRPr lang="en-US" sz="1400" dirty="0">
+              <a:latin typeface="Consolas" panose="020B0609020204030204" pitchFamily="49" charset="0"/>
+            </a:endParaRPr>
+          </a:p>
+          <a:p>
+            <a:pPr lvl="2" algn="just">
+              <a:lnSpc>
+                <a:spcPct val="100000"/>
+              </a:lnSpc>
+            </a:pPr>
+            <a:endParaRPr lang="en-US" sz="1400" dirty="0">
+              <a:latin typeface="Consolas" panose="020B0609020204030204" pitchFamily="49" charset="0"/>
+            </a:endParaRPr>
+          </a:p>
+          <a:p>
+            <a:pPr marL="914400" lvl="2" indent="0" algn="just">
+              <a:lnSpc>
+                <a:spcPct val="100000"/>
+              </a:lnSpc>
+              <a:buNone/>
+            </a:pPr>
+            <a:r>
+              <a:rPr lang="en-CA" sz="1400" b="1" dirty="0">
+                <a:latin typeface="Consolas" panose="020B0609020204030204" pitchFamily="49" charset="0"/>
+              </a:rPr>
+              <a:t>&gt;&gt;&gt; </a:t>
+            </a:r>
+            <a:r>
+              <a:rPr lang="en-CA" sz="1400" b="1" dirty="0" err="1">
+                <a:latin typeface="Consolas" panose="020B0609020204030204" pitchFamily="49" charset="0"/>
+              </a:rPr>
+              <a:t>valeur</a:t>
+            </a:r>
+            <a:r>
+              <a:rPr lang="en-CA" sz="1400" b="1" dirty="0">
+                <a:latin typeface="Consolas" panose="020B0609020204030204" pitchFamily="49" charset="0"/>
+              </a:rPr>
+              <a:t> = 10</a:t>
+            </a:r>
+          </a:p>
+          <a:p>
+            <a:pPr marL="914400" lvl="2" indent="0" algn="just">
+              <a:lnSpc>
+                <a:spcPct val="100000"/>
+              </a:lnSpc>
+              <a:buNone/>
+            </a:pPr>
+            <a:r>
+              <a:rPr lang="en-CA" sz="1400" b="1" dirty="0">
+                <a:latin typeface="Consolas" panose="020B0609020204030204" pitchFamily="49" charset="0"/>
+              </a:rPr>
+              <a:t>&gt;&gt;&gt; if </a:t>
+            </a:r>
+            <a:r>
+              <a:rPr lang="en-CA" sz="1400" b="1" dirty="0" err="1">
+                <a:latin typeface="Consolas" panose="020B0609020204030204" pitchFamily="49" charset="0"/>
+              </a:rPr>
+              <a:t>valeur</a:t>
+            </a:r>
+            <a:r>
+              <a:rPr lang="en-CA" sz="1400" b="1" dirty="0">
+                <a:latin typeface="Consolas" panose="020B0609020204030204" pitchFamily="49" charset="0"/>
+              </a:rPr>
+              <a:t> % 2 == 0:</a:t>
+            </a:r>
+          </a:p>
+          <a:p>
+            <a:pPr marL="914400" lvl="2" indent="0" algn="just">
+              <a:lnSpc>
+                <a:spcPct val="100000"/>
+              </a:lnSpc>
+              <a:buNone/>
+            </a:pPr>
+            <a:r>
+              <a:rPr lang="en-CA" sz="1400" b="1" dirty="0">
+                <a:latin typeface="Consolas" panose="020B0609020204030204" pitchFamily="49" charset="0"/>
+              </a:rPr>
+              <a:t>...   print("Le </a:t>
+            </a:r>
+            <a:r>
+              <a:rPr lang="en-CA" sz="1400" b="1" dirty="0" err="1">
+                <a:latin typeface="Consolas" panose="020B0609020204030204" pitchFamily="49" charset="0"/>
+              </a:rPr>
+              <a:t>nombre</a:t>
+            </a:r>
+            <a:r>
+              <a:rPr lang="en-CA" sz="1400" b="1" dirty="0">
+                <a:latin typeface="Consolas" panose="020B0609020204030204" pitchFamily="49" charset="0"/>
+              </a:rPr>
+              <a:t>", </a:t>
+            </a:r>
+            <a:r>
+              <a:rPr lang="en-CA" sz="1400" b="1" dirty="0" err="1">
+                <a:latin typeface="Consolas" panose="020B0609020204030204" pitchFamily="49" charset="0"/>
+              </a:rPr>
+              <a:t>valeur</a:t>
+            </a:r>
+            <a:r>
+              <a:rPr lang="en-CA" sz="1400" b="1" dirty="0">
+                <a:latin typeface="Consolas" panose="020B0609020204030204" pitchFamily="49" charset="0"/>
+              </a:rPr>
+              <a:t>, "est pair")</a:t>
+            </a:r>
+          </a:p>
+          <a:p>
+            <a:pPr marL="914400" lvl="2" indent="0" algn="just">
+              <a:lnSpc>
+                <a:spcPct val="100000"/>
+              </a:lnSpc>
+              <a:buNone/>
+            </a:pPr>
+            <a:r>
+              <a:rPr lang="en-CA" sz="1400" dirty="0">
+                <a:solidFill>
+                  <a:schemeClr val="bg1">
+                    <a:lumMod val="50000"/>
+                  </a:schemeClr>
+                </a:solidFill>
+                <a:latin typeface="Consolas" panose="020B0609020204030204" pitchFamily="49" charset="0"/>
+              </a:rPr>
+              <a:t>Le </a:t>
+            </a:r>
+            <a:r>
+              <a:rPr lang="en-CA" sz="1400" dirty="0" err="1">
+                <a:solidFill>
+                  <a:schemeClr val="bg1">
+                    <a:lumMod val="50000"/>
+                  </a:schemeClr>
+                </a:solidFill>
+                <a:latin typeface="Consolas" panose="020B0609020204030204" pitchFamily="49" charset="0"/>
+              </a:rPr>
+              <a:t>nombre</a:t>
+            </a:r>
+            <a:r>
+              <a:rPr lang="en-CA" sz="1400" dirty="0">
+                <a:solidFill>
+                  <a:schemeClr val="bg1">
+                    <a:lumMod val="50000"/>
+                  </a:schemeClr>
+                </a:solidFill>
+                <a:latin typeface="Consolas" panose="020B0609020204030204" pitchFamily="49" charset="0"/>
+              </a:rPr>
+              <a:t> 10 est pair</a:t>
+            </a:r>
+          </a:p>
+          <a:p>
+            <a:pPr lvl="1" algn="just">
+              <a:lnSpc>
+                <a:spcPct val="100000"/>
+              </a:lnSpc>
+            </a:pPr>
+            <a:endParaRPr lang="en-US" sz="1800" dirty="0">
+              <a:latin typeface="Consolas" panose="020B0609020204030204" pitchFamily="49" charset="0"/>
+            </a:endParaRPr>
+          </a:p>
+          <a:p>
             <a:pPr marL="457200" lvl="1" indent="0" algn="just">
               <a:lnSpc>
                 <a:spcPct val="100000"/>
@@ -15082,33 +15444,6 @@
               <a:buNone/>
             </a:pPr>
             <a:endParaRPr lang="en-CA" sz="1800" dirty="0">
-              <a:latin typeface="Consolas" panose="020B0609020204030204" pitchFamily="49" charset="0"/>
-            </a:endParaRPr>
-          </a:p>
-          <a:p>
-            <a:pPr algn="just">
-              <a:lnSpc>
-                <a:spcPct val="100000"/>
-              </a:lnSpc>
-            </a:pPr>
-            <a:r>
-              <a:rPr lang="en-US" sz="1800" dirty="0">
-                <a:latin typeface="Consolas" panose="020B0609020204030204" pitchFamily="49" charset="0"/>
-              </a:rPr>
-              <a:t>...</a:t>
-            </a:r>
-            <a:endParaRPr lang="fr-CA" sz="1800" dirty="0">
-              <a:latin typeface="Consolas" panose="020B0609020204030204" pitchFamily="49" charset="0"/>
-            </a:endParaRPr>
-          </a:p>
-          <a:p>
-            <a:pPr marL="457200" lvl="1" indent="0" algn="just">
-              <a:lnSpc>
-                <a:spcPct val="100000"/>
-              </a:lnSpc>
-              <a:buNone/>
-            </a:pPr>
-            <a:endParaRPr lang="fr-CA" sz="1800" dirty="0">
               <a:latin typeface="Consolas" panose="020B0609020204030204" pitchFamily="49" charset="0"/>
             </a:endParaRPr>
           </a:p>
@@ -15145,205 +15480,106 @@
       </p:sp>
       <p:sp>
         <p:nvSpPr>
-          <p:cNvPr id="9" name="Content Placeholder 2">
+          <p:cNvPr id="4" name="TextBox 3">
             <a:extLst>
               <a:ext uri="{FF2B5EF4-FFF2-40B4-BE49-F238E27FC236}">
-                <a16:creationId xmlns:a16="http://schemas.microsoft.com/office/drawing/2014/main" id="{639F647E-8868-AE5B-744B-856F4CFFCE40}"/>
+                <a16:creationId xmlns:a16="http://schemas.microsoft.com/office/drawing/2014/main" id="{071DD628-0DAD-F02E-FC9E-E2FC5931E89D}"/>
               </a:ext>
             </a:extLst>
           </p:cNvPr>
-          <p:cNvSpPr txBox="1">
-            <a:spLocks/>
-          </p:cNvSpPr>
+          <p:cNvSpPr txBox="1"/>
           <p:nvPr/>
         </p:nvSpPr>
         <p:spPr>
           <a:xfrm>
-            <a:off x="990600" y="1978025"/>
-            <a:ext cx="10515600" cy="4351338"/>
+            <a:off x="4921693" y="2800965"/>
+            <a:ext cx="2348614" cy="1200329"/>
           </a:xfrm>
           <a:prstGeom prst="rect">
             <a:avLst/>
           </a:prstGeom>
+          <a:solidFill>
+            <a:schemeClr val="bg1"/>
+          </a:solidFill>
+          <a:ln w="19050">
+            <a:solidFill>
+              <a:schemeClr val="tx1"/>
+            </a:solidFill>
+          </a:ln>
         </p:spPr>
         <p:txBody>
-          <a:bodyPr vert="horz" lIns="91440" tIns="45720" rIns="91440" bIns="45720" rtlCol="0">
-            <a:normAutofit/>
+          <a:bodyPr wrap="square" anchor="ctr">
+            <a:spAutoFit/>
           </a:bodyPr>
-          <a:lstStyle>
-            <a:lvl1pPr marL="228600" indent="-228600" algn="l" defTabSz="914400" rtl="0" eaLnBrk="1" latinLnBrk="0" hangingPunct="1">
-              <a:lnSpc>
-                <a:spcPct val="90000"/>
-              </a:lnSpc>
-              <a:spcBef>
-                <a:spcPts val="1000"/>
-              </a:spcBef>
-              <a:buFont typeface="Arial" panose="020B0604020202020204" pitchFamily="34" charset="0"/>
-              <a:buChar char="•"/>
-              <a:defRPr sz="2800" kern="1200">
+          <a:lstStyle/>
+          <a:p>
+            <a:r>
+              <a:rPr lang="en-US" dirty="0">
                 <a:solidFill>
-                  <a:schemeClr val="tx1"/>
+                  <a:schemeClr val="bg1">
+                    <a:lumMod val="50000"/>
+                  </a:schemeClr>
                 </a:solidFill>
-                <a:latin typeface="+mn-lt"/>
-                <a:ea typeface="+mn-ea"/>
-                <a:cs typeface="+mn-cs"/>
-              </a:defRPr>
-            </a:lvl1pPr>
-            <a:lvl2pPr marL="685800" indent="-228600" algn="l" defTabSz="914400" rtl="0" eaLnBrk="1" latinLnBrk="0" hangingPunct="1">
-              <a:lnSpc>
-                <a:spcPct val="90000"/>
-              </a:lnSpc>
-              <a:spcBef>
-                <a:spcPts val="500"/>
-              </a:spcBef>
-              <a:buFont typeface="Arial" panose="020B0604020202020204" pitchFamily="34" charset="0"/>
-              <a:buChar char="•"/>
-              <a:defRPr sz="2400" kern="1200">
-                <a:solidFill>
-                  <a:schemeClr val="tx1"/>
-                </a:solidFill>
-                <a:latin typeface="+mn-lt"/>
-                <a:ea typeface="+mn-ea"/>
-                <a:cs typeface="+mn-cs"/>
-              </a:defRPr>
-            </a:lvl2pPr>
-            <a:lvl3pPr marL="1143000" indent="-228600" algn="l" defTabSz="914400" rtl="0" eaLnBrk="1" latinLnBrk="0" hangingPunct="1">
-              <a:lnSpc>
-                <a:spcPct val="90000"/>
-              </a:lnSpc>
-              <a:spcBef>
-                <a:spcPts val="500"/>
-              </a:spcBef>
-              <a:buFont typeface="Arial" panose="020B0604020202020204" pitchFamily="34" charset="0"/>
-              <a:buChar char="•"/>
-              <a:defRPr sz="2000" kern="1200">
-                <a:solidFill>
-                  <a:schemeClr val="tx1"/>
-                </a:solidFill>
-                <a:latin typeface="+mn-lt"/>
-                <a:ea typeface="+mn-ea"/>
-                <a:cs typeface="+mn-cs"/>
-              </a:defRPr>
-            </a:lvl3pPr>
-            <a:lvl4pPr marL="1600200" indent="-228600" algn="l" defTabSz="914400" rtl="0" eaLnBrk="1" latinLnBrk="0" hangingPunct="1">
-              <a:lnSpc>
-                <a:spcPct val="90000"/>
-              </a:lnSpc>
-              <a:spcBef>
-                <a:spcPts val="500"/>
-              </a:spcBef>
-              <a:buFont typeface="Arial" panose="020B0604020202020204" pitchFamily="34" charset="0"/>
-              <a:buChar char="•"/>
-              <a:defRPr sz="1800" kern="1200">
-                <a:solidFill>
-                  <a:schemeClr val="tx1"/>
-                </a:solidFill>
-                <a:latin typeface="+mn-lt"/>
-                <a:ea typeface="+mn-ea"/>
-                <a:cs typeface="+mn-cs"/>
-              </a:defRPr>
-            </a:lvl4pPr>
-            <a:lvl5pPr marL="2057400" indent="-228600" algn="l" defTabSz="914400" rtl="0" eaLnBrk="1" latinLnBrk="0" hangingPunct="1">
-              <a:lnSpc>
-                <a:spcPct val="90000"/>
-              </a:lnSpc>
-              <a:spcBef>
-                <a:spcPts val="500"/>
-              </a:spcBef>
-              <a:buFont typeface="Arial" panose="020B0604020202020204" pitchFamily="34" charset="0"/>
-              <a:buChar char="•"/>
-              <a:defRPr sz="1800" kern="1200">
-                <a:solidFill>
-                  <a:schemeClr val="tx1"/>
-                </a:solidFill>
-                <a:latin typeface="+mn-lt"/>
-                <a:ea typeface="+mn-ea"/>
-                <a:cs typeface="+mn-cs"/>
-              </a:defRPr>
-            </a:lvl5pPr>
-            <a:lvl6pPr marL="2514600" indent="-228600" algn="l" defTabSz="914400" rtl="0" eaLnBrk="1" latinLnBrk="0" hangingPunct="1">
-              <a:lnSpc>
-                <a:spcPct val="90000"/>
-              </a:lnSpc>
-              <a:spcBef>
-                <a:spcPts val="500"/>
-              </a:spcBef>
-              <a:buFont typeface="Arial" panose="020B0604020202020204" pitchFamily="34" charset="0"/>
-              <a:buChar char="•"/>
-              <a:defRPr sz="1800" kern="1200">
-                <a:solidFill>
-                  <a:schemeClr val="tx1"/>
-                </a:solidFill>
-                <a:latin typeface="+mn-lt"/>
-                <a:ea typeface="+mn-ea"/>
-                <a:cs typeface="+mn-cs"/>
-              </a:defRPr>
-            </a:lvl6pPr>
-            <a:lvl7pPr marL="2971800" indent="-228600" algn="l" defTabSz="914400" rtl="0" eaLnBrk="1" latinLnBrk="0" hangingPunct="1">
-              <a:lnSpc>
-                <a:spcPct val="90000"/>
-              </a:lnSpc>
-              <a:spcBef>
-                <a:spcPts val="500"/>
-              </a:spcBef>
-              <a:buFont typeface="Arial" panose="020B0604020202020204" pitchFamily="34" charset="0"/>
-              <a:buChar char="•"/>
-              <a:defRPr sz="1800" kern="1200">
-                <a:solidFill>
-                  <a:schemeClr val="tx1"/>
-                </a:solidFill>
-                <a:latin typeface="+mn-lt"/>
-                <a:ea typeface="+mn-ea"/>
-                <a:cs typeface="+mn-cs"/>
-              </a:defRPr>
-            </a:lvl7pPr>
-            <a:lvl8pPr marL="3429000" indent="-228600" algn="l" defTabSz="914400" rtl="0" eaLnBrk="1" latinLnBrk="0" hangingPunct="1">
-              <a:lnSpc>
-                <a:spcPct val="90000"/>
-              </a:lnSpc>
-              <a:spcBef>
-                <a:spcPts val="500"/>
-              </a:spcBef>
-              <a:buFont typeface="Arial" panose="020B0604020202020204" pitchFamily="34" charset="0"/>
-              <a:buChar char="•"/>
-              <a:defRPr sz="1800" kern="1200">
-                <a:solidFill>
-                  <a:schemeClr val="tx1"/>
-                </a:solidFill>
-                <a:latin typeface="+mn-lt"/>
-                <a:ea typeface="+mn-ea"/>
-                <a:cs typeface="+mn-cs"/>
-              </a:defRPr>
-            </a:lvl8pPr>
-            <a:lvl9pPr marL="3886200" indent="-228600" algn="l" defTabSz="914400" rtl="0" eaLnBrk="1" latinLnBrk="0" hangingPunct="1">
-              <a:lnSpc>
-                <a:spcPct val="90000"/>
-              </a:lnSpc>
-              <a:spcBef>
-                <a:spcPts val="500"/>
-              </a:spcBef>
-              <a:buFont typeface="Arial" panose="020B0604020202020204" pitchFamily="34" charset="0"/>
-              <a:buChar char="•"/>
-              <a:defRPr sz="1800" kern="1200">
-                <a:solidFill>
-                  <a:schemeClr val="tx1"/>
-                </a:solidFill>
-                <a:latin typeface="+mn-lt"/>
-                <a:ea typeface="+mn-ea"/>
-                <a:cs typeface="+mn-cs"/>
-              </a:defRPr>
-            </a:lvl9pPr>
-          </a:lstStyle>
-          <a:p>
-            <a:pPr marL="457200" lvl="1" indent="0" algn="just">
-              <a:lnSpc>
-                <a:spcPct val="150000"/>
-              </a:lnSpc>
+                <a:latin typeface="Consolas" panose="020B0609020204030204" pitchFamily="49" charset="0"/>
+              </a:rPr>
+              <a:t>[instruction(s)]</a:t>
+            </a:r>
+            <a:br>
+              <a:rPr lang="en-US" b="1" dirty="0">
+                <a:latin typeface="Consolas" panose="020B0609020204030204" pitchFamily="49" charset="0"/>
+              </a:rPr>
+            </a:br>
+            <a:r>
+              <a:rPr lang="en-US" b="1" dirty="0">
+                <a:latin typeface="Consolas" panose="020B0609020204030204" pitchFamily="49" charset="0"/>
+              </a:rPr>
+              <a:t>if </a:t>
+            </a:r>
+            <a:r>
+              <a:rPr lang="en-US" dirty="0">
+                <a:latin typeface="Consolas" panose="020B0609020204030204" pitchFamily="49" charset="0"/>
+              </a:rPr>
+              <a:t>condition</a:t>
+            </a:r>
+            <a:r>
+              <a:rPr lang="en-US" b="1" dirty="0">
+                <a:latin typeface="Consolas" panose="020B0609020204030204" pitchFamily="49" charset="0"/>
+              </a:rPr>
+              <a:t>:</a:t>
+            </a:r>
+          </a:p>
+          <a:p>
+            <a:pPr marL="0" indent="0">
               <a:buNone/>
             </a:pPr>
-            <a:endParaRPr lang="en-US" sz="1800" b="1" dirty="0">
-              <a:latin typeface="Consolas" panose="020B0609020204030204" pitchFamily="49" charset="0"/>
-            </a:endParaRPr>
+            <a:r>
+              <a:rPr lang="en-US" b="1" dirty="0">
+                <a:latin typeface="Consolas" panose="020B0609020204030204" pitchFamily="49" charset="0"/>
+              </a:rPr>
+              <a:t>  </a:t>
+            </a:r>
+            <a:r>
+              <a:rPr lang="en-US" dirty="0">
+                <a:latin typeface="Consolas" panose="020B0609020204030204" pitchFamily="49" charset="0"/>
+              </a:rPr>
+              <a:t>instruction(s)</a:t>
+            </a:r>
+          </a:p>
+          <a:p>
+            <a:pPr marL="0" indent="0">
+              <a:buNone/>
+            </a:pPr>
+            <a:r>
+              <a:rPr lang="en-US" dirty="0">
+                <a:solidFill>
+                  <a:schemeClr val="bg1">
+                    <a:lumMod val="50000"/>
+                  </a:schemeClr>
+                </a:solidFill>
+                <a:latin typeface="Consolas" panose="020B0609020204030204" pitchFamily="49" charset="0"/>
+              </a:rPr>
+              <a:t>[instruction(s)]</a:t>
+            </a:r>
           </a:p>
         </p:txBody>
       </p:sp>
@@ -15357,106 +15593,1154 @@
   <p:clrMapOvr>
     <a:masterClrMapping/>
   </p:clrMapOvr>
-  <p:timing>
-    <p:tnLst>
-      <p:par>
-        <p:cTn id="1" dur="indefinite" restart="never" nodeType="tmRoot">
-          <p:childTnLst>
-            <p:seq concurrent="1" nextAc="seek">
-              <p:cTn id="2" dur="indefinite" nodeType="mainSeq">
-                <p:childTnLst>
-                  <p:par>
-                    <p:cTn id="3" fill="hold">
-                      <p:stCondLst>
-                        <p:cond delay="indefinite"/>
-                      </p:stCondLst>
-                      <p:childTnLst>
-                        <p:par>
-                          <p:cTn id="4" fill="hold">
-                            <p:stCondLst>
-                              <p:cond delay="0"/>
-                            </p:stCondLst>
-                            <p:childTnLst>
-                              <p:par>
-                                <p:cTn id="5" presetID="10" presetClass="entr" presetSubtype="0" fill="hold" nodeType="clickEffect" nodePh="1">
-                                  <p:stCondLst>
-                                    <p:cond delay="0"/>
-                                  </p:stCondLst>
-                                  <p:endCondLst>
-                                    <p:cond evt="begin" delay="0">
-                                      <p:tn val="5"/>
-                                    </p:cond>
-                                  </p:endCondLst>
-                                  <p:childTnLst>
-                                    <p:set>
-                                      <p:cBhvr>
-                                        <p:cTn id="6" dur="1" fill="hold">
-                                          <p:stCondLst>
-                                            <p:cond delay="0"/>
-                                          </p:stCondLst>
-                                        </p:cTn>
-                                        <p:tgtEl>
-                                          <p:spTgt spid="9">
-                                            <p:txEl>
-                                              <p:pRg st="0" end="0"/>
-                                            </p:txEl>
-                                          </p:spTgt>
-                                        </p:tgtEl>
-                                        <p:attrNameLst>
-                                          <p:attrName>style.visibility</p:attrName>
-                                        </p:attrNameLst>
-                                      </p:cBhvr>
-                                      <p:to>
-                                        <p:strVal val="visible"/>
-                                      </p:to>
-                                    </p:set>
-                                    <p:animEffect transition="in" filter="fade">
-                                      <p:cBhvr>
-                                        <p:cTn id="7" dur="500"/>
-                                        <p:tgtEl>
-                                          <p:spTgt spid="9">
-                                            <p:txEl>
-                                              <p:pRg st="0" end="0"/>
-                                            </p:txEl>
-                                          </p:spTgt>
-                                        </p:tgtEl>
-                                      </p:cBhvr>
-                                    </p:animEffect>
-                                  </p:childTnLst>
-                                </p:cTn>
-                              </p:par>
-                            </p:childTnLst>
-                          </p:cTn>
-                        </p:par>
-                      </p:childTnLst>
-                    </p:cTn>
-                  </p:par>
-                </p:childTnLst>
-              </p:cTn>
-              <p:prevCondLst>
-                <p:cond evt="onPrev" delay="0">
-                  <p:tgtEl>
-                    <p:sldTgt/>
-                  </p:tgtEl>
-                </p:cond>
-              </p:prevCondLst>
-              <p:nextCondLst>
-                <p:cond evt="onNext" delay="0">
-                  <p:tgtEl>
-                    <p:sldTgt/>
-                  </p:tgtEl>
-                </p:cond>
-              </p:nextCondLst>
-            </p:seq>
-          </p:childTnLst>
-        </p:cTn>
-      </p:par>
-    </p:tnLst>
-  </p:timing>
 </p:sld>
 </file>
 
 <file path=ppt/slides/slide23.xml><?xml version="1.0" encoding="utf-8"?>
+<p:sld xmlns:a="http://schemas.openxmlformats.org/drawingml/2006/main" xmlns:r="http://schemas.openxmlformats.org/officeDocument/2006/relationships" xmlns:p="http://schemas.openxmlformats.org/presentationml/2006/main">
+  <p:cSld>
+    <p:bg>
+      <p:bgPr>
+        <a:solidFill>
+          <a:srgbClr val="F5F5F5"/>
+        </a:solidFill>
+        <a:effectLst/>
+      </p:bgPr>
+    </p:bg>
+    <p:spTree>
+      <p:nvGrpSpPr>
+        <p:cNvPr id="1" name="">
+          <a:extLst>
+            <a:ext uri="{FF2B5EF4-FFF2-40B4-BE49-F238E27FC236}">
+              <a16:creationId xmlns:a16="http://schemas.microsoft.com/office/drawing/2014/main" id="{3E7CB226-7102-D2C6-479D-BDC8641A1FF7}"/>
+            </a:ext>
+          </a:extLst>
+        </p:cNvPr>
+        <p:cNvGrpSpPr/>
+        <p:nvPr/>
+      </p:nvGrpSpPr>
+      <p:grpSpPr>
+        <a:xfrm>
+          <a:off x="0" y="0"/>
+          <a:ext cx="0" cy="0"/>
+          <a:chOff x="0" y="0"/>
+          <a:chExt cx="0" cy="0"/>
+        </a:xfrm>
+      </p:grpSpPr>
+      <p:sp>
+        <p:nvSpPr>
+          <p:cNvPr id="2" name="Title 1">
+            <a:extLst>
+              <a:ext uri="{FF2B5EF4-FFF2-40B4-BE49-F238E27FC236}">
+                <a16:creationId xmlns:a16="http://schemas.microsoft.com/office/drawing/2014/main" id="{30AA4980-4955-DCAD-B5A3-B5D6C102E9AF}"/>
+              </a:ext>
+            </a:extLst>
+          </p:cNvPr>
+          <p:cNvSpPr>
+            <a:spLocks noGrp="1"/>
+          </p:cNvSpPr>
+          <p:nvPr>
+            <p:ph type="title"/>
+          </p:nvPr>
+        </p:nvSpPr>
+        <p:spPr/>
+        <p:txBody>
+          <a:bodyPr/>
+          <a:lstStyle/>
+          <a:p>
+            <a:r>
+              <a:rPr lang="en-US" dirty="0">
+                <a:latin typeface="Arial Rounded MT Bold" panose="020F0704030504030204" pitchFamily="34" charset="0"/>
+              </a:rPr>
+              <a:t>Choix [2/3]</a:t>
+            </a:r>
+            <a:endParaRPr lang="fr-CA" dirty="0">
+              <a:latin typeface="Arial Rounded MT Bold" panose="020F0704030504030204" pitchFamily="34" charset="0"/>
+            </a:endParaRPr>
+          </a:p>
+        </p:txBody>
+      </p:sp>
+      <p:sp>
+        <p:nvSpPr>
+          <p:cNvPr id="3" name="Content Placeholder 2">
+            <a:extLst>
+              <a:ext uri="{FF2B5EF4-FFF2-40B4-BE49-F238E27FC236}">
+                <a16:creationId xmlns:a16="http://schemas.microsoft.com/office/drawing/2014/main" id="{B5B13F47-8F94-E85C-86CD-89FCBF14C12A}"/>
+              </a:ext>
+            </a:extLst>
+          </p:cNvPr>
+          <p:cNvSpPr>
+            <a:spLocks noGrp="1"/>
+          </p:cNvSpPr>
+          <p:nvPr>
+            <p:ph idx="1"/>
+          </p:nvPr>
+        </p:nvSpPr>
+        <p:spPr/>
+        <p:txBody>
+          <a:bodyPr>
+            <a:normAutofit/>
+          </a:bodyPr>
+          <a:lstStyle/>
+          <a:p>
+            <a:pPr lvl="1" algn="just">
+              <a:lnSpc>
+                <a:spcPct val="100000"/>
+              </a:lnSpc>
+            </a:pPr>
+            <a:r>
+              <a:rPr lang="en-CA" sz="1800" dirty="0">
+                <a:latin typeface="Consolas" panose="020B0609020204030204" pitchFamily="49" charset="0"/>
+              </a:rPr>
+              <a:t>E</a:t>
+            </a:r>
+            <a:r>
+              <a:rPr lang="fr-CA" sz="1800" dirty="0">
+                <a:latin typeface="Consolas" panose="020B0609020204030204" pitchFamily="49" charset="0"/>
+              </a:rPr>
+              <a:t>x</a:t>
+            </a:r>
+            <a:r>
+              <a:rPr lang="en-US" sz="1800" dirty="0" err="1">
+                <a:latin typeface="Consolas" panose="020B0609020204030204" pitchFamily="49" charset="0"/>
+              </a:rPr>
+              <a:t>écuter</a:t>
+            </a:r>
+            <a:r>
+              <a:rPr lang="en-US" sz="1800" dirty="0">
+                <a:latin typeface="Consolas" panose="020B0609020204030204" pitchFamily="49" charset="0"/>
+              </a:rPr>
+              <a:t> du code </a:t>
+            </a:r>
+            <a:r>
+              <a:rPr lang="en-US" sz="1800" dirty="0" err="1">
+                <a:latin typeface="Consolas" panose="020B0609020204030204" pitchFamily="49" charset="0"/>
+              </a:rPr>
+              <a:t>si</a:t>
+            </a:r>
+            <a:r>
+              <a:rPr lang="en-US" sz="1800" dirty="0">
+                <a:latin typeface="Consolas" panose="020B0609020204030204" pitchFamily="49" charset="0"/>
+              </a:rPr>
+              <a:t> </a:t>
+            </a:r>
+            <a:r>
+              <a:rPr lang="en-US" sz="1800" dirty="0" err="1">
+                <a:latin typeface="Consolas" panose="020B0609020204030204" pitchFamily="49" charset="0"/>
+              </a:rPr>
+              <a:t>une</a:t>
+            </a:r>
+            <a:r>
+              <a:rPr lang="en-US" sz="1800" dirty="0">
+                <a:latin typeface="Consolas" panose="020B0609020204030204" pitchFamily="49" charset="0"/>
+              </a:rPr>
+              <a:t> condition est </a:t>
+            </a:r>
+            <a:r>
+              <a:rPr lang="en-US" sz="1800" dirty="0" err="1">
+                <a:latin typeface="Consolas" panose="020B0609020204030204" pitchFamily="49" charset="0"/>
+              </a:rPr>
+              <a:t>vraie</a:t>
+            </a:r>
+            <a:r>
+              <a:rPr lang="en-US" sz="1800" dirty="0">
+                <a:latin typeface="Consolas" panose="020B0609020204030204" pitchFamily="49" charset="0"/>
+              </a:rPr>
+              <a:t> (c.-à-d. </a:t>
+            </a:r>
+            <a:r>
+              <a:rPr lang="en-US" sz="1800" b="1" dirty="0" err="1">
+                <a:latin typeface="Consolas" panose="020B0609020204030204" pitchFamily="49" charset="0"/>
+              </a:rPr>
+              <a:t>égale</a:t>
+            </a:r>
+            <a:r>
+              <a:rPr lang="en-US" sz="1800" b="1" dirty="0">
+                <a:latin typeface="Consolas" panose="020B0609020204030204" pitchFamily="49" charset="0"/>
+              </a:rPr>
+              <a:t> à True</a:t>
+            </a:r>
+            <a:r>
+              <a:rPr lang="en-US" sz="1800" dirty="0">
+                <a:latin typeface="Consolas" panose="020B0609020204030204" pitchFamily="49" charset="0"/>
+              </a:rPr>
+              <a:t>)</a:t>
+            </a:r>
+          </a:p>
+          <a:p>
+            <a:pPr lvl="2" algn="just">
+              <a:lnSpc>
+                <a:spcPct val="100000"/>
+              </a:lnSpc>
+            </a:pPr>
+            <a:r>
+              <a:rPr lang="en-US" sz="1400" dirty="0" err="1">
+                <a:latin typeface="Consolas" panose="020B0609020204030204" pitchFamily="49" charset="0"/>
+              </a:rPr>
+              <a:t>Implique</a:t>
+            </a:r>
+            <a:r>
+              <a:rPr lang="en-US" sz="1400" dirty="0">
+                <a:latin typeface="Consolas" panose="020B0609020204030204" pitchFamily="49" charset="0"/>
+              </a:rPr>
+              <a:t> </a:t>
+            </a:r>
+            <a:r>
+              <a:rPr lang="en-US" sz="1400" dirty="0" err="1">
+                <a:latin typeface="Consolas" panose="020B0609020204030204" pitchFamily="49" charset="0"/>
+              </a:rPr>
+              <a:t>généralement</a:t>
+            </a:r>
+            <a:r>
+              <a:rPr lang="en-US" sz="1400" dirty="0">
+                <a:latin typeface="Consolas" panose="020B0609020204030204" pitchFamily="49" charset="0"/>
+              </a:rPr>
+              <a:t> les </a:t>
+            </a:r>
+            <a:r>
+              <a:rPr lang="en-US" sz="1400" dirty="0" err="1">
+                <a:latin typeface="Consolas" panose="020B0609020204030204" pitchFamily="49" charset="0"/>
+              </a:rPr>
+              <a:t>opérateurs</a:t>
+            </a:r>
+            <a:r>
+              <a:rPr lang="en-US" sz="1400" dirty="0">
+                <a:latin typeface="Consolas" panose="020B0609020204030204" pitchFamily="49" charset="0"/>
+              </a:rPr>
+              <a:t> de </a:t>
+            </a:r>
+            <a:r>
+              <a:rPr lang="en-US" sz="1400" dirty="0" err="1">
+                <a:latin typeface="Consolas" panose="020B0609020204030204" pitchFamily="49" charset="0"/>
+              </a:rPr>
+              <a:t>comparaison</a:t>
+            </a:r>
+            <a:r>
+              <a:rPr lang="en-US" sz="1400" dirty="0">
+                <a:latin typeface="Consolas" panose="020B0609020204030204" pitchFamily="49" charset="0"/>
+              </a:rPr>
+              <a:t> et les </a:t>
+            </a:r>
+            <a:r>
+              <a:rPr lang="en-US" sz="1400" dirty="0" err="1">
+                <a:latin typeface="Consolas" panose="020B0609020204030204" pitchFamily="49" charset="0"/>
+              </a:rPr>
+              <a:t>opérateurs</a:t>
+            </a:r>
+            <a:r>
+              <a:rPr lang="en-US" sz="1400" dirty="0">
+                <a:latin typeface="Consolas" panose="020B0609020204030204" pitchFamily="49" charset="0"/>
+              </a:rPr>
+              <a:t> </a:t>
+            </a:r>
+            <a:r>
+              <a:rPr lang="en-US" sz="1400" dirty="0" err="1">
+                <a:latin typeface="Consolas" panose="020B0609020204030204" pitchFamily="49" charset="0"/>
+              </a:rPr>
+              <a:t>logiques</a:t>
+            </a:r>
+            <a:endParaRPr lang="en-US" sz="1400" dirty="0">
+              <a:latin typeface="Consolas" panose="020B0609020204030204" pitchFamily="49" charset="0"/>
+            </a:endParaRPr>
+          </a:p>
+          <a:p>
+            <a:pPr lvl="2" algn="just">
+              <a:lnSpc>
+                <a:spcPct val="100000"/>
+              </a:lnSpc>
+            </a:pPr>
+            <a:endParaRPr lang="en-US" sz="1400" dirty="0">
+              <a:latin typeface="Consolas" panose="020B0609020204030204" pitchFamily="49" charset="0"/>
+            </a:endParaRPr>
+          </a:p>
+          <a:p>
+            <a:pPr lvl="2" algn="just">
+              <a:lnSpc>
+                <a:spcPct val="100000"/>
+              </a:lnSpc>
+            </a:pPr>
+            <a:endParaRPr lang="en-US" sz="1400" dirty="0">
+              <a:latin typeface="Consolas" panose="020B0609020204030204" pitchFamily="49" charset="0"/>
+            </a:endParaRPr>
+          </a:p>
+          <a:p>
+            <a:pPr lvl="2" algn="just">
+              <a:lnSpc>
+                <a:spcPct val="100000"/>
+              </a:lnSpc>
+            </a:pPr>
+            <a:endParaRPr lang="en-US" sz="1400" dirty="0">
+              <a:latin typeface="Consolas" panose="020B0609020204030204" pitchFamily="49" charset="0"/>
+            </a:endParaRPr>
+          </a:p>
+          <a:p>
+            <a:pPr lvl="2" algn="just">
+              <a:lnSpc>
+                <a:spcPct val="100000"/>
+              </a:lnSpc>
+            </a:pPr>
+            <a:endParaRPr lang="en-US" sz="1400" dirty="0">
+              <a:latin typeface="Consolas" panose="020B0609020204030204" pitchFamily="49" charset="0"/>
+            </a:endParaRPr>
+          </a:p>
+          <a:p>
+            <a:pPr lvl="2" algn="just">
+              <a:lnSpc>
+                <a:spcPct val="100000"/>
+              </a:lnSpc>
+            </a:pPr>
+            <a:endParaRPr lang="en-US" sz="1400" dirty="0">
+              <a:latin typeface="Consolas" panose="020B0609020204030204" pitchFamily="49" charset="0"/>
+            </a:endParaRPr>
+          </a:p>
+          <a:p>
+            <a:pPr lvl="2" algn="just">
+              <a:lnSpc>
+                <a:spcPct val="100000"/>
+              </a:lnSpc>
+            </a:pPr>
+            <a:endParaRPr lang="en-US" sz="1400" dirty="0">
+              <a:latin typeface="Consolas" panose="020B0609020204030204" pitchFamily="49" charset="0"/>
+            </a:endParaRPr>
+          </a:p>
+          <a:p>
+            <a:pPr marL="914400" lvl="2" indent="0" algn="just">
+              <a:lnSpc>
+                <a:spcPct val="100000"/>
+              </a:lnSpc>
+              <a:buNone/>
+            </a:pPr>
+            <a:br>
+              <a:rPr lang="en-CA" sz="1400" b="1" dirty="0">
+                <a:latin typeface="Consolas" panose="020B0609020204030204" pitchFamily="49" charset="0"/>
+              </a:rPr>
+            </a:br>
+            <a:r>
+              <a:rPr lang="en-CA" sz="1400" b="1" dirty="0">
+                <a:latin typeface="Consolas" panose="020B0609020204030204" pitchFamily="49" charset="0"/>
+              </a:rPr>
+              <a:t>&gt;&gt;&gt; </a:t>
+            </a:r>
+            <a:r>
+              <a:rPr lang="en-CA" sz="1400" b="1" dirty="0" err="1">
+                <a:latin typeface="Consolas" panose="020B0609020204030204" pitchFamily="49" charset="0"/>
+              </a:rPr>
+              <a:t>valeur</a:t>
+            </a:r>
+            <a:r>
+              <a:rPr lang="en-CA" sz="1400" b="1" dirty="0">
+                <a:latin typeface="Consolas" panose="020B0609020204030204" pitchFamily="49" charset="0"/>
+              </a:rPr>
+              <a:t> = 11</a:t>
+            </a:r>
+          </a:p>
+          <a:p>
+            <a:pPr marL="914400" lvl="2" indent="0" algn="just">
+              <a:lnSpc>
+                <a:spcPct val="100000"/>
+              </a:lnSpc>
+              <a:buNone/>
+            </a:pPr>
+            <a:r>
+              <a:rPr lang="en-CA" sz="1400" b="1" dirty="0">
+                <a:latin typeface="Consolas" panose="020B0609020204030204" pitchFamily="49" charset="0"/>
+              </a:rPr>
+              <a:t>&gt;&gt;&gt; if </a:t>
+            </a:r>
+            <a:r>
+              <a:rPr lang="en-CA" sz="1400" b="1" dirty="0" err="1">
+                <a:latin typeface="Consolas" panose="020B0609020204030204" pitchFamily="49" charset="0"/>
+              </a:rPr>
+              <a:t>valeur</a:t>
+            </a:r>
+            <a:r>
+              <a:rPr lang="en-CA" sz="1400" b="1" dirty="0">
+                <a:latin typeface="Consolas" panose="020B0609020204030204" pitchFamily="49" charset="0"/>
+              </a:rPr>
+              <a:t> % 2 == 0:</a:t>
+            </a:r>
+          </a:p>
+          <a:p>
+            <a:pPr marL="914400" lvl="2" indent="0" algn="just">
+              <a:lnSpc>
+                <a:spcPct val="100000"/>
+              </a:lnSpc>
+              <a:buNone/>
+            </a:pPr>
+            <a:r>
+              <a:rPr lang="en-CA" sz="1400" b="1" dirty="0">
+                <a:latin typeface="Consolas" panose="020B0609020204030204" pitchFamily="49" charset="0"/>
+              </a:rPr>
+              <a:t>...   print("La </a:t>
+            </a:r>
+            <a:r>
+              <a:rPr lang="en-CA" sz="1400" b="1" dirty="0" err="1">
+                <a:latin typeface="Consolas" panose="020B0609020204030204" pitchFamily="49" charset="0"/>
+              </a:rPr>
+              <a:t>nombre</a:t>
+            </a:r>
+            <a:r>
+              <a:rPr lang="en-CA" sz="1400" b="1" dirty="0">
+                <a:latin typeface="Consolas" panose="020B0609020204030204" pitchFamily="49" charset="0"/>
+              </a:rPr>
+              <a:t>", </a:t>
+            </a:r>
+            <a:r>
+              <a:rPr lang="en-CA" sz="1400" b="1" dirty="0" err="1">
+                <a:latin typeface="Consolas" panose="020B0609020204030204" pitchFamily="49" charset="0"/>
+              </a:rPr>
+              <a:t>valeur</a:t>
+            </a:r>
+            <a:r>
+              <a:rPr lang="en-CA" sz="1400" b="1" dirty="0">
+                <a:latin typeface="Consolas" panose="020B0609020204030204" pitchFamily="49" charset="0"/>
+              </a:rPr>
+              <a:t>, "est pair")</a:t>
+            </a:r>
+          </a:p>
+          <a:p>
+            <a:pPr marL="914400" lvl="2" indent="0" algn="just">
+              <a:lnSpc>
+                <a:spcPct val="100000"/>
+              </a:lnSpc>
+              <a:buNone/>
+            </a:pPr>
+            <a:r>
+              <a:rPr lang="en-CA" sz="1400" b="1" dirty="0">
+                <a:latin typeface="Consolas" panose="020B0609020204030204" pitchFamily="49" charset="0"/>
+              </a:rPr>
+              <a:t>... </a:t>
+            </a:r>
+            <a:r>
+              <a:rPr lang="en-CA" sz="1400" b="1" dirty="0" err="1">
+                <a:latin typeface="Consolas" panose="020B0609020204030204" pitchFamily="49" charset="0"/>
+              </a:rPr>
+              <a:t>elif</a:t>
+            </a:r>
+            <a:r>
+              <a:rPr lang="en-CA" sz="1400" b="1" dirty="0">
+                <a:latin typeface="Consolas" panose="020B0609020204030204" pitchFamily="49" charset="0"/>
+              </a:rPr>
+              <a:t> </a:t>
+            </a:r>
+            <a:r>
+              <a:rPr lang="en-CA" sz="1400" b="1" dirty="0" err="1">
+                <a:latin typeface="Consolas" panose="020B0609020204030204" pitchFamily="49" charset="0"/>
+              </a:rPr>
+              <a:t>valeur</a:t>
+            </a:r>
+            <a:r>
+              <a:rPr lang="en-CA" sz="1400" b="1" dirty="0">
+                <a:latin typeface="Consolas" panose="020B0609020204030204" pitchFamily="49" charset="0"/>
+              </a:rPr>
+              <a:t> % 2 == 1:</a:t>
+            </a:r>
+          </a:p>
+          <a:p>
+            <a:pPr marL="914400" lvl="2" indent="0" algn="just">
+              <a:lnSpc>
+                <a:spcPct val="100000"/>
+              </a:lnSpc>
+              <a:buNone/>
+            </a:pPr>
+            <a:r>
+              <a:rPr lang="en-CA" sz="1400" b="1" dirty="0">
+                <a:latin typeface="Consolas" panose="020B0609020204030204" pitchFamily="49" charset="0"/>
+              </a:rPr>
+              <a:t>...   print("Le </a:t>
+            </a:r>
+            <a:r>
+              <a:rPr lang="en-CA" sz="1400" b="1" dirty="0" err="1">
+                <a:latin typeface="Consolas" panose="020B0609020204030204" pitchFamily="49" charset="0"/>
+              </a:rPr>
+              <a:t>nombre</a:t>
+            </a:r>
+            <a:r>
+              <a:rPr lang="en-CA" sz="1400" b="1" dirty="0">
+                <a:latin typeface="Consolas" panose="020B0609020204030204" pitchFamily="49" charset="0"/>
+              </a:rPr>
+              <a:t>", </a:t>
+            </a:r>
+            <a:r>
+              <a:rPr lang="en-CA" sz="1400" b="1" dirty="0" err="1">
+                <a:latin typeface="Consolas" panose="020B0609020204030204" pitchFamily="49" charset="0"/>
+              </a:rPr>
+              <a:t>valeur</a:t>
+            </a:r>
+            <a:r>
+              <a:rPr lang="en-CA" sz="1400" b="1" dirty="0">
+                <a:latin typeface="Consolas" panose="020B0609020204030204" pitchFamily="49" charset="0"/>
+              </a:rPr>
+              <a:t>, "est impair")</a:t>
+            </a:r>
+          </a:p>
+          <a:p>
+            <a:pPr marL="914400" lvl="2" indent="0" algn="just">
+              <a:lnSpc>
+                <a:spcPct val="100000"/>
+              </a:lnSpc>
+              <a:buNone/>
+            </a:pPr>
+            <a:r>
+              <a:rPr lang="en-CA" sz="1400" dirty="0">
+                <a:solidFill>
+                  <a:schemeClr val="bg1">
+                    <a:lumMod val="50000"/>
+                  </a:schemeClr>
+                </a:solidFill>
+                <a:latin typeface="Consolas" panose="020B0609020204030204" pitchFamily="49" charset="0"/>
+              </a:rPr>
+              <a:t>Le </a:t>
+            </a:r>
+            <a:r>
+              <a:rPr lang="en-CA" sz="1400" dirty="0" err="1">
+                <a:solidFill>
+                  <a:schemeClr val="bg1">
+                    <a:lumMod val="50000"/>
+                  </a:schemeClr>
+                </a:solidFill>
+                <a:latin typeface="Consolas" panose="020B0609020204030204" pitchFamily="49" charset="0"/>
+              </a:rPr>
+              <a:t>nombre</a:t>
+            </a:r>
+            <a:r>
+              <a:rPr lang="en-CA" sz="1400" dirty="0">
+                <a:solidFill>
+                  <a:schemeClr val="bg1">
+                    <a:lumMod val="50000"/>
+                  </a:schemeClr>
+                </a:solidFill>
+                <a:latin typeface="Consolas" panose="020B0609020204030204" pitchFamily="49" charset="0"/>
+              </a:rPr>
+              <a:t> 11 est impair</a:t>
+            </a:r>
+          </a:p>
+          <a:p>
+            <a:pPr lvl="1" algn="just">
+              <a:lnSpc>
+                <a:spcPct val="100000"/>
+              </a:lnSpc>
+            </a:pPr>
+            <a:endParaRPr lang="en-US" sz="1800" dirty="0">
+              <a:latin typeface="Consolas" panose="020B0609020204030204" pitchFamily="49" charset="0"/>
+            </a:endParaRPr>
+          </a:p>
+          <a:p>
+            <a:pPr marL="457200" lvl="1" indent="0" algn="just">
+              <a:lnSpc>
+                <a:spcPct val="100000"/>
+              </a:lnSpc>
+              <a:buNone/>
+            </a:pPr>
+            <a:endParaRPr lang="en-CA" sz="1800" dirty="0">
+              <a:latin typeface="Consolas" panose="020B0609020204030204" pitchFamily="49" charset="0"/>
+            </a:endParaRPr>
+          </a:p>
+        </p:txBody>
+      </p:sp>
+      <p:sp>
+        <p:nvSpPr>
+          <p:cNvPr id="5" name="Slide Number Placeholder 4">
+            <a:extLst>
+              <a:ext uri="{FF2B5EF4-FFF2-40B4-BE49-F238E27FC236}">
+                <a16:creationId xmlns:a16="http://schemas.microsoft.com/office/drawing/2014/main" id="{A42DB256-3F68-8146-C0B7-FAD3B848F06A}"/>
+              </a:ext>
+            </a:extLst>
+          </p:cNvPr>
+          <p:cNvSpPr>
+            <a:spLocks noGrp="1"/>
+          </p:cNvSpPr>
+          <p:nvPr>
+            <p:ph type="sldNum" sz="quarter" idx="12"/>
+          </p:nvPr>
+        </p:nvSpPr>
+        <p:spPr/>
+        <p:txBody>
+          <a:bodyPr/>
+          <a:lstStyle/>
+          <a:p>
+            <a:fld id="{846B06B1-1179-491F-A487-8E0C403F7C13}" type="slidenum">
+              <a:rPr lang="fr-CA" smtClean="0"/>
+              <a:t>23</a:t>
+            </a:fld>
+            <a:endParaRPr lang="fr-CA"/>
+          </a:p>
+        </p:txBody>
+      </p:sp>
+      <p:sp>
+        <p:nvSpPr>
+          <p:cNvPr id="7" name="TextBox 6">
+            <a:extLst>
+              <a:ext uri="{FF2B5EF4-FFF2-40B4-BE49-F238E27FC236}">
+                <a16:creationId xmlns:a16="http://schemas.microsoft.com/office/drawing/2014/main" id="{7E07BAE4-1F1B-E35B-60B9-FE9F09C643E5}"/>
+              </a:ext>
+            </a:extLst>
+          </p:cNvPr>
+          <p:cNvSpPr txBox="1"/>
+          <p:nvPr/>
+        </p:nvSpPr>
+        <p:spPr>
+          <a:xfrm>
+            <a:off x="4791488" y="2634214"/>
+            <a:ext cx="2609024" cy="1754326"/>
+          </a:xfrm>
+          <a:prstGeom prst="rect">
+            <a:avLst/>
+          </a:prstGeom>
+          <a:solidFill>
+            <a:schemeClr val="bg1"/>
+          </a:solidFill>
+          <a:ln w="19050">
+            <a:solidFill>
+              <a:schemeClr val="tx1"/>
+            </a:solidFill>
+          </a:ln>
+        </p:spPr>
+        <p:txBody>
+          <a:bodyPr wrap="square" anchor="ctr">
+            <a:spAutoFit/>
+          </a:bodyPr>
+          <a:lstStyle/>
+          <a:p>
+            <a:pPr marL="0" indent="0">
+              <a:buNone/>
+            </a:pPr>
+            <a:r>
+              <a:rPr lang="en-US" dirty="0">
+                <a:solidFill>
+                  <a:schemeClr val="bg1">
+                    <a:lumMod val="50000"/>
+                  </a:schemeClr>
+                </a:solidFill>
+                <a:latin typeface="Consolas" panose="020B0609020204030204" pitchFamily="49" charset="0"/>
+              </a:rPr>
+              <a:t>[instructions]</a:t>
+            </a:r>
+          </a:p>
+          <a:p>
+            <a:pPr marL="0" indent="0">
+              <a:buNone/>
+            </a:pPr>
+            <a:r>
+              <a:rPr lang="en-US" b="1" dirty="0">
+                <a:latin typeface="Consolas" panose="020B0609020204030204" pitchFamily="49" charset="0"/>
+              </a:rPr>
+              <a:t>if</a:t>
+            </a:r>
+            <a:r>
+              <a:rPr lang="en-US" dirty="0">
+                <a:latin typeface="Consolas" panose="020B0609020204030204" pitchFamily="49" charset="0"/>
+              </a:rPr>
+              <a:t> condition_1</a:t>
+            </a:r>
+            <a:r>
+              <a:rPr lang="en-US" b="1" dirty="0">
+                <a:latin typeface="Consolas" panose="020B0609020204030204" pitchFamily="49" charset="0"/>
+              </a:rPr>
+              <a:t>:</a:t>
+            </a:r>
+          </a:p>
+          <a:p>
+            <a:pPr marL="0" indent="0">
+              <a:buNone/>
+            </a:pPr>
+            <a:r>
+              <a:rPr lang="en-US" dirty="0">
+                <a:latin typeface="Consolas" panose="020B0609020204030204" pitchFamily="49" charset="0"/>
+              </a:rPr>
+              <a:t>  instructions</a:t>
+            </a:r>
+          </a:p>
+          <a:p>
+            <a:pPr marL="0" indent="0">
+              <a:buNone/>
+            </a:pPr>
+            <a:r>
+              <a:rPr lang="en-US" b="1" dirty="0" err="1">
+                <a:latin typeface="Consolas" panose="020B0609020204030204" pitchFamily="49" charset="0"/>
+              </a:rPr>
+              <a:t>elif</a:t>
+            </a:r>
+            <a:r>
+              <a:rPr lang="en-US" dirty="0">
+                <a:latin typeface="Consolas" panose="020B0609020204030204" pitchFamily="49" charset="0"/>
+              </a:rPr>
+              <a:t> condition_2</a:t>
+            </a:r>
+            <a:r>
+              <a:rPr lang="en-US" b="1" dirty="0">
+                <a:latin typeface="Consolas" panose="020B0609020204030204" pitchFamily="49" charset="0"/>
+              </a:rPr>
+              <a:t>:</a:t>
+            </a:r>
+          </a:p>
+          <a:p>
+            <a:pPr marL="0" indent="0">
+              <a:buNone/>
+            </a:pPr>
+            <a:r>
+              <a:rPr lang="en-US" dirty="0">
+                <a:latin typeface="Consolas" panose="020B0609020204030204" pitchFamily="49" charset="0"/>
+              </a:rPr>
+              <a:t>  instructions</a:t>
+            </a:r>
+          </a:p>
+          <a:p>
+            <a:pPr marL="0" indent="0">
+              <a:buNone/>
+            </a:pPr>
+            <a:r>
+              <a:rPr lang="en-US" dirty="0">
+                <a:solidFill>
+                  <a:schemeClr val="bg1">
+                    <a:lumMod val="50000"/>
+                  </a:schemeClr>
+                </a:solidFill>
+                <a:latin typeface="Consolas" panose="020B0609020204030204" pitchFamily="49" charset="0"/>
+              </a:rPr>
+              <a:t>[instructions]</a:t>
+            </a:r>
+          </a:p>
+        </p:txBody>
+      </p:sp>
+    </p:spTree>
+    <p:extLst>
+      <p:ext uri="{BB962C8B-B14F-4D97-AF65-F5344CB8AC3E}">
+        <p14:creationId xmlns:p14="http://schemas.microsoft.com/office/powerpoint/2010/main" val="1632743349"/>
+      </p:ext>
+    </p:extLst>
+  </p:cSld>
+  <p:clrMapOvr>
+    <a:masterClrMapping/>
+  </p:clrMapOvr>
+</p:sld>
+</file>
+
+<file path=ppt/slides/slide24.xml><?xml version="1.0" encoding="utf-8"?>
+<p:sld xmlns:a="http://schemas.openxmlformats.org/drawingml/2006/main" xmlns:r="http://schemas.openxmlformats.org/officeDocument/2006/relationships" xmlns:p="http://schemas.openxmlformats.org/presentationml/2006/main">
+  <p:cSld>
+    <p:bg>
+      <p:bgPr>
+        <a:solidFill>
+          <a:srgbClr val="F5F5F5"/>
+        </a:solidFill>
+        <a:effectLst/>
+      </p:bgPr>
+    </p:bg>
+    <p:spTree>
+      <p:nvGrpSpPr>
+        <p:cNvPr id="1" name="">
+          <a:extLst>
+            <a:ext uri="{FF2B5EF4-FFF2-40B4-BE49-F238E27FC236}">
+              <a16:creationId xmlns:a16="http://schemas.microsoft.com/office/drawing/2014/main" id="{41CAA905-3395-07D0-E9EC-F2C52DE5565E}"/>
+            </a:ext>
+          </a:extLst>
+        </p:cNvPr>
+        <p:cNvGrpSpPr/>
+        <p:nvPr/>
+      </p:nvGrpSpPr>
+      <p:grpSpPr>
+        <a:xfrm>
+          <a:off x="0" y="0"/>
+          <a:ext cx="0" cy="0"/>
+          <a:chOff x="0" y="0"/>
+          <a:chExt cx="0" cy="0"/>
+        </a:xfrm>
+      </p:grpSpPr>
+      <p:sp>
+        <p:nvSpPr>
+          <p:cNvPr id="2" name="Title 1">
+            <a:extLst>
+              <a:ext uri="{FF2B5EF4-FFF2-40B4-BE49-F238E27FC236}">
+                <a16:creationId xmlns:a16="http://schemas.microsoft.com/office/drawing/2014/main" id="{4C0A76DD-5BE2-A84A-DBA4-4092FE7F994D}"/>
+              </a:ext>
+            </a:extLst>
+          </p:cNvPr>
+          <p:cNvSpPr>
+            <a:spLocks noGrp="1"/>
+          </p:cNvSpPr>
+          <p:nvPr>
+            <p:ph type="title"/>
+          </p:nvPr>
+        </p:nvSpPr>
+        <p:spPr/>
+        <p:txBody>
+          <a:bodyPr/>
+          <a:lstStyle/>
+          <a:p>
+            <a:r>
+              <a:rPr lang="en-US" dirty="0">
+                <a:latin typeface="Arial Rounded MT Bold" panose="020F0704030504030204" pitchFamily="34" charset="0"/>
+              </a:rPr>
+              <a:t>Choix [3/3]</a:t>
+            </a:r>
+            <a:endParaRPr lang="fr-CA" dirty="0">
+              <a:latin typeface="Arial Rounded MT Bold" panose="020F0704030504030204" pitchFamily="34" charset="0"/>
+            </a:endParaRPr>
+          </a:p>
+        </p:txBody>
+      </p:sp>
+      <p:sp>
+        <p:nvSpPr>
+          <p:cNvPr id="3" name="Content Placeholder 2">
+            <a:extLst>
+              <a:ext uri="{FF2B5EF4-FFF2-40B4-BE49-F238E27FC236}">
+                <a16:creationId xmlns:a16="http://schemas.microsoft.com/office/drawing/2014/main" id="{C5D36386-3A04-3A7F-9BBE-CEBA63E49A28}"/>
+              </a:ext>
+            </a:extLst>
+          </p:cNvPr>
+          <p:cNvSpPr>
+            <a:spLocks noGrp="1"/>
+          </p:cNvSpPr>
+          <p:nvPr>
+            <p:ph idx="1"/>
+          </p:nvPr>
+        </p:nvSpPr>
+        <p:spPr/>
+        <p:txBody>
+          <a:bodyPr>
+            <a:normAutofit/>
+          </a:bodyPr>
+          <a:lstStyle/>
+          <a:p>
+            <a:pPr lvl="1" algn="just">
+              <a:lnSpc>
+                <a:spcPct val="100000"/>
+              </a:lnSpc>
+            </a:pPr>
+            <a:r>
+              <a:rPr lang="en-CA" sz="1800" dirty="0">
+                <a:latin typeface="Consolas" panose="020B0609020204030204" pitchFamily="49" charset="0"/>
+              </a:rPr>
+              <a:t>E</a:t>
+            </a:r>
+            <a:r>
+              <a:rPr lang="fr-CA" sz="1800" dirty="0">
+                <a:latin typeface="Consolas" panose="020B0609020204030204" pitchFamily="49" charset="0"/>
+              </a:rPr>
+              <a:t>x</a:t>
+            </a:r>
+            <a:r>
+              <a:rPr lang="en-US" sz="1800" dirty="0" err="1">
+                <a:latin typeface="Consolas" panose="020B0609020204030204" pitchFamily="49" charset="0"/>
+              </a:rPr>
+              <a:t>écuter</a:t>
+            </a:r>
+            <a:r>
+              <a:rPr lang="en-US" sz="1800" dirty="0">
+                <a:latin typeface="Consolas" panose="020B0609020204030204" pitchFamily="49" charset="0"/>
+              </a:rPr>
+              <a:t> du code </a:t>
+            </a:r>
+            <a:r>
+              <a:rPr lang="en-US" sz="1800" dirty="0" err="1">
+                <a:latin typeface="Consolas" panose="020B0609020204030204" pitchFamily="49" charset="0"/>
+              </a:rPr>
+              <a:t>si</a:t>
+            </a:r>
+            <a:r>
+              <a:rPr lang="en-US" sz="1800" dirty="0">
+                <a:latin typeface="Consolas" panose="020B0609020204030204" pitchFamily="49" charset="0"/>
+              </a:rPr>
+              <a:t> </a:t>
+            </a:r>
+            <a:r>
+              <a:rPr lang="en-US" sz="1800" dirty="0" err="1">
+                <a:latin typeface="Consolas" panose="020B0609020204030204" pitchFamily="49" charset="0"/>
+              </a:rPr>
+              <a:t>une</a:t>
+            </a:r>
+            <a:r>
+              <a:rPr lang="en-US" sz="1800" dirty="0">
+                <a:latin typeface="Consolas" panose="020B0609020204030204" pitchFamily="49" charset="0"/>
+              </a:rPr>
+              <a:t> condition est </a:t>
+            </a:r>
+            <a:r>
+              <a:rPr lang="en-US" sz="1800" dirty="0" err="1">
+                <a:latin typeface="Consolas" panose="020B0609020204030204" pitchFamily="49" charset="0"/>
+              </a:rPr>
+              <a:t>vraie</a:t>
+            </a:r>
+            <a:r>
+              <a:rPr lang="en-US" sz="1800" dirty="0">
+                <a:latin typeface="Consolas" panose="020B0609020204030204" pitchFamily="49" charset="0"/>
+              </a:rPr>
+              <a:t> (c.-à-d. </a:t>
+            </a:r>
+            <a:r>
+              <a:rPr lang="en-US" sz="1800" b="1" dirty="0" err="1">
+                <a:latin typeface="Consolas" panose="020B0609020204030204" pitchFamily="49" charset="0"/>
+              </a:rPr>
+              <a:t>égale</a:t>
+            </a:r>
+            <a:r>
+              <a:rPr lang="en-US" sz="1800" b="1" dirty="0">
+                <a:latin typeface="Consolas" panose="020B0609020204030204" pitchFamily="49" charset="0"/>
+              </a:rPr>
+              <a:t> à True</a:t>
+            </a:r>
+            <a:r>
+              <a:rPr lang="en-US" sz="1800" dirty="0">
+                <a:latin typeface="Consolas" panose="020B0609020204030204" pitchFamily="49" charset="0"/>
+              </a:rPr>
+              <a:t>)</a:t>
+            </a:r>
+          </a:p>
+          <a:p>
+            <a:pPr lvl="2" algn="just">
+              <a:lnSpc>
+                <a:spcPct val="100000"/>
+              </a:lnSpc>
+            </a:pPr>
+            <a:r>
+              <a:rPr lang="en-US" sz="1400" dirty="0" err="1">
+                <a:latin typeface="Consolas" panose="020B0609020204030204" pitchFamily="49" charset="0"/>
+              </a:rPr>
+              <a:t>Implique</a:t>
+            </a:r>
+            <a:r>
+              <a:rPr lang="en-US" sz="1400" dirty="0">
+                <a:latin typeface="Consolas" panose="020B0609020204030204" pitchFamily="49" charset="0"/>
+              </a:rPr>
+              <a:t> </a:t>
+            </a:r>
+            <a:r>
+              <a:rPr lang="en-US" sz="1400" dirty="0" err="1">
+                <a:latin typeface="Consolas" panose="020B0609020204030204" pitchFamily="49" charset="0"/>
+              </a:rPr>
+              <a:t>généralement</a:t>
+            </a:r>
+            <a:r>
+              <a:rPr lang="en-US" sz="1400" dirty="0">
+                <a:latin typeface="Consolas" panose="020B0609020204030204" pitchFamily="49" charset="0"/>
+              </a:rPr>
+              <a:t> les </a:t>
+            </a:r>
+            <a:r>
+              <a:rPr lang="en-US" sz="1400" dirty="0" err="1">
+                <a:latin typeface="Consolas" panose="020B0609020204030204" pitchFamily="49" charset="0"/>
+              </a:rPr>
+              <a:t>opérateurs</a:t>
+            </a:r>
+            <a:r>
+              <a:rPr lang="en-US" sz="1400" dirty="0">
+                <a:latin typeface="Consolas" panose="020B0609020204030204" pitchFamily="49" charset="0"/>
+              </a:rPr>
+              <a:t> de </a:t>
+            </a:r>
+            <a:r>
+              <a:rPr lang="en-US" sz="1400" dirty="0" err="1">
+                <a:latin typeface="Consolas" panose="020B0609020204030204" pitchFamily="49" charset="0"/>
+              </a:rPr>
+              <a:t>comparaison</a:t>
+            </a:r>
+            <a:r>
+              <a:rPr lang="en-US" sz="1400" dirty="0">
+                <a:latin typeface="Consolas" panose="020B0609020204030204" pitchFamily="49" charset="0"/>
+              </a:rPr>
+              <a:t> et les </a:t>
+            </a:r>
+            <a:r>
+              <a:rPr lang="en-US" sz="1400" dirty="0" err="1">
+                <a:latin typeface="Consolas" panose="020B0609020204030204" pitchFamily="49" charset="0"/>
+              </a:rPr>
+              <a:t>opérateurs</a:t>
+            </a:r>
+            <a:r>
+              <a:rPr lang="en-US" sz="1400" dirty="0">
+                <a:latin typeface="Consolas" panose="020B0609020204030204" pitchFamily="49" charset="0"/>
+              </a:rPr>
+              <a:t> </a:t>
+            </a:r>
+            <a:r>
+              <a:rPr lang="en-US" sz="1400" dirty="0" err="1">
+                <a:latin typeface="Consolas" panose="020B0609020204030204" pitchFamily="49" charset="0"/>
+              </a:rPr>
+              <a:t>logiques</a:t>
+            </a:r>
+            <a:endParaRPr lang="en-US" sz="1400" dirty="0">
+              <a:latin typeface="Consolas" panose="020B0609020204030204" pitchFamily="49" charset="0"/>
+            </a:endParaRPr>
+          </a:p>
+          <a:p>
+            <a:pPr marL="457200" lvl="1" indent="0" algn="just">
+              <a:lnSpc>
+                <a:spcPct val="100000"/>
+              </a:lnSpc>
+              <a:buNone/>
+            </a:pPr>
+            <a:endParaRPr lang="en-CA" sz="1800" dirty="0">
+              <a:latin typeface="Consolas" panose="020B0609020204030204" pitchFamily="49" charset="0"/>
+            </a:endParaRPr>
+          </a:p>
+        </p:txBody>
+      </p:sp>
+      <p:sp>
+        <p:nvSpPr>
+          <p:cNvPr id="5" name="Slide Number Placeholder 4">
+            <a:extLst>
+              <a:ext uri="{FF2B5EF4-FFF2-40B4-BE49-F238E27FC236}">
+                <a16:creationId xmlns:a16="http://schemas.microsoft.com/office/drawing/2014/main" id="{71535C36-60F1-DEEC-5D53-7AD440BDC53F}"/>
+              </a:ext>
+            </a:extLst>
+          </p:cNvPr>
+          <p:cNvSpPr>
+            <a:spLocks noGrp="1"/>
+          </p:cNvSpPr>
+          <p:nvPr>
+            <p:ph type="sldNum" sz="quarter" idx="12"/>
+          </p:nvPr>
+        </p:nvSpPr>
+        <p:spPr/>
+        <p:txBody>
+          <a:bodyPr/>
+          <a:lstStyle/>
+          <a:p>
+            <a:fld id="{846B06B1-1179-491F-A487-8E0C403F7C13}" type="slidenum">
+              <a:rPr lang="fr-CA" smtClean="0"/>
+              <a:t>24</a:t>
+            </a:fld>
+            <a:endParaRPr lang="fr-CA"/>
+          </a:p>
+        </p:txBody>
+      </p:sp>
+      <p:sp>
+        <p:nvSpPr>
+          <p:cNvPr id="6" name="TextBox 5">
+            <a:extLst>
+              <a:ext uri="{FF2B5EF4-FFF2-40B4-BE49-F238E27FC236}">
+                <a16:creationId xmlns:a16="http://schemas.microsoft.com/office/drawing/2014/main" id="{9F83F37A-7CDA-1028-C66C-6F4A4138B0F2}"/>
+              </a:ext>
+            </a:extLst>
+          </p:cNvPr>
+          <p:cNvSpPr txBox="1"/>
+          <p:nvPr/>
+        </p:nvSpPr>
+        <p:spPr>
+          <a:xfrm>
+            <a:off x="4791488" y="2800965"/>
+            <a:ext cx="2609024" cy="1200329"/>
+          </a:xfrm>
+          <a:prstGeom prst="rect">
+            <a:avLst/>
+          </a:prstGeom>
+          <a:solidFill>
+            <a:schemeClr val="bg1"/>
+          </a:solidFill>
+          <a:ln w="19050">
+            <a:solidFill>
+              <a:schemeClr val="tx1"/>
+            </a:solidFill>
+          </a:ln>
+        </p:spPr>
+        <p:txBody>
+          <a:bodyPr wrap="square" anchor="ctr">
+            <a:spAutoFit/>
+          </a:bodyPr>
+          <a:lstStyle/>
+          <a:p>
+            <a:pPr marL="0" indent="0">
+              <a:buNone/>
+            </a:pPr>
+            <a:r>
+              <a:rPr lang="en-US" b="1" dirty="0">
+                <a:latin typeface="Consolas" panose="020B0609020204030204" pitchFamily="49" charset="0"/>
+              </a:rPr>
+              <a:t>if </a:t>
+            </a:r>
+            <a:r>
+              <a:rPr lang="en-US" dirty="0">
+                <a:latin typeface="Consolas" panose="020B0609020204030204" pitchFamily="49" charset="0"/>
+              </a:rPr>
+              <a:t>condition_1</a:t>
+            </a:r>
+            <a:r>
+              <a:rPr lang="en-US" b="1" dirty="0">
+                <a:latin typeface="Consolas" panose="020B0609020204030204" pitchFamily="49" charset="0"/>
+              </a:rPr>
+              <a:t>:</a:t>
+            </a:r>
+          </a:p>
+          <a:p>
+            <a:pPr marL="0" indent="0">
+              <a:buNone/>
+            </a:pPr>
+            <a:r>
+              <a:rPr lang="en-US" b="1" dirty="0">
+                <a:latin typeface="Consolas" panose="020B0609020204030204" pitchFamily="49" charset="0"/>
+              </a:rPr>
+              <a:t>  </a:t>
+            </a:r>
+            <a:r>
+              <a:rPr lang="en-US" dirty="0">
+                <a:latin typeface="Consolas" panose="020B0609020204030204" pitchFamily="49" charset="0"/>
+              </a:rPr>
+              <a:t>instructions</a:t>
+            </a:r>
+          </a:p>
+          <a:p>
+            <a:pPr marL="0" indent="0">
+              <a:buNone/>
+            </a:pPr>
+            <a:r>
+              <a:rPr lang="en-US" b="1" dirty="0" err="1">
+                <a:latin typeface="Consolas" panose="020B0609020204030204" pitchFamily="49" charset="0"/>
+              </a:rPr>
+              <a:t>elif</a:t>
+            </a:r>
+            <a:r>
+              <a:rPr lang="en-US" b="1" dirty="0">
+                <a:latin typeface="Consolas" panose="020B0609020204030204" pitchFamily="49" charset="0"/>
+              </a:rPr>
+              <a:t> </a:t>
+            </a:r>
+            <a:r>
+              <a:rPr lang="en-US" dirty="0">
+                <a:latin typeface="Consolas" panose="020B0609020204030204" pitchFamily="49" charset="0"/>
+              </a:rPr>
+              <a:t>condition_2</a:t>
+            </a:r>
+            <a:r>
+              <a:rPr lang="en-US" b="1" dirty="0">
+                <a:latin typeface="Consolas" panose="020B0609020204030204" pitchFamily="49" charset="0"/>
+              </a:rPr>
+              <a:t>:</a:t>
+            </a:r>
+          </a:p>
+          <a:p>
+            <a:pPr marL="0" indent="0">
+              <a:buNone/>
+            </a:pPr>
+            <a:r>
+              <a:rPr lang="en-US" b="1" dirty="0">
+                <a:latin typeface="Consolas" panose="020B0609020204030204" pitchFamily="49" charset="0"/>
+              </a:rPr>
+              <a:t>  </a:t>
+            </a:r>
+            <a:r>
+              <a:rPr lang="en-US" dirty="0">
+                <a:latin typeface="Consolas" panose="020B0609020204030204" pitchFamily="49" charset="0"/>
+              </a:rPr>
+              <a:t>instructions</a:t>
+            </a:r>
+          </a:p>
+        </p:txBody>
+      </p:sp>
+    </p:spTree>
+    <p:extLst>
+      <p:ext uri="{BB962C8B-B14F-4D97-AF65-F5344CB8AC3E}">
+        <p14:creationId xmlns:p14="http://schemas.microsoft.com/office/powerpoint/2010/main" val="3135586547"/>
+      </p:ext>
+    </p:extLst>
+  </p:cSld>
+  <p:clrMapOvr>
+    <a:masterClrMapping/>
+  </p:clrMapOvr>
+</p:sld>
+</file>
+
+<file path=ppt/slides/slide25.xml><?xml version="1.0" encoding="utf-8"?>
 <p:sld xmlns:a="http://schemas.openxmlformats.org/drawingml/2006/main" xmlns:r="http://schemas.openxmlformats.org/officeDocument/2006/relationships" xmlns:p="http://schemas.openxmlformats.org/presentationml/2006/main">
   <p:cSld>
     <p:bg>
@@ -15605,7 +16889,7 @@
           <a:p>
             <a:fld id="{846B06B1-1179-491F-A487-8E0C403F7C13}" type="slidenum">
               <a:rPr lang="fr-CA" smtClean="0"/>
-              <a:t>23</a:t>
+              <a:t>25</a:t>
             </a:fld>
             <a:endParaRPr lang="fr-CA"/>
           </a:p>
@@ -15924,7 +17208,7 @@
 </p:sld>
 </file>
 
-<file path=ppt/slides/slide24.xml><?xml version="1.0" encoding="utf-8"?>
+<file path=ppt/slides/slide26.xml><?xml version="1.0" encoding="utf-8"?>
 <p:sld xmlns:a="http://schemas.openxmlformats.org/drawingml/2006/main" xmlns:r="http://schemas.openxmlformats.org/officeDocument/2006/relationships" xmlns:p="http://schemas.openxmlformats.org/presentationml/2006/main">
   <p:cSld>
     <p:bg>
@@ -16085,7 +17369,7 @@
           <a:p>
             <a:fld id="{846B06B1-1179-491F-A487-8E0C403F7C13}" type="slidenum">
               <a:rPr lang="fr-CA" smtClean="0"/>
-              <a:t>24</a:t>
+              <a:t>26</a:t>
             </a:fld>
             <a:endParaRPr lang="fr-CA"/>
           </a:p>
@@ -16404,7 +17688,7 @@
 </p:sld>
 </file>
 
-<file path=ppt/slides/slide25.xml><?xml version="1.0" encoding="utf-8"?>
+<file path=ppt/slides/slide27.xml><?xml version="1.0" encoding="utf-8"?>
 <p:sld xmlns:a="http://schemas.openxmlformats.org/drawingml/2006/main" xmlns:r="http://schemas.openxmlformats.org/officeDocument/2006/relationships" xmlns:p="http://schemas.openxmlformats.org/presentationml/2006/main">
   <p:cSld>
     <p:bg>
@@ -16493,7 +17777,7 @@
           <a:p>
             <a:fld id="{846B06B1-1179-491F-A487-8E0C403F7C13}" type="slidenum">
               <a:rPr lang="fr-CA" smtClean="0"/>
-              <a:t>25</a:t>
+              <a:t>27</a:t>
             </a:fld>
             <a:endParaRPr lang="fr-CA"/>
           </a:p>
@@ -20994,9 +22278,9 @@
         <p:grpSpPr>
           <a:xfrm>
             <a:off x="7723773" y="4165699"/>
-            <a:ext cx="4082040" cy="369332"/>
+            <a:ext cx="3498291" cy="369332"/>
             <a:chOff x="6485106" y="4913563"/>
-            <a:chExt cx="4082040" cy="369332"/>
+            <a:chExt cx="3498291" cy="369332"/>
           </a:xfrm>
         </p:grpSpPr>
         <p:sp>
@@ -21014,7 +22298,7 @@
           <p:spPr>
             <a:xfrm>
               <a:off x="7309395" y="4913563"/>
-              <a:ext cx="3257751" cy="369332"/>
+              <a:ext cx="2674002" cy="369332"/>
             </a:xfrm>
             <a:prstGeom prst="rect">
               <a:avLst/>
@@ -21029,15 +22313,7 @@
             <a:p>
               <a:r>
                 <a:rPr lang="en-US" b="1" dirty="0"/>
-                <a:t>Corps </a:t>
-              </a:r>
-              <a:r>
-                <a:rPr lang="en-US" b="1" dirty="0" err="1"/>
-                <a:t>contenant</a:t>
-              </a:r>
-              <a:r>
-                <a:rPr lang="en-US" b="1" dirty="0"/>
-                <a:t> instructions</a:t>
+                <a:t>Corps avec instructions</a:t>
               </a:r>
               <a:endParaRPr lang="fr-CA" b="1" dirty="0"/>
             </a:p>

</xml_diff>

<commit_message>
feat: Complete python_1 presentation up to slide no.24
</commit_message>
<xml_diff>
--- a/python_1/presentation_python_1.pptx
+++ b/python_1/presentation_python_1.pptx
@@ -31,7 +31,7 @@
     <p:sldId id="283" r:id="rId22"/>
     <p:sldId id="280" r:id="rId23"/>
     <p:sldId id="286" r:id="rId24"/>
-    <p:sldId id="284" r:id="rId25"/>
+    <p:sldId id="287" r:id="rId25"/>
     <p:sldId id="279" r:id="rId26"/>
     <p:sldId id="281" r:id="rId27"/>
     <p:sldId id="270" r:id="rId28"/>
@@ -223,7 +223,7 @@
           <a:p>
             <a:fld id="{17426931-AE65-4D08-8B32-62FCBDE55937}" type="datetimeFigureOut">
               <a:rPr lang="fr-CA" smtClean="0"/>
-              <a:t>2026-04-12</a:t>
+              <a:t>2026-04-13</a:t>
             </a:fld>
             <a:endParaRPr lang="fr-CA"/>
           </a:p>
@@ -640,7 +640,7 @@
           <a:p>
             <a:fld id="{73720E39-F9E6-45F4-9AF3-0670893E0E05}" type="datetime1">
               <a:rPr lang="fr-CA" smtClean="0"/>
-              <a:t>2026-04-12</a:t>
+              <a:t>2026-04-13</a:t>
             </a:fld>
             <a:endParaRPr lang="fr-CA"/>
           </a:p>
@@ -840,7 +840,7 @@
           <a:p>
             <a:fld id="{2A86A87F-FCE1-414B-898E-E056954DFB53}" type="datetime1">
               <a:rPr lang="fr-CA" smtClean="0"/>
-              <a:t>2026-04-12</a:t>
+              <a:t>2026-04-13</a:t>
             </a:fld>
             <a:endParaRPr lang="fr-CA"/>
           </a:p>
@@ -1050,7 +1050,7 @@
           <a:p>
             <a:fld id="{86217A25-A768-4FB5-8838-4C76F4A4D771}" type="datetime1">
               <a:rPr lang="fr-CA" smtClean="0"/>
-              <a:t>2026-04-12</a:t>
+              <a:t>2026-04-13</a:t>
             </a:fld>
             <a:endParaRPr lang="fr-CA"/>
           </a:p>
@@ -1250,7 +1250,7 @@
           <a:p>
             <a:fld id="{6DF5E9B1-F4B4-44A9-8978-A50A0AD8373C}" type="datetime1">
               <a:rPr lang="fr-CA" smtClean="0"/>
-              <a:t>2026-04-12</a:t>
+              <a:t>2026-04-13</a:t>
             </a:fld>
             <a:endParaRPr lang="fr-CA"/>
           </a:p>
@@ -1526,7 +1526,7 @@
           <a:p>
             <a:fld id="{5DE8FE0D-E91C-47AE-8B70-2B0ABA5D1B1E}" type="datetime1">
               <a:rPr lang="fr-CA" smtClean="0"/>
-              <a:t>2026-04-12</a:t>
+              <a:t>2026-04-13</a:t>
             </a:fld>
             <a:endParaRPr lang="fr-CA"/>
           </a:p>
@@ -1794,7 +1794,7 @@
           <a:p>
             <a:fld id="{F3AB8F30-8420-4011-A9ED-ED2F47883C93}" type="datetime1">
               <a:rPr lang="fr-CA" smtClean="0"/>
-              <a:t>2026-04-12</a:t>
+              <a:t>2026-04-13</a:t>
             </a:fld>
             <a:endParaRPr lang="fr-CA"/>
           </a:p>
@@ -2209,7 +2209,7 @@
           <a:p>
             <a:fld id="{852876F1-672F-46E4-BC46-E9D4C880BFEF}" type="datetime1">
               <a:rPr lang="fr-CA" smtClean="0"/>
-              <a:t>2026-04-12</a:t>
+              <a:t>2026-04-13</a:t>
             </a:fld>
             <a:endParaRPr lang="fr-CA"/>
           </a:p>
@@ -2351,7 +2351,7 @@
           <a:p>
             <a:fld id="{05494588-57AE-4A88-AA7D-14590C8ABB1D}" type="datetime1">
               <a:rPr lang="fr-CA" smtClean="0"/>
-              <a:t>2026-04-12</a:t>
+              <a:t>2026-04-13</a:t>
             </a:fld>
             <a:endParaRPr lang="fr-CA"/>
           </a:p>
@@ -2464,7 +2464,7 @@
           <a:p>
             <a:fld id="{70596107-F84A-4D89-B7EE-30826EF0EE70}" type="datetime1">
               <a:rPr lang="fr-CA" smtClean="0"/>
-              <a:t>2026-04-12</a:t>
+              <a:t>2026-04-13</a:t>
             </a:fld>
             <a:endParaRPr lang="fr-CA"/>
           </a:p>
@@ -2777,7 +2777,7 @@
           <a:p>
             <a:fld id="{12C269CA-6797-4965-A975-3F40F12DAD06}" type="datetime1">
               <a:rPr lang="fr-CA" smtClean="0"/>
-              <a:t>2026-04-12</a:t>
+              <a:t>2026-04-13</a:t>
             </a:fld>
             <a:endParaRPr lang="fr-CA"/>
           </a:p>
@@ -3066,7 +3066,7 @@
           <a:p>
             <a:fld id="{3F5AE234-69D2-4522-AB7A-F911A65753A0}" type="datetime1">
               <a:rPr lang="fr-CA" smtClean="0"/>
-              <a:t>2026-04-12</a:t>
+              <a:t>2026-04-13</a:t>
             </a:fld>
             <a:endParaRPr lang="fr-CA"/>
           </a:p>
@@ -3309,7 +3309,7 @@
           <a:p>
             <a:fld id="{30546B8D-50B2-4CF7-ACAA-221A68F8C882}" type="datetime1">
               <a:rPr lang="fr-CA" smtClean="0"/>
-              <a:t>2026-04-12</a:t>
+              <a:t>2026-04-13</a:t>
             </a:fld>
             <a:endParaRPr lang="fr-CA"/>
           </a:p>
@@ -13694,8 +13694,8 @@
           </a:p>
         </p:txBody>
       </p:sp>
-      <mc:AlternateContent xmlns:mc="http://schemas.openxmlformats.org/markup-compatibility/2006">
-        <mc:Choice xmlns:a14="http://schemas.microsoft.com/office/drawing/2010/main" Requires="a14">
+      <mc:AlternateContent xmlns:mc="http://schemas.openxmlformats.org/markup-compatibility/2006" xmlns:a14="http://schemas.microsoft.com/office/drawing/2010/main">
+        <mc:Choice Requires="a14">
           <p:sp>
             <p:nvSpPr>
               <p:cNvPr id="3" name="Content Placeholder 2">
@@ -14143,7 +14143,7 @@
             </p:txBody>
           </p:sp>
         </mc:Choice>
-        <mc:Fallback>
+        <mc:Fallback xmlns="">
           <p:sp>
             <p:nvSpPr>
               <p:cNvPr id="3" name="Content Placeholder 2">
@@ -14604,8 +14604,8 @@
           </a:p>
         </p:txBody>
       </p:sp>
-      <mc:AlternateContent xmlns:mc="http://schemas.openxmlformats.org/markup-compatibility/2006">
-        <mc:Choice xmlns:a14="http://schemas.microsoft.com/office/drawing/2010/main" Requires="a14">
+      <mc:AlternateContent xmlns:mc="http://schemas.openxmlformats.org/markup-compatibility/2006" xmlns:a14="http://schemas.microsoft.com/office/drawing/2010/main">
+        <mc:Choice Requires="a14">
           <p:sp>
             <p:nvSpPr>
               <p:cNvPr id="3" name="Content Placeholder 2">
@@ -14906,7 +14906,7 @@
             </p:txBody>
           </p:sp>
         </mc:Choice>
-        <mc:Fallback>
+        <mc:Fallback xmlns="">
           <p:sp>
             <p:nvSpPr>
               <p:cNvPr id="3" name="Content Placeholder 2">
@@ -15044,7 +15044,7 @@
               <a:rPr lang="en-US" dirty="0">
                 <a:latin typeface="Arial Rounded MT Bold" panose="020F0704030504030204" pitchFamily="34" charset="0"/>
               </a:rPr>
-              <a:t>Choix [1/3]</a:t>
+              <a:t>Choix: SI</a:t>
             </a:r>
             <a:endParaRPr lang="fr-CA" dirty="0">
               <a:latin typeface="Arial Rounded MT Bold" panose="020F0704030504030204" pitchFamily="34" charset="0"/>
@@ -15075,364 +15075,142 @@
           </a:bodyPr>
           <a:lstStyle/>
           <a:p>
+            <a:pPr algn="just">
+              <a:lnSpc>
+                <a:spcPct val="100000"/>
+              </a:lnSpc>
+            </a:pPr>
+            <a:r>
+              <a:rPr lang="en-CA" sz="2200" dirty="0">
+                <a:latin typeface="Consolas" panose="020B0609020204030204" pitchFamily="49" charset="0"/>
+              </a:rPr>
+              <a:t>E</a:t>
+            </a:r>
+            <a:r>
+              <a:rPr lang="fr-CA" sz="2200" dirty="0">
+                <a:latin typeface="Consolas" panose="020B0609020204030204" pitchFamily="49" charset="0"/>
+              </a:rPr>
+              <a:t>x</a:t>
+            </a:r>
+            <a:r>
+              <a:rPr lang="en-US" sz="2200" dirty="0" err="1">
+                <a:latin typeface="Consolas" panose="020B0609020204030204" pitchFamily="49" charset="0"/>
+              </a:rPr>
+              <a:t>écuter</a:t>
+            </a:r>
+            <a:r>
+              <a:rPr lang="en-US" sz="2200" dirty="0">
+                <a:latin typeface="Consolas" panose="020B0609020204030204" pitchFamily="49" charset="0"/>
+              </a:rPr>
+              <a:t> du code </a:t>
+            </a:r>
+            <a:r>
+              <a:rPr lang="en-US" sz="2200" dirty="0" err="1">
+                <a:latin typeface="Consolas" panose="020B0609020204030204" pitchFamily="49" charset="0"/>
+              </a:rPr>
+              <a:t>si</a:t>
+            </a:r>
+            <a:r>
+              <a:rPr lang="en-US" sz="2200" dirty="0">
+                <a:latin typeface="Consolas" panose="020B0609020204030204" pitchFamily="49" charset="0"/>
+              </a:rPr>
+              <a:t> </a:t>
+            </a:r>
+            <a:r>
+              <a:rPr lang="en-US" sz="2200" dirty="0" err="1">
+                <a:latin typeface="Consolas" panose="020B0609020204030204" pitchFamily="49" charset="0"/>
+              </a:rPr>
+              <a:t>une</a:t>
+            </a:r>
+            <a:r>
+              <a:rPr lang="en-US" sz="2200" dirty="0">
+                <a:latin typeface="Consolas" panose="020B0609020204030204" pitchFamily="49" charset="0"/>
+              </a:rPr>
+              <a:t> condition est </a:t>
+            </a:r>
+            <a:r>
+              <a:rPr lang="en-US" sz="2200" dirty="0" err="1">
+                <a:latin typeface="Consolas" panose="020B0609020204030204" pitchFamily="49" charset="0"/>
+              </a:rPr>
+              <a:t>vraie</a:t>
+            </a:r>
+            <a:endParaRPr lang="en-US" sz="2200" dirty="0">
+              <a:latin typeface="Consolas" panose="020B0609020204030204" pitchFamily="49" charset="0"/>
+            </a:endParaRPr>
+          </a:p>
+          <a:p>
             <a:pPr lvl="1" algn="just">
               <a:lnSpc>
                 <a:spcPct val="100000"/>
               </a:lnSpc>
             </a:pPr>
             <a:r>
-              <a:rPr lang="en-CA" sz="1800" dirty="0">
-                <a:latin typeface="Consolas" panose="020B0609020204030204" pitchFamily="49" charset="0"/>
-              </a:rPr>
-              <a:t>E</a:t>
-            </a:r>
-            <a:r>
-              <a:rPr lang="fr-CA" sz="1800" dirty="0">
-                <a:latin typeface="Consolas" panose="020B0609020204030204" pitchFamily="49" charset="0"/>
-              </a:rPr>
-              <a:t>x</a:t>
-            </a:r>
-            <a:r>
               <a:rPr lang="en-US" sz="1800" dirty="0" err="1">
                 <a:latin typeface="Consolas" panose="020B0609020204030204" pitchFamily="49" charset="0"/>
               </a:rPr>
-              <a:t>écuter</a:t>
+              <a:t>Implique</a:t>
             </a:r>
             <a:r>
               <a:rPr lang="en-US" sz="1800" dirty="0">
                 <a:latin typeface="Consolas" panose="020B0609020204030204" pitchFamily="49" charset="0"/>
               </a:rPr>
-              <a:t> du code </a:t>
+              <a:t> </a:t>
             </a:r>
             <a:r>
               <a:rPr lang="en-US" sz="1800" dirty="0" err="1">
                 <a:latin typeface="Consolas" panose="020B0609020204030204" pitchFamily="49" charset="0"/>
               </a:rPr>
-              <a:t>si</a:t>
+              <a:t>généralement</a:t>
             </a:r>
             <a:r>
               <a:rPr lang="en-US" sz="1800" dirty="0">
                 <a:latin typeface="Consolas" panose="020B0609020204030204" pitchFamily="49" charset="0"/>
               </a:rPr>
+              <a:t> les </a:t>
+            </a:r>
+            <a:r>
+              <a:rPr lang="en-US" sz="1800" b="1" dirty="0" err="1">
+                <a:latin typeface="Consolas" panose="020B0609020204030204" pitchFamily="49" charset="0"/>
+              </a:rPr>
+              <a:t>opérateurs</a:t>
+            </a:r>
+            <a:r>
+              <a:rPr lang="en-US" sz="1800" b="1" dirty="0">
+                <a:latin typeface="Consolas" panose="020B0609020204030204" pitchFamily="49" charset="0"/>
+              </a:rPr>
+              <a:t> de </a:t>
+            </a:r>
+            <a:r>
+              <a:rPr lang="en-US" sz="1800" b="1" dirty="0" err="1">
+                <a:latin typeface="Consolas" panose="020B0609020204030204" pitchFamily="49" charset="0"/>
+              </a:rPr>
+              <a:t>comparaison</a:t>
+            </a:r>
+            <a:r>
+              <a:rPr lang="en-US" sz="1800" dirty="0">
+                <a:latin typeface="Consolas" panose="020B0609020204030204" pitchFamily="49" charset="0"/>
+              </a:rPr>
+              <a:t> et les </a:t>
+            </a:r>
+            <a:r>
+              <a:rPr lang="en-US" sz="1800" b="1" dirty="0" err="1">
+                <a:latin typeface="Consolas" panose="020B0609020204030204" pitchFamily="49" charset="0"/>
+              </a:rPr>
+              <a:t>opérateurs</a:t>
+            </a:r>
+            <a:r>
+              <a:rPr lang="en-US" sz="1800" b="1" dirty="0">
+                <a:latin typeface="Consolas" panose="020B0609020204030204" pitchFamily="49" charset="0"/>
+              </a:rPr>
               <a:t> </a:t>
             </a:r>
             <a:r>
-              <a:rPr lang="en-US" sz="1800" dirty="0" err="1">
-                <a:latin typeface="Consolas" panose="020B0609020204030204" pitchFamily="49" charset="0"/>
-              </a:rPr>
-              <a:t>une</a:t>
-            </a:r>
-            <a:r>
-              <a:rPr lang="en-US" sz="1800" dirty="0">
-                <a:latin typeface="Consolas" panose="020B0609020204030204" pitchFamily="49" charset="0"/>
-              </a:rPr>
-              <a:t> condition est </a:t>
-            </a:r>
-            <a:r>
-              <a:rPr lang="en-US" sz="1800" dirty="0" err="1">
-                <a:latin typeface="Consolas" panose="020B0609020204030204" pitchFamily="49" charset="0"/>
-              </a:rPr>
-              <a:t>vraie</a:t>
-            </a:r>
-            <a:r>
-              <a:rPr lang="en-US" sz="1800" dirty="0">
-                <a:latin typeface="Consolas" panose="020B0609020204030204" pitchFamily="49" charset="0"/>
-              </a:rPr>
-              <a:t> (c.-à-d. </a:t>
-            </a:r>
-            <a:r>
               <a:rPr lang="en-US" sz="1800" b="1" dirty="0" err="1">
                 <a:latin typeface="Consolas" panose="020B0609020204030204" pitchFamily="49" charset="0"/>
               </a:rPr>
-              <a:t>égale</a:t>
-            </a:r>
-            <a:r>
-              <a:rPr lang="en-US" sz="1800" b="1" dirty="0">
-                <a:latin typeface="Consolas" panose="020B0609020204030204" pitchFamily="49" charset="0"/>
-              </a:rPr>
-              <a:t> à True</a:t>
-            </a:r>
-            <a:r>
-              <a:rPr lang="en-US" sz="1800" dirty="0">
-                <a:latin typeface="Consolas" panose="020B0609020204030204" pitchFamily="49" charset="0"/>
-              </a:rPr>
-              <a:t>)</a:t>
-            </a:r>
-          </a:p>
-          <a:p>
-            <a:pPr lvl="2" algn="just">
-              <a:lnSpc>
-                <a:spcPct val="100000"/>
-              </a:lnSpc>
-            </a:pPr>
-            <a:r>
-              <a:rPr lang="en-US" sz="1400" dirty="0" err="1">
-                <a:latin typeface="Consolas" panose="020B0609020204030204" pitchFamily="49" charset="0"/>
-              </a:rPr>
-              <a:t>Implique</a:t>
-            </a:r>
-            <a:r>
-              <a:rPr lang="en-US" sz="1400" dirty="0">
-                <a:latin typeface="Consolas" panose="020B0609020204030204" pitchFamily="49" charset="0"/>
-              </a:rPr>
-              <a:t> </a:t>
-            </a:r>
-            <a:r>
-              <a:rPr lang="en-US" sz="1400" dirty="0" err="1">
-                <a:latin typeface="Consolas" panose="020B0609020204030204" pitchFamily="49" charset="0"/>
-              </a:rPr>
-              <a:t>généralement</a:t>
-            </a:r>
-            <a:r>
-              <a:rPr lang="en-US" sz="1400" dirty="0">
-                <a:latin typeface="Consolas" panose="020B0609020204030204" pitchFamily="49" charset="0"/>
-              </a:rPr>
-              <a:t> les </a:t>
-            </a:r>
-            <a:r>
-              <a:rPr lang="en-US" sz="1400" dirty="0" err="1">
-                <a:latin typeface="Consolas" panose="020B0609020204030204" pitchFamily="49" charset="0"/>
-              </a:rPr>
-              <a:t>opérateurs</a:t>
-            </a:r>
-            <a:r>
-              <a:rPr lang="en-US" sz="1400" dirty="0">
-                <a:latin typeface="Consolas" panose="020B0609020204030204" pitchFamily="49" charset="0"/>
-              </a:rPr>
-              <a:t> de </a:t>
-            </a:r>
-            <a:r>
-              <a:rPr lang="en-US" sz="1400" dirty="0" err="1">
-                <a:latin typeface="Consolas" panose="020B0609020204030204" pitchFamily="49" charset="0"/>
-              </a:rPr>
-              <a:t>comparaison</a:t>
-            </a:r>
-            <a:r>
-              <a:rPr lang="en-US" sz="1400" dirty="0">
-                <a:latin typeface="Consolas" panose="020B0609020204030204" pitchFamily="49" charset="0"/>
-              </a:rPr>
-              <a:t> et les </a:t>
-            </a:r>
-            <a:r>
-              <a:rPr lang="en-US" sz="1400" dirty="0" err="1">
-                <a:latin typeface="Consolas" panose="020B0609020204030204" pitchFamily="49" charset="0"/>
-              </a:rPr>
-              <a:t>opérateurs</a:t>
-            </a:r>
-            <a:r>
-              <a:rPr lang="en-US" sz="1400" dirty="0">
-                <a:latin typeface="Consolas" panose="020B0609020204030204" pitchFamily="49" charset="0"/>
-              </a:rPr>
-              <a:t> </a:t>
-            </a:r>
-            <a:r>
-              <a:rPr lang="en-US" sz="1400" dirty="0" err="1">
-                <a:latin typeface="Consolas" panose="020B0609020204030204" pitchFamily="49" charset="0"/>
-              </a:rPr>
               <a:t>logiques</a:t>
             </a:r>
-            <a:endParaRPr lang="en-US" sz="1400" dirty="0">
-              <a:latin typeface="Consolas" panose="020B0609020204030204" pitchFamily="49" charset="0"/>
-            </a:endParaRPr>
-          </a:p>
-          <a:p>
-            <a:pPr lvl="2" algn="just">
-              <a:lnSpc>
-                <a:spcPct val="100000"/>
-              </a:lnSpc>
-            </a:pPr>
-            <a:endParaRPr lang="en-US" sz="1400" dirty="0">
-              <a:latin typeface="Consolas" panose="020B0609020204030204" pitchFamily="49" charset="0"/>
-            </a:endParaRPr>
-          </a:p>
-          <a:p>
-            <a:pPr lvl="2" algn="just">
-              <a:lnSpc>
-                <a:spcPct val="100000"/>
-              </a:lnSpc>
-            </a:pPr>
-            <a:endParaRPr lang="en-US" sz="1400" dirty="0">
-              <a:latin typeface="Consolas" panose="020B0609020204030204" pitchFamily="49" charset="0"/>
-            </a:endParaRPr>
-          </a:p>
-          <a:p>
-            <a:pPr lvl="2" algn="just">
-              <a:lnSpc>
-                <a:spcPct val="100000"/>
-              </a:lnSpc>
-            </a:pPr>
-            <a:endParaRPr lang="en-US" sz="1400" dirty="0">
-              <a:latin typeface="Consolas" panose="020B0609020204030204" pitchFamily="49" charset="0"/>
-            </a:endParaRPr>
-          </a:p>
-          <a:p>
-            <a:pPr lvl="2" algn="just">
-              <a:lnSpc>
-                <a:spcPct val="100000"/>
-              </a:lnSpc>
-            </a:pPr>
-            <a:endParaRPr lang="en-US" sz="1400" dirty="0">
-              <a:latin typeface="Consolas" panose="020B0609020204030204" pitchFamily="49" charset="0"/>
-            </a:endParaRPr>
-          </a:p>
-          <a:p>
-            <a:pPr lvl="2" algn="just">
-              <a:lnSpc>
-                <a:spcPct val="100000"/>
-              </a:lnSpc>
-            </a:pPr>
-            <a:endParaRPr lang="en-US" sz="1400" dirty="0">
-              <a:latin typeface="Consolas" panose="020B0609020204030204" pitchFamily="49" charset="0"/>
-            </a:endParaRPr>
-          </a:p>
-          <a:p>
-            <a:pPr lvl="2" algn="just">
-              <a:lnSpc>
-                <a:spcPct val="100000"/>
-              </a:lnSpc>
-            </a:pPr>
-            <a:endParaRPr lang="en-US" sz="1400" dirty="0">
-              <a:latin typeface="Consolas" panose="020B0609020204030204" pitchFamily="49" charset="0"/>
-            </a:endParaRPr>
-          </a:p>
-          <a:p>
-            <a:pPr marL="914400" lvl="2" indent="0" algn="just">
-              <a:lnSpc>
-                <a:spcPct val="100000"/>
-              </a:lnSpc>
-              <a:buNone/>
-            </a:pPr>
-            <a:r>
-              <a:rPr lang="en-CA" sz="1400" b="1" dirty="0">
-                <a:latin typeface="Consolas" panose="020B0609020204030204" pitchFamily="49" charset="0"/>
-              </a:rPr>
-              <a:t>&gt;&gt;&gt; </a:t>
-            </a:r>
-            <a:r>
-              <a:rPr lang="en-CA" sz="1400" b="1" dirty="0" err="1">
-                <a:latin typeface="Consolas" panose="020B0609020204030204" pitchFamily="49" charset="0"/>
-              </a:rPr>
-              <a:t>valeur</a:t>
-            </a:r>
-            <a:r>
-              <a:rPr lang="en-CA" sz="1400" b="1" dirty="0">
-                <a:latin typeface="Consolas" panose="020B0609020204030204" pitchFamily="49" charset="0"/>
-              </a:rPr>
-              <a:t> = 10</a:t>
-            </a:r>
-          </a:p>
-          <a:p>
-            <a:pPr marL="914400" lvl="2" indent="0" algn="just">
-              <a:lnSpc>
-                <a:spcPct val="100000"/>
-              </a:lnSpc>
-              <a:buNone/>
-            </a:pPr>
-            <a:r>
-              <a:rPr lang="en-CA" sz="1400" b="1" dirty="0">
-                <a:latin typeface="Consolas" panose="020B0609020204030204" pitchFamily="49" charset="0"/>
-              </a:rPr>
-              <a:t>&gt;&gt;&gt; if </a:t>
-            </a:r>
-            <a:r>
-              <a:rPr lang="en-CA" sz="1400" b="1" dirty="0" err="1">
-                <a:latin typeface="Consolas" panose="020B0609020204030204" pitchFamily="49" charset="0"/>
-              </a:rPr>
-              <a:t>valeur</a:t>
-            </a:r>
-            <a:r>
-              <a:rPr lang="en-CA" sz="1400" b="1" dirty="0">
-                <a:latin typeface="Consolas" panose="020B0609020204030204" pitchFamily="49" charset="0"/>
-              </a:rPr>
-              <a:t> % 2 == 0:</a:t>
-            </a:r>
-          </a:p>
-          <a:p>
-            <a:pPr marL="914400" lvl="2" indent="0" algn="just">
-              <a:lnSpc>
-                <a:spcPct val="100000"/>
-              </a:lnSpc>
-              <a:buNone/>
-            </a:pPr>
-            <a:r>
-              <a:rPr lang="en-CA" sz="1400" b="1" dirty="0">
-                <a:latin typeface="Consolas" panose="020B0609020204030204" pitchFamily="49" charset="0"/>
-              </a:rPr>
-              <a:t>...   print("Le </a:t>
-            </a:r>
-            <a:r>
-              <a:rPr lang="en-CA" sz="1400" b="1" dirty="0" err="1">
-                <a:latin typeface="Consolas" panose="020B0609020204030204" pitchFamily="49" charset="0"/>
-              </a:rPr>
-              <a:t>nombre</a:t>
-            </a:r>
-            <a:r>
-              <a:rPr lang="en-CA" sz="1400" b="1" dirty="0">
-                <a:latin typeface="Consolas" panose="020B0609020204030204" pitchFamily="49" charset="0"/>
-              </a:rPr>
-              <a:t>", </a:t>
-            </a:r>
-            <a:r>
-              <a:rPr lang="en-CA" sz="1400" b="1" dirty="0" err="1">
-                <a:latin typeface="Consolas" panose="020B0609020204030204" pitchFamily="49" charset="0"/>
-              </a:rPr>
-              <a:t>valeur</a:t>
-            </a:r>
-            <a:r>
-              <a:rPr lang="en-CA" sz="1400" b="1" dirty="0">
-                <a:latin typeface="Consolas" panose="020B0609020204030204" pitchFamily="49" charset="0"/>
-              </a:rPr>
-              <a:t>, "est pair")</a:t>
-            </a:r>
-          </a:p>
-          <a:p>
-            <a:pPr marL="914400" lvl="2" indent="0" algn="just">
-              <a:lnSpc>
-                <a:spcPct val="100000"/>
-              </a:lnSpc>
-              <a:buNone/>
-            </a:pPr>
-            <a:r>
-              <a:rPr lang="en-CA" sz="1400" dirty="0">
-                <a:solidFill>
-                  <a:schemeClr val="bg1">
-                    <a:lumMod val="50000"/>
-                  </a:schemeClr>
-                </a:solidFill>
-                <a:latin typeface="Consolas" panose="020B0609020204030204" pitchFamily="49" charset="0"/>
-              </a:rPr>
-              <a:t>Le </a:t>
-            </a:r>
-            <a:r>
-              <a:rPr lang="en-CA" sz="1400" dirty="0" err="1">
-                <a:solidFill>
-                  <a:schemeClr val="bg1">
-                    <a:lumMod val="50000"/>
-                  </a:schemeClr>
-                </a:solidFill>
-                <a:latin typeface="Consolas" panose="020B0609020204030204" pitchFamily="49" charset="0"/>
-              </a:rPr>
-              <a:t>nombre</a:t>
-            </a:r>
-            <a:r>
-              <a:rPr lang="en-CA" sz="1400" dirty="0">
-                <a:solidFill>
-                  <a:schemeClr val="bg1">
-                    <a:lumMod val="50000"/>
-                  </a:schemeClr>
-                </a:solidFill>
-                <a:latin typeface="Consolas" panose="020B0609020204030204" pitchFamily="49" charset="0"/>
-              </a:rPr>
-              <a:t> 10 est pair</a:t>
-            </a:r>
-          </a:p>
-          <a:p>
-            <a:pPr lvl="1" algn="just">
-              <a:lnSpc>
-                <a:spcPct val="100000"/>
-              </a:lnSpc>
-            </a:pPr>
-            <a:endParaRPr lang="en-US" sz="1800" dirty="0">
+            <a:endParaRPr lang="en-US" sz="1800" b="1" dirty="0">
               <a:latin typeface="Consolas" panose="020B0609020204030204" pitchFamily="49" charset="0"/>
             </a:endParaRPr>
           </a:p>
@@ -15443,9 +15221,140 @@
               </a:lnSpc>
               <a:buNone/>
             </a:pPr>
-            <a:endParaRPr lang="en-CA" sz="1800" dirty="0">
+            <a:endParaRPr lang="en-US" sz="2200" dirty="0">
               <a:latin typeface="Consolas" panose="020B0609020204030204" pitchFamily="49" charset="0"/>
             </a:endParaRPr>
+          </a:p>
+          <a:p>
+            <a:pPr marL="457200" lvl="1" indent="0" algn="just">
+              <a:lnSpc>
+                <a:spcPct val="100000"/>
+              </a:lnSpc>
+              <a:buNone/>
+            </a:pPr>
+            <a:r>
+              <a:rPr lang="en-CA" sz="1200" b="1" dirty="0">
+                <a:latin typeface="Consolas" panose="020B0609020204030204" pitchFamily="49" charset="0"/>
+              </a:rPr>
+              <a:t>&gt;&gt;&gt; </a:t>
+            </a:r>
+            <a:r>
+              <a:rPr lang="en-CA" sz="1200" b="1" dirty="0" err="1">
+                <a:latin typeface="Consolas" panose="020B0609020204030204" pitchFamily="49" charset="0"/>
+              </a:rPr>
+              <a:t>valeur</a:t>
+            </a:r>
+            <a:r>
+              <a:rPr lang="en-CA" sz="1200" b="1" dirty="0">
+                <a:latin typeface="Consolas" panose="020B0609020204030204" pitchFamily="49" charset="0"/>
+              </a:rPr>
+              <a:t> = 10</a:t>
+            </a:r>
+          </a:p>
+          <a:p>
+            <a:pPr marL="457200" lvl="1" indent="0" algn="just">
+              <a:lnSpc>
+                <a:spcPct val="100000"/>
+              </a:lnSpc>
+              <a:buNone/>
+            </a:pPr>
+            <a:r>
+              <a:rPr lang="en-CA" sz="1200" b="1" dirty="0">
+                <a:latin typeface="Consolas" panose="020B0609020204030204" pitchFamily="49" charset="0"/>
+              </a:rPr>
+              <a:t>&gt;&gt;&gt; if </a:t>
+            </a:r>
+            <a:r>
+              <a:rPr lang="en-CA" sz="1200" b="1" dirty="0" err="1">
+                <a:latin typeface="Consolas" panose="020B0609020204030204" pitchFamily="49" charset="0"/>
+              </a:rPr>
+              <a:t>valeur</a:t>
+            </a:r>
+            <a:r>
+              <a:rPr lang="en-CA" sz="1200" b="1" dirty="0">
+                <a:latin typeface="Consolas" panose="020B0609020204030204" pitchFamily="49" charset="0"/>
+              </a:rPr>
+              <a:t> % 2 == 0:</a:t>
+            </a:r>
+          </a:p>
+          <a:p>
+            <a:pPr marL="457200" lvl="1" indent="0" algn="just">
+              <a:lnSpc>
+                <a:spcPct val="100000"/>
+              </a:lnSpc>
+              <a:buNone/>
+            </a:pPr>
+            <a:r>
+              <a:rPr lang="en-CA" sz="1200" b="1" dirty="0">
+                <a:latin typeface="Consolas" panose="020B0609020204030204" pitchFamily="49" charset="0"/>
+              </a:rPr>
+              <a:t>...   print("Le </a:t>
+            </a:r>
+            <a:r>
+              <a:rPr lang="en-CA" sz="1200" b="1" dirty="0" err="1">
+                <a:latin typeface="Consolas" panose="020B0609020204030204" pitchFamily="49" charset="0"/>
+              </a:rPr>
+              <a:t>nombre</a:t>
+            </a:r>
+            <a:r>
+              <a:rPr lang="en-CA" sz="1200" b="1" dirty="0">
+                <a:latin typeface="Consolas" panose="020B0609020204030204" pitchFamily="49" charset="0"/>
+              </a:rPr>
+              <a:t>", </a:t>
+            </a:r>
+            <a:r>
+              <a:rPr lang="en-CA" sz="1200" b="1" dirty="0" err="1">
+                <a:latin typeface="Consolas" panose="020B0609020204030204" pitchFamily="49" charset="0"/>
+              </a:rPr>
+              <a:t>valeur</a:t>
+            </a:r>
+            <a:r>
+              <a:rPr lang="en-CA" sz="1200" b="1" dirty="0">
+                <a:latin typeface="Consolas" panose="020B0609020204030204" pitchFamily="49" charset="0"/>
+              </a:rPr>
+              <a:t>, "est pair")</a:t>
+            </a:r>
+          </a:p>
+          <a:p>
+            <a:pPr marL="457200" lvl="1" indent="0" algn="just">
+              <a:lnSpc>
+                <a:spcPct val="100000"/>
+              </a:lnSpc>
+              <a:buNone/>
+            </a:pPr>
+            <a:r>
+              <a:rPr lang="en-CA" sz="1200" dirty="0">
+                <a:solidFill>
+                  <a:schemeClr val="bg1">
+                    <a:lumMod val="50000"/>
+                  </a:schemeClr>
+                </a:solidFill>
+                <a:latin typeface="Consolas" panose="020B0609020204030204" pitchFamily="49" charset="0"/>
+              </a:rPr>
+              <a:t>Le </a:t>
+            </a:r>
+            <a:r>
+              <a:rPr lang="en-CA" sz="1200" dirty="0" err="1">
+                <a:solidFill>
+                  <a:schemeClr val="bg1">
+                    <a:lumMod val="50000"/>
+                  </a:schemeClr>
+                </a:solidFill>
+                <a:latin typeface="Consolas" panose="020B0609020204030204" pitchFamily="49" charset="0"/>
+              </a:rPr>
+              <a:t>nombre</a:t>
+            </a:r>
+            <a:r>
+              <a:rPr lang="en-CA" sz="1200" dirty="0">
+                <a:solidFill>
+                  <a:schemeClr val="bg1">
+                    <a:lumMod val="50000"/>
+                  </a:schemeClr>
+                </a:solidFill>
+                <a:latin typeface="Consolas" panose="020B0609020204030204" pitchFamily="49" charset="0"/>
+              </a:rPr>
+              <a:t> 10 est pair</a:t>
+            </a:r>
           </a:p>
         </p:txBody>
       </p:sp>
@@ -15492,7 +15401,7 @@
         </p:nvSpPr>
         <p:spPr>
           <a:xfrm>
-            <a:off x="4921693" y="2800965"/>
+            <a:off x="7436293" y="3401129"/>
             <a:ext cx="2348614" cy="1200329"/>
           </a:xfrm>
           <a:prstGeom prst="rect">
@@ -15522,7 +15431,7 @@
                 </a:solidFill>
                 <a:latin typeface="Consolas" panose="020B0609020204030204" pitchFamily="49" charset="0"/>
               </a:rPr>
-              <a:t>[instruction(s)]</a:t>
+              <a:t>[instructions]</a:t>
             </a:r>
             <a:br>
               <a:rPr lang="en-US" b="1" dirty="0">
@@ -15578,7 +15487,7 @@
                 </a:solidFill>
                 <a:latin typeface="Consolas" panose="020B0609020204030204" pitchFamily="49" charset="0"/>
               </a:rPr>
-              <a:t>[instruction(s)]</a:t>
+              <a:t>[instructions]</a:t>
             </a:r>
           </a:p>
         </p:txBody>
@@ -15652,7 +15561,7 @@
               <a:rPr lang="en-US" dirty="0">
                 <a:latin typeface="Arial Rounded MT Bold" panose="020F0704030504030204" pitchFamily="34" charset="0"/>
               </a:rPr>
-              <a:t>Choix [2/3]</a:t>
+              <a:t>Choix: SI - SINON SI</a:t>
             </a:r>
             <a:endParaRPr lang="fr-CA" dirty="0">
               <a:latin typeface="Arial Rounded MT Bold" panose="020F0704030504030204" pitchFamily="34" charset="0"/>
@@ -15683,447 +15592,47 @@
           </a:bodyPr>
           <a:lstStyle/>
           <a:p>
-            <a:pPr lvl="1" algn="just">
+            <a:pPr algn="just">
               <a:lnSpc>
                 <a:spcPct val="100000"/>
               </a:lnSpc>
             </a:pPr>
             <a:r>
-              <a:rPr lang="en-CA" sz="1800" dirty="0">
+              <a:rPr lang="en-CA" sz="2200" dirty="0">
                 <a:latin typeface="Consolas" panose="020B0609020204030204" pitchFamily="49" charset="0"/>
               </a:rPr>
               <a:t>E</a:t>
             </a:r>
             <a:r>
-              <a:rPr lang="fr-CA" sz="1800" dirty="0">
+              <a:rPr lang="fr-CA" sz="2200" dirty="0">
                 <a:latin typeface="Consolas" panose="020B0609020204030204" pitchFamily="49" charset="0"/>
               </a:rPr>
               <a:t>x</a:t>
             </a:r>
             <a:r>
-              <a:rPr lang="en-US" sz="1800" dirty="0" err="1">
+              <a:rPr lang="en-US" sz="2200" dirty="0" err="1">
                 <a:latin typeface="Consolas" panose="020B0609020204030204" pitchFamily="49" charset="0"/>
               </a:rPr>
               <a:t>écuter</a:t>
             </a:r>
             <a:r>
-              <a:rPr lang="en-US" sz="1800" dirty="0">
-                <a:latin typeface="Consolas" panose="020B0609020204030204" pitchFamily="49" charset="0"/>
-              </a:rPr>
-              <a:t> du code </a:t>
-            </a:r>
-            <a:r>
-              <a:rPr lang="en-US" sz="1800" dirty="0" err="1">
-                <a:latin typeface="Consolas" panose="020B0609020204030204" pitchFamily="49" charset="0"/>
-              </a:rPr>
-              <a:t>si</a:t>
-            </a:r>
-            <a:r>
-              <a:rPr lang="en-US" sz="1800" dirty="0">
-                <a:latin typeface="Consolas" panose="020B0609020204030204" pitchFamily="49" charset="0"/>
-              </a:rPr>
-              <a:t> </a:t>
-            </a:r>
-            <a:r>
-              <a:rPr lang="en-US" sz="1800" dirty="0" err="1">
-                <a:latin typeface="Consolas" panose="020B0609020204030204" pitchFamily="49" charset="0"/>
-              </a:rPr>
-              <a:t>une</a:t>
-            </a:r>
-            <a:r>
-              <a:rPr lang="en-US" sz="1800" dirty="0">
-                <a:latin typeface="Consolas" panose="020B0609020204030204" pitchFamily="49" charset="0"/>
-              </a:rPr>
-              <a:t> condition est </a:t>
-            </a:r>
-            <a:r>
-              <a:rPr lang="en-US" sz="1800" dirty="0" err="1">
-                <a:latin typeface="Consolas" panose="020B0609020204030204" pitchFamily="49" charset="0"/>
-              </a:rPr>
-              <a:t>vraie</a:t>
-            </a:r>
-            <a:r>
-              <a:rPr lang="en-US" sz="1800" dirty="0">
-                <a:latin typeface="Consolas" panose="020B0609020204030204" pitchFamily="49" charset="0"/>
-              </a:rPr>
-              <a:t> (c.-à-d. </a:t>
-            </a:r>
-            <a:r>
-              <a:rPr lang="en-US" sz="1800" b="1" dirty="0" err="1">
+              <a:rPr lang="en-US" sz="2200" dirty="0">
+                <a:latin typeface="Consolas" panose="020B0609020204030204" pitchFamily="49" charset="0"/>
+              </a:rPr>
+              <a:t> les instructions de la première condition </a:t>
+            </a:r>
+            <a:r>
+              <a:rPr lang="en-US" sz="2200" dirty="0" err="1">
                 <a:latin typeface="Consolas" panose="020B0609020204030204" pitchFamily="49" charset="0"/>
               </a:rPr>
               <a:t>égale</a:t>
             </a:r>
             <a:r>
-              <a:rPr lang="en-US" sz="1800" b="1" dirty="0">
-                <a:latin typeface="Consolas" panose="020B0609020204030204" pitchFamily="49" charset="0"/>
-              </a:rPr>
-              <a:t> à True</a:t>
-            </a:r>
-            <a:r>
-              <a:rPr lang="en-US" sz="1800" dirty="0">
-                <a:latin typeface="Consolas" panose="020B0609020204030204" pitchFamily="49" charset="0"/>
-              </a:rPr>
-              <a:t>)</a:t>
-            </a:r>
-          </a:p>
-          <a:p>
-            <a:pPr lvl="2" algn="just">
-              <a:lnSpc>
-                <a:spcPct val="100000"/>
-              </a:lnSpc>
-            </a:pPr>
-            <a:r>
-              <a:rPr lang="en-US" sz="1400" dirty="0" err="1">
-                <a:latin typeface="Consolas" panose="020B0609020204030204" pitchFamily="49" charset="0"/>
-              </a:rPr>
-              <a:t>Implique</a:t>
-            </a:r>
-            <a:r>
-              <a:rPr lang="en-US" sz="1400" dirty="0">
-                <a:latin typeface="Consolas" panose="020B0609020204030204" pitchFamily="49" charset="0"/>
-              </a:rPr>
-              <a:t> </a:t>
-            </a:r>
-            <a:r>
-              <a:rPr lang="en-US" sz="1400" dirty="0" err="1">
-                <a:latin typeface="Consolas" panose="020B0609020204030204" pitchFamily="49" charset="0"/>
-              </a:rPr>
-              <a:t>généralement</a:t>
-            </a:r>
-            <a:r>
-              <a:rPr lang="en-US" sz="1400" dirty="0">
-                <a:latin typeface="Consolas" panose="020B0609020204030204" pitchFamily="49" charset="0"/>
-              </a:rPr>
-              <a:t> les </a:t>
-            </a:r>
-            <a:r>
-              <a:rPr lang="en-US" sz="1400" dirty="0" err="1">
-                <a:latin typeface="Consolas" panose="020B0609020204030204" pitchFamily="49" charset="0"/>
-              </a:rPr>
-              <a:t>opérateurs</a:t>
-            </a:r>
-            <a:r>
-              <a:rPr lang="en-US" sz="1400" dirty="0">
-                <a:latin typeface="Consolas" panose="020B0609020204030204" pitchFamily="49" charset="0"/>
-              </a:rPr>
-              <a:t> de </a:t>
-            </a:r>
-            <a:r>
-              <a:rPr lang="en-US" sz="1400" dirty="0" err="1">
-                <a:latin typeface="Consolas" panose="020B0609020204030204" pitchFamily="49" charset="0"/>
-              </a:rPr>
-              <a:t>comparaison</a:t>
-            </a:r>
-            <a:r>
-              <a:rPr lang="en-US" sz="1400" dirty="0">
-                <a:latin typeface="Consolas" panose="020B0609020204030204" pitchFamily="49" charset="0"/>
-              </a:rPr>
-              <a:t> et les </a:t>
-            </a:r>
-            <a:r>
-              <a:rPr lang="en-US" sz="1400" dirty="0" err="1">
-                <a:latin typeface="Consolas" panose="020B0609020204030204" pitchFamily="49" charset="0"/>
-              </a:rPr>
-              <a:t>opérateurs</a:t>
-            </a:r>
-            <a:r>
-              <a:rPr lang="en-US" sz="1400" dirty="0">
-                <a:latin typeface="Consolas" panose="020B0609020204030204" pitchFamily="49" charset="0"/>
-              </a:rPr>
-              <a:t> </a:t>
-            </a:r>
-            <a:r>
-              <a:rPr lang="en-US" sz="1400" dirty="0" err="1">
-                <a:latin typeface="Consolas" panose="020B0609020204030204" pitchFamily="49" charset="0"/>
-              </a:rPr>
-              <a:t>logiques</a:t>
-            </a:r>
-            <a:endParaRPr lang="en-US" sz="1400" dirty="0">
-              <a:latin typeface="Consolas" panose="020B0609020204030204" pitchFamily="49" charset="0"/>
-            </a:endParaRPr>
-          </a:p>
-          <a:p>
-            <a:pPr lvl="2" algn="just">
-              <a:lnSpc>
-                <a:spcPct val="100000"/>
-              </a:lnSpc>
-            </a:pPr>
-            <a:endParaRPr lang="en-US" sz="1400" dirty="0">
-              <a:latin typeface="Consolas" panose="020B0609020204030204" pitchFamily="49" charset="0"/>
-            </a:endParaRPr>
-          </a:p>
-          <a:p>
-            <a:pPr lvl="2" algn="just">
-              <a:lnSpc>
-                <a:spcPct val="100000"/>
-              </a:lnSpc>
-            </a:pPr>
-            <a:endParaRPr lang="en-US" sz="1400" dirty="0">
-              <a:latin typeface="Consolas" panose="020B0609020204030204" pitchFamily="49" charset="0"/>
-            </a:endParaRPr>
-          </a:p>
-          <a:p>
-            <a:pPr lvl="2" algn="just">
-              <a:lnSpc>
-                <a:spcPct val="100000"/>
-              </a:lnSpc>
-            </a:pPr>
-            <a:endParaRPr lang="en-US" sz="1400" dirty="0">
-              <a:latin typeface="Consolas" panose="020B0609020204030204" pitchFamily="49" charset="0"/>
-            </a:endParaRPr>
-          </a:p>
-          <a:p>
-            <a:pPr lvl="2" algn="just">
-              <a:lnSpc>
-                <a:spcPct val="100000"/>
-              </a:lnSpc>
-            </a:pPr>
-            <a:endParaRPr lang="en-US" sz="1400" dirty="0">
-              <a:latin typeface="Consolas" panose="020B0609020204030204" pitchFamily="49" charset="0"/>
-            </a:endParaRPr>
-          </a:p>
-          <a:p>
-            <a:pPr lvl="2" algn="just">
-              <a:lnSpc>
-                <a:spcPct val="100000"/>
-              </a:lnSpc>
-            </a:pPr>
-            <a:endParaRPr lang="en-US" sz="1400" dirty="0">
-              <a:latin typeface="Consolas" panose="020B0609020204030204" pitchFamily="49" charset="0"/>
-            </a:endParaRPr>
-          </a:p>
-          <a:p>
-            <a:pPr lvl="2" algn="just">
-              <a:lnSpc>
-                <a:spcPct val="100000"/>
-              </a:lnSpc>
-            </a:pPr>
-            <a:endParaRPr lang="en-US" sz="1400" dirty="0">
-              <a:latin typeface="Consolas" panose="020B0609020204030204" pitchFamily="49" charset="0"/>
-            </a:endParaRPr>
-          </a:p>
-          <a:p>
-            <a:pPr marL="914400" lvl="2" indent="0" algn="just">
-              <a:lnSpc>
-                <a:spcPct val="100000"/>
-              </a:lnSpc>
-              <a:buNone/>
-            </a:pPr>
-            <a:br>
-              <a:rPr lang="en-CA" sz="1400" b="1" dirty="0">
-                <a:latin typeface="Consolas" panose="020B0609020204030204" pitchFamily="49" charset="0"/>
-              </a:rPr>
-            </a:br>
-            <a:r>
-              <a:rPr lang="en-CA" sz="1400" b="1" dirty="0">
-                <a:latin typeface="Consolas" panose="020B0609020204030204" pitchFamily="49" charset="0"/>
-              </a:rPr>
-              <a:t>&gt;&gt;&gt; </a:t>
-            </a:r>
-            <a:r>
-              <a:rPr lang="en-CA" sz="1400" b="1" dirty="0" err="1">
-                <a:latin typeface="Consolas" panose="020B0609020204030204" pitchFamily="49" charset="0"/>
-              </a:rPr>
-              <a:t>valeur</a:t>
-            </a:r>
-            <a:r>
-              <a:rPr lang="en-CA" sz="1400" b="1" dirty="0">
-                <a:latin typeface="Consolas" panose="020B0609020204030204" pitchFamily="49" charset="0"/>
-              </a:rPr>
-              <a:t> = 11</a:t>
-            </a:r>
-          </a:p>
-          <a:p>
-            <a:pPr marL="914400" lvl="2" indent="0" algn="just">
-              <a:lnSpc>
-                <a:spcPct val="100000"/>
-              </a:lnSpc>
-              <a:buNone/>
-            </a:pPr>
-            <a:r>
-              <a:rPr lang="en-CA" sz="1400" b="1" dirty="0">
-                <a:latin typeface="Consolas" panose="020B0609020204030204" pitchFamily="49" charset="0"/>
-              </a:rPr>
-              <a:t>&gt;&gt;&gt; if </a:t>
-            </a:r>
-            <a:r>
-              <a:rPr lang="en-CA" sz="1400" b="1" dirty="0" err="1">
-                <a:latin typeface="Consolas" panose="020B0609020204030204" pitchFamily="49" charset="0"/>
-              </a:rPr>
-              <a:t>valeur</a:t>
-            </a:r>
-            <a:r>
-              <a:rPr lang="en-CA" sz="1400" b="1" dirty="0">
-                <a:latin typeface="Consolas" panose="020B0609020204030204" pitchFamily="49" charset="0"/>
-              </a:rPr>
-              <a:t> % 2 == 0:</a:t>
-            </a:r>
-          </a:p>
-          <a:p>
-            <a:pPr marL="914400" lvl="2" indent="0" algn="just">
-              <a:lnSpc>
-                <a:spcPct val="100000"/>
-              </a:lnSpc>
-              <a:buNone/>
-            </a:pPr>
-            <a:r>
-              <a:rPr lang="en-CA" sz="1400" b="1" dirty="0">
-                <a:latin typeface="Consolas" panose="020B0609020204030204" pitchFamily="49" charset="0"/>
-              </a:rPr>
-              <a:t>...   print("La </a:t>
-            </a:r>
-            <a:r>
-              <a:rPr lang="en-CA" sz="1400" b="1" dirty="0" err="1">
-                <a:latin typeface="Consolas" panose="020B0609020204030204" pitchFamily="49" charset="0"/>
-              </a:rPr>
-              <a:t>nombre</a:t>
-            </a:r>
-            <a:r>
-              <a:rPr lang="en-CA" sz="1400" b="1" dirty="0">
-                <a:latin typeface="Consolas" panose="020B0609020204030204" pitchFamily="49" charset="0"/>
-              </a:rPr>
-              <a:t>", </a:t>
-            </a:r>
-            <a:r>
-              <a:rPr lang="en-CA" sz="1400" b="1" dirty="0" err="1">
-                <a:latin typeface="Consolas" panose="020B0609020204030204" pitchFamily="49" charset="0"/>
-              </a:rPr>
-              <a:t>valeur</a:t>
-            </a:r>
-            <a:r>
-              <a:rPr lang="en-CA" sz="1400" b="1" dirty="0">
-                <a:latin typeface="Consolas" panose="020B0609020204030204" pitchFamily="49" charset="0"/>
-              </a:rPr>
-              <a:t>, "est pair")</a:t>
-            </a:r>
-          </a:p>
-          <a:p>
-            <a:pPr marL="914400" lvl="2" indent="0" algn="just">
-              <a:lnSpc>
-                <a:spcPct val="100000"/>
-              </a:lnSpc>
-              <a:buNone/>
-            </a:pPr>
-            <a:r>
-              <a:rPr lang="en-CA" sz="1400" b="1" dirty="0">
-                <a:latin typeface="Consolas" panose="020B0609020204030204" pitchFamily="49" charset="0"/>
-              </a:rPr>
-              <a:t>... </a:t>
-            </a:r>
-            <a:r>
-              <a:rPr lang="en-CA" sz="1400" b="1" dirty="0" err="1">
-                <a:latin typeface="Consolas" panose="020B0609020204030204" pitchFamily="49" charset="0"/>
-              </a:rPr>
-              <a:t>elif</a:t>
-            </a:r>
-            <a:r>
-              <a:rPr lang="en-CA" sz="1400" b="1" dirty="0">
-                <a:latin typeface="Consolas" panose="020B0609020204030204" pitchFamily="49" charset="0"/>
-              </a:rPr>
-              <a:t> </a:t>
-            </a:r>
-            <a:r>
-              <a:rPr lang="en-CA" sz="1400" b="1" dirty="0" err="1">
-                <a:latin typeface="Consolas" panose="020B0609020204030204" pitchFamily="49" charset="0"/>
-              </a:rPr>
-              <a:t>valeur</a:t>
-            </a:r>
-            <a:r>
-              <a:rPr lang="en-CA" sz="1400" b="1" dirty="0">
-                <a:latin typeface="Consolas" panose="020B0609020204030204" pitchFamily="49" charset="0"/>
-              </a:rPr>
-              <a:t> % 2 == 1:</a:t>
-            </a:r>
-          </a:p>
-          <a:p>
-            <a:pPr marL="914400" lvl="2" indent="0" algn="just">
-              <a:lnSpc>
-                <a:spcPct val="100000"/>
-              </a:lnSpc>
-              <a:buNone/>
-            </a:pPr>
-            <a:r>
-              <a:rPr lang="en-CA" sz="1400" b="1" dirty="0">
-                <a:latin typeface="Consolas" panose="020B0609020204030204" pitchFamily="49" charset="0"/>
-              </a:rPr>
-              <a:t>...   print("Le </a:t>
-            </a:r>
-            <a:r>
-              <a:rPr lang="en-CA" sz="1400" b="1" dirty="0" err="1">
-                <a:latin typeface="Consolas" panose="020B0609020204030204" pitchFamily="49" charset="0"/>
-              </a:rPr>
-              <a:t>nombre</a:t>
-            </a:r>
-            <a:r>
-              <a:rPr lang="en-CA" sz="1400" b="1" dirty="0">
-                <a:latin typeface="Consolas" panose="020B0609020204030204" pitchFamily="49" charset="0"/>
-              </a:rPr>
-              <a:t>", </a:t>
-            </a:r>
-            <a:r>
-              <a:rPr lang="en-CA" sz="1400" b="1" dirty="0" err="1">
-                <a:latin typeface="Consolas" panose="020B0609020204030204" pitchFamily="49" charset="0"/>
-              </a:rPr>
-              <a:t>valeur</a:t>
-            </a:r>
-            <a:r>
-              <a:rPr lang="en-CA" sz="1400" b="1" dirty="0">
-                <a:latin typeface="Consolas" panose="020B0609020204030204" pitchFamily="49" charset="0"/>
-              </a:rPr>
-              <a:t>, "est impair")</a:t>
-            </a:r>
-          </a:p>
-          <a:p>
-            <a:pPr marL="914400" lvl="2" indent="0" algn="just">
-              <a:lnSpc>
-                <a:spcPct val="100000"/>
-              </a:lnSpc>
-              <a:buNone/>
-            </a:pPr>
-            <a:r>
-              <a:rPr lang="en-CA" sz="1400" dirty="0">
-                <a:solidFill>
-                  <a:schemeClr val="bg1">
-                    <a:lumMod val="50000"/>
-                  </a:schemeClr>
-                </a:solidFill>
-                <a:latin typeface="Consolas" panose="020B0609020204030204" pitchFamily="49" charset="0"/>
-              </a:rPr>
-              <a:t>Le </a:t>
-            </a:r>
-            <a:r>
-              <a:rPr lang="en-CA" sz="1400" dirty="0" err="1">
-                <a:solidFill>
-                  <a:schemeClr val="bg1">
-                    <a:lumMod val="50000"/>
-                  </a:schemeClr>
-                </a:solidFill>
-                <a:latin typeface="Consolas" panose="020B0609020204030204" pitchFamily="49" charset="0"/>
-              </a:rPr>
-              <a:t>nombre</a:t>
-            </a:r>
-            <a:r>
-              <a:rPr lang="en-CA" sz="1400" dirty="0">
-                <a:solidFill>
-                  <a:schemeClr val="bg1">
-                    <a:lumMod val="50000"/>
-                  </a:schemeClr>
-                </a:solidFill>
-                <a:latin typeface="Consolas" panose="020B0609020204030204" pitchFamily="49" charset="0"/>
-              </a:rPr>
-              <a:t> 11 est impair</a:t>
-            </a:r>
-          </a:p>
-          <a:p>
-            <a:pPr lvl="1" algn="just">
-              <a:lnSpc>
-                <a:spcPct val="100000"/>
-              </a:lnSpc>
-            </a:pPr>
-            <a:endParaRPr lang="en-US" sz="1800" dirty="0">
-              <a:latin typeface="Consolas" panose="020B0609020204030204" pitchFamily="49" charset="0"/>
-            </a:endParaRPr>
+              <a:rPr lang="en-US" sz="2200" dirty="0">
+                <a:latin typeface="Consolas" panose="020B0609020204030204" pitchFamily="49" charset="0"/>
+              </a:rPr>
+              <a:t> à True:</a:t>
+            </a:r>
           </a:p>
           <a:p>
             <a:pPr marL="457200" lvl="1" indent="0" algn="just">
@@ -16132,9 +15641,228 @@
               </a:lnSpc>
               <a:buNone/>
             </a:pPr>
-            <a:endParaRPr lang="en-CA" sz="1800" dirty="0">
+            <a:endParaRPr lang="en-CA" sz="1800" b="1" dirty="0">
               <a:latin typeface="Consolas" panose="020B0609020204030204" pitchFamily="49" charset="0"/>
             </a:endParaRPr>
+          </a:p>
+          <a:p>
+            <a:pPr marL="457200" lvl="1" indent="0" algn="just">
+              <a:lnSpc>
+                <a:spcPct val="100000"/>
+              </a:lnSpc>
+              <a:buNone/>
+            </a:pPr>
+            <a:r>
+              <a:rPr lang="en-CA" sz="1200" b="1" dirty="0">
+                <a:latin typeface="Consolas" panose="020B0609020204030204" pitchFamily="49" charset="0"/>
+              </a:rPr>
+              <a:t>&gt;&gt;&gt; </a:t>
+            </a:r>
+            <a:r>
+              <a:rPr lang="en-CA" sz="1200" b="1" dirty="0" err="1">
+                <a:latin typeface="Consolas" panose="020B0609020204030204" pitchFamily="49" charset="0"/>
+              </a:rPr>
+              <a:t>valeur</a:t>
+            </a:r>
+            <a:r>
+              <a:rPr lang="en-CA" sz="1200" b="1" dirty="0">
+                <a:latin typeface="Consolas" panose="020B0609020204030204" pitchFamily="49" charset="0"/>
+              </a:rPr>
+              <a:t> = 10</a:t>
+            </a:r>
+          </a:p>
+          <a:p>
+            <a:pPr marL="457200" lvl="1" indent="0" algn="just">
+              <a:lnSpc>
+                <a:spcPct val="100000"/>
+              </a:lnSpc>
+              <a:buNone/>
+            </a:pPr>
+            <a:r>
+              <a:rPr lang="en-CA" sz="1200" b="1" dirty="0">
+                <a:latin typeface="Consolas" panose="020B0609020204030204" pitchFamily="49" charset="0"/>
+              </a:rPr>
+              <a:t>&gt;&gt;&gt; if </a:t>
+            </a:r>
+            <a:r>
+              <a:rPr lang="en-CA" sz="1200" b="1" dirty="0" err="1">
+                <a:latin typeface="Consolas" panose="020B0609020204030204" pitchFamily="49" charset="0"/>
+              </a:rPr>
+              <a:t>valeur</a:t>
+            </a:r>
+            <a:r>
+              <a:rPr lang="en-CA" sz="1200" b="1" dirty="0">
+                <a:latin typeface="Consolas" panose="020B0609020204030204" pitchFamily="49" charset="0"/>
+              </a:rPr>
+              <a:t> % 2 == 0:</a:t>
+            </a:r>
+          </a:p>
+          <a:p>
+            <a:pPr marL="457200" lvl="1" indent="0" algn="just">
+              <a:lnSpc>
+                <a:spcPct val="100000"/>
+              </a:lnSpc>
+              <a:buNone/>
+            </a:pPr>
+            <a:r>
+              <a:rPr lang="en-CA" sz="1200" b="1" dirty="0">
+                <a:latin typeface="Consolas" panose="020B0609020204030204" pitchFamily="49" charset="0"/>
+              </a:rPr>
+              <a:t>...   print("La </a:t>
+            </a:r>
+            <a:r>
+              <a:rPr lang="en-CA" sz="1200" b="1" dirty="0" err="1">
+                <a:latin typeface="Consolas" panose="020B0609020204030204" pitchFamily="49" charset="0"/>
+              </a:rPr>
+              <a:t>nombre</a:t>
+            </a:r>
+            <a:r>
+              <a:rPr lang="en-CA" sz="1200" b="1" dirty="0">
+                <a:latin typeface="Consolas" panose="020B0609020204030204" pitchFamily="49" charset="0"/>
+              </a:rPr>
+              <a:t>", </a:t>
+            </a:r>
+            <a:r>
+              <a:rPr lang="en-CA" sz="1200" b="1" dirty="0" err="1">
+                <a:latin typeface="Consolas" panose="020B0609020204030204" pitchFamily="49" charset="0"/>
+              </a:rPr>
+              <a:t>valeur</a:t>
+            </a:r>
+            <a:r>
+              <a:rPr lang="en-CA" sz="1200" b="1" dirty="0">
+                <a:latin typeface="Consolas" panose="020B0609020204030204" pitchFamily="49" charset="0"/>
+              </a:rPr>
+              <a:t>, "est pair")</a:t>
+            </a:r>
+          </a:p>
+          <a:p>
+            <a:pPr marL="457200" lvl="1" indent="0" algn="just">
+              <a:lnSpc>
+                <a:spcPct val="100000"/>
+              </a:lnSpc>
+              <a:buNone/>
+            </a:pPr>
+            <a:r>
+              <a:rPr lang="en-CA" sz="1200" b="1" dirty="0">
+                <a:latin typeface="Consolas" panose="020B0609020204030204" pitchFamily="49" charset="0"/>
+              </a:rPr>
+              <a:t>... </a:t>
+            </a:r>
+            <a:r>
+              <a:rPr lang="en-CA" sz="1200" b="1" dirty="0" err="1">
+                <a:latin typeface="Consolas" panose="020B0609020204030204" pitchFamily="49" charset="0"/>
+              </a:rPr>
+              <a:t>elif</a:t>
+            </a:r>
+            <a:r>
+              <a:rPr lang="en-CA" sz="1200" b="1" dirty="0">
+                <a:latin typeface="Consolas" panose="020B0609020204030204" pitchFamily="49" charset="0"/>
+              </a:rPr>
+              <a:t> </a:t>
+            </a:r>
+            <a:r>
+              <a:rPr lang="en-CA" sz="1200" b="1" dirty="0" err="1">
+                <a:latin typeface="Consolas" panose="020B0609020204030204" pitchFamily="49" charset="0"/>
+              </a:rPr>
+              <a:t>valeur</a:t>
+            </a:r>
+            <a:r>
+              <a:rPr lang="en-CA" sz="1200" b="1" dirty="0">
+                <a:latin typeface="Consolas" panose="020B0609020204030204" pitchFamily="49" charset="0"/>
+              </a:rPr>
+              <a:t> &gt; 5:</a:t>
+            </a:r>
+          </a:p>
+          <a:p>
+            <a:pPr marL="457200" lvl="1" indent="0" algn="just">
+              <a:lnSpc>
+                <a:spcPct val="100000"/>
+              </a:lnSpc>
+              <a:buNone/>
+            </a:pPr>
+            <a:r>
+              <a:rPr lang="en-CA" sz="1200" b="1" dirty="0">
+                <a:latin typeface="Consolas" panose="020B0609020204030204" pitchFamily="49" charset="0"/>
+              </a:rPr>
+              <a:t>...   print("Le </a:t>
+            </a:r>
+            <a:r>
+              <a:rPr lang="en-CA" sz="1200" b="1" dirty="0" err="1">
+                <a:latin typeface="Consolas" panose="020B0609020204030204" pitchFamily="49" charset="0"/>
+              </a:rPr>
+              <a:t>nombre</a:t>
+            </a:r>
+            <a:r>
+              <a:rPr lang="en-CA" sz="1200" b="1" dirty="0">
+                <a:latin typeface="Consolas" panose="020B0609020204030204" pitchFamily="49" charset="0"/>
+              </a:rPr>
+              <a:t>", </a:t>
+            </a:r>
+            <a:r>
+              <a:rPr lang="en-CA" sz="1200" b="1" dirty="0" err="1">
+                <a:latin typeface="Consolas" panose="020B0609020204030204" pitchFamily="49" charset="0"/>
+              </a:rPr>
+              <a:t>valeur</a:t>
+            </a:r>
+            <a:r>
+              <a:rPr lang="en-CA" sz="1200" b="1" dirty="0">
+                <a:latin typeface="Consolas" panose="020B0609020204030204" pitchFamily="49" charset="0"/>
+              </a:rPr>
+              <a:t>, "est plus grand </a:t>
+            </a:r>
+            <a:r>
+              <a:rPr lang="en-CA" sz="1200" b="1" dirty="0" err="1">
+                <a:latin typeface="Consolas" panose="020B0609020204030204" pitchFamily="49" charset="0"/>
+              </a:rPr>
+              <a:t>que</a:t>
+            </a:r>
+            <a:r>
+              <a:rPr lang="en-CA" sz="1200" b="1" dirty="0">
+                <a:latin typeface="Consolas" panose="020B0609020204030204" pitchFamily="49" charset="0"/>
+              </a:rPr>
+              <a:t> 5")</a:t>
+            </a:r>
+          </a:p>
+          <a:p>
+            <a:pPr marL="457200" lvl="1" indent="0" algn="just">
+              <a:lnSpc>
+                <a:spcPct val="100000"/>
+              </a:lnSpc>
+              <a:buNone/>
+            </a:pPr>
+            <a:r>
+              <a:rPr lang="en-CA" sz="1200" dirty="0">
+                <a:solidFill>
+                  <a:schemeClr val="bg1">
+                    <a:lumMod val="50000"/>
+                  </a:schemeClr>
+                </a:solidFill>
+                <a:latin typeface="Consolas" panose="020B0609020204030204" pitchFamily="49" charset="0"/>
+              </a:rPr>
+              <a:t>Le </a:t>
+            </a:r>
+            <a:r>
+              <a:rPr lang="en-CA" sz="1200" dirty="0" err="1">
+                <a:solidFill>
+                  <a:schemeClr val="bg1">
+                    <a:lumMod val="50000"/>
+                  </a:schemeClr>
+                </a:solidFill>
+                <a:latin typeface="Consolas" panose="020B0609020204030204" pitchFamily="49" charset="0"/>
+              </a:rPr>
+              <a:t>nombre</a:t>
+            </a:r>
+            <a:r>
+              <a:rPr lang="en-CA" sz="1200" dirty="0">
+                <a:solidFill>
+                  <a:schemeClr val="bg1">
+                    <a:lumMod val="50000"/>
+                  </a:schemeClr>
+                </a:solidFill>
+                <a:latin typeface="Consolas" panose="020B0609020204030204" pitchFamily="49" charset="0"/>
+              </a:rPr>
+              <a:t> 10 est impair</a:t>
+            </a:r>
           </a:p>
         </p:txBody>
       </p:sp>
@@ -16181,8 +15909,8 @@
         </p:nvSpPr>
         <p:spPr>
           <a:xfrm>
-            <a:off x="4791488" y="2634214"/>
-            <a:ext cx="2609024" cy="1754326"/>
+            <a:off x="7437000" y="3124131"/>
+            <a:ext cx="2347200" cy="1754326"/>
           </a:xfrm>
           <a:prstGeom prst="rect">
             <a:avLst/>
@@ -16332,7 +16060,7 @@
         <p:cNvPr id="1" name="">
           <a:extLst>
             <a:ext uri="{FF2B5EF4-FFF2-40B4-BE49-F238E27FC236}">
-              <a16:creationId xmlns:a16="http://schemas.microsoft.com/office/drawing/2014/main" id="{41CAA905-3395-07D0-E9EC-F2C52DE5565E}"/>
+              <a16:creationId xmlns:a16="http://schemas.microsoft.com/office/drawing/2014/main" id="{D6F3E6CD-1F57-D8FA-B1AC-296799E36C46}"/>
             </a:ext>
           </a:extLst>
         </p:cNvPr>
@@ -16352,7 +16080,7 @@
           <p:cNvPr id="2" name="Title 1">
             <a:extLst>
               <a:ext uri="{FF2B5EF4-FFF2-40B4-BE49-F238E27FC236}">
-                <a16:creationId xmlns:a16="http://schemas.microsoft.com/office/drawing/2014/main" id="{4C0A76DD-5BE2-A84A-DBA4-4092FE7F994D}"/>
+                <a16:creationId xmlns:a16="http://schemas.microsoft.com/office/drawing/2014/main" id="{A7C466D1-7485-B700-C1BC-27864514DDA7}"/>
               </a:ext>
             </a:extLst>
           </p:cNvPr>
@@ -16372,7 +16100,7 @@
               <a:rPr lang="en-US" dirty="0">
                 <a:latin typeface="Arial Rounded MT Bold" panose="020F0704030504030204" pitchFamily="34" charset="0"/>
               </a:rPr>
-              <a:t>Choix [3/3]</a:t>
+              <a:t>Choix: SI - SINON SI - SINON </a:t>
             </a:r>
             <a:endParaRPr lang="fr-CA" dirty="0">
               <a:latin typeface="Arial Rounded MT Bold" panose="020F0704030504030204" pitchFamily="34" charset="0"/>
@@ -16385,7 +16113,7 @@
           <p:cNvPr id="3" name="Content Placeholder 2">
             <a:extLst>
               <a:ext uri="{FF2B5EF4-FFF2-40B4-BE49-F238E27FC236}">
-                <a16:creationId xmlns:a16="http://schemas.microsoft.com/office/drawing/2014/main" id="{C5D36386-3A04-3A7F-9BBE-CEBA63E49A28}"/>
+                <a16:creationId xmlns:a16="http://schemas.microsoft.com/office/drawing/2014/main" id="{0FD4AB40-1495-63FA-2A8D-E0E4C33FF0C5}"/>
               </a:ext>
             </a:extLst>
           </p:cNvPr>
@@ -16403,163 +16131,90 @@
           </a:bodyPr>
           <a:lstStyle/>
           <a:p>
-            <a:pPr lvl="1" algn="just">
+            <a:pPr algn="just">
               <a:lnSpc>
                 <a:spcPct val="100000"/>
               </a:lnSpc>
             </a:pPr>
             <a:r>
-              <a:rPr lang="en-CA" sz="1800" dirty="0">
+              <a:rPr lang="en-CA" sz="2200" dirty="0">
                 <a:latin typeface="Consolas" panose="020B0609020204030204" pitchFamily="49" charset="0"/>
               </a:rPr>
               <a:t>E</a:t>
             </a:r>
             <a:r>
-              <a:rPr lang="fr-CA" sz="1800" dirty="0">
+              <a:rPr lang="fr-CA" sz="2200" dirty="0">
                 <a:latin typeface="Consolas" panose="020B0609020204030204" pitchFamily="49" charset="0"/>
               </a:rPr>
               <a:t>x</a:t>
             </a:r>
             <a:r>
-              <a:rPr lang="en-US" sz="1800" dirty="0" err="1">
+              <a:rPr lang="en-US" sz="2200" dirty="0" err="1">
                 <a:latin typeface="Consolas" panose="020B0609020204030204" pitchFamily="49" charset="0"/>
               </a:rPr>
               <a:t>écuter</a:t>
             </a:r>
             <a:r>
-              <a:rPr lang="en-US" sz="1800" dirty="0">
-                <a:latin typeface="Consolas" panose="020B0609020204030204" pitchFamily="49" charset="0"/>
-              </a:rPr>
-              <a:t> du code </a:t>
-            </a:r>
-            <a:r>
-              <a:rPr lang="en-US" sz="1800" dirty="0" err="1">
-                <a:latin typeface="Consolas" panose="020B0609020204030204" pitchFamily="49" charset="0"/>
-              </a:rPr>
-              <a:t>si</a:t>
-            </a:r>
-            <a:r>
-              <a:rPr lang="en-US" sz="1800" dirty="0">
+              <a:rPr lang="en-US" sz="2200" dirty="0">
+                <a:latin typeface="Consolas" panose="020B0609020204030204" pitchFamily="49" charset="0"/>
+              </a:rPr>
+              <a:t> des instructions </a:t>
+            </a:r>
+            <a:r>
+              <a:rPr lang="en-US" sz="2200" dirty="0" err="1">
+                <a:latin typeface="Consolas" panose="020B0609020204030204" pitchFamily="49" charset="0"/>
+              </a:rPr>
+              <a:t>lorsque</a:t>
+            </a:r>
+            <a:r>
+              <a:rPr lang="en-US" sz="2200" dirty="0">
                 <a:latin typeface="Consolas" panose="020B0609020204030204" pitchFamily="49" charset="0"/>
               </a:rPr>
               <a:t> </a:t>
             </a:r>
             <a:r>
-              <a:rPr lang="en-US" sz="1800" dirty="0" err="1">
-                <a:latin typeface="Consolas" panose="020B0609020204030204" pitchFamily="49" charset="0"/>
-              </a:rPr>
-              <a:t>une</a:t>
-            </a:r>
-            <a:r>
-              <a:rPr lang="en-US" sz="1800" dirty="0">
-                <a:latin typeface="Consolas" panose="020B0609020204030204" pitchFamily="49" charset="0"/>
-              </a:rPr>
-              <a:t> condition est </a:t>
-            </a:r>
-            <a:r>
-              <a:rPr lang="en-US" sz="1800" dirty="0" err="1">
-                <a:latin typeface="Consolas" panose="020B0609020204030204" pitchFamily="49" charset="0"/>
-              </a:rPr>
-              <a:t>vraie</a:t>
-            </a:r>
-            <a:r>
-              <a:rPr lang="en-US" sz="1800" dirty="0">
-                <a:latin typeface="Consolas" panose="020B0609020204030204" pitchFamily="49" charset="0"/>
-              </a:rPr>
-              <a:t> (c.-à-d. </a:t>
-            </a:r>
-            <a:r>
-              <a:rPr lang="en-US" sz="1800" b="1" dirty="0" err="1">
-                <a:latin typeface="Consolas" panose="020B0609020204030204" pitchFamily="49" charset="0"/>
-              </a:rPr>
-              <a:t>égale</a:t>
-            </a:r>
-            <a:r>
-              <a:rPr lang="en-US" sz="1800" b="1" dirty="0">
-                <a:latin typeface="Consolas" panose="020B0609020204030204" pitchFamily="49" charset="0"/>
-              </a:rPr>
-              <a:t> à True</a:t>
-            </a:r>
-            <a:r>
-              <a:rPr lang="en-US" sz="1800" dirty="0">
-                <a:latin typeface="Consolas" panose="020B0609020204030204" pitchFamily="49" charset="0"/>
-              </a:rPr>
-              <a:t>)</a:t>
-            </a:r>
-          </a:p>
-          <a:p>
-            <a:pPr lvl="2" algn="just">
-              <a:lnSpc>
-                <a:spcPct val="100000"/>
-              </a:lnSpc>
-            </a:pPr>
-            <a:r>
-              <a:rPr lang="en-US" sz="1400" dirty="0" err="1">
-                <a:latin typeface="Consolas" panose="020B0609020204030204" pitchFamily="49" charset="0"/>
-              </a:rPr>
-              <a:t>Implique</a:t>
-            </a:r>
-            <a:r>
-              <a:rPr lang="en-US" sz="1400" dirty="0">
+              <a:rPr lang="en-US" sz="2200" b="1" dirty="0" err="1">
+                <a:latin typeface="Consolas" panose="020B0609020204030204" pitchFamily="49" charset="0"/>
+              </a:rPr>
+              <a:t>toutes</a:t>
+            </a:r>
+            <a:r>
+              <a:rPr lang="en-US" sz="2200" b="1" dirty="0">
+                <a:latin typeface="Consolas" panose="020B0609020204030204" pitchFamily="49" charset="0"/>
+              </a:rPr>
+              <a:t> les conditions </a:t>
+            </a:r>
+            <a:r>
+              <a:rPr lang="en-US" sz="2200" b="1" dirty="0" err="1">
+                <a:latin typeface="Consolas" panose="020B0609020204030204" pitchFamily="49" charset="0"/>
+              </a:rPr>
+              <a:t>sont</a:t>
+            </a:r>
+            <a:r>
+              <a:rPr lang="en-US" sz="2200" b="1" dirty="0">
                 <a:latin typeface="Consolas" panose="020B0609020204030204" pitchFamily="49" charset="0"/>
               </a:rPr>
               <a:t> </a:t>
             </a:r>
             <a:r>
-              <a:rPr lang="en-US" sz="1400" dirty="0" err="1">
-                <a:latin typeface="Consolas" panose="020B0609020204030204" pitchFamily="49" charset="0"/>
-              </a:rPr>
-              <a:t>généralement</a:t>
-            </a:r>
-            <a:r>
-              <a:rPr lang="en-US" sz="1400" dirty="0">
-                <a:latin typeface="Consolas" panose="020B0609020204030204" pitchFamily="49" charset="0"/>
-              </a:rPr>
-              <a:t> les </a:t>
-            </a:r>
-            <a:r>
-              <a:rPr lang="en-US" sz="1400" dirty="0" err="1">
-                <a:latin typeface="Consolas" panose="020B0609020204030204" pitchFamily="49" charset="0"/>
-              </a:rPr>
-              <a:t>opérateurs</a:t>
-            </a:r>
-            <a:r>
-              <a:rPr lang="en-US" sz="1400" dirty="0">
-                <a:latin typeface="Consolas" panose="020B0609020204030204" pitchFamily="49" charset="0"/>
-              </a:rPr>
-              <a:t> de </a:t>
-            </a:r>
-            <a:r>
-              <a:rPr lang="en-US" sz="1400" dirty="0" err="1">
-                <a:latin typeface="Consolas" panose="020B0609020204030204" pitchFamily="49" charset="0"/>
-              </a:rPr>
-              <a:t>comparaison</a:t>
-            </a:r>
-            <a:r>
-              <a:rPr lang="en-US" sz="1400" dirty="0">
-                <a:latin typeface="Consolas" panose="020B0609020204030204" pitchFamily="49" charset="0"/>
-              </a:rPr>
-              <a:t> et les </a:t>
-            </a:r>
-            <a:r>
-              <a:rPr lang="en-US" sz="1400" dirty="0" err="1">
-                <a:latin typeface="Consolas" panose="020B0609020204030204" pitchFamily="49" charset="0"/>
-              </a:rPr>
-              <a:t>opérateurs</a:t>
-            </a:r>
-            <a:r>
-              <a:rPr lang="en-US" sz="1400" dirty="0">
-                <a:latin typeface="Consolas" panose="020B0609020204030204" pitchFamily="49" charset="0"/>
-              </a:rPr>
-              <a:t> </a:t>
-            </a:r>
-            <a:r>
-              <a:rPr lang="en-US" sz="1400" dirty="0" err="1">
-                <a:latin typeface="Consolas" panose="020B0609020204030204" pitchFamily="49" charset="0"/>
-              </a:rPr>
-              <a:t>logiques</a:t>
-            </a:r>
-            <a:endParaRPr lang="en-US" sz="1400" dirty="0">
+              <a:rPr lang="en-US" sz="2200" b="1" dirty="0" err="1">
+                <a:latin typeface="Consolas" panose="020B0609020204030204" pitchFamily="49" charset="0"/>
+              </a:rPr>
+              <a:t>égales</a:t>
+            </a:r>
+            <a:r>
+              <a:rPr lang="en-US" sz="2200" b="1" dirty="0">
+                <a:latin typeface="Consolas" panose="020B0609020204030204" pitchFamily="49" charset="0"/>
+              </a:rPr>
+              <a:t> à False</a:t>
+            </a:r>
+            <a:r>
+              <a:rPr lang="en-US" sz="2200" dirty="0">
+                <a:latin typeface="Consolas" panose="020B0609020204030204" pitchFamily="49" charset="0"/>
+              </a:rPr>
+              <a:t>:</a:t>
+            </a:r>
+            <a:endParaRPr lang="en-US" sz="1800" dirty="0">
               <a:latin typeface="Consolas" panose="020B0609020204030204" pitchFamily="49" charset="0"/>
             </a:endParaRPr>
           </a:p>
@@ -16570,9 +16225,346 @@
               </a:lnSpc>
               <a:buNone/>
             </a:pPr>
-            <a:endParaRPr lang="en-CA" sz="1800" dirty="0">
+            <a:endParaRPr lang="en-CA" sz="1800" b="1" dirty="0">
               <a:latin typeface="Consolas" panose="020B0609020204030204" pitchFamily="49" charset="0"/>
             </a:endParaRPr>
+          </a:p>
+          <a:p>
+            <a:pPr marL="457200" lvl="1" indent="0" algn="just">
+              <a:lnSpc>
+                <a:spcPct val="100000"/>
+              </a:lnSpc>
+              <a:buNone/>
+            </a:pPr>
+            <a:r>
+              <a:rPr lang="en-CA" sz="1200" b="1" dirty="0">
+                <a:latin typeface="Consolas" panose="020B0609020204030204" pitchFamily="49" charset="0"/>
+              </a:rPr>
+              <a:t>&gt;&gt;&gt; </a:t>
+            </a:r>
+            <a:r>
+              <a:rPr lang="en-CA" sz="1200" b="1" dirty="0" err="1">
+                <a:latin typeface="Consolas" panose="020B0609020204030204" pitchFamily="49" charset="0"/>
+              </a:rPr>
+              <a:t>valeur</a:t>
+            </a:r>
+            <a:r>
+              <a:rPr lang="en-CA" sz="1200" b="1" dirty="0">
+                <a:latin typeface="Consolas" panose="020B0609020204030204" pitchFamily="49" charset="0"/>
+              </a:rPr>
+              <a:t> = 5</a:t>
+            </a:r>
+          </a:p>
+          <a:p>
+            <a:pPr marL="457200" lvl="1" indent="0" algn="just">
+              <a:lnSpc>
+                <a:spcPct val="100000"/>
+              </a:lnSpc>
+              <a:buNone/>
+            </a:pPr>
+            <a:r>
+              <a:rPr lang="en-CA" sz="1200" b="1" dirty="0">
+                <a:latin typeface="Consolas" panose="020B0609020204030204" pitchFamily="49" charset="0"/>
+              </a:rPr>
+              <a:t>&gt;&gt;&gt; if </a:t>
+            </a:r>
+            <a:r>
+              <a:rPr lang="en-CA" sz="1200" b="1" dirty="0" err="1">
+                <a:latin typeface="Consolas" panose="020B0609020204030204" pitchFamily="49" charset="0"/>
+              </a:rPr>
+              <a:t>valeur</a:t>
+            </a:r>
+            <a:r>
+              <a:rPr lang="en-CA" sz="1200" b="1" dirty="0">
+                <a:latin typeface="Consolas" panose="020B0609020204030204" pitchFamily="49" charset="0"/>
+              </a:rPr>
+              <a:t> % 2 == 0:</a:t>
+            </a:r>
+          </a:p>
+          <a:p>
+            <a:pPr marL="457200" lvl="1" indent="0" algn="just">
+              <a:lnSpc>
+                <a:spcPct val="100000"/>
+              </a:lnSpc>
+              <a:buNone/>
+            </a:pPr>
+            <a:r>
+              <a:rPr lang="en-CA" sz="1200" b="1" dirty="0">
+                <a:latin typeface="Consolas" panose="020B0609020204030204" pitchFamily="49" charset="0"/>
+              </a:rPr>
+              <a:t>...   print("La </a:t>
+            </a:r>
+            <a:r>
+              <a:rPr lang="en-CA" sz="1200" b="1" dirty="0" err="1">
+                <a:latin typeface="Consolas" panose="020B0609020204030204" pitchFamily="49" charset="0"/>
+              </a:rPr>
+              <a:t>nombre</a:t>
+            </a:r>
+            <a:r>
+              <a:rPr lang="en-CA" sz="1200" b="1" dirty="0">
+                <a:latin typeface="Consolas" panose="020B0609020204030204" pitchFamily="49" charset="0"/>
+              </a:rPr>
+              <a:t>", </a:t>
+            </a:r>
+            <a:r>
+              <a:rPr lang="en-CA" sz="1200" b="1" dirty="0" err="1">
+                <a:latin typeface="Consolas" panose="020B0609020204030204" pitchFamily="49" charset="0"/>
+              </a:rPr>
+              <a:t>valeur</a:t>
+            </a:r>
+            <a:r>
+              <a:rPr lang="en-CA" sz="1200" b="1" dirty="0">
+                <a:latin typeface="Consolas" panose="020B0609020204030204" pitchFamily="49" charset="0"/>
+              </a:rPr>
+              <a:t>, "est pair")</a:t>
+            </a:r>
+          </a:p>
+          <a:p>
+            <a:pPr marL="457200" lvl="1" indent="0" algn="just">
+              <a:lnSpc>
+                <a:spcPct val="100000"/>
+              </a:lnSpc>
+              <a:buNone/>
+            </a:pPr>
+            <a:r>
+              <a:rPr lang="en-CA" sz="1200" b="1" dirty="0">
+                <a:latin typeface="Consolas" panose="020B0609020204030204" pitchFamily="49" charset="0"/>
+              </a:rPr>
+              <a:t>... </a:t>
+            </a:r>
+            <a:r>
+              <a:rPr lang="en-CA" sz="1200" b="1" dirty="0" err="1">
+                <a:latin typeface="Consolas" panose="020B0609020204030204" pitchFamily="49" charset="0"/>
+              </a:rPr>
+              <a:t>elif</a:t>
+            </a:r>
+            <a:r>
+              <a:rPr lang="en-CA" sz="1200" b="1" dirty="0">
+                <a:latin typeface="Consolas" panose="020B0609020204030204" pitchFamily="49" charset="0"/>
+              </a:rPr>
+              <a:t> </a:t>
+            </a:r>
+            <a:r>
+              <a:rPr lang="en-CA" sz="1200" b="1" dirty="0" err="1">
+                <a:latin typeface="Consolas" panose="020B0609020204030204" pitchFamily="49" charset="0"/>
+              </a:rPr>
+              <a:t>valeur</a:t>
+            </a:r>
+            <a:r>
+              <a:rPr lang="en-CA" sz="1200" b="1" dirty="0">
+                <a:latin typeface="Consolas" panose="020B0609020204030204" pitchFamily="49" charset="0"/>
+              </a:rPr>
+              <a:t> &gt; 5:</a:t>
+            </a:r>
+          </a:p>
+          <a:p>
+            <a:pPr marL="457200" lvl="1" indent="0" algn="just">
+              <a:lnSpc>
+                <a:spcPct val="100000"/>
+              </a:lnSpc>
+              <a:buNone/>
+            </a:pPr>
+            <a:r>
+              <a:rPr lang="en-CA" sz="1200" b="1" dirty="0">
+                <a:latin typeface="Consolas" panose="020B0609020204030204" pitchFamily="49" charset="0"/>
+              </a:rPr>
+              <a:t>...   print("Le </a:t>
+            </a:r>
+            <a:r>
+              <a:rPr lang="en-CA" sz="1200" b="1" dirty="0" err="1">
+                <a:latin typeface="Consolas" panose="020B0609020204030204" pitchFamily="49" charset="0"/>
+              </a:rPr>
+              <a:t>nombre</a:t>
+            </a:r>
+            <a:r>
+              <a:rPr lang="en-CA" sz="1200" b="1" dirty="0">
+                <a:latin typeface="Consolas" panose="020B0609020204030204" pitchFamily="49" charset="0"/>
+              </a:rPr>
+              <a:t>", </a:t>
+            </a:r>
+            <a:r>
+              <a:rPr lang="en-CA" sz="1200" b="1" dirty="0" err="1">
+                <a:latin typeface="Consolas" panose="020B0609020204030204" pitchFamily="49" charset="0"/>
+              </a:rPr>
+              <a:t>valeur</a:t>
+            </a:r>
+            <a:r>
+              <a:rPr lang="en-CA" sz="1200" b="1" dirty="0">
+                <a:latin typeface="Consolas" panose="020B0609020204030204" pitchFamily="49" charset="0"/>
+              </a:rPr>
+              <a:t>, "est plus grand </a:t>
+            </a:r>
+            <a:r>
+              <a:rPr lang="en-CA" sz="1200" b="1" dirty="0" err="1">
+                <a:latin typeface="Consolas" panose="020B0609020204030204" pitchFamily="49" charset="0"/>
+              </a:rPr>
+              <a:t>que</a:t>
+            </a:r>
+            <a:r>
+              <a:rPr lang="en-CA" sz="1200" b="1" dirty="0">
+                <a:latin typeface="Consolas" panose="020B0609020204030204" pitchFamily="49" charset="0"/>
+              </a:rPr>
+              <a:t> 5")</a:t>
+            </a:r>
+          </a:p>
+          <a:p>
+            <a:pPr marL="457200" lvl="1" indent="0" algn="just">
+              <a:lnSpc>
+                <a:spcPct val="100000"/>
+              </a:lnSpc>
+              <a:buNone/>
+            </a:pPr>
+            <a:r>
+              <a:rPr lang="en-CA" sz="1200" b="1" dirty="0">
+                <a:latin typeface="Consolas" panose="020B0609020204030204" pitchFamily="49" charset="0"/>
+              </a:rPr>
+              <a:t>... else:</a:t>
+            </a:r>
+          </a:p>
+          <a:p>
+            <a:pPr marL="457200" lvl="1" indent="0" algn="just">
+              <a:lnSpc>
+                <a:spcPct val="100000"/>
+              </a:lnSpc>
+              <a:buNone/>
+            </a:pPr>
+            <a:r>
+              <a:rPr lang="en-CA" sz="1200" b="1" dirty="0">
+                <a:latin typeface="Consolas" panose="020B0609020204030204" pitchFamily="49" charset="0"/>
+              </a:rPr>
+              <a:t>...   print("Le </a:t>
+            </a:r>
+            <a:r>
+              <a:rPr lang="en-CA" sz="1200" b="1" dirty="0" err="1">
+                <a:latin typeface="Consolas" panose="020B0609020204030204" pitchFamily="49" charset="0"/>
+              </a:rPr>
+              <a:t>nombre</a:t>
+            </a:r>
+            <a:r>
+              <a:rPr lang="en-CA" sz="1200" b="1" dirty="0">
+                <a:latin typeface="Consolas" panose="020B0609020204030204" pitchFamily="49" charset="0"/>
+              </a:rPr>
+              <a:t>", </a:t>
+            </a:r>
+            <a:r>
+              <a:rPr lang="en-CA" sz="1200" b="1" dirty="0" err="1">
+                <a:latin typeface="Consolas" panose="020B0609020204030204" pitchFamily="49" charset="0"/>
+              </a:rPr>
+              <a:t>valeur</a:t>
+            </a:r>
+            <a:r>
+              <a:rPr lang="en-CA" sz="1200" b="1" dirty="0">
+                <a:latin typeface="Consolas" panose="020B0609020204030204" pitchFamily="49" charset="0"/>
+              </a:rPr>
+              <a:t>, "est impair et &lt;= à 5")</a:t>
+            </a:r>
+          </a:p>
+          <a:p>
+            <a:pPr marL="457200" lvl="1" indent="0" algn="just">
+              <a:lnSpc>
+                <a:spcPct val="100000"/>
+              </a:lnSpc>
+              <a:buNone/>
+            </a:pPr>
+            <a:r>
+              <a:rPr lang="en-CA" sz="1200" dirty="0">
+                <a:solidFill>
+                  <a:schemeClr val="bg1">
+                    <a:lumMod val="50000"/>
+                  </a:schemeClr>
+                </a:solidFill>
+                <a:latin typeface="Consolas" panose="020B0609020204030204" pitchFamily="49" charset="0"/>
+              </a:rPr>
+              <a:t>Le </a:t>
+            </a:r>
+            <a:r>
+              <a:rPr lang="en-CA" sz="1200" dirty="0" err="1">
+                <a:solidFill>
+                  <a:schemeClr val="bg1">
+                    <a:lumMod val="50000"/>
+                  </a:schemeClr>
+                </a:solidFill>
+                <a:latin typeface="Consolas" panose="020B0609020204030204" pitchFamily="49" charset="0"/>
+              </a:rPr>
+              <a:t>nombre</a:t>
+            </a:r>
+            <a:r>
+              <a:rPr lang="en-CA" sz="1200" dirty="0">
+                <a:solidFill>
+                  <a:schemeClr val="bg1">
+                    <a:lumMod val="50000"/>
+                  </a:schemeClr>
+                </a:solidFill>
+                <a:latin typeface="Consolas" panose="020B0609020204030204" pitchFamily="49" charset="0"/>
+              </a:rPr>
+              <a:t> 5 est impair et </a:t>
+            </a:r>
+            <a:r>
+              <a:rPr lang="en-CA" sz="1200" dirty="0" err="1">
+                <a:solidFill>
+                  <a:schemeClr val="bg1">
+                    <a:lumMod val="50000"/>
+                  </a:schemeClr>
+                </a:solidFill>
+                <a:latin typeface="Consolas" panose="020B0609020204030204" pitchFamily="49" charset="0"/>
+              </a:rPr>
+              <a:t>inférieur</a:t>
+            </a:r>
+            <a:r>
+              <a:rPr lang="en-CA" sz="1200" dirty="0">
+                <a:solidFill>
+                  <a:schemeClr val="bg1">
+                    <a:lumMod val="50000"/>
+                  </a:schemeClr>
+                </a:solidFill>
+                <a:latin typeface="Consolas" panose="020B0609020204030204" pitchFamily="49" charset="0"/>
+              </a:rPr>
+              <a:t> </a:t>
+            </a:r>
+            <a:r>
+              <a:rPr lang="en-CA" sz="1200" dirty="0" err="1">
+                <a:solidFill>
+                  <a:schemeClr val="bg1">
+                    <a:lumMod val="50000"/>
+                  </a:schemeClr>
+                </a:solidFill>
+                <a:latin typeface="Consolas" panose="020B0609020204030204" pitchFamily="49" charset="0"/>
+              </a:rPr>
+              <a:t>ou</a:t>
+            </a:r>
+            <a:r>
+              <a:rPr lang="en-CA" sz="1200" dirty="0">
+                <a:solidFill>
+                  <a:schemeClr val="bg1">
+                    <a:lumMod val="50000"/>
+                  </a:schemeClr>
+                </a:solidFill>
+                <a:latin typeface="Consolas" panose="020B0609020204030204" pitchFamily="49" charset="0"/>
+              </a:rPr>
+              <a:t> </a:t>
+            </a:r>
+            <a:r>
+              <a:rPr lang="en-CA" sz="1200" dirty="0" err="1">
+                <a:solidFill>
+                  <a:schemeClr val="bg1">
+                    <a:lumMod val="50000"/>
+                  </a:schemeClr>
+                </a:solidFill>
+                <a:latin typeface="Consolas" panose="020B0609020204030204" pitchFamily="49" charset="0"/>
+              </a:rPr>
+              <a:t>égal</a:t>
+            </a:r>
+            <a:r>
+              <a:rPr lang="en-CA" sz="1200" dirty="0">
+                <a:solidFill>
+                  <a:schemeClr val="bg1">
+                    <a:lumMod val="50000"/>
+                  </a:schemeClr>
+                </a:solidFill>
+                <a:latin typeface="Consolas" panose="020B0609020204030204" pitchFamily="49" charset="0"/>
+              </a:rPr>
+              <a:t> à 5</a:t>
+            </a:r>
           </a:p>
         </p:txBody>
       </p:sp>
@@ -16581,7 +16573,7 @@
           <p:cNvPr id="5" name="Slide Number Placeholder 4">
             <a:extLst>
               <a:ext uri="{FF2B5EF4-FFF2-40B4-BE49-F238E27FC236}">
-                <a16:creationId xmlns:a16="http://schemas.microsoft.com/office/drawing/2014/main" id="{71535C36-60F1-DEEC-5D53-7AD440BDC53F}"/>
+                <a16:creationId xmlns:a16="http://schemas.microsoft.com/office/drawing/2014/main" id="{86D1BF86-D28B-1824-7797-DF484496B954}"/>
               </a:ext>
             </a:extLst>
           </p:cNvPr>
@@ -16607,10 +16599,10 @@
       </p:sp>
       <p:sp>
         <p:nvSpPr>
-          <p:cNvPr id="6" name="TextBox 5">
+          <p:cNvPr id="7" name="TextBox 6">
             <a:extLst>
               <a:ext uri="{FF2B5EF4-FFF2-40B4-BE49-F238E27FC236}">
-                <a16:creationId xmlns:a16="http://schemas.microsoft.com/office/drawing/2014/main" id="{9F83F37A-7CDA-1028-C66C-6F4A4138B0F2}"/>
+                <a16:creationId xmlns:a16="http://schemas.microsoft.com/office/drawing/2014/main" id="{DB43EDB9-0C0B-B6CD-4AB2-F3D481D5F4BB}"/>
               </a:ext>
             </a:extLst>
           </p:cNvPr>
@@ -16619,8 +16611,8 @@
         </p:nvSpPr>
         <p:spPr>
           <a:xfrm>
-            <a:off x="4791488" y="2800965"/>
-            <a:ext cx="2609024" cy="1200329"/>
+            <a:off x="7437000" y="2847132"/>
+            <a:ext cx="2347200" cy="2308324"/>
           </a:xfrm>
           <a:prstGeom prst="rect">
             <a:avLst/>
@@ -16644,22 +16636,15 @@
               <a:buNone/>
             </a:pPr>
             <a:r>
-              <a:rPr lang="en-US" b="1" dirty="0">
-                <a:latin typeface="Consolas" panose="020B0609020204030204" pitchFamily="49" charset="0"/>
-              </a:rPr>
-              <a:t>if </a:t>
-            </a:r>
-            <a:r>
               <a:rPr lang="en-US" dirty="0">
-                <a:latin typeface="Consolas" panose="020B0609020204030204" pitchFamily="49" charset="0"/>
-              </a:rPr>
-              <a:t>condition_1</a:t>
-            </a:r>
-            <a:r>
-              <a:rPr lang="en-US" b="1" dirty="0">
-                <a:latin typeface="Consolas" panose="020B0609020204030204" pitchFamily="49" charset="0"/>
-              </a:rPr>
-              <a:t>:</a:t>
+                <a:solidFill>
+                  <a:schemeClr val="bg1">
+                    <a:lumMod val="50000"/>
+                  </a:schemeClr>
+                </a:solidFill>
+                <a:latin typeface="Consolas" panose="020B0609020204030204" pitchFamily="49" charset="0"/>
+              </a:rPr>
+              <a:t>[instructions]</a:t>
             </a:r>
           </a:p>
           <a:p>
@@ -16670,13 +16655,19 @@
               <a:rPr lang="en-US" b="1" dirty="0">
                 <a:latin typeface="Consolas" panose="020B0609020204030204" pitchFamily="49" charset="0"/>
               </a:rPr>
-              <a:t>  </a:t>
+              <a:t>if</a:t>
             </a:r>
             <a:r>
               <a:rPr lang="en-US" dirty="0">
                 <a:latin typeface="Consolas" panose="020B0609020204030204" pitchFamily="49" charset="0"/>
               </a:rPr>
-              <a:t>instructions</a:t>
+              <a:t> condition_1</a:t>
+            </a:r>
+            <a:r>
+              <a:rPr lang="en-US" b="1" dirty="0">
+                <a:latin typeface="Consolas" panose="020B0609020204030204" pitchFamily="49" charset="0"/>
+              </a:rPr>
+              <a:t>:</a:t>
             </a:r>
           </a:p>
           <a:p>
@@ -16684,28 +16675,10 @@
               <a:buNone/>
             </a:pPr>
             <a:r>
-              <a:rPr lang="en-US" b="1" dirty="0" err="1">
-                <a:latin typeface="Consolas" panose="020B0609020204030204" pitchFamily="49" charset="0"/>
-              </a:rPr>
-              <a:t>elif</a:t>
-            </a:r>
-            <a:r>
-              <a:rPr lang="en-US" b="1" dirty="0">
-                <a:latin typeface="Consolas" panose="020B0609020204030204" pitchFamily="49" charset="0"/>
-              </a:rPr>
-              <a:t> </a:t>
-            </a:r>
-            <a:r>
               <a:rPr lang="en-US" dirty="0">
                 <a:latin typeface="Consolas" panose="020B0609020204030204" pitchFamily="49" charset="0"/>
               </a:rPr>
-              <a:t>condition_2</a:t>
-            </a:r>
-            <a:r>
-              <a:rPr lang="en-US" b="1" dirty="0">
-                <a:latin typeface="Consolas" panose="020B0609020204030204" pitchFamily="49" charset="0"/>
-              </a:rPr>
-              <a:t>:</a:t>
+              <a:t>  instructions</a:t>
             </a:r>
           </a:p>
           <a:p>
@@ -16713,16 +16686,77 @@
               <a:buNone/>
             </a:pPr>
             <a:r>
+              <a:rPr lang="en-US" b="1" dirty="0" err="1">
+                <a:latin typeface="Consolas" panose="020B0609020204030204" pitchFamily="49" charset="0"/>
+              </a:rPr>
+              <a:t>elif</a:t>
+            </a:r>
+            <a:r>
+              <a:rPr lang="en-US" dirty="0">
+                <a:latin typeface="Consolas" panose="020B0609020204030204" pitchFamily="49" charset="0"/>
+              </a:rPr>
+              <a:t> condition_2</a:t>
+            </a:r>
+            <a:r>
               <a:rPr lang="en-US" b="1" dirty="0">
                 <a:latin typeface="Consolas" panose="020B0609020204030204" pitchFamily="49" charset="0"/>
               </a:rPr>
-              <a:t>  </a:t>
-            </a:r>
+              <a:t>:</a:t>
+            </a:r>
+          </a:p>
+          <a:p>
+            <a:pPr marL="0" indent="0">
+              <a:buNone/>
+            </a:pPr>
             <a:r>
               <a:rPr lang="en-US" dirty="0">
                 <a:latin typeface="Consolas" panose="020B0609020204030204" pitchFamily="49" charset="0"/>
               </a:rPr>
-              <a:t>instructions</a:t>
+              <a:t>  instructions</a:t>
+            </a:r>
+          </a:p>
+          <a:p>
+            <a:pPr marL="0" indent="0">
+              <a:buNone/>
+            </a:pPr>
+            <a:r>
+              <a:rPr lang="en-US" b="1" dirty="0">
+                <a:latin typeface="Consolas" panose="020B0609020204030204" pitchFamily="49" charset="0"/>
+              </a:rPr>
+              <a:t>else</a:t>
+            </a:r>
+            <a:r>
+              <a:rPr lang="en-US" dirty="0">
+                <a:latin typeface="Consolas" panose="020B0609020204030204" pitchFamily="49" charset="0"/>
+              </a:rPr>
+              <a:t>:</a:t>
+            </a:r>
+          </a:p>
+          <a:p>
+            <a:pPr marL="0" indent="0">
+              <a:buNone/>
+            </a:pPr>
+            <a:r>
+              <a:rPr lang="en-US" dirty="0">
+                <a:latin typeface="Consolas" panose="020B0609020204030204" pitchFamily="49" charset="0"/>
+              </a:rPr>
+              <a:t>  instructions</a:t>
+            </a:r>
+          </a:p>
+          <a:p>
+            <a:pPr marL="0" indent="0">
+              <a:buNone/>
+            </a:pPr>
+            <a:r>
+              <a:rPr lang="en-US" dirty="0">
+                <a:solidFill>
+                  <a:schemeClr val="bg1">
+                    <a:lumMod val="50000"/>
+                  </a:schemeClr>
+                </a:solidFill>
+                <a:latin typeface="Consolas" panose="020B0609020204030204" pitchFamily="49" charset="0"/>
+              </a:rPr>
+              <a:t>[instructions]</a:t>
             </a:r>
           </a:p>
         </p:txBody>
@@ -16730,7 +16764,7 @@
     </p:spTree>
     <p:extLst>
       <p:ext uri="{BB962C8B-B14F-4D97-AF65-F5344CB8AC3E}">
-        <p14:creationId xmlns:p14="http://schemas.microsoft.com/office/powerpoint/2010/main" val="3135586547"/>
+        <p14:creationId xmlns:p14="http://schemas.microsoft.com/office/powerpoint/2010/main" val="749582193"/>
       </p:ext>
     </p:extLst>
   </p:cSld>

</xml_diff>

<commit_message>
feat: Complete python_1 presentation up to slide no.31
</commit_message>
<xml_diff>
--- a/python_1/presentation_python_1.pptx
+++ b/python_1/presentation_python_1.pptx
@@ -5,7 +5,7 @@
     <p:sldMasterId id="2147483648" r:id="rId1"/>
   </p:sldMasterIdLst>
   <p:notesMasterIdLst>
-    <p:notesMasterId r:id="rId33"/>
+    <p:notesMasterId r:id="rId34"/>
   </p:notesMasterIdLst>
   <p:sldIdLst>
     <p:sldId id="256" r:id="rId2"/>
@@ -35,10 +35,11 @@
     <p:sldId id="279" r:id="rId26"/>
     <p:sldId id="288" r:id="rId27"/>
     <p:sldId id="289" r:id="rId28"/>
-    <p:sldId id="290" r:id="rId29"/>
+    <p:sldId id="292" r:id="rId29"/>
     <p:sldId id="291" r:id="rId30"/>
     <p:sldId id="281" r:id="rId31"/>
-    <p:sldId id="270" r:id="rId32"/>
+    <p:sldId id="290" r:id="rId32"/>
+    <p:sldId id="270" r:id="rId33"/>
   </p:sldIdLst>
   <p:sldSz cx="12192000" cy="6858000"/>
   <p:notesSz cx="6858000" cy="9144000"/>
@@ -10155,7 +10156,7 @@
               <a:rPr lang="fr-CA" sz="2000" b="1" dirty="0">
                 <a:latin typeface="Consolas" panose="020B0609020204030204" pitchFamily="49" charset="0"/>
               </a:rPr>
-              <a:t>("x =", </a:t>
+              <a:t>('x =', </a:t>
             </a:r>
             <a:r>
               <a:rPr lang="en-CA" sz="2000" b="1" dirty="0">
@@ -10167,13 +10168,13 @@
               <a:rPr lang="fr-CA" sz="2000" b="1" dirty="0">
                 <a:latin typeface="Consolas" panose="020B0609020204030204" pitchFamily="49" charset="0"/>
               </a:rPr>
-              <a:t>['x'], "et y =", </a:t>
+              <a:t>['x'], 'et y =', </a:t>
             </a:r>
             <a:r>
               <a:rPr lang="en-CA" sz="2000" b="1" dirty="0">
                 <a:latin typeface="Consolas" panose="020B0609020204030204" pitchFamily="49" charset="0"/>
               </a:rPr>
-              <a:t>point["y"]</a:t>
+              <a:t>point['y']</a:t>
             </a:r>
             <a:r>
               <a:rPr lang="fr-CA" sz="2000" b="1" dirty="0">
@@ -10265,7 +10266,7 @@
               <a:rPr lang="fr-CA" sz="2000" b="1" dirty="0">
                 <a:latin typeface="Consolas" panose="020B0609020204030204" pitchFamily="49" charset="0"/>
               </a:rPr>
-              <a:t>"a": 1, "b": 2, "c": -1</a:t>
+              <a:t>'a': 1, 'b': 2, 'c': -1</a:t>
             </a:r>
             <a:r>
               <a:rPr lang="en-CA" sz="2000" b="1" dirty="0">
@@ -10285,7 +10286,7 @@
               <a:rPr lang="en-CA" sz="2000" b="1" dirty="0">
                 <a:latin typeface="Consolas" panose="020B0609020204030204" pitchFamily="49" charset="0"/>
               </a:rPr>
-              <a:t>&gt;&gt;&gt; print(', '.join(f"{k} = {v}" for k, v in </a:t>
+              <a:t>&gt;&gt;&gt; print(', '.join(f'{k} = {v}' for k, v in </a:t>
             </a:r>
             <a:r>
               <a:rPr lang="en-CA" sz="2000" b="1" dirty="0" err="1">
@@ -22293,7 +22294,7 @@
         <p:cNvPr id="1" name="">
           <a:extLst>
             <a:ext uri="{FF2B5EF4-FFF2-40B4-BE49-F238E27FC236}">
-              <a16:creationId xmlns:a16="http://schemas.microsoft.com/office/drawing/2014/main" id="{808E75C2-6E05-D4AE-5915-518C66CDFFB4}"/>
+              <a16:creationId xmlns:a16="http://schemas.microsoft.com/office/drawing/2014/main" id="{3597CFED-078A-7F88-CD3B-D5E448042E26}"/>
             </a:ext>
           </a:extLst>
         </p:cNvPr>
@@ -22313,7 +22314,7 @@
           <p:cNvPr id="2" name="Title 1">
             <a:extLst>
               <a:ext uri="{FF2B5EF4-FFF2-40B4-BE49-F238E27FC236}">
-                <a16:creationId xmlns:a16="http://schemas.microsoft.com/office/drawing/2014/main" id="{DFCE78E3-6E2F-2513-0701-01EE22E72B4D}"/>
+                <a16:creationId xmlns:a16="http://schemas.microsoft.com/office/drawing/2014/main" id="{ED86132A-D8FA-C910-51D3-DBB25B379CB8}"/>
               </a:ext>
             </a:extLst>
           </p:cNvPr>
@@ -22346,7 +22347,7 @@
           <p:cNvPr id="3" name="Content Placeholder 2">
             <a:extLst>
               <a:ext uri="{FF2B5EF4-FFF2-40B4-BE49-F238E27FC236}">
-                <a16:creationId xmlns:a16="http://schemas.microsoft.com/office/drawing/2014/main" id="{E5BFA73A-5F16-C1DB-89AE-EB491A024297}"/>
+                <a16:creationId xmlns:a16="http://schemas.microsoft.com/office/drawing/2014/main" id="{209B0117-97AD-2C2E-47B7-99E3AFD46C1E}"/>
               </a:ext>
             </a:extLst>
           </p:cNvPr>
@@ -22434,7 +22435,19 @@
               <a:rPr lang="en-US" sz="2500" b="1" dirty="0">
                 <a:latin typeface="Consolas" panose="020B0609020204030204" pitchFamily="49" charset="0"/>
               </a:rPr>
-              <a:t> modulo (%)</a:t>
+              <a:t> modulo (%) </a:t>
+            </a:r>
+            <a:r>
+              <a:rPr lang="en-US" sz="2500" b="1" dirty="0" err="1">
+                <a:latin typeface="Consolas" panose="020B0609020204030204" pitchFamily="49" charset="0"/>
+              </a:rPr>
+              <a:t>ou</a:t>
+            </a:r>
+            <a:r>
+              <a:rPr lang="en-US" sz="2500" b="1" dirty="0">
+                <a:latin typeface="Consolas" panose="020B0609020204030204" pitchFamily="49" charset="0"/>
+              </a:rPr>
+              <a:t> la division entire (//)</a:t>
             </a:r>
             <a:r>
               <a:rPr lang="en-US" sz="2500" dirty="0">
@@ -22450,7 +22463,7 @@
           <p:cNvPr id="4" name="Slide Number Placeholder 3">
             <a:extLst>
               <a:ext uri="{FF2B5EF4-FFF2-40B4-BE49-F238E27FC236}">
-                <a16:creationId xmlns:a16="http://schemas.microsoft.com/office/drawing/2014/main" id="{C73E7699-9260-2B26-4E4F-F82743E2161A}"/>
+                <a16:creationId xmlns:a16="http://schemas.microsoft.com/office/drawing/2014/main" id="{F17353F2-0094-2AF3-EFE1-C6825287D540}"/>
               </a:ext>
             </a:extLst>
           </p:cNvPr>
@@ -22479,7 +22492,7 @@
           <p:cNvPr id="5" name="Google Shape;353;p18">
             <a:extLst>
               <a:ext uri="{FF2B5EF4-FFF2-40B4-BE49-F238E27FC236}">
-                <a16:creationId xmlns:a16="http://schemas.microsoft.com/office/drawing/2014/main" id="{7D568963-5643-F03E-57F7-D87FE9389096}"/>
+                <a16:creationId xmlns:a16="http://schemas.microsoft.com/office/drawing/2014/main" id="{83DB22CC-A9CE-0C89-D3B7-317F6A29CD52}"/>
               </a:ext>
             </a:extLst>
           </p:cNvPr>
@@ -22734,7 +22747,7 @@
     </p:spTree>
     <p:extLst>
       <p:ext uri="{BB962C8B-B14F-4D97-AF65-F5344CB8AC3E}">
-        <p14:creationId xmlns:p14="http://schemas.microsoft.com/office/powerpoint/2010/main" val="1553947036"/>
+        <p14:creationId xmlns:p14="http://schemas.microsoft.com/office/powerpoint/2010/main" val="4079072362"/>
       </p:ext>
     </p:extLst>
   </p:cSld>
@@ -22837,17 +22850,6 @@
           </a:bodyPr>
           <a:lstStyle/>
           <a:p>
-            <a:pPr marL="457200" lvl="1" indent="0" algn="just">
-              <a:lnSpc>
-                <a:spcPct val="100000"/>
-              </a:lnSpc>
-              <a:buNone/>
-            </a:pPr>
-            <a:endParaRPr lang="en-CA" sz="1800" dirty="0">
-              <a:latin typeface="Consolas" panose="020B0609020204030204" pitchFamily="49" charset="0"/>
-            </a:endParaRPr>
-          </a:p>
-          <a:p>
             <a:pPr lvl="0" algn="just">
               <a:lnSpc>
                 <a:spcPct val="150000"/>
@@ -23015,7 +23017,7 @@
               <a:buChar char="•"/>
             </a:pPr>
             <a:r>
-              <a:rPr lang="fr-FR" sz="1400" dirty="0">
+              <a:rPr lang="fr-FR" sz="1800" dirty="0">
                 <a:solidFill>
                   <a:schemeClr val="dk1"/>
                 </a:solidFill>
@@ -23027,7 +23029,7 @@
               <a:t>La structure est principalement implémentée par les </a:t>
             </a:r>
             <a:r>
-              <a:rPr lang="fr-FR" sz="1400" b="1" dirty="0">
+              <a:rPr lang="fr-FR" sz="1800" b="1" dirty="0">
                 <a:solidFill>
                   <a:schemeClr val="dk1"/>
                 </a:solidFill>
@@ -23039,7 +23041,7 @@
               <a:t>propriétés</a:t>
             </a:r>
             <a:r>
-              <a:rPr lang="fr-FR" sz="1400" dirty="0">
+              <a:rPr lang="fr-FR" sz="1800" dirty="0">
                 <a:solidFill>
                   <a:schemeClr val="dk1"/>
                 </a:solidFill>
@@ -23051,7 +23053,7 @@
               <a:t>/</a:t>
             </a:r>
             <a:r>
-              <a:rPr lang="fr-FR" sz="1400" b="1" dirty="0">
+              <a:rPr lang="fr-FR" sz="1800" b="1" dirty="0">
                 <a:solidFill>
                   <a:schemeClr val="dk1"/>
                 </a:solidFill>
@@ -23063,7 +23065,7 @@
               <a:t>attributs</a:t>
             </a:r>
             <a:r>
-              <a:rPr lang="fr-FR" sz="1400" dirty="0">
+              <a:rPr lang="fr-FR" sz="1800" dirty="0">
                 <a:solidFill>
                   <a:schemeClr val="dk1"/>
                 </a:solidFill>
@@ -23091,7 +23093,7 @@
               <a:buChar char="•"/>
             </a:pPr>
             <a:r>
-              <a:rPr lang="fr-FR" sz="1400" dirty="0">
+              <a:rPr lang="fr-FR" sz="1800" dirty="0">
                 <a:solidFill>
                   <a:schemeClr val="dk1"/>
                 </a:solidFill>
@@ -23103,7 +23105,7 @@
               <a:t>Les opérations sont implémentées par les </a:t>
             </a:r>
             <a:r>
-              <a:rPr lang="fr-FR" sz="1400" b="1" dirty="0">
+              <a:rPr lang="fr-FR" sz="1800" b="1" dirty="0">
                 <a:solidFill>
                   <a:schemeClr val="dk1"/>
                 </a:solidFill>
@@ -23115,7 +23117,7 @@
               <a:t>méthodes</a:t>
             </a:r>
             <a:r>
-              <a:rPr lang="fr-FR" sz="1400" dirty="0">
+              <a:rPr lang="fr-FR" sz="1800" dirty="0">
                 <a:solidFill>
                   <a:schemeClr val="dk1"/>
                 </a:solidFill>
@@ -23203,211 +23205,7 @@
               <a:rPr lang="fr-CA" smtClean="0"/>
               <a:t>29</a:t>
             </a:fld>
-            <a:endParaRPr lang="fr-CA"/>
-          </a:p>
-        </p:txBody>
-      </p:sp>
-      <p:sp>
-        <p:nvSpPr>
-          <p:cNvPr id="9" name="Content Placeholder 2">
-            <a:extLst>
-              <a:ext uri="{FF2B5EF4-FFF2-40B4-BE49-F238E27FC236}">
-                <a16:creationId xmlns:a16="http://schemas.microsoft.com/office/drawing/2014/main" id="{2F4323C1-EFA3-E8CE-B8A7-C9E1232B339C}"/>
-              </a:ext>
-            </a:extLst>
-          </p:cNvPr>
-          <p:cNvSpPr txBox="1">
-            <a:spLocks/>
-          </p:cNvSpPr>
-          <p:nvPr/>
-        </p:nvSpPr>
-        <p:spPr>
-          <a:xfrm>
-            <a:off x="990600" y="1978025"/>
-            <a:ext cx="10515600" cy="4351338"/>
-          </a:xfrm>
-          <a:prstGeom prst="rect">
-            <a:avLst/>
-          </a:prstGeom>
-        </p:spPr>
-        <p:txBody>
-          <a:bodyPr vert="horz" lIns="91440" tIns="45720" rIns="91440" bIns="45720" rtlCol="0">
-            <a:normAutofit/>
-          </a:bodyPr>
-          <a:lstStyle>
-            <a:lvl1pPr marL="228600" indent="-228600" algn="l" defTabSz="914400" rtl="0" eaLnBrk="1" latinLnBrk="0" hangingPunct="1">
-              <a:lnSpc>
-                <a:spcPct val="90000"/>
-              </a:lnSpc>
-              <a:spcBef>
-                <a:spcPts val="1000"/>
-              </a:spcBef>
-              <a:buFont typeface="Arial" panose="020B0604020202020204" pitchFamily="34" charset="0"/>
-              <a:buChar char="•"/>
-              <a:defRPr sz="2800" kern="1200">
-                <a:solidFill>
-                  <a:schemeClr val="tx1"/>
-                </a:solidFill>
-                <a:latin typeface="+mn-lt"/>
-                <a:ea typeface="+mn-ea"/>
-                <a:cs typeface="+mn-cs"/>
-              </a:defRPr>
-            </a:lvl1pPr>
-            <a:lvl2pPr marL="685800" indent="-228600" algn="l" defTabSz="914400" rtl="0" eaLnBrk="1" latinLnBrk="0" hangingPunct="1">
-              <a:lnSpc>
-                <a:spcPct val="90000"/>
-              </a:lnSpc>
-              <a:spcBef>
-                <a:spcPts val="500"/>
-              </a:spcBef>
-              <a:buFont typeface="Arial" panose="020B0604020202020204" pitchFamily="34" charset="0"/>
-              <a:buChar char="•"/>
-              <a:defRPr sz="2400" kern="1200">
-                <a:solidFill>
-                  <a:schemeClr val="tx1"/>
-                </a:solidFill>
-                <a:latin typeface="+mn-lt"/>
-                <a:ea typeface="+mn-ea"/>
-                <a:cs typeface="+mn-cs"/>
-              </a:defRPr>
-            </a:lvl2pPr>
-            <a:lvl3pPr marL="1143000" indent="-228600" algn="l" defTabSz="914400" rtl="0" eaLnBrk="1" latinLnBrk="0" hangingPunct="1">
-              <a:lnSpc>
-                <a:spcPct val="90000"/>
-              </a:lnSpc>
-              <a:spcBef>
-                <a:spcPts val="500"/>
-              </a:spcBef>
-              <a:buFont typeface="Arial" panose="020B0604020202020204" pitchFamily="34" charset="0"/>
-              <a:buChar char="•"/>
-              <a:defRPr sz="2000" kern="1200">
-                <a:solidFill>
-                  <a:schemeClr val="tx1"/>
-                </a:solidFill>
-                <a:latin typeface="+mn-lt"/>
-                <a:ea typeface="+mn-ea"/>
-                <a:cs typeface="+mn-cs"/>
-              </a:defRPr>
-            </a:lvl3pPr>
-            <a:lvl4pPr marL="1600200" indent="-228600" algn="l" defTabSz="914400" rtl="0" eaLnBrk="1" latinLnBrk="0" hangingPunct="1">
-              <a:lnSpc>
-                <a:spcPct val="90000"/>
-              </a:lnSpc>
-              <a:spcBef>
-                <a:spcPts val="500"/>
-              </a:spcBef>
-              <a:buFont typeface="Arial" panose="020B0604020202020204" pitchFamily="34" charset="0"/>
-              <a:buChar char="•"/>
-              <a:defRPr sz="1800" kern="1200">
-                <a:solidFill>
-                  <a:schemeClr val="tx1"/>
-                </a:solidFill>
-                <a:latin typeface="+mn-lt"/>
-                <a:ea typeface="+mn-ea"/>
-                <a:cs typeface="+mn-cs"/>
-              </a:defRPr>
-            </a:lvl4pPr>
-            <a:lvl5pPr marL="2057400" indent="-228600" algn="l" defTabSz="914400" rtl="0" eaLnBrk="1" latinLnBrk="0" hangingPunct="1">
-              <a:lnSpc>
-                <a:spcPct val="90000"/>
-              </a:lnSpc>
-              <a:spcBef>
-                <a:spcPts val="500"/>
-              </a:spcBef>
-              <a:buFont typeface="Arial" panose="020B0604020202020204" pitchFamily="34" charset="0"/>
-              <a:buChar char="•"/>
-              <a:defRPr sz="1800" kern="1200">
-                <a:solidFill>
-                  <a:schemeClr val="tx1"/>
-                </a:solidFill>
-                <a:latin typeface="+mn-lt"/>
-                <a:ea typeface="+mn-ea"/>
-                <a:cs typeface="+mn-cs"/>
-              </a:defRPr>
-            </a:lvl5pPr>
-            <a:lvl6pPr marL="2514600" indent="-228600" algn="l" defTabSz="914400" rtl="0" eaLnBrk="1" latinLnBrk="0" hangingPunct="1">
-              <a:lnSpc>
-                <a:spcPct val="90000"/>
-              </a:lnSpc>
-              <a:spcBef>
-                <a:spcPts val="500"/>
-              </a:spcBef>
-              <a:buFont typeface="Arial" panose="020B0604020202020204" pitchFamily="34" charset="0"/>
-              <a:buChar char="•"/>
-              <a:defRPr sz="1800" kern="1200">
-                <a:solidFill>
-                  <a:schemeClr val="tx1"/>
-                </a:solidFill>
-                <a:latin typeface="+mn-lt"/>
-                <a:ea typeface="+mn-ea"/>
-                <a:cs typeface="+mn-cs"/>
-              </a:defRPr>
-            </a:lvl6pPr>
-            <a:lvl7pPr marL="2971800" indent="-228600" algn="l" defTabSz="914400" rtl="0" eaLnBrk="1" latinLnBrk="0" hangingPunct="1">
-              <a:lnSpc>
-                <a:spcPct val="90000"/>
-              </a:lnSpc>
-              <a:spcBef>
-                <a:spcPts val="500"/>
-              </a:spcBef>
-              <a:buFont typeface="Arial" panose="020B0604020202020204" pitchFamily="34" charset="0"/>
-              <a:buChar char="•"/>
-              <a:defRPr sz="1800" kern="1200">
-                <a:solidFill>
-                  <a:schemeClr val="tx1"/>
-                </a:solidFill>
-                <a:latin typeface="+mn-lt"/>
-                <a:ea typeface="+mn-ea"/>
-                <a:cs typeface="+mn-cs"/>
-              </a:defRPr>
-            </a:lvl7pPr>
-            <a:lvl8pPr marL="3429000" indent="-228600" algn="l" defTabSz="914400" rtl="0" eaLnBrk="1" latinLnBrk="0" hangingPunct="1">
-              <a:lnSpc>
-                <a:spcPct val="90000"/>
-              </a:lnSpc>
-              <a:spcBef>
-                <a:spcPts val="500"/>
-              </a:spcBef>
-              <a:buFont typeface="Arial" panose="020B0604020202020204" pitchFamily="34" charset="0"/>
-              <a:buChar char="•"/>
-              <a:defRPr sz="1800" kern="1200">
-                <a:solidFill>
-                  <a:schemeClr val="tx1"/>
-                </a:solidFill>
-                <a:latin typeface="+mn-lt"/>
-                <a:ea typeface="+mn-ea"/>
-                <a:cs typeface="+mn-cs"/>
-              </a:defRPr>
-            </a:lvl8pPr>
-            <a:lvl9pPr marL="3886200" indent="-228600" algn="l" defTabSz="914400" rtl="0" eaLnBrk="1" latinLnBrk="0" hangingPunct="1">
-              <a:lnSpc>
-                <a:spcPct val="90000"/>
-              </a:lnSpc>
-              <a:spcBef>
-                <a:spcPts val="500"/>
-              </a:spcBef>
-              <a:buFont typeface="Arial" panose="020B0604020202020204" pitchFamily="34" charset="0"/>
-              <a:buChar char="•"/>
-              <a:defRPr sz="1800" kern="1200">
-                <a:solidFill>
-                  <a:schemeClr val="tx1"/>
-                </a:solidFill>
-                <a:latin typeface="+mn-lt"/>
-                <a:ea typeface="+mn-ea"/>
-                <a:cs typeface="+mn-cs"/>
-              </a:defRPr>
-            </a:lvl9pPr>
-          </a:lstStyle>
-          <a:p>
-            <a:pPr marL="457200" lvl="1" indent="0" algn="just">
-              <a:lnSpc>
-                <a:spcPct val="150000"/>
-              </a:lnSpc>
-              <a:buNone/>
-            </a:pPr>
-            <a:endParaRPr lang="en-US" sz="1800" b="1" dirty="0">
-              <a:latin typeface="Consolas" panose="020B0609020204030204" pitchFamily="49" charset="0"/>
-            </a:endParaRPr>
+            <a:endParaRPr lang="fr-CA" dirty="0"/>
           </a:p>
         </p:txBody>
       </p:sp>
@@ -23425,7 +23223,7 @@
         </p:nvGrpSpPr>
         <p:grpSpPr>
           <a:xfrm>
-            <a:off x="3083673" y="5825363"/>
+            <a:off x="3083673" y="5708633"/>
             <a:ext cx="6024654" cy="504000"/>
             <a:chOff x="6682372" y="3766184"/>
             <a:chExt cx="6801271" cy="768000"/>
@@ -23653,7 +23451,7 @@
         </p:nvGrpSpPr>
         <p:grpSpPr>
           <a:xfrm>
-            <a:off x="3857466" y="4274273"/>
+            <a:off x="3857466" y="4157543"/>
             <a:ext cx="4477068" cy="1277456"/>
             <a:chOff x="6658831" y="4690909"/>
             <a:chExt cx="4477068" cy="1277456"/>
@@ -23904,102 +23702,6 @@
   <p:clrMapOvr>
     <a:masterClrMapping/>
   </p:clrMapOvr>
-  <p:timing>
-    <p:tnLst>
-      <p:par>
-        <p:cTn id="1" dur="indefinite" restart="never" nodeType="tmRoot">
-          <p:childTnLst>
-            <p:seq concurrent="1" nextAc="seek">
-              <p:cTn id="2" dur="indefinite" nodeType="mainSeq">
-                <p:childTnLst>
-                  <p:par>
-                    <p:cTn id="3" fill="hold">
-                      <p:stCondLst>
-                        <p:cond delay="indefinite"/>
-                      </p:stCondLst>
-                      <p:childTnLst>
-                        <p:par>
-                          <p:cTn id="4" fill="hold">
-                            <p:stCondLst>
-                              <p:cond delay="0"/>
-                            </p:stCondLst>
-                            <p:childTnLst>
-                              <p:par>
-                                <p:cTn id="5" presetID="10" presetClass="entr" presetSubtype="0" fill="hold" nodeType="clickEffect" nodePh="1">
-                                  <p:stCondLst>
-                                    <p:cond delay="0"/>
-                                  </p:stCondLst>
-                                  <p:endCondLst>
-                                    <p:cond evt="begin" delay="0">
-                                      <p:tn val="5"/>
-                                    </p:cond>
-                                  </p:endCondLst>
-                                  <p:childTnLst>
-                                    <p:set>
-                                      <p:cBhvr>
-                                        <p:cTn id="6" dur="1" fill="hold">
-                                          <p:stCondLst>
-                                            <p:cond delay="0"/>
-                                          </p:stCondLst>
-                                        </p:cTn>
-                                        <p:tgtEl>
-                                          <p:spTgt spid="9">
-                                            <p:txEl>
-                                              <p:pRg st="0" end="0"/>
-                                            </p:txEl>
-                                          </p:spTgt>
-                                        </p:tgtEl>
-                                        <p:attrNameLst>
-                                          <p:attrName>style.visibility</p:attrName>
-                                        </p:attrNameLst>
-                                      </p:cBhvr>
-                                      <p:to>
-                                        <p:strVal val="visible"/>
-                                      </p:to>
-                                    </p:set>
-                                    <p:animEffect transition="in" filter="fade">
-                                      <p:cBhvr>
-                                        <p:cTn id="7" dur="500"/>
-                                        <p:tgtEl>
-                                          <p:spTgt spid="9">
-                                            <p:txEl>
-                                              <p:pRg st="0" end="0"/>
-                                            </p:txEl>
-                                          </p:spTgt>
-                                        </p:tgtEl>
-                                      </p:cBhvr>
-                                    </p:animEffect>
-                                  </p:childTnLst>
-                                </p:cTn>
-                              </p:par>
-                            </p:childTnLst>
-                          </p:cTn>
-                        </p:par>
-                      </p:childTnLst>
-                    </p:cTn>
-                  </p:par>
-                </p:childTnLst>
-              </p:cTn>
-              <p:prevCondLst>
-                <p:cond evt="onPrev" delay="0">
-                  <p:tgtEl>
-                    <p:sldTgt/>
-                  </p:tgtEl>
-                </p:cond>
-              </p:prevCondLst>
-              <p:nextCondLst>
-                <p:cond evt="onNext" delay="0">
-                  <p:tgtEl>
-                    <p:sldTgt/>
-                  </p:tgtEl>
-                </p:cond>
-              </p:nextCondLst>
-            </p:seq>
-          </p:childTnLst>
-        </p:cTn>
-      </p:par>
-    </p:tnLst>
-  </p:timing>
 </p:sld>
 </file>
 
@@ -25219,28 +24921,40 @@
               <a:t> </a:t>
             </a:r>
             <a:r>
-              <a:rPr lang="en-US" sz="1800" dirty="0" err="1">
+              <a:rPr lang="en-US" sz="1800" b="1" dirty="0" err="1">
                 <a:latin typeface="Consolas" panose="020B0609020204030204" pitchFamily="49" charset="0"/>
               </a:rPr>
               <a:t>l'opérateur</a:t>
             </a:r>
             <a:r>
+              <a:rPr lang="en-US" sz="1800" b="1" dirty="0">
+                <a:latin typeface="Consolas" panose="020B0609020204030204" pitchFamily="49" charset="0"/>
+              </a:rPr>
+              <a:t> </a:t>
+            </a:r>
+            <a:r>
+              <a:rPr lang="en-US" sz="1800" b="1" dirty="0" err="1">
+                <a:latin typeface="Consolas" panose="020B0609020204030204" pitchFamily="49" charset="0"/>
+              </a:rPr>
+              <a:t>d'accès</a:t>
+            </a:r>
+            <a:r>
               <a:rPr lang="en-US" sz="1800" dirty="0">
                 <a:latin typeface="Consolas" panose="020B0609020204030204" pitchFamily="49" charset="0"/>
               </a:rPr>
-              <a:t> </a:t>
-            </a:r>
-            <a:r>
-              <a:rPr lang="en-US" sz="1800" dirty="0" err="1">
-                <a:latin typeface="Consolas" panose="020B0609020204030204" pitchFamily="49" charset="0"/>
-              </a:rPr>
-              <a:t>d'accès</a:t>
+              <a:t> qui correspond à un </a:t>
+            </a:r>
+            <a:r>
+              <a:rPr lang="en-US" sz="1800" b="1" dirty="0">
+                <a:latin typeface="Consolas" panose="020B0609020204030204" pitchFamily="49" charset="0"/>
+              </a:rPr>
+              <a:t>point</a:t>
             </a:r>
             <a:r>
               <a:rPr lang="en-US" sz="1800" dirty="0">
                 <a:latin typeface="Consolas" panose="020B0609020204030204" pitchFamily="49" charset="0"/>
               </a:rPr>
-              <a:t> qui correspond à un point entre le nom de </a:t>
+              <a:t> entre le nom de </a:t>
             </a:r>
             <a:r>
               <a:rPr lang="en-US" sz="1800" dirty="0" err="1">
@@ -25334,6 +25048,18 @@
               </a:lnSpc>
             </a:pPr>
             <a:r>
+              <a:rPr lang="fr-FR" sz="1800" b="1" dirty="0">
+                <a:solidFill>
+                  <a:srgbClr val="000000"/>
+                </a:solidFill>
+                <a:latin typeface="Consolas"/>
+                <a:ea typeface="Consolas"/>
+                <a:cs typeface="Consolas"/>
+                <a:sym typeface="Consolas"/>
+              </a:rPr>
+              <a:t>En mots:</a:t>
+            </a:r>
+            <a:r>
               <a:rPr lang="fr-FR" sz="1800" dirty="0">
                 <a:solidFill>
                   <a:srgbClr val="000000"/>
@@ -25343,7 +25069,7 @@
                 <a:cs typeface="Consolas"/>
                 <a:sym typeface="Consolas"/>
               </a:rPr>
-              <a:t>Nous avons créé une instance de la classe </a:t>
+              <a:t> Nous avons créé une instance de la classe </a:t>
             </a:r>
             <a:r>
               <a:rPr lang="fr-FR" sz="1800" dirty="0" err="1">
@@ -26035,7 +25761,7 @@
                 <a:buNone/>
               </a:pPr>
               <a:r>
-                <a:rPr lang="fr-CA" sz="1400" b="0" i="0" u="none" strike="noStrike" cap="none">
+                <a:rPr lang="fr-CA" sz="1400" b="0" i="0" u="none" strike="noStrike" cap="none" dirty="0">
                   <a:solidFill>
                     <a:srgbClr val="FFFFFF"/>
                   </a:solidFill>
@@ -26046,7 +25772,7 @@
                 </a:rPr>
                 <a:t>&gt;&gt;&gt; liste = [1, 2]</a:t>
               </a:r>
-              <a:endParaRPr/>
+              <a:endParaRPr dirty="0"/>
             </a:p>
             <a:p>
               <a:pPr marL="0" marR="0" lvl="0" indent="0" algn="l" rtl="0">
@@ -26067,7 +25793,7 @@
                 <a:buNone/>
               </a:pPr>
               <a:r>
-                <a:rPr lang="fr-CA" sz="1400" b="0" i="0" u="none" strike="noStrike" cap="none">
+                <a:rPr lang="fr-CA" sz="1400" b="0" i="0" u="none" strike="noStrike" cap="none" dirty="0">
                   <a:solidFill>
                     <a:srgbClr val="FFFFFF"/>
                   </a:solidFill>
@@ -26076,9 +25802,33 @@
                   <a:cs typeface="Consolas"/>
                   <a:sym typeface="Consolas"/>
                 </a:rPr>
-                <a:t>&gt;&gt;&gt; liste.extend([3, 4])</a:t>
+                <a:t>&gt;&gt;&gt; </a:t>
               </a:r>
-              <a:endParaRPr/>
+              <a:r>
+                <a:rPr lang="fr-CA" sz="1400" b="0" i="0" u="none" strike="noStrike" cap="none" dirty="0" err="1">
+                  <a:solidFill>
+                    <a:srgbClr val="FFFFFF"/>
+                  </a:solidFill>
+                  <a:latin typeface="Consolas"/>
+                  <a:ea typeface="Consolas"/>
+                  <a:cs typeface="Consolas"/>
+                  <a:sym typeface="Consolas"/>
+                </a:rPr>
+                <a:t>liste.extend</a:t>
+              </a:r>
+              <a:r>
+                <a:rPr lang="fr-CA" sz="1400" b="0" i="0" u="none" strike="noStrike" cap="none" dirty="0">
+                  <a:solidFill>
+                    <a:srgbClr val="FFFFFF"/>
+                  </a:solidFill>
+                  <a:latin typeface="Consolas"/>
+                  <a:ea typeface="Consolas"/>
+                  <a:cs typeface="Consolas"/>
+                  <a:sym typeface="Consolas"/>
+                </a:rPr>
+                <a:t>([3, 4])</a:t>
+              </a:r>
+              <a:endParaRPr dirty="0"/>
             </a:p>
             <a:p>
               <a:pPr marL="0" marR="0" lvl="0" indent="0" algn="l" rtl="0">
@@ -26099,7 +25849,7 @@
                 <a:buNone/>
               </a:pPr>
               <a:r>
-                <a:rPr lang="fr-CA" sz="1400" b="0" i="0" u="none" strike="noStrike" cap="none">
+                <a:rPr lang="fr-CA" sz="1400" b="0" i="0" u="none" strike="noStrike" cap="none" dirty="0">
                   <a:solidFill>
                     <a:srgbClr val="FFFFFF"/>
                   </a:solidFill>
@@ -26108,10 +25858,34 @@
                   <a:cs typeface="Consolas"/>
                   <a:sym typeface="Consolas"/>
                 </a:rPr>
-                <a:t>&gt;&gt;&gt; print(liste)</a:t>
+                <a:t>&gt;&gt;&gt; </a:t>
+              </a:r>
+              <a:r>
+                <a:rPr lang="fr-CA" sz="1400" b="0" i="0" u="none" strike="noStrike" cap="none" dirty="0" err="1">
+                  <a:solidFill>
+                    <a:srgbClr val="FFFFFF"/>
+                  </a:solidFill>
+                  <a:latin typeface="Consolas"/>
+                  <a:ea typeface="Consolas"/>
+                  <a:cs typeface="Consolas"/>
+                  <a:sym typeface="Consolas"/>
+                </a:rPr>
+                <a:t>print</a:t>
+              </a:r>
+              <a:r>
+                <a:rPr lang="fr-CA" sz="1400" b="0" i="0" u="none" strike="noStrike" cap="none" dirty="0">
+                  <a:solidFill>
+                    <a:srgbClr val="FFFFFF"/>
+                  </a:solidFill>
+                  <a:latin typeface="Consolas"/>
+                  <a:ea typeface="Consolas"/>
+                  <a:cs typeface="Consolas"/>
+                  <a:sym typeface="Consolas"/>
+                </a:rPr>
+                <a:t>(liste)</a:t>
               </a:r>
               <a:br>
-                <a:rPr lang="fr-CA" sz="1400" b="0" i="0" u="none" strike="noStrike" cap="none">
+                <a:rPr lang="fr-CA" sz="1400" b="0" i="0" u="none" strike="noStrike" cap="none" dirty="0">
                   <a:solidFill>
                     <a:srgbClr val="FFFFFF"/>
                   </a:solidFill>
@@ -26122,7 +25896,7 @@
                 </a:rPr>
               </a:br>
               <a:r>
-                <a:rPr lang="fr-CA" sz="1400" b="0" i="0" u="none" strike="noStrike" cap="none">
+                <a:rPr lang="fr-CA" sz="1400" b="0" i="0" u="none" strike="noStrike" cap="none" dirty="0">
                   <a:solidFill>
                     <a:srgbClr val="FFFFFF"/>
                   </a:solidFill>
@@ -26133,7 +25907,7 @@
                 </a:rPr>
                 <a:t>[1, 2, 3, 4]</a:t>
               </a:r>
-              <a:endParaRPr sz="1400" b="0" i="0" u="none" strike="noStrike" cap="none">
+              <a:endParaRPr sz="1400" b="0" i="0" u="none" strike="noStrike" cap="none" dirty="0">
                 <a:solidFill>
                   <a:srgbClr val="FFFFFF"/>
                 </a:solidFill>
@@ -26261,6 +26035,466 @@
     <p:bg>
       <p:bgPr>
         <a:solidFill>
+          <a:schemeClr val="accent6">
+            <a:lumMod val="20000"/>
+            <a:lumOff val="80000"/>
+          </a:schemeClr>
+        </a:solidFill>
+        <a:effectLst/>
+      </p:bgPr>
+    </p:bg>
+    <p:spTree>
+      <p:nvGrpSpPr>
+        <p:cNvPr id="1" name="">
+          <a:extLst>
+            <a:ext uri="{FF2B5EF4-FFF2-40B4-BE49-F238E27FC236}">
+              <a16:creationId xmlns:a16="http://schemas.microsoft.com/office/drawing/2014/main" id="{808E75C2-6E05-D4AE-5915-518C66CDFFB4}"/>
+            </a:ext>
+          </a:extLst>
+        </p:cNvPr>
+        <p:cNvGrpSpPr/>
+        <p:nvPr/>
+      </p:nvGrpSpPr>
+      <p:grpSpPr>
+        <a:xfrm>
+          <a:off x="0" y="0"/>
+          <a:ext cx="0" cy="0"/>
+          <a:chOff x="0" y="0"/>
+          <a:chExt cx="0" cy="0"/>
+        </a:xfrm>
+      </p:grpSpPr>
+      <p:sp>
+        <p:nvSpPr>
+          <p:cNvPr id="2" name="Title 1">
+            <a:extLst>
+              <a:ext uri="{FF2B5EF4-FFF2-40B4-BE49-F238E27FC236}">
+                <a16:creationId xmlns:a16="http://schemas.microsoft.com/office/drawing/2014/main" id="{DFCE78E3-6E2F-2513-0701-01EE22E72B4D}"/>
+              </a:ext>
+            </a:extLst>
+          </p:cNvPr>
+          <p:cNvSpPr>
+            <a:spLocks noGrp="1"/>
+          </p:cNvSpPr>
+          <p:nvPr>
+            <p:ph type="title"/>
+          </p:nvPr>
+        </p:nvSpPr>
+        <p:spPr/>
+        <p:txBody>
+          <a:bodyPr/>
+          <a:lstStyle/>
+          <a:p>
+            <a:r>
+              <a:rPr lang="en-US" dirty="0">
+                <a:latin typeface="Arial Rounded MT Bold" panose="020F0704030504030204" pitchFamily="34" charset="0"/>
+              </a:rPr>
+              <a:t>XR6 – Moyenne et </a:t>
+            </a:r>
+            <a:r>
+              <a:rPr lang="en-US" dirty="0" err="1">
+                <a:latin typeface="Arial Rounded MT Bold" panose="020F0704030504030204" pitchFamily="34" charset="0"/>
+              </a:rPr>
+              <a:t>écart</a:t>
+            </a:r>
+            <a:r>
+              <a:rPr lang="en-US" dirty="0">
+                <a:latin typeface="Arial Rounded MT Bold" panose="020F0704030504030204" pitchFamily="34" charset="0"/>
+              </a:rPr>
+              <a:t>-type</a:t>
+            </a:r>
+            <a:endParaRPr lang="fr-CA" dirty="0">
+              <a:latin typeface="Arial Rounded MT Bold" panose="020F0704030504030204" pitchFamily="34" charset="0"/>
+            </a:endParaRPr>
+          </a:p>
+        </p:txBody>
+      </p:sp>
+      <p:sp>
+        <p:nvSpPr>
+          <p:cNvPr id="3" name="Content Placeholder 2">
+            <a:extLst>
+              <a:ext uri="{FF2B5EF4-FFF2-40B4-BE49-F238E27FC236}">
+                <a16:creationId xmlns:a16="http://schemas.microsoft.com/office/drawing/2014/main" id="{E5BFA73A-5F16-C1DB-89AE-EB491A024297}"/>
+              </a:ext>
+            </a:extLst>
+          </p:cNvPr>
+          <p:cNvSpPr>
+            <a:spLocks noGrp="1"/>
+          </p:cNvSpPr>
+          <p:nvPr>
+            <p:ph idx="1"/>
+          </p:nvPr>
+        </p:nvSpPr>
+        <p:spPr/>
+        <p:txBody>
+          <a:bodyPr>
+            <a:normAutofit/>
+          </a:bodyPr>
+          <a:lstStyle/>
+          <a:p>
+            <a:pPr marL="0" indent="0" algn="just">
+              <a:lnSpc>
+                <a:spcPct val="100000"/>
+              </a:lnSpc>
+              <a:buNone/>
+            </a:pPr>
+            <a:r>
+              <a:rPr lang="en-US" sz="2200" dirty="0" err="1">
+                <a:latin typeface="Consolas" panose="020B0609020204030204" pitchFamily="49" charset="0"/>
+              </a:rPr>
+              <a:t>Implémentez</a:t>
+            </a:r>
+            <a:r>
+              <a:rPr lang="en-US" sz="2200" dirty="0">
+                <a:latin typeface="Consolas" panose="020B0609020204030204" pitchFamily="49" charset="0"/>
+              </a:rPr>
+              <a:t> la function </a:t>
+            </a:r>
+            <a:r>
+              <a:rPr lang="en-US" sz="2200" b="1" dirty="0" err="1">
+                <a:latin typeface="Consolas" panose="020B0609020204030204" pitchFamily="49" charset="0"/>
+              </a:rPr>
+              <a:t>afficher_moyenne_ecart_type</a:t>
+            </a:r>
+            <a:r>
+              <a:rPr lang="en-US" sz="2200" b="1" dirty="0">
+                <a:latin typeface="Consolas" panose="020B0609020204030204" pitchFamily="49" charset="0"/>
+              </a:rPr>
+              <a:t> </a:t>
+            </a:r>
+            <a:r>
+              <a:rPr lang="en-US" sz="2200" dirty="0">
+                <a:latin typeface="Consolas" panose="020B0609020204030204" pitchFamily="49" charset="0"/>
+              </a:rPr>
+              <a:t>qui suit:</a:t>
+            </a:r>
+          </a:p>
+          <a:p>
+            <a:pPr marL="0" indent="0" algn="just">
+              <a:lnSpc>
+                <a:spcPct val="100000"/>
+              </a:lnSpc>
+              <a:buNone/>
+            </a:pPr>
+            <a:endParaRPr lang="en-US" sz="200" dirty="0">
+              <a:latin typeface="Consolas" panose="020B0609020204030204" pitchFamily="49" charset="0"/>
+            </a:endParaRPr>
+          </a:p>
+          <a:p>
+            <a:pPr marL="457200" lvl="1" indent="0" algn="just">
+              <a:lnSpc>
+                <a:spcPct val="100000"/>
+              </a:lnSpc>
+              <a:buNone/>
+            </a:pPr>
+            <a:r>
+              <a:rPr lang="fr-CA" sz="2000" b="1" dirty="0">
+                <a:latin typeface="Consolas" panose="020B0609020204030204" pitchFamily="49" charset="0"/>
+              </a:rPr>
+              <a:t>&gt;&gt;&gt; </a:t>
+            </a:r>
+            <a:r>
+              <a:rPr lang="fr-CA" sz="2000" b="1" dirty="0" err="1">
+                <a:latin typeface="Consolas" panose="020B0609020204030204" pitchFamily="49" charset="0"/>
+              </a:rPr>
+              <a:t>afficher_moyenne_ecart_type</a:t>
+            </a:r>
+            <a:r>
+              <a:rPr lang="fr-CA" sz="2000" b="1">
+                <a:latin typeface="Consolas" panose="020B0609020204030204" pitchFamily="49" charset="0"/>
+              </a:rPr>
+              <a:t>()</a:t>
+            </a:r>
+            <a:endParaRPr lang="fr-CA" sz="2000" b="1" dirty="0">
+              <a:latin typeface="Consolas" panose="020B0609020204030204" pitchFamily="49" charset="0"/>
+            </a:endParaRPr>
+          </a:p>
+          <a:p>
+            <a:pPr marL="457200" lvl="1" indent="0" algn="just">
+              <a:lnSpc>
+                <a:spcPct val="100000"/>
+              </a:lnSpc>
+              <a:buNone/>
+            </a:pPr>
+            <a:r>
+              <a:rPr lang="fr-CA" sz="2000" dirty="0" err="1">
+                <a:solidFill>
+                  <a:schemeClr val="bg1">
+                    <a:lumMod val="50000"/>
+                  </a:schemeClr>
+                </a:solidFill>
+                <a:latin typeface="Consolas" panose="020B0609020204030204" pitchFamily="49" charset="0"/>
+              </a:rPr>
+              <a:t>Saissez</a:t>
+            </a:r>
+            <a:r>
+              <a:rPr lang="fr-CA" sz="2000" dirty="0">
+                <a:solidFill>
+                  <a:schemeClr val="bg1">
+                    <a:lumMod val="50000"/>
+                  </a:schemeClr>
+                </a:solidFill>
+                <a:latin typeface="Consolas" panose="020B0609020204030204" pitchFamily="49" charset="0"/>
+              </a:rPr>
+              <a:t> une valeur (rien pour quitter): 1</a:t>
+            </a:r>
+          </a:p>
+          <a:p>
+            <a:pPr marL="457200" lvl="1" indent="0" algn="just">
+              <a:lnSpc>
+                <a:spcPct val="100000"/>
+              </a:lnSpc>
+              <a:buNone/>
+            </a:pPr>
+            <a:r>
+              <a:rPr lang="fr-CA" sz="2000" dirty="0" err="1">
+                <a:solidFill>
+                  <a:schemeClr val="bg1">
+                    <a:lumMod val="50000"/>
+                  </a:schemeClr>
+                </a:solidFill>
+                <a:latin typeface="Consolas" panose="020B0609020204030204" pitchFamily="49" charset="0"/>
+              </a:rPr>
+              <a:t>Saissez</a:t>
+            </a:r>
+            <a:r>
+              <a:rPr lang="fr-CA" sz="2000" dirty="0">
+                <a:solidFill>
+                  <a:schemeClr val="bg1">
+                    <a:lumMod val="50000"/>
+                  </a:schemeClr>
+                </a:solidFill>
+                <a:latin typeface="Consolas" panose="020B0609020204030204" pitchFamily="49" charset="0"/>
+              </a:rPr>
+              <a:t> une valeur (rien pour quitter): 2</a:t>
+            </a:r>
+          </a:p>
+          <a:p>
+            <a:pPr marL="457200" lvl="1" indent="0" algn="just">
+              <a:lnSpc>
+                <a:spcPct val="100000"/>
+              </a:lnSpc>
+              <a:buNone/>
+            </a:pPr>
+            <a:r>
+              <a:rPr lang="fr-CA" sz="2000" dirty="0" err="1">
+                <a:solidFill>
+                  <a:schemeClr val="bg1">
+                    <a:lumMod val="50000"/>
+                  </a:schemeClr>
+                </a:solidFill>
+                <a:latin typeface="Consolas" panose="020B0609020204030204" pitchFamily="49" charset="0"/>
+              </a:rPr>
+              <a:t>Saissez</a:t>
+            </a:r>
+            <a:r>
+              <a:rPr lang="fr-CA" sz="2000" dirty="0">
+                <a:solidFill>
+                  <a:schemeClr val="bg1">
+                    <a:lumMod val="50000"/>
+                  </a:schemeClr>
+                </a:solidFill>
+                <a:latin typeface="Consolas" panose="020B0609020204030204" pitchFamily="49" charset="0"/>
+              </a:rPr>
+              <a:t> une valeur (rien pour quitter): 3</a:t>
+            </a:r>
+          </a:p>
+          <a:p>
+            <a:pPr marL="457200" lvl="1" indent="0" algn="just">
+              <a:lnSpc>
+                <a:spcPct val="100000"/>
+              </a:lnSpc>
+              <a:buNone/>
+            </a:pPr>
+            <a:r>
+              <a:rPr lang="fr-CA" sz="2000" dirty="0" err="1">
+                <a:solidFill>
+                  <a:schemeClr val="bg1">
+                    <a:lumMod val="50000"/>
+                  </a:schemeClr>
+                </a:solidFill>
+                <a:latin typeface="Consolas" panose="020B0609020204030204" pitchFamily="49" charset="0"/>
+              </a:rPr>
+              <a:t>Saissez</a:t>
+            </a:r>
+            <a:r>
+              <a:rPr lang="fr-CA" sz="2000" dirty="0">
+                <a:solidFill>
+                  <a:schemeClr val="bg1">
+                    <a:lumMod val="50000"/>
+                  </a:schemeClr>
+                </a:solidFill>
+                <a:latin typeface="Consolas" panose="020B0609020204030204" pitchFamily="49" charset="0"/>
+              </a:rPr>
+              <a:t> une valeur (rien pour quitter): 4</a:t>
+            </a:r>
+          </a:p>
+          <a:p>
+            <a:pPr marL="457200" lvl="1" indent="0" algn="just">
+              <a:lnSpc>
+                <a:spcPct val="100000"/>
+              </a:lnSpc>
+              <a:buNone/>
+            </a:pPr>
+            <a:r>
+              <a:rPr lang="fr-CA" sz="2000" dirty="0" err="1">
+                <a:solidFill>
+                  <a:schemeClr val="bg1">
+                    <a:lumMod val="50000"/>
+                  </a:schemeClr>
+                </a:solidFill>
+                <a:latin typeface="Consolas" panose="020B0609020204030204" pitchFamily="49" charset="0"/>
+              </a:rPr>
+              <a:t>Saissez</a:t>
+            </a:r>
+            <a:r>
+              <a:rPr lang="fr-CA" sz="2000" dirty="0">
+                <a:solidFill>
+                  <a:schemeClr val="bg1">
+                    <a:lumMod val="50000"/>
+                  </a:schemeClr>
+                </a:solidFill>
+                <a:latin typeface="Consolas" panose="020B0609020204030204" pitchFamily="49" charset="0"/>
+              </a:rPr>
+              <a:t> une valeur (rien pour quitter): 5</a:t>
+            </a:r>
+          </a:p>
+          <a:p>
+            <a:pPr marL="457200" lvl="1" indent="0" algn="just">
+              <a:lnSpc>
+                <a:spcPct val="100000"/>
+              </a:lnSpc>
+              <a:buNone/>
+            </a:pPr>
+            <a:r>
+              <a:rPr lang="fr-CA" sz="2000" dirty="0" err="1">
+                <a:solidFill>
+                  <a:schemeClr val="bg1">
+                    <a:lumMod val="50000"/>
+                  </a:schemeClr>
+                </a:solidFill>
+                <a:latin typeface="Consolas" panose="020B0609020204030204" pitchFamily="49" charset="0"/>
+              </a:rPr>
+              <a:t>Saissez</a:t>
+            </a:r>
+            <a:r>
+              <a:rPr lang="fr-CA" sz="2000" dirty="0">
+                <a:solidFill>
+                  <a:schemeClr val="bg1">
+                    <a:lumMod val="50000"/>
+                  </a:schemeClr>
+                </a:solidFill>
+                <a:latin typeface="Consolas" panose="020B0609020204030204" pitchFamily="49" charset="0"/>
+              </a:rPr>
+              <a:t> une valeur (rien pour quitter): </a:t>
+            </a:r>
+          </a:p>
+          <a:p>
+            <a:pPr marL="457200" lvl="1" indent="0" algn="just">
+              <a:lnSpc>
+                <a:spcPct val="100000"/>
+              </a:lnSpc>
+              <a:buNone/>
+            </a:pPr>
+            <a:r>
+              <a:rPr lang="fr-CA" sz="2000" dirty="0">
+                <a:solidFill>
+                  <a:schemeClr val="bg1">
+                    <a:lumMod val="50000"/>
+                  </a:schemeClr>
+                </a:solidFill>
+                <a:latin typeface="Consolas" panose="020B0609020204030204" pitchFamily="49" charset="0"/>
+              </a:rPr>
+              <a:t>Moyenne    : 3.0</a:t>
+            </a:r>
+          </a:p>
+          <a:p>
+            <a:pPr marL="457200" lvl="1" indent="0" algn="just">
+              <a:lnSpc>
+                <a:spcPct val="100000"/>
+              </a:lnSpc>
+              <a:buNone/>
+            </a:pPr>
+            <a:r>
+              <a:rPr lang="en-US" sz="2000" dirty="0" err="1">
+                <a:solidFill>
+                  <a:schemeClr val="bg1">
+                    <a:lumMod val="50000"/>
+                  </a:schemeClr>
+                </a:solidFill>
+                <a:latin typeface="Consolas" panose="020B0609020204030204" pitchFamily="49" charset="0"/>
+              </a:rPr>
+              <a:t>Écart</a:t>
+            </a:r>
+            <a:r>
+              <a:rPr lang="en-US" sz="2000" dirty="0">
+                <a:solidFill>
+                  <a:schemeClr val="bg1">
+                    <a:lumMod val="50000"/>
+                  </a:schemeClr>
+                </a:solidFill>
+                <a:latin typeface="Consolas" panose="020B0609020204030204" pitchFamily="49" charset="0"/>
+              </a:rPr>
+              <a:t>-type : 1.41420135623730951</a:t>
+            </a:r>
+            <a:endParaRPr lang="fr-CA" sz="2000" dirty="0">
+              <a:solidFill>
+                <a:schemeClr val="bg1">
+                  <a:lumMod val="50000"/>
+                </a:schemeClr>
+              </a:solidFill>
+              <a:latin typeface="Consolas" panose="020B0609020204030204" pitchFamily="49" charset="0"/>
+            </a:endParaRPr>
+          </a:p>
+        </p:txBody>
+      </p:sp>
+      <p:sp>
+        <p:nvSpPr>
+          <p:cNvPr id="4" name="Slide Number Placeholder 3">
+            <a:extLst>
+              <a:ext uri="{FF2B5EF4-FFF2-40B4-BE49-F238E27FC236}">
+                <a16:creationId xmlns:a16="http://schemas.microsoft.com/office/drawing/2014/main" id="{C73E7699-9260-2B26-4E4F-F82743E2161A}"/>
+              </a:ext>
+            </a:extLst>
+          </p:cNvPr>
+          <p:cNvSpPr>
+            <a:spLocks noGrp="1"/>
+          </p:cNvSpPr>
+          <p:nvPr>
+            <p:ph type="sldNum" sz="quarter" idx="12"/>
+          </p:nvPr>
+        </p:nvSpPr>
+        <p:spPr/>
+        <p:txBody>
+          <a:bodyPr/>
+          <a:lstStyle/>
+          <a:p>
+            <a:fld id="{846B06B1-1179-491F-A487-8E0C403F7C13}" type="slidenum">
+              <a:rPr lang="fr-CA" smtClean="0"/>
+              <a:t>31</a:t>
+            </a:fld>
+            <a:endParaRPr lang="fr-CA"/>
+          </a:p>
+        </p:txBody>
+      </p:sp>
+    </p:spTree>
+    <p:extLst>
+      <p:ext uri="{BB962C8B-B14F-4D97-AF65-F5344CB8AC3E}">
+        <p14:creationId xmlns:p14="http://schemas.microsoft.com/office/powerpoint/2010/main" val="1553947036"/>
+      </p:ext>
+    </p:extLst>
+  </p:cSld>
+  <p:clrMapOvr>
+    <a:masterClrMapping/>
+  </p:clrMapOvr>
+</p:sld>
+</file>
+
+<file path=ppt/slides/slide32.xml><?xml version="1.0" encoding="utf-8"?>
+<p:sld xmlns:a="http://schemas.openxmlformats.org/drawingml/2006/main" xmlns:r="http://schemas.openxmlformats.org/officeDocument/2006/relationships" xmlns:p="http://schemas.openxmlformats.org/presentationml/2006/main">
+  <p:cSld>
+    <p:bg>
+      <p:bgPr>
+        <a:solidFill>
           <a:schemeClr val="bg1">
             <a:lumMod val="95000"/>
           </a:schemeClr>
@@ -26344,7 +26578,7 @@
           <a:p>
             <a:fld id="{846B06B1-1179-491F-A487-8E0C403F7C13}" type="slidenum">
               <a:rPr lang="fr-CA" smtClean="0"/>
-              <a:t>31</a:t>
+              <a:t>32</a:t>
             </a:fld>
             <a:endParaRPr lang="fr-CA"/>
           </a:p>

</xml_diff>

<commit_message>
refactor: Clean python_1 presentation from slide no.1 to 11
</commit_message>
<xml_diff>
--- a/python_1/presentation_python_1.pptx
+++ b/python_1/presentation_python_1.pptx
@@ -228,7 +228,7 @@
           <a:p>
             <a:fld id="{17426931-AE65-4D08-8B32-62FCBDE55937}" type="datetimeFigureOut">
               <a:rPr lang="fr-CA" smtClean="0"/>
-              <a:t>2026-04-13</a:t>
+              <a:t>2026-04-14</a:t>
             </a:fld>
             <a:endParaRPr lang="fr-CA"/>
           </a:p>
@@ -645,7 +645,7 @@
           <a:p>
             <a:fld id="{73720E39-F9E6-45F4-9AF3-0670893E0E05}" type="datetime1">
               <a:rPr lang="fr-CA" smtClean="0"/>
-              <a:t>2026-04-13</a:t>
+              <a:t>2026-04-14</a:t>
             </a:fld>
             <a:endParaRPr lang="fr-CA"/>
           </a:p>
@@ -845,7 +845,7 @@
           <a:p>
             <a:fld id="{2A86A87F-FCE1-414B-898E-E056954DFB53}" type="datetime1">
               <a:rPr lang="fr-CA" smtClean="0"/>
-              <a:t>2026-04-13</a:t>
+              <a:t>2026-04-14</a:t>
             </a:fld>
             <a:endParaRPr lang="fr-CA"/>
           </a:p>
@@ -1055,7 +1055,7 @@
           <a:p>
             <a:fld id="{86217A25-A768-4FB5-8838-4C76F4A4D771}" type="datetime1">
               <a:rPr lang="fr-CA" smtClean="0"/>
-              <a:t>2026-04-13</a:t>
+              <a:t>2026-04-14</a:t>
             </a:fld>
             <a:endParaRPr lang="fr-CA"/>
           </a:p>
@@ -1255,7 +1255,7 @@
           <a:p>
             <a:fld id="{6DF5E9B1-F4B4-44A9-8978-A50A0AD8373C}" type="datetime1">
               <a:rPr lang="fr-CA" smtClean="0"/>
-              <a:t>2026-04-13</a:t>
+              <a:t>2026-04-14</a:t>
             </a:fld>
             <a:endParaRPr lang="fr-CA"/>
           </a:p>
@@ -1531,7 +1531,7 @@
           <a:p>
             <a:fld id="{5DE8FE0D-E91C-47AE-8B70-2B0ABA5D1B1E}" type="datetime1">
               <a:rPr lang="fr-CA" smtClean="0"/>
-              <a:t>2026-04-13</a:t>
+              <a:t>2026-04-14</a:t>
             </a:fld>
             <a:endParaRPr lang="fr-CA"/>
           </a:p>
@@ -1799,7 +1799,7 @@
           <a:p>
             <a:fld id="{F3AB8F30-8420-4011-A9ED-ED2F47883C93}" type="datetime1">
               <a:rPr lang="fr-CA" smtClean="0"/>
-              <a:t>2026-04-13</a:t>
+              <a:t>2026-04-14</a:t>
             </a:fld>
             <a:endParaRPr lang="fr-CA"/>
           </a:p>
@@ -2214,7 +2214,7 @@
           <a:p>
             <a:fld id="{852876F1-672F-46E4-BC46-E9D4C880BFEF}" type="datetime1">
               <a:rPr lang="fr-CA" smtClean="0"/>
-              <a:t>2026-04-13</a:t>
+              <a:t>2026-04-14</a:t>
             </a:fld>
             <a:endParaRPr lang="fr-CA"/>
           </a:p>
@@ -2356,7 +2356,7 @@
           <a:p>
             <a:fld id="{05494588-57AE-4A88-AA7D-14590C8ABB1D}" type="datetime1">
               <a:rPr lang="fr-CA" smtClean="0"/>
-              <a:t>2026-04-13</a:t>
+              <a:t>2026-04-14</a:t>
             </a:fld>
             <a:endParaRPr lang="fr-CA"/>
           </a:p>
@@ -2469,7 +2469,7 @@
           <a:p>
             <a:fld id="{70596107-F84A-4D89-B7EE-30826EF0EE70}" type="datetime1">
               <a:rPr lang="fr-CA" smtClean="0"/>
-              <a:t>2026-04-13</a:t>
+              <a:t>2026-04-14</a:t>
             </a:fld>
             <a:endParaRPr lang="fr-CA"/>
           </a:p>
@@ -2782,7 +2782,7 @@
           <a:p>
             <a:fld id="{12C269CA-6797-4965-A975-3F40F12DAD06}" type="datetime1">
               <a:rPr lang="fr-CA" smtClean="0"/>
-              <a:t>2026-04-13</a:t>
+              <a:t>2026-04-14</a:t>
             </a:fld>
             <a:endParaRPr lang="fr-CA"/>
           </a:p>
@@ -3071,7 +3071,7 @@
           <a:p>
             <a:fld id="{3F5AE234-69D2-4522-AB7A-F911A65753A0}" type="datetime1">
               <a:rPr lang="fr-CA" smtClean="0"/>
-              <a:t>2026-04-13</a:t>
+              <a:t>2026-04-14</a:t>
             </a:fld>
             <a:endParaRPr lang="fr-CA"/>
           </a:p>
@@ -3314,7 +3314,7 @@
           <a:p>
             <a:fld id="{30546B8D-50B2-4CF7-ACAA-221A68F8C882}" type="datetime1">
               <a:rPr lang="fr-CA" smtClean="0"/>
-              <a:t>2026-04-13</a:t>
+              <a:t>2026-04-14</a:t>
             </a:fld>
             <a:endParaRPr lang="fr-CA"/>
           </a:p>
@@ -3870,7 +3870,7 @@
         <p:spPr>
           <a:xfrm>
             <a:off x="2698481" y="2716450"/>
-            <a:ext cx="6795040" cy="2785378"/>
+            <a:ext cx="6795040" cy="2585323"/>
           </a:xfrm>
           <a:prstGeom prst="rect">
             <a:avLst/>
@@ -3890,117 +3890,433 @@
           </a:bodyPr>
           <a:lstStyle/>
           <a:p>
-            <a:br>
-              <a:rPr lang="pt-BR" sz="500" b="1" dirty="0">
-                <a:latin typeface="Consolas" panose="020B0609020204030204" pitchFamily="49" charset="0"/>
-              </a:rPr>
-            </a:br>
-            <a:r>
-              <a:rPr lang="pt-BR" b="1" dirty="0">
-                <a:latin typeface="Consolas" panose="020B0609020204030204" pitchFamily="49" charset="0"/>
-              </a:rPr>
-              <a:t>def calculer_afficher_racines(a, b, c):</a:t>
-            </a:r>
-          </a:p>
-          <a:p>
-            <a:endParaRPr lang="pt-BR" sz="100" b="1" dirty="0">
+            <a:pPr algn="l">
+              <a:buNone/>
+            </a:pPr>
+            <a:r>
+              <a:rPr lang="en-CA" b="1" i="0" dirty="0">
+                <a:solidFill>
+                  <a:srgbClr val="008800"/>
+                </a:solidFill>
+                <a:effectLst/>
+                <a:latin typeface="Consolas" panose="020B0609020204030204" pitchFamily="49" charset="0"/>
+              </a:rPr>
+              <a:t>def</a:t>
+            </a:r>
+            <a:r>
+              <a:rPr lang="en-CA" b="0" i="0" dirty="0">
+                <a:solidFill>
+                  <a:srgbClr val="BBBBBB"/>
+                </a:solidFill>
+                <a:effectLst/>
+                <a:latin typeface="Consolas" panose="020B0609020204030204" pitchFamily="49" charset="0"/>
+              </a:rPr>
+              <a:t> </a:t>
+            </a:r>
+            <a:r>
+              <a:rPr lang="en-CA" b="1" i="0" dirty="0" err="1">
+                <a:solidFill>
+                  <a:srgbClr val="0066BB"/>
+                </a:solidFill>
+                <a:effectLst/>
+                <a:latin typeface="Consolas" panose="020B0609020204030204" pitchFamily="49" charset="0"/>
+              </a:rPr>
+              <a:t>calculer_afficher_racines</a:t>
+            </a:r>
+            <a:r>
+              <a:rPr lang="en-CA" b="0" i="0" dirty="0">
+                <a:solidFill>
+                  <a:srgbClr val="333333"/>
+                </a:solidFill>
+                <a:effectLst/>
+                <a:latin typeface="Consolas" panose="020B0609020204030204" pitchFamily="49" charset="0"/>
+              </a:rPr>
+              <a:t>(a, b, c):</a:t>
+            </a:r>
+          </a:p>
+          <a:p>
+            <a:pPr algn="l">
+              <a:buNone/>
+            </a:pPr>
+            <a:endParaRPr lang="en-CA" b="0" i="0" dirty="0">
+              <a:solidFill>
+                <a:srgbClr val="333333"/>
+              </a:solidFill>
+              <a:effectLst/>
               <a:latin typeface="Consolas" panose="020B0609020204030204" pitchFamily="49" charset="0"/>
             </a:endParaRPr>
           </a:p>
           <a:p>
-            <a:r>
-              <a:rPr lang="pt-BR" b="1" dirty="0">
+            <a:pPr algn="l">
+              <a:buNone/>
+            </a:pPr>
+            <a:r>
+              <a:rPr lang="en-CA" b="0" i="0" dirty="0">
+                <a:solidFill>
+                  <a:srgbClr val="333333"/>
+                </a:solidFill>
+                <a:effectLst/>
                 <a:latin typeface="Consolas" panose="020B0609020204030204" pitchFamily="49" charset="0"/>
               </a:rPr>
               <a:t>  </a:t>
             </a:r>
-            <a:br>
-              <a:rPr lang="pt-BR" b="1" dirty="0">
-                <a:latin typeface="Consolas" panose="020B0609020204030204" pitchFamily="49" charset="0"/>
-              </a:rPr>
-            </a:br>
-            <a:r>
-              <a:rPr lang="pt-BR" b="1" dirty="0">
-                <a:latin typeface="Consolas" panose="020B0609020204030204" pitchFamily="49" charset="0"/>
-              </a:rPr>
-              <a:t>  </a:t>
-            </a:r>
-            <a:r>
-              <a:rPr lang="pt-BR" b="1" i="1" dirty="0">
-                <a:solidFill>
-                  <a:schemeClr val="accent6"/>
-                </a:solidFill>
-                <a:latin typeface="Consolas" panose="020B0609020204030204" pitchFamily="49" charset="0"/>
-              </a:rPr>
-              <a:t># Calcul des racines</a:t>
-            </a:r>
-          </a:p>
-          <a:p>
-            <a:r>
-              <a:rPr lang="pt-BR" b="1" dirty="0">
-                <a:latin typeface="Consolas" panose="020B0609020204030204" pitchFamily="49" charset="0"/>
-              </a:rPr>
-              <a:t>  RACINE_DISCRIMINANT = (b ** 2 - 4 * a * c) ** 0.5</a:t>
-            </a:r>
-          </a:p>
-          <a:p>
-            <a:r>
-              <a:rPr lang="pt-BR" b="1" dirty="0">
-                <a:latin typeface="Consolas" panose="020B0609020204030204" pitchFamily="49" charset="0"/>
-              </a:rPr>
-              <a:t>  racine_1 = (-b - RACINE_DISCRIMINANT ) / (2 * a)</a:t>
-            </a:r>
-          </a:p>
-          <a:p>
-            <a:r>
-              <a:rPr lang="pt-BR" b="1" dirty="0">
-                <a:latin typeface="Consolas" panose="020B0609020204030204" pitchFamily="49" charset="0"/>
-              </a:rPr>
-              <a:t>  racine_2 = (-b + RACINE_DISCRIMINANT ) / (2 * a)</a:t>
-            </a:r>
-          </a:p>
-          <a:p>
-            <a:br>
-              <a:rPr lang="pt-BR" sz="100" b="1" dirty="0">
-                <a:latin typeface="Consolas" panose="020B0609020204030204" pitchFamily="49" charset="0"/>
-              </a:rPr>
-            </a:br>
-            <a:endParaRPr lang="pt-BR" sz="100" b="1" dirty="0">
+            <a:r>
+              <a:rPr lang="en-CA" b="0" i="0" dirty="0">
+                <a:solidFill>
+                  <a:srgbClr val="888888"/>
+                </a:solidFill>
+                <a:effectLst/>
+                <a:latin typeface="Consolas" panose="020B0609020204030204" pitchFamily="49" charset="0"/>
+              </a:rPr>
+              <a:t># </a:t>
+            </a:r>
+            <a:r>
+              <a:rPr lang="en-CA" b="0" i="0" dirty="0" err="1">
+                <a:solidFill>
+                  <a:srgbClr val="888888"/>
+                </a:solidFill>
+                <a:effectLst/>
+                <a:latin typeface="Consolas" panose="020B0609020204030204" pitchFamily="49" charset="0"/>
+              </a:rPr>
+              <a:t>Calcul</a:t>
+            </a:r>
+            <a:r>
+              <a:rPr lang="en-CA" b="0" i="0" dirty="0">
+                <a:solidFill>
+                  <a:srgbClr val="888888"/>
+                </a:solidFill>
+                <a:effectLst/>
+                <a:latin typeface="Consolas" panose="020B0609020204030204" pitchFamily="49" charset="0"/>
+              </a:rPr>
+              <a:t> des </a:t>
+            </a:r>
+            <a:r>
+              <a:rPr lang="en-CA" b="0" i="0" dirty="0" err="1">
+                <a:solidFill>
+                  <a:srgbClr val="888888"/>
+                </a:solidFill>
+                <a:effectLst/>
+                <a:latin typeface="Consolas" panose="020B0609020204030204" pitchFamily="49" charset="0"/>
+              </a:rPr>
+              <a:t>racines</a:t>
+            </a:r>
+            <a:endParaRPr lang="en-CA" b="0" i="0" dirty="0">
+              <a:solidFill>
+                <a:srgbClr val="333333"/>
+              </a:solidFill>
+              <a:effectLst/>
               <a:latin typeface="Consolas" panose="020B0609020204030204" pitchFamily="49" charset="0"/>
             </a:endParaRPr>
           </a:p>
           <a:p>
-            <a:r>
-              <a:rPr lang="pt-BR" b="1" dirty="0">
+            <a:pPr algn="l">
+              <a:buNone/>
+            </a:pPr>
+            <a:r>
+              <a:rPr lang="en-CA" b="0" i="0" dirty="0">
+                <a:solidFill>
+                  <a:srgbClr val="333333"/>
+                </a:solidFill>
+                <a:effectLst/>
                 <a:latin typeface="Consolas" panose="020B0609020204030204" pitchFamily="49" charset="0"/>
               </a:rPr>
               <a:t>  </a:t>
             </a:r>
-          </a:p>
-          <a:p>
-            <a:r>
-              <a:rPr lang="pt-BR" b="1" i="1" dirty="0">
-                <a:solidFill>
-                  <a:schemeClr val="accent6"/>
-                </a:solidFill>
-                <a:latin typeface="Consolas" panose="020B0609020204030204" pitchFamily="49" charset="0"/>
-              </a:rPr>
-              <a:t>  # Affichage</a:t>
-            </a:r>
-          </a:p>
-          <a:p>
-            <a:r>
-              <a:rPr lang="pt-BR" b="1" dirty="0">
-                <a:latin typeface="Consolas" panose="020B0609020204030204" pitchFamily="49" charset="0"/>
-              </a:rPr>
-              <a:t>  print('r1 = ', racine_1, 'r2 = ', racine_2)</a:t>
-            </a:r>
-            <a:br>
-              <a:rPr lang="pt-BR" b="1" dirty="0">
-                <a:latin typeface="Consolas" panose="020B0609020204030204" pitchFamily="49" charset="0"/>
-              </a:rPr>
-            </a:br>
-            <a:endParaRPr lang="fr-CA" sz="500" dirty="0"/>
+            <a:r>
+              <a:rPr lang="en-CA" b="0" i="0" dirty="0" err="1">
+                <a:solidFill>
+                  <a:srgbClr val="333333"/>
+                </a:solidFill>
+                <a:effectLst/>
+                <a:latin typeface="Consolas" panose="020B0609020204030204" pitchFamily="49" charset="0"/>
+              </a:rPr>
+              <a:t>racine_discriminant</a:t>
+            </a:r>
+            <a:r>
+              <a:rPr lang="en-CA" b="0" i="0" dirty="0">
+                <a:solidFill>
+                  <a:srgbClr val="333333"/>
+                </a:solidFill>
+                <a:effectLst/>
+                <a:latin typeface="Consolas" panose="020B0609020204030204" pitchFamily="49" charset="0"/>
+              </a:rPr>
+              <a:t>= (b ** </a:t>
+            </a:r>
+            <a:r>
+              <a:rPr lang="en-CA" b="1" i="0" dirty="0">
+                <a:solidFill>
+                  <a:srgbClr val="0000DD"/>
+                </a:solidFill>
+                <a:effectLst/>
+                <a:latin typeface="Consolas" panose="020B0609020204030204" pitchFamily="49" charset="0"/>
+              </a:rPr>
+              <a:t>2</a:t>
+            </a:r>
+            <a:r>
+              <a:rPr lang="en-CA" b="0" i="0" dirty="0">
+                <a:solidFill>
+                  <a:srgbClr val="333333"/>
+                </a:solidFill>
+                <a:effectLst/>
+                <a:latin typeface="Consolas" panose="020B0609020204030204" pitchFamily="49" charset="0"/>
+              </a:rPr>
+              <a:t> - </a:t>
+            </a:r>
+            <a:r>
+              <a:rPr lang="en-CA" b="1" i="0" dirty="0">
+                <a:solidFill>
+                  <a:srgbClr val="0000DD"/>
+                </a:solidFill>
+                <a:effectLst/>
+                <a:latin typeface="Consolas" panose="020B0609020204030204" pitchFamily="49" charset="0"/>
+              </a:rPr>
+              <a:t>4</a:t>
+            </a:r>
+            <a:r>
+              <a:rPr lang="en-CA" b="0" i="0" dirty="0">
+                <a:solidFill>
+                  <a:srgbClr val="333333"/>
+                </a:solidFill>
+                <a:effectLst/>
+                <a:latin typeface="Consolas" panose="020B0609020204030204" pitchFamily="49" charset="0"/>
+              </a:rPr>
+              <a:t> * a * c) ** </a:t>
+            </a:r>
+            <a:r>
+              <a:rPr lang="en-CA" b="1" i="0" dirty="0">
+                <a:solidFill>
+                  <a:srgbClr val="6600EE"/>
+                </a:solidFill>
+                <a:effectLst/>
+                <a:latin typeface="Consolas" panose="020B0609020204030204" pitchFamily="49" charset="0"/>
+              </a:rPr>
+              <a:t>0.5</a:t>
+            </a:r>
+            <a:endParaRPr lang="en-CA" b="0" i="0" dirty="0">
+              <a:solidFill>
+                <a:srgbClr val="333333"/>
+              </a:solidFill>
+              <a:effectLst/>
+              <a:latin typeface="Consolas" panose="020B0609020204030204" pitchFamily="49" charset="0"/>
+            </a:endParaRPr>
+          </a:p>
+          <a:p>
+            <a:r>
+              <a:rPr lang="en-CA" b="0" i="0" dirty="0">
+                <a:solidFill>
+                  <a:srgbClr val="333333"/>
+                </a:solidFill>
+                <a:effectLst/>
+                <a:latin typeface="Consolas" panose="020B0609020204030204" pitchFamily="49" charset="0"/>
+              </a:rPr>
+              <a:t>  racine_1 = (-b </a:t>
+            </a:r>
+            <a:r>
+              <a:rPr lang="en-CA" dirty="0">
+                <a:solidFill>
+                  <a:srgbClr val="333333"/>
+                </a:solidFill>
+                <a:latin typeface="Consolas" panose="020B0609020204030204" pitchFamily="49" charset="0"/>
+              </a:rPr>
+              <a:t>- </a:t>
+            </a:r>
+            <a:r>
+              <a:rPr lang="en-CA" dirty="0" err="1">
+                <a:solidFill>
+                  <a:srgbClr val="333333"/>
+                </a:solidFill>
+                <a:latin typeface="Consolas" panose="020B0609020204030204" pitchFamily="49" charset="0"/>
+              </a:rPr>
+              <a:t>racine_discriminant</a:t>
+            </a:r>
+            <a:r>
+              <a:rPr lang="en-CA" dirty="0">
+                <a:solidFill>
+                  <a:srgbClr val="333333"/>
+                </a:solidFill>
+                <a:latin typeface="Consolas" panose="020B0609020204030204" pitchFamily="49" charset="0"/>
+              </a:rPr>
+              <a:t>) </a:t>
+            </a:r>
+            <a:r>
+              <a:rPr lang="en-CA" b="0" i="0" dirty="0">
+                <a:solidFill>
+                  <a:srgbClr val="333333"/>
+                </a:solidFill>
+                <a:effectLst/>
+                <a:latin typeface="Consolas" panose="020B0609020204030204" pitchFamily="49" charset="0"/>
+              </a:rPr>
+              <a:t>/ (</a:t>
+            </a:r>
+            <a:r>
+              <a:rPr lang="en-CA" b="1" i="0" dirty="0">
+                <a:solidFill>
+                  <a:srgbClr val="0000DD"/>
+                </a:solidFill>
+                <a:effectLst/>
+                <a:latin typeface="Consolas" panose="020B0609020204030204" pitchFamily="49" charset="0"/>
+              </a:rPr>
+              <a:t>2</a:t>
+            </a:r>
+            <a:r>
+              <a:rPr lang="en-CA" b="0" i="0" dirty="0">
+                <a:solidFill>
+                  <a:srgbClr val="333333"/>
+                </a:solidFill>
+                <a:effectLst/>
+                <a:latin typeface="Consolas" panose="020B0609020204030204" pitchFamily="49" charset="0"/>
+              </a:rPr>
+              <a:t> * a)</a:t>
+            </a:r>
+          </a:p>
+          <a:p>
+            <a:r>
+              <a:rPr lang="en-CA" b="0" i="0" dirty="0">
+                <a:solidFill>
+                  <a:srgbClr val="333333"/>
+                </a:solidFill>
+                <a:effectLst/>
+                <a:latin typeface="Consolas" panose="020B0609020204030204" pitchFamily="49" charset="0"/>
+              </a:rPr>
+              <a:t>  racine_2 = (-b </a:t>
+            </a:r>
+            <a:r>
+              <a:rPr lang="en-CA" dirty="0">
+                <a:solidFill>
+                  <a:srgbClr val="333333"/>
+                </a:solidFill>
+                <a:latin typeface="Consolas" panose="020B0609020204030204" pitchFamily="49" charset="0"/>
+              </a:rPr>
+              <a:t>+ </a:t>
+            </a:r>
+            <a:r>
+              <a:rPr lang="en-CA" dirty="0" err="1">
+                <a:solidFill>
+                  <a:srgbClr val="333333"/>
+                </a:solidFill>
+                <a:latin typeface="Consolas" panose="020B0609020204030204" pitchFamily="49" charset="0"/>
+              </a:rPr>
+              <a:t>racine_discriminant</a:t>
+            </a:r>
+            <a:r>
+              <a:rPr lang="en-CA" b="0" i="0" dirty="0">
+                <a:solidFill>
+                  <a:srgbClr val="333333"/>
+                </a:solidFill>
+                <a:effectLst/>
+                <a:latin typeface="Consolas" panose="020B0609020204030204" pitchFamily="49" charset="0"/>
+              </a:rPr>
+              <a:t>) / (</a:t>
+            </a:r>
+            <a:r>
+              <a:rPr lang="en-CA" b="1" i="0" dirty="0">
+                <a:solidFill>
+                  <a:srgbClr val="0000DD"/>
+                </a:solidFill>
+                <a:effectLst/>
+                <a:latin typeface="Consolas" panose="020B0609020204030204" pitchFamily="49" charset="0"/>
+              </a:rPr>
+              <a:t>2</a:t>
+            </a:r>
+            <a:r>
+              <a:rPr lang="en-CA" b="0" i="0" dirty="0">
+                <a:solidFill>
+                  <a:srgbClr val="333333"/>
+                </a:solidFill>
+                <a:effectLst/>
+                <a:latin typeface="Consolas" panose="020B0609020204030204" pitchFamily="49" charset="0"/>
+              </a:rPr>
+              <a:t> * a)</a:t>
+            </a:r>
+          </a:p>
+          <a:p>
+            <a:pPr algn="l">
+              <a:buNone/>
+            </a:pPr>
+            <a:endParaRPr lang="en-CA" b="0" i="0" dirty="0">
+              <a:solidFill>
+                <a:srgbClr val="333333"/>
+              </a:solidFill>
+              <a:effectLst/>
+              <a:latin typeface="Consolas" panose="020B0609020204030204" pitchFamily="49" charset="0"/>
+            </a:endParaRPr>
+          </a:p>
+          <a:p>
+            <a:pPr algn="l">
+              <a:buNone/>
+            </a:pPr>
+            <a:r>
+              <a:rPr lang="en-CA" b="0" i="0" dirty="0">
+                <a:solidFill>
+                  <a:srgbClr val="333333"/>
+                </a:solidFill>
+                <a:effectLst/>
+                <a:latin typeface="Consolas" panose="020B0609020204030204" pitchFamily="49" charset="0"/>
+              </a:rPr>
+              <a:t>  </a:t>
+            </a:r>
+            <a:r>
+              <a:rPr lang="en-CA" b="0" i="0" dirty="0">
+                <a:solidFill>
+                  <a:srgbClr val="888888"/>
+                </a:solidFill>
+                <a:effectLst/>
+                <a:latin typeface="Consolas" panose="020B0609020204030204" pitchFamily="49" charset="0"/>
+              </a:rPr>
+              <a:t># </a:t>
+            </a:r>
+            <a:r>
+              <a:rPr lang="en-CA" b="0" i="0" dirty="0" err="1">
+                <a:solidFill>
+                  <a:srgbClr val="888888"/>
+                </a:solidFill>
+                <a:effectLst/>
+                <a:latin typeface="Consolas" panose="020B0609020204030204" pitchFamily="49" charset="0"/>
+              </a:rPr>
+              <a:t>Affichage</a:t>
+            </a:r>
+            <a:endParaRPr lang="en-CA" b="0" i="0" dirty="0">
+              <a:solidFill>
+                <a:srgbClr val="333333"/>
+              </a:solidFill>
+              <a:effectLst/>
+              <a:latin typeface="Consolas" panose="020B0609020204030204" pitchFamily="49" charset="0"/>
+            </a:endParaRPr>
+          </a:p>
+          <a:p>
+            <a:pPr algn="l">
+              <a:buNone/>
+            </a:pPr>
+            <a:r>
+              <a:rPr lang="en-CA" b="0" i="0" dirty="0">
+                <a:solidFill>
+                  <a:srgbClr val="333333"/>
+                </a:solidFill>
+                <a:effectLst/>
+                <a:latin typeface="Consolas" panose="020B0609020204030204" pitchFamily="49" charset="0"/>
+              </a:rPr>
+              <a:t>  </a:t>
+            </a:r>
+            <a:r>
+              <a:rPr lang="en-CA" b="0" i="0" dirty="0">
+                <a:solidFill>
+                  <a:srgbClr val="007020"/>
+                </a:solidFill>
+                <a:effectLst/>
+                <a:latin typeface="Consolas" panose="020B0609020204030204" pitchFamily="49" charset="0"/>
+              </a:rPr>
+              <a:t>print</a:t>
+            </a:r>
+            <a:r>
+              <a:rPr lang="en-CA" b="0" i="0" dirty="0">
+                <a:solidFill>
+                  <a:srgbClr val="333333"/>
+                </a:solidFill>
+                <a:effectLst/>
+                <a:latin typeface="Consolas" panose="020B0609020204030204" pitchFamily="49" charset="0"/>
+              </a:rPr>
+              <a:t>('r1 = ', racine_1, 'r2 = ', racine_2)</a:t>
+            </a:r>
           </a:p>
         </p:txBody>
       </p:sp>
@@ -4018,8 +4334,8 @@
         </p:nvSpPr>
         <p:spPr>
           <a:xfrm>
-            <a:off x="2698480" y="383636"/>
-            <a:ext cx="6795040" cy="1954381"/>
+            <a:off x="2698481" y="956062"/>
+            <a:ext cx="6795040" cy="1200329"/>
           </a:xfrm>
           <a:prstGeom prst="rect">
             <a:avLst/>
@@ -4039,96 +4355,314 @@
           </a:bodyPr>
           <a:lstStyle/>
           <a:p>
-            <a:br>
-              <a:rPr lang="pt-BR" sz="500" b="1" dirty="0">
-                <a:latin typeface="Consolas" panose="020B0609020204030204" pitchFamily="49" charset="0"/>
-              </a:rPr>
-            </a:br>
-            <a:r>
-              <a:rPr lang="pt-BR" b="1" dirty="0">
-                <a:latin typeface="Consolas" panose="020B0609020204030204" pitchFamily="49" charset="0"/>
-              </a:rPr>
-              <a:t>def calculer_afficher_racines(a,b,c):</a:t>
-            </a:r>
-          </a:p>
-          <a:p>
-            <a:endParaRPr lang="pt-BR" sz="100" b="1" dirty="0">
-              <a:latin typeface="Consolas" panose="020B0609020204030204" pitchFamily="49" charset="0"/>
-            </a:endParaRPr>
-          </a:p>
-          <a:p>
-            <a:r>
-              <a:rPr lang="pt-BR" b="1" dirty="0">
+            <a:pPr algn="l">
+              <a:buNone/>
+            </a:pPr>
+            <a:r>
+              <a:rPr lang="en-CA" b="1" i="0" dirty="0">
+                <a:solidFill>
+                  <a:srgbClr val="008800"/>
+                </a:solidFill>
+                <a:effectLst/>
+                <a:latin typeface="Consolas" panose="020B0609020204030204" pitchFamily="49" charset="0"/>
+              </a:rPr>
+              <a:t>def</a:t>
+            </a:r>
+            <a:r>
+              <a:rPr lang="en-CA" b="0" i="0" dirty="0">
+                <a:solidFill>
+                  <a:srgbClr val="BBBBBB"/>
+                </a:solidFill>
+                <a:effectLst/>
+                <a:latin typeface="Consolas" panose="020B0609020204030204" pitchFamily="49" charset="0"/>
+              </a:rPr>
+              <a:t> </a:t>
+            </a:r>
+            <a:r>
+              <a:rPr lang="en-CA" b="1" i="0" dirty="0" err="1">
+                <a:solidFill>
+                  <a:srgbClr val="0066BB"/>
+                </a:solidFill>
+                <a:effectLst/>
+                <a:latin typeface="Consolas" panose="020B0609020204030204" pitchFamily="49" charset="0"/>
+              </a:rPr>
+              <a:t>rac</a:t>
+            </a:r>
+            <a:r>
+              <a:rPr lang="en-CA" b="0" i="0" dirty="0">
+                <a:solidFill>
+                  <a:srgbClr val="333333"/>
+                </a:solidFill>
+                <a:effectLst/>
+                <a:latin typeface="Consolas" panose="020B0609020204030204" pitchFamily="49" charset="0"/>
+              </a:rPr>
+              <a:t>(</a:t>
+            </a:r>
+            <a:r>
+              <a:rPr lang="en-CA" b="0" i="0" dirty="0" err="1">
+                <a:solidFill>
+                  <a:srgbClr val="333333"/>
+                </a:solidFill>
+                <a:effectLst/>
+                <a:latin typeface="Consolas" panose="020B0609020204030204" pitchFamily="49" charset="0"/>
+              </a:rPr>
+              <a:t>a,b,c</a:t>
+            </a:r>
+            <a:r>
+              <a:rPr lang="en-CA" b="0" i="0" dirty="0">
+                <a:solidFill>
+                  <a:srgbClr val="333333"/>
+                </a:solidFill>
+                <a:effectLst/>
+                <a:latin typeface="Consolas" panose="020B0609020204030204" pitchFamily="49" charset="0"/>
+              </a:rPr>
+              <a:t>):</a:t>
+            </a:r>
+          </a:p>
+          <a:p>
+            <a:pPr algn="l">
+              <a:buNone/>
+            </a:pPr>
+            <a:r>
+              <a:rPr lang="en-CA" b="0" i="0" dirty="0">
+                <a:solidFill>
+                  <a:srgbClr val="333333"/>
+                </a:solidFill>
+                <a:effectLst/>
+                <a:latin typeface="Consolas" panose="020B0609020204030204" pitchFamily="49" charset="0"/>
+              </a:rPr>
+              <a:t>  x = (-a2-(a2**</a:t>
+            </a:r>
+            <a:r>
+              <a:rPr lang="en-CA" b="1" i="0" dirty="0">
+                <a:solidFill>
+                  <a:srgbClr val="0000DD"/>
+                </a:solidFill>
+                <a:effectLst/>
+                <a:latin typeface="Consolas" panose="020B0609020204030204" pitchFamily="49" charset="0"/>
+              </a:rPr>
+              <a:t>2</a:t>
+            </a:r>
+            <a:r>
+              <a:rPr lang="en-CA" b="0" i="0" dirty="0">
+                <a:solidFill>
+                  <a:srgbClr val="333333"/>
+                </a:solidFill>
+                <a:effectLst/>
+                <a:latin typeface="Consolas" panose="020B0609020204030204" pitchFamily="49" charset="0"/>
+              </a:rPr>
+              <a:t>-</a:t>
+            </a:r>
+            <a:r>
+              <a:rPr lang="en-CA" b="1" i="0" dirty="0">
+                <a:solidFill>
+                  <a:srgbClr val="0000DD"/>
+                </a:solidFill>
+                <a:effectLst/>
+                <a:latin typeface="Consolas" panose="020B0609020204030204" pitchFamily="49" charset="0"/>
+              </a:rPr>
+              <a:t>4</a:t>
+            </a:r>
+            <a:r>
+              <a:rPr lang="en-CA" b="0" i="0" dirty="0">
+                <a:solidFill>
+                  <a:srgbClr val="333333"/>
+                </a:solidFill>
+                <a:effectLst/>
+                <a:latin typeface="Consolas" panose="020B0609020204030204" pitchFamily="49" charset="0"/>
+              </a:rPr>
+              <a:t>*a1*a3)**</a:t>
+            </a:r>
+            <a:r>
+              <a:rPr lang="en-CA" b="1" i="0" dirty="0">
+                <a:solidFill>
+                  <a:srgbClr val="6600EE"/>
+                </a:solidFill>
+                <a:effectLst/>
+                <a:latin typeface="Consolas" panose="020B0609020204030204" pitchFamily="49" charset="0"/>
+              </a:rPr>
+              <a:t>0.5</a:t>
+            </a:r>
+            <a:r>
+              <a:rPr lang="en-CA" b="0" i="0" dirty="0">
+                <a:solidFill>
+                  <a:srgbClr val="333333"/>
+                </a:solidFill>
+                <a:effectLst/>
+                <a:latin typeface="Consolas" panose="020B0609020204030204" pitchFamily="49" charset="0"/>
+              </a:rPr>
+              <a:t>)/(</a:t>
+            </a:r>
+            <a:r>
+              <a:rPr lang="en-CA" b="1" i="0" dirty="0">
+                <a:solidFill>
+                  <a:srgbClr val="0000DD"/>
+                </a:solidFill>
+                <a:effectLst/>
+                <a:latin typeface="Consolas" panose="020B0609020204030204" pitchFamily="49" charset="0"/>
+              </a:rPr>
+              <a:t>2</a:t>
+            </a:r>
+            <a:r>
+              <a:rPr lang="en-CA" b="0" i="0" dirty="0">
+                <a:solidFill>
+                  <a:srgbClr val="333333"/>
+                </a:solidFill>
+                <a:effectLst/>
+                <a:latin typeface="Consolas" panose="020B0609020204030204" pitchFamily="49" charset="0"/>
+              </a:rPr>
+              <a:t>*a1)</a:t>
+            </a:r>
+          </a:p>
+          <a:p>
+            <a:pPr algn="l">
+              <a:buNone/>
+            </a:pPr>
+            <a:r>
+              <a:rPr lang="en-CA" b="0" i="0" dirty="0">
+                <a:solidFill>
+                  <a:srgbClr val="333333"/>
+                </a:solidFill>
+                <a:effectLst/>
+                <a:latin typeface="Consolas" panose="020B0609020204030204" pitchFamily="49" charset="0"/>
+              </a:rPr>
+              <a:t>  y = (-a2+(a2**</a:t>
+            </a:r>
+            <a:r>
+              <a:rPr lang="en-CA" b="1" i="0" dirty="0">
+                <a:solidFill>
+                  <a:srgbClr val="0000DD"/>
+                </a:solidFill>
+                <a:effectLst/>
+                <a:latin typeface="Consolas" panose="020B0609020204030204" pitchFamily="49" charset="0"/>
+              </a:rPr>
+              <a:t>2</a:t>
+            </a:r>
+            <a:r>
+              <a:rPr lang="en-CA" b="0" i="0" dirty="0">
+                <a:solidFill>
+                  <a:srgbClr val="333333"/>
+                </a:solidFill>
+                <a:effectLst/>
+                <a:latin typeface="Consolas" panose="020B0609020204030204" pitchFamily="49" charset="0"/>
+              </a:rPr>
+              <a:t>-</a:t>
+            </a:r>
+            <a:r>
+              <a:rPr lang="en-CA" b="1" i="0" dirty="0">
+                <a:solidFill>
+                  <a:srgbClr val="0000DD"/>
+                </a:solidFill>
+                <a:effectLst/>
+                <a:latin typeface="Consolas" panose="020B0609020204030204" pitchFamily="49" charset="0"/>
+              </a:rPr>
+              <a:t>4</a:t>
+            </a:r>
+            <a:r>
+              <a:rPr lang="en-CA" b="0" i="0" dirty="0">
+                <a:solidFill>
+                  <a:srgbClr val="333333"/>
+                </a:solidFill>
+                <a:effectLst/>
+                <a:latin typeface="Consolas" panose="020B0609020204030204" pitchFamily="49" charset="0"/>
+              </a:rPr>
+              <a:t>*a2*a3)**</a:t>
+            </a:r>
+            <a:r>
+              <a:rPr lang="en-CA" b="1" i="0" dirty="0">
+                <a:solidFill>
+                  <a:srgbClr val="6600EE"/>
+                </a:solidFill>
+                <a:effectLst/>
+                <a:latin typeface="Consolas" panose="020B0609020204030204" pitchFamily="49" charset="0"/>
+              </a:rPr>
+              <a:t>0.5</a:t>
+            </a:r>
+            <a:r>
+              <a:rPr lang="en-CA" b="0" i="0" dirty="0">
+                <a:solidFill>
+                  <a:srgbClr val="333333"/>
+                </a:solidFill>
+                <a:effectLst/>
+                <a:latin typeface="Consolas" panose="020B0609020204030204" pitchFamily="49" charset="0"/>
+              </a:rPr>
+              <a:t>)/(</a:t>
+            </a:r>
+            <a:r>
+              <a:rPr lang="en-CA" b="1" i="0" dirty="0">
+                <a:solidFill>
+                  <a:srgbClr val="0000DD"/>
+                </a:solidFill>
+                <a:effectLst/>
+                <a:latin typeface="Consolas" panose="020B0609020204030204" pitchFamily="49" charset="0"/>
+              </a:rPr>
+              <a:t>2</a:t>
+            </a:r>
+            <a:r>
+              <a:rPr lang="en-CA" b="0" i="0" dirty="0">
+                <a:solidFill>
+                  <a:srgbClr val="333333"/>
+                </a:solidFill>
+                <a:effectLst/>
+                <a:latin typeface="Consolas" panose="020B0609020204030204" pitchFamily="49" charset="0"/>
+              </a:rPr>
+              <a:t>*a1)</a:t>
+            </a:r>
+          </a:p>
+          <a:p>
+            <a:pPr algn="l">
+              <a:buNone/>
+            </a:pPr>
+            <a:r>
+              <a:rPr lang="en-CA" b="0" i="0" dirty="0">
+                <a:solidFill>
+                  <a:srgbClr val="333333"/>
+                </a:solidFill>
+                <a:effectLst/>
                 <a:latin typeface="Consolas" panose="020B0609020204030204" pitchFamily="49" charset="0"/>
               </a:rPr>
               <a:t>  </a:t>
             </a:r>
             <a:r>
-              <a:rPr lang="pt-BR" b="1" i="1" dirty="0">
-                <a:solidFill>
-                  <a:schemeClr val="accent6"/>
-                </a:solidFill>
-                <a:latin typeface="Consolas" panose="020B0609020204030204" pitchFamily="49" charset="0"/>
-              </a:rPr>
-              <a:t># Calcul des racines</a:t>
-            </a:r>
-          </a:p>
-          <a:p>
-            <a:r>
-              <a:rPr lang="pt-BR" b="1" dirty="0">
-                <a:latin typeface="Consolas" panose="020B0609020204030204" pitchFamily="49" charset="0"/>
-              </a:rPr>
-              <a:t>  r1 = (-b-(b**2-4*a*c)**0.5)/(2*a)</a:t>
-            </a:r>
-          </a:p>
-          <a:p>
-            <a:r>
-              <a:rPr lang="pt-BR" b="1" dirty="0">
-                <a:latin typeface="Consolas" panose="020B0609020204030204" pitchFamily="49" charset="0"/>
-              </a:rPr>
-              <a:t>  r2 = (-b+(b**2-4*a*c)**0.5)/(2*a)</a:t>
-            </a:r>
-          </a:p>
-          <a:p>
-            <a:br>
-              <a:rPr lang="pt-BR" sz="100" b="1" dirty="0">
-                <a:latin typeface="Consolas" panose="020B0609020204030204" pitchFamily="49" charset="0"/>
-              </a:rPr>
-            </a:br>
-            <a:endParaRPr lang="pt-BR" sz="100" b="1" dirty="0">
-              <a:latin typeface="Consolas" panose="020B0609020204030204" pitchFamily="49" charset="0"/>
-            </a:endParaRPr>
-          </a:p>
-          <a:p>
-            <a:r>
-              <a:rPr lang="pt-BR" b="1" dirty="0">
-                <a:latin typeface="Consolas" panose="020B0609020204030204" pitchFamily="49" charset="0"/>
-              </a:rPr>
-              <a:t>  </a:t>
-            </a:r>
-            <a:r>
-              <a:rPr lang="pt-BR" b="1" i="1" dirty="0">
-                <a:solidFill>
-                  <a:schemeClr val="accent6"/>
-                </a:solidFill>
-                <a:latin typeface="Consolas" panose="020B0609020204030204" pitchFamily="49" charset="0"/>
-              </a:rPr>
-              <a:t># Affichage</a:t>
-            </a:r>
-          </a:p>
-          <a:p>
-            <a:r>
-              <a:rPr lang="pt-BR" b="1" dirty="0">
-                <a:latin typeface="Consolas" panose="020B0609020204030204" pitchFamily="49" charset="0"/>
-              </a:rPr>
-              <a:t>  print(r1,r2)</a:t>
-            </a:r>
-            <a:br>
-              <a:rPr lang="pt-BR" b="1" dirty="0">
-                <a:latin typeface="Consolas" panose="020B0609020204030204" pitchFamily="49" charset="0"/>
-              </a:rPr>
-            </a:br>
-            <a:endParaRPr lang="fr-CA" sz="500" dirty="0"/>
+              <a:rPr lang="en-CA" b="0" i="0" dirty="0">
+                <a:solidFill>
+                  <a:srgbClr val="007020"/>
+                </a:solidFill>
+                <a:effectLst/>
+                <a:latin typeface="Consolas" panose="020B0609020204030204" pitchFamily="49" charset="0"/>
+              </a:rPr>
+              <a:t>print</a:t>
+            </a:r>
+            <a:r>
+              <a:rPr lang="en-CA" b="0" i="0" dirty="0">
+                <a:solidFill>
+                  <a:srgbClr val="333333"/>
+                </a:solidFill>
+                <a:effectLst/>
+                <a:latin typeface="Consolas" panose="020B0609020204030204" pitchFamily="49" charset="0"/>
+              </a:rPr>
+              <a:t>(</a:t>
+            </a:r>
+            <a:r>
+              <a:rPr lang="en-CA" b="0" i="0" dirty="0" err="1">
+                <a:solidFill>
+                  <a:srgbClr val="333333"/>
+                </a:solidFill>
+                <a:effectLst/>
+                <a:latin typeface="Consolas" panose="020B0609020204030204" pitchFamily="49" charset="0"/>
+              </a:rPr>
+              <a:t>x,y</a:t>
+            </a:r>
+            <a:r>
+              <a:rPr lang="en-CA" b="0" i="0" dirty="0">
+                <a:solidFill>
+                  <a:srgbClr val="333333"/>
+                </a:solidFill>
+                <a:effectLst/>
+                <a:latin typeface="Consolas" panose="020B0609020204030204" pitchFamily="49" charset="0"/>
+              </a:rPr>
+              <a:t>)</a:t>
+            </a:r>
           </a:p>
         </p:txBody>
       </p:sp>
@@ -4195,6 +4729,48 @@
           </a:p>
         </p:txBody>
       </p:sp>
+      <p:cxnSp>
+        <p:nvCxnSpPr>
+          <p:cNvPr id="3" name="Straight Arrow Connector 2">
+            <a:extLst>
+              <a:ext uri="{FF2B5EF4-FFF2-40B4-BE49-F238E27FC236}">
+                <a16:creationId xmlns:a16="http://schemas.microsoft.com/office/drawing/2014/main" id="{1C213A72-2EF7-99B1-1855-77C1EA1514C1}"/>
+              </a:ext>
+            </a:extLst>
+          </p:cNvPr>
+          <p:cNvCxnSpPr>
+            <a:stCxn id="9" idx="2"/>
+            <a:endCxn id="5" idx="0"/>
+          </p:cNvCxnSpPr>
+          <p:nvPr/>
+        </p:nvCxnSpPr>
+        <p:spPr>
+          <a:xfrm>
+            <a:off x="6096001" y="2156391"/>
+            <a:ext cx="0" cy="560059"/>
+          </a:xfrm>
+          <a:prstGeom prst="straightConnector1">
+            <a:avLst/>
+          </a:prstGeom>
+          <a:ln>
+            <a:tailEnd type="triangle"/>
+          </a:ln>
+        </p:spPr>
+        <p:style>
+          <a:lnRef idx="2">
+            <a:schemeClr val="dk1"/>
+          </a:lnRef>
+          <a:fillRef idx="0">
+            <a:schemeClr val="dk1"/>
+          </a:fillRef>
+          <a:effectRef idx="1">
+            <a:schemeClr val="dk1"/>
+          </a:effectRef>
+          <a:fontRef idx="minor">
+            <a:schemeClr val="tx1"/>
+          </a:fontRef>
+        </p:style>
+      </p:cxnSp>
     </p:spTree>
     <p:extLst>
       <p:ext uri="{BB962C8B-B14F-4D97-AF65-F5344CB8AC3E}">
@@ -4205,6 +4781,127 @@
   <p:clrMapOvr>
     <a:masterClrMapping/>
   </p:clrMapOvr>
+  <p:timing>
+    <p:tnLst>
+      <p:par>
+        <p:cTn id="1" dur="indefinite" restart="never" nodeType="tmRoot">
+          <p:childTnLst>
+            <p:seq concurrent="1" nextAc="seek">
+              <p:cTn id="2" dur="indefinite" nodeType="mainSeq">
+                <p:childTnLst>
+                  <p:par>
+                    <p:cTn id="3" fill="hold">
+                      <p:stCondLst>
+                        <p:cond delay="indefinite"/>
+                      </p:stCondLst>
+                      <p:childTnLst>
+                        <p:par>
+                          <p:cTn id="4" fill="hold">
+                            <p:stCondLst>
+                              <p:cond delay="0"/>
+                            </p:stCondLst>
+                            <p:childTnLst>
+                              <p:par>
+                                <p:cTn id="5" presetID="10" presetClass="entr" presetSubtype="0" fill="hold" nodeType="clickEffect">
+                                  <p:stCondLst>
+                                    <p:cond delay="0"/>
+                                  </p:stCondLst>
+                                  <p:childTnLst>
+                                    <p:set>
+                                      <p:cBhvr>
+                                        <p:cTn id="6" dur="1" fill="hold">
+                                          <p:stCondLst>
+                                            <p:cond delay="0"/>
+                                          </p:stCondLst>
+                                        </p:cTn>
+                                        <p:tgtEl>
+                                          <p:spTgt spid="3"/>
+                                        </p:tgtEl>
+                                        <p:attrNameLst>
+                                          <p:attrName>style.visibility</p:attrName>
+                                        </p:attrNameLst>
+                                      </p:cBhvr>
+                                      <p:to>
+                                        <p:strVal val="visible"/>
+                                      </p:to>
+                                    </p:set>
+                                    <p:animEffect transition="in" filter="fade">
+                                      <p:cBhvr>
+                                        <p:cTn id="7" dur="500"/>
+                                        <p:tgtEl>
+                                          <p:spTgt spid="3"/>
+                                        </p:tgtEl>
+                                      </p:cBhvr>
+                                    </p:animEffect>
+                                  </p:childTnLst>
+                                </p:cTn>
+                              </p:par>
+                              <p:par>
+                                <p:cTn id="8" presetID="10" presetClass="entr" presetSubtype="0" fill="hold" grpId="0" nodeType="withEffect">
+                                  <p:stCondLst>
+                                    <p:cond delay="0"/>
+                                  </p:stCondLst>
+                                  <p:childTnLst>
+                                    <p:set>
+                                      <p:cBhvr>
+                                        <p:cTn id="9" dur="1" fill="hold">
+                                          <p:stCondLst>
+                                            <p:cond delay="0"/>
+                                          </p:stCondLst>
+                                        </p:cTn>
+                                        <p:tgtEl>
+                                          <p:spTgt spid="5"/>
+                                        </p:tgtEl>
+                                        <p:attrNameLst>
+                                          <p:attrName>style.visibility</p:attrName>
+                                        </p:attrNameLst>
+                                      </p:cBhvr>
+                                      <p:to>
+                                        <p:strVal val="visible"/>
+                                      </p:to>
+                                    </p:set>
+                                    <p:animEffect transition="in" filter="fade">
+                                      <p:cBhvr>
+                                        <p:cTn id="10" dur="500"/>
+                                        <p:tgtEl>
+                                          <p:spTgt spid="5"/>
+                                        </p:tgtEl>
+                                      </p:cBhvr>
+                                    </p:animEffect>
+                                  </p:childTnLst>
+                                </p:cTn>
+                              </p:par>
+                            </p:childTnLst>
+                          </p:cTn>
+                        </p:par>
+                      </p:childTnLst>
+                    </p:cTn>
+                  </p:par>
+                </p:childTnLst>
+              </p:cTn>
+              <p:prevCondLst>
+                <p:cond evt="onPrev" delay="0">
+                  <p:tgtEl>
+                    <p:sldTgt/>
+                  </p:tgtEl>
+                </p:cond>
+              </p:prevCondLst>
+              <p:nextCondLst>
+                <p:cond evt="onNext" delay="0">
+                  <p:tgtEl>
+                    <p:sldTgt/>
+                  </p:tgtEl>
+                </p:cond>
+              </p:nextCondLst>
+            </p:seq>
+          </p:childTnLst>
+        </p:cTn>
+      </p:par>
+    </p:tnLst>
+    <p:bldLst>
+      <p:bldP spid="5" grpId="0" animBg="1"/>
+    </p:bldLst>
+  </p:timing>
 </p:sld>
 </file>
 
@@ -4287,11 +4984,13 @@
               <a:t>-tête (</a:t>
             </a:r>
             <a:r>
-              <a:rPr lang="en-US" i="1" dirty="0">
-                <a:solidFill>
-                  <a:srgbClr val="C00000"/>
+              <a:rPr lang="en-US" dirty="0">
+                <a:solidFill>
+                  <a:srgbClr val="DD4422"/>
                 </a:solidFill>
                 <a:latin typeface="Arial Rounded MT Bold" panose="020F0704030504030204" pitchFamily="34" charset="0"/>
+                <a:ea typeface="+mn-ea"/>
+                <a:cs typeface="+mn-cs"/>
               </a:rPr>
               <a:t>docstring</a:t>
             </a:r>
@@ -4350,8 +5049,8 @@
         </p:nvSpPr>
         <p:spPr>
           <a:xfrm>
-            <a:off x="1999032" y="1690688"/>
-            <a:ext cx="4829785" cy="3693319"/>
+            <a:off x="1463040" y="1690688"/>
+            <a:ext cx="5365777" cy="3970318"/>
           </a:xfrm>
           <a:prstGeom prst="rect">
             <a:avLst/>
@@ -4371,172 +5070,378 @@
           </a:bodyPr>
           <a:lstStyle/>
           <a:p>
-            <a:br>
-              <a:rPr lang="pt-BR" sz="500" b="1" dirty="0">
-                <a:latin typeface="Consolas" panose="020B0609020204030204" pitchFamily="49" charset="0"/>
-              </a:rPr>
-            </a:br>
-            <a:r>
-              <a:rPr lang="pt-BR" sz="1600" b="1" dirty="0">
-                <a:latin typeface="Consolas" panose="020B0609020204030204" pitchFamily="49" charset="0"/>
-              </a:rPr>
-              <a:t>def calculer_afficher_racines(a, b, c):</a:t>
-            </a:r>
-          </a:p>
-          <a:p>
-            <a:endParaRPr lang="pt-BR" sz="500" b="1" dirty="0">
+            <a:pPr algn="l">
+              <a:buNone/>
+            </a:pPr>
+            <a:r>
+              <a:rPr lang="fr-FR" b="1" i="0" dirty="0" err="1">
+                <a:solidFill>
+                  <a:srgbClr val="008800"/>
+                </a:solidFill>
+                <a:effectLst/>
+                <a:latin typeface="Consolas" panose="020B0609020204030204" pitchFamily="49" charset="0"/>
+              </a:rPr>
+              <a:t>def</a:t>
+            </a:r>
+            <a:r>
+              <a:rPr lang="fr-FR" b="0" i="0" dirty="0">
+                <a:solidFill>
+                  <a:srgbClr val="BBBBBB"/>
+                </a:solidFill>
+                <a:effectLst/>
+                <a:latin typeface="Consolas" panose="020B0609020204030204" pitchFamily="49" charset="0"/>
+              </a:rPr>
+              <a:t> </a:t>
+            </a:r>
+            <a:r>
+              <a:rPr lang="fr-FR" b="1" i="0" dirty="0" err="1">
+                <a:solidFill>
+                  <a:srgbClr val="0066BB"/>
+                </a:solidFill>
+                <a:effectLst/>
+                <a:latin typeface="Consolas" panose="020B0609020204030204" pitchFamily="49" charset="0"/>
+              </a:rPr>
+              <a:t>calculer_afficher_racines</a:t>
+            </a:r>
+            <a:r>
+              <a:rPr lang="fr-FR" b="0" i="0" dirty="0">
+                <a:solidFill>
+                  <a:srgbClr val="333333"/>
+                </a:solidFill>
+                <a:effectLst/>
+                <a:latin typeface="Consolas" panose="020B0609020204030204" pitchFamily="49" charset="0"/>
+              </a:rPr>
+              <a:t>(a, b, c):</a:t>
+            </a:r>
+          </a:p>
+          <a:p>
+            <a:pPr algn="l">
+              <a:buNone/>
+            </a:pPr>
+            <a:r>
+              <a:rPr lang="fr-FR" b="0" i="0" dirty="0">
+                <a:solidFill>
+                  <a:srgbClr val="BBBBBB"/>
+                </a:solidFill>
+                <a:effectLst/>
+                <a:latin typeface="Consolas" panose="020B0609020204030204" pitchFamily="49" charset="0"/>
+              </a:rPr>
+              <a:t>  </a:t>
+            </a:r>
+            <a:r>
+              <a:rPr lang="fr-FR" b="0" i="0" dirty="0">
+                <a:solidFill>
+                  <a:srgbClr val="DD4422"/>
+                </a:solidFill>
+                <a:effectLst/>
+                <a:latin typeface="Consolas" panose="020B0609020204030204" pitchFamily="49" charset="0"/>
+              </a:rPr>
+              <a:t>"""</a:t>
+            </a:r>
+            <a:endParaRPr lang="fr-FR" b="0" i="0" dirty="0">
+              <a:solidFill>
+                <a:srgbClr val="333333"/>
+              </a:solidFill>
+              <a:effectLst/>
               <a:latin typeface="Consolas" panose="020B0609020204030204" pitchFamily="49" charset="0"/>
             </a:endParaRPr>
           </a:p>
           <a:p>
-            <a:r>
-              <a:rPr lang="pt-BR" sz="1600" b="1" dirty="0">
-                <a:latin typeface="Consolas" panose="020B0609020204030204" pitchFamily="49" charset="0"/>
-              </a:rPr>
-              <a:t>  </a:t>
-            </a:r>
-            <a:r>
-              <a:rPr lang="pt-BR" sz="1600" b="1" dirty="0">
-                <a:solidFill>
-                  <a:srgbClr val="C00000"/>
-                </a:solidFill>
-                <a:latin typeface="Consolas" panose="020B0609020204030204" pitchFamily="49" charset="0"/>
-              </a:rPr>
-              <a:t>"""</a:t>
-            </a:r>
-          </a:p>
-          <a:p>
-            <a:r>
-              <a:rPr lang="pt-BR" sz="1600" b="1" dirty="0">
-                <a:solidFill>
-                  <a:srgbClr val="C00000"/>
-                </a:solidFill>
+            <a:pPr algn="l">
+              <a:buNone/>
+            </a:pPr>
+            <a:r>
+              <a:rPr lang="fr-FR" b="0" i="0" dirty="0">
+                <a:solidFill>
+                  <a:srgbClr val="DD4422"/>
+                </a:solidFill>
+                <a:effectLst/>
                 <a:latin typeface="Consolas" panose="020B0609020204030204" pitchFamily="49" charset="0"/>
               </a:rPr>
               <a:t>  Calcule et affiche les racines d'une </a:t>
             </a:r>
             <a:br>
-              <a:rPr lang="pt-BR" sz="1600" b="1" dirty="0">
-                <a:solidFill>
-                  <a:srgbClr val="C00000"/>
-                </a:solidFill>
+              <a:rPr lang="fr-FR" b="0" i="0" dirty="0">
+                <a:solidFill>
+                  <a:srgbClr val="DD4422"/>
+                </a:solidFill>
+                <a:effectLst/>
                 <a:latin typeface="Consolas" panose="020B0609020204030204" pitchFamily="49" charset="0"/>
               </a:rPr>
             </a:br>
             <a:r>
-              <a:rPr lang="pt-BR" sz="1600" b="1" dirty="0">
-                <a:solidFill>
-                  <a:srgbClr val="C00000"/>
-                </a:solidFill>
+              <a:rPr lang="fr-FR" b="0" i="0" dirty="0">
+                <a:solidFill>
+                  <a:srgbClr val="DD4422"/>
+                </a:solidFill>
+                <a:effectLst/>
                 <a:latin typeface="Consolas" panose="020B0609020204030204" pitchFamily="49" charset="0"/>
               </a:rPr>
               <a:t>  quadratique.</a:t>
             </a:r>
-          </a:p>
-          <a:p>
-            <a:endParaRPr lang="pt-BR" sz="1600" b="1" dirty="0">
+            <a:endParaRPr lang="fr-FR" b="0" i="0" dirty="0">
               <a:solidFill>
-                <a:srgbClr val="C00000"/>
+                <a:srgbClr val="333333"/>
               </a:solidFill>
+              <a:effectLst/>
               <a:latin typeface="Consolas" panose="020B0609020204030204" pitchFamily="49" charset="0"/>
             </a:endParaRPr>
           </a:p>
           <a:p>
-            <a:r>
-              <a:rPr lang="pt-BR" sz="1600" b="1" dirty="0">
-                <a:solidFill>
-                  <a:srgbClr val="C00000"/>
-                </a:solidFill>
-                <a:latin typeface="Consolas" panose="020B0609020204030204" pitchFamily="49" charset="0"/>
-              </a:rPr>
-              <a:t>  Arguments:</a:t>
-            </a:r>
-          </a:p>
-          <a:p>
-            <a:r>
-              <a:rPr lang="pt-BR" sz="1600" b="1" dirty="0">
-                <a:solidFill>
-                  <a:srgbClr val="C00000"/>
-                </a:solidFill>
-                <a:latin typeface="Consolas" panose="020B0609020204030204" pitchFamily="49" charset="0"/>
-              </a:rPr>
-              <a:t>    a (int): Coefficient du terme x^2.</a:t>
-            </a:r>
-          </a:p>
-          <a:p>
-            <a:r>
-              <a:rPr lang="pt-BR" sz="1600" b="1" dirty="0">
-                <a:solidFill>
-                  <a:srgbClr val="C00000"/>
-                </a:solidFill>
-                <a:latin typeface="Consolas" panose="020B0609020204030204" pitchFamily="49" charset="0"/>
-              </a:rPr>
-              <a:t>    b (int): Coefficient du terme x^1.</a:t>
-            </a:r>
-          </a:p>
-          <a:p>
-            <a:r>
-              <a:rPr lang="pt-BR" sz="1600" b="1" dirty="0">
-                <a:solidFill>
-                  <a:srgbClr val="C00000"/>
-                </a:solidFill>
-                <a:latin typeface="Consolas" panose="020B0609020204030204" pitchFamily="49" charset="0"/>
-              </a:rPr>
-              <a:t>    c (int): Coefficient du terme x^0.</a:t>
-            </a:r>
-          </a:p>
-          <a:p>
-            <a:endParaRPr lang="pt-BR" sz="1600" b="1" dirty="0">
+            <a:pPr algn="l">
+              <a:buNone/>
+            </a:pPr>
+            <a:endParaRPr lang="fr-FR" b="0" i="0" dirty="0">
               <a:solidFill>
-                <a:srgbClr val="C00000"/>
+                <a:srgbClr val="333333"/>
               </a:solidFill>
+              <a:effectLst/>
               <a:latin typeface="Consolas" panose="020B0609020204030204" pitchFamily="49" charset="0"/>
             </a:endParaRPr>
           </a:p>
           <a:p>
-            <a:r>
-              <a:rPr lang="pt-BR" sz="1600" b="1" dirty="0">
-                <a:solidFill>
-                  <a:srgbClr val="C00000"/>
-                </a:solidFill>
+            <a:pPr algn="l">
+              <a:buNone/>
+            </a:pPr>
+            <a:r>
+              <a:rPr lang="fr-FR" b="0" i="0" dirty="0">
+                <a:solidFill>
+                  <a:srgbClr val="DD4422"/>
+                </a:solidFill>
+                <a:effectLst/>
+                <a:latin typeface="Consolas" panose="020B0609020204030204" pitchFamily="49" charset="0"/>
+              </a:rPr>
+              <a:t>  Arguments:</a:t>
+            </a:r>
+            <a:endParaRPr lang="fr-FR" b="0" i="0" dirty="0">
+              <a:solidFill>
+                <a:srgbClr val="333333"/>
+              </a:solidFill>
+              <a:effectLst/>
+              <a:latin typeface="Consolas" panose="020B0609020204030204" pitchFamily="49" charset="0"/>
+            </a:endParaRPr>
+          </a:p>
+          <a:p>
+            <a:pPr algn="l">
+              <a:buNone/>
+            </a:pPr>
+            <a:r>
+              <a:rPr lang="fr-FR" b="0" i="0" dirty="0">
+                <a:solidFill>
+                  <a:srgbClr val="DD4422"/>
+                </a:solidFill>
+                <a:effectLst/>
+                <a:latin typeface="Consolas" panose="020B0609020204030204" pitchFamily="49" charset="0"/>
+              </a:rPr>
+              <a:t>    a (</a:t>
+            </a:r>
+            <a:r>
+              <a:rPr lang="fr-FR" b="0" i="0" dirty="0" err="1">
+                <a:solidFill>
+                  <a:srgbClr val="DD4422"/>
+                </a:solidFill>
+                <a:effectLst/>
+                <a:latin typeface="Consolas" panose="020B0609020204030204" pitchFamily="49" charset="0"/>
+              </a:rPr>
+              <a:t>int</a:t>
+            </a:r>
+            <a:r>
+              <a:rPr lang="fr-FR" b="0" i="0" dirty="0">
+                <a:solidFill>
+                  <a:srgbClr val="DD4422"/>
+                </a:solidFill>
+                <a:effectLst/>
+                <a:latin typeface="Consolas" panose="020B0609020204030204" pitchFamily="49" charset="0"/>
+              </a:rPr>
+              <a:t>): Coefficient du terme x^2.</a:t>
+            </a:r>
+            <a:endParaRPr lang="fr-FR" b="0" i="0" dirty="0">
+              <a:solidFill>
+                <a:srgbClr val="333333"/>
+              </a:solidFill>
+              <a:effectLst/>
+              <a:latin typeface="Consolas" panose="020B0609020204030204" pitchFamily="49" charset="0"/>
+            </a:endParaRPr>
+          </a:p>
+          <a:p>
+            <a:pPr algn="l">
+              <a:buNone/>
+            </a:pPr>
+            <a:r>
+              <a:rPr lang="fr-FR" b="0" i="0" dirty="0">
+                <a:solidFill>
+                  <a:srgbClr val="DD4422"/>
+                </a:solidFill>
+                <a:effectLst/>
+                <a:latin typeface="Consolas" panose="020B0609020204030204" pitchFamily="49" charset="0"/>
+              </a:rPr>
+              <a:t>    b (</a:t>
+            </a:r>
+            <a:r>
+              <a:rPr lang="fr-FR" b="0" i="0" dirty="0" err="1">
+                <a:solidFill>
+                  <a:srgbClr val="DD4422"/>
+                </a:solidFill>
+                <a:effectLst/>
+                <a:latin typeface="Consolas" panose="020B0609020204030204" pitchFamily="49" charset="0"/>
+              </a:rPr>
+              <a:t>int</a:t>
+            </a:r>
+            <a:r>
+              <a:rPr lang="fr-FR" b="0" i="0" dirty="0">
+                <a:solidFill>
+                  <a:srgbClr val="DD4422"/>
+                </a:solidFill>
+                <a:effectLst/>
+                <a:latin typeface="Consolas" panose="020B0609020204030204" pitchFamily="49" charset="0"/>
+              </a:rPr>
+              <a:t>): Coefficient du terme x^1.</a:t>
+            </a:r>
+            <a:endParaRPr lang="fr-FR" b="0" i="0" dirty="0">
+              <a:solidFill>
+                <a:srgbClr val="333333"/>
+              </a:solidFill>
+              <a:effectLst/>
+              <a:latin typeface="Consolas" panose="020B0609020204030204" pitchFamily="49" charset="0"/>
+            </a:endParaRPr>
+          </a:p>
+          <a:p>
+            <a:pPr algn="l">
+              <a:buNone/>
+            </a:pPr>
+            <a:r>
+              <a:rPr lang="fr-FR" b="0" i="0" dirty="0">
+                <a:solidFill>
+                  <a:srgbClr val="DD4422"/>
+                </a:solidFill>
+                <a:effectLst/>
+                <a:latin typeface="Consolas" panose="020B0609020204030204" pitchFamily="49" charset="0"/>
+              </a:rPr>
+              <a:t>    c (</a:t>
+            </a:r>
+            <a:r>
+              <a:rPr lang="fr-FR" b="0" i="0" dirty="0" err="1">
+                <a:solidFill>
+                  <a:srgbClr val="DD4422"/>
+                </a:solidFill>
+                <a:effectLst/>
+                <a:latin typeface="Consolas" panose="020B0609020204030204" pitchFamily="49" charset="0"/>
+              </a:rPr>
+              <a:t>int</a:t>
+            </a:r>
+            <a:r>
+              <a:rPr lang="fr-FR" b="0" i="0" dirty="0">
+                <a:solidFill>
+                  <a:srgbClr val="DD4422"/>
+                </a:solidFill>
+                <a:effectLst/>
+                <a:latin typeface="Consolas" panose="020B0609020204030204" pitchFamily="49" charset="0"/>
+              </a:rPr>
+              <a:t>): Coefficient du terme x^0.</a:t>
+            </a:r>
+            <a:endParaRPr lang="fr-FR" b="0" i="0" dirty="0">
+              <a:solidFill>
+                <a:srgbClr val="333333"/>
+              </a:solidFill>
+              <a:effectLst/>
+              <a:latin typeface="Consolas" panose="020B0609020204030204" pitchFamily="49" charset="0"/>
+            </a:endParaRPr>
+          </a:p>
+          <a:p>
+            <a:pPr algn="l">
+              <a:buNone/>
+            </a:pPr>
+            <a:endParaRPr lang="fr-FR" b="0" i="0" dirty="0">
+              <a:solidFill>
+                <a:srgbClr val="333333"/>
+              </a:solidFill>
+              <a:effectLst/>
+              <a:latin typeface="Consolas" panose="020B0609020204030204" pitchFamily="49" charset="0"/>
+            </a:endParaRPr>
+          </a:p>
+          <a:p>
+            <a:pPr algn="l">
+              <a:buNone/>
+            </a:pPr>
+            <a:r>
+              <a:rPr lang="fr-FR" b="0" i="0" dirty="0">
+                <a:solidFill>
+                  <a:srgbClr val="DD4422"/>
+                </a:solidFill>
+                <a:effectLst/>
                 <a:latin typeface="Consolas" panose="020B0609020204030204" pitchFamily="49" charset="0"/>
               </a:rPr>
               <a:t>  Retourne:</a:t>
             </a:r>
-          </a:p>
-          <a:p>
-            <a:r>
-              <a:rPr lang="pt-BR" sz="1600" b="1" dirty="0">
-                <a:solidFill>
-                  <a:srgbClr val="C00000"/>
-                </a:solidFill>
+            <a:endParaRPr lang="fr-FR" b="0" i="0" dirty="0">
+              <a:solidFill>
+                <a:srgbClr val="333333"/>
+              </a:solidFill>
+              <a:effectLst/>
+              <a:latin typeface="Consolas" panose="020B0609020204030204" pitchFamily="49" charset="0"/>
+            </a:endParaRPr>
+          </a:p>
+          <a:p>
+            <a:pPr algn="l">
+              <a:buNone/>
+            </a:pPr>
+            <a:r>
+              <a:rPr lang="fr-FR" b="0" i="0" dirty="0">
+                <a:solidFill>
+                  <a:srgbClr val="DD4422"/>
+                </a:solidFill>
+                <a:effectLst/>
                 <a:latin typeface="Consolas" panose="020B0609020204030204" pitchFamily="49" charset="0"/>
               </a:rPr>
               <a:t>    Rien.</a:t>
             </a:r>
-          </a:p>
-          <a:p>
-            <a:r>
-              <a:rPr lang="pt-BR" sz="1600" b="1" dirty="0">
-                <a:solidFill>
-                  <a:srgbClr val="C00000"/>
-                </a:solidFill>
+            <a:endParaRPr lang="fr-FR" b="0" i="0" dirty="0">
+              <a:solidFill>
+                <a:srgbClr val="333333"/>
+              </a:solidFill>
+              <a:effectLst/>
+              <a:latin typeface="Consolas" panose="020B0609020204030204" pitchFamily="49" charset="0"/>
+            </a:endParaRPr>
+          </a:p>
+          <a:p>
+            <a:pPr algn="l">
+              <a:buNone/>
+            </a:pPr>
+            <a:r>
+              <a:rPr lang="fr-FR" b="0" i="0" dirty="0">
+                <a:solidFill>
+                  <a:srgbClr val="DD4422"/>
+                </a:solidFill>
+                <a:effectLst/>
                 <a:latin typeface="Consolas" panose="020B0609020204030204" pitchFamily="49" charset="0"/>
               </a:rPr>
               <a:t>  """</a:t>
             </a:r>
-            <a:br>
-              <a:rPr lang="pt-BR" sz="1600" b="1" dirty="0">
-                <a:latin typeface="Consolas" panose="020B0609020204030204" pitchFamily="49" charset="0"/>
-              </a:rPr>
-            </a:br>
-            <a:r>
-              <a:rPr lang="pt-BR" sz="1600" b="1" dirty="0">
+            <a:r>
+              <a:rPr lang="fr-FR" b="0" i="0" dirty="0">
+                <a:solidFill>
+                  <a:srgbClr val="333333"/>
+                </a:solidFill>
+                <a:effectLst/>
+                <a:latin typeface="Consolas" panose="020B0609020204030204" pitchFamily="49" charset="0"/>
+              </a:rPr>
+              <a:t>  </a:t>
+            </a:r>
+          </a:p>
+          <a:p>
+            <a:pPr algn="l">
+              <a:buNone/>
+            </a:pPr>
+            <a:r>
+              <a:rPr lang="fr-FR" b="0" i="0" dirty="0">
+                <a:solidFill>
+                  <a:srgbClr val="333333"/>
+                </a:solidFill>
+                <a:effectLst/>
                 <a:latin typeface="Consolas" panose="020B0609020204030204" pitchFamily="49" charset="0"/>
               </a:rPr>
               <a:t>  ...</a:t>
             </a:r>
-            <a:endParaRPr lang="fr-CA" sz="1600" dirty="0"/>
           </a:p>
         </p:txBody>
       </p:sp>
@@ -12612,8 +13517,8 @@
           </a:p>
         </p:txBody>
       </p:sp>
-      <mc:AlternateContent xmlns:mc="http://schemas.openxmlformats.org/markup-compatibility/2006" xmlns:a14="http://schemas.microsoft.com/office/drawing/2010/main">
-        <mc:Choice Requires="a14">
+      <mc:AlternateContent xmlns:mc="http://schemas.openxmlformats.org/markup-compatibility/2006">
+        <mc:Choice xmlns:a14="http://schemas.microsoft.com/office/drawing/2010/main" Requires="a14">
           <p:sp>
             <p:nvSpPr>
               <p:cNvPr id="3" name="Content Placeholder 2">
@@ -12954,16 +13859,10 @@
                   <a:t> </a:t>
                 </a:r>
                 <a:r>
-                  <a:rPr lang="en-CA" i="1" dirty="0">
+                  <a:rPr lang="en-CA" dirty="0">
                     <a:latin typeface="Consolas" panose="020B0609020204030204" pitchFamily="49" charset="0"/>
                   </a:rPr>
-                  <a:t>r</a:t>
-                </a:r>
-                <a:r>
-                  <a:rPr lang="fr-CA" i="1" dirty="0">
-                    <a:latin typeface="Consolas" panose="020B0609020204030204" pitchFamily="49" charset="0"/>
-                  </a:rPr>
-                  <a:t>é</a:t>
+                  <a:t>re</a:t>
                 </a:r>
                 <a:r>
                   <a:rPr lang="fr-CA" dirty="0">
@@ -13083,7 +13982,7 @@
             </p:txBody>
           </p:sp>
         </mc:Choice>
-        <mc:Fallback xmlns="">
+        <mc:Fallback>
           <p:sp>
             <p:nvSpPr>
               <p:cNvPr id="3" name="Content Placeholder 2">
@@ -26725,7 +27624,19 @@
               <a:rPr lang="en-US" dirty="0">
                 <a:latin typeface="Arial Rounded MT Bold" panose="020F0704030504030204" pitchFamily="34" charset="0"/>
               </a:rPr>
-              <a:t> simple</a:t>
+              <a:t> simple (</a:t>
+            </a:r>
+            <a:r>
+              <a:rPr lang="en-US" dirty="0">
+                <a:latin typeface="Consolas" panose="020B0609020204030204" pitchFamily="49" charset="0"/>
+              </a:rPr>
+              <a:t>print</a:t>
+            </a:r>
+            <a:r>
+              <a:rPr lang="en-US" dirty="0">
+                <a:latin typeface="Arial Rounded MT Bold" panose="020F0704030504030204" pitchFamily="34" charset="0"/>
+              </a:rPr>
+              <a:t>)</a:t>
             </a:r>
             <a:endParaRPr lang="fr-CA" dirty="0">
               <a:latin typeface="Arial Rounded MT Bold" panose="020F0704030504030204" pitchFamily="34" charset="0"/>
@@ -26939,7 +27850,7 @@
         </p:nvSpPr>
         <p:spPr>
           <a:xfrm>
-            <a:off x="2230873" y="1690688"/>
+            <a:off x="2230875" y="1690688"/>
             <a:ext cx="7730249" cy="749141"/>
           </a:xfrm>
           <a:prstGeom prst="roundRect">
@@ -27682,7 +28593,22 @@
               <a:rPr lang="fr-CA" sz="2600" b="1" dirty="0">
                 <a:latin typeface="Consolas" panose="020B0609020204030204" pitchFamily="49" charset="0"/>
               </a:rPr>
-              <a:t>(1 / 2 </a:t>
+              <a:t>(1 </a:t>
+            </a:r>
+            <a:r>
+              <a:rPr lang="fr-CA" sz="2600" b="1" dirty="0">
+                <a:solidFill>
+                  <a:srgbClr val="FF2500"/>
+                </a:solidFill>
+                <a:latin typeface="Consolas" panose="020B0609020204030204" pitchFamily="49" charset="0"/>
+              </a:rPr>
+              <a:t>/</a:t>
+            </a:r>
+            <a:r>
+              <a:rPr lang="fr-CA" sz="2600" b="1" dirty="0">
+                <a:latin typeface="Consolas" panose="020B0609020204030204" pitchFamily="49" charset="0"/>
+              </a:rPr>
+              <a:t> 2 </a:t>
             </a:r>
             <a:r>
               <a:rPr lang="fr-CA" sz="2600" b="1" dirty="0">
@@ -28477,8 +29403,8 @@
           <a:chExt cx="0" cy="0"/>
         </a:xfrm>
       </p:grpSpPr>
-      <mc:AlternateContent xmlns:mc="http://schemas.openxmlformats.org/markup-compatibility/2006" xmlns:a14="http://schemas.microsoft.com/office/drawing/2010/main">
-        <mc:Choice Requires="a14">
+      <mc:AlternateContent xmlns:mc="http://schemas.openxmlformats.org/markup-compatibility/2006">
+        <mc:Choice xmlns:a14="http://schemas.microsoft.com/office/drawing/2010/main" Requires="a14">
           <p:sp>
             <p:nvSpPr>
               <p:cNvPr id="2" name="Title 1">
@@ -28508,6 +29434,18 @@
                 </a:r>
                 <a14:m>
                   <m:oMath xmlns:m="http://schemas.openxmlformats.org/officeDocument/2006/math">
+                    <m:r>
+                      <a:rPr lang="en-US" b="0" i="1" smtClean="0">
+                        <a:latin typeface="Cambria Math" panose="02040503050406030204" pitchFamily="18" charset="0"/>
+                      </a:rPr>
+                      <m:t>𝑦</m:t>
+                    </m:r>
+                    <m:r>
+                      <a:rPr lang="en-US" b="0" i="1" smtClean="0">
+                        <a:latin typeface="Cambria Math" panose="02040503050406030204" pitchFamily="18" charset="0"/>
+                      </a:rPr>
+                      <m:t>=</m:t>
+                    </m:r>
                     <m:r>
                       <a:rPr lang="en-CA" b="0" i="1" smtClean="0">
                         <a:latin typeface="Cambria Math" panose="02040503050406030204" pitchFamily="18" charset="0"/>
@@ -28572,7 +29510,7 @@
             </p:txBody>
           </p:sp>
         </mc:Choice>
-        <mc:Fallback xmlns="">
+        <mc:Fallback>
           <p:sp>
             <p:nvSpPr>
               <p:cNvPr id="2" name="Title 1">
@@ -28612,8 +29550,8 @@
           </p:sp>
         </mc:Fallback>
       </mc:AlternateContent>
-      <mc:AlternateContent xmlns:mc="http://schemas.openxmlformats.org/markup-compatibility/2006" xmlns:a14="http://schemas.microsoft.com/office/drawing/2010/main">
-        <mc:Choice Requires="a14">
+      <mc:AlternateContent xmlns:mc="http://schemas.openxmlformats.org/markup-compatibility/2006">
+        <mc:Choice xmlns:a14="http://schemas.microsoft.com/office/drawing/2010/main" Requires="a14">
           <p:sp>
             <p:nvSpPr>
               <p:cNvPr id="3" name="Content Placeholder 2">
@@ -28641,7 +29579,7 @@
                   <a:buNone/>
                 </a:pPr>
                 <a:r>
-                  <a:rPr lang="en-CA" b="1" dirty="0">
+                  <a:rPr lang="en-CA" dirty="0">
                     <a:latin typeface="Consolas" panose="020B0609020204030204" pitchFamily="49" charset="0"/>
                   </a:rPr>
                   <a:t>a </a:t>
@@ -28649,7 +29587,7 @@
                 <a14:m>
                   <m:oMath xmlns:m="http://schemas.openxmlformats.org/officeDocument/2006/math">
                     <m:r>
-                      <a:rPr lang="en-CA" b="1" i="0">
+                      <a:rPr lang="en-CA" b="0" i="0">
                         <a:latin typeface="Cambria Math" panose="02040503050406030204" pitchFamily="18" charset="0"/>
                       </a:rPr>
                       <m:t>←</m:t>
@@ -28657,7 +29595,7 @@
                   </m:oMath>
                 </a14:m>
                 <a:r>
-                  <a:rPr lang="en-CA" b="1" dirty="0">
+                  <a:rPr lang="en-CA" dirty="0">
                     <a:latin typeface="Consolas" panose="020B0609020204030204" pitchFamily="49" charset="0"/>
                   </a:rPr>
                   <a:t> </a:t>
@@ -28665,14 +29603,14 @@
                 <a14:m>
                   <m:oMath xmlns:m="http://schemas.openxmlformats.org/officeDocument/2006/math">
                     <m:r>
-                      <a:rPr lang="en-CA" b="1" i="1" dirty="0" smtClean="0">
+                      <a:rPr lang="en-CA" b="0" i="1" dirty="0" smtClean="0">
                         <a:latin typeface="Cambria Math" panose="02040503050406030204" pitchFamily="18" charset="0"/>
                       </a:rPr>
-                      <m:t>𝒙</m:t>
+                      <m:t>𝑥</m:t>
                     </m:r>
                   </m:oMath>
                 </a14:m>
-                <a:endParaRPr lang="en-CA" b="1" dirty="0">
+                <a:endParaRPr lang="en-CA" dirty="0">
                   <a:latin typeface="Consolas" panose="020B0609020204030204" pitchFamily="49" charset="0"/>
                 </a:endParaRPr>
               </a:p>
@@ -28681,7 +29619,7 @@
                   <a:buNone/>
                 </a:pPr>
                 <a:r>
-                  <a:rPr lang="en-CA" b="1" dirty="0">
+                  <a:rPr lang="en-CA" dirty="0">
                     <a:latin typeface="Consolas" panose="020B0609020204030204" pitchFamily="49" charset="0"/>
                   </a:rPr>
                   <a:t>b </a:t>
@@ -28689,7 +29627,7 @@
                 <a14:m>
                   <m:oMath xmlns:m="http://schemas.openxmlformats.org/officeDocument/2006/math">
                     <m:r>
-                      <a:rPr lang="en-CA" b="1" i="0">
+                      <a:rPr lang="en-CA" b="0" i="0">
                         <a:latin typeface="Cambria Math" panose="02040503050406030204" pitchFamily="18" charset="0"/>
                       </a:rPr>
                       <m:t>←</m:t>
@@ -28697,7 +29635,7 @@
                   </m:oMath>
                 </a14:m>
                 <a:r>
-                  <a:rPr lang="en-CA" b="1" dirty="0">
+                  <a:rPr lang="en-CA" dirty="0">
                     <a:latin typeface="Consolas" panose="020B0609020204030204" pitchFamily="49" charset="0"/>
                   </a:rPr>
                   <a:t> </a:t>
@@ -28705,14 +29643,14 @@
                 <a14:m>
                   <m:oMath xmlns:m="http://schemas.openxmlformats.org/officeDocument/2006/math">
                     <m:r>
-                      <a:rPr lang="en-CA" b="1" i="1" dirty="0" smtClean="0">
+                      <a:rPr lang="en-CA" b="0" i="1" dirty="0" smtClean="0">
                         <a:latin typeface="Cambria Math" panose="02040503050406030204" pitchFamily="18" charset="0"/>
                       </a:rPr>
-                      <m:t>𝒚</m:t>
+                      <m:t>𝑦</m:t>
                     </m:r>
                   </m:oMath>
                 </a14:m>
-                <a:endParaRPr lang="en-CA" b="1" dirty="0">
+                <a:endParaRPr lang="en-CA" dirty="0">
                   <a:latin typeface="Consolas" panose="020B0609020204030204" pitchFamily="49" charset="0"/>
                 </a:endParaRPr>
               </a:p>
@@ -28721,7 +29659,7 @@
                   <a:buNone/>
                 </a:pPr>
                 <a:r>
-                  <a:rPr lang="en-CA" b="1" dirty="0">
+                  <a:rPr lang="en-CA" dirty="0">
                     <a:latin typeface="Consolas" panose="020B0609020204030204" pitchFamily="49" charset="0"/>
                   </a:rPr>
                   <a:t>c </a:t>
@@ -28729,7 +29667,7 @@
                 <a14:m>
                   <m:oMath xmlns:m="http://schemas.openxmlformats.org/officeDocument/2006/math">
                     <m:r>
-                      <a:rPr lang="en-CA" b="1" i="0">
+                      <a:rPr lang="en-CA" b="0" i="0">
                         <a:latin typeface="Cambria Math" panose="02040503050406030204" pitchFamily="18" charset="0"/>
                       </a:rPr>
                       <m:t>←</m:t>
@@ -28737,7 +29675,7 @@
                   </m:oMath>
                 </a14:m>
                 <a:r>
-                  <a:rPr lang="en-CA" b="1" dirty="0">
+                  <a:rPr lang="en-CA" dirty="0">
                     <a:latin typeface="Consolas" panose="020B0609020204030204" pitchFamily="49" charset="0"/>
                   </a:rPr>
                   <a:t> </a:t>
@@ -28745,14 +29683,14 @@
                 <a14:m>
                   <m:oMath xmlns:m="http://schemas.openxmlformats.org/officeDocument/2006/math">
                     <m:r>
-                      <a:rPr lang="en-US" b="1" i="1" dirty="0" smtClean="0">
+                      <a:rPr lang="en-US" b="0" i="1" dirty="0" smtClean="0">
                         <a:latin typeface="Cambria Math" panose="02040503050406030204" pitchFamily="18" charset="0"/>
                       </a:rPr>
-                      <m:t>𝒛</m:t>
+                      <m:t>𝑧</m:t>
                     </m:r>
                   </m:oMath>
                 </a14:m>
-                <a:endParaRPr lang="en-CA" b="1" dirty="0">
+                <a:endParaRPr lang="en-CA" dirty="0">
                   <a:latin typeface="Consolas" panose="020B0609020204030204" pitchFamily="49" charset="0"/>
                 </a:endParaRPr>
               </a:p>
@@ -28763,21 +29701,21 @@
                 <a14:m>
                   <m:oMath xmlns:m="http://schemas.openxmlformats.org/officeDocument/2006/math">
                     <m:r>
-                      <a:rPr lang="en-CA" b="1" i="1" dirty="0" smtClean="0">
+                      <a:rPr lang="en-CA" b="0" i="1" dirty="0" smtClean="0">
                         <a:latin typeface="Cambria Math" panose="02040503050406030204" pitchFamily="18" charset="0"/>
                       </a:rPr>
-                      <m:t>𝒓</m:t>
+                      <m:t>𝑟</m:t>
                     </m:r>
                     <m:r>
-                      <a:rPr lang="en-CA" b="1" i="1" dirty="0" smtClean="0">
+                      <a:rPr lang="en-CA" b="0" i="1" dirty="0" smtClean="0">
                         <a:latin typeface="Cambria Math" panose="02040503050406030204" pitchFamily="18" charset="0"/>
                       </a:rPr>
-                      <m:t>𝟏</m:t>
+                      <m:t>1</m:t>
                     </m:r>
                   </m:oMath>
                 </a14:m>
                 <a:r>
-                  <a:rPr lang="en-CA" b="1" dirty="0">
+                  <a:rPr lang="en-CA" dirty="0">
                     <a:latin typeface="Consolas" panose="020B0609020204030204" pitchFamily="49" charset="0"/>
                   </a:rPr>
                   <a:t> </a:t>
@@ -28785,7 +29723,7 @@
                 <a14:m>
                   <m:oMath xmlns:m="http://schemas.openxmlformats.org/officeDocument/2006/math">
                     <m:r>
-                      <a:rPr lang="en-CA" b="1" i="0" smtClean="0">
+                      <a:rPr lang="en-CA" b="0" i="0" smtClean="0">
                         <a:latin typeface="Cambria Math" panose="02040503050406030204" pitchFamily="18" charset="0"/>
                       </a:rPr>
                       <m:t>←</m:t>
@@ -28793,7 +29731,7 @@
                   </m:oMath>
                 </a14:m>
                 <a:r>
-                  <a:rPr lang="en-CA" b="1" dirty="0">
+                  <a:rPr lang="en-CA" dirty="0">
                     <a:latin typeface="Consolas" panose="020B0609020204030204" pitchFamily="49" charset="0"/>
                   </a:rPr>
                   <a:t> </a:t>
@@ -28803,26 +29741,26 @@
                     <m:f>
                       <m:fPr>
                         <m:ctrlPr>
-                          <a:rPr lang="en-US" b="1" i="1" dirty="0" smtClean="0">
+                          <a:rPr lang="en-US" i="1" dirty="0" smtClean="0">
                             <a:latin typeface="Cambria Math" panose="02040503050406030204" pitchFamily="18" charset="0"/>
                           </a:rPr>
                         </m:ctrlPr>
                       </m:fPr>
                       <m:num>
                         <m:r>
-                          <a:rPr lang="en-US" b="1" i="1" dirty="0" smtClean="0">
+                          <a:rPr lang="en-US" b="0" i="1" dirty="0" smtClean="0">
                             <a:latin typeface="Cambria Math" panose="02040503050406030204" pitchFamily="18" charset="0"/>
                           </a:rPr>
                           <m:t>−</m:t>
                         </m:r>
                         <m:r>
-                          <a:rPr lang="en-US" b="1" i="1" dirty="0" smtClean="0">
+                          <a:rPr lang="en-US" b="0" i="1" dirty="0" smtClean="0">
                             <a:latin typeface="Cambria Math" panose="02040503050406030204" pitchFamily="18" charset="0"/>
                           </a:rPr>
-                          <m:t>𝒃</m:t>
+                          <m:t>𝑏</m:t>
                         </m:r>
                         <m:r>
-                          <a:rPr lang="en-US" b="1" i="1" dirty="0" smtClean="0">
+                          <a:rPr lang="en-US" b="0" i="1" dirty="0" smtClean="0">
                             <a:latin typeface="Cambria Math" panose="02040503050406030204" pitchFamily="18" charset="0"/>
                           </a:rPr>
                           <m:t>−</m:t>
@@ -28831,7 +29769,7 @@
                           <m:radPr>
                             <m:degHide m:val="on"/>
                             <m:ctrlPr>
-                              <a:rPr lang="en-US" b="1" i="1" dirty="0" smtClean="0">
+                              <a:rPr lang="en-US" i="1" dirty="0" smtClean="0">
                                 <a:latin typeface="Cambria Math" panose="02040503050406030204" pitchFamily="18" charset="0"/>
                               </a:rPr>
                             </m:ctrlPr>
@@ -28841,67 +29779,61 @@
                             <m:sSup>
                               <m:sSupPr>
                                 <m:ctrlPr>
-                                  <a:rPr lang="en-US" b="1" i="1" dirty="0" smtClean="0">
+                                  <a:rPr lang="en-US" i="1" dirty="0" smtClean="0">
                                     <a:latin typeface="Cambria Math" panose="02040503050406030204" pitchFamily="18" charset="0"/>
                                   </a:rPr>
                                 </m:ctrlPr>
                               </m:sSupPr>
                               <m:e>
                                 <m:r>
-                                  <a:rPr lang="en-US" b="1" i="1" dirty="0" smtClean="0">
+                                  <a:rPr lang="en-US" b="0" i="1" dirty="0" smtClean="0">
                                     <a:latin typeface="Cambria Math" panose="02040503050406030204" pitchFamily="18" charset="0"/>
                                   </a:rPr>
-                                  <m:t>𝒃</m:t>
+                                  <m:t>𝑏</m:t>
                                 </m:r>
                               </m:e>
                               <m:sup>
                                 <m:r>
-                                  <a:rPr lang="en-US" b="1" i="1" dirty="0" smtClean="0">
+                                  <a:rPr lang="en-US" b="0" i="1" dirty="0" smtClean="0">
                                     <a:latin typeface="Cambria Math" panose="02040503050406030204" pitchFamily="18" charset="0"/>
                                   </a:rPr>
-                                  <m:t>𝟐</m:t>
+                                  <m:t>2</m:t>
                                 </m:r>
                               </m:sup>
                             </m:sSup>
                             <m:r>
-                              <a:rPr lang="en-US" b="1" i="1" dirty="0" smtClean="0">
+                              <a:rPr lang="en-US" b="0" i="1" dirty="0" smtClean="0">
                                 <a:latin typeface="Cambria Math" panose="02040503050406030204" pitchFamily="18" charset="0"/>
                               </a:rPr>
-                              <m:t>−</m:t>
+                              <m:t>−4</m:t>
                             </m:r>
                             <m:r>
-                              <a:rPr lang="en-US" b="1" i="1" dirty="0" smtClean="0">
+                              <a:rPr lang="en-US" b="0" i="1" dirty="0" smtClean="0">
                                 <a:latin typeface="Cambria Math" panose="02040503050406030204" pitchFamily="18" charset="0"/>
                               </a:rPr>
-                              <m:t>𝟒</m:t>
-                            </m:r>
-                            <m:r>
-                              <a:rPr lang="en-US" b="1" i="1" dirty="0" smtClean="0">
-                                <a:latin typeface="Cambria Math" panose="02040503050406030204" pitchFamily="18" charset="0"/>
-                              </a:rPr>
-                              <m:t>𝒂𝒄</m:t>
+                              <m:t>𝑎𝑐</m:t>
                             </m:r>
                           </m:e>
                         </m:rad>
                       </m:num>
                       <m:den>
                         <m:r>
-                          <a:rPr lang="en-US" b="1" i="1" dirty="0" smtClean="0">
+                          <a:rPr lang="en-US" b="0" i="1" dirty="0" smtClean="0">
                             <a:latin typeface="Cambria Math" panose="02040503050406030204" pitchFamily="18" charset="0"/>
                           </a:rPr>
-                          <m:t>𝟐</m:t>
+                          <m:t>2</m:t>
                         </m:r>
                         <m:r>
-                          <a:rPr lang="en-US" b="1" i="1" dirty="0" smtClean="0">
+                          <a:rPr lang="en-US" b="0" i="1" dirty="0" smtClean="0">
                             <a:latin typeface="Cambria Math" panose="02040503050406030204" pitchFamily="18" charset="0"/>
                           </a:rPr>
-                          <m:t>𝒂</m:t>
+                          <m:t>𝑎</m:t>
                         </m:r>
                       </m:den>
                     </m:f>
                   </m:oMath>
                 </a14:m>
-                <a:endParaRPr lang="en-CA" b="1" i="1" dirty="0">
+                <a:endParaRPr lang="en-CA" i="1" dirty="0">
                   <a:latin typeface="Consolas" panose="020B0609020204030204" pitchFamily="49" charset="0"/>
                 </a:endParaRPr>
               </a:p>
@@ -28912,21 +29844,21 @@
                 <a14:m>
                   <m:oMath xmlns:m="http://schemas.openxmlformats.org/officeDocument/2006/math">
                     <m:r>
-                      <a:rPr lang="en-CA" b="1" i="1" dirty="0" smtClean="0">
+                      <a:rPr lang="en-CA" b="0" i="1" dirty="0" smtClean="0">
                         <a:latin typeface="Cambria Math" panose="02040503050406030204" pitchFamily="18" charset="0"/>
                       </a:rPr>
-                      <m:t>𝒓</m:t>
+                      <m:t>𝑟</m:t>
                     </m:r>
                     <m:r>
-                      <a:rPr lang="en-CA" b="1" i="1" dirty="0" smtClean="0">
+                      <a:rPr lang="en-CA" b="0" i="1" dirty="0" smtClean="0">
                         <a:latin typeface="Cambria Math" panose="02040503050406030204" pitchFamily="18" charset="0"/>
                       </a:rPr>
-                      <m:t>𝟐</m:t>
+                      <m:t>2</m:t>
                     </m:r>
                   </m:oMath>
                 </a14:m>
                 <a:r>
-                  <a:rPr lang="en-CA" b="1" dirty="0">
+                  <a:rPr lang="en-CA" dirty="0">
                     <a:latin typeface="Consolas" panose="020B0609020204030204" pitchFamily="49" charset="0"/>
                   </a:rPr>
                   <a:t> </a:t>
@@ -28934,7 +29866,7 @@
                 <a14:m>
                   <m:oMath xmlns:m="http://schemas.openxmlformats.org/officeDocument/2006/math">
                     <m:r>
-                      <a:rPr lang="en-CA" b="1" i="0" smtClean="0">
+                      <a:rPr lang="en-CA" b="0" i="0" smtClean="0">
                         <a:latin typeface="Cambria Math" panose="02040503050406030204" pitchFamily="18" charset="0"/>
                       </a:rPr>
                       <m:t>←</m:t>
@@ -28942,7 +29874,7 @@
                   </m:oMath>
                 </a14:m>
                 <a:r>
-                  <a:rPr lang="en-CA" b="1" dirty="0">
+                  <a:rPr lang="en-CA" dirty="0">
                     <a:latin typeface="Consolas" panose="020B0609020204030204" pitchFamily="49" charset="0"/>
                   </a:rPr>
                   <a:t> </a:t>
@@ -28952,26 +29884,26 @@
                     <m:f>
                       <m:fPr>
                         <m:ctrlPr>
-                          <a:rPr lang="en-US" b="1" i="1" dirty="0" smtClean="0">
+                          <a:rPr lang="en-US" i="1" dirty="0" smtClean="0">
                             <a:latin typeface="Cambria Math" panose="02040503050406030204" pitchFamily="18" charset="0"/>
                           </a:rPr>
                         </m:ctrlPr>
                       </m:fPr>
                       <m:num>
                         <m:r>
-                          <a:rPr lang="en-US" b="1" i="1" dirty="0" smtClean="0">
+                          <a:rPr lang="en-US" b="0" i="1" dirty="0" smtClean="0">
                             <a:latin typeface="Cambria Math" panose="02040503050406030204" pitchFamily="18" charset="0"/>
                           </a:rPr>
                           <m:t>−</m:t>
                         </m:r>
                         <m:r>
-                          <a:rPr lang="en-US" b="1" i="1" dirty="0" smtClean="0">
+                          <a:rPr lang="en-US" b="0" i="1" dirty="0" smtClean="0">
                             <a:latin typeface="Cambria Math" panose="02040503050406030204" pitchFamily="18" charset="0"/>
                           </a:rPr>
-                          <m:t>𝒃</m:t>
+                          <m:t>𝑏</m:t>
                         </m:r>
                         <m:r>
-                          <a:rPr lang="en-US" b="1" i="1" dirty="0" smtClean="0">
+                          <a:rPr lang="en-US" b="0" i="1" dirty="0" smtClean="0">
                             <a:latin typeface="Cambria Math" panose="02040503050406030204" pitchFamily="18" charset="0"/>
                           </a:rPr>
                           <m:t>+</m:t>
@@ -28980,7 +29912,7 @@
                           <m:radPr>
                             <m:degHide m:val="on"/>
                             <m:ctrlPr>
-                              <a:rPr lang="en-US" b="1" i="1" dirty="0" smtClean="0">
+                              <a:rPr lang="en-US" i="1" dirty="0" smtClean="0">
                                 <a:latin typeface="Cambria Math" panose="02040503050406030204" pitchFamily="18" charset="0"/>
                               </a:rPr>
                             </m:ctrlPr>
@@ -28990,67 +29922,61 @@
                             <m:sSup>
                               <m:sSupPr>
                                 <m:ctrlPr>
-                                  <a:rPr lang="en-US" b="1" i="1" dirty="0" smtClean="0">
+                                  <a:rPr lang="en-US" i="1" dirty="0" smtClean="0">
                                     <a:latin typeface="Cambria Math" panose="02040503050406030204" pitchFamily="18" charset="0"/>
                                   </a:rPr>
                                 </m:ctrlPr>
                               </m:sSupPr>
                               <m:e>
                                 <m:r>
-                                  <a:rPr lang="en-US" b="1" i="1" dirty="0" smtClean="0">
+                                  <a:rPr lang="en-US" b="0" i="1" dirty="0" smtClean="0">
                                     <a:latin typeface="Cambria Math" panose="02040503050406030204" pitchFamily="18" charset="0"/>
                                   </a:rPr>
-                                  <m:t>𝒃</m:t>
+                                  <m:t>𝑏</m:t>
                                 </m:r>
                               </m:e>
                               <m:sup>
                                 <m:r>
-                                  <a:rPr lang="en-US" b="1" i="1" dirty="0" smtClean="0">
+                                  <a:rPr lang="en-US" b="0" i="1" dirty="0" smtClean="0">
                                     <a:latin typeface="Cambria Math" panose="02040503050406030204" pitchFamily="18" charset="0"/>
                                   </a:rPr>
-                                  <m:t>𝟐</m:t>
+                                  <m:t>2</m:t>
                                 </m:r>
                               </m:sup>
                             </m:sSup>
                             <m:r>
-                              <a:rPr lang="en-US" b="1" i="1" dirty="0" smtClean="0">
+                              <a:rPr lang="en-US" b="0" i="1" dirty="0" smtClean="0">
                                 <a:latin typeface="Cambria Math" panose="02040503050406030204" pitchFamily="18" charset="0"/>
                               </a:rPr>
-                              <m:t>−</m:t>
+                              <m:t>−4</m:t>
                             </m:r>
                             <m:r>
-                              <a:rPr lang="en-US" b="1" i="1" dirty="0" smtClean="0">
+                              <a:rPr lang="en-US" b="0" i="1" dirty="0" smtClean="0">
                                 <a:latin typeface="Cambria Math" panose="02040503050406030204" pitchFamily="18" charset="0"/>
                               </a:rPr>
-                              <m:t>𝟒</m:t>
-                            </m:r>
-                            <m:r>
-                              <a:rPr lang="en-US" b="1" i="1" dirty="0" smtClean="0">
-                                <a:latin typeface="Cambria Math" panose="02040503050406030204" pitchFamily="18" charset="0"/>
-                              </a:rPr>
-                              <m:t>𝒂𝒄</m:t>
+                              <m:t>𝑎𝑐</m:t>
                             </m:r>
                           </m:e>
                         </m:rad>
                       </m:num>
                       <m:den>
                         <m:r>
-                          <a:rPr lang="en-US" b="1" i="1" dirty="0" smtClean="0">
+                          <a:rPr lang="en-US" b="0" i="1" dirty="0" smtClean="0">
                             <a:latin typeface="Cambria Math" panose="02040503050406030204" pitchFamily="18" charset="0"/>
                           </a:rPr>
-                          <m:t>𝟐</m:t>
+                          <m:t>2</m:t>
                         </m:r>
                         <m:r>
-                          <a:rPr lang="en-US" b="1" i="1" dirty="0" smtClean="0">
+                          <a:rPr lang="en-US" b="0" i="1" dirty="0" smtClean="0">
                             <a:latin typeface="Cambria Math" panose="02040503050406030204" pitchFamily="18" charset="0"/>
                           </a:rPr>
-                          <m:t>𝒂</m:t>
+                          <m:t>𝑎</m:t>
                         </m:r>
                       </m:den>
                     </m:f>
                   </m:oMath>
                 </a14:m>
-                <a:endParaRPr lang="en-CA" b="1" i="1" dirty="0">
+                <a:endParaRPr lang="en-CA" i="1" dirty="0">
                   <a:latin typeface="Consolas" panose="020B0609020204030204" pitchFamily="49" charset="0"/>
                 </a:endParaRPr>
               </a:p>
@@ -29065,7 +29991,7 @@
                   <a:t>Afficher</a:t>
                 </a:r>
                 <a:r>
-                  <a:rPr lang="en-CA" b="1" dirty="0">
+                  <a:rPr lang="en-CA" dirty="0">
                     <a:latin typeface="Consolas" panose="020B0609020204030204" pitchFamily="49" charset="0"/>
                   </a:rPr>
                   <a:t> </a:t>
@@ -29073,21 +29999,21 @@
                 <a14:m>
                   <m:oMath xmlns:m="http://schemas.openxmlformats.org/officeDocument/2006/math">
                     <m:r>
-                      <a:rPr lang="en-CA" b="1" i="1" dirty="0" smtClean="0">
+                      <a:rPr lang="en-CA" b="0" i="1" dirty="0" smtClean="0">
                         <a:latin typeface="Cambria Math" panose="02040503050406030204" pitchFamily="18" charset="0"/>
                       </a:rPr>
-                      <m:t>𝒓</m:t>
+                      <m:t>𝑟</m:t>
                     </m:r>
                     <m:r>
-                      <a:rPr lang="en-CA" b="1" i="1" dirty="0" smtClean="0">
+                      <a:rPr lang="en-CA" b="0" i="1" dirty="0" smtClean="0">
                         <a:latin typeface="Cambria Math" panose="02040503050406030204" pitchFamily="18" charset="0"/>
                       </a:rPr>
-                      <m:t>𝟏</m:t>
+                      <m:t>1</m:t>
                     </m:r>
                   </m:oMath>
                 </a14:m>
                 <a:r>
-                  <a:rPr lang="en-CA" b="1" dirty="0">
+                  <a:rPr lang="en-CA" dirty="0">
                     <a:latin typeface="Consolas" panose="020B0609020204030204" pitchFamily="49" charset="0"/>
                   </a:rPr>
                   <a:t> et </a:t>
@@ -29095,20 +30021,20 @@
                 <a14:m>
                   <m:oMath xmlns:m="http://schemas.openxmlformats.org/officeDocument/2006/math">
                     <m:r>
-                      <a:rPr lang="en-CA" b="1" i="1" dirty="0" smtClean="0">
+                      <a:rPr lang="en-CA" b="0" i="1" dirty="0" smtClean="0">
                         <a:latin typeface="Cambria Math" panose="02040503050406030204" pitchFamily="18" charset="0"/>
                       </a:rPr>
-                      <m:t>𝒓</m:t>
+                      <m:t>𝑟</m:t>
                     </m:r>
                     <m:r>
-                      <a:rPr lang="en-CA" b="1" i="1" dirty="0" smtClean="0">
+                      <a:rPr lang="en-CA" b="0" i="1" dirty="0" smtClean="0">
                         <a:latin typeface="Cambria Math" panose="02040503050406030204" pitchFamily="18" charset="0"/>
                       </a:rPr>
-                      <m:t>𝟐</m:t>
+                      <m:t>2</m:t>
                     </m:r>
                   </m:oMath>
                 </a14:m>
-                <a:endParaRPr lang="en-CA" b="1" dirty="0">
+                <a:endParaRPr lang="en-CA" dirty="0">
                   <a:latin typeface="Consolas" panose="020B0609020204030204" pitchFamily="49" charset="0"/>
                 </a:endParaRPr>
               </a:p>
@@ -29123,7 +30049,7 @@
                   <a:t>Assumant</a:t>
                 </a:r>
                 <a:r>
-                  <a:rPr lang="en-CA" b="1" dirty="0">
+                  <a:rPr lang="en-CA" dirty="0">
                     <a:latin typeface="Consolas" panose="020B0609020204030204" pitchFamily="49" charset="0"/>
                   </a:rPr>
                   <a:t> </a:t>
@@ -29131,27 +30057,21 @@
                 <a14:m>
                   <m:oMath xmlns:m="http://schemas.openxmlformats.org/officeDocument/2006/math">
                     <m:r>
-                      <a:rPr lang="en-CA" b="1" i="1" smtClean="0">
+                      <a:rPr lang="en-CA" b="0" i="1" smtClean="0">
                         <a:latin typeface="Cambria Math" panose="02040503050406030204" pitchFamily="18" charset="0"/>
                       </a:rPr>
-                      <m:t>𝒙</m:t>
+                      <m:t>𝑥</m:t>
                     </m:r>
                     <m:r>
-                      <a:rPr lang="en-CA" b="1" i="1" smtClean="0">
+                      <a:rPr lang="en-CA" b="0" i="1" smtClean="0">
                         <a:latin typeface="Cambria Math" panose="02040503050406030204" pitchFamily="18" charset="0"/>
                       </a:rPr>
-                      <m:t>=</m:t>
-                    </m:r>
-                    <m:r>
-                      <a:rPr lang="en-CA" b="1" i="1" smtClean="0">
-                        <a:latin typeface="Cambria Math" panose="02040503050406030204" pitchFamily="18" charset="0"/>
-                      </a:rPr>
-                      <m:t>𝟏</m:t>
+                      <m:t>=1</m:t>
                     </m:r>
                   </m:oMath>
                 </a14:m>
                 <a:r>
-                  <a:rPr lang="en-CA" b="1" dirty="0">
+                  <a:rPr lang="en-CA" dirty="0">
                     <a:latin typeface="Consolas" panose="020B0609020204030204" pitchFamily="49" charset="0"/>
                   </a:rPr>
                   <a:t>, </a:t>
@@ -29159,27 +30079,21 @@
                 <a14:m>
                   <m:oMath xmlns:m="http://schemas.openxmlformats.org/officeDocument/2006/math">
                     <m:r>
-                      <a:rPr lang="en-CA" b="1" i="1" smtClean="0">
+                      <a:rPr lang="en-CA" b="0" i="1" smtClean="0">
                         <a:latin typeface="Cambria Math" panose="02040503050406030204" pitchFamily="18" charset="0"/>
                       </a:rPr>
-                      <m:t>𝒚</m:t>
+                      <m:t>𝑦</m:t>
                     </m:r>
                     <m:r>
-                      <a:rPr lang="en-CA" b="1" i="1" smtClean="0">
+                      <a:rPr lang="en-CA" b="0" i="1" smtClean="0">
                         <a:latin typeface="Cambria Math" panose="02040503050406030204" pitchFamily="18" charset="0"/>
                       </a:rPr>
-                      <m:t>=</m:t>
-                    </m:r>
-                    <m:r>
-                      <a:rPr lang="en-CA" b="1" i="1" smtClean="0">
-                        <a:latin typeface="Cambria Math" panose="02040503050406030204" pitchFamily="18" charset="0"/>
-                      </a:rPr>
-                      <m:t>𝟐</m:t>
+                      <m:t>=2</m:t>
                     </m:r>
                   </m:oMath>
                 </a14:m>
                 <a:r>
-                  <a:rPr lang="en-CA" b="1" dirty="0">
+                  <a:rPr lang="en-CA" dirty="0">
                     <a:latin typeface="Consolas" panose="020B0609020204030204" pitchFamily="49" charset="0"/>
                   </a:rPr>
                   <a:t>, </a:t>
@@ -29187,33 +30101,27 @@
                 <a14:m>
                   <m:oMath xmlns:m="http://schemas.openxmlformats.org/officeDocument/2006/math">
                     <m:r>
-                      <a:rPr lang="en-CA" b="1" i="1" smtClean="0">
+                      <a:rPr lang="en-CA" b="0" i="1" smtClean="0">
                         <a:latin typeface="Cambria Math" panose="02040503050406030204" pitchFamily="18" charset="0"/>
                       </a:rPr>
-                      <m:t>𝒛</m:t>
+                      <m:t>𝑧</m:t>
                     </m:r>
                     <m:r>
-                      <a:rPr lang="en-CA" b="1" i="1" smtClean="0">
+                      <a:rPr lang="en-CA" b="0" i="1" smtClean="0">
                         <a:latin typeface="Cambria Math" panose="02040503050406030204" pitchFamily="18" charset="0"/>
                       </a:rPr>
-                      <m:t>=−</m:t>
-                    </m:r>
-                    <m:r>
-                      <a:rPr lang="en-CA" b="1" i="1" smtClean="0">
-                        <a:latin typeface="Cambria Math" panose="02040503050406030204" pitchFamily="18" charset="0"/>
-                      </a:rPr>
-                      <m:t>𝟏</m:t>
+                      <m:t>=−1</m:t>
                     </m:r>
                   </m:oMath>
                 </a14:m>
-                <a:endParaRPr lang="en-CA" b="1" dirty="0">
+                <a:endParaRPr lang="en-CA" dirty="0">
                   <a:latin typeface="Consolas" panose="020B0609020204030204" pitchFamily="49" charset="0"/>
                 </a:endParaRPr>
               </a:p>
             </p:txBody>
           </p:sp>
         </mc:Choice>
-        <mc:Fallback xmlns="">
+        <mc:Fallback>
           <p:sp>
             <p:nvSpPr>
               <p:cNvPr id="3" name="Content Placeholder 2">
@@ -29382,172 +30290,6 @@
       </p:sp>
       <p:sp>
         <p:nvSpPr>
-          <p:cNvPr id="3" name="Content Placeholder 2">
-            <a:extLst>
-              <a:ext uri="{FF2B5EF4-FFF2-40B4-BE49-F238E27FC236}">
-                <a16:creationId xmlns:a16="http://schemas.microsoft.com/office/drawing/2014/main" id="{D5FDED70-2ABA-0FB9-7DED-5D74AFDDA0C0}"/>
-              </a:ext>
-            </a:extLst>
-          </p:cNvPr>
-          <p:cNvSpPr>
-            <a:spLocks noGrp="1"/>
-          </p:cNvSpPr>
-          <p:nvPr>
-            <p:ph idx="1"/>
-          </p:nvPr>
-        </p:nvSpPr>
-        <p:spPr/>
-        <p:txBody>
-          <a:bodyPr>
-            <a:normAutofit fontScale="92500" lnSpcReduction="20000"/>
-          </a:bodyPr>
-          <a:lstStyle/>
-          <a:p>
-            <a:pPr marL="0" indent="0">
-              <a:buNone/>
-            </a:pPr>
-            <a:r>
-              <a:rPr lang="en-US" i="1" dirty="0">
-                <a:solidFill>
-                  <a:schemeClr val="accent6"/>
-                </a:solidFill>
-                <a:latin typeface="Consolas" panose="020B0609020204030204" pitchFamily="49" charset="0"/>
-              </a:rPr>
-              <a:t># </a:t>
-            </a:r>
-            <a:r>
-              <a:rPr lang="en-US" i="1" dirty="0" err="1">
-                <a:solidFill>
-                  <a:schemeClr val="accent6"/>
-                </a:solidFill>
-                <a:latin typeface="Consolas" panose="020B0609020204030204" pitchFamily="49" charset="0"/>
-              </a:rPr>
-              <a:t>Paramètres</a:t>
-            </a:r>
-            <a:endParaRPr lang="en-US" i="1" dirty="0">
-              <a:solidFill>
-                <a:schemeClr val="accent6"/>
-              </a:solidFill>
-              <a:latin typeface="Consolas" panose="020B0609020204030204" pitchFamily="49" charset="0"/>
-            </a:endParaRPr>
-          </a:p>
-          <a:p>
-            <a:pPr marL="0" indent="0">
-              <a:buNone/>
-            </a:pPr>
-            <a:r>
-              <a:rPr lang="pt-BR" sz="2600" dirty="0">
-                <a:latin typeface="Consolas" panose="020B0609020204030204" pitchFamily="49" charset="0"/>
-              </a:rPr>
-              <a:t>a = 1</a:t>
-            </a:r>
-          </a:p>
-          <a:p>
-            <a:pPr marL="0" indent="0">
-              <a:buNone/>
-            </a:pPr>
-            <a:r>
-              <a:rPr lang="pt-BR" sz="2600" dirty="0">
-                <a:latin typeface="Consolas" panose="020B0609020204030204" pitchFamily="49" charset="0"/>
-              </a:rPr>
-              <a:t>b = 2</a:t>
-            </a:r>
-          </a:p>
-          <a:p>
-            <a:pPr marL="0" indent="0">
-              <a:buNone/>
-            </a:pPr>
-            <a:r>
-              <a:rPr lang="pt-BR" sz="2600" dirty="0">
-                <a:latin typeface="Consolas" panose="020B0609020204030204" pitchFamily="49" charset="0"/>
-              </a:rPr>
-              <a:t>c = -1</a:t>
-            </a:r>
-          </a:p>
-          <a:p>
-            <a:pPr marL="0" indent="0">
-              <a:buNone/>
-            </a:pPr>
-            <a:endParaRPr lang="pt-BR" sz="2600" dirty="0">
-              <a:latin typeface="Consolas" panose="020B0609020204030204" pitchFamily="49" charset="0"/>
-            </a:endParaRPr>
-          </a:p>
-          <a:p>
-            <a:pPr marL="0" indent="0">
-              <a:buNone/>
-            </a:pPr>
-            <a:r>
-              <a:rPr lang="pt-BR" sz="2600" i="1" dirty="0">
-                <a:solidFill>
-                  <a:schemeClr val="accent6"/>
-                </a:solidFill>
-                <a:latin typeface="Consolas" panose="020B0609020204030204" pitchFamily="49" charset="0"/>
-              </a:rPr>
-              <a:t># Calcul des racines</a:t>
-            </a:r>
-          </a:p>
-          <a:p>
-            <a:pPr marL="0" indent="0">
-              <a:buNone/>
-            </a:pPr>
-            <a:r>
-              <a:rPr lang="pt-BR" sz="2600" dirty="0">
-                <a:latin typeface="Consolas" panose="020B0609020204030204" pitchFamily="49" charset="0"/>
-              </a:rPr>
-              <a:t>r1 = (-b - (b**2 - 4 * a * c)**0.5) / (2 * a)</a:t>
-            </a:r>
-          </a:p>
-          <a:p>
-            <a:pPr marL="0" indent="0">
-              <a:buNone/>
-            </a:pPr>
-            <a:r>
-              <a:rPr lang="pt-BR" sz="2600" dirty="0">
-                <a:latin typeface="Consolas" panose="020B0609020204030204" pitchFamily="49" charset="0"/>
-              </a:rPr>
-              <a:t>r2 = (-b + (b**2 - 4 * a * c)**0.5) / (2 * a)</a:t>
-            </a:r>
-          </a:p>
-          <a:p>
-            <a:pPr marL="0" indent="0">
-              <a:buNone/>
-            </a:pPr>
-            <a:endParaRPr lang="pt-BR" sz="2600" dirty="0">
-              <a:latin typeface="Consolas" panose="020B0609020204030204" pitchFamily="49" charset="0"/>
-            </a:endParaRPr>
-          </a:p>
-          <a:p>
-            <a:pPr marL="0" indent="0">
-              <a:buNone/>
-            </a:pPr>
-            <a:r>
-              <a:rPr lang="pt-BR" sz="2600" i="1" dirty="0">
-                <a:solidFill>
-                  <a:schemeClr val="accent6"/>
-                </a:solidFill>
-                <a:latin typeface="Consolas" panose="020B0609020204030204" pitchFamily="49" charset="0"/>
-              </a:rPr>
-              <a:t># Affichage</a:t>
-            </a:r>
-          </a:p>
-          <a:p>
-            <a:pPr marL="0" indent="0">
-              <a:buNone/>
-            </a:pPr>
-            <a:r>
-              <a:rPr lang="pt-BR" sz="2600" dirty="0">
-                <a:latin typeface="Consolas" panose="020B0609020204030204" pitchFamily="49" charset="0"/>
-              </a:rPr>
-              <a:t>print('r1 = ', r1, 'r2 = ', r2)</a:t>
-            </a:r>
-            <a:endParaRPr lang="en-US" sz="2600" dirty="0">
-              <a:latin typeface="Consolas" panose="020B0609020204030204" pitchFamily="49" charset="0"/>
-            </a:endParaRPr>
-          </a:p>
-        </p:txBody>
-      </p:sp>
-      <p:sp>
-        <p:nvSpPr>
           <p:cNvPr id="11" name="Slide Number Placeholder 10">
             <a:extLst>
               <a:ext uri="{FF2B5EF4-FFF2-40B4-BE49-F238E27FC236}">
@@ -29575,6 +30317,547 @@
           </a:p>
         </p:txBody>
       </p:sp>
+      <p:sp>
+        <p:nvSpPr>
+          <p:cNvPr id="4" name="TextBox 3">
+            <a:extLst>
+              <a:ext uri="{FF2B5EF4-FFF2-40B4-BE49-F238E27FC236}">
+                <a16:creationId xmlns:a16="http://schemas.microsoft.com/office/drawing/2014/main" id="{6D5C844B-8100-128E-22B7-A10D9A2A52D1}"/>
+              </a:ext>
+            </a:extLst>
+          </p:cNvPr>
+          <p:cNvSpPr txBox="1"/>
+          <p:nvPr/>
+        </p:nvSpPr>
+        <p:spPr>
+          <a:xfrm>
+            <a:off x="3107987" y="2154634"/>
+            <a:ext cx="5976026" cy="3693319"/>
+          </a:xfrm>
+          <a:prstGeom prst="rect">
+            <a:avLst/>
+          </a:prstGeom>
+          <a:solidFill>
+            <a:schemeClr val="bg1"/>
+          </a:solidFill>
+          <a:ln w="12700">
+            <a:solidFill>
+              <a:schemeClr val="tx1"/>
+            </a:solidFill>
+          </a:ln>
+        </p:spPr>
+        <p:txBody>
+          <a:bodyPr wrap="square">
+            <a:spAutoFit/>
+          </a:bodyPr>
+          <a:lstStyle/>
+          <a:p>
+            <a:endParaRPr lang="pt-BR" dirty="0">
+              <a:solidFill>
+                <a:srgbClr val="888888"/>
+              </a:solidFill>
+              <a:latin typeface="Consolas" panose="020B0609020204030204" pitchFamily="49" charset="0"/>
+            </a:endParaRPr>
+          </a:p>
+          <a:p>
+            <a:r>
+              <a:rPr lang="pt-BR" dirty="0">
+                <a:solidFill>
+                  <a:schemeClr val="accent6"/>
+                </a:solidFill>
+                <a:latin typeface="Consolas" panose="020B0609020204030204" pitchFamily="49" charset="0"/>
+              </a:rPr>
+              <a:t># Paramètres</a:t>
+            </a:r>
+          </a:p>
+          <a:p>
+            <a:r>
+              <a:rPr lang="pt-BR" dirty="0">
+                <a:solidFill>
+                  <a:srgbClr val="333333"/>
+                </a:solidFill>
+                <a:latin typeface="Consolas" panose="020B0609020204030204" pitchFamily="49" charset="0"/>
+              </a:rPr>
+              <a:t>a = </a:t>
+            </a:r>
+            <a:r>
+              <a:rPr lang="pt-BR" b="1" dirty="0">
+                <a:solidFill>
+                  <a:srgbClr val="0000DD"/>
+                </a:solidFill>
+                <a:latin typeface="Consolas" panose="020B0609020204030204" pitchFamily="49" charset="0"/>
+              </a:rPr>
+              <a:t>1</a:t>
+            </a:r>
+            <a:endParaRPr lang="pt-BR" dirty="0">
+              <a:solidFill>
+                <a:srgbClr val="333333"/>
+              </a:solidFill>
+              <a:latin typeface="Consolas" panose="020B0609020204030204" pitchFamily="49" charset="0"/>
+            </a:endParaRPr>
+          </a:p>
+          <a:p>
+            <a:r>
+              <a:rPr lang="pt-BR" dirty="0">
+                <a:solidFill>
+                  <a:srgbClr val="333333"/>
+                </a:solidFill>
+                <a:latin typeface="Consolas" panose="020B0609020204030204" pitchFamily="49" charset="0"/>
+              </a:rPr>
+              <a:t>b = </a:t>
+            </a:r>
+            <a:r>
+              <a:rPr lang="pt-BR" b="1" dirty="0">
+                <a:solidFill>
+                  <a:srgbClr val="0000DD"/>
+                </a:solidFill>
+                <a:latin typeface="Consolas" panose="020B0609020204030204" pitchFamily="49" charset="0"/>
+              </a:rPr>
+              <a:t>2</a:t>
+            </a:r>
+            <a:endParaRPr lang="pt-BR" dirty="0">
+              <a:solidFill>
+                <a:srgbClr val="333333"/>
+              </a:solidFill>
+              <a:latin typeface="Consolas" panose="020B0609020204030204" pitchFamily="49" charset="0"/>
+            </a:endParaRPr>
+          </a:p>
+          <a:p>
+            <a:r>
+              <a:rPr lang="pt-BR" dirty="0">
+                <a:solidFill>
+                  <a:srgbClr val="333333"/>
+                </a:solidFill>
+                <a:latin typeface="Consolas" panose="020B0609020204030204" pitchFamily="49" charset="0"/>
+              </a:rPr>
+              <a:t>c = -</a:t>
+            </a:r>
+            <a:r>
+              <a:rPr lang="pt-BR" b="1" dirty="0">
+                <a:solidFill>
+                  <a:srgbClr val="0000DD"/>
+                </a:solidFill>
+                <a:latin typeface="Consolas" panose="020B0609020204030204" pitchFamily="49" charset="0"/>
+              </a:rPr>
+              <a:t>1</a:t>
+            </a:r>
+            <a:endParaRPr lang="pt-BR" dirty="0">
+              <a:solidFill>
+                <a:srgbClr val="333333"/>
+              </a:solidFill>
+              <a:latin typeface="Consolas" panose="020B0609020204030204" pitchFamily="49" charset="0"/>
+            </a:endParaRPr>
+          </a:p>
+          <a:p>
+            <a:endParaRPr lang="pt-BR" dirty="0">
+              <a:solidFill>
+                <a:srgbClr val="333333"/>
+              </a:solidFill>
+              <a:latin typeface="Consolas" panose="020B0609020204030204" pitchFamily="49" charset="0"/>
+            </a:endParaRPr>
+          </a:p>
+          <a:p>
+            <a:r>
+              <a:rPr lang="pt-BR" dirty="0">
+                <a:solidFill>
+                  <a:schemeClr val="accent6"/>
+                </a:solidFill>
+                <a:latin typeface="Consolas" panose="020B0609020204030204" pitchFamily="49" charset="0"/>
+              </a:rPr>
+              <a:t># Calcul des racines</a:t>
+            </a:r>
+          </a:p>
+          <a:p>
+            <a:r>
+              <a:rPr lang="pt-BR" dirty="0">
+                <a:solidFill>
+                  <a:srgbClr val="333333"/>
+                </a:solidFill>
+                <a:latin typeface="Consolas" panose="020B0609020204030204" pitchFamily="49" charset="0"/>
+              </a:rPr>
+              <a:t>r1 = (-b - (b**</a:t>
+            </a:r>
+            <a:r>
+              <a:rPr lang="pt-BR" b="1" dirty="0">
+                <a:solidFill>
+                  <a:srgbClr val="0000DD"/>
+                </a:solidFill>
+                <a:latin typeface="Consolas" panose="020B0609020204030204" pitchFamily="49" charset="0"/>
+              </a:rPr>
+              <a:t>2</a:t>
+            </a:r>
+            <a:r>
+              <a:rPr lang="pt-BR" dirty="0">
+                <a:solidFill>
+                  <a:srgbClr val="333333"/>
+                </a:solidFill>
+                <a:latin typeface="Consolas" panose="020B0609020204030204" pitchFamily="49" charset="0"/>
+              </a:rPr>
+              <a:t> - </a:t>
+            </a:r>
+            <a:r>
+              <a:rPr lang="pt-BR" b="1" dirty="0">
+                <a:solidFill>
+                  <a:srgbClr val="0000DD"/>
+                </a:solidFill>
+                <a:latin typeface="Consolas" panose="020B0609020204030204" pitchFamily="49" charset="0"/>
+              </a:rPr>
+              <a:t>4</a:t>
+            </a:r>
+            <a:r>
+              <a:rPr lang="pt-BR" dirty="0">
+                <a:solidFill>
+                  <a:srgbClr val="333333"/>
+                </a:solidFill>
+                <a:latin typeface="Consolas" panose="020B0609020204030204" pitchFamily="49" charset="0"/>
+              </a:rPr>
+              <a:t> * a * c)**</a:t>
+            </a:r>
+            <a:r>
+              <a:rPr lang="pt-BR" b="1" dirty="0">
+                <a:solidFill>
+                  <a:srgbClr val="6600EE"/>
+                </a:solidFill>
+                <a:latin typeface="Consolas" panose="020B0609020204030204" pitchFamily="49" charset="0"/>
+              </a:rPr>
+              <a:t>0.5</a:t>
+            </a:r>
+            <a:r>
+              <a:rPr lang="pt-BR" dirty="0">
+                <a:solidFill>
+                  <a:srgbClr val="333333"/>
+                </a:solidFill>
+                <a:latin typeface="Consolas" panose="020B0609020204030204" pitchFamily="49" charset="0"/>
+              </a:rPr>
+              <a:t>) / (</a:t>
+            </a:r>
+            <a:r>
+              <a:rPr lang="pt-BR" b="1" dirty="0">
+                <a:solidFill>
+                  <a:srgbClr val="0000DD"/>
+                </a:solidFill>
+                <a:latin typeface="Consolas" panose="020B0609020204030204" pitchFamily="49" charset="0"/>
+              </a:rPr>
+              <a:t>2</a:t>
+            </a:r>
+            <a:r>
+              <a:rPr lang="pt-BR" dirty="0">
+                <a:solidFill>
+                  <a:srgbClr val="333333"/>
+                </a:solidFill>
+                <a:latin typeface="Consolas" panose="020B0609020204030204" pitchFamily="49" charset="0"/>
+              </a:rPr>
+              <a:t> * a)</a:t>
+            </a:r>
+          </a:p>
+          <a:p>
+            <a:r>
+              <a:rPr lang="pt-BR" dirty="0">
+                <a:solidFill>
+                  <a:srgbClr val="333333"/>
+                </a:solidFill>
+                <a:latin typeface="Consolas" panose="020B0609020204030204" pitchFamily="49" charset="0"/>
+              </a:rPr>
+              <a:t>r2 = (-b + (b**</a:t>
+            </a:r>
+            <a:r>
+              <a:rPr lang="pt-BR" b="1" dirty="0">
+                <a:solidFill>
+                  <a:srgbClr val="0000DD"/>
+                </a:solidFill>
+                <a:latin typeface="Consolas" panose="020B0609020204030204" pitchFamily="49" charset="0"/>
+              </a:rPr>
+              <a:t>2</a:t>
+            </a:r>
+            <a:r>
+              <a:rPr lang="pt-BR" dirty="0">
+                <a:solidFill>
+                  <a:srgbClr val="333333"/>
+                </a:solidFill>
+                <a:latin typeface="Consolas" panose="020B0609020204030204" pitchFamily="49" charset="0"/>
+              </a:rPr>
+              <a:t> - </a:t>
+            </a:r>
+            <a:r>
+              <a:rPr lang="pt-BR" b="1" dirty="0">
+                <a:solidFill>
+                  <a:srgbClr val="0000DD"/>
+                </a:solidFill>
+                <a:latin typeface="Consolas" panose="020B0609020204030204" pitchFamily="49" charset="0"/>
+              </a:rPr>
+              <a:t>4</a:t>
+            </a:r>
+            <a:r>
+              <a:rPr lang="pt-BR" dirty="0">
+                <a:solidFill>
+                  <a:srgbClr val="333333"/>
+                </a:solidFill>
+                <a:latin typeface="Consolas" panose="020B0609020204030204" pitchFamily="49" charset="0"/>
+              </a:rPr>
+              <a:t> * a * c)**</a:t>
+            </a:r>
+            <a:r>
+              <a:rPr lang="pt-BR" b="1" dirty="0">
+                <a:solidFill>
+                  <a:srgbClr val="6600EE"/>
+                </a:solidFill>
+                <a:latin typeface="Consolas" panose="020B0609020204030204" pitchFamily="49" charset="0"/>
+              </a:rPr>
+              <a:t>0.5</a:t>
+            </a:r>
+            <a:r>
+              <a:rPr lang="pt-BR" dirty="0">
+                <a:solidFill>
+                  <a:srgbClr val="333333"/>
+                </a:solidFill>
+                <a:latin typeface="Consolas" panose="020B0609020204030204" pitchFamily="49" charset="0"/>
+              </a:rPr>
+              <a:t>) / (</a:t>
+            </a:r>
+            <a:r>
+              <a:rPr lang="pt-BR" b="1" dirty="0">
+                <a:solidFill>
+                  <a:srgbClr val="0000DD"/>
+                </a:solidFill>
+                <a:latin typeface="Consolas" panose="020B0609020204030204" pitchFamily="49" charset="0"/>
+              </a:rPr>
+              <a:t>2</a:t>
+            </a:r>
+            <a:r>
+              <a:rPr lang="pt-BR" dirty="0">
+                <a:solidFill>
+                  <a:srgbClr val="333333"/>
+                </a:solidFill>
+                <a:latin typeface="Consolas" panose="020B0609020204030204" pitchFamily="49" charset="0"/>
+              </a:rPr>
+              <a:t> * a)</a:t>
+            </a:r>
+          </a:p>
+          <a:p>
+            <a:endParaRPr lang="pt-BR" dirty="0">
+              <a:solidFill>
+                <a:srgbClr val="333333"/>
+              </a:solidFill>
+              <a:latin typeface="Consolas" panose="020B0609020204030204" pitchFamily="49" charset="0"/>
+            </a:endParaRPr>
+          </a:p>
+          <a:p>
+            <a:r>
+              <a:rPr lang="pt-BR" dirty="0">
+                <a:solidFill>
+                  <a:schemeClr val="accent6"/>
+                </a:solidFill>
+                <a:latin typeface="Consolas" panose="020B0609020204030204" pitchFamily="49" charset="0"/>
+              </a:rPr>
+              <a:t># Affichage</a:t>
+            </a:r>
+          </a:p>
+          <a:p>
+            <a:r>
+              <a:rPr lang="pt-BR" dirty="0">
+                <a:solidFill>
+                  <a:srgbClr val="007020"/>
+                </a:solidFill>
+                <a:latin typeface="Consolas" panose="020B0609020204030204" pitchFamily="49" charset="0"/>
+              </a:rPr>
+              <a:t>print</a:t>
+            </a:r>
+            <a:r>
+              <a:rPr lang="pt-BR" dirty="0">
+                <a:solidFill>
+                  <a:srgbClr val="333333"/>
+                </a:solidFill>
+                <a:latin typeface="Consolas" panose="020B0609020204030204" pitchFamily="49" charset="0"/>
+              </a:rPr>
+              <a:t>('r1 = ', r1, 'r2 = ', r2)</a:t>
+            </a:r>
+          </a:p>
+          <a:p>
+            <a:endParaRPr lang="pt-BR" dirty="0">
+              <a:solidFill>
+                <a:srgbClr val="333333"/>
+              </a:solidFill>
+              <a:latin typeface="Consolas" panose="020B0609020204030204" pitchFamily="49" charset="0"/>
+            </a:endParaRPr>
+          </a:p>
+        </p:txBody>
+      </p:sp>
+      <p:grpSp>
+        <p:nvGrpSpPr>
+          <p:cNvPr id="13" name="Group 12">
+            <a:extLst>
+              <a:ext uri="{FF2B5EF4-FFF2-40B4-BE49-F238E27FC236}">
+                <a16:creationId xmlns:a16="http://schemas.microsoft.com/office/drawing/2014/main" id="{971CC572-66AF-3FC8-55F3-1FE58AC6A1C8}"/>
+              </a:ext>
+            </a:extLst>
+          </p:cNvPr>
+          <p:cNvGrpSpPr/>
+          <p:nvPr/>
+        </p:nvGrpSpPr>
+        <p:grpSpPr>
+          <a:xfrm>
+            <a:off x="2451370" y="2613498"/>
+            <a:ext cx="557719" cy="2454613"/>
+            <a:chOff x="2451370" y="2613498"/>
+            <a:chExt cx="557719" cy="2454613"/>
+          </a:xfrm>
+        </p:grpSpPr>
+        <p:cxnSp>
+          <p:nvCxnSpPr>
+            <p:cNvPr id="6" name="Straight Arrow Connector 5">
+              <a:extLst>
+                <a:ext uri="{FF2B5EF4-FFF2-40B4-BE49-F238E27FC236}">
+                  <a16:creationId xmlns:a16="http://schemas.microsoft.com/office/drawing/2014/main" id="{F9D02BAD-0E78-66FC-B463-97391E2BAEA5}"/>
+                </a:ext>
+              </a:extLst>
+            </p:cNvPr>
+            <p:cNvCxnSpPr/>
+            <p:nvPr/>
+          </p:nvCxnSpPr>
+          <p:spPr>
+            <a:xfrm>
+              <a:off x="2451370" y="2613498"/>
+              <a:ext cx="557719" cy="0"/>
+            </a:xfrm>
+            <a:prstGeom prst="straightConnector1">
+              <a:avLst/>
+            </a:prstGeom>
+            <a:ln>
+              <a:tailEnd type="triangle"/>
+            </a:ln>
+          </p:spPr>
+          <p:style>
+            <a:lnRef idx="2">
+              <a:schemeClr val="dk1"/>
+            </a:lnRef>
+            <a:fillRef idx="0">
+              <a:schemeClr val="dk1"/>
+            </a:fillRef>
+            <a:effectRef idx="1">
+              <a:schemeClr val="dk1"/>
+            </a:effectRef>
+            <a:fontRef idx="minor">
+              <a:schemeClr val="tx1"/>
+            </a:fontRef>
+          </p:style>
+        </p:cxnSp>
+        <p:cxnSp>
+          <p:nvCxnSpPr>
+            <p:cNvPr id="7" name="Straight Arrow Connector 6">
+              <a:extLst>
+                <a:ext uri="{FF2B5EF4-FFF2-40B4-BE49-F238E27FC236}">
+                  <a16:creationId xmlns:a16="http://schemas.microsoft.com/office/drawing/2014/main" id="{BB860FCF-E9BE-C17B-B1A1-2B4A924664F0}"/>
+                </a:ext>
+              </a:extLst>
+            </p:cNvPr>
+            <p:cNvCxnSpPr/>
+            <p:nvPr/>
+          </p:nvCxnSpPr>
+          <p:spPr>
+            <a:xfrm>
+              <a:off x="2451370" y="3978613"/>
+              <a:ext cx="557719" cy="0"/>
+            </a:xfrm>
+            <a:prstGeom prst="straightConnector1">
+              <a:avLst/>
+            </a:prstGeom>
+            <a:ln>
+              <a:tailEnd type="triangle"/>
+            </a:ln>
+          </p:spPr>
+          <p:style>
+            <a:lnRef idx="2">
+              <a:schemeClr val="dk1"/>
+            </a:lnRef>
+            <a:fillRef idx="0">
+              <a:schemeClr val="dk1"/>
+            </a:fillRef>
+            <a:effectRef idx="1">
+              <a:schemeClr val="dk1"/>
+            </a:effectRef>
+            <a:fontRef idx="minor">
+              <a:schemeClr val="tx1"/>
+            </a:fontRef>
+          </p:style>
+        </p:cxnSp>
+        <p:cxnSp>
+          <p:nvCxnSpPr>
+            <p:cNvPr id="8" name="Straight Arrow Connector 7">
+              <a:extLst>
+                <a:ext uri="{FF2B5EF4-FFF2-40B4-BE49-F238E27FC236}">
+                  <a16:creationId xmlns:a16="http://schemas.microsoft.com/office/drawing/2014/main" id="{07F9D728-B9C5-151F-04CF-E99D7D28100D}"/>
+                </a:ext>
+              </a:extLst>
+            </p:cNvPr>
+            <p:cNvCxnSpPr/>
+            <p:nvPr/>
+          </p:nvCxnSpPr>
+          <p:spPr>
+            <a:xfrm>
+              <a:off x="2451370" y="5068111"/>
+              <a:ext cx="557719" cy="0"/>
+            </a:xfrm>
+            <a:prstGeom prst="straightConnector1">
+              <a:avLst/>
+            </a:prstGeom>
+            <a:ln>
+              <a:tailEnd type="triangle"/>
+            </a:ln>
+          </p:spPr>
+          <p:style>
+            <a:lnRef idx="2">
+              <a:schemeClr val="dk1"/>
+            </a:lnRef>
+            <a:fillRef idx="0">
+              <a:schemeClr val="dk1"/>
+            </a:fillRef>
+            <a:effectRef idx="1">
+              <a:schemeClr val="dk1"/>
+            </a:effectRef>
+            <a:fontRef idx="minor">
+              <a:schemeClr val="tx1"/>
+            </a:fontRef>
+          </p:style>
+        </p:cxnSp>
+        <p:cxnSp>
+          <p:nvCxnSpPr>
+            <p:cNvPr id="10" name="Straight Connector 9">
+              <a:extLst>
+                <a:ext uri="{FF2B5EF4-FFF2-40B4-BE49-F238E27FC236}">
+                  <a16:creationId xmlns:a16="http://schemas.microsoft.com/office/drawing/2014/main" id="{152D9215-D601-F940-28BE-4BD7BA22CFC1}"/>
+                </a:ext>
+              </a:extLst>
+            </p:cNvPr>
+            <p:cNvCxnSpPr>
+              <a:cxnSpLocks/>
+            </p:cNvCxnSpPr>
+            <p:nvPr/>
+          </p:nvCxnSpPr>
+          <p:spPr>
+            <a:xfrm>
+              <a:off x="2451370" y="2613498"/>
+              <a:ext cx="0" cy="2454613"/>
+            </a:xfrm>
+            <a:prstGeom prst="line">
+              <a:avLst/>
+            </a:prstGeom>
+          </p:spPr>
+          <p:style>
+            <a:lnRef idx="2">
+              <a:schemeClr val="dk1"/>
+            </a:lnRef>
+            <a:fillRef idx="0">
+              <a:schemeClr val="dk1"/>
+            </a:fillRef>
+            <a:effectRef idx="1">
+              <a:schemeClr val="dk1"/>
+            </a:effectRef>
+            <a:fontRef idx="minor">
+              <a:schemeClr val="tx1"/>
+            </a:fontRef>
+          </p:style>
+        </p:cxnSp>
+      </p:grpSp>
     </p:spTree>
     <p:extLst>
       <p:ext uri="{BB962C8B-B14F-4D97-AF65-F5344CB8AC3E}">
@@ -29585,6 +30868,89 @@
   <p:clrMapOvr>
     <a:masterClrMapping/>
   </p:clrMapOvr>
+  <p:timing>
+    <p:tnLst>
+      <p:par>
+        <p:cTn id="1" dur="indefinite" restart="never" nodeType="tmRoot">
+          <p:childTnLst>
+            <p:seq concurrent="1" nextAc="seek">
+              <p:cTn id="2" dur="indefinite" nodeType="mainSeq">
+                <p:childTnLst>
+                  <p:par>
+                    <p:cTn id="3" fill="hold">
+                      <p:stCondLst>
+                        <p:cond delay="indefinite"/>
+                      </p:stCondLst>
+                      <p:childTnLst>
+                        <p:par>
+                          <p:cTn id="4" fill="hold">
+                            <p:stCondLst>
+                              <p:cond delay="0"/>
+                            </p:stCondLst>
+                            <p:childTnLst>
+                              <p:par>
+                                <p:cTn id="5" presetID="10" presetClass="entr" presetSubtype="0" fill="hold" nodeType="clickEffect">
+                                  <p:stCondLst>
+                                    <p:cond delay="0"/>
+                                  </p:stCondLst>
+                                  <p:childTnLst>
+                                    <p:set>
+                                      <p:cBhvr>
+                                        <p:cTn id="6" dur="1" fill="hold">
+                                          <p:stCondLst>
+                                            <p:cond delay="0"/>
+                                          </p:stCondLst>
+                                        </p:cTn>
+                                        <p:tgtEl>
+                                          <p:spTgt spid="13"/>
+                                        </p:tgtEl>
+                                        <p:attrNameLst>
+                                          <p:attrName>style.visibility</p:attrName>
+                                        </p:attrNameLst>
+                                      </p:cBhvr>
+                                      <p:to>
+                                        <p:strVal val="visible"/>
+                                      </p:to>
+                                    </p:set>
+                                    <p:animEffect transition="in" filter="fade">
+                                      <p:cBhvr>
+                                        <p:cTn id="7" dur="500"/>
+                                        <p:tgtEl>
+                                          <p:spTgt spid="13"/>
+                                        </p:tgtEl>
+                                      </p:cBhvr>
+                                    </p:animEffect>
+                                  </p:childTnLst>
+                                </p:cTn>
+                              </p:par>
+                            </p:childTnLst>
+                          </p:cTn>
+                        </p:par>
+                      </p:childTnLst>
+                    </p:cTn>
+                  </p:par>
+                </p:childTnLst>
+              </p:cTn>
+              <p:prevCondLst>
+                <p:cond evt="onPrev" delay="0">
+                  <p:tgtEl>
+                    <p:sldTgt/>
+                  </p:tgtEl>
+                </p:cond>
+              </p:prevCondLst>
+              <p:nextCondLst>
+                <p:cond evt="onNext" delay="0">
+                  <p:tgtEl>
+                    <p:sldTgt/>
+                  </p:tgtEl>
+                </p:cond>
+              </p:nextCondLst>
+            </p:seq>
+          </p:childTnLst>
+        </p:cTn>
+      </p:par>
+    </p:tnLst>
+  </p:timing>
 </p:sld>
 </file>
 
@@ -29664,8 +31030,8 @@
           </a:p>
         </p:txBody>
       </p:sp>
-      <mc:AlternateContent xmlns:mc="http://schemas.openxmlformats.org/markup-compatibility/2006" xmlns:a14="http://schemas.microsoft.com/office/drawing/2010/main">
-        <mc:Choice Requires="a14">
+      <mc:AlternateContent xmlns:mc="http://schemas.openxmlformats.org/markup-compatibility/2006">
+        <mc:Choice xmlns:a14="http://schemas.microsoft.com/office/drawing/2010/main" Requires="a14">
           <p:sp>
             <p:nvSpPr>
               <p:cNvPr id="3" name="Content Placeholder 2">
@@ -29690,7 +31056,7 @@
               <a:lstStyle/>
               <a:p>
                 <a:r>
-                  <a:rPr lang="pt-BR" sz="2600" b="1" dirty="0">
+                  <a:rPr lang="pt-BR" sz="2600" dirty="0">
                     <a:latin typeface="Consolas" panose="020B0609020204030204" pitchFamily="49" charset="0"/>
                   </a:rPr>
                   <a:t>Déclarer fonction </a:t>
@@ -29698,7 +31064,7 @@
                 <a14:m>
                   <m:oMath xmlns:m="http://schemas.openxmlformats.org/officeDocument/2006/math">
                     <m:r>
-                      <a:rPr lang="pt-BR" sz="2600" b="1" i="1" smtClean="0">
+                      <a:rPr lang="pt-BR" sz="2600" b="0" i="1" smtClean="0">
                         <a:latin typeface="Cambria Math" panose="02040503050406030204" pitchFamily="18" charset="0"/>
                         <a:ea typeface="Cambria Math" panose="02040503050406030204" pitchFamily="18" charset="0"/>
                       </a:rPr>
@@ -29707,10 +31073,37 @@
                   </m:oMath>
                 </a14:m>
                 <a:r>
-                  <a:rPr lang="pt-BR" sz="2600" b="1" dirty="0">
+                  <a:rPr lang="pt-BR" sz="2600" dirty="0">
                     <a:latin typeface="Consolas" panose="020B0609020204030204" pitchFamily="49" charset="0"/>
                   </a:rPr>
                   <a:t> </a:t>
+                </a:r>
+                <a:r>
+                  <a:rPr lang="pt-BR" sz="2400" b="1" dirty="0">
+                    <a:solidFill>
+                      <a:srgbClr val="008800"/>
+                    </a:solidFill>
+                    <a:latin typeface="Consolas" panose="020B0609020204030204" pitchFamily="49" charset="0"/>
+                  </a:rPr>
+                  <a:t>def</a:t>
+                </a:r>
+                <a:r>
+                  <a:rPr lang="pt-BR" sz="2400" dirty="0">
+                    <a:solidFill>
+                      <a:srgbClr val="BBBBBB"/>
+                    </a:solidFill>
+                    <a:latin typeface="Consolas" panose="020B0609020204030204" pitchFamily="49" charset="0"/>
+                  </a:rPr>
+                  <a:t> </a:t>
+                </a:r>
+                <a:r>
+                  <a:rPr lang="pt-BR" sz="2400" b="1" dirty="0">
+                    <a:solidFill>
+                      <a:srgbClr val="0066BB"/>
+                    </a:solidFill>
+                    <a:latin typeface="Consolas" panose="020B0609020204030204" pitchFamily="49" charset="0"/>
+                  </a:rPr>
+                  <a:t>foo</a:t>
                 </a:r>
                 <a:r>
                   <a:rPr lang="pt-BR" sz="2600" dirty="0">
@@ -29718,7 +31111,7 @@
                     <a:ea typeface="+mj-ea"/>
                     <a:cs typeface="+mj-cs"/>
                   </a:rPr>
-                  <a:t>def foo(*args): ...</a:t>
+                  <a:t>(...): ...</a:t>
                 </a:r>
               </a:p>
               <a:p>
@@ -29726,7 +31119,13 @@
                   <a:rPr lang="pt-BR" sz="2600" b="1" dirty="0">
                     <a:latin typeface="Consolas" panose="020B0609020204030204" pitchFamily="49" charset="0"/>
                   </a:rPr>
-                  <a:t>Décalage constant (tabulation) des instructions</a:t>
+                  <a:t>Décalage constant </a:t>
+                </a:r>
+                <a:r>
+                  <a:rPr lang="pt-BR" sz="2600" dirty="0">
+                    <a:latin typeface="Consolas" panose="020B0609020204030204" pitchFamily="49" charset="0"/>
+                  </a:rPr>
+                  <a:t>du corps</a:t>
                 </a:r>
                 <a:br>
                   <a:rPr lang="pt-BR" sz="2600" b="1" dirty="0">
@@ -29748,7 +31147,7 @@
             </p:txBody>
           </p:sp>
         </mc:Choice>
-        <mc:Fallback xmlns="">
+        <mc:Fallback>
           <p:sp>
             <p:nvSpPr>
               <p:cNvPr id="3" name="Content Placeholder 2">
@@ -29832,7 +31231,7 @@
         <p:spPr>
           <a:xfrm>
             <a:off x="2869659" y="3104135"/>
-            <a:ext cx="5100537" cy="1954381"/>
+            <a:ext cx="5100537" cy="2308324"/>
           </a:xfrm>
           <a:prstGeom prst="rect">
             <a:avLst/>
@@ -29852,96 +31251,362 @@
           </a:bodyPr>
           <a:lstStyle/>
           <a:p>
-            <a:br>
-              <a:rPr lang="pt-BR" sz="500" b="1" dirty="0">
-                <a:latin typeface="Consolas" panose="020B0609020204030204" pitchFamily="49" charset="0"/>
-              </a:rPr>
-            </a:br>
-            <a:r>
-              <a:rPr lang="pt-BR" b="1" dirty="0">
-                <a:latin typeface="Consolas" panose="020B0609020204030204" pitchFamily="49" charset="0"/>
-              </a:rPr>
-              <a:t>def calculer_afficher_racines(a,b,c):</a:t>
-            </a:r>
-          </a:p>
-          <a:p>
-            <a:endParaRPr lang="pt-BR" sz="100" b="1" dirty="0">
+            <a:pPr algn="l">
+              <a:buNone/>
+            </a:pPr>
+            <a:r>
+              <a:rPr lang="pt-BR" b="1" i="0" dirty="0">
+                <a:solidFill>
+                  <a:srgbClr val="008800"/>
+                </a:solidFill>
+                <a:effectLst/>
+                <a:latin typeface="Consolas" panose="020B0609020204030204" pitchFamily="49" charset="0"/>
+              </a:rPr>
+              <a:t>def</a:t>
+            </a:r>
+            <a:r>
+              <a:rPr lang="pt-BR" b="0" i="0" dirty="0">
+                <a:solidFill>
+                  <a:srgbClr val="BBBBBB"/>
+                </a:solidFill>
+                <a:effectLst/>
+                <a:latin typeface="Consolas" panose="020B0609020204030204" pitchFamily="49" charset="0"/>
+              </a:rPr>
+              <a:t> </a:t>
+            </a:r>
+            <a:r>
+              <a:rPr lang="pt-BR" b="1" i="0" dirty="0">
+                <a:solidFill>
+                  <a:srgbClr val="0066BB"/>
+                </a:solidFill>
+                <a:effectLst/>
+                <a:latin typeface="Consolas" panose="020B0609020204030204" pitchFamily="49" charset="0"/>
+              </a:rPr>
+              <a:t>calculer_afficher_racines</a:t>
+            </a:r>
+            <a:r>
+              <a:rPr lang="pt-BR" b="0" i="0" dirty="0">
+                <a:solidFill>
+                  <a:srgbClr val="333333"/>
+                </a:solidFill>
+                <a:effectLst/>
+                <a:latin typeface="Consolas" panose="020B0609020204030204" pitchFamily="49" charset="0"/>
+              </a:rPr>
+              <a:t>(a,b,c):</a:t>
+            </a:r>
+          </a:p>
+          <a:p>
+            <a:pPr algn="l">
+              <a:buNone/>
+            </a:pPr>
+            <a:endParaRPr lang="pt-BR" b="0" i="0" dirty="0">
+              <a:solidFill>
+                <a:srgbClr val="333333"/>
+              </a:solidFill>
+              <a:effectLst/>
               <a:latin typeface="Consolas" panose="020B0609020204030204" pitchFamily="49" charset="0"/>
             </a:endParaRPr>
           </a:p>
           <a:p>
-            <a:r>
-              <a:rPr lang="pt-BR" b="1" dirty="0">
+            <a:pPr algn="l">
+              <a:buNone/>
+            </a:pPr>
+            <a:r>
+              <a:rPr lang="pt-BR" b="0" i="0" dirty="0">
+                <a:solidFill>
+                  <a:srgbClr val="333333"/>
+                </a:solidFill>
+                <a:effectLst/>
                 <a:latin typeface="Consolas" panose="020B0609020204030204" pitchFamily="49" charset="0"/>
               </a:rPr>
               <a:t>  </a:t>
             </a:r>
             <a:r>
-              <a:rPr lang="pt-BR" b="1" i="1" dirty="0">
-                <a:solidFill>
-                  <a:schemeClr val="accent6"/>
-                </a:solidFill>
+              <a:rPr lang="pt-BR" b="0" i="0" dirty="0">
+                <a:solidFill>
+                  <a:srgbClr val="888888"/>
+                </a:solidFill>
+                <a:effectLst/>
                 <a:latin typeface="Consolas" panose="020B0609020204030204" pitchFamily="49" charset="0"/>
               </a:rPr>
               <a:t># Calcul des racines</a:t>
             </a:r>
-          </a:p>
-          <a:p>
-            <a:r>
-              <a:rPr lang="pt-BR" b="1" dirty="0">
-                <a:latin typeface="Consolas" panose="020B0609020204030204" pitchFamily="49" charset="0"/>
-              </a:rPr>
-              <a:t>  r1 = (-b-(b**2-4*a*c)**0.5)/(2*a)</a:t>
-            </a:r>
-          </a:p>
-          <a:p>
-            <a:r>
-              <a:rPr lang="pt-BR" b="1" dirty="0">
-                <a:latin typeface="Consolas" panose="020B0609020204030204" pitchFamily="49" charset="0"/>
-              </a:rPr>
-              <a:t>  r2 = (-b+(b**2-4*a*c)**0.5)/(2*a)</a:t>
-            </a:r>
-          </a:p>
-          <a:p>
-            <a:br>
-              <a:rPr lang="pt-BR" sz="100" b="1" dirty="0">
-                <a:latin typeface="Consolas" panose="020B0609020204030204" pitchFamily="49" charset="0"/>
-              </a:rPr>
-            </a:br>
-            <a:endParaRPr lang="pt-BR" sz="100" b="1" dirty="0">
+            <a:endParaRPr lang="pt-BR" b="0" i="0" dirty="0">
+              <a:solidFill>
+                <a:srgbClr val="333333"/>
+              </a:solidFill>
+              <a:effectLst/>
               <a:latin typeface="Consolas" panose="020B0609020204030204" pitchFamily="49" charset="0"/>
             </a:endParaRPr>
           </a:p>
           <a:p>
-            <a:r>
-              <a:rPr lang="pt-BR" b="1" dirty="0">
+            <a:pPr algn="l">
+              <a:buNone/>
+            </a:pPr>
+            <a:r>
+              <a:rPr lang="pt-BR" b="0" i="0" dirty="0">
+                <a:solidFill>
+                  <a:srgbClr val="333333"/>
+                </a:solidFill>
+                <a:effectLst/>
+                <a:latin typeface="Consolas" panose="020B0609020204030204" pitchFamily="49" charset="0"/>
+              </a:rPr>
+              <a:t>  r1 = (-b-(b**</a:t>
+            </a:r>
+            <a:r>
+              <a:rPr lang="pt-BR" b="1" i="0" dirty="0">
+                <a:solidFill>
+                  <a:srgbClr val="0000DD"/>
+                </a:solidFill>
+                <a:effectLst/>
+                <a:latin typeface="Consolas" panose="020B0609020204030204" pitchFamily="49" charset="0"/>
+              </a:rPr>
+              <a:t>2</a:t>
+            </a:r>
+            <a:r>
+              <a:rPr lang="pt-BR" b="0" i="0" dirty="0">
+                <a:solidFill>
+                  <a:srgbClr val="333333"/>
+                </a:solidFill>
+                <a:effectLst/>
+                <a:latin typeface="Consolas" panose="020B0609020204030204" pitchFamily="49" charset="0"/>
+              </a:rPr>
+              <a:t>-</a:t>
+            </a:r>
+            <a:r>
+              <a:rPr lang="pt-BR" b="1" i="0" dirty="0">
+                <a:solidFill>
+                  <a:srgbClr val="0000DD"/>
+                </a:solidFill>
+                <a:effectLst/>
+                <a:latin typeface="Consolas" panose="020B0609020204030204" pitchFamily="49" charset="0"/>
+              </a:rPr>
+              <a:t>4</a:t>
+            </a:r>
+            <a:r>
+              <a:rPr lang="pt-BR" b="0" i="0" dirty="0">
+                <a:solidFill>
+                  <a:srgbClr val="333333"/>
+                </a:solidFill>
+                <a:effectLst/>
+                <a:latin typeface="Consolas" panose="020B0609020204030204" pitchFamily="49" charset="0"/>
+              </a:rPr>
+              <a:t>*a*c)**</a:t>
+            </a:r>
+            <a:r>
+              <a:rPr lang="pt-BR" b="1" i="0" dirty="0">
+                <a:solidFill>
+                  <a:srgbClr val="6600EE"/>
+                </a:solidFill>
+                <a:effectLst/>
+                <a:latin typeface="Consolas" panose="020B0609020204030204" pitchFamily="49" charset="0"/>
+              </a:rPr>
+              <a:t>0.5</a:t>
+            </a:r>
+            <a:r>
+              <a:rPr lang="pt-BR" b="0" i="0" dirty="0">
+                <a:solidFill>
+                  <a:srgbClr val="333333"/>
+                </a:solidFill>
+                <a:effectLst/>
+                <a:latin typeface="Consolas" panose="020B0609020204030204" pitchFamily="49" charset="0"/>
+              </a:rPr>
+              <a:t>)/(</a:t>
+            </a:r>
+            <a:r>
+              <a:rPr lang="pt-BR" b="1" i="0" dirty="0">
+                <a:solidFill>
+                  <a:srgbClr val="0000DD"/>
+                </a:solidFill>
+                <a:effectLst/>
+                <a:latin typeface="Consolas" panose="020B0609020204030204" pitchFamily="49" charset="0"/>
+              </a:rPr>
+              <a:t>2</a:t>
+            </a:r>
+            <a:r>
+              <a:rPr lang="pt-BR" b="0" i="0" dirty="0">
+                <a:solidFill>
+                  <a:srgbClr val="333333"/>
+                </a:solidFill>
+                <a:effectLst/>
+                <a:latin typeface="Consolas" panose="020B0609020204030204" pitchFamily="49" charset="0"/>
+              </a:rPr>
+              <a:t>*a)</a:t>
+            </a:r>
+          </a:p>
+          <a:p>
+            <a:pPr algn="l">
+              <a:buNone/>
+            </a:pPr>
+            <a:r>
+              <a:rPr lang="pt-BR" b="0" i="0" dirty="0">
+                <a:solidFill>
+                  <a:srgbClr val="333333"/>
+                </a:solidFill>
+                <a:effectLst/>
+                <a:latin typeface="Consolas" panose="020B0609020204030204" pitchFamily="49" charset="0"/>
+              </a:rPr>
+              <a:t>  r2 = (-b+(b**</a:t>
+            </a:r>
+            <a:r>
+              <a:rPr lang="pt-BR" b="1" i="0" dirty="0">
+                <a:solidFill>
+                  <a:srgbClr val="0000DD"/>
+                </a:solidFill>
+                <a:effectLst/>
+                <a:latin typeface="Consolas" panose="020B0609020204030204" pitchFamily="49" charset="0"/>
+              </a:rPr>
+              <a:t>2</a:t>
+            </a:r>
+            <a:r>
+              <a:rPr lang="pt-BR" b="0" i="0" dirty="0">
+                <a:solidFill>
+                  <a:srgbClr val="333333"/>
+                </a:solidFill>
+                <a:effectLst/>
+                <a:latin typeface="Consolas" panose="020B0609020204030204" pitchFamily="49" charset="0"/>
+              </a:rPr>
+              <a:t>-</a:t>
+            </a:r>
+            <a:r>
+              <a:rPr lang="pt-BR" b="1" i="0" dirty="0">
+                <a:solidFill>
+                  <a:srgbClr val="0000DD"/>
+                </a:solidFill>
+                <a:effectLst/>
+                <a:latin typeface="Consolas" panose="020B0609020204030204" pitchFamily="49" charset="0"/>
+              </a:rPr>
+              <a:t>4</a:t>
+            </a:r>
+            <a:r>
+              <a:rPr lang="pt-BR" b="0" i="0" dirty="0">
+                <a:solidFill>
+                  <a:srgbClr val="333333"/>
+                </a:solidFill>
+                <a:effectLst/>
+                <a:latin typeface="Consolas" panose="020B0609020204030204" pitchFamily="49" charset="0"/>
+              </a:rPr>
+              <a:t>*a*c)**</a:t>
+            </a:r>
+            <a:r>
+              <a:rPr lang="pt-BR" b="1" i="0" dirty="0">
+                <a:solidFill>
+                  <a:srgbClr val="6600EE"/>
+                </a:solidFill>
+                <a:effectLst/>
+                <a:latin typeface="Consolas" panose="020B0609020204030204" pitchFamily="49" charset="0"/>
+              </a:rPr>
+              <a:t>0.5</a:t>
+            </a:r>
+            <a:r>
+              <a:rPr lang="pt-BR" b="0" i="0" dirty="0">
+                <a:solidFill>
+                  <a:srgbClr val="333333"/>
+                </a:solidFill>
+                <a:effectLst/>
+                <a:latin typeface="Consolas" panose="020B0609020204030204" pitchFamily="49" charset="0"/>
+              </a:rPr>
+              <a:t>)/(</a:t>
+            </a:r>
+            <a:r>
+              <a:rPr lang="pt-BR" b="1" i="0" dirty="0">
+                <a:solidFill>
+                  <a:srgbClr val="0000DD"/>
+                </a:solidFill>
+                <a:effectLst/>
+                <a:latin typeface="Consolas" panose="020B0609020204030204" pitchFamily="49" charset="0"/>
+              </a:rPr>
+              <a:t>2</a:t>
+            </a:r>
+            <a:r>
+              <a:rPr lang="pt-BR" b="0" i="0" dirty="0">
+                <a:solidFill>
+                  <a:srgbClr val="333333"/>
+                </a:solidFill>
+                <a:effectLst/>
+                <a:latin typeface="Consolas" panose="020B0609020204030204" pitchFamily="49" charset="0"/>
+              </a:rPr>
+              <a:t>*a)</a:t>
+            </a:r>
+          </a:p>
+          <a:p>
+            <a:pPr algn="l">
+              <a:buNone/>
+            </a:pPr>
+            <a:endParaRPr lang="pt-BR" b="0" i="0" dirty="0">
+              <a:solidFill>
+                <a:srgbClr val="333333"/>
+              </a:solidFill>
+              <a:effectLst/>
+              <a:latin typeface="Consolas" panose="020B0609020204030204" pitchFamily="49" charset="0"/>
+            </a:endParaRPr>
+          </a:p>
+          <a:p>
+            <a:pPr algn="l">
+              <a:buNone/>
+            </a:pPr>
+            <a:r>
+              <a:rPr lang="pt-BR" b="0" i="0" dirty="0">
+                <a:solidFill>
+                  <a:srgbClr val="333333"/>
+                </a:solidFill>
+                <a:effectLst/>
                 <a:latin typeface="Consolas" panose="020B0609020204030204" pitchFamily="49" charset="0"/>
               </a:rPr>
               <a:t>  </a:t>
             </a:r>
             <a:r>
-              <a:rPr lang="pt-BR" b="1" i="1" dirty="0">
-                <a:solidFill>
-                  <a:schemeClr val="accent6"/>
-                </a:solidFill>
+              <a:rPr lang="pt-BR" b="0" i="0" dirty="0">
+                <a:solidFill>
+                  <a:srgbClr val="888888"/>
+                </a:solidFill>
+                <a:effectLst/>
                 <a:latin typeface="Consolas" panose="020B0609020204030204" pitchFamily="49" charset="0"/>
               </a:rPr>
               <a:t># Affichage</a:t>
             </a:r>
-          </a:p>
-          <a:p>
-            <a:r>
-              <a:rPr lang="pt-BR" b="1" dirty="0">
-                <a:latin typeface="Consolas" panose="020B0609020204030204" pitchFamily="49" charset="0"/>
-              </a:rPr>
-              <a:t>  print('r1 = ', r1, 'r2 = ', r2)</a:t>
-            </a:r>
-            <a:br>
-              <a:rPr lang="pt-BR" b="1" dirty="0">
-                <a:latin typeface="Consolas" panose="020B0609020204030204" pitchFamily="49" charset="0"/>
-              </a:rPr>
-            </a:br>
-            <a:endParaRPr lang="fr-CA" sz="500" dirty="0"/>
+            <a:endParaRPr lang="pt-BR" b="0" i="0" dirty="0">
+              <a:solidFill>
+                <a:srgbClr val="333333"/>
+              </a:solidFill>
+              <a:effectLst/>
+              <a:latin typeface="Consolas" panose="020B0609020204030204" pitchFamily="49" charset="0"/>
+            </a:endParaRPr>
+          </a:p>
+          <a:p>
+            <a:pPr algn="l">
+              <a:buNone/>
+            </a:pPr>
+            <a:r>
+              <a:rPr lang="pt-BR" b="0" i="0" dirty="0">
+                <a:solidFill>
+                  <a:srgbClr val="333333"/>
+                </a:solidFill>
+                <a:effectLst/>
+                <a:latin typeface="Consolas" panose="020B0609020204030204" pitchFamily="49" charset="0"/>
+              </a:rPr>
+              <a:t>  </a:t>
+            </a:r>
+            <a:r>
+              <a:rPr lang="pt-BR" b="0" i="0" dirty="0">
+                <a:solidFill>
+                  <a:srgbClr val="007020"/>
+                </a:solidFill>
+                <a:effectLst/>
+                <a:latin typeface="Consolas" panose="020B0609020204030204" pitchFamily="49" charset="0"/>
+              </a:rPr>
+              <a:t>print</a:t>
+            </a:r>
+            <a:r>
+              <a:rPr lang="pt-BR" b="0" i="0" dirty="0">
+                <a:solidFill>
+                  <a:srgbClr val="333333"/>
+                </a:solidFill>
+                <a:effectLst/>
+                <a:latin typeface="Consolas" panose="020B0609020204030204" pitchFamily="49" charset="0"/>
+              </a:rPr>
+              <a:t>('r1 = ', r1, 'r2 = ', r2)</a:t>
+            </a:r>
           </a:p>
         </p:txBody>
       </p:sp>
@@ -29959,10 +31624,10 @@
         </p:nvGrpSpPr>
         <p:grpSpPr>
           <a:xfrm>
-            <a:off x="7723773" y="3205424"/>
-            <a:ext cx="1771280" cy="369332"/>
+            <a:off x="7723773" y="3114634"/>
+            <a:ext cx="1895416" cy="369332"/>
             <a:chOff x="6485106" y="3914378"/>
-            <a:chExt cx="1771280" cy="369332"/>
+            <a:chExt cx="1895416" cy="369332"/>
           </a:xfrm>
         </p:grpSpPr>
         <p:sp>
@@ -29980,7 +31645,7 @@
           <p:spPr>
             <a:xfrm>
               <a:off x="7309395" y="3914378"/>
-              <a:ext cx="946991" cy="369332"/>
+              <a:ext cx="1071127" cy="369332"/>
             </a:xfrm>
             <a:prstGeom prst="rect">
               <a:avLst/>
@@ -29994,10 +31659,14 @@
             <a:lstStyle/>
             <a:p>
               <a:r>
-                <a:rPr lang="en-US" b="1" dirty="0"/>
+                <a:rPr lang="en-US" b="1" dirty="0">
+                  <a:latin typeface="Consolas" panose="020B0609020204030204" pitchFamily="49" charset="0"/>
+                </a:rPr>
                 <a:t>En-tête</a:t>
               </a:r>
-              <a:endParaRPr lang="fr-CA" b="1" dirty="0"/>
+              <a:endParaRPr lang="fr-CA" b="1" dirty="0">
+                <a:latin typeface="Consolas" panose="020B0609020204030204" pitchFamily="49" charset="0"/>
+              </a:endParaRPr>
             </a:p>
           </p:txBody>
         </p:sp>
@@ -30057,10 +31726,10 @@
         </p:nvGrpSpPr>
         <p:grpSpPr>
           <a:xfrm>
-            <a:off x="7723773" y="4165699"/>
-            <a:ext cx="3498291" cy="369332"/>
+            <a:off x="7723773" y="4087879"/>
+            <a:ext cx="3921612" cy="369332"/>
             <a:chOff x="6485106" y="4913563"/>
-            <a:chExt cx="3498291" cy="369332"/>
+            <a:chExt cx="3921612" cy="369332"/>
           </a:xfrm>
         </p:grpSpPr>
         <p:sp>
@@ -30078,7 +31747,7 @@
           <p:spPr>
             <a:xfrm>
               <a:off x="7309395" y="4913563"/>
-              <a:ext cx="2674002" cy="369332"/>
+              <a:ext cx="3097323" cy="369332"/>
             </a:xfrm>
             <a:prstGeom prst="rect">
               <a:avLst/>
@@ -30092,10 +31761,14 @@
             <a:lstStyle/>
             <a:p>
               <a:r>
-                <a:rPr lang="en-US" b="1" dirty="0"/>
+                <a:rPr lang="en-US" b="1" dirty="0">
+                  <a:latin typeface="Consolas" panose="020B0609020204030204" pitchFamily="49" charset="0"/>
+                </a:rPr>
                 <a:t>Corps avec instructions</a:t>
               </a:r>
-              <a:endParaRPr lang="fr-CA" b="1" dirty="0"/>
+              <a:endParaRPr lang="fr-CA" b="1" dirty="0">
+                <a:latin typeface="Consolas" panose="020B0609020204030204" pitchFamily="49" charset="0"/>
+              </a:endParaRPr>
             </a:p>
           </p:txBody>
         </p:sp>
@@ -30134,6 +31807,157 @@
             </a:fillRef>
             <a:effectRef idx="1">
               <a:schemeClr val="dk1"/>
+            </a:effectRef>
+            <a:fontRef idx="minor">
+              <a:schemeClr val="tx1"/>
+            </a:fontRef>
+          </p:style>
+        </p:cxnSp>
+      </p:grpSp>
+      <p:grpSp>
+        <p:nvGrpSpPr>
+          <p:cNvPr id="21" name="Group 20">
+            <a:extLst>
+              <a:ext uri="{FF2B5EF4-FFF2-40B4-BE49-F238E27FC236}">
+                <a16:creationId xmlns:a16="http://schemas.microsoft.com/office/drawing/2014/main" id="{CB07367E-C4A4-7038-3BBE-A8469ACC2D65}"/>
+              </a:ext>
+            </a:extLst>
+          </p:cNvPr>
+          <p:cNvGrpSpPr/>
+          <p:nvPr/>
+        </p:nvGrpSpPr>
+        <p:grpSpPr>
+          <a:xfrm>
+            <a:off x="2983888" y="3426619"/>
+            <a:ext cx="184762" cy="1892300"/>
+            <a:chOff x="2983888" y="3426619"/>
+            <a:chExt cx="184762" cy="1892300"/>
+          </a:xfrm>
+        </p:grpSpPr>
+        <p:cxnSp>
+          <p:nvCxnSpPr>
+            <p:cNvPr id="13" name="Straight Connector 12">
+              <a:extLst>
+                <a:ext uri="{FF2B5EF4-FFF2-40B4-BE49-F238E27FC236}">
+                  <a16:creationId xmlns:a16="http://schemas.microsoft.com/office/drawing/2014/main" id="{94B48597-301C-8225-CAA0-8B8799450E13}"/>
+                </a:ext>
+              </a:extLst>
+            </p:cNvPr>
+            <p:cNvCxnSpPr>
+              <a:cxnSpLocks/>
+            </p:cNvCxnSpPr>
+            <p:nvPr/>
+          </p:nvCxnSpPr>
+          <p:spPr>
+            <a:xfrm flipV="1">
+              <a:off x="3168650" y="3431381"/>
+              <a:ext cx="0" cy="1886400"/>
+            </a:xfrm>
+            <a:prstGeom prst="line">
+              <a:avLst/>
+            </a:prstGeom>
+            <a:ln>
+              <a:solidFill>
+                <a:srgbClr val="FF00FF"/>
+              </a:solidFill>
+              <a:prstDash val="dash"/>
+            </a:ln>
+          </p:spPr>
+          <p:style>
+            <a:lnRef idx="2">
+              <a:schemeClr val="accent5"/>
+            </a:lnRef>
+            <a:fillRef idx="0">
+              <a:schemeClr val="accent5"/>
+            </a:fillRef>
+            <a:effectRef idx="1">
+              <a:schemeClr val="accent5"/>
+            </a:effectRef>
+            <a:fontRef idx="minor">
+              <a:schemeClr val="tx1"/>
+            </a:fontRef>
+          </p:style>
+        </p:cxnSp>
+        <p:cxnSp>
+          <p:nvCxnSpPr>
+            <p:cNvPr id="16" name="Straight Connector 15">
+              <a:extLst>
+                <a:ext uri="{FF2B5EF4-FFF2-40B4-BE49-F238E27FC236}">
+                  <a16:creationId xmlns:a16="http://schemas.microsoft.com/office/drawing/2014/main" id="{A9A81C80-1C4F-C526-7F2F-515F654717D0}"/>
+                </a:ext>
+              </a:extLst>
+            </p:cNvPr>
+            <p:cNvCxnSpPr>
+              <a:cxnSpLocks/>
+            </p:cNvCxnSpPr>
+            <p:nvPr/>
+          </p:nvCxnSpPr>
+          <p:spPr>
+            <a:xfrm flipV="1">
+              <a:off x="2990850" y="3426619"/>
+              <a:ext cx="0" cy="1892300"/>
+            </a:xfrm>
+            <a:prstGeom prst="line">
+              <a:avLst/>
+            </a:prstGeom>
+            <a:ln>
+              <a:solidFill>
+                <a:srgbClr val="FF00FF"/>
+              </a:solidFill>
+              <a:prstDash val="dash"/>
+            </a:ln>
+          </p:spPr>
+          <p:style>
+            <a:lnRef idx="2">
+              <a:schemeClr val="accent5"/>
+            </a:lnRef>
+            <a:fillRef idx="0">
+              <a:schemeClr val="accent5"/>
+            </a:fillRef>
+            <a:effectRef idx="1">
+              <a:schemeClr val="accent5"/>
+            </a:effectRef>
+            <a:fontRef idx="minor">
+              <a:schemeClr val="tx1"/>
+            </a:fontRef>
+          </p:style>
+        </p:cxnSp>
+        <p:cxnSp>
+          <p:nvCxnSpPr>
+            <p:cNvPr id="18" name="Straight Arrow Connector 17">
+              <a:extLst>
+                <a:ext uri="{FF2B5EF4-FFF2-40B4-BE49-F238E27FC236}">
+                  <a16:creationId xmlns:a16="http://schemas.microsoft.com/office/drawing/2014/main" id="{041A6C80-F44A-FA63-417F-FC4D68FD43F0}"/>
+                </a:ext>
+              </a:extLst>
+            </p:cNvPr>
+            <p:cNvCxnSpPr/>
+            <p:nvPr/>
+          </p:nvCxnSpPr>
+          <p:spPr>
+            <a:xfrm>
+              <a:off x="2983888" y="4318067"/>
+              <a:ext cx="180000" cy="0"/>
+            </a:xfrm>
+            <a:prstGeom prst="straightConnector1">
+              <a:avLst/>
+            </a:prstGeom>
+            <a:ln>
+              <a:solidFill>
+                <a:srgbClr val="FF00FF"/>
+              </a:solidFill>
+              <a:tailEnd type="triangle"/>
+            </a:ln>
+          </p:spPr>
+          <p:style>
+            <a:lnRef idx="2">
+              <a:schemeClr val="accent5"/>
+            </a:lnRef>
+            <a:fillRef idx="0">
+              <a:schemeClr val="accent5"/>
+            </a:fillRef>
+            <a:effectRef idx="1">
+              <a:schemeClr val="accent5"/>
             </a:effectRef>
             <a:fontRef idx="minor">
               <a:schemeClr val="tx1"/>
@@ -30185,6 +32009,49 @@
                                           </p:stCondLst>
                                         </p:cTn>
                                         <p:tgtEl>
+                                          <p:spTgt spid="3">
+                                            <p:txEl>
+                                              <p:pRg st="0" end="0"/>
+                                            </p:txEl>
+                                          </p:spTgt>
+                                        </p:tgtEl>
+                                        <p:attrNameLst>
+                                          <p:attrName>style.visibility</p:attrName>
+                                        </p:attrNameLst>
+                                      </p:cBhvr>
+                                      <p:to>
+                                        <p:strVal val="visible"/>
+                                      </p:to>
+                                    </p:set>
+                                    <p:animEffect transition="in" filter="fade">
+                                      <p:cBhvr>
+                                        <p:cTn id="7" dur="500"/>
+                                        <p:tgtEl>
+                                          <p:spTgt spid="3">
+                                            <p:txEl>
+                                              <p:pRg st="0" end="0"/>
+                                            </p:txEl>
+                                          </p:spTgt>
+                                        </p:tgtEl>
+                                      </p:cBhvr>
+                                    </p:animEffect>
+                                  </p:childTnLst>
+                                </p:cTn>
+                              </p:par>
+                              <p:par>
+                                <p:cTn id="8" presetID="10" presetClass="entr" presetSubtype="0" fill="hold" nodeType="withEffect">
+                                  <p:stCondLst>
+                                    <p:cond delay="0"/>
+                                  </p:stCondLst>
+                                  <p:childTnLst>
+                                    <p:set>
+                                      <p:cBhvr>
+                                        <p:cTn id="9" dur="1" fill="hold">
+                                          <p:stCondLst>
+                                            <p:cond delay="0"/>
+                                          </p:stCondLst>
+                                        </p:cTn>
+                                        <p:tgtEl>
                                           <p:spTgt spid="4"/>
                                         </p:tgtEl>
                                         <p:attrNameLst>
@@ -30197,7 +32064,7 @@
                                     </p:set>
                                     <p:animEffect transition="in" filter="fade">
                                       <p:cBhvr>
-                                        <p:cTn id="7" dur="500"/>
+                                        <p:cTn id="10" dur="500"/>
                                         <p:tgtEl>
                                           <p:spTgt spid="4"/>
                                         </p:tgtEl>
@@ -30213,26 +32080,69 @@
                     </p:cTn>
                   </p:par>
                   <p:par>
-                    <p:cTn id="8" fill="hold">
+                    <p:cTn id="11" fill="hold">
                       <p:stCondLst>
                         <p:cond delay="indefinite"/>
                       </p:stCondLst>
                       <p:childTnLst>
                         <p:par>
-                          <p:cTn id="9" fill="hold">
+                          <p:cTn id="12" fill="hold">
                             <p:stCondLst>
                               <p:cond delay="0"/>
                             </p:stCondLst>
                             <p:childTnLst>
                               <p:par>
-                                <p:cTn id="10" presetID="10" presetClass="entr" presetSubtype="0" fill="hold" nodeType="clickEffect">
+                                <p:cTn id="13" presetID="10" presetClass="entr" presetSubtype="0" fill="hold" nodeType="clickEffect">
                                   <p:stCondLst>
                                     <p:cond delay="0"/>
                                   </p:stCondLst>
                                   <p:childTnLst>
                                     <p:set>
                                       <p:cBhvr>
-                                        <p:cTn id="11" dur="1" fill="hold">
+                                        <p:cTn id="14" dur="1" fill="hold">
+                                          <p:stCondLst>
+                                            <p:cond delay="0"/>
+                                          </p:stCondLst>
+                                        </p:cTn>
+                                        <p:tgtEl>
+                                          <p:spTgt spid="3">
+                                            <p:txEl>
+                                              <p:pRg st="1" end="1"/>
+                                            </p:txEl>
+                                          </p:spTgt>
+                                        </p:tgtEl>
+                                        <p:attrNameLst>
+                                          <p:attrName>style.visibility</p:attrName>
+                                        </p:attrNameLst>
+                                      </p:cBhvr>
+                                      <p:to>
+                                        <p:strVal val="visible"/>
+                                      </p:to>
+                                    </p:set>
+                                    <p:animEffect transition="in" filter="fade">
+                                      <p:cBhvr>
+                                        <p:cTn id="15" dur="500"/>
+                                        <p:tgtEl>
+                                          <p:spTgt spid="3">
+                                            <p:txEl>
+                                              <p:pRg st="1" end="1"/>
+                                            </p:txEl>
+                                          </p:spTgt>
+                                        </p:tgtEl>
+                                      </p:cBhvr>
+                                    </p:animEffect>
+                                  </p:childTnLst>
+                                </p:cTn>
+                              </p:par>
+                              <p:par>
+                                <p:cTn id="16" presetID="10" presetClass="entr" presetSubtype="0" fill="hold" nodeType="withEffect">
+                                  <p:stCondLst>
+                                    <p:cond delay="0"/>
+                                  </p:stCondLst>
+                                  <p:childTnLst>
+                                    <p:set>
+                                      <p:cBhvr>
+                                        <p:cTn id="17" dur="1" fill="hold">
                                           <p:stCondLst>
                                             <p:cond delay="0"/>
                                           </p:stCondLst>
@@ -30250,9 +32160,44 @@
                                     </p:set>
                                     <p:animEffect transition="in" filter="fade">
                                       <p:cBhvr>
-                                        <p:cTn id="12" dur="500"/>
+                                        <p:cTn id="18" dur="500"/>
                                         <p:tgtEl>
                                           <p:spTgt spid="8"/>
+                                        </p:tgtEl>
+                                      </p:cBhvr>
+                                    </p:animEffect>
+                                  </p:childTnLst>
+                                </p:cTn>
+                              </p:par>
+                              <p:par>
+                                <p:cTn id="19" presetID="10" presetClass="entr" presetSubtype="0" fill="hold" nodeType="withEffect">
+                                  <p:stCondLst>
+                                    <p:cond delay="0"/>
+                                  </p:stCondLst>
+                                  <p:childTnLst>
+                                    <p:set>
+                                      <p:cBhvr>
+                                        <p:cTn id="20" dur="1" fill="hold">
+                                          <p:stCondLst>
+                                            <p:cond delay="0"/>
+                                          </p:stCondLst>
+                                        </p:cTn>
+                                        <p:tgtEl>
+                                          <p:spTgt spid="21"/>
+                                        </p:tgtEl>
+                                        <p:attrNameLst>
+                                          <p:attrName>style.visibility</p:attrName>
+                                        </p:attrNameLst>
+                                      </p:cBhvr>
+                                      <p:to>
+                                        <p:strVal val="visible"/>
+                                      </p:to>
+                                    </p:set>
+                                    <p:animEffect transition="in" filter="fade">
+                                      <p:cBhvr>
+                                        <p:cTn id="21" dur="500"/>
+                                        <p:tgtEl>
+                                          <p:spTgt spid="21"/>
                                         </p:tgtEl>
                                       </p:cBhvr>
                                     </p:animEffect>
@@ -30563,6 +32508,54 @@
           </a:p>
         </p:txBody>
       </p:sp>
+      <p:sp>
+        <p:nvSpPr>
+          <p:cNvPr id="4" name="TextBox 3">
+            <a:extLst>
+              <a:ext uri="{FF2B5EF4-FFF2-40B4-BE49-F238E27FC236}">
+                <a16:creationId xmlns:a16="http://schemas.microsoft.com/office/drawing/2014/main" id="{E23CE088-1A87-BB0D-C807-5BD0083F9895}"/>
+              </a:ext>
+            </a:extLst>
+          </p:cNvPr>
+          <p:cNvSpPr txBox="1"/>
+          <p:nvPr/>
+        </p:nvSpPr>
+        <p:spPr>
+          <a:xfrm>
+            <a:off x="838199" y="6176963"/>
+            <a:ext cx="10515599" cy="369332"/>
+          </a:xfrm>
+          <a:prstGeom prst="rect">
+            <a:avLst/>
+          </a:prstGeom>
+          <a:noFill/>
+        </p:spPr>
+        <p:txBody>
+          <a:bodyPr wrap="square">
+            <a:spAutoFit/>
+          </a:bodyPr>
+          <a:lstStyle/>
+          <a:p>
+            <a:pPr algn="ctr"/>
+            <a:r>
+              <a:rPr lang="fr-CA" sz="1800" b="1" dirty="0">
+                <a:latin typeface="Consolas" panose="020B0609020204030204" pitchFamily="49" charset="0"/>
+              </a:rPr>
+              <a:t>SOURCE: </a:t>
+            </a:r>
+            <a:r>
+              <a:rPr lang="fr-CA" b="1" dirty="0">
+                <a:latin typeface="Consolas" panose="020B0609020204030204" pitchFamily="49" charset="0"/>
+                <a:hlinkClick r:id="rId2"/>
+              </a:rPr>
+              <a:t>https://docs.python.org/3/reference/lexical_analysis.html#soft-keywords</a:t>
+            </a:r>
+            <a:endParaRPr lang="fr-CA" sz="1800" b="1" dirty="0">
+              <a:latin typeface="Consolas" panose="020B0609020204030204" pitchFamily="49" charset="0"/>
+            </a:endParaRPr>
+          </a:p>
+        </p:txBody>
+      </p:sp>
     </p:spTree>
     <p:extLst>
       <p:ext uri="{BB962C8B-B14F-4D97-AF65-F5344CB8AC3E}">
@@ -30573,6 +32566,463 @@
   <p:clrMapOvr>
     <a:masterClrMapping/>
   </p:clrMapOvr>
+  <p:timing>
+    <p:tnLst>
+      <p:par>
+        <p:cTn id="1" dur="indefinite" restart="never" nodeType="tmRoot">
+          <p:childTnLst>
+            <p:seq concurrent="1" nextAc="seek">
+              <p:cTn id="2" dur="indefinite" nodeType="mainSeq">
+                <p:childTnLst>
+                  <p:par>
+                    <p:cTn id="3" fill="hold">
+                      <p:stCondLst>
+                        <p:cond delay="indefinite"/>
+                      </p:stCondLst>
+                      <p:childTnLst>
+                        <p:par>
+                          <p:cTn id="4" fill="hold">
+                            <p:stCondLst>
+                              <p:cond delay="0"/>
+                            </p:stCondLst>
+                            <p:childTnLst>
+                              <p:par>
+                                <p:cTn id="5" presetID="10" presetClass="entr" presetSubtype="0" fill="hold" nodeType="clickEffect">
+                                  <p:stCondLst>
+                                    <p:cond delay="0"/>
+                                  </p:stCondLst>
+                                  <p:childTnLst>
+                                    <p:set>
+                                      <p:cBhvr>
+                                        <p:cTn id="6" dur="1" fill="hold">
+                                          <p:stCondLst>
+                                            <p:cond delay="0"/>
+                                          </p:stCondLst>
+                                        </p:cTn>
+                                        <p:tgtEl>
+                                          <p:spTgt spid="3">
+                                            <p:txEl>
+                                              <p:pRg st="0" end="0"/>
+                                            </p:txEl>
+                                          </p:spTgt>
+                                        </p:tgtEl>
+                                        <p:attrNameLst>
+                                          <p:attrName>style.visibility</p:attrName>
+                                        </p:attrNameLst>
+                                      </p:cBhvr>
+                                      <p:to>
+                                        <p:strVal val="visible"/>
+                                      </p:to>
+                                    </p:set>
+                                    <p:animEffect transition="in" filter="fade">
+                                      <p:cBhvr>
+                                        <p:cTn id="7" dur="500"/>
+                                        <p:tgtEl>
+                                          <p:spTgt spid="3">
+                                            <p:txEl>
+                                              <p:pRg st="0" end="0"/>
+                                            </p:txEl>
+                                          </p:spTgt>
+                                        </p:tgtEl>
+                                      </p:cBhvr>
+                                    </p:animEffect>
+                                  </p:childTnLst>
+                                </p:cTn>
+                              </p:par>
+                            </p:childTnLst>
+                          </p:cTn>
+                        </p:par>
+                      </p:childTnLst>
+                    </p:cTn>
+                  </p:par>
+                  <p:par>
+                    <p:cTn id="8" fill="hold">
+                      <p:stCondLst>
+                        <p:cond delay="indefinite"/>
+                      </p:stCondLst>
+                      <p:childTnLst>
+                        <p:par>
+                          <p:cTn id="9" fill="hold">
+                            <p:stCondLst>
+                              <p:cond delay="0"/>
+                            </p:stCondLst>
+                            <p:childTnLst>
+                              <p:par>
+                                <p:cTn id="10" presetID="10" presetClass="entr" presetSubtype="0" fill="hold" nodeType="clickEffect">
+                                  <p:stCondLst>
+                                    <p:cond delay="0"/>
+                                  </p:stCondLst>
+                                  <p:childTnLst>
+                                    <p:set>
+                                      <p:cBhvr>
+                                        <p:cTn id="11" dur="1" fill="hold">
+                                          <p:stCondLst>
+                                            <p:cond delay="0"/>
+                                          </p:stCondLst>
+                                        </p:cTn>
+                                        <p:tgtEl>
+                                          <p:spTgt spid="3">
+                                            <p:txEl>
+                                              <p:pRg st="1" end="1"/>
+                                            </p:txEl>
+                                          </p:spTgt>
+                                        </p:tgtEl>
+                                        <p:attrNameLst>
+                                          <p:attrName>style.visibility</p:attrName>
+                                        </p:attrNameLst>
+                                      </p:cBhvr>
+                                      <p:to>
+                                        <p:strVal val="visible"/>
+                                      </p:to>
+                                    </p:set>
+                                    <p:animEffect transition="in" filter="fade">
+                                      <p:cBhvr>
+                                        <p:cTn id="12" dur="500"/>
+                                        <p:tgtEl>
+                                          <p:spTgt spid="3">
+                                            <p:txEl>
+                                              <p:pRg st="1" end="1"/>
+                                            </p:txEl>
+                                          </p:spTgt>
+                                        </p:tgtEl>
+                                      </p:cBhvr>
+                                    </p:animEffect>
+                                  </p:childTnLst>
+                                </p:cTn>
+                              </p:par>
+                            </p:childTnLst>
+                          </p:cTn>
+                        </p:par>
+                      </p:childTnLst>
+                    </p:cTn>
+                  </p:par>
+                  <p:par>
+                    <p:cTn id="13" fill="hold">
+                      <p:stCondLst>
+                        <p:cond delay="indefinite"/>
+                      </p:stCondLst>
+                      <p:childTnLst>
+                        <p:par>
+                          <p:cTn id="14" fill="hold">
+                            <p:stCondLst>
+                              <p:cond delay="0"/>
+                            </p:stCondLst>
+                            <p:childTnLst>
+                              <p:par>
+                                <p:cTn id="15" presetID="10" presetClass="entr" presetSubtype="0" fill="hold" nodeType="clickEffect">
+                                  <p:stCondLst>
+                                    <p:cond delay="0"/>
+                                  </p:stCondLst>
+                                  <p:childTnLst>
+                                    <p:set>
+                                      <p:cBhvr>
+                                        <p:cTn id="16" dur="1" fill="hold">
+                                          <p:stCondLst>
+                                            <p:cond delay="0"/>
+                                          </p:stCondLst>
+                                        </p:cTn>
+                                        <p:tgtEl>
+                                          <p:spTgt spid="3">
+                                            <p:txEl>
+                                              <p:pRg st="2" end="2"/>
+                                            </p:txEl>
+                                          </p:spTgt>
+                                        </p:tgtEl>
+                                        <p:attrNameLst>
+                                          <p:attrName>style.visibility</p:attrName>
+                                        </p:attrNameLst>
+                                      </p:cBhvr>
+                                      <p:to>
+                                        <p:strVal val="visible"/>
+                                      </p:to>
+                                    </p:set>
+                                    <p:animEffect transition="in" filter="fade">
+                                      <p:cBhvr>
+                                        <p:cTn id="17" dur="500"/>
+                                        <p:tgtEl>
+                                          <p:spTgt spid="3">
+                                            <p:txEl>
+                                              <p:pRg st="2" end="2"/>
+                                            </p:txEl>
+                                          </p:spTgt>
+                                        </p:tgtEl>
+                                      </p:cBhvr>
+                                    </p:animEffect>
+                                  </p:childTnLst>
+                                </p:cTn>
+                              </p:par>
+                            </p:childTnLst>
+                          </p:cTn>
+                        </p:par>
+                      </p:childTnLst>
+                    </p:cTn>
+                  </p:par>
+                  <p:par>
+                    <p:cTn id="18" fill="hold">
+                      <p:stCondLst>
+                        <p:cond delay="indefinite"/>
+                      </p:stCondLst>
+                      <p:childTnLst>
+                        <p:par>
+                          <p:cTn id="19" fill="hold">
+                            <p:stCondLst>
+                              <p:cond delay="0"/>
+                            </p:stCondLst>
+                            <p:childTnLst>
+                              <p:par>
+                                <p:cTn id="20" presetID="10" presetClass="entr" presetSubtype="0" fill="hold" nodeType="clickEffect">
+                                  <p:stCondLst>
+                                    <p:cond delay="0"/>
+                                  </p:stCondLst>
+                                  <p:childTnLst>
+                                    <p:set>
+                                      <p:cBhvr>
+                                        <p:cTn id="21" dur="1" fill="hold">
+                                          <p:stCondLst>
+                                            <p:cond delay="0"/>
+                                          </p:stCondLst>
+                                        </p:cTn>
+                                        <p:tgtEl>
+                                          <p:spTgt spid="3">
+                                            <p:txEl>
+                                              <p:pRg st="3" end="3"/>
+                                            </p:txEl>
+                                          </p:spTgt>
+                                        </p:tgtEl>
+                                        <p:attrNameLst>
+                                          <p:attrName>style.visibility</p:attrName>
+                                        </p:attrNameLst>
+                                      </p:cBhvr>
+                                      <p:to>
+                                        <p:strVal val="visible"/>
+                                      </p:to>
+                                    </p:set>
+                                    <p:animEffect transition="in" filter="fade">
+                                      <p:cBhvr>
+                                        <p:cTn id="22" dur="500"/>
+                                        <p:tgtEl>
+                                          <p:spTgt spid="3">
+                                            <p:txEl>
+                                              <p:pRg st="3" end="3"/>
+                                            </p:txEl>
+                                          </p:spTgt>
+                                        </p:tgtEl>
+                                      </p:cBhvr>
+                                    </p:animEffect>
+                                  </p:childTnLst>
+                                </p:cTn>
+                              </p:par>
+                            </p:childTnLst>
+                          </p:cTn>
+                        </p:par>
+                      </p:childTnLst>
+                    </p:cTn>
+                  </p:par>
+                  <p:par>
+                    <p:cTn id="23" fill="hold">
+                      <p:stCondLst>
+                        <p:cond delay="indefinite"/>
+                      </p:stCondLst>
+                      <p:childTnLst>
+                        <p:par>
+                          <p:cTn id="24" fill="hold">
+                            <p:stCondLst>
+                              <p:cond delay="0"/>
+                            </p:stCondLst>
+                            <p:childTnLst>
+                              <p:par>
+                                <p:cTn id="25" presetID="10" presetClass="entr" presetSubtype="0" fill="hold" nodeType="clickEffect">
+                                  <p:stCondLst>
+                                    <p:cond delay="0"/>
+                                  </p:stCondLst>
+                                  <p:childTnLst>
+                                    <p:set>
+                                      <p:cBhvr>
+                                        <p:cTn id="26" dur="1" fill="hold">
+                                          <p:stCondLst>
+                                            <p:cond delay="0"/>
+                                          </p:stCondLst>
+                                        </p:cTn>
+                                        <p:tgtEl>
+                                          <p:spTgt spid="3">
+                                            <p:txEl>
+                                              <p:pRg st="4" end="4"/>
+                                            </p:txEl>
+                                          </p:spTgt>
+                                        </p:tgtEl>
+                                        <p:attrNameLst>
+                                          <p:attrName>style.visibility</p:attrName>
+                                        </p:attrNameLst>
+                                      </p:cBhvr>
+                                      <p:to>
+                                        <p:strVal val="visible"/>
+                                      </p:to>
+                                    </p:set>
+                                    <p:animEffect transition="in" filter="fade">
+                                      <p:cBhvr>
+                                        <p:cTn id="27" dur="500"/>
+                                        <p:tgtEl>
+                                          <p:spTgt spid="3">
+                                            <p:txEl>
+                                              <p:pRg st="4" end="4"/>
+                                            </p:txEl>
+                                          </p:spTgt>
+                                        </p:tgtEl>
+                                      </p:cBhvr>
+                                    </p:animEffect>
+                                  </p:childTnLst>
+                                </p:cTn>
+                              </p:par>
+                            </p:childTnLst>
+                          </p:cTn>
+                        </p:par>
+                      </p:childTnLst>
+                    </p:cTn>
+                  </p:par>
+                  <p:par>
+                    <p:cTn id="28" fill="hold">
+                      <p:stCondLst>
+                        <p:cond delay="indefinite"/>
+                      </p:stCondLst>
+                      <p:childTnLst>
+                        <p:par>
+                          <p:cTn id="29" fill="hold">
+                            <p:stCondLst>
+                              <p:cond delay="0"/>
+                            </p:stCondLst>
+                            <p:childTnLst>
+                              <p:par>
+                                <p:cTn id="30" presetID="10" presetClass="entr" presetSubtype="0" fill="hold" nodeType="clickEffect">
+                                  <p:stCondLst>
+                                    <p:cond delay="0"/>
+                                  </p:stCondLst>
+                                  <p:childTnLst>
+                                    <p:set>
+                                      <p:cBhvr>
+                                        <p:cTn id="31" dur="1" fill="hold">
+                                          <p:stCondLst>
+                                            <p:cond delay="0"/>
+                                          </p:stCondLst>
+                                        </p:cTn>
+                                        <p:tgtEl>
+                                          <p:spTgt spid="3">
+                                            <p:txEl>
+                                              <p:pRg st="5" end="5"/>
+                                            </p:txEl>
+                                          </p:spTgt>
+                                        </p:tgtEl>
+                                        <p:attrNameLst>
+                                          <p:attrName>style.visibility</p:attrName>
+                                        </p:attrNameLst>
+                                      </p:cBhvr>
+                                      <p:to>
+                                        <p:strVal val="visible"/>
+                                      </p:to>
+                                    </p:set>
+                                    <p:animEffect transition="in" filter="fade">
+                                      <p:cBhvr>
+                                        <p:cTn id="32" dur="500"/>
+                                        <p:tgtEl>
+                                          <p:spTgt spid="3">
+                                            <p:txEl>
+                                              <p:pRg st="5" end="5"/>
+                                            </p:txEl>
+                                          </p:spTgt>
+                                        </p:tgtEl>
+                                      </p:cBhvr>
+                                    </p:animEffect>
+                                  </p:childTnLst>
+                                </p:cTn>
+                              </p:par>
+                            </p:childTnLst>
+                          </p:cTn>
+                        </p:par>
+                      </p:childTnLst>
+                    </p:cTn>
+                  </p:par>
+                  <p:par>
+                    <p:cTn id="33" fill="hold">
+                      <p:stCondLst>
+                        <p:cond delay="indefinite"/>
+                      </p:stCondLst>
+                      <p:childTnLst>
+                        <p:par>
+                          <p:cTn id="34" fill="hold">
+                            <p:stCondLst>
+                              <p:cond delay="0"/>
+                            </p:stCondLst>
+                            <p:childTnLst>
+                              <p:par>
+                                <p:cTn id="35" presetID="10" presetClass="entr" presetSubtype="0" fill="hold" nodeType="clickEffect">
+                                  <p:stCondLst>
+                                    <p:cond delay="0"/>
+                                  </p:stCondLst>
+                                  <p:childTnLst>
+                                    <p:set>
+                                      <p:cBhvr>
+                                        <p:cTn id="36" dur="1" fill="hold">
+                                          <p:stCondLst>
+                                            <p:cond delay="0"/>
+                                          </p:stCondLst>
+                                        </p:cTn>
+                                        <p:tgtEl>
+                                          <p:spTgt spid="3">
+                                            <p:txEl>
+                                              <p:pRg st="6" end="6"/>
+                                            </p:txEl>
+                                          </p:spTgt>
+                                        </p:tgtEl>
+                                        <p:attrNameLst>
+                                          <p:attrName>style.visibility</p:attrName>
+                                        </p:attrNameLst>
+                                      </p:cBhvr>
+                                      <p:to>
+                                        <p:strVal val="visible"/>
+                                      </p:to>
+                                    </p:set>
+                                    <p:animEffect transition="in" filter="fade">
+                                      <p:cBhvr>
+                                        <p:cTn id="37" dur="500"/>
+                                        <p:tgtEl>
+                                          <p:spTgt spid="3">
+                                            <p:txEl>
+                                              <p:pRg st="6" end="6"/>
+                                            </p:txEl>
+                                          </p:spTgt>
+                                        </p:tgtEl>
+                                      </p:cBhvr>
+                                    </p:animEffect>
+                                  </p:childTnLst>
+                                </p:cTn>
+                              </p:par>
+                            </p:childTnLst>
+                          </p:cTn>
+                        </p:par>
+                      </p:childTnLst>
+                    </p:cTn>
+                  </p:par>
+                </p:childTnLst>
+              </p:cTn>
+              <p:prevCondLst>
+                <p:cond evt="onPrev" delay="0">
+                  <p:tgtEl>
+                    <p:sldTgt/>
+                  </p:tgtEl>
+                </p:cond>
+              </p:prevCondLst>
+              <p:nextCondLst>
+                <p:cond evt="onNext" delay="0">
+                  <p:tgtEl>
+                    <p:sldTgt/>
+                  </p:tgtEl>
+                </p:cond>
+              </p:nextCondLst>
+            </p:seq>
+          </p:childTnLst>
+        </p:cTn>
+      </p:par>
+    </p:tnLst>
+  </p:timing>
 </p:sld>
 </file>
 

</xml_diff>

<commit_message>
fix: Fix typos in python_1 presentation
</commit_message>
<xml_diff>
--- a/python_1/presentation_python_1.pptx
+++ b/python_1/presentation_python_1.pptx
@@ -226,7 +226,7 @@
           <a:p>
             <a:fld id="{17426931-AE65-4D08-8B32-62FCBDE55937}" type="datetimeFigureOut">
               <a:rPr lang="fr-CA" smtClean="0"/>
-              <a:t>2026-04-21</a:t>
+              <a:t>2026-04-27</a:t>
             </a:fld>
             <a:endParaRPr lang="fr-CA"/>
           </a:p>
@@ -385,7 +385,7 @@
           <a:p>
             <a:fld id="{D755565A-1FEC-4FFE-8425-B731D92946D0}" type="slidenum">
               <a:rPr lang="fr-CA" smtClean="0"/>
-              <a:t>‹#›</a:t>
+              <a:t>‹N°›</a:t>
             </a:fld>
             <a:endParaRPr lang="fr-CA"/>
           </a:p>
@@ -643,7 +643,7 @@
           <a:p>
             <a:fld id="{73720E39-F9E6-45F4-9AF3-0670893E0E05}" type="datetime1">
               <a:rPr lang="fr-CA" smtClean="0"/>
-              <a:t>2026-04-21</a:t>
+              <a:t>2026-04-27</a:t>
             </a:fld>
             <a:endParaRPr lang="fr-CA"/>
           </a:p>
@@ -697,7 +697,7 @@
           <a:p>
             <a:fld id="{846B06B1-1179-491F-A487-8E0C403F7C13}" type="slidenum">
               <a:rPr lang="fr-CA" smtClean="0"/>
-              <a:t>‹#›</a:t>
+              <a:t>‹N°›</a:t>
             </a:fld>
             <a:endParaRPr lang="fr-CA"/>
           </a:p>
@@ -843,7 +843,7 @@
           <a:p>
             <a:fld id="{2A86A87F-FCE1-414B-898E-E056954DFB53}" type="datetime1">
               <a:rPr lang="fr-CA" smtClean="0"/>
-              <a:t>2026-04-21</a:t>
+              <a:t>2026-04-27</a:t>
             </a:fld>
             <a:endParaRPr lang="fr-CA"/>
           </a:p>
@@ -897,7 +897,7 @@
           <a:p>
             <a:fld id="{846B06B1-1179-491F-A487-8E0C403F7C13}" type="slidenum">
               <a:rPr lang="fr-CA" smtClean="0"/>
-              <a:t>‹#›</a:t>
+              <a:t>‹N°›</a:t>
             </a:fld>
             <a:endParaRPr lang="fr-CA"/>
           </a:p>
@@ -1053,7 +1053,7 @@
           <a:p>
             <a:fld id="{86217A25-A768-4FB5-8838-4C76F4A4D771}" type="datetime1">
               <a:rPr lang="fr-CA" smtClean="0"/>
-              <a:t>2026-04-21</a:t>
+              <a:t>2026-04-27</a:t>
             </a:fld>
             <a:endParaRPr lang="fr-CA"/>
           </a:p>
@@ -1107,7 +1107,7 @@
           <a:p>
             <a:fld id="{846B06B1-1179-491F-A487-8E0C403F7C13}" type="slidenum">
               <a:rPr lang="fr-CA" smtClean="0"/>
-              <a:t>‹#›</a:t>
+              <a:t>‹N°›</a:t>
             </a:fld>
             <a:endParaRPr lang="fr-CA"/>
           </a:p>
@@ -1253,7 +1253,7 @@
           <a:p>
             <a:fld id="{6DF5E9B1-F4B4-44A9-8978-A50A0AD8373C}" type="datetime1">
               <a:rPr lang="fr-CA" smtClean="0"/>
-              <a:t>2026-04-21</a:t>
+              <a:t>2026-04-27</a:t>
             </a:fld>
             <a:endParaRPr lang="fr-CA"/>
           </a:p>
@@ -1307,7 +1307,7 @@
           <a:p>
             <a:fld id="{846B06B1-1179-491F-A487-8E0C403F7C13}" type="slidenum">
               <a:rPr lang="fr-CA" smtClean="0"/>
-              <a:t>‹#›</a:t>
+              <a:t>‹N°›</a:t>
             </a:fld>
             <a:endParaRPr lang="fr-CA"/>
           </a:p>
@@ -1529,7 +1529,7 @@
           <a:p>
             <a:fld id="{5DE8FE0D-E91C-47AE-8B70-2B0ABA5D1B1E}" type="datetime1">
               <a:rPr lang="fr-CA" smtClean="0"/>
-              <a:t>2026-04-21</a:t>
+              <a:t>2026-04-27</a:t>
             </a:fld>
             <a:endParaRPr lang="fr-CA"/>
           </a:p>
@@ -1583,7 +1583,7 @@
           <a:p>
             <a:fld id="{846B06B1-1179-491F-A487-8E0C403F7C13}" type="slidenum">
               <a:rPr lang="fr-CA" smtClean="0"/>
-              <a:t>‹#›</a:t>
+              <a:t>‹N°›</a:t>
             </a:fld>
             <a:endParaRPr lang="fr-CA"/>
           </a:p>
@@ -1797,7 +1797,7 @@
           <a:p>
             <a:fld id="{F3AB8F30-8420-4011-A9ED-ED2F47883C93}" type="datetime1">
               <a:rPr lang="fr-CA" smtClean="0"/>
-              <a:t>2026-04-21</a:t>
+              <a:t>2026-04-27</a:t>
             </a:fld>
             <a:endParaRPr lang="fr-CA"/>
           </a:p>
@@ -1851,7 +1851,7 @@
           <a:p>
             <a:fld id="{846B06B1-1179-491F-A487-8E0C403F7C13}" type="slidenum">
               <a:rPr lang="fr-CA" smtClean="0"/>
-              <a:t>‹#›</a:t>
+              <a:t>‹N°›</a:t>
             </a:fld>
             <a:endParaRPr lang="fr-CA"/>
           </a:p>
@@ -2212,7 +2212,7 @@
           <a:p>
             <a:fld id="{852876F1-672F-46E4-BC46-E9D4C880BFEF}" type="datetime1">
               <a:rPr lang="fr-CA" smtClean="0"/>
-              <a:t>2026-04-21</a:t>
+              <a:t>2026-04-27</a:t>
             </a:fld>
             <a:endParaRPr lang="fr-CA"/>
           </a:p>
@@ -2266,7 +2266,7 @@
           <a:p>
             <a:fld id="{846B06B1-1179-491F-A487-8E0C403F7C13}" type="slidenum">
               <a:rPr lang="fr-CA" smtClean="0"/>
-              <a:t>‹#›</a:t>
+              <a:t>‹N°›</a:t>
             </a:fld>
             <a:endParaRPr lang="fr-CA"/>
           </a:p>
@@ -2354,7 +2354,7 @@
           <a:p>
             <a:fld id="{05494588-57AE-4A88-AA7D-14590C8ABB1D}" type="datetime1">
               <a:rPr lang="fr-CA" smtClean="0"/>
-              <a:t>2026-04-21</a:t>
+              <a:t>2026-04-27</a:t>
             </a:fld>
             <a:endParaRPr lang="fr-CA"/>
           </a:p>
@@ -2408,7 +2408,7 @@
           <a:p>
             <a:fld id="{846B06B1-1179-491F-A487-8E0C403F7C13}" type="slidenum">
               <a:rPr lang="fr-CA" smtClean="0"/>
-              <a:t>‹#›</a:t>
+              <a:t>‹N°›</a:t>
             </a:fld>
             <a:endParaRPr lang="fr-CA"/>
           </a:p>
@@ -2467,7 +2467,7 @@
           <a:p>
             <a:fld id="{70596107-F84A-4D89-B7EE-30826EF0EE70}" type="datetime1">
               <a:rPr lang="fr-CA" smtClean="0"/>
-              <a:t>2026-04-21</a:t>
+              <a:t>2026-04-27</a:t>
             </a:fld>
             <a:endParaRPr lang="fr-CA"/>
           </a:p>
@@ -2521,7 +2521,7 @@
           <a:p>
             <a:fld id="{846B06B1-1179-491F-A487-8E0C403F7C13}" type="slidenum">
               <a:rPr lang="fr-CA" smtClean="0"/>
-              <a:t>‹#›</a:t>
+              <a:t>‹N°›</a:t>
             </a:fld>
             <a:endParaRPr lang="fr-CA"/>
           </a:p>
@@ -2780,7 +2780,7 @@
           <a:p>
             <a:fld id="{12C269CA-6797-4965-A975-3F40F12DAD06}" type="datetime1">
               <a:rPr lang="fr-CA" smtClean="0"/>
-              <a:t>2026-04-21</a:t>
+              <a:t>2026-04-27</a:t>
             </a:fld>
             <a:endParaRPr lang="fr-CA"/>
           </a:p>
@@ -2834,7 +2834,7 @@
           <a:p>
             <a:fld id="{846B06B1-1179-491F-A487-8E0C403F7C13}" type="slidenum">
               <a:rPr lang="fr-CA" smtClean="0"/>
-              <a:t>‹#›</a:t>
+              <a:t>‹N°›</a:t>
             </a:fld>
             <a:endParaRPr lang="fr-CA"/>
           </a:p>
@@ -3069,7 +3069,7 @@
           <a:p>
             <a:fld id="{3F5AE234-69D2-4522-AB7A-F911A65753A0}" type="datetime1">
               <a:rPr lang="fr-CA" smtClean="0"/>
-              <a:t>2026-04-21</a:t>
+              <a:t>2026-04-27</a:t>
             </a:fld>
             <a:endParaRPr lang="fr-CA"/>
           </a:p>
@@ -3123,7 +3123,7 @@
           <a:p>
             <a:fld id="{846B06B1-1179-491F-A487-8E0C403F7C13}" type="slidenum">
               <a:rPr lang="fr-CA" smtClean="0"/>
-              <a:t>‹#›</a:t>
+              <a:t>‹N°›</a:t>
             </a:fld>
             <a:endParaRPr lang="fr-CA"/>
           </a:p>
@@ -3312,7 +3312,7 @@
           <a:p>
             <a:fld id="{30546B8D-50B2-4CF7-ACAA-221A68F8C882}" type="datetime1">
               <a:rPr lang="fr-CA" smtClean="0"/>
-              <a:t>2026-04-21</a:t>
+              <a:t>2026-04-27</a:t>
             </a:fld>
             <a:endParaRPr lang="fr-CA"/>
           </a:p>
@@ -3402,7 +3402,7 @@
           <a:p>
             <a:fld id="{846B06B1-1179-491F-A487-8E0C403F7C13}" type="slidenum">
               <a:rPr lang="fr-CA" smtClean="0"/>
-              <a:t>‹#›</a:t>
+              <a:t>‹N°›</a:t>
             </a:fld>
             <a:endParaRPr lang="fr-CA"/>
           </a:p>
@@ -5645,28 +5645,25 @@
                 <a:effectLst/>
                 <a:latin typeface="Consolas" panose="020B0609020204030204" pitchFamily="49" charset="0"/>
               </a:rPr>
-              <a:t>(</a:t>
-            </a:r>
-            <a:r>
-              <a:rPr lang="en-CA" b="0" i="0" dirty="0" err="1">
+              <a:t>(a1,</a:t>
+            </a:r>
+            <a:r>
+              <a:rPr lang="en-CA" b="0" i="0">
                 <a:solidFill>
                   <a:srgbClr val="333333"/>
                 </a:solidFill>
                 <a:effectLst/>
                 <a:latin typeface="Consolas" panose="020B0609020204030204" pitchFamily="49" charset="0"/>
               </a:rPr>
-              <a:t>a,b,c</a:t>
-            </a:r>
-            <a:r>
-              <a:rPr lang="en-CA" b="0" i="0" dirty="0">
-                <a:solidFill>
-                  <a:srgbClr val="333333"/>
-                </a:solidFill>
-                <a:effectLst/>
-                <a:latin typeface="Consolas" panose="020B0609020204030204" pitchFamily="49" charset="0"/>
-              </a:rPr>
-              <a:t>):</a:t>
-            </a:r>
+              <a:t>a2,a3):</a:t>
+            </a:r>
+            <a:endParaRPr lang="en-CA" b="0" i="0" dirty="0">
+              <a:solidFill>
+                <a:srgbClr val="333333"/>
+              </a:solidFill>
+              <a:effectLst/>
+              <a:latin typeface="Consolas" panose="020B0609020204030204" pitchFamily="49" charset="0"/>
+            </a:endParaRPr>
           </a:p>
           <a:p>
             <a:pPr algn="l">
@@ -14069,8 +14066,8 @@
           </a:p>
         </p:txBody>
       </p:sp>
-      <mc:AlternateContent xmlns:mc="http://schemas.openxmlformats.org/markup-compatibility/2006" xmlns:a14="http://schemas.microsoft.com/office/drawing/2010/main">
-        <mc:Choice Requires="a14">
+      <mc:AlternateContent xmlns:mc="http://schemas.openxmlformats.org/markup-compatibility/2006">
+        <mc:Choice xmlns:a14="http://schemas.microsoft.com/office/drawing/2010/main" Requires="a14">
           <p:sp>
             <p:nvSpPr>
               <p:cNvPr id="3" name="Content Placeholder 2">
@@ -14170,19 +14167,19 @@
                   </a:lnSpc>
                 </a:pPr>
                 <a:r>
-                  <a:rPr lang="en-US" sz="1400" dirty="0" err="1">
+                  <a:rPr lang="en-US" sz="1800" dirty="0" err="1">
                     <a:latin typeface="Consolas" panose="020B0609020204030204" pitchFamily="49" charset="0"/>
                   </a:rPr>
                   <a:t>explicites</a:t>
                 </a:r>
                 <a:r>
-                  <a:rPr lang="en-US" sz="1400" dirty="0">
+                  <a:rPr lang="en-US" sz="1800" dirty="0">
                     <a:latin typeface="Consolas" panose="020B0609020204030204" pitchFamily="49" charset="0"/>
                   </a:rPr>
                   <a:t>: </a:t>
                 </a:r>
                 <a:r>
-                  <a:rPr lang="pt-BR" sz="1400" b="1" dirty="0">
+                  <a:rPr lang="pt-BR" sz="1800" b="1" dirty="0">
                     <a:solidFill>
                       <a:srgbClr val="00B0F0"/>
                     </a:solidFill>
@@ -14191,13 +14188,13 @@
                   <a:t>p1</a:t>
                 </a:r>
                 <a:r>
-                  <a:rPr lang="pt-BR" sz="1400" b="1" dirty="0">
+                  <a:rPr lang="pt-BR" sz="1800" b="1" dirty="0">
                     <a:latin typeface="Consolas" panose="020B0609020204030204" pitchFamily="49" charset="0"/>
                   </a:rPr>
                   <a:t>, </a:t>
                 </a:r>
                 <a:r>
-                  <a:rPr lang="pt-BR" sz="1400" b="1" dirty="0">
+                  <a:rPr lang="pt-BR" sz="1800" b="1" dirty="0">
                     <a:solidFill>
                       <a:srgbClr val="00B0F0"/>
                     </a:solidFill>
@@ -14206,13 +14203,13 @@
                   <a:t>p2</a:t>
                 </a:r>
                 <a:r>
-                  <a:rPr lang="pt-BR" sz="1400" b="1" dirty="0">
+                  <a:rPr lang="pt-BR" sz="1800" b="1" dirty="0">
                     <a:latin typeface="Consolas" panose="020B0609020204030204" pitchFamily="49" charset="0"/>
                   </a:rPr>
                   <a:t>, </a:t>
                 </a:r>
                 <a:r>
-                  <a:rPr lang="pt-BR" sz="1400" b="1" dirty="0">
+                  <a:rPr lang="pt-BR" sz="1800" b="1" dirty="0">
                     <a:solidFill>
                       <a:srgbClr val="00B0F0"/>
                     </a:solidFill>
@@ -14228,19 +14225,19 @@
                   </a:lnSpc>
                 </a:pPr>
                 <a:r>
-                  <a:rPr lang="en-US" sz="1400" dirty="0" err="1">
+                  <a:rPr lang="en-US" sz="1800" dirty="0" err="1">
                     <a:latin typeface="Consolas" panose="020B0609020204030204" pitchFamily="49" charset="0"/>
                   </a:rPr>
                   <a:t>supplémentaires</a:t>
                 </a:r>
                 <a:r>
-                  <a:rPr lang="en-US" sz="1400" dirty="0">
+                  <a:rPr lang="en-US" sz="1800" dirty="0">
                     <a:latin typeface="Consolas" panose="020B0609020204030204" pitchFamily="49" charset="0"/>
                   </a:rPr>
                   <a:t>: </a:t>
                 </a:r>
                 <a:r>
-                  <a:rPr lang="pt-BR" sz="1400" b="1" dirty="0">
+                  <a:rPr lang="pt-BR" sz="1800" b="1" dirty="0">
                     <a:solidFill>
                       <a:srgbClr val="7030A0"/>
                     </a:solidFill>
@@ -14249,12 +14246,12 @@
                   <a:t>*args</a:t>
                 </a:r>
                 <a:r>
-                  <a:rPr lang="en-US" sz="1400" dirty="0">
+                  <a:rPr lang="en-US" sz="1800" dirty="0">
                     <a:latin typeface="Consolas" panose="020B0609020204030204" pitchFamily="49" charset="0"/>
                   </a:rPr>
                   <a:t> (tuple)</a:t>
                 </a:r>
-                <a:endParaRPr lang="en-US" sz="1400" dirty="0">
+                <a:endParaRPr lang="en-US" sz="1800" dirty="0">
                   <a:solidFill>
                     <a:srgbClr val="00B0F0"/>
                   </a:solidFill>
@@ -14334,19 +14331,19 @@
                   </a:lnSpc>
                 </a:pPr>
                 <a:r>
-                  <a:rPr lang="en-US" sz="1400" dirty="0" err="1">
+                  <a:rPr lang="en-US" sz="1800" dirty="0" err="1">
                     <a:latin typeface="Consolas" panose="020B0609020204030204" pitchFamily="49" charset="0"/>
                   </a:rPr>
                   <a:t>explicites</a:t>
                 </a:r>
                 <a:r>
-                  <a:rPr lang="en-US" sz="1400" dirty="0">
+                  <a:rPr lang="en-US" sz="1800" dirty="0">
                     <a:latin typeface="Consolas" panose="020B0609020204030204" pitchFamily="49" charset="0"/>
                   </a:rPr>
                   <a:t>: </a:t>
                 </a:r>
                 <a:r>
-                  <a:rPr lang="pt-BR" sz="1400" b="1" dirty="0">
+                  <a:rPr lang="pt-BR" sz="1800" b="1" dirty="0">
                     <a:solidFill>
                       <a:schemeClr val="accent6"/>
                     </a:solidFill>
@@ -14355,13 +14352,13 @@
                   <a:t>n1=v1</a:t>
                 </a:r>
                 <a:r>
-                  <a:rPr lang="en-US" sz="1400" dirty="0">
+                  <a:rPr lang="en-US" sz="1800" dirty="0">
                     <a:latin typeface="Consolas" panose="020B0609020204030204" pitchFamily="49" charset="0"/>
                   </a:rPr>
                   <a:t>, </a:t>
                 </a:r>
                 <a:r>
-                  <a:rPr lang="pt-BR" sz="1400" b="1" dirty="0">
+                  <a:rPr lang="pt-BR" sz="1800" b="1" dirty="0">
                     <a:solidFill>
                       <a:schemeClr val="accent6"/>
                     </a:solidFill>
@@ -14370,13 +14367,13 @@
                   <a:t>n2=v2</a:t>
                 </a:r>
                 <a:r>
-                  <a:rPr lang="en-US" sz="1400" dirty="0">
+                  <a:rPr lang="en-US" sz="1800" dirty="0">
                     <a:latin typeface="Consolas" panose="020B0609020204030204" pitchFamily="49" charset="0"/>
                   </a:rPr>
                   <a:t>, </a:t>
                 </a:r>
                 <a:r>
-                  <a:rPr lang="pt-BR" sz="1400" b="1" dirty="0">
+                  <a:rPr lang="pt-BR" sz="1800" b="1" dirty="0">
                     <a:solidFill>
                       <a:schemeClr val="accent6"/>
                     </a:solidFill>
@@ -14392,19 +14389,19 @@
                   </a:lnSpc>
                 </a:pPr>
                 <a:r>
-                  <a:rPr lang="en-US" sz="1400" dirty="0" err="1">
+                  <a:rPr lang="en-US" sz="1800" dirty="0" err="1">
                     <a:latin typeface="Consolas" panose="020B0609020204030204" pitchFamily="49" charset="0"/>
                   </a:rPr>
                   <a:t>supplémentaires</a:t>
                 </a:r>
                 <a:r>
-                  <a:rPr lang="en-US" sz="1400" dirty="0">
+                  <a:rPr lang="en-US" sz="1800" dirty="0">
                     <a:latin typeface="Consolas" panose="020B0609020204030204" pitchFamily="49" charset="0"/>
                   </a:rPr>
                   <a:t>: </a:t>
                 </a:r>
                 <a:r>
-                  <a:rPr lang="pt-BR" sz="1400" b="1" dirty="0">
+                  <a:rPr lang="pt-BR" sz="1800" b="1" dirty="0">
                     <a:solidFill>
                       <a:schemeClr val="accent2"/>
                     </a:solidFill>
@@ -14413,19 +14410,19 @@
                   <a:t>**kwargs</a:t>
                 </a:r>
                 <a:r>
-                  <a:rPr lang="en-US" sz="1400" dirty="0">
+                  <a:rPr lang="en-US" sz="1800" dirty="0">
                     <a:latin typeface="Consolas" panose="020B0609020204030204" pitchFamily="49" charset="0"/>
                   </a:rPr>
                   <a:t> (</a:t>
                 </a:r>
                 <a:r>
-                  <a:rPr lang="en-US" sz="1400" dirty="0" err="1">
+                  <a:rPr lang="en-US" sz="1800" dirty="0" err="1">
                     <a:latin typeface="Consolas" panose="020B0609020204030204" pitchFamily="49" charset="0"/>
                   </a:rPr>
                   <a:t>dict</a:t>
                 </a:r>
                 <a:r>
-                  <a:rPr lang="en-US" sz="1400" dirty="0">
+                  <a:rPr lang="en-US" sz="1800" dirty="0">
                     <a:latin typeface="Consolas" panose="020B0609020204030204" pitchFamily="49" charset="0"/>
                   </a:rPr>
                   <a:t>)</a:t>
@@ -14448,7 +14445,7 @@
             </p:txBody>
           </p:sp>
         </mc:Choice>
-        <mc:Fallback xmlns="">
+        <mc:Fallback>
           <p:sp>
             <p:nvSpPr>
               <p:cNvPr id="3" name="Content Placeholder 2">
@@ -16474,8 +16471,8 @@
           </a:p>
         </p:txBody>
       </p:sp>
-      <mc:AlternateContent xmlns:mc="http://schemas.openxmlformats.org/markup-compatibility/2006" xmlns:a14="http://schemas.microsoft.com/office/drawing/2010/main">
-        <mc:Choice Requires="a14">
+      <mc:AlternateContent xmlns:mc="http://schemas.openxmlformats.org/markup-compatibility/2006">
+        <mc:Choice xmlns:a14="http://schemas.microsoft.com/office/drawing/2010/main" Requires="a14">
           <p:sp>
             <p:nvSpPr>
               <p:cNvPr id="3" name="Content Placeholder 2">
@@ -16688,7 +16685,7 @@
                   <a:rPr lang="en-CA" sz="1400" b="1" dirty="0">
                     <a:latin typeface="Consolas" panose="020B0609020204030204" pitchFamily="49" charset="0"/>
                   </a:rPr>
-                  <a:t> exp(1) ** pi</a:t>
+                  <a:t> exp(pi)</a:t>
                 </a:r>
               </a:p>
               <a:p>
@@ -16965,7 +16962,7 @@
             </p:txBody>
           </p:sp>
         </mc:Choice>
-        <mc:Fallback xmlns="">
+        <mc:Fallback>
           <p:sp>
             <p:nvSpPr>
               <p:cNvPr id="3" name="Content Placeholder 2">
@@ -18544,52 +18541,52 @@
               <a:rPr lang="en-CA" b="1" dirty="0">
                 <a:latin typeface="Consolas" panose="020B0609020204030204" pitchFamily="49" charset="0"/>
               </a:rPr>
+              <a:t>...   print("Impair")</a:t>
+            </a:r>
+          </a:p>
+          <a:p>
+            <a:pPr algn="just"/>
+            <a:r>
+              <a:rPr lang="en-CA" b="1" dirty="0">
+                <a:latin typeface="Consolas" panose="020B0609020204030204" pitchFamily="49" charset="0"/>
+              </a:rPr>
+              <a:t>... </a:t>
+            </a:r>
+            <a:r>
+              <a:rPr lang="en-CA" b="1" dirty="0" err="1">
+                <a:solidFill>
+                  <a:srgbClr val="FF2500"/>
+                </a:solidFill>
+                <a:latin typeface="Consolas" panose="020B0609020204030204" pitchFamily="49" charset="0"/>
+              </a:rPr>
+              <a:t>elif</a:t>
+            </a:r>
+            <a:r>
+              <a:rPr lang="en-CA" b="1" dirty="0">
+                <a:latin typeface="Consolas" panose="020B0609020204030204" pitchFamily="49" charset="0"/>
+              </a:rPr>
+              <a:t> </a:t>
+            </a:r>
+            <a:r>
+              <a:rPr lang="en-CA" b="1" dirty="0" err="1">
+                <a:latin typeface="Consolas" panose="020B0609020204030204" pitchFamily="49" charset="0"/>
+              </a:rPr>
+              <a:t>valeur</a:t>
+            </a:r>
+            <a:r>
+              <a:rPr lang="en-CA" b="1" dirty="0">
+                <a:latin typeface="Consolas" panose="020B0609020204030204" pitchFamily="49" charset="0"/>
+              </a:rPr>
+              <a:t> % 2 == 0:</a:t>
+            </a:r>
+          </a:p>
+          <a:p>
+            <a:pPr algn="just"/>
+            <a:r>
+              <a:rPr lang="en-CA" b="1" dirty="0">
+                <a:latin typeface="Consolas" panose="020B0609020204030204" pitchFamily="49" charset="0"/>
+              </a:rPr>
               <a:t>...   print("Pair")</a:t>
-            </a:r>
-          </a:p>
-          <a:p>
-            <a:pPr algn="just"/>
-            <a:r>
-              <a:rPr lang="en-CA" b="1" dirty="0">
-                <a:latin typeface="Consolas" panose="020B0609020204030204" pitchFamily="49" charset="0"/>
-              </a:rPr>
-              <a:t>... </a:t>
-            </a:r>
-            <a:r>
-              <a:rPr lang="en-CA" b="1" dirty="0" err="1">
-                <a:solidFill>
-                  <a:srgbClr val="FF2500"/>
-                </a:solidFill>
-                <a:latin typeface="Consolas" panose="020B0609020204030204" pitchFamily="49" charset="0"/>
-              </a:rPr>
-              <a:t>elif</a:t>
-            </a:r>
-            <a:r>
-              <a:rPr lang="en-CA" b="1" dirty="0">
-                <a:latin typeface="Consolas" panose="020B0609020204030204" pitchFamily="49" charset="0"/>
-              </a:rPr>
-              <a:t> </a:t>
-            </a:r>
-            <a:r>
-              <a:rPr lang="en-CA" b="1" dirty="0" err="1">
-                <a:latin typeface="Consolas" panose="020B0609020204030204" pitchFamily="49" charset="0"/>
-              </a:rPr>
-              <a:t>valeur</a:t>
-            </a:r>
-            <a:r>
-              <a:rPr lang="en-CA" b="1" dirty="0">
-                <a:latin typeface="Consolas" panose="020B0609020204030204" pitchFamily="49" charset="0"/>
-              </a:rPr>
-              <a:t> % 2 == 0:</a:t>
-            </a:r>
-          </a:p>
-          <a:p>
-            <a:pPr algn="just"/>
-            <a:r>
-              <a:rPr lang="en-CA" b="1" dirty="0">
-                <a:latin typeface="Consolas" panose="020B0609020204030204" pitchFamily="49" charset="0"/>
-              </a:rPr>
-              <a:t>...   print("Impair")</a:t>
             </a:r>
           </a:p>
           <a:p>
@@ -18683,49 +18680,49 @@
               <a:rPr lang="en-CA" b="1" dirty="0">
                 <a:latin typeface="Consolas" panose="020B0609020204030204" pitchFamily="49" charset="0"/>
               </a:rPr>
+              <a:t>...   print("Impair")</a:t>
+            </a:r>
+          </a:p>
+          <a:p>
+            <a:pPr algn="just"/>
+            <a:r>
+              <a:rPr lang="en-CA" b="1" dirty="0">
+                <a:latin typeface="Consolas" panose="020B0609020204030204" pitchFamily="49" charset="0"/>
+              </a:rPr>
+              <a:t>... </a:t>
+            </a:r>
+            <a:r>
+              <a:rPr lang="en-CA" b="1" dirty="0" err="1">
+                <a:latin typeface="Consolas" panose="020B0609020204030204" pitchFamily="49" charset="0"/>
+              </a:rPr>
+              <a:t>elif</a:t>
+            </a:r>
+            <a:r>
+              <a:rPr lang="en-CA" b="1" dirty="0">
+                <a:latin typeface="Consolas" panose="020B0609020204030204" pitchFamily="49" charset="0"/>
+              </a:rPr>
+              <a:t> </a:t>
+            </a:r>
+            <a:r>
+              <a:rPr lang="en-CA" b="1" dirty="0" err="1">
+                <a:latin typeface="Consolas" panose="020B0609020204030204" pitchFamily="49" charset="0"/>
+              </a:rPr>
+              <a:t>valeur</a:t>
+            </a:r>
+            <a:r>
+              <a:rPr lang="en-CA" b="1" dirty="0">
+                <a:latin typeface="Consolas" panose="020B0609020204030204" pitchFamily="49" charset="0"/>
+              </a:rPr>
+              <a:t> % 2 == 0:</a:t>
+            </a:r>
+          </a:p>
+          <a:p>
+            <a:pPr algn="just"/>
+            <a:r>
+              <a:rPr lang="en-CA" b="1" dirty="0">
+                <a:latin typeface="Consolas" panose="020B0609020204030204" pitchFamily="49" charset="0"/>
+              </a:rPr>
               <a:t>...   print("Pair")</a:t>
-            </a:r>
-          </a:p>
-          <a:p>
-            <a:pPr algn="just"/>
-            <a:r>
-              <a:rPr lang="en-CA" b="1" dirty="0">
-                <a:latin typeface="Consolas" panose="020B0609020204030204" pitchFamily="49" charset="0"/>
-              </a:rPr>
-              <a:t>... </a:t>
-            </a:r>
-            <a:r>
-              <a:rPr lang="en-CA" b="1" dirty="0" err="1">
-                <a:latin typeface="Consolas" panose="020B0609020204030204" pitchFamily="49" charset="0"/>
-              </a:rPr>
-              <a:t>elif</a:t>
-            </a:r>
-            <a:r>
-              <a:rPr lang="en-CA" b="1" dirty="0">
-                <a:latin typeface="Consolas" panose="020B0609020204030204" pitchFamily="49" charset="0"/>
-              </a:rPr>
-              <a:t> </a:t>
-            </a:r>
-            <a:r>
-              <a:rPr lang="en-CA" b="1" dirty="0" err="1">
-                <a:latin typeface="Consolas" panose="020B0609020204030204" pitchFamily="49" charset="0"/>
-              </a:rPr>
-              <a:t>valeur</a:t>
-            </a:r>
-            <a:r>
-              <a:rPr lang="en-CA" b="1" dirty="0">
-                <a:latin typeface="Consolas" panose="020B0609020204030204" pitchFamily="49" charset="0"/>
-              </a:rPr>
-              <a:t> % 2 == 0:</a:t>
-            </a:r>
-          </a:p>
-          <a:p>
-            <a:pPr algn="just"/>
-            <a:r>
-              <a:rPr lang="en-CA" b="1" dirty="0">
-                <a:latin typeface="Consolas" panose="020B0609020204030204" pitchFamily="49" charset="0"/>
-              </a:rPr>
-              <a:t>...   print("Impair")</a:t>
             </a:r>
           </a:p>
           <a:p>

</xml_diff>